<commit_message>
add 29 sunday sep songs
</commit_message>
<xml_diff>
--- a/songsTemplate.pptx
+++ b/songsTemplate.pptx
@@ -108,7 +108,7 @@
   <p:extLst>
     <p:ext uri="{EFAFB233-063F-42B5-8137-9DF3F51BA10A}">
       <p15:sldGuideLst xmlns:p15="http://schemas.microsoft.com/office/powerpoint/2012/main">
-        <p15:guide id="1" orient="horz" pos="2160" userDrawn="1">
+        <p15:guide id="1" orient="horz" pos="2137" userDrawn="1">
           <p15:clr>
             <a:srgbClr val="A4A3A4"/>
           </p15:clr>
@@ -255,7 +255,7 @@
           <a:p>
             <a:fld id="{F1102B08-ED9E-409F-B95F-09CAA1DAF6E0}" type="datetimeFigureOut">
               <a:rPr lang="en-IN" smtClean="0"/>
-              <a:t>21-09-2024</a:t>
+              <a:t>28-09-2024</a:t>
             </a:fld>
             <a:endParaRPr lang="en-IN"/>
           </a:p>
@@ -425,7 +425,7 @@
           <a:p>
             <a:fld id="{F1102B08-ED9E-409F-B95F-09CAA1DAF6E0}" type="datetimeFigureOut">
               <a:rPr lang="en-IN" smtClean="0"/>
-              <a:t>21-09-2024</a:t>
+              <a:t>28-09-2024</a:t>
             </a:fld>
             <a:endParaRPr lang="en-IN"/>
           </a:p>
@@ -605,7 +605,7 @@
           <a:p>
             <a:fld id="{F1102B08-ED9E-409F-B95F-09CAA1DAF6E0}" type="datetimeFigureOut">
               <a:rPr lang="en-IN" smtClean="0"/>
-              <a:t>21-09-2024</a:t>
+              <a:t>28-09-2024</a:t>
             </a:fld>
             <a:endParaRPr lang="en-IN"/>
           </a:p>
@@ -775,7 +775,7 @@
           <a:p>
             <a:fld id="{F1102B08-ED9E-409F-B95F-09CAA1DAF6E0}" type="datetimeFigureOut">
               <a:rPr lang="en-IN" smtClean="0"/>
-              <a:t>21-09-2024</a:t>
+              <a:t>28-09-2024</a:t>
             </a:fld>
             <a:endParaRPr lang="en-IN"/>
           </a:p>
@@ -1019,7 +1019,7 @@
           <a:p>
             <a:fld id="{F1102B08-ED9E-409F-B95F-09CAA1DAF6E0}" type="datetimeFigureOut">
               <a:rPr lang="en-IN" smtClean="0"/>
-              <a:t>21-09-2024</a:t>
+              <a:t>28-09-2024</a:t>
             </a:fld>
             <a:endParaRPr lang="en-IN"/>
           </a:p>
@@ -1251,7 +1251,7 @@
           <a:p>
             <a:fld id="{F1102B08-ED9E-409F-B95F-09CAA1DAF6E0}" type="datetimeFigureOut">
               <a:rPr lang="en-IN" smtClean="0"/>
-              <a:t>21-09-2024</a:t>
+              <a:t>28-09-2024</a:t>
             </a:fld>
             <a:endParaRPr lang="en-IN"/>
           </a:p>
@@ -1618,7 +1618,7 @@
           <a:p>
             <a:fld id="{F1102B08-ED9E-409F-B95F-09CAA1DAF6E0}" type="datetimeFigureOut">
               <a:rPr lang="en-IN" smtClean="0"/>
-              <a:t>21-09-2024</a:t>
+              <a:t>28-09-2024</a:t>
             </a:fld>
             <a:endParaRPr lang="en-IN"/>
           </a:p>
@@ -1736,7 +1736,7 @@
           <a:p>
             <a:fld id="{F1102B08-ED9E-409F-B95F-09CAA1DAF6E0}" type="datetimeFigureOut">
               <a:rPr lang="en-IN" smtClean="0"/>
-              <a:t>21-09-2024</a:t>
+              <a:t>28-09-2024</a:t>
             </a:fld>
             <a:endParaRPr lang="en-IN"/>
           </a:p>
@@ -1831,7 +1831,7 @@
           <a:p>
             <a:fld id="{F1102B08-ED9E-409F-B95F-09CAA1DAF6E0}" type="datetimeFigureOut">
               <a:rPr lang="en-IN" smtClean="0"/>
-              <a:t>21-09-2024</a:t>
+              <a:t>28-09-2024</a:t>
             </a:fld>
             <a:endParaRPr lang="en-IN"/>
           </a:p>
@@ -2108,7 +2108,7 @@
           <a:p>
             <a:fld id="{F1102B08-ED9E-409F-B95F-09CAA1DAF6E0}" type="datetimeFigureOut">
               <a:rPr lang="en-IN" smtClean="0"/>
-              <a:t>21-09-2024</a:t>
+              <a:t>28-09-2024</a:t>
             </a:fld>
             <a:endParaRPr lang="en-IN"/>
           </a:p>
@@ -2365,7 +2365,7 @@
           <a:p>
             <a:fld id="{F1102B08-ED9E-409F-B95F-09CAA1DAF6E0}" type="datetimeFigureOut">
               <a:rPr lang="en-IN" smtClean="0"/>
-              <a:t>21-09-2024</a:t>
+              <a:t>28-09-2024</a:t>
             </a:fld>
             <a:endParaRPr lang="en-IN"/>
           </a:p>
@@ -2578,7 +2578,7 @@
           <a:p>
             <a:fld id="{F1102B08-ED9E-409F-B95F-09CAA1DAF6E0}" type="datetimeFigureOut">
               <a:rPr lang="en-IN" smtClean="0"/>
-              <a:t>21-09-2024</a:t>
+              <a:t>28-09-2024</a:t>
             </a:fld>
             <a:endParaRPr lang="en-IN"/>
           </a:p>
@@ -3073,7 +3073,7 @@
           <p:spPr>
             <a:xfrm>
               <a:off x="267762" y="787955"/>
-              <a:ext cx="4836576" cy="5262979"/>
+              <a:ext cx="4836576" cy="4939814"/>
             </a:xfrm>
             <a:prstGeom prst="rect">
               <a:avLst/>
@@ -3090,82 +3090,68 @@
                 <a:defRPr/>
               </a:pPr>
               <a:r>
-                <a:rPr lang="te-IN" sz="2400" dirty="0">
-                  <a:latin typeface="Ramabhadra" panose="02000600000000000000" pitchFamily="2" charset="0"/>
-                  <a:cs typeface="Ramabhadra" panose="02000600000000000000" pitchFamily="2" charset="0"/>
-                </a:rPr>
-                <a:t>యేసు నీ కృపలో</a:t>
-              </a:r>
-              <a:r>
-                <a:rPr lang="en-IN" sz="2400" dirty="0">
+                <a:rPr lang="te-IN" sz="2100" dirty="0">
+                  <a:latin typeface="Ramabhadra" panose="02000600000000000000" pitchFamily="2" charset="0"/>
+                  <a:cs typeface="Ramabhadra" panose="02000600000000000000" pitchFamily="2" charset="0"/>
+                </a:rPr>
+                <a:t>నేనెందుకని నీ సొత్తుగా మారితిని</a:t>
+              </a:r>
+            </a:p>
+            <a:p>
+              <a:pPr defTabSz="439781">
+                <a:defRPr/>
+              </a:pPr>
+              <a:r>
+                <a:rPr lang="te-IN" sz="2100" dirty="0">
+                  <a:latin typeface="Ramabhadra" panose="02000600000000000000" pitchFamily="2" charset="0"/>
+                  <a:cs typeface="Ramabhadra" panose="02000600000000000000" pitchFamily="2" charset="0"/>
+                </a:rPr>
+                <a:t>యేసయ్యా నీ రక్తముచే... కడుగబడి</a:t>
+              </a:r>
+              <a:r>
+                <a:rPr lang="en-IN" sz="2100" dirty="0">
                   <a:latin typeface="Ramabhadra" panose="02000600000000000000" pitchFamily="2" charset="0"/>
                   <a:cs typeface="Ramabhadra" panose="02000600000000000000" pitchFamily="2" charset="0"/>
                 </a:rPr>
                 <a:t> </a:t>
               </a:r>
               <a:r>
-                <a:rPr lang="te-IN" sz="2400" dirty="0">
-                  <a:latin typeface="Ramabhadra" panose="02000600000000000000" pitchFamily="2" charset="0"/>
-                  <a:cs typeface="Ramabhadra" panose="02000600000000000000" pitchFamily="2" charset="0"/>
-                </a:rPr>
-                <a:t>-</a:t>
-              </a:r>
-              <a:r>
-                <a:rPr lang="en-IN" sz="2400" dirty="0">
-                  <a:latin typeface="Ramabhadra" panose="02000600000000000000" pitchFamily="2" charset="0"/>
-                  <a:cs typeface="Ramabhadra" panose="02000600000000000000" pitchFamily="2" charset="0"/>
-                </a:rPr>
-                <a:t> </a:t>
-              </a:r>
-              <a:r>
-                <a:rPr lang="te-IN" sz="2400" dirty="0">
-                  <a:latin typeface="Ramabhadra" panose="02000600000000000000" pitchFamily="2" charset="0"/>
-                  <a:cs typeface="Ramabhadra" panose="02000600000000000000" pitchFamily="2" charset="0"/>
-                </a:rPr>
-                <a:t>మమ్ము కాపాడుము దేవా</a:t>
-              </a:r>
-            </a:p>
-            <a:p>
-              <a:pPr defTabSz="439781">
-                <a:defRPr/>
-              </a:pPr>
-              <a:r>
-                <a:rPr lang="te-IN" sz="2400" dirty="0">
-                  <a:latin typeface="Ramabhadra" panose="02000600000000000000" pitchFamily="2" charset="0"/>
-                  <a:cs typeface="Ramabhadra" panose="02000600000000000000" pitchFamily="2" charset="0"/>
-                </a:rPr>
-                <a:t>మమ్ము రక్షించి - నిత్య రాజ్యములో</a:t>
-              </a:r>
-            </a:p>
-            <a:p>
-              <a:pPr defTabSz="439781">
-                <a:defRPr/>
-              </a:pPr>
-              <a:r>
-                <a:rPr lang="te-IN" sz="2400" dirty="0">
-                  <a:latin typeface="Ramabhadra" panose="02000600000000000000" pitchFamily="2" charset="0"/>
-                  <a:cs typeface="Ramabhadra" panose="02000600000000000000" pitchFamily="2" charset="0"/>
-                </a:rPr>
-                <a:t>నడుపుము మా ప్రభువా -</a:t>
-              </a:r>
-            </a:p>
-            <a:p>
-              <a:pPr defTabSz="439781">
-                <a:defRPr/>
-              </a:pPr>
-              <a:r>
-                <a:rPr lang="te-IN" sz="2400" dirty="0">
-                  <a:latin typeface="Ramabhadra" panose="02000600000000000000" pitchFamily="2" charset="0"/>
-                  <a:cs typeface="Ramabhadra" panose="02000600000000000000" pitchFamily="2" charset="0"/>
-                </a:rPr>
-                <a:t>నడుపుము మా ప్రభువా</a:t>
-              </a:r>
-            </a:p>
-            <a:p>
-              <a:pPr defTabSz="439781">
-                <a:defRPr/>
-              </a:pPr>
-              <a:endParaRPr lang="te-IN" sz="2400" dirty="0">
+                <a:rPr lang="te-IN" sz="2100" dirty="0">
+                  <a:latin typeface="Ramabhadra" panose="02000600000000000000" pitchFamily="2" charset="0"/>
+                  <a:cs typeface="Ramabhadra" panose="02000600000000000000" pitchFamily="2" charset="0"/>
+                </a:rPr>
+                <a:t>నందున</a:t>
+              </a:r>
+            </a:p>
+            <a:p>
+              <a:pPr defTabSz="439781">
+                <a:defRPr/>
+              </a:pPr>
+              <a:r>
+                <a:rPr lang="te-IN" sz="2100" dirty="0">
+                  <a:latin typeface="Ramabhadra" panose="02000600000000000000" pitchFamily="2" charset="0"/>
+                  <a:cs typeface="Ramabhadra" panose="02000600000000000000" pitchFamily="2" charset="0"/>
+                </a:rPr>
+                <a:t>నీ అనాది ప్రణాళికలో...</a:t>
+              </a:r>
+            </a:p>
+            <a:p>
+              <a:pPr defTabSz="439781">
+                <a:defRPr/>
+              </a:pPr>
+              <a:r>
+                <a:rPr lang="te-IN" sz="2100" dirty="0">
+                  <a:latin typeface="Ramabhadra" panose="02000600000000000000" pitchFamily="2" charset="0"/>
+                  <a:cs typeface="Ramabhadra" panose="02000600000000000000" pitchFamily="2" charset="0"/>
+                </a:rPr>
+                <a:t>హర్షించెను నా హృదయసీమ</a:t>
+              </a:r>
+            </a:p>
+            <a:p>
+              <a:pPr defTabSz="439781">
+                <a:defRPr/>
+              </a:pPr>
+              <a:endParaRPr lang="te-IN" sz="2100" dirty="0">
                 <a:latin typeface="Ramabhadra" panose="02000600000000000000" pitchFamily="2" charset="0"/>
                 <a:cs typeface="Ramabhadra" panose="02000600000000000000" pitchFamily="2" charset="0"/>
               </a:endParaRPr>
@@ -3175,54 +3161,77 @@
                 <a:defRPr/>
               </a:pPr>
               <a:r>
-                <a:rPr lang="te-IN" sz="2400" dirty="0">
-                  <a:latin typeface="Ramabhadra" panose="02000600000000000000" pitchFamily="2" charset="0"/>
-                  <a:cs typeface="Ramabhadra" panose="02000600000000000000" pitchFamily="2" charset="0"/>
-                </a:rPr>
-                <a:t>కృంగిన వేళలలో – అలసిన సమయములో</a:t>
-              </a:r>
-            </a:p>
-            <a:p>
-              <a:pPr defTabSz="439781">
-                <a:defRPr/>
-              </a:pPr>
-              <a:r>
-                <a:rPr lang="te-IN" sz="2400" dirty="0">
-                  <a:latin typeface="Ramabhadra" panose="02000600000000000000" pitchFamily="2" charset="0"/>
-                  <a:cs typeface="Ramabhadra" panose="02000600000000000000" pitchFamily="2" charset="0"/>
-                </a:rPr>
-                <a:t>నా చేయి విడువకుము – నన్ను నిలబెట్టు</a:t>
-              </a:r>
-            </a:p>
-            <a:p>
-              <a:pPr defTabSz="439781">
-                <a:defRPr/>
-              </a:pPr>
-              <a:r>
-                <a:rPr lang="te-IN" sz="2400" dirty="0">
-                  <a:latin typeface="Ramabhadra" panose="02000600000000000000" pitchFamily="2" charset="0"/>
-                  <a:cs typeface="Ramabhadra" panose="02000600000000000000" pitchFamily="2" charset="0"/>
-                </a:rPr>
-                <a:t>యేసు నీ రక్తములో – శుద్ధి పరచి నన్ను</a:t>
-              </a:r>
-            </a:p>
-            <a:p>
-              <a:pPr defTabSz="439781">
-                <a:defRPr/>
-              </a:pPr>
-              <a:r>
-                <a:rPr lang="te-IN" sz="2400" dirty="0">
-                  <a:latin typeface="Ramabhadra" panose="02000600000000000000" pitchFamily="2" charset="0"/>
-                  <a:cs typeface="Ramabhadra" panose="02000600000000000000" pitchFamily="2" charset="0"/>
-                </a:rPr>
-                <a:t>నిలుపుము జ్యోతివలె – నిలుపుము జ్యోతివలె</a:t>
-              </a:r>
-            </a:p>
-            <a:p>
-              <a:pPr defTabSz="439781">
-                <a:defRPr/>
-              </a:pPr>
-              <a:endParaRPr lang="te-IN" sz="2400" dirty="0">
+                <a:rPr lang="te-IN" sz="2100" dirty="0">
+                  <a:latin typeface="Ramabhadra" panose="02000600000000000000" pitchFamily="2" charset="0"/>
+                  <a:cs typeface="Ramabhadra" panose="02000600000000000000" pitchFamily="2" charset="0"/>
+                </a:rPr>
+                <a:t>నీ పరిచర్యను తుదముట్టించుటే...</a:t>
+              </a:r>
+            </a:p>
+            <a:p>
+              <a:pPr defTabSz="439781">
+                <a:defRPr/>
+              </a:pPr>
+              <a:r>
+                <a:rPr lang="te-IN" sz="2100" dirty="0">
+                  <a:latin typeface="Ramabhadra" panose="02000600000000000000" pitchFamily="2" charset="0"/>
+                  <a:cs typeface="Ramabhadra" panose="02000600000000000000" pitchFamily="2" charset="0"/>
+                </a:rPr>
+                <a:t>నా నియమమాయెనే</a:t>
+              </a:r>
+            </a:p>
+            <a:p>
+              <a:pPr defTabSz="439781">
+                <a:defRPr/>
+              </a:pPr>
+              <a:r>
+                <a:rPr lang="te-IN" sz="2100" dirty="0">
+                  <a:latin typeface="Ramabhadra" panose="02000600000000000000" pitchFamily="2" charset="0"/>
+                  <a:cs typeface="Ramabhadra" panose="02000600000000000000" pitchFamily="2" charset="0"/>
+                </a:rPr>
+                <a:t>నీ సన్నిధిలో నీ పోందుకోరి...</a:t>
+              </a:r>
+              <a:r>
+                <a:rPr lang="en-IN" sz="2100" dirty="0">
+                  <a:latin typeface="Ramabhadra" panose="02000600000000000000" pitchFamily="2" charset="0"/>
+                  <a:cs typeface="Ramabhadra" panose="02000600000000000000" pitchFamily="2" charset="0"/>
+                </a:rPr>
+                <a:t> </a:t>
+              </a:r>
+              <a:r>
+                <a:rPr lang="te-IN" sz="2100" dirty="0">
+                  <a:latin typeface="Ramabhadra" panose="02000600000000000000" pitchFamily="2" charset="0"/>
+                  <a:cs typeface="Ramabhadra" panose="02000600000000000000" pitchFamily="2" charset="0"/>
+                </a:rPr>
+                <a:t>నీ స్నేహితుడనైతినే</a:t>
+              </a:r>
+            </a:p>
+            <a:p>
+              <a:pPr defTabSz="439781">
+                <a:defRPr/>
+              </a:pPr>
+              <a:r>
+                <a:rPr lang="te-IN" sz="2100" dirty="0">
+                  <a:latin typeface="Ramabhadra" panose="02000600000000000000" pitchFamily="2" charset="0"/>
+                  <a:cs typeface="Ramabhadra" panose="02000600000000000000" pitchFamily="2" charset="0"/>
+                </a:rPr>
+                <a:t>అహా..! నాధన్యత ఓహో...!</a:t>
+              </a:r>
+              <a:r>
+                <a:rPr lang="en-IN" sz="2100" dirty="0">
+                  <a:latin typeface="Ramabhadra" panose="02000600000000000000" pitchFamily="2" charset="0"/>
+                  <a:cs typeface="Ramabhadra" panose="02000600000000000000" pitchFamily="2" charset="0"/>
+                </a:rPr>
+                <a:t> </a:t>
+              </a:r>
+              <a:r>
+                <a:rPr lang="te-IN" sz="2100" dirty="0">
+                  <a:latin typeface="Ramabhadra" panose="02000600000000000000" pitchFamily="2" charset="0"/>
+                  <a:cs typeface="Ramabhadra" panose="02000600000000000000" pitchFamily="2" charset="0"/>
+                </a:rPr>
+                <a:t>నాభాగ్యము...</a:t>
+              </a:r>
+              <a:endParaRPr lang="en-IN" sz="2100" dirty="0">
                 <a:latin typeface="Ramabhadra" panose="02000600000000000000" pitchFamily="2" charset="0"/>
                 <a:cs typeface="Ramabhadra" panose="02000600000000000000" pitchFamily="2" charset="0"/>
               </a:endParaRPr>
@@ -3232,47 +3241,111 @@
                 <a:defRPr/>
               </a:pPr>
               <a:r>
-                <a:rPr lang="te-IN" sz="2400" dirty="0">
-                  <a:latin typeface="Ramabhadra" panose="02000600000000000000" pitchFamily="2" charset="0"/>
-                  <a:cs typeface="Ramabhadra" panose="02000600000000000000" pitchFamily="2" charset="0"/>
-                </a:rPr>
-                <a:t>సిలువని మోసుకొని – సువార్త చాటింప</a:t>
-              </a:r>
-            </a:p>
-            <a:p>
-              <a:pPr defTabSz="439781">
-                <a:defRPr/>
-              </a:pPr>
-              <a:r>
-                <a:rPr lang="te-IN" sz="2400" dirty="0">
-                  <a:latin typeface="Ramabhadra" panose="02000600000000000000" pitchFamily="2" charset="0"/>
-                  <a:cs typeface="Ramabhadra" panose="02000600000000000000" pitchFamily="2" charset="0"/>
-                </a:rPr>
-                <a:t>విలువగు నీ శక్తిచే – నిత్యము నడిపించు </a:t>
-              </a:r>
-            </a:p>
-            <a:p>
-              <a:pPr defTabSz="439781">
-                <a:defRPr/>
-              </a:pPr>
-              <a:r>
-                <a:rPr lang="te-IN" sz="2400" dirty="0">
-                  <a:latin typeface="Ramabhadra" panose="02000600000000000000" pitchFamily="2" charset="0"/>
-                  <a:cs typeface="Ramabhadra" panose="02000600000000000000" pitchFamily="2" charset="0"/>
-                </a:rPr>
-                <a:t>యేసు నీ రాకడలో – నిన్ను చూచుటకు</a:t>
-              </a:r>
-            </a:p>
-            <a:p>
-              <a:pPr defTabSz="439781">
-                <a:defRPr/>
-              </a:pPr>
-              <a:r>
-                <a:rPr lang="te-IN" sz="2400" dirty="0">
-                  <a:latin typeface="Ramabhadra" panose="02000600000000000000" pitchFamily="2" charset="0"/>
-                  <a:cs typeface="Ramabhadra" panose="02000600000000000000" pitchFamily="2" charset="0"/>
-                </a:rPr>
-                <a:t>నీ కృప నీయుమయా –నీ కృప నీయుమయా</a:t>
+                <a:rPr lang="te-IN" sz="2100" dirty="0">
+                  <a:latin typeface="Ramabhadra" panose="02000600000000000000" pitchFamily="2" charset="0"/>
+                  <a:cs typeface="Ramabhadra" panose="02000600000000000000" pitchFamily="2" charset="0"/>
+                </a:rPr>
+                <a:t>ఏమని వివరింతును</a:t>
+              </a:r>
+              <a:r>
+                <a:rPr lang="en-IN" sz="2100" dirty="0">
+                  <a:latin typeface="Ramabhadra" panose="02000600000000000000" pitchFamily="2" charset="0"/>
+                  <a:cs typeface="Ramabhadra" panose="02000600000000000000" pitchFamily="2" charset="0"/>
+                </a:rPr>
+                <a:t>...</a:t>
+              </a:r>
+              <a:endParaRPr lang="te-IN" sz="2100" dirty="0">
+                <a:latin typeface="Ramabhadra" panose="02000600000000000000" pitchFamily="2" charset="0"/>
+                <a:cs typeface="Ramabhadra" panose="02000600000000000000" pitchFamily="2" charset="0"/>
+              </a:endParaRPr>
+            </a:p>
+            <a:p>
+              <a:pPr defTabSz="439781">
+                <a:defRPr/>
+              </a:pPr>
+              <a:endParaRPr lang="te-IN" sz="2100" dirty="0">
+                <a:latin typeface="Ramabhadra" panose="02000600000000000000" pitchFamily="2" charset="0"/>
+                <a:cs typeface="Ramabhadra" panose="02000600000000000000" pitchFamily="2" charset="0"/>
+              </a:endParaRPr>
+            </a:p>
+            <a:p>
+              <a:pPr defTabSz="439781">
+                <a:defRPr/>
+              </a:pPr>
+              <a:r>
+                <a:rPr lang="te-IN" sz="2100" dirty="0">
+                  <a:latin typeface="Ramabhadra" panose="02000600000000000000" pitchFamily="2" charset="0"/>
+                  <a:cs typeface="Ramabhadra" panose="02000600000000000000" pitchFamily="2" charset="0"/>
+                </a:rPr>
+                <a:t>నీ శ్రమలలో పాలొందుటయే... నా దర్శనమాయెనే</a:t>
+              </a:r>
+            </a:p>
+            <a:p>
+              <a:pPr defTabSz="439781">
+                <a:defRPr/>
+              </a:pPr>
+              <a:r>
+                <a:rPr lang="te-IN" sz="2100" dirty="0">
+                  <a:latin typeface="Ramabhadra" panose="02000600000000000000" pitchFamily="2" charset="0"/>
+                  <a:cs typeface="Ramabhadra" panose="02000600000000000000" pitchFamily="2" charset="0"/>
+                </a:rPr>
+                <a:t>నా తనువందున శ్రమలు సహించి...</a:t>
+              </a:r>
+              <a:r>
+                <a:rPr lang="en-IN" sz="2100" dirty="0">
+                  <a:latin typeface="Ramabhadra" panose="02000600000000000000" pitchFamily="2" charset="0"/>
+                  <a:cs typeface="Ramabhadra" panose="02000600000000000000" pitchFamily="2" charset="0"/>
+                </a:rPr>
+                <a:t> </a:t>
+              </a:r>
+              <a:r>
+                <a:rPr lang="te-IN" dirty="0">
+                  <a:latin typeface="Ramabhadra" panose="02000600000000000000" pitchFamily="2" charset="0"/>
+                  <a:cs typeface="Ramabhadra" panose="02000600000000000000" pitchFamily="2" charset="0"/>
+                </a:rPr>
+                <a:t>నీ వారసుడనైతినే</a:t>
+              </a:r>
+            </a:p>
+            <a:p>
+              <a:pPr defTabSz="439781">
+                <a:defRPr/>
+              </a:pPr>
+              <a:r>
+                <a:rPr lang="te-IN" sz="2100" dirty="0">
+                  <a:latin typeface="Ramabhadra" panose="02000600000000000000" pitchFamily="2" charset="0"/>
+                  <a:cs typeface="Ramabhadra" panose="02000600000000000000" pitchFamily="2" charset="0"/>
+                </a:rPr>
+                <a:t>అహా..! నాధన్యత ఓహో...!</a:t>
+              </a:r>
+              <a:r>
+                <a:rPr lang="en-IN" sz="2100" dirty="0">
+                  <a:latin typeface="Ramabhadra" panose="02000600000000000000" pitchFamily="2" charset="0"/>
+                  <a:cs typeface="Ramabhadra" panose="02000600000000000000" pitchFamily="2" charset="0"/>
+                </a:rPr>
+                <a:t> </a:t>
+              </a:r>
+              <a:r>
+                <a:rPr lang="te-IN" sz="2100" dirty="0">
+                  <a:latin typeface="Ramabhadra" panose="02000600000000000000" pitchFamily="2" charset="0"/>
+                  <a:cs typeface="Ramabhadra" panose="02000600000000000000" pitchFamily="2" charset="0"/>
+                </a:rPr>
+                <a:t>నాభాగ్యము...</a:t>
+              </a:r>
+              <a:endParaRPr lang="en-IN" sz="2100" dirty="0">
+                <a:latin typeface="Ramabhadra" panose="02000600000000000000" pitchFamily="2" charset="0"/>
+                <a:cs typeface="Ramabhadra" panose="02000600000000000000" pitchFamily="2" charset="0"/>
+              </a:endParaRPr>
+            </a:p>
+            <a:p>
+              <a:pPr defTabSz="439781">
+                <a:defRPr/>
+              </a:pPr>
+              <a:r>
+                <a:rPr lang="te-IN" sz="2100" dirty="0">
+                  <a:latin typeface="Ramabhadra" panose="02000600000000000000" pitchFamily="2" charset="0"/>
+                  <a:cs typeface="Ramabhadra" panose="02000600000000000000" pitchFamily="2" charset="0"/>
+                </a:rPr>
+                <a:t>ఏమని వివరింతును</a:t>
               </a:r>
             </a:p>
           </p:txBody>
@@ -3335,788 +3408,6 @@
                   </a:solidFill>
                 </a:rPr>
                 <a:t>4</a:t>
-              </a:r>
-            </a:p>
-          </p:txBody>
-        </p:sp>
-      </p:grpSp>
-      <p:grpSp>
-        <p:nvGrpSpPr>
-          <p:cNvPr id="10" name="Group 9">
-            <a:extLst>
-              <a:ext uri="{FF2B5EF4-FFF2-40B4-BE49-F238E27FC236}">
-                <a16:creationId xmlns:a16="http://schemas.microsoft.com/office/drawing/2014/main" id="{BD4861E3-0140-4666-A772-E1339125A35F}"/>
-              </a:ext>
-            </a:extLst>
-          </p:cNvPr>
-          <p:cNvGrpSpPr/>
-          <p:nvPr/>
-        </p:nvGrpSpPr>
-        <p:grpSpPr>
-          <a:xfrm>
-            <a:off x="5104338" y="182031"/>
-            <a:ext cx="4711520" cy="6493935"/>
-            <a:chOff x="160868" y="182032"/>
-            <a:chExt cx="4711520" cy="6493935"/>
-          </a:xfrm>
-        </p:grpSpPr>
-        <p:sp>
-          <p:nvSpPr>
-            <p:cNvPr id="11" name="Rectangle 10">
-              <a:extLst>
-                <a:ext uri="{FF2B5EF4-FFF2-40B4-BE49-F238E27FC236}">
-                  <a16:creationId xmlns:a16="http://schemas.microsoft.com/office/drawing/2014/main" id="{0E606F7A-0439-43E4-A07F-A35A8691EB42}"/>
-                </a:ext>
-              </a:extLst>
-            </p:cNvPr>
-            <p:cNvSpPr/>
-            <p:nvPr/>
-          </p:nvSpPr>
-          <p:spPr>
-            <a:xfrm>
-              <a:off x="160868" y="182032"/>
-              <a:ext cx="4648200" cy="6493935"/>
-            </a:xfrm>
-            <a:prstGeom prst="rect">
-              <a:avLst/>
-            </a:prstGeom>
-            <a:noFill/>
-            <a:ln w="19050" cmpd="thinThick">
-              <a:solidFill>
-                <a:schemeClr val="tx1">
-                  <a:lumMod val="50000"/>
-                  <a:lumOff val="50000"/>
-                </a:schemeClr>
-              </a:solidFill>
-            </a:ln>
-          </p:spPr>
-          <p:style>
-            <a:lnRef idx="2">
-              <a:schemeClr val="accent1">
-                <a:shade val="50000"/>
-              </a:schemeClr>
-            </a:lnRef>
-            <a:fillRef idx="1">
-              <a:schemeClr val="accent1"/>
-            </a:fillRef>
-            <a:effectRef idx="0">
-              <a:schemeClr val="accent1"/>
-            </a:effectRef>
-            <a:fontRef idx="minor">
-              <a:schemeClr val="lt1"/>
-            </a:fontRef>
-          </p:style>
-          <p:txBody>
-            <a:bodyPr rtlCol="0" anchor="ctr"/>
-            <a:lstStyle/>
-            <a:p>
-              <a:pPr algn="ctr"/>
-              <a:endParaRPr lang="en-IN"/>
-            </a:p>
-          </p:txBody>
-        </p:sp>
-        <p:sp>
-          <p:nvSpPr>
-            <p:cNvPr id="12" name="TextBox 11">
-              <a:extLst>
-                <a:ext uri="{FF2B5EF4-FFF2-40B4-BE49-F238E27FC236}">
-                  <a16:creationId xmlns:a16="http://schemas.microsoft.com/office/drawing/2014/main" id="{DD950E5A-63C0-4187-892B-9549599FCD15}"/>
-                </a:ext>
-              </a:extLst>
-            </p:cNvPr>
-            <p:cNvSpPr txBox="1"/>
-            <p:nvPr/>
-          </p:nvSpPr>
-          <p:spPr>
-            <a:xfrm>
-              <a:off x="331082" y="742713"/>
-              <a:ext cx="4541306" cy="5647700"/>
-            </a:xfrm>
-            <a:prstGeom prst="rect">
-              <a:avLst/>
-            </a:prstGeom>
-            <a:noFill/>
-          </p:spPr>
-          <p:txBody>
-            <a:bodyPr wrap="square" rtlCol="0">
-              <a:spAutoFit/>
-            </a:bodyPr>
-            <a:lstStyle/>
-            <a:p>
-              <a:pPr defTabSz="439781">
-                <a:defRPr/>
-              </a:pPr>
-              <a:r>
-                <a:rPr lang="te-IN" sz="1900" dirty="0">
-                  <a:latin typeface="Ramabhadra" panose="02000600000000000000" pitchFamily="2" charset="0"/>
-                  <a:cs typeface="Ramabhadra" panose="02000600000000000000" pitchFamily="2" charset="0"/>
-                </a:rPr>
-                <a:t>స్తుతి పాడుటకే బ్రతికించిన – జీవనదాతవు నీవేనయ్యా</a:t>
-              </a:r>
-            </a:p>
-            <a:p>
-              <a:pPr defTabSz="439781">
-                <a:defRPr/>
-              </a:pPr>
-              <a:r>
-                <a:rPr lang="te-IN" sz="1900" dirty="0">
-                  <a:latin typeface="Ramabhadra" panose="02000600000000000000" pitchFamily="2" charset="0"/>
-                  <a:cs typeface="Ramabhadra" panose="02000600000000000000" pitchFamily="2" charset="0"/>
-                </a:rPr>
-                <a:t>ఇన్నాళ్లుగా నను పోషించిన – తల్లివలె నను ఓదార్చిన</a:t>
-              </a:r>
-            </a:p>
-            <a:p>
-              <a:pPr defTabSz="439781">
-                <a:defRPr/>
-              </a:pPr>
-              <a:r>
-                <a:rPr lang="te-IN" sz="1900" dirty="0">
-                  <a:latin typeface="Ramabhadra" panose="02000600000000000000" pitchFamily="2" charset="0"/>
-                  <a:cs typeface="Ramabhadra" panose="02000600000000000000" pitchFamily="2" charset="0"/>
-                </a:rPr>
-                <a:t>నీ ప్రేమ నాపై ఎన్నడు మారదు యేసయ్యా (2)</a:t>
-              </a:r>
-            </a:p>
-            <a:p>
-              <a:pPr defTabSz="439781">
-                <a:defRPr/>
-              </a:pPr>
-              <a:r>
-                <a:rPr lang="te-IN" sz="1900" dirty="0">
-                  <a:latin typeface="Ramabhadra" panose="02000600000000000000" pitchFamily="2" charset="0"/>
-                  <a:cs typeface="Ramabhadra" panose="02000600000000000000" pitchFamily="2" charset="0"/>
-                </a:rPr>
-                <a:t>జీవితకాలమంతా ఆధారం నీవేనయ్యా</a:t>
-              </a:r>
-            </a:p>
-            <a:p>
-              <a:pPr defTabSz="439781">
-                <a:defRPr/>
-              </a:pPr>
-              <a:r>
-                <a:rPr lang="te-IN" sz="1900" dirty="0">
-                  <a:latin typeface="Ramabhadra" panose="02000600000000000000" pitchFamily="2" charset="0"/>
-                  <a:cs typeface="Ramabhadra" panose="02000600000000000000" pitchFamily="2" charset="0"/>
-                </a:rPr>
-                <a:t>నా జీవితకాలమంతా ఆరాధించి ఘనపరతును</a:t>
-              </a:r>
-            </a:p>
-            <a:p>
-              <a:pPr defTabSz="439781">
-                <a:defRPr/>
-              </a:pPr>
-              <a:endParaRPr lang="te-IN" sz="1900" dirty="0">
-                <a:latin typeface="Ramabhadra" panose="02000600000000000000" pitchFamily="2" charset="0"/>
-                <a:cs typeface="Ramabhadra" panose="02000600000000000000" pitchFamily="2" charset="0"/>
-              </a:endParaRPr>
-            </a:p>
-            <a:p>
-              <a:pPr defTabSz="439781">
-                <a:defRPr/>
-              </a:pPr>
-              <a:r>
-                <a:rPr lang="te-IN" sz="1900" dirty="0">
-                  <a:latin typeface="Ramabhadra" panose="02000600000000000000" pitchFamily="2" charset="0"/>
-                  <a:cs typeface="Ramabhadra" panose="02000600000000000000" pitchFamily="2" charset="0"/>
-                </a:rPr>
-                <a:t>ప్రాణభయమును తొలగించినావు -</a:t>
-              </a:r>
-            </a:p>
-            <a:p>
-              <a:pPr defTabSz="439781">
-                <a:defRPr/>
-              </a:pPr>
-              <a:r>
-                <a:rPr lang="te-IN" sz="1900" dirty="0">
-                  <a:latin typeface="Ramabhadra" panose="02000600000000000000" pitchFamily="2" charset="0"/>
-                  <a:cs typeface="Ramabhadra" panose="02000600000000000000" pitchFamily="2" charset="0"/>
-                </a:rPr>
-                <a:t>ప్రాకారములను స్థాపించినావు</a:t>
-              </a:r>
-            </a:p>
-            <a:p>
-              <a:pPr defTabSz="439781">
-                <a:defRPr/>
-              </a:pPr>
-              <a:r>
-                <a:rPr lang="te-IN" sz="1900" dirty="0">
-                  <a:latin typeface="Ramabhadra" panose="02000600000000000000" pitchFamily="2" charset="0"/>
-                  <a:cs typeface="Ramabhadra" panose="02000600000000000000" pitchFamily="2" charset="0"/>
-                </a:rPr>
-                <a:t>సర్వజనులలో నీ మహిమ వివరింప -</a:t>
-              </a:r>
-            </a:p>
-            <a:p>
-              <a:pPr defTabSz="439781">
-                <a:defRPr/>
-              </a:pPr>
-              <a:r>
-                <a:rPr lang="te-IN" sz="1900" dirty="0">
-                  <a:latin typeface="Ramabhadra" panose="02000600000000000000" pitchFamily="2" charset="0"/>
-                  <a:cs typeface="Ramabhadra" panose="02000600000000000000" pitchFamily="2" charset="0"/>
-                </a:rPr>
-                <a:t>దీర్ఘాయువుతో నను నింపినావు (2)</a:t>
-              </a:r>
-            </a:p>
-            <a:p>
-              <a:pPr defTabSz="439781">
-                <a:defRPr/>
-              </a:pPr>
-              <a:r>
-                <a:rPr lang="te-IN" sz="1900" dirty="0">
-                  <a:latin typeface="Ramabhadra" panose="02000600000000000000" pitchFamily="2" charset="0"/>
-                  <a:cs typeface="Ramabhadra" panose="02000600000000000000" pitchFamily="2" charset="0"/>
-                </a:rPr>
-                <a:t>నీ కృపా బాహుళ్యమే వీడని అనుబంధమై</a:t>
-              </a:r>
-            </a:p>
-            <a:p>
-              <a:pPr defTabSz="439781">
-                <a:defRPr/>
-              </a:pPr>
-              <a:r>
-                <a:rPr lang="te-IN" sz="1900" dirty="0">
-                  <a:latin typeface="Ramabhadra" panose="02000600000000000000" pitchFamily="2" charset="0"/>
-                  <a:cs typeface="Ramabhadra" panose="02000600000000000000" pitchFamily="2" charset="0"/>
-                </a:rPr>
-                <a:t>తలచిన ప్రతిక్షణమున నూతన బలమిచ్చెను</a:t>
-              </a:r>
-            </a:p>
-            <a:p>
-              <a:pPr defTabSz="439781">
-                <a:defRPr/>
-              </a:pPr>
-              <a:endParaRPr lang="te-IN" sz="1900" dirty="0">
-                <a:latin typeface="Ramabhadra" panose="02000600000000000000" pitchFamily="2" charset="0"/>
-                <a:cs typeface="Ramabhadra" panose="02000600000000000000" pitchFamily="2" charset="0"/>
-              </a:endParaRPr>
-            </a:p>
-            <a:p>
-              <a:pPr defTabSz="439781">
-                <a:defRPr/>
-              </a:pPr>
-              <a:r>
-                <a:rPr lang="te-IN" sz="1900" dirty="0">
-                  <a:latin typeface="Ramabhadra" panose="02000600000000000000" pitchFamily="2" charset="0"/>
-                  <a:cs typeface="Ramabhadra" panose="02000600000000000000" pitchFamily="2" charset="0"/>
-                </a:rPr>
-                <a:t>నాపై ఉదయించె నీ మహిమ కిరణాలు –</a:t>
-              </a:r>
-            </a:p>
-            <a:p>
-              <a:pPr defTabSz="439781">
-                <a:defRPr/>
-              </a:pPr>
-              <a:r>
-                <a:rPr lang="te-IN" sz="1900" dirty="0">
-                  <a:latin typeface="Ramabhadra" panose="02000600000000000000" pitchFamily="2" charset="0"/>
-                  <a:cs typeface="Ramabhadra" panose="02000600000000000000" pitchFamily="2" charset="0"/>
-                </a:rPr>
-                <a:t>కనుమరుగాయెను నా దుఖ:దినములు</a:t>
-              </a:r>
-            </a:p>
-            <a:p>
-              <a:pPr defTabSz="439781">
-                <a:defRPr/>
-              </a:pPr>
-              <a:r>
-                <a:rPr lang="te-IN" sz="1900" dirty="0">
-                  <a:latin typeface="Ramabhadra" panose="02000600000000000000" pitchFamily="2" charset="0"/>
-                  <a:cs typeface="Ramabhadra" panose="02000600000000000000" pitchFamily="2" charset="0"/>
-                </a:rPr>
-                <a:t>కృపలనుపొంది నీ కాడి మోయుటకు -</a:t>
-              </a:r>
-            </a:p>
-            <a:p>
-              <a:pPr defTabSz="439781">
-                <a:defRPr/>
-              </a:pPr>
-              <a:r>
-                <a:rPr lang="te-IN" sz="1900" dirty="0">
-                  <a:latin typeface="Ramabhadra" panose="02000600000000000000" pitchFamily="2" charset="0"/>
-                  <a:cs typeface="Ramabhadra" panose="02000600000000000000" pitchFamily="2" charset="0"/>
-                </a:rPr>
-                <a:t>లోకములోనుండి ఏర్పరచినావు (2)</a:t>
-              </a:r>
-            </a:p>
-            <a:p>
-              <a:pPr defTabSz="439781">
-                <a:defRPr/>
-              </a:pPr>
-              <a:r>
-                <a:rPr lang="te-IN" sz="1900" dirty="0">
-                  <a:latin typeface="Ramabhadra" panose="02000600000000000000" pitchFamily="2" charset="0"/>
-                  <a:cs typeface="Ramabhadra" panose="02000600000000000000" pitchFamily="2" charset="0"/>
-                </a:rPr>
-                <a:t>నీ దివ్య సంకల్పమే- అవనిలో శుభప్రదమై</a:t>
-              </a:r>
-            </a:p>
-            <a:p>
-              <a:pPr defTabSz="439781">
-                <a:defRPr/>
-              </a:pPr>
-              <a:r>
-                <a:rPr lang="te-IN" sz="1900" dirty="0">
-                  <a:latin typeface="Ramabhadra" panose="02000600000000000000" pitchFamily="2" charset="0"/>
-                  <a:cs typeface="Ramabhadra" panose="02000600000000000000" pitchFamily="2" charset="0"/>
-                </a:rPr>
-                <a:t>నీ నిత్య రాజ్యమునకై నిరీక్షణ కలిగించెను</a:t>
-              </a:r>
-            </a:p>
-          </p:txBody>
-        </p:sp>
-        <p:sp>
-          <p:nvSpPr>
-            <p:cNvPr id="13" name="Oval 12">
-              <a:extLst>
-                <a:ext uri="{FF2B5EF4-FFF2-40B4-BE49-F238E27FC236}">
-                  <a16:creationId xmlns:a16="http://schemas.microsoft.com/office/drawing/2014/main" id="{26F461D1-594E-4D24-8238-761378173A6A}"/>
-                </a:ext>
-              </a:extLst>
-            </p:cNvPr>
-            <p:cNvSpPr/>
-            <p:nvPr/>
-          </p:nvSpPr>
-          <p:spPr>
-            <a:xfrm>
-              <a:off x="343961" y="326430"/>
-              <a:ext cx="390525" cy="390525"/>
-            </a:xfrm>
-            <a:prstGeom prst="ellipse">
-              <a:avLst/>
-            </a:prstGeom>
-            <a:noFill/>
-            <a:ln w="19050">
-              <a:solidFill>
-                <a:schemeClr val="tx1">
-                  <a:lumMod val="50000"/>
-                  <a:lumOff val="50000"/>
-                </a:schemeClr>
-              </a:solidFill>
-            </a:ln>
-          </p:spPr>
-          <p:style>
-            <a:lnRef idx="2">
-              <a:schemeClr val="accent1">
-                <a:shade val="50000"/>
-              </a:schemeClr>
-            </a:lnRef>
-            <a:fillRef idx="1">
-              <a:schemeClr val="accent1"/>
-            </a:fillRef>
-            <a:effectRef idx="0">
-              <a:schemeClr val="accent1"/>
-            </a:effectRef>
-            <a:fontRef idx="minor">
-              <a:schemeClr val="lt1"/>
-            </a:fontRef>
-          </p:style>
-          <p:txBody>
-            <a:bodyPr rtlCol="0" anchor="ctr"/>
-            <a:lstStyle/>
-            <a:p>
-              <a:pPr algn="ctr"/>
-              <a:r>
-                <a:rPr lang="en-IN" dirty="0">
-                  <a:solidFill>
-                    <a:schemeClr val="tx1"/>
-                  </a:solidFill>
-                </a:rPr>
-                <a:t>1</a:t>
-              </a:r>
-            </a:p>
-          </p:txBody>
-        </p:sp>
-      </p:grpSp>
-    </p:spTree>
-    <p:extLst>
-      <p:ext uri="{BB962C8B-B14F-4D97-AF65-F5344CB8AC3E}">
-        <p14:creationId xmlns:p14="http://schemas.microsoft.com/office/powerpoint/2010/main" val="3342490066"/>
-      </p:ext>
-    </p:extLst>
-  </p:cSld>
-  <p:clrMapOvr>
-    <a:masterClrMapping/>
-  </p:clrMapOvr>
-</p:sld>
-</file>
-
-<file path=ppt/slides/slide2.xml><?xml version="1.0" encoding="utf-8"?>
-<p:sld xmlns:a="http://schemas.openxmlformats.org/drawingml/2006/main" xmlns:r="http://schemas.openxmlformats.org/officeDocument/2006/relationships" xmlns:p="http://schemas.openxmlformats.org/presentationml/2006/main">
-  <p:cSld>
-    <p:spTree>
-      <p:nvGrpSpPr>
-        <p:cNvPr id="1" name=""/>
-        <p:cNvGrpSpPr/>
-        <p:nvPr/>
-      </p:nvGrpSpPr>
-      <p:grpSpPr>
-        <a:xfrm>
-          <a:off x="0" y="0"/>
-          <a:ext cx="0" cy="0"/>
-          <a:chOff x="0" y="0"/>
-          <a:chExt cx="0" cy="0"/>
-        </a:xfrm>
-      </p:grpSpPr>
-      <p:grpSp>
-        <p:nvGrpSpPr>
-          <p:cNvPr id="9" name="Group 8">
-            <a:extLst>
-              <a:ext uri="{FF2B5EF4-FFF2-40B4-BE49-F238E27FC236}">
-                <a16:creationId xmlns:a16="http://schemas.microsoft.com/office/drawing/2014/main" id="{A7E1EC36-C610-4951-92FB-5FA9BAA559EC}"/>
-              </a:ext>
-            </a:extLst>
-          </p:cNvPr>
-          <p:cNvGrpSpPr/>
-          <p:nvPr/>
-        </p:nvGrpSpPr>
-        <p:grpSpPr>
-          <a:xfrm>
-            <a:off x="160868" y="182032"/>
-            <a:ext cx="4780852" cy="6493935"/>
-            <a:chOff x="160868" y="182032"/>
-            <a:chExt cx="4780852" cy="6493935"/>
-          </a:xfrm>
-        </p:grpSpPr>
-        <p:sp>
-          <p:nvSpPr>
-            <p:cNvPr id="4" name="Rectangle 3">
-              <a:extLst>
-                <a:ext uri="{FF2B5EF4-FFF2-40B4-BE49-F238E27FC236}">
-                  <a16:creationId xmlns:a16="http://schemas.microsoft.com/office/drawing/2014/main" id="{7B702E0D-FD8D-4F00-8F9D-9ACEED91C763}"/>
-                </a:ext>
-              </a:extLst>
-            </p:cNvPr>
-            <p:cNvSpPr/>
-            <p:nvPr/>
-          </p:nvSpPr>
-          <p:spPr>
-            <a:xfrm>
-              <a:off x="160868" y="182032"/>
-              <a:ext cx="4648200" cy="6493935"/>
-            </a:xfrm>
-            <a:prstGeom prst="rect">
-              <a:avLst/>
-            </a:prstGeom>
-            <a:noFill/>
-            <a:ln w="19050" cmpd="thinThick">
-              <a:solidFill>
-                <a:schemeClr val="tx1">
-                  <a:lumMod val="50000"/>
-                  <a:lumOff val="50000"/>
-                </a:schemeClr>
-              </a:solidFill>
-            </a:ln>
-          </p:spPr>
-          <p:style>
-            <a:lnRef idx="2">
-              <a:schemeClr val="accent1">
-                <a:shade val="50000"/>
-              </a:schemeClr>
-            </a:lnRef>
-            <a:fillRef idx="1">
-              <a:schemeClr val="accent1"/>
-            </a:fillRef>
-            <a:effectRef idx="0">
-              <a:schemeClr val="accent1"/>
-            </a:effectRef>
-            <a:fontRef idx="minor">
-              <a:schemeClr val="lt1"/>
-            </a:fontRef>
-          </p:style>
-          <p:txBody>
-            <a:bodyPr rtlCol="0" anchor="ctr"/>
-            <a:lstStyle/>
-            <a:p>
-              <a:pPr algn="ctr"/>
-              <a:endParaRPr lang="en-IN"/>
-            </a:p>
-          </p:txBody>
-        </p:sp>
-        <p:sp>
-          <p:nvSpPr>
-            <p:cNvPr id="7" name="TextBox 6">
-              <a:extLst>
-                <a:ext uri="{FF2B5EF4-FFF2-40B4-BE49-F238E27FC236}">
-                  <a16:creationId xmlns:a16="http://schemas.microsoft.com/office/drawing/2014/main" id="{C5F65C11-52F8-415B-A70B-C02268F6F4A1}"/>
-                </a:ext>
-              </a:extLst>
-            </p:cNvPr>
-            <p:cNvSpPr txBox="1"/>
-            <p:nvPr/>
-          </p:nvSpPr>
-          <p:spPr>
-            <a:xfrm>
-              <a:off x="293520" y="758873"/>
-              <a:ext cx="4648200" cy="5847755"/>
-            </a:xfrm>
-            <a:prstGeom prst="rect">
-              <a:avLst/>
-            </a:prstGeom>
-            <a:noFill/>
-          </p:spPr>
-          <p:txBody>
-            <a:bodyPr wrap="square" rtlCol="0">
-              <a:spAutoFit/>
-            </a:bodyPr>
-            <a:lstStyle/>
-            <a:p>
-              <a:pPr defTabSz="439781">
-                <a:defRPr/>
-              </a:pPr>
-              <a:r>
-                <a:rPr lang="te-IN" sz="2200" dirty="0">
-                  <a:latin typeface="Ramabhadra" panose="02000600000000000000" pitchFamily="2" charset="0"/>
-                  <a:cs typeface="Ramabhadra" panose="02000600000000000000" pitchFamily="2" charset="0"/>
-                </a:rPr>
-                <a:t>కృపలను తలంచుచు (2)</a:t>
-              </a:r>
-            </a:p>
-            <a:p>
-              <a:pPr defTabSz="439781">
-                <a:defRPr/>
-              </a:pPr>
-              <a:r>
-                <a:rPr lang="te-IN" sz="2200" dirty="0">
-                  <a:latin typeface="Ramabhadra" panose="02000600000000000000" pitchFamily="2" charset="0"/>
-                  <a:cs typeface="Ramabhadra" panose="02000600000000000000" pitchFamily="2" charset="0"/>
-                </a:rPr>
-                <a:t>ఆయుష్కాలమంతా ప్రభుని</a:t>
-              </a:r>
-            </a:p>
-            <a:p>
-              <a:pPr defTabSz="439781">
-                <a:defRPr/>
-              </a:pPr>
-              <a:r>
-                <a:rPr lang="te-IN" sz="2200" dirty="0">
-                  <a:latin typeface="Ramabhadra" panose="02000600000000000000" pitchFamily="2" charset="0"/>
-                  <a:cs typeface="Ramabhadra" panose="02000600000000000000" pitchFamily="2" charset="0"/>
-                </a:rPr>
-                <a:t>కృతజ్ఞతతో స్తుతింతున్ (2)</a:t>
-              </a:r>
-            </a:p>
-            <a:p>
-              <a:pPr defTabSz="439781">
-                <a:defRPr/>
-              </a:pPr>
-              <a:endParaRPr lang="te-IN" sz="2200" dirty="0">
-                <a:latin typeface="Ramabhadra" panose="02000600000000000000" pitchFamily="2" charset="0"/>
-                <a:cs typeface="Ramabhadra" panose="02000600000000000000" pitchFamily="2" charset="0"/>
-              </a:endParaRPr>
-            </a:p>
-            <a:p>
-              <a:pPr defTabSz="439781">
-                <a:defRPr/>
-              </a:pPr>
-              <a:r>
-                <a:rPr lang="te-IN" sz="2200" dirty="0">
-                  <a:latin typeface="Ramabhadra" panose="02000600000000000000" pitchFamily="2" charset="0"/>
-                  <a:cs typeface="Ramabhadra" panose="02000600000000000000" pitchFamily="2" charset="0"/>
-                </a:rPr>
-                <a:t>రూపింపబడుచున్న</a:t>
-              </a:r>
-            </a:p>
-            <a:p>
-              <a:pPr defTabSz="439781">
-                <a:defRPr/>
-              </a:pPr>
-              <a:r>
-                <a:rPr lang="te-IN" sz="2200" dirty="0">
-                  <a:latin typeface="Ramabhadra" panose="02000600000000000000" pitchFamily="2" charset="0"/>
-                  <a:cs typeface="Ramabhadra" panose="02000600000000000000" pitchFamily="2" charset="0"/>
-                </a:rPr>
-                <a:t>ఏ ఆయుధముండినను (2)</a:t>
-              </a:r>
-            </a:p>
-            <a:p>
-              <a:pPr defTabSz="439781">
-                <a:defRPr/>
-              </a:pPr>
-              <a:r>
-                <a:rPr lang="te-IN" sz="2200" dirty="0">
-                  <a:latin typeface="Ramabhadra" panose="02000600000000000000" pitchFamily="2" charset="0"/>
-                  <a:cs typeface="Ramabhadra" panose="02000600000000000000" pitchFamily="2" charset="0"/>
-                </a:rPr>
-                <a:t>నాకు విరోధమై వర్ధిల్లదు యని</a:t>
-              </a:r>
-            </a:p>
-            <a:p>
-              <a:pPr defTabSz="439781">
-                <a:defRPr/>
-              </a:pPr>
-              <a:r>
-                <a:rPr lang="te-IN" sz="2200" dirty="0">
-                  <a:latin typeface="Ramabhadra" panose="02000600000000000000" pitchFamily="2" charset="0"/>
-                  <a:cs typeface="Ramabhadra" panose="02000600000000000000" pitchFamily="2" charset="0"/>
-                </a:rPr>
-                <a:t>చెప్పిన మాట సత్యం – (2)</a:t>
-              </a:r>
-              <a:endParaRPr lang="en-IN" sz="2200" dirty="0">
-                <a:latin typeface="Ramabhadra" panose="02000600000000000000" pitchFamily="2" charset="0"/>
-                <a:cs typeface="Ramabhadra" panose="02000600000000000000" pitchFamily="2" charset="0"/>
-              </a:endParaRPr>
-            </a:p>
-            <a:p>
-              <a:pPr defTabSz="439781">
-                <a:defRPr/>
-              </a:pPr>
-              <a:endParaRPr lang="en-IN" sz="2200" dirty="0">
-                <a:latin typeface="Ramabhadra" panose="02000600000000000000" pitchFamily="2" charset="0"/>
-                <a:cs typeface="Ramabhadra" panose="02000600000000000000" pitchFamily="2" charset="0"/>
-              </a:endParaRPr>
-            </a:p>
-            <a:p>
-              <a:pPr defTabSz="439781">
-                <a:defRPr/>
-              </a:pPr>
-              <a:r>
-                <a:rPr lang="te-IN" sz="2200" dirty="0">
-                  <a:latin typeface="Ramabhadra" panose="02000600000000000000" pitchFamily="2" charset="0"/>
-                  <a:cs typeface="Ramabhadra" panose="02000600000000000000" pitchFamily="2" charset="0"/>
-                </a:rPr>
-                <a:t>కన్నీటి లోయలలో నే కృంగిన వేళలలో (2)</a:t>
-              </a:r>
-              <a:br>
-                <a:rPr lang="te-IN" sz="2200" dirty="0">
-                  <a:latin typeface="Ramabhadra" panose="02000600000000000000" pitchFamily="2" charset="0"/>
-                  <a:cs typeface="Ramabhadra" panose="02000600000000000000" pitchFamily="2" charset="0"/>
-                </a:rPr>
-              </a:br>
-              <a:r>
-                <a:rPr lang="te-IN" sz="2200" dirty="0">
-                  <a:latin typeface="Ramabhadra" panose="02000600000000000000" pitchFamily="2" charset="0"/>
-                  <a:cs typeface="Ramabhadra" panose="02000600000000000000" pitchFamily="2" charset="0"/>
-                </a:rPr>
-                <a:t>నింగిని చీల్చి వర్షము పంపి </a:t>
-              </a:r>
-              <a:br>
-                <a:rPr lang="te-IN" sz="2200" dirty="0">
-                  <a:latin typeface="Ramabhadra" panose="02000600000000000000" pitchFamily="2" charset="0"/>
-                  <a:cs typeface="Ramabhadra" panose="02000600000000000000" pitchFamily="2" charset="0"/>
-                </a:rPr>
-              </a:br>
-              <a:r>
-                <a:rPr lang="te-IN" sz="2200" dirty="0">
-                  <a:latin typeface="Ramabhadra" panose="02000600000000000000" pitchFamily="2" charset="0"/>
-                  <a:cs typeface="Ramabhadra" panose="02000600000000000000" pitchFamily="2" charset="0"/>
-                </a:rPr>
-                <a:t>నింపెను నా హృదయం (యేసు)</a:t>
-              </a:r>
-            </a:p>
-            <a:p>
-              <a:pPr defTabSz="439781">
-                <a:defRPr/>
-              </a:pPr>
-              <a:endParaRPr lang="en-IN" sz="2200" dirty="0">
-                <a:latin typeface="Ramabhadra" panose="02000600000000000000" pitchFamily="2" charset="0"/>
-                <a:cs typeface="Ramabhadra" panose="02000600000000000000" pitchFamily="2" charset="0"/>
-              </a:endParaRPr>
-            </a:p>
-            <a:p>
-              <a:pPr defTabSz="439781">
-                <a:defRPr/>
-              </a:pPr>
-              <a:r>
-                <a:rPr lang="te-IN" sz="2200" dirty="0">
-                  <a:latin typeface="Ramabhadra" panose="02000600000000000000" pitchFamily="2" charset="0"/>
-                  <a:cs typeface="Ramabhadra" panose="02000600000000000000" pitchFamily="2" charset="0"/>
-                </a:rPr>
-                <a:t>హల్లెలూయా ఆమెన్ ఆ.. నాకెంతో ఆనందమే (2)</a:t>
-              </a:r>
-            </a:p>
-            <a:p>
-              <a:pPr defTabSz="439781">
-                <a:defRPr/>
-              </a:pPr>
-              <a:r>
-                <a:rPr lang="te-IN" sz="2200" dirty="0">
-                  <a:latin typeface="Ramabhadra" panose="02000600000000000000" pitchFamily="2" charset="0"/>
-                  <a:cs typeface="Ramabhadra" panose="02000600000000000000" pitchFamily="2" charset="0"/>
-                </a:rPr>
-                <a:t>సీయోను నివాసం నాకెంతో ఆనందం</a:t>
-              </a:r>
-            </a:p>
-            <a:p>
-              <a:pPr defTabSz="439781">
-                <a:defRPr/>
-              </a:pPr>
-              <a:r>
-                <a:rPr lang="te-IN" sz="2200" dirty="0">
-                  <a:latin typeface="Ramabhadra" panose="02000600000000000000" pitchFamily="2" charset="0"/>
-                  <a:cs typeface="Ramabhadra" panose="02000600000000000000" pitchFamily="2" charset="0"/>
-                </a:rPr>
-                <a:t>ఆనందమానందమే – (2)</a:t>
-              </a:r>
-              <a:endParaRPr lang="en-IN" sz="2200" dirty="0">
-                <a:latin typeface="Ramabhadra" panose="02000600000000000000" pitchFamily="2" charset="0"/>
-                <a:cs typeface="Ramabhadra" panose="02000600000000000000" pitchFamily="2" charset="0"/>
-              </a:endParaRPr>
-            </a:p>
-            <a:p>
-              <a:endParaRPr lang="en-IN" sz="2200" dirty="0"/>
-            </a:p>
-          </p:txBody>
-        </p:sp>
-        <p:sp>
-          <p:nvSpPr>
-            <p:cNvPr id="8" name="Oval 7">
-              <a:extLst>
-                <a:ext uri="{FF2B5EF4-FFF2-40B4-BE49-F238E27FC236}">
-                  <a16:creationId xmlns:a16="http://schemas.microsoft.com/office/drawing/2014/main" id="{B70ED263-63AA-434F-8E88-AB7AD897A1CD}"/>
-                </a:ext>
-              </a:extLst>
-            </p:cNvPr>
-            <p:cNvSpPr/>
-            <p:nvPr/>
-          </p:nvSpPr>
-          <p:spPr>
-            <a:xfrm>
-              <a:off x="343961" y="326430"/>
-              <a:ext cx="390525" cy="390525"/>
-            </a:xfrm>
-            <a:prstGeom prst="ellipse">
-              <a:avLst/>
-            </a:prstGeom>
-            <a:noFill/>
-            <a:ln w="19050">
-              <a:solidFill>
-                <a:schemeClr val="tx1">
-                  <a:lumMod val="50000"/>
-                  <a:lumOff val="50000"/>
-                </a:schemeClr>
-              </a:solidFill>
-            </a:ln>
-          </p:spPr>
-          <p:style>
-            <a:lnRef idx="2">
-              <a:schemeClr val="accent1">
-                <a:shade val="50000"/>
-              </a:schemeClr>
-            </a:lnRef>
-            <a:fillRef idx="1">
-              <a:schemeClr val="accent1"/>
-            </a:fillRef>
-            <a:effectRef idx="0">
-              <a:schemeClr val="accent1"/>
-            </a:effectRef>
-            <a:fontRef idx="minor">
-              <a:schemeClr val="lt1"/>
-            </a:fontRef>
-          </p:style>
-          <p:txBody>
-            <a:bodyPr rtlCol="0" anchor="ctr"/>
-            <a:lstStyle/>
-            <a:p>
-              <a:pPr algn="ctr"/>
-              <a:r>
-                <a:rPr lang="en-IN" dirty="0">
-                  <a:solidFill>
-                    <a:schemeClr val="tx1"/>
-                  </a:solidFill>
-                </a:rPr>
-                <a:t>2</a:t>
               </a:r>
             </a:p>
           </p:txBody>
@@ -4211,8 +3502,8 @@
           </p:nvSpPr>
           <p:spPr>
             <a:xfrm>
-              <a:off x="343961" y="797511"/>
-              <a:ext cx="4541306" cy="5262979"/>
+              <a:off x="343961" y="841707"/>
+              <a:ext cx="4541306" cy="4832092"/>
             </a:xfrm>
             <a:prstGeom prst="rect">
               <a:avLst/>
@@ -4229,11 +3520,370 @@
                 <a:defRPr/>
               </a:pPr>
               <a:r>
+                <a:rPr lang="te-IN" sz="2200" dirty="0">
+                  <a:latin typeface="Ramabhadra" panose="02000600000000000000" pitchFamily="2" charset="0"/>
+                  <a:cs typeface="Ramabhadra" panose="02000600000000000000" pitchFamily="2" charset="0"/>
+                </a:rPr>
+                <a:t>స్తోత్రము చెల్లించెదము మన యేసుకే</a:t>
+              </a:r>
+            </a:p>
+            <a:p>
+              <a:pPr defTabSz="439781">
+                <a:defRPr/>
+              </a:pPr>
+              <a:r>
+                <a:rPr lang="te-IN" sz="2200" dirty="0">
+                  <a:latin typeface="Ramabhadra" panose="02000600000000000000" pitchFamily="2" charset="0"/>
+                  <a:cs typeface="Ramabhadra" panose="02000600000000000000" pitchFamily="2" charset="0"/>
+                </a:rPr>
+                <a:t>స్తోత్రము చెల్లించెదము</a:t>
+              </a:r>
+            </a:p>
+            <a:p>
+              <a:pPr defTabSz="439781">
+                <a:defRPr/>
+              </a:pPr>
+              <a:r>
+                <a:rPr lang="te-IN" sz="2200" dirty="0">
+                  <a:latin typeface="Ramabhadra" panose="02000600000000000000" pitchFamily="2" charset="0"/>
+                  <a:cs typeface="Ramabhadra" panose="02000600000000000000" pitchFamily="2" charset="0"/>
+                </a:rPr>
+                <a:t>మంచివాడు గొప్పవాడు మన దేవుడు</a:t>
+              </a:r>
+            </a:p>
+            <a:p>
+              <a:pPr defTabSz="439781">
+                <a:defRPr/>
+              </a:pPr>
+              <a:r>
+                <a:rPr lang="te-IN" sz="2200" dirty="0">
+                  <a:latin typeface="Ramabhadra" panose="02000600000000000000" pitchFamily="2" charset="0"/>
+                  <a:cs typeface="Ramabhadra" panose="02000600000000000000" pitchFamily="2" charset="0"/>
+                </a:rPr>
+                <a:t>వాక్యమునిచ్చు దేవుడు (2)</a:t>
+              </a:r>
+            </a:p>
+            <a:p>
+              <a:pPr defTabSz="439781">
+                <a:defRPr/>
+              </a:pPr>
+              <a:endParaRPr lang="te-IN" sz="2200" dirty="0">
+                <a:latin typeface="Ramabhadra" panose="02000600000000000000" pitchFamily="2" charset="0"/>
+                <a:cs typeface="Ramabhadra" panose="02000600000000000000" pitchFamily="2" charset="0"/>
+              </a:endParaRPr>
+            </a:p>
+            <a:p>
+              <a:pPr defTabSz="439781">
+                <a:defRPr/>
+              </a:pPr>
+              <a:r>
+                <a:rPr lang="te-IN" sz="2200" dirty="0">
+                  <a:latin typeface="Ramabhadra" panose="02000600000000000000" pitchFamily="2" charset="0"/>
+                  <a:cs typeface="Ramabhadra" panose="02000600000000000000" pitchFamily="2" charset="0"/>
+                </a:rPr>
+                <a:t>యెరికో మనకు ముందు వచ్చినా –</a:t>
+              </a:r>
+            </a:p>
+            <a:p>
+              <a:pPr defTabSz="439781">
+                <a:defRPr/>
+              </a:pPr>
+              <a:r>
+                <a:rPr lang="te-IN" sz="2200" dirty="0">
+                  <a:latin typeface="Ramabhadra" panose="02000600000000000000" pitchFamily="2" charset="0"/>
+                  <a:cs typeface="Ramabhadra" panose="02000600000000000000" pitchFamily="2" charset="0"/>
+                </a:rPr>
+                <a:t>క్రీస్తు యేసు ముందే నిలుచును</a:t>
+              </a:r>
+            </a:p>
+            <a:p>
+              <a:pPr defTabSz="439781">
+                <a:defRPr/>
+              </a:pPr>
+              <a:r>
+                <a:rPr lang="te-IN" sz="2200" dirty="0">
+                  <a:latin typeface="Ramabhadra" panose="02000600000000000000" pitchFamily="2" charset="0"/>
+                  <a:cs typeface="Ramabhadra" panose="02000600000000000000" pitchFamily="2" charset="0"/>
+                </a:rPr>
+                <a:t>భయపడకు దిగులు పడకు -</a:t>
+              </a:r>
+            </a:p>
+            <a:p>
+              <a:pPr defTabSz="439781">
+                <a:defRPr/>
+              </a:pPr>
+              <a:r>
+                <a:rPr lang="te-IN" sz="2200" dirty="0">
+                  <a:latin typeface="Ramabhadra" panose="02000600000000000000" pitchFamily="2" charset="0"/>
+                  <a:cs typeface="Ramabhadra" panose="02000600000000000000" pitchFamily="2" charset="0"/>
+                </a:rPr>
+                <a:t>ప్రార్ధించి స్తుతియించుము</a:t>
+              </a:r>
+            </a:p>
+            <a:p>
+              <a:pPr defTabSz="439781">
+                <a:defRPr/>
+              </a:pPr>
+              <a:endParaRPr lang="te-IN" sz="2200" dirty="0">
+                <a:latin typeface="Ramabhadra" panose="02000600000000000000" pitchFamily="2" charset="0"/>
+                <a:cs typeface="Ramabhadra" panose="02000600000000000000" pitchFamily="2" charset="0"/>
+              </a:endParaRPr>
+            </a:p>
+            <a:p>
+              <a:pPr defTabSz="439781">
+                <a:defRPr/>
+              </a:pPr>
+              <a:r>
+                <a:rPr lang="te-IN" sz="2200" dirty="0">
+                  <a:latin typeface="Ramabhadra" panose="02000600000000000000" pitchFamily="2" charset="0"/>
+                  <a:cs typeface="Ramabhadra" panose="02000600000000000000" pitchFamily="2" charset="0"/>
+                </a:rPr>
+                <a:t>గొల్యాత్ మనకు ఎదురు వచ్చినా –</a:t>
+              </a:r>
+            </a:p>
+            <a:p>
+              <a:pPr defTabSz="439781">
+                <a:defRPr/>
+              </a:pPr>
+              <a:r>
+                <a:rPr lang="te-IN" sz="2200" dirty="0">
+                  <a:latin typeface="Ramabhadra" panose="02000600000000000000" pitchFamily="2" charset="0"/>
+                  <a:cs typeface="Ramabhadra" panose="02000600000000000000" pitchFamily="2" charset="0"/>
+                </a:rPr>
+                <a:t>క్రీస్తుయేసు ముందే నిలుచును</a:t>
+              </a:r>
+            </a:p>
+            <a:p>
+              <a:pPr defTabSz="439781">
+                <a:defRPr/>
+              </a:pPr>
+              <a:r>
+                <a:rPr lang="te-IN" sz="2200" dirty="0">
+                  <a:latin typeface="Ramabhadra" panose="02000600000000000000" pitchFamily="2" charset="0"/>
+                  <a:cs typeface="Ramabhadra" panose="02000600000000000000" pitchFamily="2" charset="0"/>
+                </a:rPr>
+                <a:t>హల్లేలూయా – హల్లేలూయా</a:t>
+              </a:r>
+            </a:p>
+            <a:p>
+              <a:pPr defTabSz="439781">
+                <a:defRPr/>
+              </a:pPr>
+              <a:r>
+                <a:rPr lang="te-IN" sz="2200" dirty="0">
+                  <a:latin typeface="Ramabhadra" panose="02000600000000000000" pitchFamily="2" charset="0"/>
+                  <a:cs typeface="Ramabhadra" panose="02000600000000000000" pitchFamily="2" charset="0"/>
+                </a:rPr>
+                <a:t>జయమని పాడెదమూ</a:t>
+              </a:r>
+            </a:p>
+          </p:txBody>
+        </p:sp>
+        <p:sp>
+          <p:nvSpPr>
+            <p:cNvPr id="13" name="Oval 12">
+              <a:extLst>
+                <a:ext uri="{FF2B5EF4-FFF2-40B4-BE49-F238E27FC236}">
+                  <a16:creationId xmlns:a16="http://schemas.microsoft.com/office/drawing/2014/main" id="{26F461D1-594E-4D24-8238-761378173A6A}"/>
+                </a:ext>
+              </a:extLst>
+            </p:cNvPr>
+            <p:cNvSpPr/>
+            <p:nvPr/>
+          </p:nvSpPr>
+          <p:spPr>
+            <a:xfrm>
+              <a:off x="343961" y="326430"/>
+              <a:ext cx="390525" cy="390525"/>
+            </a:xfrm>
+            <a:prstGeom prst="ellipse">
+              <a:avLst/>
+            </a:prstGeom>
+            <a:noFill/>
+            <a:ln w="19050">
+              <a:solidFill>
+                <a:schemeClr val="tx1">
+                  <a:lumMod val="50000"/>
+                  <a:lumOff val="50000"/>
+                </a:schemeClr>
+              </a:solidFill>
+            </a:ln>
+          </p:spPr>
+          <p:style>
+            <a:lnRef idx="2">
+              <a:schemeClr val="accent1">
+                <a:shade val="50000"/>
+              </a:schemeClr>
+            </a:lnRef>
+            <a:fillRef idx="1">
+              <a:schemeClr val="accent1"/>
+            </a:fillRef>
+            <a:effectRef idx="0">
+              <a:schemeClr val="accent1"/>
+            </a:effectRef>
+            <a:fontRef idx="minor">
+              <a:schemeClr val="lt1"/>
+            </a:fontRef>
+          </p:style>
+          <p:txBody>
+            <a:bodyPr rtlCol="0" anchor="ctr"/>
+            <a:lstStyle/>
+            <a:p>
+              <a:pPr algn="ctr"/>
+              <a:r>
+                <a:rPr lang="en-IN" dirty="0">
+                  <a:solidFill>
+                    <a:schemeClr val="tx1"/>
+                  </a:solidFill>
+                </a:rPr>
+                <a:t>1</a:t>
+              </a:r>
+            </a:p>
+          </p:txBody>
+        </p:sp>
+      </p:grpSp>
+    </p:spTree>
+    <p:extLst>
+      <p:ext uri="{BB962C8B-B14F-4D97-AF65-F5344CB8AC3E}">
+        <p14:creationId xmlns:p14="http://schemas.microsoft.com/office/powerpoint/2010/main" val="3342490066"/>
+      </p:ext>
+    </p:extLst>
+  </p:cSld>
+  <p:clrMapOvr>
+    <a:masterClrMapping/>
+  </p:clrMapOvr>
+</p:sld>
+</file>
+
+<file path=ppt/slides/slide2.xml><?xml version="1.0" encoding="utf-8"?>
+<p:sld xmlns:a="http://schemas.openxmlformats.org/drawingml/2006/main" xmlns:r="http://schemas.openxmlformats.org/officeDocument/2006/relationships" xmlns:p="http://schemas.openxmlformats.org/presentationml/2006/main">
+  <p:cSld>
+    <p:spTree>
+      <p:nvGrpSpPr>
+        <p:cNvPr id="1" name=""/>
+        <p:cNvGrpSpPr/>
+        <p:nvPr/>
+      </p:nvGrpSpPr>
+      <p:grpSpPr>
+        <a:xfrm>
+          <a:off x="0" y="0"/>
+          <a:ext cx="0" cy="0"/>
+          <a:chOff x="0" y="0"/>
+          <a:chExt cx="0" cy="0"/>
+        </a:xfrm>
+      </p:grpSpPr>
+      <p:grpSp>
+        <p:nvGrpSpPr>
+          <p:cNvPr id="9" name="Group 8">
+            <a:extLst>
+              <a:ext uri="{FF2B5EF4-FFF2-40B4-BE49-F238E27FC236}">
+                <a16:creationId xmlns:a16="http://schemas.microsoft.com/office/drawing/2014/main" id="{A7E1EC36-C610-4951-92FB-5FA9BAA559EC}"/>
+              </a:ext>
+            </a:extLst>
+          </p:cNvPr>
+          <p:cNvGrpSpPr/>
+          <p:nvPr/>
+        </p:nvGrpSpPr>
+        <p:grpSpPr>
+          <a:xfrm>
+            <a:off x="160868" y="182032"/>
+            <a:ext cx="4767793" cy="6493935"/>
+            <a:chOff x="160868" y="182032"/>
+            <a:chExt cx="4767793" cy="6493935"/>
+          </a:xfrm>
+        </p:grpSpPr>
+        <p:sp>
+          <p:nvSpPr>
+            <p:cNvPr id="4" name="Rectangle 3">
+              <a:extLst>
+                <a:ext uri="{FF2B5EF4-FFF2-40B4-BE49-F238E27FC236}">
+                  <a16:creationId xmlns:a16="http://schemas.microsoft.com/office/drawing/2014/main" id="{7B702E0D-FD8D-4F00-8F9D-9ACEED91C763}"/>
+                </a:ext>
+              </a:extLst>
+            </p:cNvPr>
+            <p:cNvSpPr/>
+            <p:nvPr/>
+          </p:nvSpPr>
+          <p:spPr>
+            <a:xfrm>
+              <a:off x="160868" y="182032"/>
+              <a:ext cx="4648200" cy="6493935"/>
+            </a:xfrm>
+            <a:prstGeom prst="rect">
+              <a:avLst/>
+            </a:prstGeom>
+            <a:noFill/>
+            <a:ln w="19050" cmpd="thinThick">
+              <a:solidFill>
+                <a:schemeClr val="tx1">
+                  <a:lumMod val="50000"/>
+                  <a:lumOff val="50000"/>
+                </a:schemeClr>
+              </a:solidFill>
+            </a:ln>
+          </p:spPr>
+          <p:style>
+            <a:lnRef idx="2">
+              <a:schemeClr val="accent1">
+                <a:shade val="50000"/>
+              </a:schemeClr>
+            </a:lnRef>
+            <a:fillRef idx="1">
+              <a:schemeClr val="accent1"/>
+            </a:fillRef>
+            <a:effectRef idx="0">
+              <a:schemeClr val="accent1"/>
+            </a:effectRef>
+            <a:fontRef idx="minor">
+              <a:schemeClr val="lt1"/>
+            </a:fontRef>
+          </p:style>
+          <p:txBody>
+            <a:bodyPr rtlCol="0" anchor="ctr"/>
+            <a:lstStyle/>
+            <a:p>
+              <a:pPr algn="ctr"/>
+              <a:endParaRPr lang="en-IN"/>
+            </a:p>
+          </p:txBody>
+        </p:sp>
+        <p:sp>
+          <p:nvSpPr>
+            <p:cNvPr id="7" name="TextBox 6">
+              <a:extLst>
+                <a:ext uri="{FF2B5EF4-FFF2-40B4-BE49-F238E27FC236}">
+                  <a16:creationId xmlns:a16="http://schemas.microsoft.com/office/drawing/2014/main" id="{C5F65C11-52F8-415B-A70B-C02268F6F4A1}"/>
+                </a:ext>
+              </a:extLst>
+            </p:cNvPr>
+            <p:cNvSpPr txBox="1"/>
+            <p:nvPr/>
+          </p:nvSpPr>
+          <p:spPr>
+            <a:xfrm>
+              <a:off x="280461" y="835357"/>
+              <a:ext cx="4648200" cy="4154984"/>
+            </a:xfrm>
+            <a:prstGeom prst="rect">
+              <a:avLst/>
+            </a:prstGeom>
+            <a:noFill/>
+          </p:spPr>
+          <p:txBody>
+            <a:bodyPr wrap="square" rtlCol="0">
+              <a:spAutoFit/>
+            </a:bodyPr>
+            <a:lstStyle/>
+            <a:p>
+              <a:pPr defTabSz="439781">
+                <a:defRPr/>
+              </a:pPr>
+              <a:r>
                 <a:rPr lang="te-IN" sz="2400" dirty="0">
                   <a:latin typeface="Ramabhadra" panose="02000600000000000000" pitchFamily="2" charset="0"/>
                   <a:cs typeface="Ramabhadra" panose="02000600000000000000" pitchFamily="2" charset="0"/>
                 </a:rPr>
-                <a:t>నీవు చేసిన ఉపకారములకు</a:t>
+                <a:t>నా కొకరు ఉన్నారు నను ప్రేమించే వారు</a:t>
               </a:r>
             </a:p>
             <a:p>
@@ -4245,7 +3895,7 @@
                   <a:latin typeface="Ramabhadra" panose="02000600000000000000" pitchFamily="2" charset="0"/>
                   <a:cs typeface="Ramabhadra" panose="02000600000000000000" pitchFamily="2" charset="0"/>
                 </a:rPr>
-                <a:t>నేనేమి చెల్లింతును (2)</a:t>
+                <a:t>అడవులలో అల్లాడగా కరుణతో నను వెదకెను  </a:t>
               </a:r>
             </a:p>
             <a:p>
@@ -4257,19 +3907,7 @@
                   <a:latin typeface="Ramabhadra" panose="02000600000000000000" pitchFamily="2" charset="0"/>
                   <a:cs typeface="Ramabhadra" panose="02000600000000000000" pitchFamily="2" charset="0"/>
                 </a:rPr>
-                <a:t>ఏడాది దూడెలనా...</a:t>
-              </a:r>
-            </a:p>
-            <a:p>
-              <a:pPr defTabSz="439781">
-                <a:defRPr/>
-              </a:pPr>
-              <a:r>
-                <a:rPr lang="te-IN" sz="2400" dirty="0">
-                  <a:latin typeface="Ramabhadra" panose="02000600000000000000" pitchFamily="2" charset="0"/>
-                  <a:cs typeface="Ramabhadra" panose="02000600000000000000" pitchFamily="2" charset="0"/>
-                </a:rPr>
-                <a:t>వేలాది పోట్టేల్లనా (2)</a:t>
+                <a:t>ఆయనేసు... ఆయనేసు... </a:t>
               </a:r>
             </a:p>
             <a:p>
@@ -4290,7 +3928,7 @@
                   <a:latin typeface="Ramabhadra" panose="02000600000000000000" pitchFamily="2" charset="0"/>
                   <a:cs typeface="Ramabhadra" panose="02000600000000000000" pitchFamily="2" charset="0"/>
                 </a:rPr>
-                <a:t>వేలాది నదులంత విస్తార తైలము</a:t>
+                <a:t>మందలోని గొర్రెవలె మతి తప్పితిరిగితిని</a:t>
               </a:r>
             </a:p>
             <a:p>
@@ -4302,7 +3940,7 @@
                   <a:latin typeface="Ramabhadra" panose="02000600000000000000" pitchFamily="2" charset="0"/>
                   <a:cs typeface="Ramabhadra" panose="02000600000000000000" pitchFamily="2" charset="0"/>
                 </a:rPr>
-                <a:t>నీకిచ్చినా చాలునా (2)</a:t>
+                <a:t>కాపరివై వెదకి వచ్చి తనఒడి చేర్చుకొనున్</a:t>
               </a:r>
             </a:p>
             <a:p>
@@ -4314,19 +3952,7 @@
                   <a:latin typeface="Ramabhadra" panose="02000600000000000000" pitchFamily="2" charset="0"/>
                   <a:cs typeface="Ramabhadra" panose="02000600000000000000" pitchFamily="2" charset="0"/>
                 </a:rPr>
-                <a:t>గర్భ ఫలమైన నా జేష్ట పుత్రుని</a:t>
-              </a:r>
-            </a:p>
-            <a:p>
-              <a:pPr defTabSz="439781">
-                <a:defRPr/>
-              </a:pPr>
-              <a:r>
-                <a:rPr lang="te-IN" sz="2400" dirty="0">
-                  <a:latin typeface="Ramabhadra" panose="02000600000000000000" pitchFamily="2" charset="0"/>
-                  <a:cs typeface="Ramabhadra" panose="02000600000000000000" pitchFamily="2" charset="0"/>
-                </a:rPr>
-                <a:t>నీకిచ్చినా చాలునా (2)</a:t>
+                <a:t>ఆయనేసు... ఆయనేసు... </a:t>
               </a:r>
             </a:p>
             <a:p>
@@ -4347,7 +3973,7 @@
                   <a:latin typeface="Ramabhadra" panose="02000600000000000000" pitchFamily="2" charset="0"/>
                   <a:cs typeface="Ramabhadra" panose="02000600000000000000" pitchFamily="2" charset="0"/>
                 </a:rPr>
-                <a:t>మరణపాత్రుడనైయున్న నాకై</a:t>
+                <a:t>నన్నెరిగి నను పిలువ నా రాజుని ఎరిగితిని</a:t>
               </a:r>
             </a:p>
             <a:p>
@@ -4359,7 +3985,7 @@
                   <a:latin typeface="Ramabhadra" panose="02000600000000000000" pitchFamily="2" charset="0"/>
                   <a:cs typeface="Ramabhadra" panose="02000600000000000000" pitchFamily="2" charset="0"/>
                 </a:rPr>
-                <a:t>మరణించితివి సిలువలో (2)</a:t>
+                <a:t>పరమున నను చేర్చెన్  పరిశుద్ధునిగా మార్చెన్</a:t>
               </a:r>
             </a:p>
             <a:p>
@@ -4371,19 +3997,384 @@
                   <a:latin typeface="Ramabhadra" panose="02000600000000000000" pitchFamily="2" charset="0"/>
                   <a:cs typeface="Ramabhadra" panose="02000600000000000000" pitchFamily="2" charset="0"/>
                 </a:rPr>
-                <a:t>కరుణ చూపి నీ జీవ మార్గాన</a:t>
-              </a:r>
-            </a:p>
-            <a:p>
-              <a:pPr defTabSz="439781">
-                <a:defRPr/>
-              </a:pPr>
-              <a:r>
-                <a:rPr lang="te-IN" sz="2400" dirty="0">
-                  <a:latin typeface="Ramabhadra" panose="02000600000000000000" pitchFamily="2" charset="0"/>
-                  <a:cs typeface="Ramabhadra" panose="02000600000000000000" pitchFamily="2" charset="0"/>
-                </a:rPr>
-                <a:t>నడిపించుమో యేసయ్యా (2)</a:t>
+                <a:t>ఆయనేసు... ఆయనేసు... </a:t>
+              </a:r>
+            </a:p>
+          </p:txBody>
+        </p:sp>
+        <p:sp>
+          <p:nvSpPr>
+            <p:cNvPr id="8" name="Oval 7">
+              <a:extLst>
+                <a:ext uri="{FF2B5EF4-FFF2-40B4-BE49-F238E27FC236}">
+                  <a16:creationId xmlns:a16="http://schemas.microsoft.com/office/drawing/2014/main" id="{B70ED263-63AA-434F-8E88-AB7AD897A1CD}"/>
+                </a:ext>
+              </a:extLst>
+            </p:cNvPr>
+            <p:cNvSpPr/>
+            <p:nvPr/>
+          </p:nvSpPr>
+          <p:spPr>
+            <a:xfrm>
+              <a:off x="343961" y="326430"/>
+              <a:ext cx="390525" cy="390525"/>
+            </a:xfrm>
+            <a:prstGeom prst="ellipse">
+              <a:avLst/>
+            </a:prstGeom>
+            <a:noFill/>
+            <a:ln w="19050">
+              <a:solidFill>
+                <a:schemeClr val="tx1">
+                  <a:lumMod val="50000"/>
+                  <a:lumOff val="50000"/>
+                </a:schemeClr>
+              </a:solidFill>
+            </a:ln>
+          </p:spPr>
+          <p:style>
+            <a:lnRef idx="2">
+              <a:schemeClr val="accent1">
+                <a:shade val="50000"/>
+              </a:schemeClr>
+            </a:lnRef>
+            <a:fillRef idx="1">
+              <a:schemeClr val="accent1"/>
+            </a:fillRef>
+            <a:effectRef idx="0">
+              <a:schemeClr val="accent1"/>
+            </a:effectRef>
+            <a:fontRef idx="minor">
+              <a:schemeClr val="lt1"/>
+            </a:fontRef>
+          </p:style>
+          <p:txBody>
+            <a:bodyPr rtlCol="0" anchor="ctr"/>
+            <a:lstStyle/>
+            <a:p>
+              <a:pPr algn="ctr"/>
+              <a:r>
+                <a:rPr lang="en-IN" dirty="0">
+                  <a:solidFill>
+                    <a:schemeClr val="tx1"/>
+                  </a:solidFill>
+                </a:rPr>
+                <a:t>2</a:t>
+              </a:r>
+            </a:p>
+          </p:txBody>
+        </p:sp>
+      </p:grpSp>
+      <p:grpSp>
+        <p:nvGrpSpPr>
+          <p:cNvPr id="10" name="Group 9">
+            <a:extLst>
+              <a:ext uri="{FF2B5EF4-FFF2-40B4-BE49-F238E27FC236}">
+                <a16:creationId xmlns:a16="http://schemas.microsoft.com/office/drawing/2014/main" id="{BD4861E3-0140-4666-A772-E1339125A35F}"/>
+              </a:ext>
+            </a:extLst>
+          </p:cNvPr>
+          <p:cNvGrpSpPr/>
+          <p:nvPr/>
+        </p:nvGrpSpPr>
+        <p:grpSpPr>
+          <a:xfrm>
+            <a:off x="5104338" y="182031"/>
+            <a:ext cx="5229224" cy="6493935"/>
+            <a:chOff x="160868" y="182032"/>
+            <a:chExt cx="5229224" cy="6493935"/>
+          </a:xfrm>
+        </p:grpSpPr>
+        <p:sp>
+          <p:nvSpPr>
+            <p:cNvPr id="11" name="Rectangle 10">
+              <a:extLst>
+                <a:ext uri="{FF2B5EF4-FFF2-40B4-BE49-F238E27FC236}">
+                  <a16:creationId xmlns:a16="http://schemas.microsoft.com/office/drawing/2014/main" id="{0E606F7A-0439-43E4-A07F-A35A8691EB42}"/>
+                </a:ext>
+              </a:extLst>
+            </p:cNvPr>
+            <p:cNvSpPr/>
+            <p:nvPr/>
+          </p:nvSpPr>
+          <p:spPr>
+            <a:xfrm>
+              <a:off x="160868" y="182032"/>
+              <a:ext cx="4648200" cy="6493935"/>
+            </a:xfrm>
+            <a:prstGeom prst="rect">
+              <a:avLst/>
+            </a:prstGeom>
+            <a:noFill/>
+            <a:ln w="19050" cmpd="thinThick">
+              <a:solidFill>
+                <a:schemeClr val="tx1">
+                  <a:lumMod val="50000"/>
+                  <a:lumOff val="50000"/>
+                </a:schemeClr>
+              </a:solidFill>
+            </a:ln>
+          </p:spPr>
+          <p:style>
+            <a:lnRef idx="2">
+              <a:schemeClr val="accent1">
+                <a:shade val="50000"/>
+              </a:schemeClr>
+            </a:lnRef>
+            <a:fillRef idx="1">
+              <a:schemeClr val="accent1"/>
+            </a:fillRef>
+            <a:effectRef idx="0">
+              <a:schemeClr val="accent1"/>
+            </a:effectRef>
+            <a:fontRef idx="minor">
+              <a:schemeClr val="lt1"/>
+            </a:fontRef>
+          </p:style>
+          <p:txBody>
+            <a:bodyPr rtlCol="0" anchor="ctr"/>
+            <a:lstStyle/>
+            <a:p>
+              <a:pPr algn="ctr"/>
+              <a:endParaRPr lang="en-IN"/>
+            </a:p>
+          </p:txBody>
+        </p:sp>
+        <p:sp>
+          <p:nvSpPr>
+            <p:cNvPr id="12" name="TextBox 11">
+              <a:extLst>
+                <a:ext uri="{FF2B5EF4-FFF2-40B4-BE49-F238E27FC236}">
+                  <a16:creationId xmlns:a16="http://schemas.microsoft.com/office/drawing/2014/main" id="{DD950E5A-63C0-4187-892B-9549599FCD15}"/>
+                </a:ext>
+              </a:extLst>
+            </p:cNvPr>
+            <p:cNvSpPr txBox="1"/>
+            <p:nvPr/>
+          </p:nvSpPr>
+          <p:spPr>
+            <a:xfrm>
+              <a:off x="848786" y="474344"/>
+              <a:ext cx="4541306" cy="5909310"/>
+            </a:xfrm>
+            <a:prstGeom prst="rect">
+              <a:avLst/>
+            </a:prstGeom>
+            <a:noFill/>
+          </p:spPr>
+          <p:txBody>
+            <a:bodyPr wrap="square" rtlCol="0">
+              <a:spAutoFit/>
+            </a:bodyPr>
+            <a:lstStyle/>
+            <a:p>
+              <a:pPr defTabSz="439781">
+                <a:defRPr/>
+              </a:pPr>
+              <a:r>
+                <a:rPr lang="te-IN" sz="2100" dirty="0">
+                  <a:latin typeface="Ramabhadra" panose="02000600000000000000" pitchFamily="2" charset="0"/>
+                  <a:cs typeface="Ramabhadra" panose="02000600000000000000" pitchFamily="2" charset="0"/>
+                </a:rPr>
+                <a:t>నీ ప్రేమ ఎంతో అపారము</a:t>
+              </a:r>
+            </a:p>
+            <a:p>
+              <a:pPr defTabSz="439781">
+                <a:defRPr/>
+              </a:pPr>
+              <a:r>
+                <a:rPr lang="te-IN" sz="2100" dirty="0">
+                  <a:latin typeface="Ramabhadra" panose="02000600000000000000" pitchFamily="2" charset="0"/>
+                  <a:cs typeface="Ramabhadra" panose="02000600000000000000" pitchFamily="2" charset="0"/>
+                </a:rPr>
+                <a:t>వర్ణింపతరమా నా ప్రభూ</a:t>
+              </a:r>
+            </a:p>
+            <a:p>
+              <a:pPr defTabSz="439781">
+                <a:defRPr/>
+              </a:pPr>
+              <a:r>
+                <a:rPr lang="te-IN" sz="2100" dirty="0">
+                  <a:latin typeface="Ramabhadra" panose="02000600000000000000" pitchFamily="2" charset="0"/>
+                  <a:cs typeface="Ramabhadra" panose="02000600000000000000" pitchFamily="2" charset="0"/>
+                </a:rPr>
+                <a:t>పులకింప చేసెను నా హృది</a:t>
+              </a:r>
+            </a:p>
+            <a:p>
+              <a:pPr defTabSz="439781">
+                <a:defRPr/>
+              </a:pPr>
+              <a:r>
+                <a:rPr lang="te-IN" sz="2100" dirty="0">
+                  <a:latin typeface="Ramabhadra" panose="02000600000000000000" pitchFamily="2" charset="0"/>
+                  <a:cs typeface="Ramabhadra" panose="02000600000000000000" pitchFamily="2" charset="0"/>
+                </a:rPr>
+                <a:t>హృదయేశ్వరా నా యేసువా</a:t>
+              </a:r>
+            </a:p>
+            <a:p>
+              <a:pPr defTabSz="439781">
+                <a:defRPr/>
+              </a:pPr>
+              <a:endParaRPr lang="te-IN" sz="2100" dirty="0">
+                <a:latin typeface="Ramabhadra" panose="02000600000000000000" pitchFamily="2" charset="0"/>
+                <a:cs typeface="Ramabhadra" panose="02000600000000000000" pitchFamily="2" charset="0"/>
+              </a:endParaRPr>
+            </a:p>
+            <a:p>
+              <a:pPr defTabSz="439781">
+                <a:defRPr/>
+              </a:pPr>
+              <a:r>
+                <a:rPr lang="te-IN" sz="2100" dirty="0">
+                  <a:latin typeface="Ramabhadra" panose="02000600000000000000" pitchFamily="2" charset="0"/>
+                  <a:cs typeface="Ramabhadra" panose="02000600000000000000" pitchFamily="2" charset="0"/>
+                </a:rPr>
+                <a:t>నన్ను ఎంతో ప్రేమించి</a:t>
+              </a:r>
+            </a:p>
+            <a:p>
+              <a:pPr defTabSz="439781">
+                <a:defRPr/>
+              </a:pPr>
+              <a:r>
+                <a:rPr lang="te-IN" sz="2100" dirty="0">
+                  <a:latin typeface="Ramabhadra" panose="02000600000000000000" pitchFamily="2" charset="0"/>
+                  <a:cs typeface="Ramabhadra" panose="02000600000000000000" pitchFamily="2" charset="0"/>
+                </a:rPr>
+                <a:t>నాదు పాపమె క్షమియించి</a:t>
+              </a:r>
+            </a:p>
+            <a:p>
+              <a:pPr defTabSz="439781">
+                <a:defRPr/>
+              </a:pPr>
+              <a:r>
+                <a:rPr lang="te-IN" sz="2100" dirty="0">
+                  <a:latin typeface="Ramabhadra" panose="02000600000000000000" pitchFamily="2" charset="0"/>
+                  <a:cs typeface="Ramabhadra" panose="02000600000000000000" pitchFamily="2" charset="0"/>
+                </a:rPr>
+                <a:t>కృప కనికరముల నీడలో</a:t>
+              </a:r>
+            </a:p>
+            <a:p>
+              <a:pPr defTabSz="439781">
+                <a:defRPr/>
+              </a:pPr>
+              <a:r>
+                <a:rPr lang="te-IN" sz="2100" dirty="0">
+                  <a:latin typeface="Ramabhadra" panose="02000600000000000000" pitchFamily="2" charset="0"/>
+                  <a:cs typeface="Ramabhadra" panose="02000600000000000000" pitchFamily="2" charset="0"/>
+                </a:rPr>
+                <a:t>నన్ను చేర్చిన నా ప్రభూ</a:t>
+              </a:r>
+            </a:p>
+            <a:p>
+              <a:pPr defTabSz="439781">
+                <a:defRPr/>
+              </a:pPr>
+              <a:r>
+                <a:rPr lang="te-IN" sz="2100" dirty="0">
+                  <a:latin typeface="Ramabhadra" panose="02000600000000000000" pitchFamily="2" charset="0"/>
+                  <a:cs typeface="Ramabhadra" panose="02000600000000000000" pitchFamily="2" charset="0"/>
+                </a:rPr>
+                <a:t>జీవితమంతా స్తుతియించినా</a:t>
+              </a:r>
+            </a:p>
+            <a:p>
+              <a:pPr defTabSz="439781">
+                <a:defRPr/>
+              </a:pPr>
+              <a:r>
+                <a:rPr lang="te-IN" sz="2100" dirty="0">
+                  <a:latin typeface="Ramabhadra" panose="02000600000000000000" pitchFamily="2" charset="0"/>
+                  <a:cs typeface="Ramabhadra" panose="02000600000000000000" pitchFamily="2" charset="0"/>
+                </a:rPr>
+                <a:t>తీరునా నీ ఋణం</a:t>
+              </a:r>
+            </a:p>
+            <a:p>
+              <a:pPr defTabSz="439781">
+                <a:defRPr/>
+              </a:pPr>
+              <a:endParaRPr lang="te-IN" sz="2100" dirty="0">
+                <a:latin typeface="Ramabhadra" panose="02000600000000000000" pitchFamily="2" charset="0"/>
+                <a:cs typeface="Ramabhadra" panose="02000600000000000000" pitchFamily="2" charset="0"/>
+              </a:endParaRPr>
+            </a:p>
+            <a:p>
+              <a:pPr defTabSz="439781">
+                <a:defRPr/>
+              </a:pPr>
+              <a:r>
+                <a:rPr lang="te-IN" sz="2100" dirty="0">
+                  <a:latin typeface="Ramabhadra" panose="02000600000000000000" pitchFamily="2" charset="0"/>
+                  <a:cs typeface="Ramabhadra" panose="02000600000000000000" pitchFamily="2" charset="0"/>
+                </a:rPr>
+                <a:t>నీదు సన్నిధినే కాంక్షించి</a:t>
+              </a:r>
+            </a:p>
+            <a:p>
+              <a:pPr defTabSz="439781">
+                <a:defRPr/>
+              </a:pPr>
+              <a:r>
+                <a:rPr lang="te-IN" sz="2100" dirty="0">
+                  <a:latin typeface="Ramabhadra" panose="02000600000000000000" pitchFamily="2" charset="0"/>
+                  <a:cs typeface="Ramabhadra" panose="02000600000000000000" pitchFamily="2" charset="0"/>
+                </a:rPr>
+                <a:t>పాప బ్రతుకే వీడితి</a:t>
+              </a:r>
+            </a:p>
+            <a:p>
+              <a:pPr defTabSz="439781">
+                <a:defRPr/>
+              </a:pPr>
+              <a:r>
+                <a:rPr lang="te-IN" sz="2100" dirty="0">
+                  <a:latin typeface="Ramabhadra" panose="02000600000000000000" pitchFamily="2" charset="0"/>
+                  <a:cs typeface="Ramabhadra" panose="02000600000000000000" pitchFamily="2" charset="0"/>
+                </a:rPr>
+                <a:t>నీదు జీవమె నిండుగ</a:t>
+              </a:r>
+            </a:p>
+            <a:p>
+              <a:pPr defTabSz="439781">
+                <a:defRPr/>
+              </a:pPr>
+              <a:r>
+                <a:rPr lang="te-IN" sz="2100" dirty="0">
+                  <a:latin typeface="Ramabhadra" panose="02000600000000000000" pitchFamily="2" charset="0"/>
+                  <a:cs typeface="Ramabhadra" panose="02000600000000000000" pitchFamily="2" charset="0"/>
+                </a:rPr>
+                <a:t>నాలో నింపుము నా ప్రభు</a:t>
+              </a:r>
+            </a:p>
+            <a:p>
+              <a:pPr defTabSz="439781">
+                <a:defRPr/>
+              </a:pPr>
+              <a:r>
+                <a:rPr lang="te-IN" sz="2100" dirty="0">
+                  <a:latin typeface="Ramabhadra" panose="02000600000000000000" pitchFamily="2" charset="0"/>
+                  <a:cs typeface="Ramabhadra" panose="02000600000000000000" pitchFamily="2" charset="0"/>
+                </a:rPr>
+                <a:t>జీవితమంతా నీ ప్రేమన్</a:t>
+              </a:r>
+            </a:p>
+            <a:p>
+              <a:pPr defTabSz="439781">
+                <a:defRPr/>
+              </a:pPr>
+              <a:r>
+                <a:rPr lang="te-IN" sz="2100" dirty="0">
+                  <a:latin typeface="Ramabhadra" panose="02000600000000000000" pitchFamily="2" charset="0"/>
+                  <a:cs typeface="Ramabhadra" panose="02000600000000000000" pitchFamily="2" charset="0"/>
+                </a:rPr>
+                <a:t>చాటు చుందును</a:t>
               </a:r>
             </a:p>
           </p:txBody>

</xml_diff>

<commit_message>
06 oct 24 sun songs
</commit_message>
<xml_diff>
--- a/songsTemplate.pptx
+++ b/songsTemplate.pptx
@@ -255,7 +255,7 @@
           <a:p>
             <a:fld id="{F1102B08-ED9E-409F-B95F-09CAA1DAF6E0}" type="datetimeFigureOut">
               <a:rPr lang="en-IN" smtClean="0"/>
-              <a:t>28-09-2024</a:t>
+              <a:t>05-10-2024</a:t>
             </a:fld>
             <a:endParaRPr lang="en-IN"/>
           </a:p>
@@ -425,7 +425,7 @@
           <a:p>
             <a:fld id="{F1102B08-ED9E-409F-B95F-09CAA1DAF6E0}" type="datetimeFigureOut">
               <a:rPr lang="en-IN" smtClean="0"/>
-              <a:t>28-09-2024</a:t>
+              <a:t>05-10-2024</a:t>
             </a:fld>
             <a:endParaRPr lang="en-IN"/>
           </a:p>
@@ -605,7 +605,7 @@
           <a:p>
             <a:fld id="{F1102B08-ED9E-409F-B95F-09CAA1DAF6E0}" type="datetimeFigureOut">
               <a:rPr lang="en-IN" smtClean="0"/>
-              <a:t>28-09-2024</a:t>
+              <a:t>05-10-2024</a:t>
             </a:fld>
             <a:endParaRPr lang="en-IN"/>
           </a:p>
@@ -775,7 +775,7 @@
           <a:p>
             <a:fld id="{F1102B08-ED9E-409F-B95F-09CAA1DAF6E0}" type="datetimeFigureOut">
               <a:rPr lang="en-IN" smtClean="0"/>
-              <a:t>28-09-2024</a:t>
+              <a:t>05-10-2024</a:t>
             </a:fld>
             <a:endParaRPr lang="en-IN"/>
           </a:p>
@@ -1019,7 +1019,7 @@
           <a:p>
             <a:fld id="{F1102B08-ED9E-409F-B95F-09CAA1DAF6E0}" type="datetimeFigureOut">
               <a:rPr lang="en-IN" smtClean="0"/>
-              <a:t>28-09-2024</a:t>
+              <a:t>05-10-2024</a:t>
             </a:fld>
             <a:endParaRPr lang="en-IN"/>
           </a:p>
@@ -1251,7 +1251,7 @@
           <a:p>
             <a:fld id="{F1102B08-ED9E-409F-B95F-09CAA1DAF6E0}" type="datetimeFigureOut">
               <a:rPr lang="en-IN" smtClean="0"/>
-              <a:t>28-09-2024</a:t>
+              <a:t>05-10-2024</a:t>
             </a:fld>
             <a:endParaRPr lang="en-IN"/>
           </a:p>
@@ -1618,7 +1618,7 @@
           <a:p>
             <a:fld id="{F1102B08-ED9E-409F-B95F-09CAA1DAF6E0}" type="datetimeFigureOut">
               <a:rPr lang="en-IN" smtClean="0"/>
-              <a:t>28-09-2024</a:t>
+              <a:t>05-10-2024</a:t>
             </a:fld>
             <a:endParaRPr lang="en-IN"/>
           </a:p>
@@ -1736,7 +1736,7 @@
           <a:p>
             <a:fld id="{F1102B08-ED9E-409F-B95F-09CAA1DAF6E0}" type="datetimeFigureOut">
               <a:rPr lang="en-IN" smtClean="0"/>
-              <a:t>28-09-2024</a:t>
+              <a:t>05-10-2024</a:t>
             </a:fld>
             <a:endParaRPr lang="en-IN"/>
           </a:p>
@@ -1831,7 +1831,7 @@
           <a:p>
             <a:fld id="{F1102B08-ED9E-409F-B95F-09CAA1DAF6E0}" type="datetimeFigureOut">
               <a:rPr lang="en-IN" smtClean="0"/>
-              <a:t>28-09-2024</a:t>
+              <a:t>05-10-2024</a:t>
             </a:fld>
             <a:endParaRPr lang="en-IN"/>
           </a:p>
@@ -2108,7 +2108,7 @@
           <a:p>
             <a:fld id="{F1102B08-ED9E-409F-B95F-09CAA1DAF6E0}" type="datetimeFigureOut">
               <a:rPr lang="en-IN" smtClean="0"/>
-              <a:t>28-09-2024</a:t>
+              <a:t>05-10-2024</a:t>
             </a:fld>
             <a:endParaRPr lang="en-IN"/>
           </a:p>
@@ -2365,7 +2365,7 @@
           <a:p>
             <a:fld id="{F1102B08-ED9E-409F-B95F-09CAA1DAF6E0}" type="datetimeFigureOut">
               <a:rPr lang="en-IN" smtClean="0"/>
-              <a:t>28-09-2024</a:t>
+              <a:t>05-10-2024</a:t>
             </a:fld>
             <a:endParaRPr lang="en-IN"/>
           </a:p>
@@ -2578,7 +2578,7 @@
           <a:p>
             <a:fld id="{F1102B08-ED9E-409F-B95F-09CAA1DAF6E0}" type="datetimeFigureOut">
               <a:rPr lang="en-IN" smtClean="0"/>
-              <a:t>28-09-2024</a:t>
+              <a:t>05-10-2024</a:t>
             </a:fld>
             <a:endParaRPr lang="en-IN"/>
           </a:p>
@@ -3072,8 +3072,8 @@
           </p:nvSpPr>
           <p:spPr>
             <a:xfrm>
-              <a:off x="267762" y="787955"/>
-              <a:ext cx="4836576" cy="4939814"/>
+              <a:off x="267762" y="709414"/>
+              <a:ext cx="4836576" cy="5847755"/>
             </a:xfrm>
             <a:prstGeom prst="rect">
               <a:avLst/>
@@ -3090,68 +3090,78 @@
                 <a:defRPr/>
               </a:pPr>
               <a:r>
-                <a:rPr lang="te-IN" sz="2100" dirty="0">
-                  <a:latin typeface="Ramabhadra" panose="02000600000000000000" pitchFamily="2" charset="0"/>
-                  <a:cs typeface="Ramabhadra" panose="02000600000000000000" pitchFamily="2" charset="0"/>
-                </a:rPr>
-                <a:t>నేనెందుకని నీ సొత్తుగా మారితిని</a:t>
-              </a:r>
-            </a:p>
-            <a:p>
-              <a:pPr defTabSz="439781">
-                <a:defRPr/>
-              </a:pPr>
-              <a:r>
-                <a:rPr lang="te-IN" sz="2100" dirty="0">
-                  <a:latin typeface="Ramabhadra" panose="02000600000000000000" pitchFamily="2" charset="0"/>
-                  <a:cs typeface="Ramabhadra" panose="02000600000000000000" pitchFamily="2" charset="0"/>
-                </a:rPr>
-                <a:t>యేసయ్యా నీ రక్తముచే... కడుగబడి</a:t>
-              </a:r>
-              <a:r>
-                <a:rPr lang="en-IN" sz="2100" dirty="0">
-                  <a:latin typeface="Ramabhadra" panose="02000600000000000000" pitchFamily="2" charset="0"/>
-                  <a:cs typeface="Ramabhadra" panose="02000600000000000000" pitchFamily="2" charset="0"/>
-                </a:rPr>
-                <a:t> </a:t>
-              </a:r>
-              <a:r>
-                <a:rPr lang="te-IN" sz="2100" dirty="0">
-                  <a:latin typeface="Ramabhadra" panose="02000600000000000000" pitchFamily="2" charset="0"/>
-                  <a:cs typeface="Ramabhadra" panose="02000600000000000000" pitchFamily="2" charset="0"/>
-                </a:rPr>
-                <a:t>నందున</a:t>
-              </a:r>
-            </a:p>
-            <a:p>
-              <a:pPr defTabSz="439781">
-                <a:defRPr/>
-              </a:pPr>
-              <a:r>
-                <a:rPr lang="te-IN" sz="2100" dirty="0">
-                  <a:latin typeface="Ramabhadra" panose="02000600000000000000" pitchFamily="2" charset="0"/>
-                  <a:cs typeface="Ramabhadra" panose="02000600000000000000" pitchFamily="2" charset="0"/>
-                </a:rPr>
-                <a:t>నీ అనాది ప్రణాళికలో...</a:t>
-              </a:r>
-            </a:p>
-            <a:p>
-              <a:pPr defTabSz="439781">
-                <a:defRPr/>
-              </a:pPr>
-              <a:r>
-                <a:rPr lang="te-IN" sz="2100" dirty="0">
-                  <a:latin typeface="Ramabhadra" panose="02000600000000000000" pitchFamily="2" charset="0"/>
-                  <a:cs typeface="Ramabhadra" panose="02000600000000000000" pitchFamily="2" charset="0"/>
-                </a:rPr>
-                <a:t>హర్షించెను నా హృదయసీమ</a:t>
-              </a:r>
-            </a:p>
-            <a:p>
-              <a:pPr defTabSz="439781">
-                <a:defRPr/>
-              </a:pPr>
-              <a:endParaRPr lang="te-IN" sz="2100" dirty="0">
+                <a:rPr lang="te-IN" sz="2200" dirty="0">
+                  <a:latin typeface="Ramabhadra" panose="02000600000000000000" pitchFamily="2" charset="0"/>
+                  <a:cs typeface="Ramabhadra" panose="02000600000000000000" pitchFamily="2" charset="0"/>
+                </a:rPr>
+                <a:t>చాలిన దేవుడవు యేసు </a:t>
+              </a:r>
+            </a:p>
+            <a:p>
+              <a:pPr defTabSz="439781">
+                <a:defRPr/>
+              </a:pPr>
+              <a:r>
+                <a:rPr lang="te-IN" sz="2200" dirty="0">
+                  <a:latin typeface="Ramabhadra" panose="02000600000000000000" pitchFamily="2" charset="0"/>
+                  <a:cs typeface="Ramabhadra" panose="02000600000000000000" pitchFamily="2" charset="0"/>
+                </a:rPr>
+                <a:t>చాలిన దేవుడ నీవు</a:t>
+              </a:r>
+            </a:p>
+            <a:p>
+              <a:pPr defTabSz="439781">
+                <a:defRPr/>
+              </a:pPr>
+              <a:r>
+                <a:rPr lang="te-IN" sz="2200" dirty="0">
+                  <a:latin typeface="Ramabhadra" panose="02000600000000000000" pitchFamily="2" charset="0"/>
+                  <a:cs typeface="Ramabhadra" panose="02000600000000000000" pitchFamily="2" charset="0"/>
+                </a:rPr>
+                <a:t>వ్యాధి బాధ సమయములో</a:t>
+              </a:r>
+            </a:p>
+            <a:p>
+              <a:pPr defTabSz="439781">
+                <a:defRPr/>
+              </a:pPr>
+              <a:r>
+                <a:rPr lang="te-IN" sz="2200" dirty="0">
+                  <a:latin typeface="Ramabhadra" panose="02000600000000000000" pitchFamily="2" charset="0"/>
+                  <a:cs typeface="Ramabhadra" panose="02000600000000000000" pitchFamily="2" charset="0"/>
+                </a:rPr>
+                <a:t>కష్టసుడుల తరంగములో</a:t>
+              </a:r>
+            </a:p>
+            <a:p>
+              <a:pPr defTabSz="439781">
+                <a:defRPr/>
+              </a:pPr>
+              <a:r>
+                <a:rPr lang="te-IN" sz="2200" dirty="0">
+                  <a:latin typeface="Ramabhadra" panose="02000600000000000000" pitchFamily="2" charset="0"/>
+                  <a:cs typeface="Ramabhadra" panose="02000600000000000000" pitchFamily="2" charset="0"/>
+                </a:rPr>
+                <a:t>ఏమున్నా లేకున్నా ఏ స్ధితికైనా</a:t>
+              </a:r>
+            </a:p>
+            <a:p>
+              <a:pPr defTabSz="439781">
+                <a:defRPr/>
+              </a:pPr>
+              <a:r>
+                <a:rPr lang="te-IN" sz="2200" dirty="0">
+                  <a:latin typeface="Ramabhadra" panose="02000600000000000000" pitchFamily="2" charset="0"/>
+                  <a:cs typeface="Ramabhadra" panose="02000600000000000000" pitchFamily="2" charset="0"/>
+                </a:rPr>
+                <a:t>చాలిన దేవుడ నీవు</a:t>
+              </a:r>
+            </a:p>
+            <a:p>
+              <a:pPr defTabSz="439781">
+                <a:defRPr/>
+              </a:pPr>
+              <a:endParaRPr lang="te-IN" sz="2200" dirty="0">
                 <a:latin typeface="Ramabhadra" panose="02000600000000000000" pitchFamily="2" charset="0"/>
                 <a:cs typeface="Ramabhadra" panose="02000600000000000000" pitchFamily="2" charset="0"/>
               </a:endParaRPr>
@@ -3161,77 +3171,54 @@
                 <a:defRPr/>
               </a:pPr>
               <a:r>
-                <a:rPr lang="te-IN" sz="2100" dirty="0">
-                  <a:latin typeface="Ramabhadra" panose="02000600000000000000" pitchFamily="2" charset="0"/>
-                  <a:cs typeface="Ramabhadra" panose="02000600000000000000" pitchFamily="2" charset="0"/>
-                </a:rPr>
-                <a:t>నీ పరిచర్యను తుదముట్టించుటే...</a:t>
-              </a:r>
-            </a:p>
-            <a:p>
-              <a:pPr defTabSz="439781">
-                <a:defRPr/>
-              </a:pPr>
-              <a:r>
-                <a:rPr lang="te-IN" sz="2100" dirty="0">
-                  <a:latin typeface="Ramabhadra" panose="02000600000000000000" pitchFamily="2" charset="0"/>
-                  <a:cs typeface="Ramabhadra" panose="02000600000000000000" pitchFamily="2" charset="0"/>
-                </a:rPr>
-                <a:t>నా నియమమాయెనే</a:t>
-              </a:r>
-            </a:p>
-            <a:p>
-              <a:pPr defTabSz="439781">
-                <a:defRPr/>
-              </a:pPr>
-              <a:r>
-                <a:rPr lang="te-IN" sz="2100" dirty="0">
-                  <a:latin typeface="Ramabhadra" panose="02000600000000000000" pitchFamily="2" charset="0"/>
-                  <a:cs typeface="Ramabhadra" panose="02000600000000000000" pitchFamily="2" charset="0"/>
-                </a:rPr>
-                <a:t>నీ సన్నిధిలో నీ పోందుకోరి...</a:t>
-              </a:r>
-              <a:r>
-                <a:rPr lang="en-IN" sz="2100" dirty="0">
-                  <a:latin typeface="Ramabhadra" panose="02000600000000000000" pitchFamily="2" charset="0"/>
-                  <a:cs typeface="Ramabhadra" panose="02000600000000000000" pitchFamily="2" charset="0"/>
-                </a:rPr>
-                <a:t> </a:t>
-              </a:r>
-              <a:r>
-                <a:rPr lang="te-IN" sz="2100" dirty="0">
-                  <a:latin typeface="Ramabhadra" panose="02000600000000000000" pitchFamily="2" charset="0"/>
-                  <a:cs typeface="Ramabhadra" panose="02000600000000000000" pitchFamily="2" charset="0"/>
-                </a:rPr>
-                <a:t>నీ స్నేహితుడనైతినే</a:t>
-              </a:r>
-            </a:p>
-            <a:p>
-              <a:pPr defTabSz="439781">
-                <a:defRPr/>
-              </a:pPr>
-              <a:r>
-                <a:rPr lang="te-IN" sz="2100" dirty="0">
-                  <a:latin typeface="Ramabhadra" panose="02000600000000000000" pitchFamily="2" charset="0"/>
-                  <a:cs typeface="Ramabhadra" panose="02000600000000000000" pitchFamily="2" charset="0"/>
-                </a:rPr>
-                <a:t>అహా..! నాధన్యత ఓహో...!</a:t>
-              </a:r>
-              <a:r>
-                <a:rPr lang="en-IN" sz="2100" dirty="0">
-                  <a:latin typeface="Ramabhadra" panose="02000600000000000000" pitchFamily="2" charset="0"/>
-                  <a:cs typeface="Ramabhadra" panose="02000600000000000000" pitchFamily="2" charset="0"/>
-                </a:rPr>
-                <a:t> </a:t>
-              </a:r>
-              <a:r>
-                <a:rPr lang="te-IN" sz="2100" dirty="0">
-                  <a:latin typeface="Ramabhadra" panose="02000600000000000000" pitchFamily="2" charset="0"/>
-                  <a:cs typeface="Ramabhadra" panose="02000600000000000000" pitchFamily="2" charset="0"/>
-                </a:rPr>
-                <a:t>నాభాగ్యము...</a:t>
-              </a:r>
-              <a:endParaRPr lang="en-IN" sz="2100" dirty="0">
+                <a:rPr lang="te-IN" sz="2200" dirty="0">
+                  <a:latin typeface="Ramabhadra" panose="02000600000000000000" pitchFamily="2" charset="0"/>
+                  <a:cs typeface="Ramabhadra" panose="02000600000000000000" pitchFamily="2" charset="0"/>
+                </a:rPr>
+                <a:t>అంజూర చెట్లు పూయకున్నను</a:t>
+              </a:r>
+            </a:p>
+            <a:p>
+              <a:pPr defTabSz="439781">
+                <a:defRPr/>
+              </a:pPr>
+              <a:r>
+                <a:rPr lang="te-IN" sz="2200" dirty="0">
+                  <a:latin typeface="Ramabhadra" panose="02000600000000000000" pitchFamily="2" charset="0"/>
+                  <a:cs typeface="Ramabhadra" panose="02000600000000000000" pitchFamily="2" charset="0"/>
+                </a:rPr>
+                <a:t> ద్రాక్ష చెట్లు ఫలింపకున్నను</a:t>
+              </a:r>
+            </a:p>
+            <a:p>
+              <a:pPr defTabSz="439781">
+                <a:defRPr/>
+              </a:pPr>
+              <a:r>
+                <a:rPr lang="te-IN" sz="2200" dirty="0">
+                  <a:latin typeface="Ramabhadra" panose="02000600000000000000" pitchFamily="2" charset="0"/>
+                  <a:cs typeface="Ramabhadra" panose="02000600000000000000" pitchFamily="2" charset="0"/>
+                </a:rPr>
+                <a:t>చేనులోని పైరు పండకపోయినను</a:t>
+              </a:r>
+            </a:p>
+            <a:p>
+              <a:pPr defTabSz="439781">
+                <a:defRPr/>
+              </a:pPr>
+              <a:r>
+                <a:rPr lang="te-IN" sz="2200" dirty="0">
+                  <a:latin typeface="Ramabhadra" panose="02000600000000000000" pitchFamily="2" charset="0"/>
+                  <a:cs typeface="Ramabhadra" panose="02000600000000000000" pitchFamily="2" charset="0"/>
+                </a:rPr>
+                <a:t>శాలలోని పశువులు లేక పోయినను</a:t>
+              </a:r>
+            </a:p>
+            <a:p>
+              <a:pPr defTabSz="439781">
+                <a:defRPr/>
+              </a:pPr>
+              <a:endParaRPr lang="te-IN" sz="2200" dirty="0">
                 <a:latin typeface="Ramabhadra" panose="02000600000000000000" pitchFamily="2" charset="0"/>
                 <a:cs typeface="Ramabhadra" panose="02000600000000000000" pitchFamily="2" charset="0"/>
               </a:endParaRPr>
@@ -3241,20 +3228,37 @@
                 <a:defRPr/>
               </a:pPr>
               <a:r>
-                <a:rPr lang="te-IN" sz="2100" dirty="0">
-                  <a:latin typeface="Ramabhadra" panose="02000600000000000000" pitchFamily="2" charset="0"/>
-                  <a:cs typeface="Ramabhadra" panose="02000600000000000000" pitchFamily="2" charset="0"/>
-                </a:rPr>
-                <a:t>ఏమని వివరింతును</a:t>
-              </a:r>
-              <a:r>
-                <a:rPr lang="en-IN" sz="2100" dirty="0">
-                  <a:latin typeface="Ramabhadra" panose="02000600000000000000" pitchFamily="2" charset="0"/>
-                  <a:cs typeface="Ramabhadra" panose="02000600000000000000" pitchFamily="2" charset="0"/>
-                </a:rPr>
-                <a:t>...</a:t>
-              </a:r>
-              <a:endParaRPr lang="te-IN" sz="2100" dirty="0">
+                <a:rPr lang="te-IN" sz="2200" dirty="0">
+                  <a:latin typeface="Ramabhadra" panose="02000600000000000000" pitchFamily="2" charset="0"/>
+                  <a:cs typeface="Ramabhadra" panose="02000600000000000000" pitchFamily="2" charset="0"/>
+                </a:rPr>
+                <a:t>గాఢాంధకారాన పయనించిన </a:t>
+              </a:r>
+            </a:p>
+            <a:p>
+              <a:pPr defTabSz="439781">
+                <a:defRPr/>
+              </a:pPr>
+              <a:r>
+                <a:rPr lang="te-IN" sz="2200" dirty="0">
+                  <a:latin typeface="Ramabhadra" panose="02000600000000000000" pitchFamily="2" charset="0"/>
+                  <a:cs typeface="Ramabhadra" panose="02000600000000000000" pitchFamily="2" charset="0"/>
+                </a:rPr>
+                <a:t>పొంగు సాగరా లెదురైన</a:t>
+              </a:r>
+            </a:p>
+            <a:p>
+              <a:pPr defTabSz="439781">
+                <a:defRPr/>
+              </a:pPr>
+              <a:r>
+                <a:rPr lang="te-IN" sz="2200" dirty="0">
+                  <a:latin typeface="Ramabhadra" panose="02000600000000000000" pitchFamily="2" charset="0"/>
+                  <a:cs typeface="Ramabhadra" panose="02000600000000000000" pitchFamily="2" charset="0"/>
+                </a:rPr>
+                <a:t>లోకమంత ఒకటైన</a:t>
+              </a:r>
+              <a:endParaRPr lang="en-IN" sz="2200" dirty="0">
                 <a:latin typeface="Ramabhadra" panose="02000600000000000000" pitchFamily="2" charset="0"/>
                 <a:cs typeface="Ramabhadra" panose="02000600000000000000" pitchFamily="2" charset="0"/>
               </a:endParaRPr>
@@ -3263,89 +3267,38 @@
               <a:pPr defTabSz="439781">
                 <a:defRPr/>
               </a:pPr>
-              <a:endParaRPr lang="te-IN" sz="2100" dirty="0">
-                <a:latin typeface="Ramabhadra" panose="02000600000000000000" pitchFamily="2" charset="0"/>
-                <a:cs typeface="Ramabhadra" panose="02000600000000000000" pitchFamily="2" charset="0"/>
-              </a:endParaRPr>
-            </a:p>
-            <a:p>
-              <a:pPr defTabSz="439781">
-                <a:defRPr/>
-              </a:pPr>
-              <a:r>
-                <a:rPr lang="te-IN" sz="2100" dirty="0">
-                  <a:latin typeface="Ramabhadra" panose="02000600000000000000" pitchFamily="2" charset="0"/>
-                  <a:cs typeface="Ramabhadra" panose="02000600000000000000" pitchFamily="2" charset="0"/>
-                </a:rPr>
-                <a:t>నీ శ్రమలలో పాలొందుటయే... నా దర్శనమాయెనే</a:t>
-              </a:r>
-            </a:p>
-            <a:p>
-              <a:pPr defTabSz="439781">
-                <a:defRPr/>
-              </a:pPr>
-              <a:r>
-                <a:rPr lang="te-IN" sz="2100" dirty="0">
-                  <a:latin typeface="Ramabhadra" panose="02000600000000000000" pitchFamily="2" charset="0"/>
-                  <a:cs typeface="Ramabhadra" panose="02000600000000000000" pitchFamily="2" charset="0"/>
-                </a:rPr>
-                <a:t>నా తనువందున శ్రమలు సహించి...</a:t>
-              </a:r>
-              <a:r>
-                <a:rPr lang="en-IN" sz="2100" dirty="0">
+              <a:r>
+                <a:rPr lang="te-IN" sz="2200" dirty="0">
+                  <a:latin typeface="Ramabhadra" panose="02000600000000000000" pitchFamily="2" charset="0"/>
+                  <a:cs typeface="Ramabhadra" panose="02000600000000000000" pitchFamily="2" charset="0"/>
+                </a:rPr>
+                <a:t>అన్యాయ</a:t>
+              </a:r>
+              <a:r>
+                <a:rPr lang="en-IN" sz="2200" dirty="0">
                   <a:latin typeface="Ramabhadra" panose="02000600000000000000" pitchFamily="2" charset="0"/>
                   <a:cs typeface="Ramabhadra" panose="02000600000000000000" pitchFamily="2" charset="0"/>
                 </a:rPr>
                 <a:t> </a:t>
               </a:r>
               <a:r>
-                <a:rPr lang="te-IN" dirty="0">
-                  <a:latin typeface="Ramabhadra" panose="02000600000000000000" pitchFamily="2" charset="0"/>
-                  <a:cs typeface="Ramabhadra" panose="02000600000000000000" pitchFamily="2" charset="0"/>
-                </a:rPr>
-                <a:t>నీ వారసుడనైతినే</a:t>
-              </a:r>
-            </a:p>
-            <a:p>
-              <a:pPr defTabSz="439781">
-                <a:defRPr/>
-              </a:pPr>
-              <a:r>
-                <a:rPr lang="te-IN" sz="2100" dirty="0">
-                  <a:latin typeface="Ramabhadra" panose="02000600000000000000" pitchFamily="2" charset="0"/>
-                  <a:cs typeface="Ramabhadra" panose="02000600000000000000" pitchFamily="2" charset="0"/>
-                </a:rPr>
-                <a:t>అహా..! నాధన్యత ఓహో...!</a:t>
-              </a:r>
-              <a:r>
-                <a:rPr lang="en-IN" sz="2100" dirty="0">
-                  <a:latin typeface="Ramabhadra" panose="02000600000000000000" pitchFamily="2" charset="0"/>
-                  <a:cs typeface="Ramabhadra" panose="02000600000000000000" pitchFamily="2" charset="0"/>
-                </a:rPr>
-                <a:t> </a:t>
-              </a:r>
-              <a:r>
-                <a:rPr lang="te-IN" sz="2100" dirty="0">
-                  <a:latin typeface="Ramabhadra" panose="02000600000000000000" pitchFamily="2" charset="0"/>
-                  <a:cs typeface="Ramabhadra" panose="02000600000000000000" pitchFamily="2" charset="0"/>
-                </a:rPr>
-                <a:t>నాభాగ్యము...</a:t>
-              </a:r>
-              <a:endParaRPr lang="en-IN" sz="2100" dirty="0">
-                <a:latin typeface="Ramabhadra" panose="02000600000000000000" pitchFamily="2" charset="0"/>
-                <a:cs typeface="Ramabhadra" panose="02000600000000000000" pitchFamily="2" charset="0"/>
-              </a:endParaRPr>
-            </a:p>
-            <a:p>
-              <a:pPr defTabSz="439781">
-                <a:defRPr/>
-              </a:pPr>
-              <a:r>
-                <a:rPr lang="te-IN" sz="2100" dirty="0">
-                  <a:latin typeface="Ramabhadra" panose="02000600000000000000" pitchFamily="2" charset="0"/>
-                  <a:cs typeface="Ramabhadra" panose="02000600000000000000" pitchFamily="2" charset="0"/>
-                </a:rPr>
-                <a:t>ఏమని వివరింతును</a:t>
+                <a:rPr lang="te-IN" sz="2200" dirty="0">
+                  <a:latin typeface="Ramabhadra" panose="02000600000000000000" pitchFamily="2" charset="0"/>
+                  <a:cs typeface="Ramabhadra" panose="02000600000000000000" pitchFamily="2" charset="0"/>
+                </a:rPr>
+                <a:t>తీర్పుకు గురిచేసిన</a:t>
+              </a:r>
+            </a:p>
+            <a:p>
+              <a:pPr defTabSz="439781">
+                <a:defRPr/>
+              </a:pPr>
+              <a:r>
+                <a:rPr lang="te-IN" sz="2200" dirty="0">
+                  <a:latin typeface="Ramabhadra" panose="02000600000000000000" pitchFamily="2" charset="0"/>
+                  <a:cs typeface="Ramabhadra" panose="02000600000000000000" pitchFamily="2" charset="0"/>
+                </a:rPr>
+                <a:t>సత్యము పలుకుటచే నష్టము కలిగినను</a:t>
               </a:r>
             </a:p>
           </p:txBody>
@@ -3502,8 +3455,8 @@
           </p:nvSpPr>
           <p:spPr>
             <a:xfrm>
-              <a:off x="343961" y="841707"/>
-              <a:ext cx="4541306" cy="4832092"/>
+              <a:off x="343961" y="736932"/>
+              <a:ext cx="4541306" cy="5847755"/>
             </a:xfrm>
             <a:prstGeom prst="rect">
               <a:avLst/>
@@ -3524,43 +3477,85 @@
                   <a:latin typeface="Ramabhadra" panose="02000600000000000000" pitchFamily="2" charset="0"/>
                   <a:cs typeface="Ramabhadra" panose="02000600000000000000" pitchFamily="2" charset="0"/>
                 </a:rPr>
-                <a:t>స్తోత్రము చెల్లించెదము మన యేసుకే</a:t>
-              </a:r>
-            </a:p>
-            <a:p>
-              <a:pPr defTabSz="439781">
-                <a:defRPr/>
-              </a:pPr>
-              <a:r>
+                <a:t>మహిమ ఘనతకు అర్హుడవు</a:t>
+              </a:r>
+              <a:br>
                 <a:rPr lang="te-IN" sz="2200" dirty="0">
                   <a:latin typeface="Ramabhadra" panose="02000600000000000000" pitchFamily="2" charset="0"/>
                   <a:cs typeface="Ramabhadra" panose="02000600000000000000" pitchFamily="2" charset="0"/>
                 </a:rPr>
-                <a:t>స్తోత్రము చెల్లించెదము</a:t>
-              </a:r>
-            </a:p>
-            <a:p>
-              <a:pPr defTabSz="439781">
-                <a:defRPr/>
-              </a:pPr>
+              </a:br>
               <a:r>
                 <a:rPr lang="te-IN" sz="2200" dirty="0">
                   <a:latin typeface="Ramabhadra" panose="02000600000000000000" pitchFamily="2" charset="0"/>
                   <a:cs typeface="Ramabhadra" panose="02000600000000000000" pitchFamily="2" charset="0"/>
                 </a:rPr>
-                <a:t>మంచివాడు గొప్పవాడు మన దేవుడు</a:t>
-              </a:r>
-            </a:p>
-            <a:p>
-              <a:pPr defTabSz="439781">
-                <a:defRPr/>
-              </a:pPr>
-              <a:r>
+                <a:t>నీవే నా దైవము</a:t>
+              </a:r>
+              <a:br>
                 <a:rPr lang="te-IN" sz="2200" dirty="0">
                   <a:latin typeface="Ramabhadra" panose="02000600000000000000" pitchFamily="2" charset="0"/>
                   <a:cs typeface="Ramabhadra" panose="02000600000000000000" pitchFamily="2" charset="0"/>
                 </a:rPr>
-                <a:t>వాక్యమునిచ్చు దేవుడు (2)</a:t>
+              </a:br>
+              <a:r>
+                <a:rPr lang="te-IN" sz="2200" dirty="0">
+                  <a:latin typeface="Ramabhadra" panose="02000600000000000000" pitchFamily="2" charset="0"/>
+                  <a:cs typeface="Ramabhadra" panose="02000600000000000000" pitchFamily="2" charset="0"/>
+                </a:rPr>
+                <a:t>సృష్టికర్త ముక్తి దాత (2)</a:t>
+              </a:r>
+              <a:br>
+                <a:rPr lang="te-IN" sz="2200" dirty="0">
+                  <a:latin typeface="Ramabhadra" panose="02000600000000000000" pitchFamily="2" charset="0"/>
+                  <a:cs typeface="Ramabhadra" panose="02000600000000000000" pitchFamily="2" charset="0"/>
+                </a:rPr>
+              </a:br>
+              <a:r>
+                <a:rPr lang="te-IN" sz="2200" dirty="0">
+                  <a:latin typeface="Ramabhadra" panose="02000600000000000000" pitchFamily="2" charset="0"/>
+                  <a:cs typeface="Ramabhadra" panose="02000600000000000000" pitchFamily="2" charset="0"/>
+                </a:rPr>
+                <a:t>మా స్తుతులకు పాత్రుడా</a:t>
+              </a:r>
+              <a:br>
+                <a:rPr lang="te-IN" sz="2200" dirty="0">
+                  <a:latin typeface="Ramabhadra" panose="02000600000000000000" pitchFamily="2" charset="0"/>
+                  <a:cs typeface="Ramabhadra" panose="02000600000000000000" pitchFamily="2" charset="0"/>
+                </a:rPr>
+              </a:br>
+              <a:r>
+                <a:rPr lang="te-IN" sz="2200" dirty="0">
+                  <a:latin typeface="Ramabhadra" panose="02000600000000000000" pitchFamily="2" charset="0"/>
+                  <a:cs typeface="Ramabhadra" panose="02000600000000000000" pitchFamily="2" charset="0"/>
+                </a:rPr>
+                <a:t>ఆరాధనా నీకే ఆరాధనా నీకే</a:t>
+              </a:r>
+              <a:br>
+                <a:rPr lang="te-IN" sz="2200" dirty="0">
+                  <a:latin typeface="Ramabhadra" panose="02000600000000000000" pitchFamily="2" charset="0"/>
+                  <a:cs typeface="Ramabhadra" panose="02000600000000000000" pitchFamily="2" charset="0"/>
+                </a:rPr>
+              </a:br>
+              <a:r>
+                <a:rPr lang="te-IN" sz="2200" dirty="0">
+                  <a:latin typeface="Ramabhadra" panose="02000600000000000000" pitchFamily="2" charset="0"/>
+                  <a:cs typeface="Ramabhadra" panose="02000600000000000000" pitchFamily="2" charset="0"/>
+                </a:rPr>
+                <a:t>ఆరాధనా స్తుతి ఆరాధనా ఆరాధనా నీకే (2)</a:t>
+              </a:r>
+              <a:br>
+                <a:rPr lang="te-IN" sz="2200" dirty="0">
+                  <a:latin typeface="Ramabhadra" panose="02000600000000000000" pitchFamily="2" charset="0"/>
+                  <a:cs typeface="Ramabhadra" panose="02000600000000000000" pitchFamily="2" charset="0"/>
+                </a:rPr>
+              </a:br>
+              <a:r>
+                <a:rPr lang="te-IN" sz="2200" dirty="0">
+                  <a:latin typeface="Ramabhadra" panose="02000600000000000000" pitchFamily="2" charset="0"/>
+                  <a:cs typeface="Ramabhadra" panose="02000600000000000000" pitchFamily="2" charset="0"/>
+                </a:rPr>
+                <a:t>ఆరాధనా నీకే ఆరాధనా నీకే</a:t>
               </a:r>
             </a:p>
             <a:p>
@@ -3581,43 +3576,46 @@
                   <a:latin typeface="Ramabhadra" panose="02000600000000000000" pitchFamily="2" charset="0"/>
                   <a:cs typeface="Ramabhadra" panose="02000600000000000000" pitchFamily="2" charset="0"/>
                 </a:rPr>
-                <a:t>యెరికో మనకు ముందు వచ్చినా –</a:t>
-              </a:r>
-            </a:p>
-            <a:p>
-              <a:pPr defTabSz="439781">
-                <a:defRPr/>
-              </a:pPr>
-              <a:r>
+                <a:t>మన్నాను కురిపించినావు</a:t>
+              </a:r>
+              <a:br>
                 <a:rPr lang="te-IN" sz="2200" dirty="0">
                   <a:latin typeface="Ramabhadra" panose="02000600000000000000" pitchFamily="2" charset="0"/>
                   <a:cs typeface="Ramabhadra" panose="02000600000000000000" pitchFamily="2" charset="0"/>
                 </a:rPr>
-                <a:t>క్రీస్తు యేసు ముందే నిలుచును</a:t>
-              </a:r>
-            </a:p>
-            <a:p>
-              <a:pPr defTabSz="439781">
-                <a:defRPr/>
-              </a:pPr>
+              </a:br>
               <a:r>
                 <a:rPr lang="te-IN" sz="2200" dirty="0">
                   <a:latin typeface="Ramabhadra" panose="02000600000000000000" pitchFamily="2" charset="0"/>
                   <a:cs typeface="Ramabhadra" panose="02000600000000000000" pitchFamily="2" charset="0"/>
                 </a:rPr>
-                <a:t>భయపడకు దిగులు పడకు -</a:t>
-              </a:r>
-            </a:p>
-            <a:p>
-              <a:pPr defTabSz="439781">
-                <a:defRPr/>
-              </a:pPr>
-              <a:r>
+                <a:t>బండనుండి నీల్లిచ్చినావు (2)</a:t>
+              </a:r>
+              <a:br>
                 <a:rPr lang="te-IN" sz="2200" dirty="0">
                   <a:latin typeface="Ramabhadra" panose="02000600000000000000" pitchFamily="2" charset="0"/>
                   <a:cs typeface="Ramabhadra" panose="02000600000000000000" pitchFamily="2" charset="0"/>
                 </a:rPr>
-                <a:t>ప్రార్ధించి స్తుతియించుము</a:t>
+              </a:br>
+              <a:r>
+                <a:rPr lang="te-IN" sz="2200" dirty="0">
+                  <a:latin typeface="Ramabhadra" panose="02000600000000000000" pitchFamily="2" charset="0"/>
+                  <a:cs typeface="Ramabhadra" panose="02000600000000000000" pitchFamily="2" charset="0"/>
+                </a:rPr>
+                <a:t>యెహోవా ఈరే చూచుకొనును</a:t>
+              </a:r>
+              <a:br>
+                <a:rPr lang="te-IN" sz="2200" dirty="0">
+                  <a:latin typeface="Ramabhadra" panose="02000600000000000000" pitchFamily="2" charset="0"/>
+                  <a:cs typeface="Ramabhadra" panose="02000600000000000000" pitchFamily="2" charset="0"/>
+                </a:rPr>
+              </a:br>
+              <a:r>
+                <a:rPr lang="te-IN" sz="2200" dirty="0">
+                  <a:latin typeface="Ramabhadra" panose="02000600000000000000" pitchFamily="2" charset="0"/>
+                  <a:cs typeface="Ramabhadra" panose="02000600000000000000" pitchFamily="2" charset="0"/>
+                </a:rPr>
+                <a:t>సర్వము సమకూర్చును           </a:t>
               </a:r>
             </a:p>
             <a:p>
@@ -3638,43 +3636,46 @@
                   <a:latin typeface="Ramabhadra" panose="02000600000000000000" pitchFamily="2" charset="0"/>
                   <a:cs typeface="Ramabhadra" panose="02000600000000000000" pitchFamily="2" charset="0"/>
                 </a:rPr>
-                <a:t>గొల్యాత్ మనకు ఎదురు వచ్చినా –</a:t>
-              </a:r>
-            </a:p>
-            <a:p>
-              <a:pPr defTabSz="439781">
-                <a:defRPr/>
-              </a:pPr>
-              <a:r>
+                <a:t>వ్యాధులను తొలగించినావు</a:t>
+              </a:r>
+              <a:br>
                 <a:rPr lang="te-IN" sz="2200" dirty="0">
                   <a:latin typeface="Ramabhadra" panose="02000600000000000000" pitchFamily="2" charset="0"/>
                   <a:cs typeface="Ramabhadra" panose="02000600000000000000" pitchFamily="2" charset="0"/>
                 </a:rPr>
-                <a:t>క్రీస్తుయేసు ముందే నిలుచును</a:t>
-              </a:r>
-            </a:p>
-            <a:p>
-              <a:pPr defTabSz="439781">
-                <a:defRPr/>
-              </a:pPr>
+              </a:br>
               <a:r>
                 <a:rPr lang="te-IN" sz="2200" dirty="0">
                   <a:latin typeface="Ramabhadra" panose="02000600000000000000" pitchFamily="2" charset="0"/>
                   <a:cs typeface="Ramabhadra" panose="02000600000000000000" pitchFamily="2" charset="0"/>
                 </a:rPr>
-                <a:t>హల్లేలూయా – హల్లేలూయా</a:t>
-              </a:r>
-            </a:p>
-            <a:p>
-              <a:pPr defTabSz="439781">
-                <a:defRPr/>
-              </a:pPr>
-              <a:r>
+                <a:t>మృతులను మరి లేపినావు (2)</a:t>
+              </a:r>
+              <a:br>
                 <a:rPr lang="te-IN" sz="2200" dirty="0">
                   <a:latin typeface="Ramabhadra" panose="02000600000000000000" pitchFamily="2" charset="0"/>
                   <a:cs typeface="Ramabhadra" panose="02000600000000000000" pitchFamily="2" charset="0"/>
                 </a:rPr>
-                <a:t>జయమని పాడెదమూ</a:t>
+              </a:br>
+              <a:r>
+                <a:rPr lang="te-IN" sz="2200" dirty="0">
+                  <a:latin typeface="Ramabhadra" panose="02000600000000000000" pitchFamily="2" charset="0"/>
+                  <a:cs typeface="Ramabhadra" panose="02000600000000000000" pitchFamily="2" charset="0"/>
+                </a:rPr>
+                <a:t>యెహోవా రాఫా స్వస్థపరచును</a:t>
+              </a:r>
+              <a:br>
+                <a:rPr lang="te-IN" sz="2200" dirty="0">
+                  <a:latin typeface="Ramabhadra" panose="02000600000000000000" pitchFamily="2" charset="0"/>
+                  <a:cs typeface="Ramabhadra" panose="02000600000000000000" pitchFamily="2" charset="0"/>
+                </a:rPr>
+              </a:br>
+              <a:r>
+                <a:rPr lang="te-IN" sz="2200" dirty="0">
+                  <a:latin typeface="Ramabhadra" panose="02000600000000000000" pitchFamily="2" charset="0"/>
+                  <a:cs typeface="Ramabhadra" panose="02000600000000000000" pitchFamily="2" charset="0"/>
+                </a:rPr>
+                <a:t>నను స్వస్థపరచును                 </a:t>
               </a:r>
             </a:p>
           </p:txBody>
@@ -3883,7 +3884,7 @@
                   <a:latin typeface="Ramabhadra" panose="02000600000000000000" pitchFamily="2" charset="0"/>
                   <a:cs typeface="Ramabhadra" panose="02000600000000000000" pitchFamily="2" charset="0"/>
                 </a:rPr>
-                <a:t>నా కొకరు ఉన్నారు నను ప్రేమించే వారు</a:t>
+                <a:t>మాధుర్యమే నా ప్రభుతో జీవితం</a:t>
               </a:r>
             </a:p>
             <a:p>
@@ -3895,19 +3896,7 @@
                   <a:latin typeface="Ramabhadra" panose="02000600000000000000" pitchFamily="2" charset="0"/>
                   <a:cs typeface="Ramabhadra" panose="02000600000000000000" pitchFamily="2" charset="0"/>
                 </a:rPr>
-                <a:t>అడవులలో అల్లాడగా కరుణతో నను వెదకెను  </a:t>
-              </a:r>
-            </a:p>
-            <a:p>
-              <a:pPr defTabSz="439781">
-                <a:defRPr/>
-              </a:pPr>
-              <a:r>
-                <a:rPr lang="te-IN" sz="2400" dirty="0">
-                  <a:latin typeface="Ramabhadra" panose="02000600000000000000" pitchFamily="2" charset="0"/>
-                  <a:cs typeface="Ramabhadra" panose="02000600000000000000" pitchFamily="2" charset="0"/>
-                </a:rPr>
-                <a:t>ఆయనేసు... ఆయనేసు... </a:t>
+                <a:t>మహిమానందమే – మహా ఆశ్చర్యమే</a:t>
               </a:r>
             </a:p>
             <a:p>
@@ -3928,7 +3917,7 @@
                   <a:latin typeface="Ramabhadra" panose="02000600000000000000" pitchFamily="2" charset="0"/>
                   <a:cs typeface="Ramabhadra" panose="02000600000000000000" pitchFamily="2" charset="0"/>
                 </a:rPr>
-                <a:t>మందలోని గొర్రెవలె మతి తప్పితిరిగితిని</a:t>
+                <a:t>సర్వ శరీరులు గడ్డిని పోలిన వారైయున్నారు</a:t>
               </a:r>
             </a:p>
             <a:p>
@@ -3940,7 +3929,7 @@
                   <a:latin typeface="Ramabhadra" panose="02000600000000000000" pitchFamily="2" charset="0"/>
                   <a:cs typeface="Ramabhadra" panose="02000600000000000000" pitchFamily="2" charset="0"/>
                 </a:rPr>
-                <a:t>కాపరివై వెదకి వచ్చి తనఒడి చేర్చుకొనున్</a:t>
+                <a:t>వారి అందమంతయు పువ్వు వలె</a:t>
               </a:r>
             </a:p>
             <a:p>
@@ -3952,7 +3941,7 @@
                   <a:latin typeface="Ramabhadra" panose="02000600000000000000" pitchFamily="2" charset="0"/>
                   <a:cs typeface="Ramabhadra" panose="02000600000000000000" pitchFamily="2" charset="0"/>
                 </a:rPr>
-                <a:t>ఆయనేసు... ఆయనేసు... </a:t>
+                <a:t>వాడిపోవును – వాడిపోవును</a:t>
               </a:r>
             </a:p>
             <a:p>
@@ -3973,7 +3962,7 @@
                   <a:latin typeface="Ramabhadra" panose="02000600000000000000" pitchFamily="2" charset="0"/>
                   <a:cs typeface="Ramabhadra" panose="02000600000000000000" pitchFamily="2" charset="0"/>
                 </a:rPr>
-                <a:t>నన్నెరిగి నను పిలువ నా రాజుని ఎరిగితిని</a:t>
+                <a:t>నెమ్మది లేకుండా విస్తారమైన</a:t>
               </a:r>
             </a:p>
             <a:p>
@@ -3985,7 +3974,7 @@
                   <a:latin typeface="Ramabhadra" panose="02000600000000000000" pitchFamily="2" charset="0"/>
                   <a:cs typeface="Ramabhadra" panose="02000600000000000000" pitchFamily="2" charset="0"/>
                 </a:rPr>
-                <a:t>పరమున నను చేర్చెన్  పరిశుద్ధునిగా మార్చెన్</a:t>
+                <a:t>ధనముండుట కంటే</a:t>
               </a:r>
             </a:p>
             <a:p>
@@ -3997,7 +3986,19 @@
                   <a:latin typeface="Ramabhadra" panose="02000600000000000000" pitchFamily="2" charset="0"/>
                   <a:cs typeface="Ramabhadra" panose="02000600000000000000" pitchFamily="2" charset="0"/>
                 </a:rPr>
-                <a:t>ఆయనేసు... ఆయనేసు... </a:t>
+                <a:t>దేవుని యందలి భయ భక్తులతో</a:t>
+              </a:r>
+            </a:p>
+            <a:p>
+              <a:pPr defTabSz="439781">
+                <a:defRPr/>
+              </a:pPr>
+              <a:r>
+                <a:rPr lang="te-IN" sz="2400" dirty="0">
+                  <a:latin typeface="Ramabhadra" panose="02000600000000000000" pitchFamily="2" charset="0"/>
+                  <a:cs typeface="Ramabhadra" panose="02000600000000000000" pitchFamily="2" charset="0"/>
+                </a:rPr>
+                <a:t>ఉండుటే మేలు – ఉండుటే మేలు</a:t>
               </a:r>
             </a:p>
           </p:txBody>
@@ -4080,9 +4081,9 @@
         <p:grpSpPr>
           <a:xfrm>
             <a:off x="5104338" y="182031"/>
-            <a:ext cx="5229224" cy="6493935"/>
+            <a:ext cx="4724399" cy="6493935"/>
             <a:chOff x="160868" y="182032"/>
-            <a:chExt cx="5229224" cy="6493935"/>
+            <a:chExt cx="4724399" cy="6493935"/>
           </a:xfrm>
         </p:grpSpPr>
         <p:sp>
@@ -4154,8 +4155,8 @@
           </p:nvSpPr>
           <p:spPr>
             <a:xfrm>
-              <a:off x="848786" y="474344"/>
-              <a:ext cx="4541306" cy="5909310"/>
+              <a:off x="343961" y="740943"/>
+              <a:ext cx="4541306" cy="5632311"/>
             </a:xfrm>
             <a:prstGeom prst="rect">
               <a:avLst/>
@@ -4172,54 +4173,13 @@
                 <a:defRPr/>
               </a:pPr>
               <a:r>
-                <a:rPr lang="te-IN" sz="2100" dirty="0">
-                  <a:latin typeface="Ramabhadra" panose="02000600000000000000" pitchFamily="2" charset="0"/>
-                  <a:cs typeface="Ramabhadra" panose="02000600000000000000" pitchFamily="2" charset="0"/>
-                </a:rPr>
-                <a:t>నీ ప్రేమ ఎంతో అపారము</a:t>
-              </a:r>
-            </a:p>
-            <a:p>
-              <a:pPr defTabSz="439781">
-                <a:defRPr/>
-              </a:pPr>
-              <a:r>
-                <a:rPr lang="te-IN" sz="2100" dirty="0">
-                  <a:latin typeface="Ramabhadra" panose="02000600000000000000" pitchFamily="2" charset="0"/>
-                  <a:cs typeface="Ramabhadra" panose="02000600000000000000" pitchFamily="2" charset="0"/>
-                </a:rPr>
-                <a:t>వర్ణింపతరమా నా ప్రభూ</a:t>
-              </a:r>
-            </a:p>
-            <a:p>
-              <a:pPr defTabSz="439781">
-                <a:defRPr/>
-              </a:pPr>
-              <a:r>
-                <a:rPr lang="te-IN" sz="2100" dirty="0">
-                  <a:latin typeface="Ramabhadra" panose="02000600000000000000" pitchFamily="2" charset="0"/>
-                  <a:cs typeface="Ramabhadra" panose="02000600000000000000" pitchFamily="2" charset="0"/>
-                </a:rPr>
-                <a:t>పులకింప చేసెను నా హృది</a:t>
-              </a:r>
-            </a:p>
-            <a:p>
-              <a:pPr defTabSz="439781">
-                <a:defRPr/>
-              </a:pPr>
-              <a:r>
-                <a:rPr lang="te-IN" sz="2100" dirty="0">
-                  <a:latin typeface="Ramabhadra" panose="02000600000000000000" pitchFamily="2" charset="0"/>
-                  <a:cs typeface="Ramabhadra" panose="02000600000000000000" pitchFamily="2" charset="0"/>
-                </a:rPr>
-                <a:t>హృదయేశ్వరా నా యేసువా</a:t>
-              </a:r>
-            </a:p>
-            <a:p>
-              <a:pPr defTabSz="439781">
-                <a:defRPr/>
-              </a:pPr>
-              <a:endParaRPr lang="te-IN" sz="2100" dirty="0">
+                <a:rPr lang="te-IN" sz="2400" dirty="0">
+                  <a:latin typeface="Ramabhadra" panose="02000600000000000000" pitchFamily="2" charset="0"/>
+                  <a:cs typeface="Ramabhadra" panose="02000600000000000000" pitchFamily="2" charset="0"/>
+                </a:rPr>
+                <a:t>నాదు రక్షక నీ మనసే ఉత్తమం</a:t>
+              </a:r>
+              <a:endParaRPr lang="en-IN" sz="2400" dirty="0">
                 <a:latin typeface="Ramabhadra" panose="02000600000000000000" pitchFamily="2" charset="0"/>
                 <a:cs typeface="Ramabhadra" panose="02000600000000000000" pitchFamily="2" charset="0"/>
               </a:endParaRPr>
@@ -4229,78 +4189,54 @@
                 <a:defRPr/>
               </a:pPr>
               <a:r>
-                <a:rPr lang="te-IN" sz="2100" dirty="0">
-                  <a:latin typeface="Ramabhadra" panose="02000600000000000000" pitchFamily="2" charset="0"/>
-                  <a:cs typeface="Ramabhadra" panose="02000600000000000000" pitchFamily="2" charset="0"/>
-                </a:rPr>
-                <a:t>నన్ను ఎంతో ప్రేమించి</a:t>
-              </a:r>
-            </a:p>
-            <a:p>
-              <a:pPr defTabSz="439781">
-                <a:defRPr/>
-              </a:pPr>
-              <a:r>
-                <a:rPr lang="te-IN" sz="2100" dirty="0">
-                  <a:latin typeface="Ramabhadra" panose="02000600000000000000" pitchFamily="2" charset="0"/>
-                  <a:cs typeface="Ramabhadra" panose="02000600000000000000" pitchFamily="2" charset="0"/>
-                </a:rPr>
-                <a:t>నాదు పాపమె క్షమియించి</a:t>
-              </a:r>
-            </a:p>
-            <a:p>
-              <a:pPr defTabSz="439781">
-                <a:defRPr/>
-              </a:pPr>
-              <a:r>
-                <a:rPr lang="te-IN" sz="2100" dirty="0">
-                  <a:latin typeface="Ramabhadra" panose="02000600000000000000" pitchFamily="2" charset="0"/>
-                  <a:cs typeface="Ramabhadra" panose="02000600000000000000" pitchFamily="2" charset="0"/>
-                </a:rPr>
-                <a:t>కృప కనికరముల నీడలో</a:t>
-              </a:r>
-            </a:p>
-            <a:p>
-              <a:pPr defTabSz="439781">
-                <a:defRPr/>
-              </a:pPr>
-              <a:r>
-                <a:rPr lang="te-IN" sz="2100" dirty="0">
-                  <a:latin typeface="Ramabhadra" panose="02000600000000000000" pitchFamily="2" charset="0"/>
-                  <a:cs typeface="Ramabhadra" panose="02000600000000000000" pitchFamily="2" charset="0"/>
-                </a:rPr>
-                <a:t>నన్ను చేర్చిన నా ప్రభూ</a:t>
-              </a:r>
-            </a:p>
-            <a:p>
-              <a:pPr defTabSz="439781">
-                <a:defRPr/>
-              </a:pPr>
-              <a:r>
-                <a:rPr lang="te-IN" sz="2100" dirty="0">
-                  <a:latin typeface="Ramabhadra" panose="02000600000000000000" pitchFamily="2" charset="0"/>
-                  <a:cs typeface="Ramabhadra" panose="02000600000000000000" pitchFamily="2" charset="0"/>
-                </a:rPr>
-                <a:t>జీవితమంతా స్తుతియించినా</a:t>
-              </a:r>
-            </a:p>
-            <a:p>
-              <a:pPr defTabSz="439781">
-                <a:defRPr/>
-              </a:pPr>
-              <a:r>
-                <a:rPr lang="te-IN" sz="2100" dirty="0">
-                  <a:latin typeface="Ramabhadra" panose="02000600000000000000" pitchFamily="2" charset="0"/>
-                  <a:cs typeface="Ramabhadra" panose="02000600000000000000" pitchFamily="2" charset="0"/>
-                </a:rPr>
-                <a:t>తీరునా నీ ఋణం</a:t>
-              </a:r>
-            </a:p>
-            <a:p>
-              <a:pPr defTabSz="439781">
-                <a:defRPr/>
-              </a:pPr>
-              <a:endParaRPr lang="te-IN" sz="2100" dirty="0">
+                <a:rPr lang="te-IN" sz="2400" dirty="0">
+                  <a:latin typeface="Ramabhadra" panose="02000600000000000000" pitchFamily="2" charset="0"/>
+                  <a:cs typeface="Ramabhadra" panose="02000600000000000000" pitchFamily="2" charset="0"/>
+                </a:rPr>
+                <a:t>దినదినము నీతోనే వసియింతును</a:t>
+              </a:r>
+            </a:p>
+            <a:p>
+              <a:pPr defTabSz="439781">
+                <a:defRPr/>
+              </a:pPr>
+              <a:r>
+                <a:rPr lang="te-IN" sz="2400" dirty="0">
+                  <a:latin typeface="Ramabhadra" panose="02000600000000000000" pitchFamily="2" charset="0"/>
+                  <a:cs typeface="Ramabhadra" panose="02000600000000000000" pitchFamily="2" charset="0"/>
+                </a:rPr>
+                <a:t>నేనేది పలికినను ఏమి చేసినను</a:t>
+              </a:r>
+            </a:p>
+            <a:p>
+              <a:pPr defTabSz="439781">
+                <a:defRPr/>
+              </a:pPr>
+              <a:r>
+                <a:rPr lang="te-IN" sz="2400" dirty="0">
+                  <a:latin typeface="Ramabhadra" panose="02000600000000000000" pitchFamily="2" charset="0"/>
+                  <a:cs typeface="Ramabhadra" panose="02000600000000000000" pitchFamily="2" charset="0"/>
+                </a:rPr>
+                <a:t>నీ ప్రేమనే కనుపరుతును</a:t>
+              </a:r>
+            </a:p>
+            <a:p>
+              <a:pPr defTabSz="439781">
+                <a:defRPr/>
+              </a:pPr>
+              <a:r>
+                <a:rPr lang="te-IN" sz="2400" dirty="0">
+                  <a:latin typeface="Ramabhadra" panose="02000600000000000000" pitchFamily="2" charset="0"/>
+                  <a:cs typeface="Ramabhadra" panose="02000600000000000000" pitchFamily="2" charset="0"/>
+                </a:rPr>
+                <a:t>నీ శక్తినే కొనియాడేదను</a:t>
+              </a:r>
+            </a:p>
+            <a:p>
+              <a:pPr defTabSz="439781">
+                <a:defRPr/>
+              </a:pPr>
+              <a:endParaRPr lang="te-IN" sz="2400" dirty="0">
                 <a:latin typeface="Ramabhadra" panose="02000600000000000000" pitchFamily="2" charset="0"/>
                 <a:cs typeface="Ramabhadra" panose="02000600000000000000" pitchFamily="2" charset="0"/>
               </a:endParaRPr>
@@ -4310,71 +4246,104 @@
                 <a:defRPr/>
               </a:pPr>
               <a:r>
-                <a:rPr lang="te-IN" sz="2100" dirty="0">
-                  <a:latin typeface="Ramabhadra" panose="02000600000000000000" pitchFamily="2" charset="0"/>
-                  <a:cs typeface="Ramabhadra" panose="02000600000000000000" pitchFamily="2" charset="0"/>
-                </a:rPr>
-                <a:t>నీదు సన్నిధినే కాంక్షించి</a:t>
-              </a:r>
-            </a:p>
-            <a:p>
-              <a:pPr defTabSz="439781">
-                <a:defRPr/>
-              </a:pPr>
-              <a:r>
-                <a:rPr lang="te-IN" sz="2100" dirty="0">
-                  <a:latin typeface="Ramabhadra" panose="02000600000000000000" pitchFamily="2" charset="0"/>
-                  <a:cs typeface="Ramabhadra" panose="02000600000000000000" pitchFamily="2" charset="0"/>
-                </a:rPr>
-                <a:t>పాప బ్రతుకే వీడితి</a:t>
-              </a:r>
-            </a:p>
-            <a:p>
-              <a:pPr defTabSz="439781">
-                <a:defRPr/>
-              </a:pPr>
-              <a:r>
-                <a:rPr lang="te-IN" sz="2100" dirty="0">
-                  <a:latin typeface="Ramabhadra" panose="02000600000000000000" pitchFamily="2" charset="0"/>
-                  <a:cs typeface="Ramabhadra" panose="02000600000000000000" pitchFamily="2" charset="0"/>
-                </a:rPr>
-                <a:t>నీదు జీవమె నిండుగ</a:t>
-              </a:r>
-            </a:p>
-            <a:p>
-              <a:pPr defTabSz="439781">
-                <a:defRPr/>
-              </a:pPr>
-              <a:r>
-                <a:rPr lang="te-IN" sz="2100" dirty="0">
-                  <a:latin typeface="Ramabhadra" panose="02000600000000000000" pitchFamily="2" charset="0"/>
-                  <a:cs typeface="Ramabhadra" panose="02000600000000000000" pitchFamily="2" charset="0"/>
-                </a:rPr>
-                <a:t>నాలో నింపుము నా ప్రభు</a:t>
-              </a:r>
-            </a:p>
-            <a:p>
-              <a:pPr defTabSz="439781">
-                <a:defRPr/>
-              </a:pPr>
-              <a:r>
-                <a:rPr lang="te-IN" sz="2100" dirty="0">
-                  <a:latin typeface="Ramabhadra" panose="02000600000000000000" pitchFamily="2" charset="0"/>
-                  <a:cs typeface="Ramabhadra" panose="02000600000000000000" pitchFamily="2" charset="0"/>
-                </a:rPr>
-                <a:t>జీవితమంతా నీ ప్రేమన్</a:t>
-              </a:r>
-            </a:p>
-            <a:p>
-              <a:pPr defTabSz="439781">
-                <a:defRPr/>
-              </a:pPr>
-              <a:r>
-                <a:rPr lang="te-IN" sz="2100" dirty="0">
-                  <a:latin typeface="Ramabhadra" panose="02000600000000000000" pitchFamily="2" charset="0"/>
-                  <a:cs typeface="Ramabhadra" panose="02000600000000000000" pitchFamily="2" charset="0"/>
-                </a:rPr>
-                <a:t>చాటు చుందును</a:t>
+                <a:rPr lang="te-IN" sz="2400" dirty="0">
+                  <a:latin typeface="Ramabhadra" panose="02000600000000000000" pitchFamily="2" charset="0"/>
+                  <a:cs typeface="Ramabhadra" panose="02000600000000000000" pitchFamily="2" charset="0"/>
+                </a:rPr>
+                <a:t>నా హృదిలో నీ వాక్యము నివసింపని </a:t>
+              </a:r>
+            </a:p>
+            <a:p>
+              <a:pPr defTabSz="439781">
+                <a:defRPr/>
+              </a:pPr>
+              <a:r>
+                <a:rPr lang="te-IN" sz="2400" dirty="0">
+                  <a:latin typeface="Ramabhadra" panose="02000600000000000000" pitchFamily="2" charset="0"/>
+                  <a:cs typeface="Ramabhadra" panose="02000600000000000000" pitchFamily="2" charset="0"/>
+                </a:rPr>
+                <a:t>ప్రతిక్షణము ప్రతిదినము ధ్యానింతును </a:t>
+              </a:r>
+            </a:p>
+            <a:p>
+              <a:pPr defTabSz="439781">
+                <a:defRPr/>
+              </a:pPr>
+              <a:r>
+                <a:rPr lang="te-IN" sz="2400" dirty="0">
+                  <a:latin typeface="Ramabhadra" panose="02000600000000000000" pitchFamily="2" charset="0"/>
+                  <a:cs typeface="Ramabhadra" panose="02000600000000000000" pitchFamily="2" charset="0"/>
+                </a:rPr>
+                <a:t>లోకము నను విడచిన నీవు విడువలేదు    </a:t>
+              </a:r>
+            </a:p>
+            <a:p>
+              <a:pPr defTabSz="439781">
+                <a:defRPr/>
+              </a:pPr>
+              <a:r>
+                <a:rPr lang="te-IN" sz="2400" dirty="0">
+                  <a:latin typeface="Ramabhadra" panose="02000600000000000000" pitchFamily="2" charset="0"/>
+                  <a:cs typeface="Ramabhadra" panose="02000600000000000000" pitchFamily="2" charset="0"/>
+                </a:rPr>
+                <a:t>నాకు జయము జయము నీ శక్తితోనే</a:t>
+              </a:r>
+            </a:p>
+            <a:p>
+              <a:pPr defTabSz="439781">
+                <a:defRPr/>
+              </a:pPr>
+              <a:endParaRPr lang="te-IN" sz="2400" dirty="0">
+                <a:latin typeface="Ramabhadra" panose="02000600000000000000" pitchFamily="2" charset="0"/>
+                <a:cs typeface="Ramabhadra" panose="02000600000000000000" pitchFamily="2" charset="0"/>
+              </a:endParaRPr>
+            </a:p>
+            <a:p>
+              <a:pPr defTabSz="439781">
+                <a:defRPr/>
+              </a:pPr>
+              <a:r>
+                <a:rPr lang="te-IN" sz="2400" dirty="0">
+                  <a:latin typeface="Ramabhadra" panose="02000600000000000000" pitchFamily="2" charset="0"/>
+                  <a:cs typeface="Ramabhadra" panose="02000600000000000000" pitchFamily="2" charset="0"/>
+                </a:rPr>
+                <a:t>నా తండ్రి నా విభుడా పాలించుమా</a:t>
+              </a:r>
+            </a:p>
+            <a:p>
+              <a:pPr defTabSz="439781">
+                <a:defRPr/>
+              </a:pPr>
+              <a:r>
+                <a:rPr lang="te-IN" sz="2400" dirty="0">
+                  <a:latin typeface="Ramabhadra" panose="02000600000000000000" pitchFamily="2" charset="0"/>
+                  <a:cs typeface="Ramabhadra" panose="02000600000000000000" pitchFamily="2" charset="0"/>
+                </a:rPr>
+                <a:t>ఆదరణ నా హృదిలోనా నింపుమయా </a:t>
+              </a:r>
+            </a:p>
+            <a:p>
+              <a:pPr defTabSz="439781">
+                <a:defRPr/>
+              </a:pPr>
+              <a:r>
+                <a:rPr lang="te-IN" sz="2400" dirty="0">
+                  <a:latin typeface="Ramabhadra" panose="02000600000000000000" pitchFamily="2" charset="0"/>
+                  <a:cs typeface="Ramabhadra" panose="02000600000000000000" pitchFamily="2" charset="0"/>
+                </a:rPr>
+                <a:t>మనుజులు నను మరిచిన నీవు మరువలేదు </a:t>
+              </a:r>
+            </a:p>
+            <a:p>
+              <a:pPr defTabSz="439781">
+                <a:defRPr/>
+              </a:pPr>
+              <a:r>
+                <a:rPr lang="te-IN" sz="2400" dirty="0">
+                  <a:latin typeface="Ramabhadra" panose="02000600000000000000" pitchFamily="2" charset="0"/>
+                  <a:cs typeface="Ramabhadra" panose="02000600000000000000" pitchFamily="2" charset="0"/>
+                </a:rPr>
+                <a:t>నాకు జయము జయము నీ ప్రేమతోనే</a:t>
               </a:r>
             </a:p>
           </p:txBody>

</xml_diff>

<commit_message>
13 songs oct 24
</commit_message>
<xml_diff>
--- a/songsTemplate.pptx
+++ b/songsTemplate.pptx
@@ -255,7 +255,7 @@
           <a:p>
             <a:fld id="{F1102B08-ED9E-409F-B95F-09CAA1DAF6E0}" type="datetimeFigureOut">
               <a:rPr lang="en-IN" smtClean="0"/>
-              <a:t>05-10-2024</a:t>
+              <a:t>12-10-2024</a:t>
             </a:fld>
             <a:endParaRPr lang="en-IN"/>
           </a:p>
@@ -425,7 +425,7 @@
           <a:p>
             <a:fld id="{F1102B08-ED9E-409F-B95F-09CAA1DAF6E0}" type="datetimeFigureOut">
               <a:rPr lang="en-IN" smtClean="0"/>
-              <a:t>05-10-2024</a:t>
+              <a:t>12-10-2024</a:t>
             </a:fld>
             <a:endParaRPr lang="en-IN"/>
           </a:p>
@@ -605,7 +605,7 @@
           <a:p>
             <a:fld id="{F1102B08-ED9E-409F-B95F-09CAA1DAF6E0}" type="datetimeFigureOut">
               <a:rPr lang="en-IN" smtClean="0"/>
-              <a:t>05-10-2024</a:t>
+              <a:t>12-10-2024</a:t>
             </a:fld>
             <a:endParaRPr lang="en-IN"/>
           </a:p>
@@ -775,7 +775,7 @@
           <a:p>
             <a:fld id="{F1102B08-ED9E-409F-B95F-09CAA1DAF6E0}" type="datetimeFigureOut">
               <a:rPr lang="en-IN" smtClean="0"/>
-              <a:t>05-10-2024</a:t>
+              <a:t>12-10-2024</a:t>
             </a:fld>
             <a:endParaRPr lang="en-IN"/>
           </a:p>
@@ -1019,7 +1019,7 @@
           <a:p>
             <a:fld id="{F1102B08-ED9E-409F-B95F-09CAA1DAF6E0}" type="datetimeFigureOut">
               <a:rPr lang="en-IN" smtClean="0"/>
-              <a:t>05-10-2024</a:t>
+              <a:t>12-10-2024</a:t>
             </a:fld>
             <a:endParaRPr lang="en-IN"/>
           </a:p>
@@ -1251,7 +1251,7 @@
           <a:p>
             <a:fld id="{F1102B08-ED9E-409F-B95F-09CAA1DAF6E0}" type="datetimeFigureOut">
               <a:rPr lang="en-IN" smtClean="0"/>
-              <a:t>05-10-2024</a:t>
+              <a:t>12-10-2024</a:t>
             </a:fld>
             <a:endParaRPr lang="en-IN"/>
           </a:p>
@@ -1618,7 +1618,7 @@
           <a:p>
             <a:fld id="{F1102B08-ED9E-409F-B95F-09CAA1DAF6E0}" type="datetimeFigureOut">
               <a:rPr lang="en-IN" smtClean="0"/>
-              <a:t>05-10-2024</a:t>
+              <a:t>12-10-2024</a:t>
             </a:fld>
             <a:endParaRPr lang="en-IN"/>
           </a:p>
@@ -1736,7 +1736,7 @@
           <a:p>
             <a:fld id="{F1102B08-ED9E-409F-B95F-09CAA1DAF6E0}" type="datetimeFigureOut">
               <a:rPr lang="en-IN" smtClean="0"/>
-              <a:t>05-10-2024</a:t>
+              <a:t>12-10-2024</a:t>
             </a:fld>
             <a:endParaRPr lang="en-IN"/>
           </a:p>
@@ -1831,7 +1831,7 @@
           <a:p>
             <a:fld id="{F1102B08-ED9E-409F-B95F-09CAA1DAF6E0}" type="datetimeFigureOut">
               <a:rPr lang="en-IN" smtClean="0"/>
-              <a:t>05-10-2024</a:t>
+              <a:t>12-10-2024</a:t>
             </a:fld>
             <a:endParaRPr lang="en-IN"/>
           </a:p>
@@ -2108,7 +2108,7 @@
           <a:p>
             <a:fld id="{F1102B08-ED9E-409F-B95F-09CAA1DAF6E0}" type="datetimeFigureOut">
               <a:rPr lang="en-IN" smtClean="0"/>
-              <a:t>05-10-2024</a:t>
+              <a:t>12-10-2024</a:t>
             </a:fld>
             <a:endParaRPr lang="en-IN"/>
           </a:p>
@@ -2365,7 +2365,7 @@
           <a:p>
             <a:fld id="{F1102B08-ED9E-409F-B95F-09CAA1DAF6E0}" type="datetimeFigureOut">
               <a:rPr lang="en-IN" smtClean="0"/>
-              <a:t>05-10-2024</a:t>
+              <a:t>12-10-2024</a:t>
             </a:fld>
             <a:endParaRPr lang="en-IN"/>
           </a:p>
@@ -2578,7 +2578,7 @@
           <a:p>
             <a:fld id="{F1102B08-ED9E-409F-B95F-09CAA1DAF6E0}" type="datetimeFigureOut">
               <a:rPr lang="en-IN" smtClean="0"/>
-              <a:t>05-10-2024</a:t>
+              <a:t>12-10-2024</a:t>
             </a:fld>
             <a:endParaRPr lang="en-IN"/>
           </a:p>
@@ -2998,9 +2998,9 @@
         <p:grpSpPr>
           <a:xfrm>
             <a:off x="160868" y="182032"/>
-            <a:ext cx="4943470" cy="6493935"/>
+            <a:ext cx="5019669" cy="6493935"/>
             <a:chOff x="160868" y="182032"/>
-            <a:chExt cx="4943470" cy="6493935"/>
+            <a:chExt cx="5019669" cy="6493935"/>
           </a:xfrm>
         </p:grpSpPr>
         <p:sp>
@@ -3072,8 +3072,8 @@
           </p:nvSpPr>
           <p:spPr>
             <a:xfrm>
-              <a:off x="267762" y="709414"/>
-              <a:ext cx="4836576" cy="5847755"/>
+              <a:off x="343961" y="748108"/>
+              <a:ext cx="4836576" cy="5170646"/>
             </a:xfrm>
             <a:prstGeom prst="rect">
               <a:avLst/>
@@ -3094,56 +3094,38 @@
                   <a:latin typeface="Ramabhadra" panose="02000600000000000000" pitchFamily="2" charset="0"/>
                   <a:cs typeface="Ramabhadra" panose="02000600000000000000" pitchFamily="2" charset="0"/>
                 </a:rPr>
-                <a:t>చాలిన దేవుడవు యేసు </a:t>
-              </a:r>
-            </a:p>
-            <a:p>
-              <a:pPr defTabSz="439781">
-                <a:defRPr/>
-              </a:pPr>
-              <a:r>
+                <a:t>భూమ్యాకాశములు సృజించిన</a:t>
+              </a:r>
+              <a:br>
                 <a:rPr lang="te-IN" sz="2200" dirty="0">
                   <a:latin typeface="Ramabhadra" panose="02000600000000000000" pitchFamily="2" charset="0"/>
                   <a:cs typeface="Ramabhadra" panose="02000600000000000000" pitchFamily="2" charset="0"/>
                 </a:rPr>
-                <a:t>చాలిన దేవుడ నీవు</a:t>
-              </a:r>
-            </a:p>
-            <a:p>
-              <a:pPr defTabSz="439781">
-                <a:defRPr/>
-              </a:pPr>
+              </a:br>
               <a:r>
                 <a:rPr lang="te-IN" sz="2200" dirty="0">
                   <a:latin typeface="Ramabhadra" panose="02000600000000000000" pitchFamily="2" charset="0"/>
                   <a:cs typeface="Ramabhadra" panose="02000600000000000000" pitchFamily="2" charset="0"/>
                 </a:rPr>
-                <a:t>వ్యాధి బాధ సమయములో</a:t>
-              </a:r>
-            </a:p>
-            <a:p>
-              <a:pPr defTabSz="439781">
-                <a:defRPr/>
-              </a:pPr>
-              <a:r>
+                <a:t>యేసయ్యా నీకే స్తోత్రం (2)</a:t>
+              </a:r>
+              <a:br>
                 <a:rPr lang="te-IN" sz="2200" dirty="0">
                   <a:latin typeface="Ramabhadra" panose="02000600000000000000" pitchFamily="2" charset="0"/>
                   <a:cs typeface="Ramabhadra" panose="02000600000000000000" pitchFamily="2" charset="0"/>
                 </a:rPr>
-                <a:t>కష్టసుడుల తరంగములో</a:t>
-              </a:r>
-            </a:p>
-            <a:p>
-              <a:pPr defTabSz="439781">
-                <a:defRPr/>
-              </a:pPr>
+              </a:br>
               <a:r>
                 <a:rPr lang="te-IN" sz="2200" dirty="0">
                   <a:latin typeface="Ramabhadra" panose="02000600000000000000" pitchFamily="2" charset="0"/>
                   <a:cs typeface="Ramabhadra" panose="02000600000000000000" pitchFamily="2" charset="0"/>
                 </a:rPr>
-                <a:t>ఏమున్నా లేకున్నా ఏ స్ధితికైనా</a:t>
-              </a:r>
+                <a:t>నీ ఆశ్ఛర్యమైన క్రియలు</a:t>
+              </a:r>
+              <a:endParaRPr lang="en-IN" sz="2200" dirty="0">
+                <a:latin typeface="Ramabhadra" panose="02000600000000000000" pitchFamily="2" charset="0"/>
+                <a:cs typeface="Ramabhadra" panose="02000600000000000000" pitchFamily="2" charset="0"/>
+              </a:endParaRPr>
             </a:p>
             <a:p>
               <a:pPr defTabSz="439781">
@@ -3154,7 +3136,20 @@
                   <a:latin typeface="Ramabhadra" panose="02000600000000000000" pitchFamily="2" charset="0"/>
                   <a:cs typeface="Ramabhadra" panose="02000600000000000000" pitchFamily="2" charset="0"/>
                 </a:rPr>
-                <a:t>చాలిన దేవుడ నీవు</a:t>
+                <a:t>నేనెలా మరచిపోదును (2)</a:t>
+              </a:r>
+              <a:br>
+                <a:rPr lang="te-IN" sz="2200" dirty="0">
+                  <a:latin typeface="Ramabhadra" panose="02000600000000000000" pitchFamily="2" charset="0"/>
+                  <a:cs typeface="Ramabhadra" panose="02000600000000000000" pitchFamily="2" charset="0"/>
+                </a:rPr>
+              </a:br>
+              <a:r>
+                <a:rPr lang="te-IN" sz="2200" dirty="0">
+                  <a:latin typeface="Ramabhadra" panose="02000600000000000000" pitchFamily="2" charset="0"/>
+                  <a:cs typeface="Ramabhadra" panose="02000600000000000000" pitchFamily="2" charset="0"/>
+                </a:rPr>
+                <a:t>హల్లెలూయ లూయ హల్లెలూయా (4)</a:t>
               </a:r>
             </a:p>
             <a:p>
@@ -3175,8 +3170,12 @@
                   <a:latin typeface="Ramabhadra" panose="02000600000000000000" pitchFamily="2" charset="0"/>
                   <a:cs typeface="Ramabhadra" panose="02000600000000000000" pitchFamily="2" charset="0"/>
                 </a:rPr>
-                <a:t>అంజూర చెట్లు పూయకున్నను</a:t>
-              </a:r>
+                <a:t>బానిసత్వమునుండి శ్రమల బారినుండి</a:t>
+              </a:r>
+              <a:endParaRPr lang="en-IN" sz="2200" dirty="0">
+                <a:latin typeface="Ramabhadra" panose="02000600000000000000" pitchFamily="2" charset="0"/>
+                <a:cs typeface="Ramabhadra" panose="02000600000000000000" pitchFamily="2" charset="0"/>
+              </a:endParaRPr>
             </a:p>
             <a:p>
               <a:pPr defTabSz="439781">
@@ -3187,119 +3186,114 @@
                   <a:latin typeface="Ramabhadra" panose="02000600000000000000" pitchFamily="2" charset="0"/>
                   <a:cs typeface="Ramabhadra" panose="02000600000000000000" pitchFamily="2" charset="0"/>
                 </a:rPr>
-                <a:t> ద్రాక్ష చెట్లు ఫలింపకున్నను</a:t>
-              </a:r>
-            </a:p>
-            <a:p>
-              <a:pPr defTabSz="439781">
-                <a:defRPr/>
-              </a:pPr>
-              <a:r>
+                <a:t>విడిపించావు నన్ను</a:t>
+              </a:r>
+              <a:br>
                 <a:rPr lang="te-IN" sz="2200" dirty="0">
                   <a:latin typeface="Ramabhadra" panose="02000600000000000000" pitchFamily="2" charset="0"/>
                   <a:cs typeface="Ramabhadra" panose="02000600000000000000" pitchFamily="2" charset="0"/>
                 </a:rPr>
-                <a:t>చేనులోని పైరు పండకపోయినను</a:t>
-              </a:r>
-            </a:p>
-            <a:p>
-              <a:pPr defTabSz="439781">
-                <a:defRPr/>
-              </a:pPr>
+              </a:br>
               <a:r>
                 <a:rPr lang="te-IN" sz="2200" dirty="0">
                   <a:latin typeface="Ramabhadra" panose="02000600000000000000" pitchFamily="2" charset="0"/>
                   <a:cs typeface="Ramabhadra" panose="02000600000000000000" pitchFamily="2" charset="0"/>
                 </a:rPr>
-                <a:t>శాలలోని పశువులు లేక పోయినను</a:t>
-              </a:r>
-            </a:p>
-            <a:p>
-              <a:pPr defTabSz="439781">
-                <a:defRPr/>
-              </a:pPr>
+                <a:t>దీన దశలో నేనుండగా </a:t>
+              </a:r>
+              <a:endParaRPr lang="en-IN" sz="2200" dirty="0">
+                <a:latin typeface="Ramabhadra" panose="02000600000000000000" pitchFamily="2" charset="0"/>
+                <a:cs typeface="Ramabhadra" panose="02000600000000000000" pitchFamily="2" charset="0"/>
+              </a:endParaRPr>
+            </a:p>
+            <a:p>
+              <a:pPr defTabSz="439781">
+                <a:defRPr/>
+              </a:pPr>
+              <a:r>
+                <a:rPr lang="te-IN" sz="2200" dirty="0">
+                  <a:latin typeface="Ramabhadra" panose="02000600000000000000" pitchFamily="2" charset="0"/>
+                  <a:cs typeface="Ramabhadra" panose="02000600000000000000" pitchFamily="2" charset="0"/>
+                </a:rPr>
+                <a:t>నను విడువనైతివి (2) </a:t>
+              </a:r>
+            </a:p>
+            <a:p>
+              <a:pPr defTabSz="439781">
+                <a:defRPr/>
+              </a:pPr>
+              <a:endParaRPr lang="en-IN" sz="2200" dirty="0">
+                <a:latin typeface="Ramabhadra" panose="02000600000000000000" pitchFamily="2" charset="0"/>
+                <a:cs typeface="Ramabhadra" panose="02000600000000000000" pitchFamily="2" charset="0"/>
+              </a:endParaRPr>
+            </a:p>
+            <a:p>
+              <a:pPr defTabSz="439781">
+                <a:defRPr/>
+              </a:pPr>
+              <a:r>
+                <a:rPr lang="te-IN" sz="2200" dirty="0">
+                  <a:latin typeface="Ramabhadra" panose="02000600000000000000" pitchFamily="2" charset="0"/>
+                  <a:cs typeface="Ramabhadra" panose="02000600000000000000" pitchFamily="2" charset="0"/>
+                </a:rPr>
+                <a:t>జీవాహారమై నీదు వాక్యము</a:t>
+              </a:r>
+              <a:endParaRPr lang="en-IN" sz="2200" dirty="0">
+                <a:latin typeface="Ramabhadra" panose="02000600000000000000" pitchFamily="2" charset="0"/>
+                <a:cs typeface="Ramabhadra" panose="02000600000000000000" pitchFamily="2" charset="0"/>
+              </a:endParaRPr>
+            </a:p>
+            <a:p>
+              <a:pPr defTabSz="439781">
+                <a:defRPr/>
+              </a:pPr>
+              <a:r>
+                <a:rPr lang="te-IN" sz="2200" dirty="0">
+                  <a:latin typeface="Ramabhadra" panose="02000600000000000000" pitchFamily="2" charset="0"/>
+                  <a:cs typeface="Ramabhadra" panose="02000600000000000000" pitchFamily="2" charset="0"/>
+                </a:rPr>
+                <a:t>పోషించెను నన్ను</a:t>
+              </a:r>
+              <a:br>
+                <a:rPr lang="te-IN" sz="2200" dirty="0">
+                  <a:latin typeface="Ramabhadra" panose="02000600000000000000" pitchFamily="2" charset="0"/>
+                  <a:cs typeface="Ramabhadra" panose="02000600000000000000" pitchFamily="2" charset="0"/>
+                </a:rPr>
+              </a:br>
+              <a:r>
+                <a:rPr lang="te-IN" sz="2200" dirty="0">
+                  <a:latin typeface="Ramabhadra" panose="02000600000000000000" pitchFamily="2" charset="0"/>
+                  <a:cs typeface="Ramabhadra" panose="02000600000000000000" pitchFamily="2" charset="0"/>
+                </a:rPr>
+                <a:t>ఆకలితో అల్లాడగా</a:t>
+              </a:r>
+              <a:endParaRPr lang="en-IN" sz="2200" dirty="0">
+                <a:latin typeface="Ramabhadra" panose="02000600000000000000" pitchFamily="2" charset="0"/>
+                <a:cs typeface="Ramabhadra" panose="02000600000000000000" pitchFamily="2" charset="0"/>
+              </a:endParaRPr>
+            </a:p>
+            <a:p>
+              <a:pPr defTabSz="439781">
+                <a:defRPr/>
+              </a:pPr>
+              <a:r>
+                <a:rPr lang="te-IN" sz="2200" dirty="0">
+                  <a:latin typeface="Ramabhadra" panose="02000600000000000000" pitchFamily="2" charset="0"/>
+                  <a:cs typeface="Ramabhadra" panose="02000600000000000000" pitchFamily="2" charset="0"/>
+                </a:rPr>
+                <a:t>నను తృప్తిపరచితివి (2</a:t>
+              </a:r>
+              <a:r>
+                <a:rPr lang="en-IN" sz="2200" dirty="0">
+                  <a:latin typeface="Ramabhadra" panose="02000600000000000000" pitchFamily="2" charset="0"/>
+                  <a:cs typeface="Ramabhadra" panose="02000600000000000000" pitchFamily="2" charset="0"/>
+                </a:rPr>
+                <a:t>)</a:t>
+              </a:r>
               <a:endParaRPr lang="te-IN" sz="2200" dirty="0">
                 <a:latin typeface="Ramabhadra" panose="02000600000000000000" pitchFamily="2" charset="0"/>
                 <a:cs typeface="Ramabhadra" panose="02000600000000000000" pitchFamily="2" charset="0"/>
               </a:endParaRPr>
-            </a:p>
-            <a:p>
-              <a:pPr defTabSz="439781">
-                <a:defRPr/>
-              </a:pPr>
-              <a:r>
-                <a:rPr lang="te-IN" sz="2200" dirty="0">
-                  <a:latin typeface="Ramabhadra" panose="02000600000000000000" pitchFamily="2" charset="0"/>
-                  <a:cs typeface="Ramabhadra" panose="02000600000000000000" pitchFamily="2" charset="0"/>
-                </a:rPr>
-                <a:t>గాఢాంధకారాన పయనించిన </a:t>
-              </a:r>
-            </a:p>
-            <a:p>
-              <a:pPr defTabSz="439781">
-                <a:defRPr/>
-              </a:pPr>
-              <a:r>
-                <a:rPr lang="te-IN" sz="2200" dirty="0">
-                  <a:latin typeface="Ramabhadra" panose="02000600000000000000" pitchFamily="2" charset="0"/>
-                  <a:cs typeface="Ramabhadra" panose="02000600000000000000" pitchFamily="2" charset="0"/>
-                </a:rPr>
-                <a:t>పొంగు సాగరా లెదురైన</a:t>
-              </a:r>
-            </a:p>
-            <a:p>
-              <a:pPr defTabSz="439781">
-                <a:defRPr/>
-              </a:pPr>
-              <a:r>
-                <a:rPr lang="te-IN" sz="2200" dirty="0">
-                  <a:latin typeface="Ramabhadra" panose="02000600000000000000" pitchFamily="2" charset="0"/>
-                  <a:cs typeface="Ramabhadra" panose="02000600000000000000" pitchFamily="2" charset="0"/>
-                </a:rPr>
-                <a:t>లోకమంత ఒకటైన</a:t>
-              </a:r>
-              <a:endParaRPr lang="en-IN" sz="2200" dirty="0">
-                <a:latin typeface="Ramabhadra" panose="02000600000000000000" pitchFamily="2" charset="0"/>
-                <a:cs typeface="Ramabhadra" panose="02000600000000000000" pitchFamily="2" charset="0"/>
-              </a:endParaRPr>
-            </a:p>
-            <a:p>
-              <a:pPr defTabSz="439781">
-                <a:defRPr/>
-              </a:pPr>
-              <a:r>
-                <a:rPr lang="te-IN" sz="2200" dirty="0">
-                  <a:latin typeface="Ramabhadra" panose="02000600000000000000" pitchFamily="2" charset="0"/>
-                  <a:cs typeface="Ramabhadra" panose="02000600000000000000" pitchFamily="2" charset="0"/>
-                </a:rPr>
-                <a:t>అన్యాయ</a:t>
-              </a:r>
-              <a:r>
-                <a:rPr lang="en-IN" sz="2200" dirty="0">
-                  <a:latin typeface="Ramabhadra" panose="02000600000000000000" pitchFamily="2" charset="0"/>
-                  <a:cs typeface="Ramabhadra" panose="02000600000000000000" pitchFamily="2" charset="0"/>
-                </a:rPr>
-                <a:t> </a:t>
-              </a:r>
-              <a:r>
-                <a:rPr lang="te-IN" sz="2200" dirty="0">
-                  <a:latin typeface="Ramabhadra" panose="02000600000000000000" pitchFamily="2" charset="0"/>
-                  <a:cs typeface="Ramabhadra" panose="02000600000000000000" pitchFamily="2" charset="0"/>
-                </a:rPr>
-                <a:t>తీర్పుకు గురిచేసిన</a:t>
-              </a:r>
-            </a:p>
-            <a:p>
-              <a:pPr defTabSz="439781">
-                <a:defRPr/>
-              </a:pPr>
-              <a:r>
-                <a:rPr lang="te-IN" sz="2200" dirty="0">
-                  <a:latin typeface="Ramabhadra" panose="02000600000000000000" pitchFamily="2" charset="0"/>
-                  <a:cs typeface="Ramabhadra" panose="02000600000000000000" pitchFamily="2" charset="0"/>
-                </a:rPr>
-                <a:t>సత్యము పలుకుటచే నష్టము కలిగినను</a:t>
-              </a:r>
             </a:p>
           </p:txBody>
         </p:sp>
@@ -3455,8 +3449,8 @@
           </p:nvSpPr>
           <p:spPr>
             <a:xfrm>
-              <a:off x="343961" y="736932"/>
-              <a:ext cx="4541306" cy="5847755"/>
+              <a:off x="343961" y="770800"/>
+              <a:ext cx="4541306" cy="5632311"/>
             </a:xfrm>
             <a:prstGeom prst="rect">
               <a:avLst/>
@@ -3473,96 +3467,78 @@
                 <a:defRPr/>
               </a:pPr>
               <a:r>
-                <a:rPr lang="te-IN" sz="2200" dirty="0">
-                  <a:latin typeface="Ramabhadra" panose="02000600000000000000" pitchFamily="2" charset="0"/>
-                  <a:cs typeface="Ramabhadra" panose="02000600000000000000" pitchFamily="2" charset="0"/>
-                </a:rPr>
-                <a:t>మహిమ ఘనతకు అర్హుడవు</a:t>
-              </a:r>
-              <a:br>
-                <a:rPr lang="te-IN" sz="2200" dirty="0">
-                  <a:latin typeface="Ramabhadra" panose="02000600000000000000" pitchFamily="2" charset="0"/>
-                  <a:cs typeface="Ramabhadra" panose="02000600000000000000" pitchFamily="2" charset="0"/>
-                </a:rPr>
-              </a:br>
-              <a:r>
-                <a:rPr lang="te-IN" sz="2200" dirty="0">
-                  <a:latin typeface="Ramabhadra" panose="02000600000000000000" pitchFamily="2" charset="0"/>
-                  <a:cs typeface="Ramabhadra" panose="02000600000000000000" pitchFamily="2" charset="0"/>
-                </a:rPr>
-                <a:t>నీవే నా దైవము</a:t>
-              </a:r>
-              <a:br>
-                <a:rPr lang="te-IN" sz="2200" dirty="0">
-                  <a:latin typeface="Ramabhadra" panose="02000600000000000000" pitchFamily="2" charset="0"/>
-                  <a:cs typeface="Ramabhadra" panose="02000600000000000000" pitchFamily="2" charset="0"/>
-                </a:rPr>
-              </a:br>
-              <a:r>
-                <a:rPr lang="te-IN" sz="2200" dirty="0">
-                  <a:latin typeface="Ramabhadra" panose="02000600000000000000" pitchFamily="2" charset="0"/>
-                  <a:cs typeface="Ramabhadra" panose="02000600000000000000" pitchFamily="2" charset="0"/>
-                </a:rPr>
-                <a:t>సృష్టికర్త ముక్తి దాత (2)</a:t>
-              </a:r>
-              <a:br>
-                <a:rPr lang="te-IN" sz="2200" dirty="0">
-                  <a:latin typeface="Ramabhadra" panose="02000600000000000000" pitchFamily="2" charset="0"/>
-                  <a:cs typeface="Ramabhadra" panose="02000600000000000000" pitchFamily="2" charset="0"/>
-                </a:rPr>
-              </a:br>
-              <a:r>
-                <a:rPr lang="te-IN" sz="2200" dirty="0">
-                  <a:latin typeface="Ramabhadra" panose="02000600000000000000" pitchFamily="2" charset="0"/>
-                  <a:cs typeface="Ramabhadra" panose="02000600000000000000" pitchFamily="2" charset="0"/>
-                </a:rPr>
-                <a:t>మా స్తుతులకు పాత్రుడా</a:t>
-              </a:r>
-              <a:br>
-                <a:rPr lang="te-IN" sz="2200" dirty="0">
-                  <a:latin typeface="Ramabhadra" panose="02000600000000000000" pitchFamily="2" charset="0"/>
-                  <a:cs typeface="Ramabhadra" panose="02000600000000000000" pitchFamily="2" charset="0"/>
-                </a:rPr>
-              </a:br>
-              <a:r>
-                <a:rPr lang="te-IN" sz="2200" dirty="0">
-                  <a:latin typeface="Ramabhadra" panose="02000600000000000000" pitchFamily="2" charset="0"/>
-                  <a:cs typeface="Ramabhadra" panose="02000600000000000000" pitchFamily="2" charset="0"/>
-                </a:rPr>
-                <a:t>ఆరాధనా నీకే ఆరాధనా నీకే</a:t>
-              </a:r>
-              <a:br>
-                <a:rPr lang="te-IN" sz="2200" dirty="0">
-                  <a:latin typeface="Ramabhadra" panose="02000600000000000000" pitchFamily="2" charset="0"/>
-                  <a:cs typeface="Ramabhadra" panose="02000600000000000000" pitchFamily="2" charset="0"/>
-                </a:rPr>
-              </a:br>
-              <a:r>
-                <a:rPr lang="te-IN" sz="2200" dirty="0">
-                  <a:latin typeface="Ramabhadra" panose="02000600000000000000" pitchFamily="2" charset="0"/>
-                  <a:cs typeface="Ramabhadra" panose="02000600000000000000" pitchFamily="2" charset="0"/>
-                </a:rPr>
-                <a:t>ఆరాధనా స్తుతి ఆరాధనా ఆరాధనా నీకే (2)</a:t>
-              </a:r>
-              <a:br>
-                <a:rPr lang="te-IN" sz="2200" dirty="0">
-                  <a:latin typeface="Ramabhadra" panose="02000600000000000000" pitchFamily="2" charset="0"/>
-                  <a:cs typeface="Ramabhadra" panose="02000600000000000000" pitchFamily="2" charset="0"/>
-                </a:rPr>
-              </a:br>
-              <a:r>
-                <a:rPr lang="te-IN" sz="2200" dirty="0">
-                  <a:latin typeface="Ramabhadra" panose="02000600000000000000" pitchFamily="2" charset="0"/>
-                  <a:cs typeface="Ramabhadra" panose="02000600000000000000" pitchFamily="2" charset="0"/>
-                </a:rPr>
-                <a:t>ఆరాధనా నీకే ఆరాధనా నీకే</a:t>
-              </a:r>
-            </a:p>
-            <a:p>
-              <a:pPr defTabSz="439781">
-                <a:defRPr/>
-              </a:pPr>
-              <a:endParaRPr lang="te-IN" sz="2200" dirty="0">
+                <a:rPr lang="te-IN" dirty="0">
+                  <a:latin typeface="Ramabhadra" panose="02000600000000000000" pitchFamily="2" charset="0"/>
+                  <a:cs typeface="Ramabhadra" panose="02000600000000000000" pitchFamily="2" charset="0"/>
+                </a:rPr>
+                <a:t>నీ ప్రేమ నా జీవితాన్ని – నీకై వెలిగించెనే యేసయ్యా</a:t>
+              </a:r>
+            </a:p>
+            <a:p>
+              <a:pPr defTabSz="439781">
+                <a:defRPr/>
+              </a:pPr>
+              <a:r>
+                <a:rPr lang="te-IN" dirty="0">
+                  <a:latin typeface="Ramabhadra" panose="02000600000000000000" pitchFamily="2" charset="0"/>
+                  <a:cs typeface="Ramabhadra" panose="02000600000000000000" pitchFamily="2" charset="0"/>
+                </a:rPr>
+                <a:t>నీ కృప సెలయేరులా – నాలో ప్రవహించెనే (2)</a:t>
+              </a:r>
+            </a:p>
+            <a:p>
+              <a:pPr defTabSz="439781">
+                <a:defRPr/>
+              </a:pPr>
+              <a:r>
+                <a:rPr lang="te-IN" dirty="0">
+                  <a:latin typeface="Ramabhadra" panose="02000600000000000000" pitchFamily="2" charset="0"/>
+                  <a:cs typeface="Ramabhadra" panose="02000600000000000000" pitchFamily="2" charset="0"/>
+                </a:rPr>
+                <a:t>నన్ను క్షమియించెనే – నన్ను కరుణించెనే</a:t>
+              </a:r>
+            </a:p>
+            <a:p>
+              <a:pPr defTabSz="439781">
+                <a:defRPr/>
+              </a:pPr>
+              <a:r>
+                <a:rPr lang="te-IN" dirty="0">
+                  <a:latin typeface="Ramabhadra" panose="02000600000000000000" pitchFamily="2" charset="0"/>
+                  <a:cs typeface="Ramabhadra" panose="02000600000000000000" pitchFamily="2" charset="0"/>
+                </a:rPr>
+                <a:t>నన్ను స్థిరపరచెనే – నన్ను ఘనపరచెనే (2)</a:t>
+              </a:r>
+            </a:p>
+            <a:p>
+              <a:pPr defTabSz="439781">
+                <a:defRPr/>
+              </a:pPr>
+              <a:r>
+                <a:rPr lang="te-IN" dirty="0">
+                  <a:latin typeface="Ramabhadra" panose="02000600000000000000" pitchFamily="2" charset="0"/>
+                  <a:cs typeface="Ramabhadra" panose="02000600000000000000" pitchFamily="2" charset="0"/>
+                </a:rPr>
+                <a:t>యేసయ్యా యేసయ్యా నా యేసయ్యా</a:t>
+              </a:r>
+            </a:p>
+            <a:p>
+              <a:pPr defTabSz="439781">
+                <a:defRPr/>
+              </a:pPr>
+              <a:r>
+                <a:rPr lang="te-IN" dirty="0">
+                  <a:latin typeface="Ramabhadra" panose="02000600000000000000" pitchFamily="2" charset="0"/>
+                  <a:cs typeface="Ramabhadra" panose="02000600000000000000" pitchFamily="2" charset="0"/>
+                </a:rPr>
+                <a:t>యేసయ్యా యేసయ్యా ఓ మెస్సయ్యా (2)</a:t>
+              </a:r>
+            </a:p>
+            <a:p>
+              <a:pPr defTabSz="439781">
+                <a:defRPr/>
+              </a:pPr>
+              <a:endParaRPr lang="te-IN" dirty="0">
                 <a:latin typeface="Ramabhadra" panose="02000600000000000000" pitchFamily="2" charset="0"/>
                 <a:cs typeface="Ramabhadra" panose="02000600000000000000" pitchFamily="2" charset="0"/>
               </a:endParaRPr>
@@ -3572,57 +3548,78 @@
                 <a:defRPr/>
               </a:pPr>
               <a:r>
-                <a:rPr lang="te-IN" sz="2200" dirty="0">
-                  <a:latin typeface="Ramabhadra" panose="02000600000000000000" pitchFamily="2" charset="0"/>
-                  <a:cs typeface="Ramabhadra" panose="02000600000000000000" pitchFamily="2" charset="0"/>
-                </a:rPr>
-                <a:t>మన్నాను కురిపించినావు</a:t>
-              </a:r>
-              <a:br>
-                <a:rPr lang="te-IN" sz="2200" dirty="0">
-                  <a:latin typeface="Ramabhadra" panose="02000600000000000000" pitchFamily="2" charset="0"/>
-                  <a:cs typeface="Ramabhadra" panose="02000600000000000000" pitchFamily="2" charset="0"/>
-                </a:rPr>
-              </a:br>
-              <a:r>
-                <a:rPr lang="te-IN" sz="2200" dirty="0">
-                  <a:latin typeface="Ramabhadra" panose="02000600000000000000" pitchFamily="2" charset="0"/>
-                  <a:cs typeface="Ramabhadra" panose="02000600000000000000" pitchFamily="2" charset="0"/>
-                </a:rPr>
-                <a:t>బండనుండి నీల్లిచ్చినావు (2)</a:t>
-              </a:r>
-              <a:br>
-                <a:rPr lang="te-IN" sz="2200" dirty="0">
-                  <a:latin typeface="Ramabhadra" panose="02000600000000000000" pitchFamily="2" charset="0"/>
-                  <a:cs typeface="Ramabhadra" panose="02000600000000000000" pitchFamily="2" charset="0"/>
-                </a:rPr>
-              </a:br>
-              <a:r>
-                <a:rPr lang="te-IN" sz="2200" dirty="0">
-                  <a:latin typeface="Ramabhadra" panose="02000600000000000000" pitchFamily="2" charset="0"/>
-                  <a:cs typeface="Ramabhadra" panose="02000600000000000000" pitchFamily="2" charset="0"/>
-                </a:rPr>
-                <a:t>యెహోవా ఈరే చూచుకొనును</a:t>
-              </a:r>
-              <a:br>
-                <a:rPr lang="te-IN" sz="2200" dirty="0">
-                  <a:latin typeface="Ramabhadra" panose="02000600000000000000" pitchFamily="2" charset="0"/>
-                  <a:cs typeface="Ramabhadra" panose="02000600000000000000" pitchFamily="2" charset="0"/>
-                </a:rPr>
-              </a:br>
-              <a:r>
-                <a:rPr lang="te-IN" sz="2200" dirty="0">
-                  <a:latin typeface="Ramabhadra" panose="02000600000000000000" pitchFamily="2" charset="0"/>
-                  <a:cs typeface="Ramabhadra" panose="02000600000000000000" pitchFamily="2" charset="0"/>
-                </a:rPr>
-                <a:t>సర్వము సమకూర్చును           </a:t>
-              </a:r>
-            </a:p>
-            <a:p>
-              <a:pPr defTabSz="439781">
-                <a:defRPr/>
-              </a:pPr>
-              <a:endParaRPr lang="te-IN" sz="2200" dirty="0">
+                <a:rPr lang="te-IN" dirty="0">
+                  <a:latin typeface="Ramabhadra" panose="02000600000000000000" pitchFamily="2" charset="0"/>
+                  <a:cs typeface="Ramabhadra" panose="02000600000000000000" pitchFamily="2" charset="0"/>
+                </a:rPr>
+                <a:t>నేను నిన్ను విడచిననూ –</a:t>
+              </a:r>
+            </a:p>
+            <a:p>
+              <a:pPr defTabSz="439781">
+                <a:defRPr/>
+              </a:pPr>
+              <a:r>
+                <a:rPr lang="te-IN" dirty="0">
+                  <a:latin typeface="Ramabhadra" panose="02000600000000000000" pitchFamily="2" charset="0"/>
+                  <a:cs typeface="Ramabhadra" panose="02000600000000000000" pitchFamily="2" charset="0"/>
+                </a:rPr>
+                <a:t>నీవు నన్ను విడువలేదయ్యా</a:t>
+              </a:r>
+            </a:p>
+            <a:p>
+              <a:pPr defTabSz="439781">
+                <a:defRPr/>
+              </a:pPr>
+              <a:r>
+                <a:rPr lang="te-IN" dirty="0">
+                  <a:latin typeface="Ramabhadra" panose="02000600000000000000" pitchFamily="2" charset="0"/>
+                  <a:cs typeface="Ramabhadra" panose="02000600000000000000" pitchFamily="2" charset="0"/>
+                </a:rPr>
+                <a:t>దారి తప్పి తొలగిననూ –</a:t>
+              </a:r>
+            </a:p>
+            <a:p>
+              <a:pPr defTabSz="439781">
+                <a:defRPr/>
+              </a:pPr>
+              <a:r>
+                <a:rPr lang="te-IN" dirty="0">
+                  <a:latin typeface="Ramabhadra" panose="02000600000000000000" pitchFamily="2" charset="0"/>
+                  <a:cs typeface="Ramabhadra" panose="02000600000000000000" pitchFamily="2" charset="0"/>
+                </a:rPr>
+                <a:t>నీ దారిలో నను చేర్చినావయ్యా (2)</a:t>
+              </a:r>
+            </a:p>
+            <a:p>
+              <a:pPr defTabSz="439781">
+                <a:defRPr/>
+              </a:pPr>
+              <a:r>
+                <a:rPr lang="te-IN" dirty="0">
+                  <a:latin typeface="Ramabhadra" panose="02000600000000000000" pitchFamily="2" charset="0"/>
+                  <a:cs typeface="Ramabhadra" panose="02000600000000000000" pitchFamily="2" charset="0"/>
+                </a:rPr>
+                <a:t>ఏమివ్వగలను నీ కృపకు నేను</a:t>
+              </a:r>
+            </a:p>
+            <a:p>
+              <a:pPr defTabSz="439781">
+                <a:defRPr/>
+              </a:pPr>
+              <a:r>
+                <a:rPr lang="te-IN" dirty="0">
+                  <a:latin typeface="Ramabhadra" panose="02000600000000000000" pitchFamily="2" charset="0"/>
+                  <a:cs typeface="Ramabhadra" panose="02000600000000000000" pitchFamily="2" charset="0"/>
+                </a:rPr>
+                <a:t>వెలకట్టలేను నీ ప్రేమను (2)</a:t>
+              </a:r>
+            </a:p>
+            <a:p>
+              <a:pPr defTabSz="439781">
+                <a:defRPr/>
+              </a:pPr>
+              <a:endParaRPr lang="te-IN" dirty="0">
                 <a:latin typeface="Ramabhadra" panose="02000600000000000000" pitchFamily="2" charset="0"/>
                 <a:cs typeface="Ramabhadra" panose="02000600000000000000" pitchFamily="2" charset="0"/>
               </a:endParaRPr>
@@ -3632,50 +3629,71 @@
                 <a:defRPr/>
               </a:pPr>
               <a:r>
-                <a:rPr lang="te-IN" sz="2200" dirty="0">
-                  <a:latin typeface="Ramabhadra" panose="02000600000000000000" pitchFamily="2" charset="0"/>
-                  <a:cs typeface="Ramabhadra" panose="02000600000000000000" pitchFamily="2" charset="0"/>
-                </a:rPr>
-                <a:t>వ్యాధులను తొలగించినావు</a:t>
-              </a:r>
-              <a:br>
-                <a:rPr lang="te-IN" sz="2200" dirty="0">
-                  <a:latin typeface="Ramabhadra" panose="02000600000000000000" pitchFamily="2" charset="0"/>
-                  <a:cs typeface="Ramabhadra" panose="02000600000000000000" pitchFamily="2" charset="0"/>
-                </a:rPr>
-              </a:br>
-              <a:r>
-                <a:rPr lang="te-IN" sz="2200" dirty="0">
-                  <a:latin typeface="Ramabhadra" panose="02000600000000000000" pitchFamily="2" charset="0"/>
-                  <a:cs typeface="Ramabhadra" panose="02000600000000000000" pitchFamily="2" charset="0"/>
-                </a:rPr>
-                <a:t>మృతులను మరి లేపినావు (2)</a:t>
-              </a:r>
-              <a:br>
-                <a:rPr lang="te-IN" sz="2200" dirty="0">
-                  <a:latin typeface="Ramabhadra" panose="02000600000000000000" pitchFamily="2" charset="0"/>
-                  <a:cs typeface="Ramabhadra" panose="02000600000000000000" pitchFamily="2" charset="0"/>
-                </a:rPr>
-              </a:br>
-              <a:r>
-                <a:rPr lang="te-IN" sz="2200" dirty="0">
-                  <a:latin typeface="Ramabhadra" panose="02000600000000000000" pitchFamily="2" charset="0"/>
-                  <a:cs typeface="Ramabhadra" panose="02000600000000000000" pitchFamily="2" charset="0"/>
-                </a:rPr>
-                <a:t>యెహోవా రాఫా స్వస్థపరచును</a:t>
-              </a:r>
-              <a:br>
-                <a:rPr lang="te-IN" sz="2200" dirty="0">
-                  <a:latin typeface="Ramabhadra" panose="02000600000000000000" pitchFamily="2" charset="0"/>
-                  <a:cs typeface="Ramabhadra" panose="02000600000000000000" pitchFamily="2" charset="0"/>
-                </a:rPr>
-              </a:br>
-              <a:r>
-                <a:rPr lang="te-IN" sz="2200" dirty="0">
-                  <a:latin typeface="Ramabhadra" panose="02000600000000000000" pitchFamily="2" charset="0"/>
-                  <a:cs typeface="Ramabhadra" panose="02000600000000000000" pitchFamily="2" charset="0"/>
-                </a:rPr>
-                <a:t>నను స్వస్థపరచును                 </a:t>
+                <a:rPr lang="te-IN" dirty="0">
+                  <a:latin typeface="Ramabhadra" panose="02000600000000000000" pitchFamily="2" charset="0"/>
+                  <a:cs typeface="Ramabhadra" panose="02000600000000000000" pitchFamily="2" charset="0"/>
+                </a:rPr>
+                <a:t>జలములు నన్ను చుట్టిననూ –</a:t>
+              </a:r>
+            </a:p>
+            <a:p>
+              <a:pPr defTabSz="439781">
+                <a:defRPr/>
+              </a:pPr>
+              <a:r>
+                <a:rPr lang="te-IN" dirty="0">
+                  <a:latin typeface="Ramabhadra" panose="02000600000000000000" pitchFamily="2" charset="0"/>
+                  <a:cs typeface="Ramabhadra" panose="02000600000000000000" pitchFamily="2" charset="0"/>
+                </a:rPr>
+                <a:t>నీ చేతిలో నను దాచినావయ్యా</a:t>
+              </a:r>
+            </a:p>
+            <a:p>
+              <a:pPr defTabSz="439781">
+                <a:defRPr/>
+              </a:pPr>
+              <a:r>
+                <a:rPr lang="te-IN" dirty="0">
+                  <a:latin typeface="Ramabhadra" panose="02000600000000000000" pitchFamily="2" charset="0"/>
+                  <a:cs typeface="Ramabhadra" panose="02000600000000000000" pitchFamily="2" charset="0"/>
+                </a:rPr>
+                <a:t>జ్వాలలు నాపై లేచిననూ –</a:t>
+              </a:r>
+            </a:p>
+            <a:p>
+              <a:pPr defTabSz="439781">
+                <a:defRPr/>
+              </a:pPr>
+              <a:r>
+                <a:rPr lang="te-IN" dirty="0">
+                  <a:latin typeface="Ramabhadra" panose="02000600000000000000" pitchFamily="2" charset="0"/>
+                  <a:cs typeface="Ramabhadra" panose="02000600000000000000" pitchFamily="2" charset="0"/>
+                </a:rPr>
+                <a:t>నీ ఆత్మతో నను కప్పినావయ్యా (2)</a:t>
+              </a:r>
+            </a:p>
+            <a:p>
+              <a:pPr defTabSz="439781">
+                <a:defRPr/>
+              </a:pPr>
+              <a:r>
+                <a:rPr lang="te-IN" dirty="0">
+                  <a:latin typeface="Ramabhadra" panose="02000600000000000000" pitchFamily="2" charset="0"/>
+                  <a:cs typeface="Ramabhadra" panose="02000600000000000000" pitchFamily="2" charset="0"/>
+                </a:rPr>
+                <a:t>ఏమివ్వగలను నీ కృపకు నేను</a:t>
+              </a:r>
+            </a:p>
+            <a:p>
+              <a:pPr defTabSz="439781">
+                <a:defRPr/>
+              </a:pPr>
+              <a:r>
+                <a:rPr lang="te-IN" dirty="0">
+                  <a:latin typeface="Ramabhadra" panose="02000600000000000000" pitchFamily="2" charset="0"/>
+                  <a:cs typeface="Ramabhadra" panose="02000600000000000000" pitchFamily="2" charset="0"/>
+                </a:rPr>
+                <a:t>వెలకట్టలేను నీ ఆత్మను (2)</a:t>
               </a:r>
             </a:p>
           </p:txBody>
@@ -3862,8 +3880,8 @@
           </p:nvSpPr>
           <p:spPr>
             <a:xfrm>
-              <a:off x="280461" y="835357"/>
-              <a:ext cx="4648200" cy="4154984"/>
+              <a:off x="280461" y="749632"/>
+              <a:ext cx="4648200" cy="5509200"/>
             </a:xfrm>
             <a:prstGeom prst="rect">
               <a:avLst/>
@@ -3880,30 +3898,54 @@
                 <a:defRPr/>
               </a:pPr>
               <a:r>
-                <a:rPr lang="te-IN" sz="2400" dirty="0">
-                  <a:latin typeface="Ramabhadra" panose="02000600000000000000" pitchFamily="2" charset="0"/>
-                  <a:cs typeface="Ramabhadra" panose="02000600000000000000" pitchFamily="2" charset="0"/>
-                </a:rPr>
-                <a:t>మాధుర్యమే నా ప్రభుతో జీవితం</a:t>
-              </a:r>
-            </a:p>
-            <a:p>
-              <a:pPr defTabSz="439781">
-                <a:defRPr/>
-              </a:pPr>
-              <a:r>
-                <a:rPr lang="te-IN" sz="2400" dirty="0">
-                  <a:latin typeface="Ramabhadra" panose="02000600000000000000" pitchFamily="2" charset="0"/>
-                  <a:cs typeface="Ramabhadra" panose="02000600000000000000" pitchFamily="2" charset="0"/>
-                </a:rPr>
-                <a:t>మహిమానందమే – మహా ఆశ్చర్యమే</a:t>
-              </a:r>
-            </a:p>
-            <a:p>
-              <a:pPr defTabSz="439781">
-                <a:defRPr/>
-              </a:pPr>
-              <a:endParaRPr lang="te-IN" sz="2400" dirty="0">
+                <a:rPr lang="te-IN" sz="2200" dirty="0">
+                  <a:latin typeface="Ramabhadra" panose="02000600000000000000" pitchFamily="2" charset="0"/>
+                  <a:cs typeface="Ramabhadra" panose="02000600000000000000" pitchFamily="2" charset="0"/>
+                </a:rPr>
+                <a:t>నా స్తుతుల పైన నివసించువాడా</a:t>
+              </a:r>
+            </a:p>
+            <a:p>
+              <a:pPr defTabSz="439781">
+                <a:defRPr/>
+              </a:pPr>
+              <a:r>
+                <a:rPr lang="te-IN" sz="2200" dirty="0">
+                  <a:latin typeface="Ramabhadra" panose="02000600000000000000" pitchFamily="2" charset="0"/>
+                  <a:cs typeface="Ramabhadra" panose="02000600000000000000" pitchFamily="2" charset="0"/>
+                </a:rPr>
+                <a:t>నా అంతరంగికుడా యేసయ్యా (2)</a:t>
+              </a:r>
+            </a:p>
+            <a:p>
+              <a:pPr defTabSz="439781">
+                <a:defRPr/>
+              </a:pPr>
+              <a:r>
+                <a:rPr lang="te-IN" sz="2200" dirty="0">
+                  <a:latin typeface="Ramabhadra" panose="02000600000000000000" pitchFamily="2" charset="0"/>
+                  <a:cs typeface="Ramabhadra" panose="02000600000000000000" pitchFamily="2" charset="0"/>
+                </a:rPr>
+                <a:t>నీవు నా పక్షమై యున్నావు గనుకే</a:t>
+              </a:r>
+            </a:p>
+            <a:p>
+              <a:pPr defTabSz="439781">
+                <a:defRPr/>
+              </a:pPr>
+              <a:r>
+                <a:rPr lang="te-IN" sz="2200" dirty="0">
+                  <a:latin typeface="Ramabhadra" panose="02000600000000000000" pitchFamily="2" charset="0"/>
+                  <a:cs typeface="Ramabhadra" panose="02000600000000000000" pitchFamily="2" charset="0"/>
+                </a:rPr>
+                <a:t>జయమే జయమే ఎల్లవేళలా జయమే (2)</a:t>
+              </a:r>
+            </a:p>
+            <a:p>
+              <a:pPr defTabSz="439781">
+                <a:defRPr/>
+              </a:pPr>
+              <a:endParaRPr lang="te-IN" sz="2200" dirty="0">
                 <a:latin typeface="Ramabhadra" panose="02000600000000000000" pitchFamily="2" charset="0"/>
                 <a:cs typeface="Ramabhadra" panose="02000600000000000000" pitchFamily="2" charset="0"/>
               </a:endParaRPr>
@@ -3913,42 +3955,13 @@
                 <a:defRPr/>
               </a:pPr>
               <a:r>
-                <a:rPr lang="te-IN" sz="2400" dirty="0">
-                  <a:latin typeface="Ramabhadra" panose="02000600000000000000" pitchFamily="2" charset="0"/>
-                  <a:cs typeface="Ramabhadra" panose="02000600000000000000" pitchFamily="2" charset="0"/>
-                </a:rPr>
-                <a:t>సర్వ శరీరులు గడ్డిని పోలిన వారైయున్నారు</a:t>
-              </a:r>
-            </a:p>
-            <a:p>
-              <a:pPr defTabSz="439781">
-                <a:defRPr/>
-              </a:pPr>
-              <a:r>
-                <a:rPr lang="te-IN" sz="2400" dirty="0">
-                  <a:latin typeface="Ramabhadra" panose="02000600000000000000" pitchFamily="2" charset="0"/>
-                  <a:cs typeface="Ramabhadra" panose="02000600000000000000" pitchFamily="2" charset="0"/>
-                </a:rPr>
-                <a:t>వారి అందమంతయు పువ్వు వలె</a:t>
-              </a:r>
-            </a:p>
-            <a:p>
-              <a:pPr defTabSz="439781">
-                <a:defRPr/>
-              </a:pPr>
-              <a:r>
-                <a:rPr lang="te-IN" sz="2400" dirty="0">
-                  <a:latin typeface="Ramabhadra" panose="02000600000000000000" pitchFamily="2" charset="0"/>
-                  <a:cs typeface="Ramabhadra" panose="02000600000000000000" pitchFamily="2" charset="0"/>
-                </a:rPr>
-                <a:t>వాడిపోవును – వాడిపోవును</a:t>
-              </a:r>
-            </a:p>
-            <a:p>
-              <a:pPr defTabSz="439781">
-                <a:defRPr/>
-              </a:pPr>
-              <a:endParaRPr lang="te-IN" sz="2400" dirty="0">
+                <a:rPr lang="te-IN" sz="2200" dirty="0">
+                  <a:latin typeface="Ramabhadra" panose="02000600000000000000" pitchFamily="2" charset="0"/>
+                  <a:cs typeface="Ramabhadra" panose="02000600000000000000" pitchFamily="2" charset="0"/>
+                </a:rPr>
+                <a:t>నన్ను నిర్మించిన రీతి తలచగా –</a:t>
+              </a:r>
+              <a:endParaRPr lang="en-IN" sz="2200" dirty="0">
                 <a:latin typeface="Ramabhadra" panose="02000600000000000000" pitchFamily="2" charset="0"/>
                 <a:cs typeface="Ramabhadra" panose="02000600000000000000" pitchFamily="2" charset="0"/>
               </a:endParaRPr>
@@ -3958,47 +3971,120 @@
                 <a:defRPr/>
               </a:pPr>
               <a:r>
-                <a:rPr lang="te-IN" sz="2400" dirty="0">
-                  <a:latin typeface="Ramabhadra" panose="02000600000000000000" pitchFamily="2" charset="0"/>
-                  <a:cs typeface="Ramabhadra" panose="02000600000000000000" pitchFamily="2" charset="0"/>
-                </a:rPr>
-                <a:t>నెమ్మది లేకుండా విస్తారమైన</a:t>
-              </a:r>
-            </a:p>
-            <a:p>
-              <a:pPr defTabSz="439781">
-                <a:defRPr/>
-              </a:pPr>
-              <a:r>
-                <a:rPr lang="te-IN" sz="2400" dirty="0">
-                  <a:latin typeface="Ramabhadra" panose="02000600000000000000" pitchFamily="2" charset="0"/>
-                  <a:cs typeface="Ramabhadra" panose="02000600000000000000" pitchFamily="2" charset="0"/>
-                </a:rPr>
-                <a:t>ధనముండుట కంటే</a:t>
-              </a:r>
-            </a:p>
-            <a:p>
-              <a:pPr defTabSz="439781">
-                <a:defRPr/>
-              </a:pPr>
-              <a:r>
-                <a:rPr lang="te-IN" sz="2400" dirty="0">
-                  <a:latin typeface="Ramabhadra" panose="02000600000000000000" pitchFamily="2" charset="0"/>
-                  <a:cs typeface="Ramabhadra" panose="02000600000000000000" pitchFamily="2" charset="0"/>
-                </a:rPr>
-                <a:t>దేవుని యందలి భయ భక్తులతో</a:t>
-              </a:r>
-            </a:p>
-            <a:p>
-              <a:pPr defTabSz="439781">
-                <a:defRPr/>
-              </a:pPr>
-              <a:r>
-                <a:rPr lang="te-IN" sz="2400" dirty="0">
-                  <a:latin typeface="Ramabhadra" panose="02000600000000000000" pitchFamily="2" charset="0"/>
-                  <a:cs typeface="Ramabhadra" panose="02000600000000000000" pitchFamily="2" charset="0"/>
-                </a:rPr>
-                <a:t>ఉండుటే మేలు – ఉండుటే మేలు</a:t>
+                <a:rPr lang="te-IN" sz="2200" dirty="0">
+                  <a:latin typeface="Ramabhadra" panose="02000600000000000000" pitchFamily="2" charset="0"/>
+                  <a:cs typeface="Ramabhadra" panose="02000600000000000000" pitchFamily="2" charset="0"/>
+                </a:rPr>
+                <a:t>ఎంతో ఆశ్చర్యమే</a:t>
+              </a:r>
+            </a:p>
+            <a:p>
+              <a:pPr defTabSz="439781">
+                <a:defRPr/>
+              </a:pPr>
+              <a:r>
+                <a:rPr lang="te-IN" sz="2200" dirty="0">
+                  <a:latin typeface="Ramabhadra" panose="02000600000000000000" pitchFamily="2" charset="0"/>
+                  <a:cs typeface="Ramabhadra" panose="02000600000000000000" pitchFamily="2" charset="0"/>
+                </a:rPr>
+                <a:t>అది నా ఊహకే వింతైనది (2)</a:t>
+              </a:r>
+            </a:p>
+            <a:p>
+              <a:pPr defTabSz="439781">
+                <a:defRPr/>
+              </a:pPr>
+              <a:r>
+                <a:rPr lang="te-IN" sz="2200" dirty="0">
+                  <a:latin typeface="Ramabhadra" panose="02000600000000000000" pitchFamily="2" charset="0"/>
+                  <a:cs typeface="Ramabhadra" panose="02000600000000000000" pitchFamily="2" charset="0"/>
+                </a:rPr>
+                <a:t>ఎరుపెక్కిన శత్రువుల చూపు నుండి తప్పించి</a:t>
+              </a:r>
+            </a:p>
+            <a:p>
+              <a:pPr defTabSz="439781">
+                <a:defRPr/>
+              </a:pPr>
+              <a:r>
+                <a:rPr lang="te-IN" sz="2200" dirty="0">
+                  <a:latin typeface="Ramabhadra" panose="02000600000000000000" pitchFamily="2" charset="0"/>
+                  <a:cs typeface="Ramabhadra" panose="02000600000000000000" pitchFamily="2" charset="0"/>
+                </a:rPr>
+                <a:t>ఎనలేని ప్రేమను నాపై కురిపించావు (2)</a:t>
+              </a:r>
+            </a:p>
+            <a:p>
+              <a:pPr defTabSz="439781">
+                <a:defRPr/>
+              </a:pPr>
+              <a:endParaRPr lang="te-IN" sz="2200" dirty="0">
+                <a:latin typeface="Ramabhadra" panose="02000600000000000000" pitchFamily="2" charset="0"/>
+                <a:cs typeface="Ramabhadra" panose="02000600000000000000" pitchFamily="2" charset="0"/>
+              </a:endParaRPr>
+            </a:p>
+            <a:p>
+              <a:pPr defTabSz="439781">
+                <a:defRPr/>
+              </a:pPr>
+              <a:r>
+                <a:rPr lang="te-IN" sz="2200" dirty="0">
+                  <a:latin typeface="Ramabhadra" panose="02000600000000000000" pitchFamily="2" charset="0"/>
+                  <a:cs typeface="Ramabhadra" panose="02000600000000000000" pitchFamily="2" charset="0"/>
+                </a:rPr>
+                <a:t>ద్రాక్షావల్లి అయిన నీలోనే –</a:t>
+              </a:r>
+              <a:endParaRPr lang="en-IN" sz="2200" dirty="0">
+                <a:latin typeface="Ramabhadra" panose="02000600000000000000" pitchFamily="2" charset="0"/>
+                <a:cs typeface="Ramabhadra" panose="02000600000000000000" pitchFamily="2" charset="0"/>
+              </a:endParaRPr>
+            </a:p>
+            <a:p>
+              <a:pPr defTabSz="439781">
+                <a:defRPr/>
+              </a:pPr>
+              <a:r>
+                <a:rPr lang="te-IN" sz="2200" dirty="0">
+                  <a:latin typeface="Ramabhadra" panose="02000600000000000000" pitchFamily="2" charset="0"/>
+                  <a:cs typeface="Ramabhadra" panose="02000600000000000000" pitchFamily="2" charset="0"/>
+                </a:rPr>
+                <a:t>బహుగా వేరు పారగా</a:t>
+              </a:r>
+            </a:p>
+            <a:p>
+              <a:pPr defTabSz="439781">
+                <a:defRPr/>
+              </a:pPr>
+              <a:r>
+                <a:rPr lang="te-IN" sz="2200" dirty="0">
+                  <a:latin typeface="Ramabhadra" panose="02000600000000000000" pitchFamily="2" charset="0"/>
+                  <a:cs typeface="Ramabhadra" panose="02000600000000000000" pitchFamily="2" charset="0"/>
+                </a:rPr>
+                <a:t>నీతో మధురమైన ఫలములీయనా (2)</a:t>
+              </a:r>
+            </a:p>
+            <a:p>
+              <a:pPr defTabSz="439781">
+                <a:defRPr/>
+              </a:pPr>
+              <a:r>
+                <a:rPr lang="te-IN" sz="2200" dirty="0">
+                  <a:latin typeface="Ramabhadra" panose="02000600000000000000" pitchFamily="2" charset="0"/>
+                  <a:cs typeface="Ramabhadra" panose="02000600000000000000" pitchFamily="2" charset="0"/>
+                </a:rPr>
+                <a:t>ఉన్నత స్థలములపై నాకు స్థానమిచ్చితివే</a:t>
+              </a:r>
+            </a:p>
+            <a:p>
+              <a:pPr defTabSz="439781">
+                <a:defRPr/>
+              </a:pPr>
+              <a:r>
+                <a:rPr lang="te-IN" sz="2200" dirty="0">
+                  <a:latin typeface="Ramabhadra" panose="02000600000000000000" pitchFamily="2" charset="0"/>
+                  <a:cs typeface="Ramabhadra" panose="02000600000000000000" pitchFamily="2" charset="0"/>
+                </a:rPr>
+                <a:t>విజయుడా నీ కృప చాలును నా జీవితాన (2)</a:t>
               </a:r>
             </a:p>
           </p:txBody>
@@ -4156,7 +4242,7 @@
           <p:spPr>
             <a:xfrm>
               <a:off x="343961" y="740943"/>
-              <a:ext cx="4541306" cy="5632311"/>
+              <a:ext cx="4541306" cy="5170646"/>
             </a:xfrm>
             <a:prstGeom prst="rect">
               <a:avLst/>
@@ -4173,13 +4259,66 @@
                 <a:defRPr/>
               </a:pPr>
               <a:r>
-                <a:rPr lang="te-IN" sz="2400" dirty="0">
-                  <a:latin typeface="Ramabhadra" panose="02000600000000000000" pitchFamily="2" charset="0"/>
-                  <a:cs typeface="Ramabhadra" panose="02000600000000000000" pitchFamily="2" charset="0"/>
-                </a:rPr>
-                <a:t>నాదు రక్షక నీ మనసే ఉత్తమం</a:t>
-              </a:r>
-              <a:endParaRPr lang="en-IN" sz="2400" dirty="0">
+                <a:rPr lang="te-IN" sz="2200" dirty="0">
+                  <a:latin typeface="Ramabhadra" panose="02000600000000000000" pitchFamily="2" charset="0"/>
+                  <a:cs typeface="Ramabhadra" panose="02000600000000000000" pitchFamily="2" charset="0"/>
+                </a:rPr>
+                <a:t>ఎవరూ సమీపించలేని</a:t>
+              </a:r>
+            </a:p>
+            <a:p>
+              <a:pPr defTabSz="439781">
+                <a:defRPr/>
+              </a:pPr>
+              <a:r>
+                <a:rPr lang="te-IN" sz="2200" dirty="0">
+                  <a:latin typeface="Ramabhadra" panose="02000600000000000000" pitchFamily="2" charset="0"/>
+                  <a:cs typeface="Ramabhadra" panose="02000600000000000000" pitchFamily="2" charset="0"/>
+                </a:rPr>
+                <a:t>తేజస్సుతో నివసించు నా యేసయ్యా (2)</a:t>
+              </a:r>
+            </a:p>
+            <a:p>
+              <a:pPr defTabSz="439781">
+                <a:defRPr/>
+              </a:pPr>
+              <a:r>
+                <a:rPr lang="te-IN" sz="2200" dirty="0">
+                  <a:latin typeface="Ramabhadra" panose="02000600000000000000" pitchFamily="2" charset="0"/>
+                  <a:cs typeface="Ramabhadra" panose="02000600000000000000" pitchFamily="2" charset="0"/>
+                </a:rPr>
+                <a:t>నీ మహిమను ధరించిన పరిశుద్ధులు</a:t>
+              </a:r>
+            </a:p>
+            <a:p>
+              <a:pPr defTabSz="439781">
+                <a:defRPr/>
+              </a:pPr>
+              <a:r>
+                <a:rPr lang="te-IN" sz="2200" dirty="0">
+                  <a:latin typeface="Ramabhadra" panose="02000600000000000000" pitchFamily="2" charset="0"/>
+                  <a:cs typeface="Ramabhadra" panose="02000600000000000000" pitchFamily="2" charset="0"/>
+                </a:rPr>
+                <a:t>నా కంటబడగానే (2)</a:t>
+              </a:r>
+            </a:p>
+            <a:p>
+              <a:pPr defTabSz="439781">
+                <a:defRPr/>
+              </a:pPr>
+              <a:r>
+                <a:rPr lang="te-IN" sz="2200" dirty="0">
+                  <a:latin typeface="Ramabhadra" panose="02000600000000000000" pitchFamily="2" charset="0"/>
+                  <a:cs typeface="Ramabhadra" panose="02000600000000000000" pitchFamily="2" charset="0"/>
+                </a:rPr>
+                <a:t>ఏమౌదునో నేనేమౌదునో (2)</a:t>
+              </a:r>
+            </a:p>
+            <a:p>
+              <a:pPr defTabSz="439781">
+                <a:defRPr/>
+              </a:pPr>
+              <a:endParaRPr lang="te-IN" sz="2200" dirty="0">
                 <a:latin typeface="Ramabhadra" panose="02000600000000000000" pitchFamily="2" charset="0"/>
                 <a:cs typeface="Ramabhadra" panose="02000600000000000000" pitchFamily="2" charset="0"/>
               </a:endParaRPr>
@@ -4189,54 +4328,54 @@
                 <a:defRPr/>
               </a:pPr>
               <a:r>
-                <a:rPr lang="te-IN" sz="2400" dirty="0">
-                  <a:latin typeface="Ramabhadra" panose="02000600000000000000" pitchFamily="2" charset="0"/>
-                  <a:cs typeface="Ramabhadra" panose="02000600000000000000" pitchFamily="2" charset="0"/>
-                </a:rPr>
-                <a:t>దినదినము నీతోనే వసియింతును</a:t>
-              </a:r>
-            </a:p>
-            <a:p>
-              <a:pPr defTabSz="439781">
-                <a:defRPr/>
-              </a:pPr>
-              <a:r>
-                <a:rPr lang="te-IN" sz="2400" dirty="0">
-                  <a:latin typeface="Ramabhadra" panose="02000600000000000000" pitchFamily="2" charset="0"/>
-                  <a:cs typeface="Ramabhadra" panose="02000600000000000000" pitchFamily="2" charset="0"/>
-                </a:rPr>
-                <a:t>నేనేది పలికినను ఏమి చేసినను</a:t>
-              </a:r>
-            </a:p>
-            <a:p>
-              <a:pPr defTabSz="439781">
-                <a:defRPr/>
-              </a:pPr>
-              <a:r>
-                <a:rPr lang="te-IN" sz="2400" dirty="0">
-                  <a:latin typeface="Ramabhadra" panose="02000600000000000000" pitchFamily="2" charset="0"/>
-                  <a:cs typeface="Ramabhadra" panose="02000600000000000000" pitchFamily="2" charset="0"/>
-                </a:rPr>
-                <a:t>నీ ప్రేమనే కనుపరుతును</a:t>
-              </a:r>
-            </a:p>
-            <a:p>
-              <a:pPr defTabSz="439781">
-                <a:defRPr/>
-              </a:pPr>
-              <a:r>
-                <a:rPr lang="te-IN" sz="2400" dirty="0">
-                  <a:latin typeface="Ramabhadra" panose="02000600000000000000" pitchFamily="2" charset="0"/>
-                  <a:cs typeface="Ramabhadra" panose="02000600000000000000" pitchFamily="2" charset="0"/>
-                </a:rPr>
-                <a:t>నీ శక్తినే కొనియాడేదను</a:t>
-              </a:r>
-            </a:p>
-            <a:p>
-              <a:pPr defTabSz="439781">
-                <a:defRPr/>
-              </a:pPr>
-              <a:endParaRPr lang="te-IN" sz="2400" dirty="0">
+                <a:rPr lang="te-IN" sz="2200" dirty="0">
+                  <a:latin typeface="Ramabhadra" panose="02000600000000000000" pitchFamily="2" charset="0"/>
+                  <a:cs typeface="Ramabhadra" panose="02000600000000000000" pitchFamily="2" charset="0"/>
+                </a:rPr>
+                <a:t>ఇహలోక బంధాలు మరచి</a:t>
+              </a:r>
+            </a:p>
+            <a:p>
+              <a:pPr defTabSz="439781">
+                <a:defRPr/>
+              </a:pPr>
+              <a:r>
+                <a:rPr lang="te-IN" sz="2200" dirty="0">
+                  <a:latin typeface="Ramabhadra" panose="02000600000000000000" pitchFamily="2" charset="0"/>
+                  <a:cs typeface="Ramabhadra" panose="02000600000000000000" pitchFamily="2" charset="0"/>
+                </a:rPr>
+                <a:t>నీ యెదుటే నేను నిలిచి (2)</a:t>
+              </a:r>
+            </a:p>
+            <a:p>
+              <a:pPr defTabSz="439781">
+                <a:defRPr/>
+              </a:pPr>
+              <a:r>
+                <a:rPr lang="te-IN" sz="2200" dirty="0">
+                  <a:latin typeface="Ramabhadra" panose="02000600000000000000" pitchFamily="2" charset="0"/>
+                  <a:cs typeface="Ramabhadra" panose="02000600000000000000" pitchFamily="2" charset="0"/>
+                </a:rPr>
+                <a:t>నీవిచ్చు బహుమతులు నే స్వీకరించి</a:t>
+              </a:r>
+            </a:p>
+            <a:p>
+              <a:pPr defTabSz="439781">
+                <a:defRPr/>
+              </a:pPr>
+              <a:r>
+                <a:rPr lang="te-IN" sz="2200" dirty="0">
+                  <a:latin typeface="Ramabhadra" panose="02000600000000000000" pitchFamily="2" charset="0"/>
+                  <a:cs typeface="Ramabhadra" panose="02000600000000000000" pitchFamily="2" charset="0"/>
+                </a:rPr>
+                <a:t>నిత్యానందముతో పరవశించు వేళ (2)</a:t>
+              </a:r>
+            </a:p>
+            <a:p>
+              <a:pPr defTabSz="439781">
+                <a:defRPr/>
+              </a:pPr>
+              <a:endParaRPr lang="te-IN" sz="2200" dirty="0">
                 <a:latin typeface="Ramabhadra" panose="02000600000000000000" pitchFamily="2" charset="0"/>
                 <a:cs typeface="Ramabhadra" panose="02000600000000000000" pitchFamily="2" charset="0"/>
               </a:endParaRPr>
@@ -4246,104 +4385,47 @@
                 <a:defRPr/>
               </a:pPr>
               <a:r>
-                <a:rPr lang="te-IN" sz="2400" dirty="0">
-                  <a:latin typeface="Ramabhadra" panose="02000600000000000000" pitchFamily="2" charset="0"/>
-                  <a:cs typeface="Ramabhadra" panose="02000600000000000000" pitchFamily="2" charset="0"/>
-                </a:rPr>
-                <a:t>నా హృదిలో నీ వాక్యము నివసింపని </a:t>
-              </a:r>
-            </a:p>
-            <a:p>
-              <a:pPr defTabSz="439781">
-                <a:defRPr/>
-              </a:pPr>
-              <a:r>
-                <a:rPr lang="te-IN" sz="2400" dirty="0">
-                  <a:latin typeface="Ramabhadra" panose="02000600000000000000" pitchFamily="2" charset="0"/>
-                  <a:cs typeface="Ramabhadra" panose="02000600000000000000" pitchFamily="2" charset="0"/>
-                </a:rPr>
-                <a:t>ప్రతిక్షణము ప్రతిదినము ధ్యానింతును </a:t>
-              </a:r>
-            </a:p>
-            <a:p>
-              <a:pPr defTabSz="439781">
-                <a:defRPr/>
-              </a:pPr>
-              <a:r>
-                <a:rPr lang="te-IN" sz="2400" dirty="0">
-                  <a:latin typeface="Ramabhadra" panose="02000600000000000000" pitchFamily="2" charset="0"/>
-                  <a:cs typeface="Ramabhadra" panose="02000600000000000000" pitchFamily="2" charset="0"/>
-                </a:rPr>
-                <a:t>లోకము నను విడచిన నీవు విడువలేదు    </a:t>
-              </a:r>
-            </a:p>
-            <a:p>
-              <a:pPr defTabSz="439781">
-                <a:defRPr/>
-              </a:pPr>
-              <a:r>
-                <a:rPr lang="te-IN" sz="2400" dirty="0">
-                  <a:latin typeface="Ramabhadra" panose="02000600000000000000" pitchFamily="2" charset="0"/>
-                  <a:cs typeface="Ramabhadra" panose="02000600000000000000" pitchFamily="2" charset="0"/>
-                </a:rPr>
-                <a:t>నాకు జయము జయము నీ శక్తితోనే</a:t>
-              </a:r>
-            </a:p>
-            <a:p>
-              <a:pPr defTabSz="439781">
-                <a:defRPr/>
-              </a:pPr>
-              <a:endParaRPr lang="te-IN" sz="2400" dirty="0">
-                <a:latin typeface="Ramabhadra" panose="02000600000000000000" pitchFamily="2" charset="0"/>
-                <a:cs typeface="Ramabhadra" panose="02000600000000000000" pitchFamily="2" charset="0"/>
-              </a:endParaRPr>
-            </a:p>
-            <a:p>
-              <a:pPr defTabSz="439781">
-                <a:defRPr/>
-              </a:pPr>
-              <a:r>
-                <a:rPr lang="te-IN" sz="2400" dirty="0">
-                  <a:latin typeface="Ramabhadra" panose="02000600000000000000" pitchFamily="2" charset="0"/>
-                  <a:cs typeface="Ramabhadra" panose="02000600000000000000" pitchFamily="2" charset="0"/>
-                </a:rPr>
-                <a:t>నా తండ్రి నా విభుడా పాలించుమా</a:t>
-              </a:r>
-            </a:p>
-            <a:p>
-              <a:pPr defTabSz="439781">
-                <a:defRPr/>
-              </a:pPr>
-              <a:r>
-                <a:rPr lang="te-IN" sz="2400" dirty="0">
-                  <a:latin typeface="Ramabhadra" panose="02000600000000000000" pitchFamily="2" charset="0"/>
-                  <a:cs typeface="Ramabhadra" panose="02000600000000000000" pitchFamily="2" charset="0"/>
-                </a:rPr>
-                <a:t>ఆదరణ నా హృదిలోనా నింపుమయా </a:t>
-              </a:r>
-            </a:p>
-            <a:p>
-              <a:pPr defTabSz="439781">
-                <a:defRPr/>
-              </a:pPr>
-              <a:r>
-                <a:rPr lang="te-IN" sz="2400" dirty="0">
-                  <a:latin typeface="Ramabhadra" panose="02000600000000000000" pitchFamily="2" charset="0"/>
-                  <a:cs typeface="Ramabhadra" panose="02000600000000000000" pitchFamily="2" charset="0"/>
-                </a:rPr>
-                <a:t>మనుజులు నను మరిచిన నీవు మరువలేదు </a:t>
-              </a:r>
-            </a:p>
-            <a:p>
-              <a:pPr defTabSz="439781">
-                <a:defRPr/>
-              </a:pPr>
-              <a:r>
-                <a:rPr lang="te-IN" sz="2400" dirty="0">
-                  <a:latin typeface="Ramabhadra" panose="02000600000000000000" pitchFamily="2" charset="0"/>
-                  <a:cs typeface="Ramabhadra" panose="02000600000000000000" pitchFamily="2" charset="0"/>
-                </a:rPr>
-                <a:t>నాకు జయము జయము నీ ప్రేమతోనే</a:t>
+                <a:rPr lang="te-IN" sz="2200" dirty="0">
+                  <a:latin typeface="Ramabhadra" panose="02000600000000000000" pitchFamily="2" charset="0"/>
+                  <a:cs typeface="Ramabhadra" panose="02000600000000000000" pitchFamily="2" charset="0"/>
+                </a:rPr>
+                <a:t>పరలోక మహిమను తలచి</a:t>
+              </a:r>
+            </a:p>
+            <a:p>
+              <a:pPr defTabSz="439781">
+                <a:defRPr/>
+              </a:pPr>
+              <a:r>
+                <a:rPr lang="te-IN" sz="2200" dirty="0">
+                  <a:latin typeface="Ramabhadra" panose="02000600000000000000" pitchFamily="2" charset="0"/>
+                  <a:cs typeface="Ramabhadra" panose="02000600000000000000" pitchFamily="2" charset="0"/>
+                </a:rPr>
+                <a:t>నీ పాద పద్మములపై ఒరిగి (2)</a:t>
+              </a:r>
+            </a:p>
+            <a:p>
+              <a:pPr defTabSz="439781">
+                <a:defRPr/>
+              </a:pPr>
+              <a:r>
+                <a:rPr lang="te-IN" sz="2200" dirty="0">
+                  <a:latin typeface="Ramabhadra" panose="02000600000000000000" pitchFamily="2" charset="0"/>
+                  <a:cs typeface="Ramabhadra" panose="02000600000000000000" pitchFamily="2" charset="0"/>
+                </a:rPr>
+                <a:t>పరలోక సైన్య సమూహాలతో కలసి</a:t>
+              </a:r>
+            </a:p>
+            <a:p>
+              <a:pPr defTabSz="439781">
+                <a:defRPr/>
+              </a:pPr>
+              <a:r>
+                <a:rPr lang="te-IN" sz="2200" dirty="0">
+                  <a:latin typeface="Ramabhadra" panose="02000600000000000000" pitchFamily="2" charset="0"/>
+                  <a:cs typeface="Ramabhadra" panose="02000600000000000000" pitchFamily="2" charset="0"/>
+                </a:rPr>
+                <a:t>నిత్యారాధన నే చేయు ప్రశాంత వేళ (2)</a:t>
               </a:r>
             </a:p>
           </p:txBody>

</xml_diff>

<commit_message>
20 sun songs oct
</commit_message>
<xml_diff>
--- a/songsTemplate.pptx
+++ b/songsTemplate.pptx
@@ -255,7 +255,7 @@
           <a:p>
             <a:fld id="{F1102B08-ED9E-409F-B95F-09CAA1DAF6E0}" type="datetimeFigureOut">
               <a:rPr lang="en-IN" smtClean="0"/>
-              <a:t>12-10-2024</a:t>
+              <a:t>16-10-2024</a:t>
             </a:fld>
             <a:endParaRPr lang="en-IN"/>
           </a:p>
@@ -425,7 +425,7 @@
           <a:p>
             <a:fld id="{F1102B08-ED9E-409F-B95F-09CAA1DAF6E0}" type="datetimeFigureOut">
               <a:rPr lang="en-IN" smtClean="0"/>
-              <a:t>12-10-2024</a:t>
+              <a:t>16-10-2024</a:t>
             </a:fld>
             <a:endParaRPr lang="en-IN"/>
           </a:p>
@@ -605,7 +605,7 @@
           <a:p>
             <a:fld id="{F1102B08-ED9E-409F-B95F-09CAA1DAF6E0}" type="datetimeFigureOut">
               <a:rPr lang="en-IN" smtClean="0"/>
-              <a:t>12-10-2024</a:t>
+              <a:t>16-10-2024</a:t>
             </a:fld>
             <a:endParaRPr lang="en-IN"/>
           </a:p>
@@ -775,7 +775,7 @@
           <a:p>
             <a:fld id="{F1102B08-ED9E-409F-B95F-09CAA1DAF6E0}" type="datetimeFigureOut">
               <a:rPr lang="en-IN" smtClean="0"/>
-              <a:t>12-10-2024</a:t>
+              <a:t>16-10-2024</a:t>
             </a:fld>
             <a:endParaRPr lang="en-IN"/>
           </a:p>
@@ -1019,7 +1019,7 @@
           <a:p>
             <a:fld id="{F1102B08-ED9E-409F-B95F-09CAA1DAF6E0}" type="datetimeFigureOut">
               <a:rPr lang="en-IN" smtClean="0"/>
-              <a:t>12-10-2024</a:t>
+              <a:t>16-10-2024</a:t>
             </a:fld>
             <a:endParaRPr lang="en-IN"/>
           </a:p>
@@ -1251,7 +1251,7 @@
           <a:p>
             <a:fld id="{F1102B08-ED9E-409F-B95F-09CAA1DAF6E0}" type="datetimeFigureOut">
               <a:rPr lang="en-IN" smtClean="0"/>
-              <a:t>12-10-2024</a:t>
+              <a:t>16-10-2024</a:t>
             </a:fld>
             <a:endParaRPr lang="en-IN"/>
           </a:p>
@@ -1618,7 +1618,7 @@
           <a:p>
             <a:fld id="{F1102B08-ED9E-409F-B95F-09CAA1DAF6E0}" type="datetimeFigureOut">
               <a:rPr lang="en-IN" smtClean="0"/>
-              <a:t>12-10-2024</a:t>
+              <a:t>16-10-2024</a:t>
             </a:fld>
             <a:endParaRPr lang="en-IN"/>
           </a:p>
@@ -1736,7 +1736,7 @@
           <a:p>
             <a:fld id="{F1102B08-ED9E-409F-B95F-09CAA1DAF6E0}" type="datetimeFigureOut">
               <a:rPr lang="en-IN" smtClean="0"/>
-              <a:t>12-10-2024</a:t>
+              <a:t>16-10-2024</a:t>
             </a:fld>
             <a:endParaRPr lang="en-IN"/>
           </a:p>
@@ -1831,7 +1831,7 @@
           <a:p>
             <a:fld id="{F1102B08-ED9E-409F-B95F-09CAA1DAF6E0}" type="datetimeFigureOut">
               <a:rPr lang="en-IN" smtClean="0"/>
-              <a:t>12-10-2024</a:t>
+              <a:t>16-10-2024</a:t>
             </a:fld>
             <a:endParaRPr lang="en-IN"/>
           </a:p>
@@ -2108,7 +2108,7 @@
           <a:p>
             <a:fld id="{F1102B08-ED9E-409F-B95F-09CAA1DAF6E0}" type="datetimeFigureOut">
               <a:rPr lang="en-IN" smtClean="0"/>
-              <a:t>12-10-2024</a:t>
+              <a:t>16-10-2024</a:t>
             </a:fld>
             <a:endParaRPr lang="en-IN"/>
           </a:p>
@@ -2365,7 +2365,7 @@
           <a:p>
             <a:fld id="{F1102B08-ED9E-409F-B95F-09CAA1DAF6E0}" type="datetimeFigureOut">
               <a:rPr lang="en-IN" smtClean="0"/>
-              <a:t>12-10-2024</a:t>
+              <a:t>16-10-2024</a:t>
             </a:fld>
             <a:endParaRPr lang="en-IN"/>
           </a:p>
@@ -2578,7 +2578,7 @@
           <a:p>
             <a:fld id="{F1102B08-ED9E-409F-B95F-09CAA1DAF6E0}" type="datetimeFigureOut">
               <a:rPr lang="en-IN" smtClean="0"/>
-              <a:t>12-10-2024</a:t>
+              <a:t>16-10-2024</a:t>
             </a:fld>
             <a:endParaRPr lang="en-IN"/>
           </a:p>
@@ -2998,9 +2998,9 @@
         <p:grpSpPr>
           <a:xfrm>
             <a:off x="160868" y="182032"/>
-            <a:ext cx="5019669" cy="6493935"/>
+            <a:ext cx="5190669" cy="6630833"/>
             <a:chOff x="160868" y="182032"/>
-            <a:chExt cx="5019669" cy="6493935"/>
+            <a:chExt cx="5190669" cy="6630833"/>
           </a:xfrm>
         </p:grpSpPr>
         <p:sp>
@@ -3072,8 +3072,8 @@
           </p:nvSpPr>
           <p:spPr>
             <a:xfrm>
-              <a:off x="343961" y="748108"/>
-              <a:ext cx="4836576" cy="5170646"/>
+              <a:off x="238127" y="257224"/>
+              <a:ext cx="5113410" cy="6555641"/>
             </a:xfrm>
             <a:prstGeom prst="rect">
               <a:avLst/>
@@ -3090,39 +3090,126 @@
                 <a:defRPr/>
               </a:pPr>
               <a:r>
-                <a:rPr lang="te-IN" sz="2200" dirty="0">
-                  <a:latin typeface="Ramabhadra" panose="02000600000000000000" pitchFamily="2" charset="0"/>
-                  <a:cs typeface="Ramabhadra" panose="02000600000000000000" pitchFamily="2" charset="0"/>
-                </a:rPr>
-                <a:t>భూమ్యాకాశములు సృజించిన</a:t>
-              </a:r>
-              <a:br>
-                <a:rPr lang="te-IN" sz="2200" dirty="0">
-                  <a:latin typeface="Ramabhadra" panose="02000600000000000000" pitchFamily="2" charset="0"/>
-                  <a:cs typeface="Ramabhadra" panose="02000600000000000000" pitchFamily="2" charset="0"/>
-                </a:rPr>
-              </a:br>
-              <a:r>
-                <a:rPr lang="te-IN" sz="2200" dirty="0">
-                  <a:latin typeface="Ramabhadra" panose="02000600000000000000" pitchFamily="2" charset="0"/>
-                  <a:cs typeface="Ramabhadra" panose="02000600000000000000" pitchFamily="2" charset="0"/>
-                </a:rPr>
-                <a:t>యేసయ్యా నీకే స్తోత్రం (2)</a:t>
-              </a:r>
-              <a:br>
-                <a:rPr lang="te-IN" sz="2200" dirty="0">
-                  <a:latin typeface="Ramabhadra" panose="02000600000000000000" pitchFamily="2" charset="0"/>
-                  <a:cs typeface="Ramabhadra" panose="02000600000000000000" pitchFamily="2" charset="0"/>
-                </a:rPr>
-              </a:br>
-              <a:r>
-                <a:rPr lang="te-IN" sz="2200" dirty="0">
-                  <a:latin typeface="Ramabhadra" panose="02000600000000000000" pitchFamily="2" charset="0"/>
-                  <a:cs typeface="Ramabhadra" panose="02000600000000000000" pitchFamily="2" charset="0"/>
-                </a:rPr>
-                <a:t>నీ ఆశ్ఛర్యమైన క్రియలు</a:t>
-              </a:r>
-              <a:endParaRPr lang="en-IN" sz="2200" dirty="0">
+                <a:rPr lang="te-IN" sz="2000" dirty="0">
+                  <a:latin typeface="Ramabhadra" panose="02000600000000000000" pitchFamily="2" charset="0"/>
+                  <a:cs typeface="Ramabhadra" panose="02000600000000000000" pitchFamily="2" charset="0"/>
+                </a:rPr>
+                <a:t>ప్రేమా పూర్ణుడా స్నేహశీలుడా </a:t>
+              </a:r>
+            </a:p>
+            <a:p>
+              <a:pPr defTabSz="439781">
+                <a:defRPr/>
+              </a:pPr>
+              <a:r>
+                <a:rPr lang="te-IN" sz="2000" dirty="0">
+                  <a:latin typeface="Ramabhadra" panose="02000600000000000000" pitchFamily="2" charset="0"/>
+                  <a:cs typeface="Ramabhadra" panose="02000600000000000000" pitchFamily="2" charset="0"/>
+                </a:rPr>
+                <a:t>విశ్వనాధుడా విజయ వీరుడా </a:t>
+              </a:r>
+            </a:p>
+            <a:p>
+              <a:pPr defTabSz="439781">
+                <a:defRPr/>
+              </a:pPr>
+              <a:r>
+                <a:rPr lang="te-IN" sz="2000" dirty="0">
+                  <a:latin typeface="Ramabhadra" panose="02000600000000000000" pitchFamily="2" charset="0"/>
+                  <a:cs typeface="Ramabhadra" panose="02000600000000000000" pitchFamily="2" charset="0"/>
+                </a:rPr>
+                <a:t>ఆపత్కాల మందున సర్వ లోకమందున్న </a:t>
+              </a:r>
+            </a:p>
+            <a:p>
+              <a:pPr defTabSz="439781">
+                <a:defRPr/>
+              </a:pPr>
+              <a:r>
+                <a:rPr lang="te-IN" sz="2000" dirty="0">
+                  <a:latin typeface="Ramabhadra" panose="02000600000000000000" pitchFamily="2" charset="0"/>
+                  <a:cs typeface="Ramabhadra" panose="02000600000000000000" pitchFamily="2" charset="0"/>
+                </a:rPr>
+                <a:t>దీన జనాలి దీపముగా వెలుగుచున్నవాడా  ..</a:t>
+              </a:r>
+            </a:p>
+            <a:p>
+              <a:pPr defTabSz="439781">
+                <a:defRPr/>
+              </a:pPr>
+              <a:r>
+                <a:rPr lang="te-IN" sz="2000" dirty="0">
+                  <a:latin typeface="Ramabhadra" panose="02000600000000000000" pitchFamily="2" charset="0"/>
+                  <a:cs typeface="Ramabhadra" panose="02000600000000000000" pitchFamily="2" charset="0"/>
+                </a:rPr>
+                <a:t>ఆరాధింతు నిన్నే లోక రక్షకుడా </a:t>
+              </a:r>
+            </a:p>
+            <a:p>
+              <a:pPr defTabSz="439781">
+                <a:defRPr/>
+              </a:pPr>
+              <a:r>
+                <a:rPr lang="te-IN" sz="2000" dirty="0">
+                  <a:latin typeface="Ramabhadra" panose="02000600000000000000" pitchFamily="2" charset="0"/>
+                  <a:cs typeface="Ramabhadra" panose="02000600000000000000" pitchFamily="2" charset="0"/>
+                </a:rPr>
+                <a:t>ఆనందింతు నీలో జీవితాంతము (2)</a:t>
+              </a:r>
+            </a:p>
+            <a:p>
+              <a:pPr defTabSz="439781">
+                <a:defRPr/>
+              </a:pPr>
+              <a:r>
+                <a:rPr lang="te-IN" sz="2000" dirty="0">
+                  <a:latin typeface="Ramabhadra" panose="02000600000000000000" pitchFamily="2" charset="0"/>
+                  <a:cs typeface="Ramabhadra" panose="02000600000000000000" pitchFamily="2" charset="0"/>
+                </a:rPr>
+                <a:t>నీ కృప ఎంత ఉన్నతమో వర్ణించలేను స్వామి </a:t>
+              </a:r>
+            </a:p>
+            <a:p>
+              <a:pPr defTabSz="439781">
+                <a:defRPr/>
+              </a:pPr>
+              <a:r>
+                <a:rPr lang="te-IN" sz="2000" dirty="0">
+                  <a:latin typeface="Ramabhadra" panose="02000600000000000000" pitchFamily="2" charset="0"/>
+                  <a:cs typeface="Ramabhadra" panose="02000600000000000000" pitchFamily="2" charset="0"/>
+                </a:rPr>
+                <a:t>నీ కృప యందు తుది వరకు నడిపించు యేసయ్యా (2)</a:t>
+              </a:r>
+            </a:p>
+            <a:p>
+              <a:pPr defTabSz="439781">
+                <a:defRPr/>
+              </a:pPr>
+              <a:r>
+                <a:rPr lang="te-IN" sz="2000" dirty="0">
+                  <a:latin typeface="Ramabhadra" panose="02000600000000000000" pitchFamily="2" charset="0"/>
+                  <a:cs typeface="Ramabhadra" panose="02000600000000000000" pitchFamily="2" charset="0"/>
+                </a:rPr>
+                <a:t>నా తోడు నీవుంటే అంతే చాలయ్యా </a:t>
+              </a:r>
+            </a:p>
+            <a:p>
+              <a:pPr defTabSz="439781">
+                <a:defRPr/>
+              </a:pPr>
+              <a:r>
+                <a:rPr lang="te-IN" sz="2000" dirty="0">
+                  <a:latin typeface="Ramabhadra" panose="02000600000000000000" pitchFamily="2" charset="0"/>
+                  <a:cs typeface="Ramabhadra" panose="02000600000000000000" pitchFamily="2" charset="0"/>
+                </a:rPr>
+                <a:t>నా ముందు నీవుంటే భయమే లేదయ్యా (2) </a:t>
+              </a:r>
+            </a:p>
+            <a:p>
+              <a:pPr defTabSz="439781">
+                <a:defRPr/>
+              </a:pPr>
+              <a:endParaRPr lang="te-IN" sz="2000" dirty="0">
                 <a:latin typeface="Ramabhadra" panose="02000600000000000000" pitchFamily="2" charset="0"/>
                 <a:cs typeface="Ramabhadra" panose="02000600000000000000" pitchFamily="2" charset="0"/>
               </a:endParaRPr>
@@ -3132,47 +3219,148 @@
                 <a:defRPr/>
               </a:pPr>
               <a:r>
-                <a:rPr lang="te-IN" sz="2200" dirty="0">
-                  <a:latin typeface="Ramabhadra" panose="02000600000000000000" pitchFamily="2" charset="0"/>
-                  <a:cs typeface="Ramabhadra" panose="02000600000000000000" pitchFamily="2" charset="0"/>
-                </a:rPr>
-                <a:t>నేనెలా మరచిపోదును (2)</a:t>
-              </a:r>
-              <a:br>
-                <a:rPr lang="te-IN" sz="2200" dirty="0">
-                  <a:latin typeface="Ramabhadra" panose="02000600000000000000" pitchFamily="2" charset="0"/>
-                  <a:cs typeface="Ramabhadra" panose="02000600000000000000" pitchFamily="2" charset="0"/>
-                </a:rPr>
-              </a:br>
-              <a:r>
-                <a:rPr lang="te-IN" sz="2200" dirty="0">
-                  <a:latin typeface="Ramabhadra" panose="02000600000000000000" pitchFamily="2" charset="0"/>
-                  <a:cs typeface="Ramabhadra" panose="02000600000000000000" pitchFamily="2" charset="0"/>
-                </a:rPr>
-                <a:t>హల్లెలూయ లూయ హల్లెలూయా (4)</a:t>
-              </a:r>
-            </a:p>
-            <a:p>
-              <a:pPr defTabSz="439781">
-                <a:defRPr/>
-              </a:pPr>
-              <a:endParaRPr lang="te-IN" sz="2200" dirty="0">
+                <a:rPr lang="en-IN" sz="2000" dirty="0">
+                  <a:latin typeface="Ramabhadra" panose="02000600000000000000" pitchFamily="2" charset="0"/>
+                  <a:cs typeface="Ramabhadra" panose="02000600000000000000" pitchFamily="2" charset="0"/>
+                </a:rPr>
+                <a:t>1. </a:t>
+              </a:r>
+              <a:r>
+                <a:rPr lang="te-IN" sz="2000" dirty="0">
+                  <a:latin typeface="Ramabhadra" panose="02000600000000000000" pitchFamily="2" charset="0"/>
+                  <a:cs typeface="Ramabhadra" panose="02000600000000000000" pitchFamily="2" charset="0"/>
+                </a:rPr>
+                <a:t>పూర్ణమై సంపూర్ణమైన నీ దివ్య చిత్తమే </a:t>
+              </a:r>
+            </a:p>
+            <a:p>
+              <a:pPr defTabSz="439781">
+                <a:defRPr/>
+              </a:pPr>
+              <a:r>
+                <a:rPr lang="te-IN" sz="2000" dirty="0">
+                  <a:latin typeface="Ramabhadra" panose="02000600000000000000" pitchFamily="2" charset="0"/>
+                  <a:cs typeface="Ramabhadra" panose="02000600000000000000" pitchFamily="2" charset="0"/>
+                </a:rPr>
+                <a:t>నీవు నను నడిపే నూతనమైన జీవ మార్గము (2) </a:t>
+              </a:r>
+            </a:p>
+            <a:p>
+              <a:pPr defTabSz="439781">
+                <a:defRPr/>
+              </a:pPr>
+              <a:r>
+                <a:rPr lang="te-IN" sz="2000" dirty="0">
+                  <a:latin typeface="Ramabhadra" panose="02000600000000000000" pitchFamily="2" charset="0"/>
+                  <a:cs typeface="Ramabhadra" panose="02000600000000000000" pitchFamily="2" charset="0"/>
+                </a:rPr>
+                <a:t>ఇహ మందు పరమందు ఆశ్రయమైన వాడవు </a:t>
+              </a:r>
+            </a:p>
+            <a:p>
+              <a:pPr defTabSz="439781">
+                <a:defRPr/>
+              </a:pPr>
+              <a:r>
+                <a:rPr lang="te-IN" sz="2000" dirty="0">
+                  <a:latin typeface="Ramabhadra" panose="02000600000000000000" pitchFamily="2" charset="0"/>
+                  <a:cs typeface="Ramabhadra" panose="02000600000000000000" pitchFamily="2" charset="0"/>
+                </a:rPr>
+                <a:t>ఇన్నాళ్లు క్షణమైనా నన్ను మరువని యేసయ్యా (2)</a:t>
+              </a:r>
+              <a:endParaRPr lang="en-IN" sz="2000" dirty="0">
                 <a:latin typeface="Ramabhadra" panose="02000600000000000000" pitchFamily="2" charset="0"/>
                 <a:cs typeface="Ramabhadra" panose="02000600000000000000" pitchFamily="2" charset="0"/>
               </a:endParaRPr>
             </a:p>
             <a:p>
-              <a:pPr defTabSz="439781">
-                <a:defRPr/>
-              </a:pPr>
-              <a:r>
-                <a:rPr lang="te-IN" sz="2200" dirty="0">
-                  <a:latin typeface="Ramabhadra" panose="02000600000000000000" pitchFamily="2" charset="0"/>
-                  <a:cs typeface="Ramabhadra" panose="02000600000000000000" pitchFamily="2" charset="0"/>
-                </a:rPr>
-                <a:t>బానిసత్వమునుండి శ్రమల బారినుండి</a:t>
-              </a:r>
-              <a:endParaRPr lang="en-IN" sz="2200" dirty="0">
+              <a:pPr algn="ctr" defTabSz="439781">
+                <a:defRPr/>
+              </a:pPr>
+              <a:r>
+                <a:rPr lang="en-IN" sz="2000" dirty="0">
+                  <a:latin typeface="Ramabhadra" panose="02000600000000000000" pitchFamily="2" charset="0"/>
+                  <a:cs typeface="Ramabhadra" panose="02000600000000000000" pitchFamily="2" charset="0"/>
+                </a:rPr>
+                <a:t>                              		|| </a:t>
+              </a:r>
+              <a:r>
+                <a:rPr lang="te-IN" sz="2000" dirty="0">
+                  <a:latin typeface="Ramabhadra" panose="02000600000000000000" pitchFamily="2" charset="0"/>
+                  <a:cs typeface="Ramabhadra" panose="02000600000000000000" pitchFamily="2" charset="0"/>
+                </a:rPr>
+                <a:t>నా తోడు</a:t>
+              </a:r>
+              <a:r>
+                <a:rPr lang="en-IN" sz="2000" dirty="0">
+                  <a:latin typeface="Ramabhadra" panose="02000600000000000000" pitchFamily="2" charset="0"/>
+                  <a:cs typeface="Ramabhadra" panose="02000600000000000000" pitchFamily="2" charset="0"/>
+                </a:rPr>
+                <a:t> ||</a:t>
+              </a:r>
+              <a:r>
+                <a:rPr lang="te-IN" sz="2000" dirty="0">
+                  <a:latin typeface="Ramabhadra" panose="02000600000000000000" pitchFamily="2" charset="0"/>
+                  <a:cs typeface="Ramabhadra" panose="02000600000000000000" pitchFamily="2" charset="0"/>
+                </a:rPr>
+                <a:t>                         </a:t>
+              </a:r>
+            </a:p>
+            <a:p>
+              <a:pPr defTabSz="439781">
+                <a:defRPr/>
+              </a:pPr>
+              <a:r>
+                <a:rPr lang="en-IN" sz="2000" dirty="0">
+                  <a:latin typeface="Ramabhadra" panose="02000600000000000000" pitchFamily="2" charset="0"/>
+                  <a:cs typeface="Ramabhadra" panose="02000600000000000000" pitchFamily="2" charset="0"/>
+                </a:rPr>
+                <a:t>2. </a:t>
+              </a:r>
+              <a:r>
+                <a:rPr lang="te-IN" sz="2000" dirty="0">
+                  <a:latin typeface="Ramabhadra" panose="02000600000000000000" pitchFamily="2" charset="0"/>
+                  <a:cs typeface="Ramabhadra" panose="02000600000000000000" pitchFamily="2" charset="0"/>
+                </a:rPr>
+                <a:t>భాగ్యమే సౌభాగ్యమే నీ దివ్య సన్నిధి </a:t>
+              </a:r>
+            </a:p>
+            <a:p>
+              <a:pPr defTabSz="439781">
+                <a:defRPr/>
+              </a:pPr>
+              <a:r>
+                <a:rPr lang="te-IN" sz="2000" dirty="0">
+                  <a:latin typeface="Ramabhadra" panose="02000600000000000000" pitchFamily="2" charset="0"/>
+                  <a:cs typeface="Ramabhadra" panose="02000600000000000000" pitchFamily="2" charset="0"/>
+                </a:rPr>
+                <a:t>బహు విస్తారమైన నీ కృప నాపై చూపితివే (2) </a:t>
+              </a:r>
+            </a:p>
+            <a:p>
+              <a:pPr defTabSz="439781">
+                <a:defRPr/>
+              </a:pPr>
+              <a:r>
+                <a:rPr lang="te-IN" sz="2000" dirty="0">
+                  <a:latin typeface="Ramabhadra" panose="02000600000000000000" pitchFamily="2" charset="0"/>
+                  <a:cs typeface="Ramabhadra" panose="02000600000000000000" pitchFamily="2" charset="0"/>
+                </a:rPr>
+                <a:t>బలమైన ఘనమైన నీ నామమందు హర్షించి </a:t>
+              </a:r>
+            </a:p>
+            <a:p>
+              <a:pPr defTabSz="439781">
+                <a:defRPr/>
+              </a:pPr>
+              <a:r>
+                <a:rPr lang="te-IN" sz="2000" dirty="0">
+                  <a:latin typeface="Ramabhadra" panose="02000600000000000000" pitchFamily="2" charset="0"/>
+                  <a:cs typeface="Ramabhadra" panose="02000600000000000000" pitchFamily="2" charset="0"/>
+                </a:rPr>
+                <a:t>భజయించి కీర్తించి ఘనపరతు నిన్ను యేసయ్యా (2)</a:t>
+              </a:r>
+              <a:endParaRPr lang="en-IN" sz="2000" dirty="0">
                 <a:latin typeface="Ramabhadra" panose="02000600000000000000" pitchFamily="2" charset="0"/>
                 <a:cs typeface="Ramabhadra" panose="02000600000000000000" pitchFamily="2" charset="0"/>
               </a:endParaRPr>
@@ -3182,115 +3370,27 @@
                 <a:defRPr/>
               </a:pPr>
               <a:r>
-                <a:rPr lang="te-IN" sz="2200" dirty="0">
-                  <a:latin typeface="Ramabhadra" panose="02000600000000000000" pitchFamily="2" charset="0"/>
-                  <a:cs typeface="Ramabhadra" panose="02000600000000000000" pitchFamily="2" charset="0"/>
-                </a:rPr>
-                <a:t>విడిపించావు నన్ను</a:t>
-              </a:r>
-              <a:br>
-                <a:rPr lang="te-IN" sz="2200" dirty="0">
-                  <a:latin typeface="Ramabhadra" panose="02000600000000000000" pitchFamily="2" charset="0"/>
-                  <a:cs typeface="Ramabhadra" panose="02000600000000000000" pitchFamily="2" charset="0"/>
-                </a:rPr>
-              </a:br>
-              <a:r>
-                <a:rPr lang="te-IN" sz="2200" dirty="0">
-                  <a:latin typeface="Ramabhadra" panose="02000600000000000000" pitchFamily="2" charset="0"/>
-                  <a:cs typeface="Ramabhadra" panose="02000600000000000000" pitchFamily="2" charset="0"/>
-                </a:rPr>
-                <a:t>దీన దశలో నేనుండగా </a:t>
-              </a:r>
-              <a:endParaRPr lang="en-IN" sz="2200" dirty="0">
-                <a:latin typeface="Ramabhadra" panose="02000600000000000000" pitchFamily="2" charset="0"/>
-                <a:cs typeface="Ramabhadra" panose="02000600000000000000" pitchFamily="2" charset="0"/>
-              </a:endParaRPr>
-            </a:p>
-            <a:p>
-              <a:pPr defTabSz="439781">
-                <a:defRPr/>
-              </a:pPr>
-              <a:r>
-                <a:rPr lang="te-IN" sz="2200" dirty="0">
-                  <a:latin typeface="Ramabhadra" panose="02000600000000000000" pitchFamily="2" charset="0"/>
-                  <a:cs typeface="Ramabhadra" panose="02000600000000000000" pitchFamily="2" charset="0"/>
-                </a:rPr>
-                <a:t>నను విడువనైతివి (2) </a:t>
-              </a:r>
-            </a:p>
-            <a:p>
-              <a:pPr defTabSz="439781">
-                <a:defRPr/>
-              </a:pPr>
-              <a:endParaRPr lang="en-IN" sz="2200" dirty="0">
-                <a:latin typeface="Ramabhadra" panose="02000600000000000000" pitchFamily="2" charset="0"/>
-                <a:cs typeface="Ramabhadra" panose="02000600000000000000" pitchFamily="2" charset="0"/>
-              </a:endParaRPr>
-            </a:p>
-            <a:p>
-              <a:pPr defTabSz="439781">
-                <a:defRPr/>
-              </a:pPr>
-              <a:r>
-                <a:rPr lang="te-IN" sz="2200" dirty="0">
-                  <a:latin typeface="Ramabhadra" panose="02000600000000000000" pitchFamily="2" charset="0"/>
-                  <a:cs typeface="Ramabhadra" panose="02000600000000000000" pitchFamily="2" charset="0"/>
-                </a:rPr>
-                <a:t>జీవాహారమై నీదు వాక్యము</a:t>
-              </a:r>
-              <a:endParaRPr lang="en-IN" sz="2200" dirty="0">
-                <a:latin typeface="Ramabhadra" panose="02000600000000000000" pitchFamily="2" charset="0"/>
-                <a:cs typeface="Ramabhadra" panose="02000600000000000000" pitchFamily="2" charset="0"/>
-              </a:endParaRPr>
-            </a:p>
-            <a:p>
-              <a:pPr defTabSz="439781">
-                <a:defRPr/>
-              </a:pPr>
-              <a:r>
-                <a:rPr lang="te-IN" sz="2200" dirty="0">
-                  <a:latin typeface="Ramabhadra" panose="02000600000000000000" pitchFamily="2" charset="0"/>
-                  <a:cs typeface="Ramabhadra" panose="02000600000000000000" pitchFamily="2" charset="0"/>
-                </a:rPr>
-                <a:t>పోషించెను నన్ను</a:t>
-              </a:r>
-              <a:br>
-                <a:rPr lang="te-IN" sz="2200" dirty="0">
-                  <a:latin typeface="Ramabhadra" panose="02000600000000000000" pitchFamily="2" charset="0"/>
-                  <a:cs typeface="Ramabhadra" panose="02000600000000000000" pitchFamily="2" charset="0"/>
-                </a:rPr>
-              </a:br>
-              <a:r>
-                <a:rPr lang="te-IN" sz="2200" dirty="0">
-                  <a:latin typeface="Ramabhadra" panose="02000600000000000000" pitchFamily="2" charset="0"/>
-                  <a:cs typeface="Ramabhadra" panose="02000600000000000000" pitchFamily="2" charset="0"/>
-                </a:rPr>
-                <a:t>ఆకలితో అల్లాడగా</a:t>
-              </a:r>
-              <a:endParaRPr lang="en-IN" sz="2200" dirty="0">
-                <a:latin typeface="Ramabhadra" panose="02000600000000000000" pitchFamily="2" charset="0"/>
-                <a:cs typeface="Ramabhadra" panose="02000600000000000000" pitchFamily="2" charset="0"/>
-              </a:endParaRPr>
-            </a:p>
-            <a:p>
-              <a:pPr defTabSz="439781">
-                <a:defRPr/>
-              </a:pPr>
-              <a:r>
-                <a:rPr lang="te-IN" sz="2200" dirty="0">
-                  <a:latin typeface="Ramabhadra" panose="02000600000000000000" pitchFamily="2" charset="0"/>
-                  <a:cs typeface="Ramabhadra" panose="02000600000000000000" pitchFamily="2" charset="0"/>
-                </a:rPr>
-                <a:t>నను తృప్తిపరచితివి (2</a:t>
-              </a:r>
-              <a:r>
-                <a:rPr lang="en-IN" sz="2200" dirty="0">
-                  <a:latin typeface="Ramabhadra" panose="02000600000000000000" pitchFamily="2" charset="0"/>
-                  <a:cs typeface="Ramabhadra" panose="02000600000000000000" pitchFamily="2" charset="0"/>
-                </a:rPr>
-                <a:t>)</a:t>
-              </a:r>
-              <a:endParaRPr lang="te-IN" sz="2200" dirty="0">
+                <a:rPr lang="en-IN" sz="2000" dirty="0">
+                  <a:latin typeface="Ramabhadra" panose="02000600000000000000" pitchFamily="2" charset="0"/>
+                  <a:cs typeface="Ramabhadra" panose="02000600000000000000" pitchFamily="2" charset="0"/>
+                </a:rPr>
+                <a:t>							|| </a:t>
+              </a:r>
+              <a:r>
+                <a:rPr lang="te-IN" sz="2000" dirty="0">
+                  <a:latin typeface="Ramabhadra" panose="02000600000000000000" pitchFamily="2" charset="0"/>
+                  <a:cs typeface="Ramabhadra" panose="02000600000000000000" pitchFamily="2" charset="0"/>
+                </a:rPr>
+                <a:t>నా తోడు</a:t>
+              </a:r>
+              <a:r>
+                <a:rPr lang="en-IN" sz="2000" dirty="0">
+                  <a:latin typeface="Ramabhadra" panose="02000600000000000000" pitchFamily="2" charset="0"/>
+                  <a:cs typeface="Ramabhadra" panose="02000600000000000000" pitchFamily="2" charset="0"/>
+                </a:rPr>
+                <a:t> ||</a:t>
+              </a:r>
+              <a:endParaRPr lang="te-IN" sz="2000" dirty="0">
                 <a:latin typeface="Ramabhadra" panose="02000600000000000000" pitchFamily="2" charset="0"/>
                 <a:cs typeface="Ramabhadra" panose="02000600000000000000" pitchFamily="2" charset="0"/>
               </a:endParaRPr>
@@ -3311,7 +3411,7 @@
           </p:nvSpPr>
           <p:spPr>
             <a:xfrm>
-              <a:off x="343961" y="326430"/>
+              <a:off x="4261380" y="326430"/>
               <a:ext cx="390525" cy="390525"/>
             </a:xfrm>
             <a:prstGeom prst="ellipse">
@@ -3450,7 +3550,7 @@
           <p:spPr>
             <a:xfrm>
               <a:off x="343961" y="770800"/>
-              <a:ext cx="4541306" cy="5632311"/>
+              <a:ext cx="4541306" cy="5047536"/>
             </a:xfrm>
             <a:prstGeom prst="rect">
               <a:avLst/>
@@ -3467,78 +3567,66 @@
                 <a:defRPr/>
               </a:pPr>
               <a:r>
-                <a:rPr lang="te-IN" dirty="0">
-                  <a:latin typeface="Ramabhadra" panose="02000600000000000000" pitchFamily="2" charset="0"/>
-                  <a:cs typeface="Ramabhadra" panose="02000600000000000000" pitchFamily="2" charset="0"/>
-                </a:rPr>
-                <a:t>నీ ప్రేమ నా జీవితాన్ని – నీకై వెలిగించెనే యేసయ్యా</a:t>
-              </a:r>
-            </a:p>
-            <a:p>
-              <a:pPr defTabSz="439781">
-                <a:defRPr/>
-              </a:pPr>
-              <a:r>
-                <a:rPr lang="te-IN" dirty="0">
-                  <a:latin typeface="Ramabhadra" panose="02000600000000000000" pitchFamily="2" charset="0"/>
-                  <a:cs typeface="Ramabhadra" panose="02000600000000000000" pitchFamily="2" charset="0"/>
-                </a:rPr>
-                <a:t>నీ కృప సెలయేరులా – నాలో ప్రవహించెనే (2)</a:t>
-              </a:r>
-            </a:p>
-            <a:p>
-              <a:pPr defTabSz="439781">
-                <a:defRPr/>
-              </a:pPr>
-              <a:r>
-                <a:rPr lang="te-IN" dirty="0">
-                  <a:latin typeface="Ramabhadra" panose="02000600000000000000" pitchFamily="2" charset="0"/>
-                  <a:cs typeface="Ramabhadra" panose="02000600000000000000" pitchFamily="2" charset="0"/>
-                </a:rPr>
-                <a:t>నన్ను క్షమియించెనే – నన్ను కరుణించెనే</a:t>
-              </a:r>
-            </a:p>
-            <a:p>
-              <a:pPr defTabSz="439781">
-                <a:defRPr/>
-              </a:pPr>
-              <a:r>
-                <a:rPr lang="te-IN" dirty="0">
-                  <a:latin typeface="Ramabhadra" panose="02000600000000000000" pitchFamily="2" charset="0"/>
-                  <a:cs typeface="Ramabhadra" panose="02000600000000000000" pitchFamily="2" charset="0"/>
-                </a:rPr>
-                <a:t>నన్ను స్థిరపరచెనే – నన్ను ఘనపరచెనే (2)</a:t>
-              </a:r>
-            </a:p>
-            <a:p>
-              <a:pPr defTabSz="439781">
-                <a:defRPr/>
-              </a:pPr>
-              <a:r>
-                <a:rPr lang="te-IN" dirty="0">
-                  <a:latin typeface="Ramabhadra" panose="02000600000000000000" pitchFamily="2" charset="0"/>
-                  <a:cs typeface="Ramabhadra" panose="02000600000000000000" pitchFamily="2" charset="0"/>
-                </a:rPr>
-                <a:t>యేసయ్యా యేసయ్యా నా యేసయ్యా</a:t>
-              </a:r>
-            </a:p>
-            <a:p>
-              <a:pPr defTabSz="439781">
-                <a:defRPr/>
-              </a:pPr>
-              <a:r>
-                <a:rPr lang="te-IN" dirty="0">
-                  <a:latin typeface="Ramabhadra" panose="02000600000000000000" pitchFamily="2" charset="0"/>
-                  <a:cs typeface="Ramabhadra" panose="02000600000000000000" pitchFamily="2" charset="0"/>
-                </a:rPr>
-                <a:t>యేసయ్యా యేసయ్యా ఓ మెస్సయ్యా (2)</a:t>
-              </a:r>
-            </a:p>
-            <a:p>
-              <a:pPr defTabSz="439781">
-                <a:defRPr/>
-              </a:pPr>
-              <a:endParaRPr lang="te-IN" dirty="0">
+                <a:rPr lang="te-IN" sz="2300" dirty="0">
+                  <a:latin typeface="Ramabhadra" panose="02000600000000000000" pitchFamily="2" charset="0"/>
+                  <a:cs typeface="Ramabhadra" panose="02000600000000000000" pitchFamily="2" charset="0"/>
+                </a:rPr>
+                <a:t>స్తోత్రము స్తుతి స్తోత్రము</a:t>
+              </a:r>
+            </a:p>
+            <a:p>
+              <a:pPr defTabSz="439781">
+                <a:defRPr/>
+              </a:pPr>
+              <a:r>
+                <a:rPr lang="te-IN" sz="2300" dirty="0">
+                  <a:latin typeface="Ramabhadra" panose="02000600000000000000" pitchFamily="2" charset="0"/>
+                  <a:cs typeface="Ramabhadra" panose="02000600000000000000" pitchFamily="2" charset="0"/>
+                </a:rPr>
+                <a:t>వేలాది వందనాలు</a:t>
+              </a:r>
+            </a:p>
+            <a:p>
+              <a:pPr defTabSz="439781">
+                <a:defRPr/>
+              </a:pPr>
+              <a:r>
+                <a:rPr lang="te-IN" sz="2300" dirty="0">
+                  <a:latin typeface="Ramabhadra" panose="02000600000000000000" pitchFamily="2" charset="0"/>
+                  <a:cs typeface="Ramabhadra" panose="02000600000000000000" pitchFamily="2" charset="0"/>
+                </a:rPr>
+                <a:t>కలుగును గాక నీకే మహిమ</a:t>
+              </a:r>
+            </a:p>
+            <a:p>
+              <a:pPr defTabSz="439781">
+                <a:defRPr/>
+              </a:pPr>
+              <a:r>
+                <a:rPr lang="te-IN" sz="2300" dirty="0">
+                  <a:latin typeface="Ramabhadra" panose="02000600000000000000" pitchFamily="2" charset="0"/>
+                  <a:cs typeface="Ramabhadra" panose="02000600000000000000" pitchFamily="2" charset="0"/>
+                </a:rPr>
+                <a:t>ఎల్లప్పుడూ స్తుతి స్తోత్రము</a:t>
+              </a:r>
+            </a:p>
+            <a:p>
+              <a:pPr defTabSz="439781">
+                <a:defRPr/>
+              </a:pPr>
+              <a:r>
+                <a:rPr lang="te-IN" sz="2300" dirty="0">
+                  <a:latin typeface="Ramabhadra" panose="02000600000000000000" pitchFamily="2" charset="0"/>
+                  <a:cs typeface="Ramabhadra" panose="02000600000000000000" pitchFamily="2" charset="0"/>
+                </a:rPr>
+                <a:t>యేసయ్య యేసయ్య యేసయ్య (4)</a:t>
+              </a:r>
+            </a:p>
+            <a:p>
+              <a:pPr defTabSz="439781">
+                <a:defRPr/>
+              </a:pPr>
+              <a:endParaRPr lang="te-IN" sz="2300" dirty="0">
                 <a:latin typeface="Ramabhadra" panose="02000600000000000000" pitchFamily="2" charset="0"/>
                 <a:cs typeface="Ramabhadra" panose="02000600000000000000" pitchFamily="2" charset="0"/>
               </a:endParaRPr>
@@ -3548,78 +3636,32 @@
                 <a:defRPr/>
               </a:pPr>
               <a:r>
-                <a:rPr lang="te-IN" dirty="0">
-                  <a:latin typeface="Ramabhadra" panose="02000600000000000000" pitchFamily="2" charset="0"/>
-                  <a:cs typeface="Ramabhadra" panose="02000600000000000000" pitchFamily="2" charset="0"/>
-                </a:rPr>
-                <a:t>నేను నిన్ను విడచిననూ –</a:t>
-              </a:r>
-            </a:p>
-            <a:p>
-              <a:pPr defTabSz="439781">
-                <a:defRPr/>
-              </a:pPr>
-              <a:r>
-                <a:rPr lang="te-IN" dirty="0">
-                  <a:latin typeface="Ramabhadra" panose="02000600000000000000" pitchFamily="2" charset="0"/>
-                  <a:cs typeface="Ramabhadra" panose="02000600000000000000" pitchFamily="2" charset="0"/>
-                </a:rPr>
-                <a:t>నీవు నన్ను విడువలేదయ్యా</a:t>
-              </a:r>
-            </a:p>
-            <a:p>
-              <a:pPr defTabSz="439781">
-                <a:defRPr/>
-              </a:pPr>
-              <a:r>
-                <a:rPr lang="te-IN" dirty="0">
-                  <a:latin typeface="Ramabhadra" panose="02000600000000000000" pitchFamily="2" charset="0"/>
-                  <a:cs typeface="Ramabhadra" panose="02000600000000000000" pitchFamily="2" charset="0"/>
-                </a:rPr>
-                <a:t>దారి తప్పి తొలగిననూ –</a:t>
-              </a:r>
-            </a:p>
-            <a:p>
-              <a:pPr defTabSz="439781">
-                <a:defRPr/>
-              </a:pPr>
-              <a:r>
-                <a:rPr lang="te-IN" dirty="0">
-                  <a:latin typeface="Ramabhadra" panose="02000600000000000000" pitchFamily="2" charset="0"/>
-                  <a:cs typeface="Ramabhadra" panose="02000600000000000000" pitchFamily="2" charset="0"/>
-                </a:rPr>
-                <a:t>నీ దారిలో నను చేర్చినావయ్యా (2)</a:t>
-              </a:r>
-            </a:p>
-            <a:p>
-              <a:pPr defTabSz="439781">
-                <a:defRPr/>
-              </a:pPr>
-              <a:r>
-                <a:rPr lang="te-IN" dirty="0">
-                  <a:latin typeface="Ramabhadra" panose="02000600000000000000" pitchFamily="2" charset="0"/>
-                  <a:cs typeface="Ramabhadra" panose="02000600000000000000" pitchFamily="2" charset="0"/>
-                </a:rPr>
-                <a:t>ఏమివ్వగలను నీ కృపకు నేను</a:t>
-              </a:r>
-            </a:p>
-            <a:p>
-              <a:pPr defTabSz="439781">
-                <a:defRPr/>
-              </a:pPr>
-              <a:r>
-                <a:rPr lang="te-IN" dirty="0">
-                  <a:latin typeface="Ramabhadra" panose="02000600000000000000" pitchFamily="2" charset="0"/>
-                  <a:cs typeface="Ramabhadra" panose="02000600000000000000" pitchFamily="2" charset="0"/>
-                </a:rPr>
-                <a:t>వెలకట్టలేను నీ ప్రేమను (2)</a:t>
-              </a:r>
-            </a:p>
-            <a:p>
-              <a:pPr defTabSz="439781">
-                <a:defRPr/>
-              </a:pPr>
-              <a:endParaRPr lang="te-IN" dirty="0">
+                <a:rPr lang="en-IN" sz="2300" dirty="0">
+                  <a:latin typeface="Ramabhadra" panose="02000600000000000000" pitchFamily="2" charset="0"/>
+                  <a:cs typeface="Ramabhadra" panose="02000600000000000000" pitchFamily="2" charset="0"/>
+                </a:rPr>
+                <a:t>1. </a:t>
+              </a:r>
+              <a:r>
+                <a:rPr lang="te-IN" sz="2300" dirty="0">
+                  <a:latin typeface="Ramabhadra" panose="02000600000000000000" pitchFamily="2" charset="0"/>
+                  <a:cs typeface="Ramabhadra" panose="02000600000000000000" pitchFamily="2" charset="0"/>
+                </a:rPr>
+                <a:t>శూన్యము నుండి సమస్తము కలుగజేసెను</a:t>
+              </a:r>
+            </a:p>
+            <a:p>
+              <a:pPr defTabSz="439781">
+                <a:defRPr/>
+              </a:pPr>
+              <a:r>
+                <a:rPr lang="te-IN" sz="2300" dirty="0">
+                  <a:latin typeface="Ramabhadra" panose="02000600000000000000" pitchFamily="2" charset="0"/>
+                  <a:cs typeface="Ramabhadra" panose="02000600000000000000" pitchFamily="2" charset="0"/>
+                </a:rPr>
+                <a:t>నిరాకారమైన నా జీవితమునకు</a:t>
+              </a:r>
+              <a:endParaRPr lang="en-IN" sz="2300" dirty="0">
                 <a:latin typeface="Ramabhadra" panose="02000600000000000000" pitchFamily="2" charset="0"/>
                 <a:cs typeface="Ramabhadra" panose="02000600000000000000" pitchFamily="2" charset="0"/>
               </a:endParaRPr>
@@ -3629,71 +3671,103 @@
                 <a:defRPr/>
               </a:pPr>
               <a:r>
-                <a:rPr lang="te-IN" dirty="0">
-                  <a:latin typeface="Ramabhadra" panose="02000600000000000000" pitchFamily="2" charset="0"/>
-                  <a:cs typeface="Ramabhadra" panose="02000600000000000000" pitchFamily="2" charset="0"/>
-                </a:rPr>
-                <a:t>జలములు నన్ను చుట్టిననూ –</a:t>
-              </a:r>
-            </a:p>
-            <a:p>
-              <a:pPr defTabSz="439781">
-                <a:defRPr/>
-              </a:pPr>
-              <a:r>
-                <a:rPr lang="te-IN" dirty="0">
-                  <a:latin typeface="Ramabhadra" panose="02000600000000000000" pitchFamily="2" charset="0"/>
-                  <a:cs typeface="Ramabhadra" panose="02000600000000000000" pitchFamily="2" charset="0"/>
-                </a:rPr>
-                <a:t>నీ చేతిలో నను దాచినావయ్యా</a:t>
-              </a:r>
-            </a:p>
-            <a:p>
-              <a:pPr defTabSz="439781">
-                <a:defRPr/>
-              </a:pPr>
-              <a:r>
-                <a:rPr lang="te-IN" dirty="0">
-                  <a:latin typeface="Ramabhadra" panose="02000600000000000000" pitchFamily="2" charset="0"/>
-                  <a:cs typeface="Ramabhadra" panose="02000600000000000000" pitchFamily="2" charset="0"/>
-                </a:rPr>
-                <a:t>జ్వాలలు నాపై లేచిననూ –</a:t>
-              </a:r>
-            </a:p>
-            <a:p>
-              <a:pPr defTabSz="439781">
-                <a:defRPr/>
-              </a:pPr>
-              <a:r>
-                <a:rPr lang="te-IN" dirty="0">
-                  <a:latin typeface="Ramabhadra" panose="02000600000000000000" pitchFamily="2" charset="0"/>
-                  <a:cs typeface="Ramabhadra" panose="02000600000000000000" pitchFamily="2" charset="0"/>
-                </a:rPr>
-                <a:t>నీ ఆత్మతో నను కప్పినావయ్యా (2)</a:t>
-              </a:r>
-            </a:p>
-            <a:p>
-              <a:pPr defTabSz="439781">
-                <a:defRPr/>
-              </a:pPr>
-              <a:r>
-                <a:rPr lang="te-IN" dirty="0">
-                  <a:latin typeface="Ramabhadra" panose="02000600000000000000" pitchFamily="2" charset="0"/>
-                  <a:cs typeface="Ramabhadra" panose="02000600000000000000" pitchFamily="2" charset="0"/>
-                </a:rPr>
-                <a:t>ఏమివ్వగలను నీ కృపకు నేను</a:t>
-              </a:r>
-            </a:p>
-            <a:p>
-              <a:pPr defTabSz="439781">
-                <a:defRPr/>
-              </a:pPr>
-              <a:r>
-                <a:rPr lang="te-IN" dirty="0">
-                  <a:latin typeface="Ramabhadra" panose="02000600000000000000" pitchFamily="2" charset="0"/>
-                  <a:cs typeface="Ramabhadra" panose="02000600000000000000" pitchFamily="2" charset="0"/>
-                </a:rPr>
-                <a:t>వెలకట్టలేను నీ ఆత్మను (2)</a:t>
+                <a:rPr lang="te-IN" sz="2300" dirty="0">
+                  <a:latin typeface="Ramabhadra" panose="02000600000000000000" pitchFamily="2" charset="0"/>
+                  <a:cs typeface="Ramabhadra" panose="02000600000000000000" pitchFamily="2" charset="0"/>
+                </a:rPr>
+                <a:t>రూపము నిచ్చెను</a:t>
+              </a:r>
+            </a:p>
+            <a:p>
+              <a:pPr defTabSz="439781">
+                <a:defRPr/>
+              </a:pPr>
+              <a:r>
+                <a:rPr lang="te-IN" sz="2300" dirty="0">
+                  <a:latin typeface="Ramabhadra" panose="02000600000000000000" pitchFamily="2" charset="0"/>
+                  <a:cs typeface="Ramabhadra" panose="02000600000000000000" pitchFamily="2" charset="0"/>
+                </a:rPr>
+                <a:t>యేసే నా సర్వము</a:t>
+              </a:r>
+              <a:r>
+                <a:rPr lang="en-IN" sz="2300" dirty="0">
+                  <a:latin typeface="Ramabhadra" panose="02000600000000000000" pitchFamily="2" charset="0"/>
+                  <a:cs typeface="Ramabhadra" panose="02000600000000000000" pitchFamily="2" charset="0"/>
+                </a:rPr>
+                <a:t> - </a:t>
+              </a:r>
+              <a:r>
+                <a:rPr lang="te-IN" sz="2300" dirty="0">
+                  <a:latin typeface="Ramabhadra" panose="02000600000000000000" pitchFamily="2" charset="0"/>
+                  <a:cs typeface="Ramabhadra" panose="02000600000000000000" pitchFamily="2" charset="0"/>
+                </a:rPr>
+                <a:t>యేసే నా సమస్తము</a:t>
+              </a:r>
+            </a:p>
+            <a:p>
+              <a:pPr defTabSz="439781">
+                <a:defRPr/>
+              </a:pPr>
+              <a:endParaRPr lang="te-IN" sz="2300" dirty="0">
+                <a:latin typeface="Ramabhadra" panose="02000600000000000000" pitchFamily="2" charset="0"/>
+                <a:cs typeface="Ramabhadra" panose="02000600000000000000" pitchFamily="2" charset="0"/>
+              </a:endParaRPr>
+            </a:p>
+            <a:p>
+              <a:pPr defTabSz="439781">
+                <a:defRPr/>
+              </a:pPr>
+              <a:r>
+                <a:rPr lang="en-IN" sz="2300" dirty="0">
+                  <a:latin typeface="Ramabhadra" panose="02000600000000000000" pitchFamily="2" charset="0"/>
+                  <a:cs typeface="Ramabhadra" panose="02000600000000000000" pitchFamily="2" charset="0"/>
+                </a:rPr>
+                <a:t>2. </a:t>
+              </a:r>
+              <a:r>
+                <a:rPr lang="te-IN" sz="2300" dirty="0">
+                  <a:latin typeface="Ramabhadra" panose="02000600000000000000" pitchFamily="2" charset="0"/>
+                  <a:cs typeface="Ramabhadra" panose="02000600000000000000" pitchFamily="2" charset="0"/>
+                </a:rPr>
+                <a:t>పరము నుండి భూమికి దిగివచ్చిన యేసు</a:t>
+              </a:r>
+            </a:p>
+            <a:p>
+              <a:pPr defTabSz="439781">
+                <a:defRPr/>
+              </a:pPr>
+              <a:r>
+                <a:rPr lang="te-IN" sz="2300" dirty="0">
+                  <a:latin typeface="Ramabhadra" panose="02000600000000000000" pitchFamily="2" charset="0"/>
+                  <a:cs typeface="Ramabhadra" panose="02000600000000000000" pitchFamily="2" charset="0"/>
+                </a:rPr>
+                <a:t>సిలువ మరణమునొంది మార్గము తెరిచెను</a:t>
+              </a:r>
+            </a:p>
+            <a:p>
+              <a:pPr defTabSz="439781">
+                <a:defRPr/>
+              </a:pPr>
+              <a:r>
+                <a:rPr lang="te-IN" sz="2300" dirty="0">
+                  <a:latin typeface="Ramabhadra" panose="02000600000000000000" pitchFamily="2" charset="0"/>
+                  <a:cs typeface="Ramabhadra" panose="02000600000000000000" pitchFamily="2" charset="0"/>
+                </a:rPr>
+                <a:t>యేసే నా రక్షణ</a:t>
+              </a:r>
+              <a:r>
+                <a:rPr lang="en-IN" sz="2300" dirty="0">
+                  <a:latin typeface="Ramabhadra" panose="02000600000000000000" pitchFamily="2" charset="0"/>
+                  <a:cs typeface="Ramabhadra" panose="02000600000000000000" pitchFamily="2" charset="0"/>
+                </a:rPr>
+                <a:t> - </a:t>
+              </a:r>
+              <a:r>
+                <a:rPr lang="te-IN" sz="2300" dirty="0">
+                  <a:latin typeface="Ramabhadra" panose="02000600000000000000" pitchFamily="2" charset="0"/>
+                  <a:cs typeface="Ramabhadra" panose="02000600000000000000" pitchFamily="2" charset="0"/>
+                </a:rPr>
+                <a:t>యేసే నా నిరీక్షణ</a:t>
               </a:r>
             </a:p>
           </p:txBody>
@@ -3806,9 +3880,9 @@
         <p:grpSpPr>
           <a:xfrm>
             <a:off x="160868" y="182032"/>
-            <a:ext cx="4767793" cy="6493935"/>
+            <a:ext cx="4831293" cy="6493935"/>
             <a:chOff x="160868" y="182032"/>
-            <a:chExt cx="4767793" cy="6493935"/>
+            <a:chExt cx="4831293" cy="6493935"/>
           </a:xfrm>
         </p:grpSpPr>
         <p:sp>
@@ -3880,8 +3954,8 @@
           </p:nvSpPr>
           <p:spPr>
             <a:xfrm>
-              <a:off x="280461" y="749632"/>
-              <a:ext cx="4648200" cy="5509200"/>
+              <a:off x="343961" y="729375"/>
+              <a:ext cx="4648200" cy="5632311"/>
             </a:xfrm>
             <a:prstGeom prst="rect">
               <a:avLst/>
@@ -3898,54 +3972,66 @@
                 <a:defRPr/>
               </a:pPr>
               <a:r>
-                <a:rPr lang="te-IN" sz="2200" dirty="0">
-                  <a:latin typeface="Ramabhadra" panose="02000600000000000000" pitchFamily="2" charset="0"/>
-                  <a:cs typeface="Ramabhadra" panose="02000600000000000000" pitchFamily="2" charset="0"/>
-                </a:rPr>
-                <a:t>నా స్తుతుల పైన నివసించువాడా</a:t>
-              </a:r>
-            </a:p>
-            <a:p>
-              <a:pPr defTabSz="439781">
-                <a:defRPr/>
-              </a:pPr>
-              <a:r>
-                <a:rPr lang="te-IN" sz="2200" dirty="0">
-                  <a:latin typeface="Ramabhadra" panose="02000600000000000000" pitchFamily="2" charset="0"/>
-                  <a:cs typeface="Ramabhadra" panose="02000600000000000000" pitchFamily="2" charset="0"/>
-                </a:rPr>
-                <a:t>నా అంతరంగికుడా యేసయ్యా (2)</a:t>
-              </a:r>
-            </a:p>
-            <a:p>
-              <a:pPr defTabSz="439781">
-                <a:defRPr/>
-              </a:pPr>
-              <a:r>
-                <a:rPr lang="te-IN" sz="2200" dirty="0">
-                  <a:latin typeface="Ramabhadra" panose="02000600000000000000" pitchFamily="2" charset="0"/>
-                  <a:cs typeface="Ramabhadra" panose="02000600000000000000" pitchFamily="2" charset="0"/>
-                </a:rPr>
-                <a:t>నీవు నా పక్షమై యున్నావు గనుకే</a:t>
-              </a:r>
-            </a:p>
-            <a:p>
-              <a:pPr defTabSz="439781">
-                <a:defRPr/>
-              </a:pPr>
-              <a:r>
-                <a:rPr lang="te-IN" sz="2200" dirty="0">
-                  <a:latin typeface="Ramabhadra" panose="02000600000000000000" pitchFamily="2" charset="0"/>
-                  <a:cs typeface="Ramabhadra" panose="02000600000000000000" pitchFamily="2" charset="0"/>
-                </a:rPr>
-                <a:t>జయమే జయమే ఎల్లవేళలా జయమే (2)</a:t>
-              </a:r>
-            </a:p>
-            <a:p>
-              <a:pPr defTabSz="439781">
-                <a:defRPr/>
-              </a:pPr>
-              <a:endParaRPr lang="te-IN" sz="2200" dirty="0">
+                <a:rPr lang="te-IN" sz="2400" dirty="0">
+                  <a:latin typeface="Ramabhadra" panose="02000600000000000000" pitchFamily="2" charset="0"/>
+                  <a:cs typeface="Ramabhadra" panose="02000600000000000000" pitchFamily="2" charset="0"/>
+                </a:rPr>
+                <a:t>నా ప్రాణమా నా అంతరంగమా </a:t>
+              </a:r>
+            </a:p>
+            <a:p>
+              <a:pPr defTabSz="439781">
+                <a:defRPr/>
+              </a:pPr>
+              <a:r>
+                <a:rPr lang="te-IN" sz="2400" dirty="0">
+                  <a:latin typeface="Ramabhadra" panose="02000600000000000000" pitchFamily="2" charset="0"/>
+                  <a:cs typeface="Ramabhadra" panose="02000600000000000000" pitchFamily="2" charset="0"/>
+                </a:rPr>
+                <a:t>నాలో వున్న నా సమస్తమా (2)</a:t>
+              </a:r>
+            </a:p>
+            <a:p>
+              <a:pPr defTabSz="439781">
+                <a:defRPr/>
+              </a:pPr>
+              <a:r>
+                <a:rPr lang="te-IN" sz="2400" dirty="0">
+                  <a:latin typeface="Ramabhadra" panose="02000600000000000000" pitchFamily="2" charset="0"/>
+                  <a:cs typeface="Ramabhadra" panose="02000600000000000000" pitchFamily="2" charset="0"/>
+                </a:rPr>
+                <a:t>యెహోవ చేసిన ఉపకారములలో</a:t>
+              </a:r>
+            </a:p>
+            <a:p>
+              <a:pPr defTabSz="439781">
+                <a:defRPr/>
+              </a:pPr>
+              <a:r>
+                <a:rPr lang="te-IN" sz="2400" dirty="0">
+                  <a:latin typeface="Ramabhadra" panose="02000600000000000000" pitchFamily="2" charset="0"/>
+                  <a:cs typeface="Ramabhadra" panose="02000600000000000000" pitchFamily="2" charset="0"/>
+                </a:rPr>
+                <a:t>దేనిని మరువక కొనియాడుమా (2)</a:t>
+              </a:r>
+            </a:p>
+            <a:p>
+              <a:pPr defTabSz="439781">
+                <a:defRPr/>
+              </a:pPr>
+              <a:r>
+                <a:rPr lang="te-IN" sz="2400" dirty="0">
+                  <a:latin typeface="Ramabhadra" panose="02000600000000000000" pitchFamily="2" charset="0"/>
+                  <a:cs typeface="Ramabhadra" panose="02000600000000000000" pitchFamily="2" charset="0"/>
+                </a:rPr>
+                <a:t>ఆ.. ఆ… ఆ.. ఆ… ఆ.. ఆ…</a:t>
+              </a:r>
+            </a:p>
+            <a:p>
+              <a:pPr defTabSz="439781">
+                <a:defRPr/>
+              </a:pPr>
+              <a:endParaRPr lang="te-IN" sz="2400" dirty="0">
                 <a:latin typeface="Ramabhadra" panose="02000600000000000000" pitchFamily="2" charset="0"/>
                 <a:cs typeface="Ramabhadra" panose="02000600000000000000" pitchFamily="2" charset="0"/>
               </a:endParaRPr>
@@ -3955,13 +4041,61 @@
                 <a:defRPr/>
               </a:pPr>
               <a:r>
-                <a:rPr lang="te-IN" sz="2200" dirty="0">
-                  <a:latin typeface="Ramabhadra" panose="02000600000000000000" pitchFamily="2" charset="0"/>
-                  <a:cs typeface="Ramabhadra" panose="02000600000000000000" pitchFamily="2" charset="0"/>
-                </a:rPr>
-                <a:t>నన్ను నిర్మించిన రీతి తలచగా –</a:t>
-              </a:r>
-              <a:endParaRPr lang="en-IN" sz="2200" dirty="0">
+                <a:rPr lang="en-IN" sz="2400" dirty="0">
+                  <a:latin typeface="Ramabhadra" panose="02000600000000000000" pitchFamily="2" charset="0"/>
+                  <a:cs typeface="Ramabhadra" panose="02000600000000000000" pitchFamily="2" charset="0"/>
+                </a:rPr>
+                <a:t>1. </a:t>
+              </a:r>
+              <a:r>
+                <a:rPr lang="te-IN" sz="2400" dirty="0">
+                  <a:latin typeface="Ramabhadra" panose="02000600000000000000" pitchFamily="2" charset="0"/>
+                  <a:cs typeface="Ramabhadra" panose="02000600000000000000" pitchFamily="2" charset="0"/>
+                </a:rPr>
+                <a:t>నీ దోషములన్ని క్షమియించువాడు </a:t>
+              </a:r>
+            </a:p>
+            <a:p>
+              <a:pPr defTabSz="439781">
+                <a:defRPr/>
+              </a:pPr>
+              <a:r>
+                <a:rPr lang="te-IN" sz="2400" dirty="0">
+                  <a:latin typeface="Ramabhadra" panose="02000600000000000000" pitchFamily="2" charset="0"/>
+                  <a:cs typeface="Ramabhadra" panose="02000600000000000000" pitchFamily="2" charset="0"/>
+                </a:rPr>
+                <a:t>నీ పాపములన్ని పార ద్రోలువాడు (2)</a:t>
+              </a:r>
+            </a:p>
+            <a:p>
+              <a:pPr defTabSz="439781">
+                <a:defRPr/>
+              </a:pPr>
+              <a:r>
+                <a:rPr lang="te-IN" sz="2400" dirty="0">
+                  <a:latin typeface="Ramabhadra" panose="02000600000000000000" pitchFamily="2" charset="0"/>
+                  <a:cs typeface="Ramabhadra" panose="02000600000000000000" pitchFamily="2" charset="0"/>
+                </a:rPr>
+                <a:t>పరమ వైద్యుడు ప్రభు యేసుడు </a:t>
+              </a:r>
+            </a:p>
+            <a:p>
+              <a:pPr defTabSz="439781">
+                <a:defRPr/>
+              </a:pPr>
+              <a:r>
+                <a:rPr lang="te-IN" sz="2400" dirty="0">
+                  <a:latin typeface="Ramabhadra" panose="02000600000000000000" pitchFamily="2" charset="0"/>
+                  <a:cs typeface="Ramabhadra" panose="02000600000000000000" pitchFamily="2" charset="0"/>
+                </a:rPr>
+                <a:t>పరిశుద్ధ నామమును సన్నుతించుమా (2)</a:t>
+              </a:r>
+            </a:p>
+            <a:p>
+              <a:pPr defTabSz="439781">
+                <a:defRPr/>
+              </a:pPr>
+              <a:endParaRPr lang="te-IN" sz="2400" dirty="0">
                 <a:latin typeface="Ramabhadra" panose="02000600000000000000" pitchFamily="2" charset="0"/>
                 <a:cs typeface="Ramabhadra" panose="02000600000000000000" pitchFamily="2" charset="0"/>
               </a:endParaRPr>
@@ -3971,120 +4105,54 @@
                 <a:defRPr/>
               </a:pPr>
               <a:r>
-                <a:rPr lang="te-IN" sz="2200" dirty="0">
-                  <a:latin typeface="Ramabhadra" panose="02000600000000000000" pitchFamily="2" charset="0"/>
-                  <a:cs typeface="Ramabhadra" panose="02000600000000000000" pitchFamily="2" charset="0"/>
-                </a:rPr>
-                <a:t>ఎంతో ఆశ్చర్యమే</a:t>
-              </a:r>
-            </a:p>
-            <a:p>
-              <a:pPr defTabSz="439781">
-                <a:defRPr/>
-              </a:pPr>
-              <a:r>
-                <a:rPr lang="te-IN" sz="2200" dirty="0">
-                  <a:latin typeface="Ramabhadra" panose="02000600000000000000" pitchFamily="2" charset="0"/>
-                  <a:cs typeface="Ramabhadra" panose="02000600000000000000" pitchFamily="2" charset="0"/>
-                </a:rPr>
-                <a:t>అది నా ఊహకే వింతైనది (2)</a:t>
-              </a:r>
-            </a:p>
-            <a:p>
-              <a:pPr defTabSz="439781">
-                <a:defRPr/>
-              </a:pPr>
-              <a:r>
-                <a:rPr lang="te-IN" sz="2200" dirty="0">
-                  <a:latin typeface="Ramabhadra" panose="02000600000000000000" pitchFamily="2" charset="0"/>
-                  <a:cs typeface="Ramabhadra" panose="02000600000000000000" pitchFamily="2" charset="0"/>
-                </a:rPr>
-                <a:t>ఎరుపెక్కిన శత్రువుల చూపు నుండి తప్పించి</a:t>
-              </a:r>
-            </a:p>
-            <a:p>
-              <a:pPr defTabSz="439781">
-                <a:defRPr/>
-              </a:pPr>
-              <a:r>
-                <a:rPr lang="te-IN" sz="2200" dirty="0">
-                  <a:latin typeface="Ramabhadra" panose="02000600000000000000" pitchFamily="2" charset="0"/>
-                  <a:cs typeface="Ramabhadra" panose="02000600000000000000" pitchFamily="2" charset="0"/>
-                </a:rPr>
-                <a:t>ఎనలేని ప్రేమను నాపై కురిపించావు (2)</a:t>
-              </a:r>
-            </a:p>
-            <a:p>
-              <a:pPr defTabSz="439781">
-                <a:defRPr/>
-              </a:pPr>
-              <a:endParaRPr lang="te-IN" sz="2200" dirty="0">
-                <a:latin typeface="Ramabhadra" panose="02000600000000000000" pitchFamily="2" charset="0"/>
-                <a:cs typeface="Ramabhadra" panose="02000600000000000000" pitchFamily="2" charset="0"/>
-              </a:endParaRPr>
-            </a:p>
-            <a:p>
-              <a:pPr defTabSz="439781">
-                <a:defRPr/>
-              </a:pPr>
-              <a:r>
-                <a:rPr lang="te-IN" sz="2200" dirty="0">
-                  <a:latin typeface="Ramabhadra" panose="02000600000000000000" pitchFamily="2" charset="0"/>
-                  <a:cs typeface="Ramabhadra" panose="02000600000000000000" pitchFamily="2" charset="0"/>
-                </a:rPr>
-                <a:t>ద్రాక్షావల్లి అయిన నీలోనే –</a:t>
-              </a:r>
-              <a:endParaRPr lang="en-IN" sz="2200" dirty="0">
-                <a:latin typeface="Ramabhadra" panose="02000600000000000000" pitchFamily="2" charset="0"/>
-                <a:cs typeface="Ramabhadra" panose="02000600000000000000" pitchFamily="2" charset="0"/>
-              </a:endParaRPr>
-            </a:p>
-            <a:p>
-              <a:pPr defTabSz="439781">
-                <a:defRPr/>
-              </a:pPr>
-              <a:r>
-                <a:rPr lang="te-IN" sz="2200" dirty="0">
-                  <a:latin typeface="Ramabhadra" panose="02000600000000000000" pitchFamily="2" charset="0"/>
-                  <a:cs typeface="Ramabhadra" panose="02000600000000000000" pitchFamily="2" charset="0"/>
-                </a:rPr>
-                <a:t>బహుగా వేరు పారగా</a:t>
-              </a:r>
-            </a:p>
-            <a:p>
-              <a:pPr defTabSz="439781">
-                <a:defRPr/>
-              </a:pPr>
-              <a:r>
-                <a:rPr lang="te-IN" sz="2200" dirty="0">
-                  <a:latin typeface="Ramabhadra" panose="02000600000000000000" pitchFamily="2" charset="0"/>
-                  <a:cs typeface="Ramabhadra" panose="02000600000000000000" pitchFamily="2" charset="0"/>
-                </a:rPr>
-                <a:t>నీతో మధురమైన ఫలములీయనా (2)</a:t>
-              </a:r>
-            </a:p>
-            <a:p>
-              <a:pPr defTabSz="439781">
-                <a:defRPr/>
-              </a:pPr>
-              <a:r>
-                <a:rPr lang="te-IN" sz="2200" dirty="0">
-                  <a:latin typeface="Ramabhadra" panose="02000600000000000000" pitchFamily="2" charset="0"/>
-                  <a:cs typeface="Ramabhadra" panose="02000600000000000000" pitchFamily="2" charset="0"/>
-                </a:rPr>
-                <a:t>ఉన్నత స్థలములపై నాకు స్థానమిచ్చితివే</a:t>
-              </a:r>
-            </a:p>
-            <a:p>
-              <a:pPr defTabSz="439781">
-                <a:defRPr/>
-              </a:pPr>
-              <a:r>
-                <a:rPr lang="te-IN" sz="2200" dirty="0">
-                  <a:latin typeface="Ramabhadra" panose="02000600000000000000" pitchFamily="2" charset="0"/>
-                  <a:cs typeface="Ramabhadra" panose="02000600000000000000" pitchFamily="2" charset="0"/>
-                </a:rPr>
-                <a:t>విజయుడా నీ కృప చాలును నా జీవితాన (2)</a:t>
+                <a:rPr lang="en-IN" sz="2400" dirty="0">
+                  <a:latin typeface="Ramabhadra" panose="02000600000000000000" pitchFamily="2" charset="0"/>
+                  <a:cs typeface="Ramabhadra" panose="02000600000000000000" pitchFamily="2" charset="0"/>
+                </a:rPr>
+                <a:t>2. </a:t>
+              </a:r>
+              <a:r>
+                <a:rPr lang="te-IN" sz="2400" dirty="0">
+                  <a:latin typeface="Ramabhadra" panose="02000600000000000000" pitchFamily="2" charset="0"/>
+                  <a:cs typeface="Ramabhadra" panose="02000600000000000000" pitchFamily="2" charset="0"/>
+                </a:rPr>
+                <a:t>సమాధిలోనుండి నీ ప్రాణమును </a:t>
+              </a:r>
+            </a:p>
+            <a:p>
+              <a:pPr defTabSz="439781">
+                <a:defRPr/>
+              </a:pPr>
+              <a:r>
+                <a:rPr lang="te-IN" sz="2400" dirty="0">
+                  <a:latin typeface="Ramabhadra" panose="02000600000000000000" pitchFamily="2" charset="0"/>
+                  <a:cs typeface="Ramabhadra" panose="02000600000000000000" pitchFamily="2" charset="0"/>
+                </a:rPr>
+                <a:t>విమోచించుచున్నాడు శ్రీయేసుడు (2)</a:t>
+              </a:r>
+            </a:p>
+            <a:p>
+              <a:pPr defTabSz="439781">
+                <a:defRPr/>
+              </a:pPr>
+              <a:r>
+                <a:rPr lang="te-IN" sz="2400" dirty="0">
+                  <a:latin typeface="Ramabhadra" panose="02000600000000000000" pitchFamily="2" charset="0"/>
+                  <a:cs typeface="Ramabhadra" panose="02000600000000000000" pitchFamily="2" charset="0"/>
+                </a:rPr>
+                <a:t>కరుణా కటాక్షములను నీకు కిరీటముగా </a:t>
+              </a:r>
+            </a:p>
+            <a:p>
+              <a:pPr defTabSz="439781">
+                <a:defRPr/>
+              </a:pPr>
+              <a:r>
+                <a:rPr lang="te-IN" sz="2400" dirty="0">
+                  <a:latin typeface="Ramabhadra" panose="02000600000000000000" pitchFamily="2" charset="0"/>
+                  <a:cs typeface="Ramabhadra" panose="02000600000000000000" pitchFamily="2" charset="0"/>
+                </a:rPr>
+                <a:t>ధరియింపజేయును ప్రభు యేసుడు (2)</a:t>
               </a:r>
             </a:p>
           </p:txBody>
@@ -4167,9 +4235,9 @@
         <p:grpSpPr>
           <a:xfrm>
             <a:off x="5104338" y="182031"/>
-            <a:ext cx="4724399" cy="6493935"/>
+            <a:ext cx="4660899" cy="6493935"/>
             <a:chOff x="160868" y="182032"/>
-            <a:chExt cx="4724399" cy="6493935"/>
+            <a:chExt cx="4660899" cy="6493935"/>
           </a:xfrm>
         </p:grpSpPr>
         <p:sp>
@@ -4241,8 +4309,8 @@
           </p:nvSpPr>
           <p:spPr>
             <a:xfrm>
-              <a:off x="343961" y="740943"/>
-              <a:ext cx="4541306" cy="5170646"/>
+              <a:off x="280461" y="861353"/>
+              <a:ext cx="4541306" cy="4832092"/>
             </a:xfrm>
             <a:prstGeom prst="rect">
               <a:avLst/>
@@ -4263,7 +4331,7 @@
                   <a:latin typeface="Ramabhadra" panose="02000600000000000000" pitchFamily="2" charset="0"/>
                   <a:cs typeface="Ramabhadra" panose="02000600000000000000" pitchFamily="2" charset="0"/>
                 </a:rPr>
-                <a:t>ఎవరూ సమీపించలేని</a:t>
+                <a:t>యేసయ్యా నా హృదయ స్పందన నీవే కదా (2)</a:t>
               </a:r>
             </a:p>
             <a:p>
@@ -4275,43 +4343,7 @@
                   <a:latin typeface="Ramabhadra" panose="02000600000000000000" pitchFamily="2" charset="0"/>
                   <a:cs typeface="Ramabhadra" panose="02000600000000000000" pitchFamily="2" charset="0"/>
                 </a:rPr>
-                <a:t>తేజస్సుతో నివసించు నా యేసయ్యా (2)</a:t>
-              </a:r>
-            </a:p>
-            <a:p>
-              <a:pPr defTabSz="439781">
-                <a:defRPr/>
-              </a:pPr>
-              <a:r>
-                <a:rPr lang="te-IN" sz="2200" dirty="0">
-                  <a:latin typeface="Ramabhadra" panose="02000600000000000000" pitchFamily="2" charset="0"/>
-                  <a:cs typeface="Ramabhadra" panose="02000600000000000000" pitchFamily="2" charset="0"/>
-                </a:rPr>
-                <a:t>నీ మహిమను ధరించిన పరిశుద్ధులు</a:t>
-              </a:r>
-            </a:p>
-            <a:p>
-              <a:pPr defTabSz="439781">
-                <a:defRPr/>
-              </a:pPr>
-              <a:r>
-                <a:rPr lang="te-IN" sz="2200" dirty="0">
-                  <a:latin typeface="Ramabhadra" panose="02000600000000000000" pitchFamily="2" charset="0"/>
-                  <a:cs typeface="Ramabhadra" panose="02000600000000000000" pitchFamily="2" charset="0"/>
-                </a:rPr>
-                <a:t>నా కంటబడగానే (2)</a:t>
-              </a:r>
-            </a:p>
-            <a:p>
-              <a:pPr defTabSz="439781">
-                <a:defRPr/>
-              </a:pPr>
-              <a:r>
-                <a:rPr lang="te-IN" sz="2200" dirty="0">
-                  <a:latin typeface="Ramabhadra" panose="02000600000000000000" pitchFamily="2" charset="0"/>
-                  <a:cs typeface="Ramabhadra" panose="02000600000000000000" pitchFamily="2" charset="0"/>
-                </a:rPr>
-                <a:t>ఏమౌదునో నేనేమౌదునో (2)</a:t>
+                <a:t>విశ్వమంతా నీ నామము ఘణనీయము (2)</a:t>
               </a:r>
             </a:p>
             <a:p>
@@ -4328,11 +4360,18 @@
                 <a:defRPr/>
               </a:pPr>
               <a:r>
+                <a:rPr lang="en-IN" sz="2200" dirty="0">
+                  <a:latin typeface="Ramabhadra" panose="02000600000000000000" pitchFamily="2" charset="0"/>
+                  <a:cs typeface="Ramabhadra" panose="02000600000000000000" pitchFamily="2" charset="0"/>
+                </a:rPr>
+                <a:t>1. </a:t>
+              </a:r>
+              <a:r>
                 <a:rPr lang="te-IN" sz="2200" dirty="0">
                   <a:latin typeface="Ramabhadra" panose="02000600000000000000" pitchFamily="2" charset="0"/>
                   <a:cs typeface="Ramabhadra" panose="02000600000000000000" pitchFamily="2" charset="0"/>
                 </a:rPr>
-                <a:t>ఇహలోక బంధాలు మరచి</a:t>
+                <a:t>నీవు కనిపించని రోజున</a:t>
               </a:r>
             </a:p>
             <a:p>
@@ -4344,7 +4383,7 @@
                   <a:latin typeface="Ramabhadra" panose="02000600000000000000" pitchFamily="2" charset="0"/>
                   <a:cs typeface="Ramabhadra" panose="02000600000000000000" pitchFamily="2" charset="0"/>
                 </a:rPr>
-                <a:t>నీ యెదుటే నేను నిలిచి (2)</a:t>
+                <a:t>ఒక క్షణమొక యుగముగా మారెనే (2)</a:t>
               </a:r>
             </a:p>
             <a:p>
@@ -4356,7 +4395,7 @@
                   <a:latin typeface="Ramabhadra" panose="02000600000000000000" pitchFamily="2" charset="0"/>
                   <a:cs typeface="Ramabhadra" panose="02000600000000000000" pitchFamily="2" charset="0"/>
                 </a:rPr>
-                <a:t>నీవిచ్చు బహుమతులు నే స్వీకరించి</a:t>
+                <a:t>నీవు నడిపించిన రోజున</a:t>
               </a:r>
             </a:p>
             <a:p>
@@ -4368,7 +4407,19 @@
                   <a:latin typeface="Ramabhadra" panose="02000600000000000000" pitchFamily="2" charset="0"/>
                   <a:cs typeface="Ramabhadra" panose="02000600000000000000" pitchFamily="2" charset="0"/>
                 </a:rPr>
-                <a:t>నిత్యానందముతో పరవశించు వేళ (2)</a:t>
+                <a:t>యుగయుగాల తలపు మది నిండెనే (2)</a:t>
+              </a:r>
+            </a:p>
+            <a:p>
+              <a:pPr defTabSz="439781">
+                <a:defRPr/>
+              </a:pPr>
+              <a:r>
+                <a:rPr lang="te-IN" sz="2200" dirty="0">
+                  <a:latin typeface="Ramabhadra" panose="02000600000000000000" pitchFamily="2" charset="0"/>
+                  <a:cs typeface="Ramabhadra" panose="02000600000000000000" pitchFamily="2" charset="0"/>
+                </a:rPr>
+                <a:t>యుగయుగాల తలపు మది నిండెనే</a:t>
               </a:r>
             </a:p>
             <a:p>
@@ -4385,11 +4436,18 @@
                 <a:defRPr/>
               </a:pPr>
               <a:r>
+                <a:rPr lang="en-IN" sz="2200" dirty="0">
+                  <a:latin typeface="Ramabhadra" panose="02000600000000000000" pitchFamily="2" charset="0"/>
+                  <a:cs typeface="Ramabhadra" panose="02000600000000000000" pitchFamily="2" charset="0"/>
+                </a:rPr>
+                <a:t>2. </a:t>
+              </a:r>
+              <a:r>
                 <a:rPr lang="te-IN" sz="2200" dirty="0">
                   <a:latin typeface="Ramabhadra" panose="02000600000000000000" pitchFamily="2" charset="0"/>
                   <a:cs typeface="Ramabhadra" panose="02000600000000000000" pitchFamily="2" charset="0"/>
                 </a:rPr>
-                <a:t>పరలోక మహిమను తలచి</a:t>
+                <a:t>నీవు మాట్లాడని రోజున</a:t>
               </a:r>
             </a:p>
             <a:p>
@@ -4401,7 +4459,7 @@
                   <a:latin typeface="Ramabhadra" panose="02000600000000000000" pitchFamily="2" charset="0"/>
                   <a:cs typeface="Ramabhadra" panose="02000600000000000000" pitchFamily="2" charset="0"/>
                 </a:rPr>
-                <a:t>నీ పాద పద్మములపై ఒరిగి (2)</a:t>
+                <a:t>నా కనులకు నిద్దుర కరువాయెనే (2)</a:t>
               </a:r>
             </a:p>
             <a:p>
@@ -4413,7 +4471,7 @@
                   <a:latin typeface="Ramabhadra" panose="02000600000000000000" pitchFamily="2" charset="0"/>
                   <a:cs typeface="Ramabhadra" panose="02000600000000000000" pitchFamily="2" charset="0"/>
                 </a:rPr>
-                <a:t>పరలోక సైన్య సమూహాలతో కలసి</a:t>
+                <a:t>నీవు పెదవిప్పిన రోజున</a:t>
               </a:r>
             </a:p>
             <a:p>
@@ -4425,7 +4483,19 @@
                   <a:latin typeface="Ramabhadra" panose="02000600000000000000" pitchFamily="2" charset="0"/>
                   <a:cs typeface="Ramabhadra" panose="02000600000000000000" pitchFamily="2" charset="0"/>
                 </a:rPr>
-                <a:t>నిత్యారాధన నే చేయు ప్రశాంత వేళ (2)</a:t>
+                <a:t>నీ సన్నిధి పచ్చిక బయలాయెనే (2)</a:t>
+              </a:r>
+            </a:p>
+            <a:p>
+              <a:pPr defTabSz="439781">
+                <a:defRPr/>
+              </a:pPr>
+              <a:r>
+                <a:rPr lang="te-IN" sz="2200" dirty="0">
+                  <a:latin typeface="Ramabhadra" panose="02000600000000000000" pitchFamily="2" charset="0"/>
+                  <a:cs typeface="Ramabhadra" panose="02000600000000000000" pitchFamily="2" charset="0"/>
+                </a:rPr>
+                <a:t>నీ సన్నిధి పచ్చిక బయలాయెనే</a:t>
               </a:r>
             </a:p>
           </p:txBody>

</xml_diff>

<commit_message>
24 sunday songs nov
</commit_message>
<xml_diff>
--- a/songsTemplate.pptx
+++ b/songsTemplate.pptx
@@ -255,7 +255,7 @@
           <a:p>
             <a:fld id="{F1102B08-ED9E-409F-B95F-09CAA1DAF6E0}" type="datetimeFigureOut">
               <a:rPr lang="en-IN" smtClean="0"/>
-              <a:t>16-11-2024</a:t>
+              <a:t>23-11-2024</a:t>
             </a:fld>
             <a:endParaRPr lang="en-IN"/>
           </a:p>
@@ -425,7 +425,7 @@
           <a:p>
             <a:fld id="{F1102B08-ED9E-409F-B95F-09CAA1DAF6E0}" type="datetimeFigureOut">
               <a:rPr lang="en-IN" smtClean="0"/>
-              <a:t>16-11-2024</a:t>
+              <a:t>23-11-2024</a:t>
             </a:fld>
             <a:endParaRPr lang="en-IN"/>
           </a:p>
@@ -605,7 +605,7 @@
           <a:p>
             <a:fld id="{F1102B08-ED9E-409F-B95F-09CAA1DAF6E0}" type="datetimeFigureOut">
               <a:rPr lang="en-IN" smtClean="0"/>
-              <a:t>16-11-2024</a:t>
+              <a:t>23-11-2024</a:t>
             </a:fld>
             <a:endParaRPr lang="en-IN"/>
           </a:p>
@@ -775,7 +775,7 @@
           <a:p>
             <a:fld id="{F1102B08-ED9E-409F-B95F-09CAA1DAF6E0}" type="datetimeFigureOut">
               <a:rPr lang="en-IN" smtClean="0"/>
-              <a:t>16-11-2024</a:t>
+              <a:t>23-11-2024</a:t>
             </a:fld>
             <a:endParaRPr lang="en-IN"/>
           </a:p>
@@ -1019,7 +1019,7 @@
           <a:p>
             <a:fld id="{F1102B08-ED9E-409F-B95F-09CAA1DAF6E0}" type="datetimeFigureOut">
               <a:rPr lang="en-IN" smtClean="0"/>
-              <a:t>16-11-2024</a:t>
+              <a:t>23-11-2024</a:t>
             </a:fld>
             <a:endParaRPr lang="en-IN"/>
           </a:p>
@@ -1251,7 +1251,7 @@
           <a:p>
             <a:fld id="{F1102B08-ED9E-409F-B95F-09CAA1DAF6E0}" type="datetimeFigureOut">
               <a:rPr lang="en-IN" smtClean="0"/>
-              <a:t>16-11-2024</a:t>
+              <a:t>23-11-2024</a:t>
             </a:fld>
             <a:endParaRPr lang="en-IN"/>
           </a:p>
@@ -1618,7 +1618,7 @@
           <a:p>
             <a:fld id="{F1102B08-ED9E-409F-B95F-09CAA1DAF6E0}" type="datetimeFigureOut">
               <a:rPr lang="en-IN" smtClean="0"/>
-              <a:t>16-11-2024</a:t>
+              <a:t>23-11-2024</a:t>
             </a:fld>
             <a:endParaRPr lang="en-IN"/>
           </a:p>
@@ -1736,7 +1736,7 @@
           <a:p>
             <a:fld id="{F1102B08-ED9E-409F-B95F-09CAA1DAF6E0}" type="datetimeFigureOut">
               <a:rPr lang="en-IN" smtClean="0"/>
-              <a:t>16-11-2024</a:t>
+              <a:t>23-11-2024</a:t>
             </a:fld>
             <a:endParaRPr lang="en-IN"/>
           </a:p>
@@ -1831,7 +1831,7 @@
           <a:p>
             <a:fld id="{F1102B08-ED9E-409F-B95F-09CAA1DAF6E0}" type="datetimeFigureOut">
               <a:rPr lang="en-IN" smtClean="0"/>
-              <a:t>16-11-2024</a:t>
+              <a:t>23-11-2024</a:t>
             </a:fld>
             <a:endParaRPr lang="en-IN"/>
           </a:p>
@@ -2108,7 +2108,7 @@
           <a:p>
             <a:fld id="{F1102B08-ED9E-409F-B95F-09CAA1DAF6E0}" type="datetimeFigureOut">
               <a:rPr lang="en-IN" smtClean="0"/>
-              <a:t>16-11-2024</a:t>
+              <a:t>23-11-2024</a:t>
             </a:fld>
             <a:endParaRPr lang="en-IN"/>
           </a:p>
@@ -2365,7 +2365,7 @@
           <a:p>
             <a:fld id="{F1102B08-ED9E-409F-B95F-09CAA1DAF6E0}" type="datetimeFigureOut">
               <a:rPr lang="en-IN" smtClean="0"/>
-              <a:t>16-11-2024</a:t>
+              <a:t>23-11-2024</a:t>
             </a:fld>
             <a:endParaRPr lang="en-IN"/>
           </a:p>
@@ -2578,7 +2578,7 @@
           <a:p>
             <a:fld id="{F1102B08-ED9E-409F-B95F-09CAA1DAF6E0}" type="datetimeFigureOut">
               <a:rPr lang="en-IN" smtClean="0"/>
-              <a:t>16-11-2024</a:t>
+              <a:t>23-11-2024</a:t>
             </a:fld>
             <a:endParaRPr lang="en-IN"/>
           </a:p>
@@ -2998,9 +2998,9 @@
         <p:grpSpPr>
           <a:xfrm>
             <a:off x="160868" y="182032"/>
-            <a:ext cx="5398025" cy="6493935"/>
+            <a:ext cx="5236140" cy="6493935"/>
             <a:chOff x="160868" y="182032"/>
-            <a:chExt cx="5398025" cy="6493935"/>
+            <a:chExt cx="5236140" cy="6493935"/>
           </a:xfrm>
         </p:grpSpPr>
         <p:sp>
@@ -3072,8 +3072,8 @@
           </p:nvSpPr>
           <p:spPr>
             <a:xfrm>
-              <a:off x="445483" y="768681"/>
-              <a:ext cx="5113410" cy="4893647"/>
+              <a:off x="283598" y="241491"/>
+              <a:ext cx="5113410" cy="6370975"/>
             </a:xfrm>
             <a:prstGeom prst="rect">
               <a:avLst/>
@@ -3094,7 +3094,20 @@
                   <a:latin typeface="Ramabhadra" panose="02000600000000000000" pitchFamily="2" charset="0"/>
                   <a:cs typeface="Ramabhadra" panose="02000600000000000000" pitchFamily="2" charset="0"/>
                 </a:rPr>
-                <a:t>సన్నుతించెదను - దయాళుడవు నీవని</a:t>
+                <a:t>ఉత్సాహ గానము చేసెదము</a:t>
+              </a:r>
+              <a:br>
+                <a:rPr lang="te-IN" sz="2400" dirty="0">
+                  <a:latin typeface="Ramabhadra" panose="02000600000000000000" pitchFamily="2" charset="0"/>
+                  <a:cs typeface="Ramabhadra" panose="02000600000000000000" pitchFamily="2" charset="0"/>
+                </a:rPr>
+              </a:br>
+              <a:r>
+                <a:rPr lang="te-IN" sz="2400" dirty="0">
+                  <a:latin typeface="Ramabhadra" panose="02000600000000000000" pitchFamily="2" charset="0"/>
+                  <a:cs typeface="Ramabhadra" panose="02000600000000000000" pitchFamily="2" charset="0"/>
+                </a:rPr>
+                <a:t>ఘనపరచెదము మన </a:t>
               </a:r>
             </a:p>
             <a:p>
@@ -3106,23 +3119,59 @@
                   <a:latin typeface="Ramabhadra" panose="02000600000000000000" pitchFamily="2" charset="0"/>
                   <a:cs typeface="Ramabhadra" panose="02000600000000000000" pitchFamily="2" charset="0"/>
                 </a:rPr>
-                <a:t>యెహోవా నీవే దయాళుడవని</a:t>
-              </a:r>
-              <a:endParaRPr lang="en-IN" sz="2400" dirty="0">
-                <a:latin typeface="Ramabhadra" panose="02000600000000000000" pitchFamily="2" charset="0"/>
-                <a:cs typeface="Ramabhadra" panose="02000600000000000000" pitchFamily="2" charset="0"/>
-              </a:endParaRPr>
-            </a:p>
-            <a:p>
-              <a:pPr defTabSz="439781">
-                <a:defRPr/>
-              </a:pPr>
-              <a:r>
+                <a:t>యేసయ్య నామమును (2)</a:t>
+              </a:r>
+              <a:br>
                 <a:rPr lang="te-IN" sz="2400" dirty="0">
                   <a:latin typeface="Ramabhadra" panose="02000600000000000000" pitchFamily="2" charset="0"/>
                   <a:cs typeface="Ramabhadra" panose="02000600000000000000" pitchFamily="2" charset="0"/>
                 </a:rPr>
-                <a:t>నిను సన్నుతించెదను - 2</a:t>
+              </a:br>
+              <a:r>
+                <a:rPr lang="te-IN" sz="2400" dirty="0">
+                  <a:latin typeface="Ramabhadra" panose="02000600000000000000" pitchFamily="2" charset="0"/>
+                  <a:cs typeface="Ramabhadra" panose="02000600000000000000" pitchFamily="2" charset="0"/>
+                </a:rPr>
+                <a:t>హల్లెలూయ యెహోవ రాఫా</a:t>
+              </a:r>
+              <a:br>
+                <a:rPr lang="te-IN" sz="2400" dirty="0">
+                  <a:latin typeface="Ramabhadra" panose="02000600000000000000" pitchFamily="2" charset="0"/>
+                  <a:cs typeface="Ramabhadra" panose="02000600000000000000" pitchFamily="2" charset="0"/>
+                </a:rPr>
+              </a:br>
+              <a:r>
+                <a:rPr lang="te-IN" sz="2400" dirty="0">
+                  <a:latin typeface="Ramabhadra" panose="02000600000000000000" pitchFamily="2" charset="0"/>
+                  <a:cs typeface="Ramabhadra" panose="02000600000000000000" pitchFamily="2" charset="0"/>
+                </a:rPr>
+                <a:t>హల్లెలూయ యెహోవ షమ్మా</a:t>
+              </a:r>
+              <a:br>
+                <a:rPr lang="te-IN" sz="2400" dirty="0">
+                  <a:latin typeface="Ramabhadra" panose="02000600000000000000" pitchFamily="2" charset="0"/>
+                  <a:cs typeface="Ramabhadra" panose="02000600000000000000" pitchFamily="2" charset="0"/>
+                </a:rPr>
+              </a:br>
+              <a:r>
+                <a:rPr lang="te-IN" sz="2400" dirty="0">
+                  <a:latin typeface="Ramabhadra" panose="02000600000000000000" pitchFamily="2" charset="0"/>
+                  <a:cs typeface="Ramabhadra" panose="02000600000000000000" pitchFamily="2" charset="0"/>
+                </a:rPr>
+                <a:t>హల్లెలూయ యెహోవ ఈరే</a:t>
+              </a:r>
+              <a:br>
+                <a:rPr lang="te-IN" sz="2400" dirty="0">
+                  <a:latin typeface="Ramabhadra" panose="02000600000000000000" pitchFamily="2" charset="0"/>
+                  <a:cs typeface="Ramabhadra" panose="02000600000000000000" pitchFamily="2" charset="0"/>
+                </a:rPr>
+              </a:br>
+              <a:r>
+                <a:rPr lang="te-IN" sz="2400" dirty="0">
+                  <a:latin typeface="Ramabhadra" panose="02000600000000000000" pitchFamily="2" charset="0"/>
+                  <a:cs typeface="Ramabhadra" panose="02000600000000000000" pitchFamily="2" charset="0"/>
+                </a:rPr>
+                <a:t>హల్లెలూయ యెహోవ షాలోమ్ (2)</a:t>
               </a:r>
             </a:p>
             <a:p>
@@ -3143,12 +3192,34 @@
                   <a:latin typeface="Ramabhadra" panose="02000600000000000000" pitchFamily="2" charset="0"/>
                   <a:cs typeface="Ramabhadra" panose="02000600000000000000" pitchFamily="2" charset="0"/>
                 </a:rPr>
-                <a:t>సర్వ సత్యములో నను నీవు నడిపి</a:t>
-              </a:r>
-              <a:endParaRPr lang="en-IN" sz="2400" dirty="0">
-                <a:latin typeface="Ramabhadra" panose="02000600000000000000" pitchFamily="2" charset="0"/>
-                <a:cs typeface="Ramabhadra" panose="02000600000000000000" pitchFamily="2" charset="0"/>
-              </a:endParaRPr>
+                <a:t>అమూల్యములైన వాగ్ధానములు</a:t>
+              </a:r>
+              <a:br>
+                <a:rPr lang="te-IN" sz="2400" dirty="0">
+                  <a:latin typeface="Ramabhadra" panose="02000600000000000000" pitchFamily="2" charset="0"/>
+                  <a:cs typeface="Ramabhadra" panose="02000600000000000000" pitchFamily="2" charset="0"/>
+                </a:rPr>
+              </a:br>
+              <a:r>
+                <a:rPr lang="te-IN" sz="2400" dirty="0">
+                  <a:latin typeface="Ramabhadra" panose="02000600000000000000" pitchFamily="2" charset="0"/>
+                  <a:cs typeface="Ramabhadra" panose="02000600000000000000" pitchFamily="2" charset="0"/>
+                </a:rPr>
+                <a:t>అత్యధికముగా ఉన్నవి (2)</a:t>
+              </a:r>
+              <a:br>
+                <a:rPr lang="te-IN" sz="2400" dirty="0">
+                  <a:latin typeface="Ramabhadra" panose="02000600000000000000" pitchFamily="2" charset="0"/>
+                  <a:cs typeface="Ramabhadra" panose="02000600000000000000" pitchFamily="2" charset="0"/>
+                </a:rPr>
+              </a:br>
+              <a:r>
+                <a:rPr lang="te-IN" sz="2400" dirty="0">
+                  <a:latin typeface="Ramabhadra" panose="02000600000000000000" pitchFamily="2" charset="0"/>
+                  <a:cs typeface="Ramabhadra" panose="02000600000000000000" pitchFamily="2" charset="0"/>
+                </a:rPr>
+                <a:t>వాటిని మనము నమ్మినయెడల</a:t>
+              </a:r>
             </a:p>
             <a:p>
               <a:pPr defTabSz="439781">
@@ -3159,67 +3230,7 @@
                   <a:latin typeface="Ramabhadra" panose="02000600000000000000" pitchFamily="2" charset="0"/>
                   <a:cs typeface="Ramabhadra" panose="02000600000000000000" pitchFamily="2" charset="0"/>
                 </a:rPr>
-                <a:t>ఆదరించిన –</a:t>
-              </a:r>
-              <a:r>
-                <a:rPr lang="en-IN" sz="2400" dirty="0">
-                  <a:latin typeface="Ramabhadra" panose="02000600000000000000" pitchFamily="2" charset="0"/>
-                  <a:cs typeface="Ramabhadra" panose="02000600000000000000" pitchFamily="2" charset="0"/>
-                </a:rPr>
-                <a:t> </a:t>
-              </a:r>
-              <a:r>
-                <a:rPr lang="te-IN" sz="2400" dirty="0">
-                  <a:latin typeface="Ramabhadra" panose="02000600000000000000" pitchFamily="2" charset="0"/>
-                  <a:cs typeface="Ramabhadra" panose="02000600000000000000" pitchFamily="2" charset="0"/>
-                </a:rPr>
-                <a:t>పరిశుద్ధాత్ముడా</a:t>
-              </a:r>
-              <a:endParaRPr lang="en-IN" sz="2400" dirty="0">
-                <a:latin typeface="Ramabhadra" panose="02000600000000000000" pitchFamily="2" charset="0"/>
-                <a:cs typeface="Ramabhadra" panose="02000600000000000000" pitchFamily="2" charset="0"/>
-              </a:endParaRPr>
-            </a:p>
-            <a:p>
-              <a:pPr defTabSz="439781">
-                <a:defRPr/>
-              </a:pPr>
-              <a:r>
-                <a:rPr lang="te-IN" sz="2400" dirty="0">
-                  <a:latin typeface="Ramabhadra" panose="02000600000000000000" pitchFamily="2" charset="0"/>
-                  <a:cs typeface="Ramabhadra" panose="02000600000000000000" pitchFamily="2" charset="0"/>
-                </a:rPr>
-                <a:t>కృపాధారము నీవెగా –</a:t>
-              </a:r>
-              <a:r>
-                <a:rPr lang="en-IN" sz="2400" dirty="0">
-                  <a:latin typeface="Ramabhadra" panose="02000600000000000000" pitchFamily="2" charset="0"/>
-                  <a:cs typeface="Ramabhadra" panose="02000600000000000000" pitchFamily="2" charset="0"/>
-                </a:rPr>
-                <a:t> </a:t>
-              </a:r>
-              <a:r>
-                <a:rPr lang="te-IN" sz="2400" dirty="0">
-                  <a:latin typeface="Ramabhadra" panose="02000600000000000000" pitchFamily="2" charset="0"/>
-                  <a:cs typeface="Ramabhadra" panose="02000600000000000000" pitchFamily="2" charset="0"/>
-                </a:rPr>
-                <a:t>షాలేమురాజా</a:t>
-              </a:r>
-              <a:endParaRPr lang="en-IN" sz="2400" dirty="0">
-                <a:latin typeface="Ramabhadra" panose="02000600000000000000" pitchFamily="2" charset="0"/>
-                <a:cs typeface="Ramabhadra" panose="02000600000000000000" pitchFamily="2" charset="0"/>
-              </a:endParaRPr>
-            </a:p>
-            <a:p>
-              <a:pPr defTabSz="439781">
-                <a:defRPr/>
-              </a:pPr>
-              <a:r>
-                <a:rPr lang="te-IN" sz="2400" dirty="0">
-                  <a:latin typeface="Ramabhadra" panose="02000600000000000000" pitchFamily="2" charset="0"/>
-                  <a:cs typeface="Ramabhadra" panose="02000600000000000000" pitchFamily="2" charset="0"/>
-                </a:rPr>
-                <a:t>నిను సన్మానించెదను</a:t>
+                <a:t>దేవుని మహిమను ఆనుభవించెదము (2)</a:t>
               </a:r>
             </a:p>
             <a:p>
@@ -3240,7 +3251,7 @@
                   <a:latin typeface="Ramabhadra" panose="02000600000000000000" pitchFamily="2" charset="0"/>
                   <a:cs typeface="Ramabhadra" panose="02000600000000000000" pitchFamily="2" charset="0"/>
                 </a:rPr>
-                <a:t>నీ కను చూపుల పరిధిలోనన్ను నిలిపి</a:t>
+                <a:t>ఆత్మీయ ఆరాధనలు జరుగుచున్నవి </a:t>
               </a:r>
             </a:p>
             <a:p>
@@ -3252,7 +3263,7 @@
                   <a:latin typeface="Ramabhadra" panose="02000600000000000000" pitchFamily="2" charset="0"/>
                   <a:cs typeface="Ramabhadra" panose="02000600000000000000" pitchFamily="2" charset="0"/>
                 </a:rPr>
-                <a:t>చూపితివా నీ వాత్సల్యమును</a:t>
+                <a:t>ఇవన్ని వాగ్ధాన ఫలములెగా </a:t>
               </a:r>
             </a:p>
             <a:p>
@@ -3264,12 +3275,8 @@
                   <a:latin typeface="Ramabhadra" panose="02000600000000000000" pitchFamily="2" charset="0"/>
                   <a:cs typeface="Ramabhadra" panose="02000600000000000000" pitchFamily="2" charset="0"/>
                 </a:rPr>
-                <a:t>కృపానిధివి నీవెగా - నా యేసురాజా</a:t>
-              </a:r>
-              <a:endParaRPr lang="en-IN" sz="2400" dirty="0">
-                <a:latin typeface="Ramabhadra" panose="02000600000000000000" pitchFamily="2" charset="0"/>
-                <a:cs typeface="Ramabhadra" panose="02000600000000000000" pitchFamily="2" charset="0"/>
-              </a:endParaRPr>
+                <a:t>అత్మాభిషేకము సమృద్ధిగా పొంది </a:t>
+              </a:r>
             </a:p>
             <a:p>
               <a:pPr defTabSz="439781">
@@ -3280,7 +3287,7 @@
                   <a:latin typeface="Ramabhadra" panose="02000600000000000000" pitchFamily="2" charset="0"/>
                   <a:cs typeface="Ramabhadra" panose="02000600000000000000" pitchFamily="2" charset="0"/>
                 </a:rPr>
-                <a:t>నిను సన్మానించెదను</a:t>
+                <a:t>ఆత్మీయ వరములు అనుభవించెదము (2)</a:t>
               </a:r>
             </a:p>
           </p:txBody>
@@ -3299,7 +3306,7 @@
           </p:nvSpPr>
           <p:spPr>
             <a:xfrm>
-              <a:off x="369283" y="326430"/>
+              <a:off x="4237077" y="320474"/>
               <a:ext cx="390525" cy="390525"/>
             </a:xfrm>
             <a:prstGeom prst="ellipse">
@@ -3363,9 +3370,9 @@
         <p:grpSpPr>
           <a:xfrm>
             <a:off x="5104338" y="182031"/>
-            <a:ext cx="4881562" cy="6493935"/>
+            <a:ext cx="4738425" cy="6493935"/>
             <a:chOff x="160868" y="182032"/>
-            <a:chExt cx="4881562" cy="6493935"/>
+            <a:chExt cx="4738425" cy="6493935"/>
           </a:xfrm>
         </p:grpSpPr>
         <p:sp>
@@ -3437,8 +3444,8 @@
           </p:nvSpPr>
           <p:spPr>
             <a:xfrm>
-              <a:off x="501124" y="653009"/>
-              <a:ext cx="4541306" cy="6001643"/>
+              <a:off x="357987" y="391483"/>
+              <a:ext cx="4541306" cy="5909310"/>
             </a:xfrm>
             <a:prstGeom prst="rect">
               <a:avLst/>
@@ -3452,151 +3459,122 @@
             <a:lstStyle/>
             <a:p>
               <a:r>
-                <a:rPr lang="te-IN" sz="2400" dirty="0">
-                  <a:latin typeface="Ramabhadra" panose="02000600000000000000" pitchFamily="2" charset="0"/>
-                  <a:cs typeface="Ramabhadra" panose="02000600000000000000" pitchFamily="2" charset="0"/>
-                </a:rPr>
-                <a:t>కృపామయుడా – నీలోనా (2)</a:t>
-              </a:r>
-            </a:p>
-            <a:p>
-              <a:r>
-                <a:rPr lang="te-IN" sz="2400" dirty="0">
-                  <a:latin typeface="Ramabhadra" panose="02000600000000000000" pitchFamily="2" charset="0"/>
-                  <a:cs typeface="Ramabhadra" panose="02000600000000000000" pitchFamily="2" charset="0"/>
-                </a:rPr>
-                <a:t>నివసింప జేసినందున</a:t>
-              </a:r>
-            </a:p>
-            <a:p>
-              <a:r>
-                <a:rPr lang="te-IN" sz="2400" dirty="0">
-                  <a:latin typeface="Ramabhadra" panose="02000600000000000000" pitchFamily="2" charset="0"/>
-                  <a:cs typeface="Ramabhadra" panose="02000600000000000000" pitchFamily="2" charset="0"/>
-                </a:rPr>
-                <a:t>ఇదిగో నా స్తుతుల సింహాసనం</a:t>
-              </a:r>
-            </a:p>
-            <a:p>
-              <a:r>
-                <a:rPr lang="te-IN" sz="2400" dirty="0">
-                  <a:latin typeface="Ramabhadra" panose="02000600000000000000" pitchFamily="2" charset="0"/>
-                  <a:cs typeface="Ramabhadra" panose="02000600000000000000" pitchFamily="2" charset="0"/>
-                </a:rPr>
-                <a:t>నీలో నివసింప జేసినందునా</a:t>
-              </a:r>
-            </a:p>
-            <a:p>
-              <a:r>
-                <a:rPr lang="te-IN" sz="2400" dirty="0">
-                  <a:latin typeface="Ramabhadra" panose="02000600000000000000" pitchFamily="2" charset="0"/>
-                  <a:cs typeface="Ramabhadra" panose="02000600000000000000" pitchFamily="2" charset="0"/>
-                </a:rPr>
-                <a:t>ఇదిగో నా స్తుతుల సింహాసనం</a:t>
-              </a:r>
-            </a:p>
-            <a:p>
-              <a:r>
-                <a:rPr lang="te-IN" sz="2400" dirty="0">
-                  <a:latin typeface="Ramabhadra" panose="02000600000000000000" pitchFamily="2" charset="0"/>
-                  <a:cs typeface="Ramabhadra" panose="02000600000000000000" pitchFamily="2" charset="0"/>
-                </a:rPr>
-                <a:t>కృపామయుడా</a:t>
-              </a:r>
-              <a:r>
-                <a:rPr lang="en-IN" sz="2400" dirty="0">
-                  <a:latin typeface="Ramabhadra" panose="02000600000000000000" pitchFamily="2" charset="0"/>
-                  <a:cs typeface="Ramabhadra" panose="02000600000000000000" pitchFamily="2" charset="0"/>
-                </a:rPr>
-                <a:t>...</a:t>
-              </a:r>
-              <a:endParaRPr lang="te-IN" sz="2400" dirty="0">
+                <a:rPr lang="te-IN" sz="2700" dirty="0">
+                  <a:latin typeface="Ramabhadra" panose="02000600000000000000" pitchFamily="2" charset="0"/>
+                  <a:cs typeface="Ramabhadra" panose="02000600000000000000" pitchFamily="2" charset="0"/>
+                </a:rPr>
+                <a:t>ప్రేమించెదన్ అధికముగా</a:t>
+              </a:r>
+            </a:p>
+            <a:p>
+              <a:r>
+                <a:rPr lang="te-IN" sz="2700" dirty="0">
+                  <a:latin typeface="Ramabhadra" panose="02000600000000000000" pitchFamily="2" charset="0"/>
+                  <a:cs typeface="Ramabhadra" panose="02000600000000000000" pitchFamily="2" charset="0"/>
+                </a:rPr>
+                <a:t>ఆరాధింతున్ ఆసక్తితో (2)</a:t>
+              </a:r>
+            </a:p>
+            <a:p>
+              <a:r>
+                <a:rPr lang="te-IN" sz="2700" dirty="0">
+                  <a:latin typeface="Ramabhadra" panose="02000600000000000000" pitchFamily="2" charset="0"/>
+                  <a:cs typeface="Ramabhadra" panose="02000600000000000000" pitchFamily="2" charset="0"/>
+                </a:rPr>
+                <a:t>నిన్ను పూర్ణ మనసుతో ఆరాధింతున్</a:t>
+              </a:r>
+            </a:p>
+            <a:p>
+              <a:r>
+                <a:rPr lang="te-IN" sz="2700" dirty="0">
+                  <a:latin typeface="Ramabhadra" panose="02000600000000000000" pitchFamily="2" charset="0"/>
+                  <a:cs typeface="Ramabhadra" panose="02000600000000000000" pitchFamily="2" charset="0"/>
+                </a:rPr>
+                <a:t>పూర్ణ బలముతో ప్రేమించెదన్</a:t>
+              </a:r>
+            </a:p>
+            <a:p>
+              <a:r>
+                <a:rPr lang="te-IN" sz="2700" dirty="0">
+                  <a:latin typeface="Ramabhadra" panose="02000600000000000000" pitchFamily="2" charset="0"/>
+                  <a:cs typeface="Ramabhadra" panose="02000600000000000000" pitchFamily="2" charset="0"/>
+                </a:rPr>
+                <a:t>ఆరాధన ఆరాధనా ఆ.. ఆ.. </a:t>
+              </a:r>
+            </a:p>
+            <a:p>
+              <a:r>
+                <a:rPr lang="te-IN" sz="2700" dirty="0">
+                  <a:latin typeface="Ramabhadra" panose="02000600000000000000" pitchFamily="2" charset="0"/>
+                  <a:cs typeface="Ramabhadra" panose="02000600000000000000" pitchFamily="2" charset="0"/>
+                </a:rPr>
+                <a:t>ఆరాధన ఆరాధనా (2)</a:t>
+              </a:r>
+            </a:p>
+            <a:p>
+              <a:endParaRPr lang="te-IN" sz="2700" dirty="0">
                 <a:latin typeface="Ramabhadra" panose="02000600000000000000" pitchFamily="2" charset="0"/>
                 <a:cs typeface="Ramabhadra" panose="02000600000000000000" pitchFamily="2" charset="0"/>
               </a:endParaRPr>
             </a:p>
             <a:p>
-              <a:endParaRPr lang="te-IN" sz="2400" dirty="0">
+              <a:r>
+                <a:rPr lang="te-IN" sz="2700" dirty="0">
+                  <a:latin typeface="Ramabhadra" panose="02000600000000000000" pitchFamily="2" charset="0"/>
+                  <a:cs typeface="Ramabhadra" panose="02000600000000000000" pitchFamily="2" charset="0"/>
+                </a:rPr>
+                <a:t>ఎబినేజరే ఎబినేజరే</a:t>
+              </a:r>
+            </a:p>
+            <a:p>
+              <a:r>
+                <a:rPr lang="te-IN" sz="2700" dirty="0">
+                  <a:latin typeface="Ramabhadra" panose="02000600000000000000" pitchFamily="2" charset="0"/>
+                  <a:cs typeface="Ramabhadra" panose="02000600000000000000" pitchFamily="2" charset="0"/>
+                </a:rPr>
+                <a:t>ఇంత వరకు ఆదుకొన్నావే (2)</a:t>
+              </a:r>
+            </a:p>
+            <a:p>
+              <a:r>
+                <a:rPr lang="te-IN" sz="2700" dirty="0">
+                  <a:latin typeface="Ramabhadra" panose="02000600000000000000" pitchFamily="2" charset="0"/>
+                  <a:cs typeface="Ramabhadra" panose="02000600000000000000" pitchFamily="2" charset="0"/>
+                </a:rPr>
+                <a:t>నన్ను ఇంత వరకు ఆదుకొన్నావే</a:t>
+              </a:r>
+            </a:p>
+            <a:p>
+              <a:endParaRPr lang="te-IN" sz="2700" dirty="0">
                 <a:latin typeface="Ramabhadra" panose="02000600000000000000" pitchFamily="2" charset="0"/>
                 <a:cs typeface="Ramabhadra" panose="02000600000000000000" pitchFamily="2" charset="0"/>
               </a:endParaRPr>
             </a:p>
             <a:p>
               <a:r>
-                <a:rPr lang="te-IN" sz="2400" dirty="0">
-                  <a:latin typeface="Ramabhadra" panose="02000600000000000000" pitchFamily="2" charset="0"/>
-                  <a:cs typeface="Ramabhadra" panose="02000600000000000000" pitchFamily="2" charset="0"/>
-                </a:rPr>
-                <a:t>ఏ అపాయము నా గుడారము</a:t>
-              </a:r>
-            </a:p>
-            <a:p>
-              <a:r>
-                <a:rPr lang="te-IN" sz="2400" dirty="0">
-                  <a:latin typeface="Ramabhadra" panose="02000600000000000000" pitchFamily="2" charset="0"/>
-                  <a:cs typeface="Ramabhadra" panose="02000600000000000000" pitchFamily="2" charset="0"/>
-                </a:rPr>
-                <a:t>సమీపించనీయక (2)</a:t>
-              </a:r>
-            </a:p>
-            <a:p>
-              <a:r>
-                <a:rPr lang="te-IN" sz="2400" dirty="0">
-                  <a:latin typeface="Ramabhadra" panose="02000600000000000000" pitchFamily="2" charset="0"/>
-                  <a:cs typeface="Ramabhadra" panose="02000600000000000000" pitchFamily="2" charset="0"/>
-                </a:rPr>
-                <a:t>నా మార్గములన్నిటిలో</a:t>
-              </a:r>
-            </a:p>
-            <a:p>
-              <a:r>
-                <a:rPr lang="te-IN" sz="2400" dirty="0">
-                  <a:latin typeface="Ramabhadra" panose="02000600000000000000" pitchFamily="2" charset="0"/>
-                  <a:cs typeface="Ramabhadra" panose="02000600000000000000" pitchFamily="2" charset="0"/>
-                </a:rPr>
-                <a:t>నీవే ఆశ్రయమైనందున (2)</a:t>
-              </a:r>
-            </a:p>
-            <a:p>
-              <a:endParaRPr lang="te-IN" sz="2400" dirty="0">
-                <a:latin typeface="Ramabhadra" panose="02000600000000000000" pitchFamily="2" charset="0"/>
-                <a:cs typeface="Ramabhadra" panose="02000600000000000000" pitchFamily="2" charset="0"/>
-              </a:endParaRPr>
-            </a:p>
-            <a:p>
-              <a:r>
-                <a:rPr lang="te-IN" sz="2400" dirty="0">
-                  <a:latin typeface="Ramabhadra" panose="02000600000000000000" pitchFamily="2" charset="0"/>
-                  <a:cs typeface="Ramabhadra" panose="02000600000000000000" pitchFamily="2" charset="0"/>
-                </a:rPr>
-                <a:t>చీకటి నుండి వెలుగులోనికి</a:t>
-              </a:r>
-            </a:p>
-            <a:p>
-              <a:r>
-                <a:rPr lang="te-IN" sz="2400" dirty="0">
-                  <a:latin typeface="Ramabhadra" panose="02000600000000000000" pitchFamily="2" charset="0"/>
-                  <a:cs typeface="Ramabhadra" panose="02000600000000000000" pitchFamily="2" charset="0"/>
-                </a:rPr>
-                <a:t>నన్ను పిలచిన తేజోమయా (2)</a:t>
-              </a:r>
-            </a:p>
-            <a:p>
-              <a:r>
-                <a:rPr lang="te-IN" sz="2400" dirty="0">
-                  <a:latin typeface="Ramabhadra" panose="02000600000000000000" pitchFamily="2" charset="0"/>
-                  <a:cs typeface="Ramabhadra" panose="02000600000000000000" pitchFamily="2" charset="0"/>
-                </a:rPr>
-                <a:t>రాజవంశములో</a:t>
-              </a:r>
-            </a:p>
-            <a:p>
-              <a:r>
-                <a:rPr lang="te-IN" sz="2400" dirty="0">
-                  <a:latin typeface="Ramabhadra" panose="02000600000000000000" pitchFamily="2" charset="0"/>
-                  <a:cs typeface="Ramabhadra" panose="02000600000000000000" pitchFamily="2" charset="0"/>
-                </a:rPr>
-                <a:t>యాజకత్వము చేసెదను (2)</a:t>
+                <a:rPr lang="te-IN" sz="2700" dirty="0">
+                  <a:latin typeface="Ramabhadra" panose="02000600000000000000" pitchFamily="2" charset="0"/>
+                  <a:cs typeface="Ramabhadra" panose="02000600000000000000" pitchFamily="2" charset="0"/>
+                </a:rPr>
+                <a:t>ఎల్రోహి ఎల్రోహి</a:t>
+              </a:r>
+            </a:p>
+            <a:p>
+              <a:r>
+                <a:rPr lang="te-IN" sz="2700" dirty="0">
+                  <a:latin typeface="Ramabhadra" panose="02000600000000000000" pitchFamily="2" charset="0"/>
+                  <a:cs typeface="Ramabhadra" panose="02000600000000000000" pitchFamily="2" charset="0"/>
+                </a:rPr>
+                <a:t>నన్ను చూచావే వందనమయ్యా (2)</a:t>
+              </a:r>
+            </a:p>
+            <a:p>
+              <a:r>
+                <a:rPr lang="te-IN" sz="2700" dirty="0">
+                  <a:latin typeface="Ramabhadra" panose="02000600000000000000" pitchFamily="2" charset="0"/>
+                  <a:cs typeface="Ramabhadra" panose="02000600000000000000" pitchFamily="2" charset="0"/>
+                </a:rPr>
+                <a:t>నన్ను చూచావే వందనమయ్యా</a:t>
               </a:r>
             </a:p>
           </p:txBody>
@@ -3615,7 +3593,7 @@
           </p:nvSpPr>
           <p:spPr>
             <a:xfrm>
-              <a:off x="343961" y="326430"/>
+              <a:off x="4224907" y="326430"/>
               <a:ext cx="390525" cy="390525"/>
             </a:xfrm>
             <a:prstGeom prst="ellipse">
@@ -3709,9 +3687,9 @@
         <p:grpSpPr>
           <a:xfrm>
             <a:off x="160868" y="182032"/>
-            <a:ext cx="5126563" cy="6493935"/>
+            <a:ext cx="4831293" cy="6493935"/>
             <a:chOff x="160868" y="182032"/>
-            <a:chExt cx="5126563" cy="6493935"/>
+            <a:chExt cx="4831293" cy="6493935"/>
           </a:xfrm>
         </p:grpSpPr>
         <p:sp>
@@ -3783,8 +3761,8 @@
           </p:nvSpPr>
           <p:spPr>
             <a:xfrm>
-              <a:off x="639231" y="701293"/>
-              <a:ext cx="4648200" cy="5847755"/>
+              <a:off x="343961" y="797508"/>
+              <a:ext cx="4648200" cy="5262979"/>
             </a:xfrm>
             <a:prstGeom prst="rect">
               <a:avLst/>
@@ -3801,11 +3779,11 @@
                 <a:defRPr/>
               </a:pPr>
               <a:r>
-                <a:rPr lang="te-IN" sz="2200" dirty="0">
-                  <a:latin typeface="Ramabhadra" panose="02000600000000000000" pitchFamily="2" charset="0"/>
-                  <a:cs typeface="Ramabhadra" panose="02000600000000000000" pitchFamily="2" charset="0"/>
-                </a:rPr>
-                <a:t>స్తుతి పాత్రుడా – స్తోత్రార్హుడా</a:t>
+                <a:rPr lang="te-IN" sz="2400" dirty="0">
+                  <a:latin typeface="Ramabhadra" panose="02000600000000000000" pitchFamily="2" charset="0"/>
+                  <a:cs typeface="Ramabhadra" panose="02000600000000000000" pitchFamily="2" charset="0"/>
+                </a:rPr>
+                <a:t>సుగుణాల సంపన్నుడా</a:t>
               </a:r>
             </a:p>
             <a:p>
@@ -3813,11 +3791,11 @@
                 <a:defRPr/>
               </a:pPr>
               <a:r>
-                <a:rPr lang="te-IN" sz="2200" dirty="0">
-                  <a:latin typeface="Ramabhadra" panose="02000600000000000000" pitchFamily="2" charset="0"/>
-                  <a:cs typeface="Ramabhadra" panose="02000600000000000000" pitchFamily="2" charset="0"/>
-                </a:rPr>
-                <a:t>స్తుతులందుకో - పూజార్హుడా</a:t>
+                <a:rPr lang="te-IN" sz="2400" dirty="0">
+                  <a:latin typeface="Ramabhadra" panose="02000600000000000000" pitchFamily="2" charset="0"/>
+                  <a:cs typeface="Ramabhadra" panose="02000600000000000000" pitchFamily="2" charset="0"/>
+                </a:rPr>
+                <a:t>స్తుతిగానాల వారసుడా</a:t>
               </a:r>
             </a:p>
             <a:p>
@@ -3825,13 +3803,30 @@
                 <a:defRPr/>
               </a:pPr>
               <a:r>
-                <a:rPr lang="te-IN" sz="2200" dirty="0">
-                  <a:latin typeface="Ramabhadra" panose="02000600000000000000" pitchFamily="2" charset="0"/>
-                  <a:cs typeface="Ramabhadra" panose="02000600000000000000" pitchFamily="2" charset="0"/>
-                </a:rPr>
-                <a:t>ఆకాశమందు నీవు తప్ప</a:t>
-              </a:r>
-              <a:endParaRPr lang="en-IN" sz="2200" dirty="0">
+                <a:rPr lang="te-IN" sz="2400" dirty="0">
+                  <a:latin typeface="Ramabhadra" panose="02000600000000000000" pitchFamily="2" charset="0"/>
+                  <a:cs typeface="Ramabhadra" panose="02000600000000000000" pitchFamily="2" charset="0"/>
+                </a:rPr>
+                <a:t>జీవింతును నిత్యము నీ నీడలో</a:t>
+              </a:r>
+            </a:p>
+            <a:p>
+              <a:pPr defTabSz="439781">
+                <a:defRPr/>
+              </a:pPr>
+              <a:r>
+                <a:rPr lang="te-IN" sz="2400" dirty="0">
+                  <a:latin typeface="Ramabhadra" panose="02000600000000000000" pitchFamily="2" charset="0"/>
+                  <a:cs typeface="Ramabhadra" panose="02000600000000000000" pitchFamily="2" charset="0"/>
+                </a:rPr>
+                <a:t>ఆస్వాదింతును నీ మాటల మకరందము</a:t>
+              </a:r>
+            </a:p>
+            <a:p>
+              <a:pPr defTabSz="439781">
+                <a:defRPr/>
+              </a:pPr>
+              <a:endParaRPr lang="te-IN" sz="2400" dirty="0">
                 <a:latin typeface="Ramabhadra" panose="02000600000000000000" pitchFamily="2" charset="0"/>
                 <a:cs typeface="Ramabhadra" panose="02000600000000000000" pitchFamily="2" charset="0"/>
               </a:endParaRPr>
@@ -3841,11 +3836,11 @@
                 <a:defRPr/>
               </a:pPr>
               <a:r>
-                <a:rPr lang="te-IN" sz="2200" dirty="0">
-                  <a:latin typeface="Ramabhadra" panose="02000600000000000000" pitchFamily="2" charset="0"/>
-                  <a:cs typeface="Ramabhadra" panose="02000600000000000000" pitchFamily="2" charset="0"/>
-                </a:rPr>
-                <a:t>నాకెవరున్నారు నా ప్రభు</a:t>
+                <a:rPr lang="te-IN" sz="2400" dirty="0">
+                  <a:latin typeface="Ramabhadra" panose="02000600000000000000" pitchFamily="2" charset="0"/>
+                  <a:cs typeface="Ramabhadra" panose="02000600000000000000" pitchFamily="2" charset="0"/>
+                </a:rPr>
+                <a:t>యేసయ్య నీతో జీవించగానే</a:t>
               </a:r>
             </a:p>
             <a:p>
@@ -3853,18 +3848,42 @@
                 <a:defRPr/>
               </a:pPr>
               <a:r>
-                <a:rPr lang="te-IN" sz="2200" dirty="0">
-                  <a:latin typeface="Ramabhadra" panose="02000600000000000000" pitchFamily="2" charset="0"/>
-                  <a:cs typeface="Ramabhadra" panose="02000600000000000000" pitchFamily="2" charset="0"/>
-                </a:rPr>
-                <a:t>స్తుతి పాత్రుడా.... ఆఆఅ</a:t>
+                <a:rPr lang="te-IN" sz="2400" dirty="0">
+                  <a:latin typeface="Ramabhadra" panose="02000600000000000000" pitchFamily="2" charset="0"/>
+                  <a:cs typeface="Ramabhadra" panose="02000600000000000000" pitchFamily="2" charset="0"/>
+                </a:rPr>
+                <a:t>నా బ్రతుకు బ్రతుకుగా మారేనులే</a:t>
               </a:r>
             </a:p>
             <a:p>
               <a:pPr defTabSz="439781">
                 <a:defRPr/>
               </a:pPr>
-              <a:endParaRPr lang="te-IN" sz="2200" dirty="0">
+              <a:r>
+                <a:rPr lang="te-IN" sz="2400" dirty="0">
+                  <a:latin typeface="Ramabhadra" panose="02000600000000000000" pitchFamily="2" charset="0"/>
+                  <a:cs typeface="Ramabhadra" panose="02000600000000000000" pitchFamily="2" charset="0"/>
+                </a:rPr>
+                <a:t>నాట్యమాడేను నా అంతరంగము</a:t>
+              </a:r>
+            </a:p>
+            <a:p>
+              <a:pPr defTabSz="439781">
+                <a:defRPr/>
+              </a:pPr>
+              <a:r>
+                <a:rPr lang="te-IN" sz="2400" dirty="0">
+                  <a:latin typeface="Ramabhadra" panose="02000600000000000000" pitchFamily="2" charset="0"/>
+                  <a:cs typeface="Ramabhadra" panose="02000600000000000000" pitchFamily="2" charset="0"/>
+                </a:rPr>
+                <a:t>ఇది రక్షణానంద భాగ్యమే</a:t>
+              </a:r>
+            </a:p>
+            <a:p>
+              <a:pPr defTabSz="439781">
+                <a:defRPr/>
+              </a:pPr>
+              <a:endParaRPr lang="te-IN" sz="2400" dirty="0">
                 <a:latin typeface="Ramabhadra" panose="02000600000000000000" pitchFamily="2" charset="0"/>
                 <a:cs typeface="Ramabhadra" panose="02000600000000000000" pitchFamily="2" charset="0"/>
               </a:endParaRPr>
@@ -3874,18 +3893,11 @@
                 <a:defRPr/>
               </a:pPr>
               <a:r>
-                <a:rPr lang="te-IN" sz="2200" dirty="0">
-                  <a:latin typeface="Ramabhadra" panose="02000600000000000000" pitchFamily="2" charset="0"/>
-                  <a:cs typeface="Ramabhadra" panose="02000600000000000000" pitchFamily="2" charset="0"/>
-                </a:rPr>
-                <a:t>నా శత్రువులు నను తరుముచుండగా </a:t>
-              </a:r>
-              <a:r>
-                <a:rPr lang="en-IN" sz="2200" dirty="0">
-                  <a:latin typeface="Ramabhadra" panose="02000600000000000000" pitchFamily="2" charset="0"/>
-                  <a:cs typeface="Ramabhadra" panose="02000600000000000000" pitchFamily="2" charset="0"/>
-                </a:rPr>
-                <a:t>-</a:t>
+                <a:rPr lang="te-IN" sz="2400" dirty="0">
+                  <a:latin typeface="Ramabhadra" panose="02000600000000000000" pitchFamily="2" charset="0"/>
+                  <a:cs typeface="Ramabhadra" panose="02000600000000000000" pitchFamily="2" charset="0"/>
+                </a:rPr>
+                <a:t>యేసయ్య నిన్ను వెన్నంటగానే</a:t>
               </a:r>
             </a:p>
             <a:p>
@@ -3893,11 +3905,11 @@
                 <a:defRPr/>
               </a:pPr>
               <a:r>
-                <a:rPr lang="te-IN" sz="2200" dirty="0">
-                  <a:latin typeface="Ramabhadra" panose="02000600000000000000" pitchFamily="2" charset="0"/>
-                  <a:cs typeface="Ramabhadra" panose="02000600000000000000" pitchFamily="2" charset="0"/>
-                </a:rPr>
-                <a:t>నా యాత్మ నాలో కృంగెనే ప్రభూ -2</a:t>
+                <a:rPr lang="te-IN" sz="2400" dirty="0">
+                  <a:latin typeface="Ramabhadra" panose="02000600000000000000" pitchFamily="2" charset="0"/>
+                  <a:cs typeface="Ramabhadra" panose="02000600000000000000" pitchFamily="2" charset="0"/>
+                </a:rPr>
+                <a:t>ఆజ్ఞల మార్గము కనిపించెనే</a:t>
               </a:r>
             </a:p>
             <a:p>
@@ -3905,18 +3917,11 @@
                 <a:defRPr/>
               </a:pPr>
               <a:r>
-                <a:rPr lang="te-IN" sz="2200" dirty="0">
-                  <a:latin typeface="Ramabhadra" panose="02000600000000000000" pitchFamily="2" charset="0"/>
-                  <a:cs typeface="Ramabhadra" panose="02000600000000000000" pitchFamily="2" charset="0"/>
-                </a:rPr>
-                <a:t>నా మనస్సు నీ వైపు త్రిప్పిన వెంటనే </a:t>
-              </a:r>
-              <a:r>
-                <a:rPr lang="en-IN" sz="2200" dirty="0">
-                  <a:latin typeface="Ramabhadra" panose="02000600000000000000" pitchFamily="2" charset="0"/>
-                  <a:cs typeface="Ramabhadra" panose="02000600000000000000" pitchFamily="2" charset="0"/>
-                </a:rPr>
-                <a:t>-</a:t>
+                <a:rPr lang="te-IN" sz="2400" dirty="0">
+                  <a:latin typeface="Ramabhadra" panose="02000600000000000000" pitchFamily="2" charset="0"/>
+                  <a:cs typeface="Ramabhadra" panose="02000600000000000000" pitchFamily="2" charset="0"/>
+                </a:rPr>
+                <a:t>నీవు నన్ను నడిపించగలవు</a:t>
               </a:r>
             </a:p>
             <a:p>
@@ -3924,114 +3929,11 @@
                 <a:defRPr/>
               </a:pPr>
               <a:r>
-                <a:rPr lang="te-IN" sz="2200" dirty="0">
-                  <a:latin typeface="Ramabhadra" panose="02000600000000000000" pitchFamily="2" charset="0"/>
-                  <a:cs typeface="Ramabhadra" panose="02000600000000000000" pitchFamily="2" charset="0"/>
-                </a:rPr>
-                <a:t>శత్రుల చేతినుండి</a:t>
-              </a:r>
-              <a:endParaRPr lang="en-IN" sz="2200" dirty="0">
-                <a:latin typeface="Ramabhadra" panose="02000600000000000000" pitchFamily="2" charset="0"/>
-                <a:cs typeface="Ramabhadra" panose="02000600000000000000" pitchFamily="2" charset="0"/>
-              </a:endParaRPr>
-            </a:p>
-            <a:p>
-              <a:pPr defTabSz="439781">
-                <a:defRPr/>
-              </a:pPr>
-              <a:r>
-                <a:rPr lang="te-IN" sz="2200" dirty="0">
-                  <a:latin typeface="Ramabhadra" panose="02000600000000000000" pitchFamily="2" charset="0"/>
-                  <a:cs typeface="Ramabhadra" panose="02000600000000000000" pitchFamily="2" charset="0"/>
-                </a:rPr>
-                <a:t>విడిపించినావు - కాపాడినావు -2</a:t>
-              </a:r>
-            </a:p>
-            <a:p>
-              <a:pPr defTabSz="439781">
-                <a:defRPr/>
-              </a:pPr>
-              <a:endParaRPr lang="te-IN" sz="2200" dirty="0">
-                <a:latin typeface="Ramabhadra" panose="02000600000000000000" pitchFamily="2" charset="0"/>
-                <a:cs typeface="Ramabhadra" panose="02000600000000000000" pitchFamily="2" charset="0"/>
-              </a:endParaRPr>
-            </a:p>
-            <a:p>
-              <a:pPr defTabSz="439781">
-                <a:defRPr/>
-              </a:pPr>
-              <a:r>
-                <a:rPr lang="te-IN" sz="2200" dirty="0">
-                  <a:latin typeface="Ramabhadra" panose="02000600000000000000" pitchFamily="2" charset="0"/>
-                  <a:cs typeface="Ramabhadra" panose="02000600000000000000" pitchFamily="2" charset="0"/>
-                </a:rPr>
-                <a:t>నా ప్రాణ స్నేహితులు నన్ను చూచి</a:t>
-              </a:r>
-              <a:r>
-                <a:rPr lang="en-IN" sz="2200" dirty="0">
-                  <a:latin typeface="Ramabhadra" panose="02000600000000000000" pitchFamily="2" charset="0"/>
-                  <a:cs typeface="Ramabhadra" panose="02000600000000000000" pitchFamily="2" charset="0"/>
-                </a:rPr>
-                <a:t> -</a:t>
-              </a:r>
-            </a:p>
-            <a:p>
-              <a:pPr defTabSz="439781">
-                <a:defRPr/>
-              </a:pPr>
-              <a:r>
-                <a:rPr lang="te-IN" sz="2200" dirty="0">
-                  <a:latin typeface="Ramabhadra" panose="02000600000000000000" pitchFamily="2" charset="0"/>
-                  <a:cs typeface="Ramabhadra" panose="02000600000000000000" pitchFamily="2" charset="0"/>
-                </a:rPr>
-                <a:t>దూరాన నిలిచేరు నా ప్రభూ -2</a:t>
-              </a:r>
-            </a:p>
-            <a:p>
-              <a:pPr defTabSz="439781">
-                <a:defRPr/>
-              </a:pPr>
-              <a:r>
-                <a:rPr lang="te-IN" sz="2200" dirty="0">
-                  <a:latin typeface="Ramabhadra" panose="02000600000000000000" pitchFamily="2" charset="0"/>
-                  <a:cs typeface="Ramabhadra" panose="02000600000000000000" pitchFamily="2" charset="0"/>
-                </a:rPr>
-                <a:t>నీ వాక్య ధ్యానమే నా త్రోవకు వెలుగై </a:t>
-              </a:r>
-              <a:r>
-                <a:rPr lang="en-IN" sz="2200" dirty="0">
-                  <a:latin typeface="Ramabhadra" panose="02000600000000000000" pitchFamily="2" charset="0"/>
-                  <a:cs typeface="Ramabhadra" panose="02000600000000000000" pitchFamily="2" charset="0"/>
-                </a:rPr>
-                <a:t>-</a:t>
-              </a:r>
-            </a:p>
-            <a:p>
-              <a:pPr defTabSz="439781">
-                <a:defRPr/>
-              </a:pPr>
-              <a:r>
-                <a:rPr lang="te-IN" sz="2200" dirty="0">
-                  <a:latin typeface="Ramabhadra" panose="02000600000000000000" pitchFamily="2" charset="0"/>
-                  <a:cs typeface="Ramabhadra" panose="02000600000000000000" pitchFamily="2" charset="0"/>
-                </a:rPr>
-                <a:t>నను నిల్పెను</a:t>
-              </a:r>
-              <a:endParaRPr lang="en-IN" sz="2200" dirty="0">
-                <a:latin typeface="Ramabhadra" panose="02000600000000000000" pitchFamily="2" charset="0"/>
-                <a:cs typeface="Ramabhadra" panose="02000600000000000000" pitchFamily="2" charset="0"/>
-              </a:endParaRPr>
-            </a:p>
-            <a:p>
-              <a:pPr defTabSz="439781">
-                <a:defRPr/>
-              </a:pPr>
-              <a:r>
-                <a:rPr lang="te-IN" sz="2200" dirty="0">
-                  <a:latin typeface="Ramabhadra" panose="02000600000000000000" pitchFamily="2" charset="0"/>
-                  <a:cs typeface="Ramabhadra" panose="02000600000000000000" pitchFamily="2" charset="0"/>
-                </a:rPr>
-                <a:t>నీ సన్నీధిలో - నీ సంఘములో -2</a:t>
+                <a:rPr lang="te-IN" sz="2400" dirty="0">
+                  <a:latin typeface="Ramabhadra" panose="02000600000000000000" pitchFamily="2" charset="0"/>
+                  <a:cs typeface="Ramabhadra" panose="02000600000000000000" pitchFamily="2" charset="0"/>
+                </a:rPr>
+                <a:t>నేను నడువ వలసిన త్రోవలో</a:t>
               </a:r>
             </a:p>
           </p:txBody>
@@ -4114,9 +4016,9 @@
         <p:grpSpPr>
           <a:xfrm>
             <a:off x="5104338" y="182031"/>
-            <a:ext cx="4734975" cy="6493935"/>
+            <a:ext cx="4943469" cy="6493935"/>
             <a:chOff x="160868" y="182032"/>
-            <a:chExt cx="4734975" cy="6493935"/>
+            <a:chExt cx="4943469" cy="6493935"/>
           </a:xfrm>
         </p:grpSpPr>
         <p:sp>
@@ -4188,8 +4090,8 @@
           </p:nvSpPr>
           <p:spPr>
             <a:xfrm>
-              <a:off x="354537" y="716955"/>
-              <a:ext cx="4541306" cy="5478423"/>
+              <a:off x="354536" y="716955"/>
+              <a:ext cx="4749801" cy="5847755"/>
             </a:xfrm>
             <a:prstGeom prst="rect">
               <a:avLst/>
@@ -4206,13 +4108,30 @@
                 <a:defRPr/>
               </a:pPr>
               <a:r>
-                <a:rPr lang="te-IN" sz="2500" dirty="0">
-                  <a:latin typeface="Ramabhadra" panose="02000600000000000000" pitchFamily="2" charset="0"/>
-                  <a:cs typeface="Ramabhadra" panose="02000600000000000000" pitchFamily="2" charset="0"/>
-                </a:rPr>
-                <a:t>ఎందుకో నన్నింతగా నీవు</a:t>
-              </a:r>
-              <a:endParaRPr lang="en-IN" sz="2500" dirty="0">
+                <a:rPr lang="te-IN" sz="2200" dirty="0">
+                  <a:latin typeface="Ramabhadra" panose="02000600000000000000" pitchFamily="2" charset="0"/>
+                  <a:cs typeface="Ramabhadra" panose="02000600000000000000" pitchFamily="2" charset="0"/>
+                </a:rPr>
+                <a:t>కుమ్మరి ఓ కుమ్మరి జగతుత్పత్తిదారి</a:t>
+              </a:r>
+            </a:p>
+            <a:p>
+              <a:pPr defTabSz="439781">
+                <a:defRPr/>
+              </a:pPr>
+              <a:r>
+                <a:rPr lang="te-IN" sz="2200" dirty="0">
+                  <a:latin typeface="Ramabhadra" panose="02000600000000000000" pitchFamily="2" charset="0"/>
+                  <a:cs typeface="Ramabhadra" panose="02000600000000000000" pitchFamily="2" charset="0"/>
+                </a:rPr>
+                <a:t>జిగట మన్నైన నా వంక చల్లంగా చూడుమయా</a:t>
+              </a:r>
+            </a:p>
+            <a:p>
+              <a:pPr defTabSz="439781">
+                <a:defRPr/>
+              </a:pPr>
+              <a:endParaRPr lang="te-IN" sz="2200" dirty="0">
                 <a:latin typeface="Ramabhadra" panose="02000600000000000000" pitchFamily="2" charset="0"/>
                 <a:cs typeface="Ramabhadra" panose="02000600000000000000" pitchFamily="2" charset="0"/>
               </a:endParaRPr>
@@ -4222,26 +4141,54 @@
                 <a:defRPr/>
               </a:pPr>
               <a:r>
-                <a:rPr lang="te-IN" sz="2500" dirty="0">
-                  <a:latin typeface="Ramabhadra" panose="02000600000000000000" pitchFamily="2" charset="0"/>
-                  <a:cs typeface="Ramabhadra" panose="02000600000000000000" pitchFamily="2" charset="0"/>
-                </a:rPr>
-                <a:t>ప్రేమించితివో దేవా</a:t>
-              </a:r>
-              <a:br>
-                <a:rPr lang="te-IN" sz="2500" dirty="0">
-                  <a:latin typeface="Ramabhadra" panose="02000600000000000000" pitchFamily="2" charset="0"/>
-                  <a:cs typeface="Ramabhadra" panose="02000600000000000000" pitchFamily="2" charset="0"/>
-                </a:rPr>
-              </a:br>
-              <a:r>
-                <a:rPr lang="te-IN" sz="2500" dirty="0">
-                  <a:latin typeface="Ramabhadra" panose="02000600000000000000" pitchFamily="2" charset="0"/>
-                  <a:cs typeface="Ramabhadra" panose="02000600000000000000" pitchFamily="2" charset="0"/>
-                </a:rPr>
-                <a:t>అందుకో నా దీన స్తుతిపాత్ర</a:t>
-              </a:r>
-              <a:endParaRPr lang="en-IN" sz="2500" dirty="0">
+                <a:rPr lang="te-IN" sz="2200" dirty="0">
+                  <a:latin typeface="Ramabhadra" panose="02000600000000000000" pitchFamily="2" charset="0"/>
+                  <a:cs typeface="Ramabhadra" panose="02000600000000000000" pitchFamily="2" charset="0"/>
+                </a:rPr>
+                <a:t>పనికిరాని పాత్ర అని –</a:t>
+              </a:r>
+            </a:p>
+            <a:p>
+              <a:pPr defTabSz="439781">
+                <a:defRPr/>
+              </a:pPr>
+              <a:r>
+                <a:rPr lang="te-IN" sz="2200" dirty="0">
+                  <a:latin typeface="Ramabhadra" panose="02000600000000000000" pitchFamily="2" charset="0"/>
+                  <a:cs typeface="Ramabhadra" panose="02000600000000000000" pitchFamily="2" charset="0"/>
+                </a:rPr>
+                <a:t>పారవేయకుమా</a:t>
+              </a:r>
+            </a:p>
+            <a:p>
+              <a:pPr defTabSz="439781">
+                <a:defRPr/>
+              </a:pPr>
+              <a:r>
+                <a:rPr lang="te-IN" sz="2200" dirty="0">
+                  <a:latin typeface="Ramabhadra" panose="02000600000000000000" pitchFamily="2" charset="0"/>
+                  <a:cs typeface="Ramabhadra" panose="02000600000000000000" pitchFamily="2" charset="0"/>
+                </a:rPr>
+                <a:t>పొంగి పొరలు పాత్రగా –</a:t>
+              </a:r>
+            </a:p>
+            <a:p>
+              <a:pPr defTabSz="439781">
+                <a:defRPr/>
+              </a:pPr>
+              <a:r>
+                <a:rPr lang="te-IN" sz="2200" dirty="0">
+                  <a:latin typeface="Ramabhadra" panose="02000600000000000000" pitchFamily="2" charset="0"/>
+                  <a:cs typeface="Ramabhadra" panose="02000600000000000000" pitchFamily="2" charset="0"/>
+                </a:rPr>
+                <a:t>నన్ను చేయుమా (2)</a:t>
+              </a:r>
+            </a:p>
+            <a:p>
+              <a:pPr defTabSz="439781">
+                <a:defRPr/>
+              </a:pPr>
+              <a:endParaRPr lang="te-IN" sz="2200" dirty="0">
                 <a:latin typeface="Ramabhadra" panose="02000600000000000000" pitchFamily="2" charset="0"/>
                 <a:cs typeface="Ramabhadra" panose="02000600000000000000" pitchFamily="2" charset="0"/>
               </a:endParaRPr>
@@ -4251,18 +4198,54 @@
                 <a:defRPr/>
               </a:pPr>
               <a:r>
-                <a:rPr lang="te-IN" sz="2500" dirty="0">
-                  <a:latin typeface="Ramabhadra" panose="02000600000000000000" pitchFamily="2" charset="0"/>
-                  <a:cs typeface="Ramabhadra" panose="02000600000000000000" pitchFamily="2" charset="0"/>
-                </a:rPr>
-                <a:t>హల్లెలూయ యేసయ్యా (2)</a:t>
+                <a:rPr lang="te-IN" sz="2200" dirty="0">
+                  <a:latin typeface="Ramabhadra" panose="02000600000000000000" pitchFamily="2" charset="0"/>
+                  <a:cs typeface="Ramabhadra" panose="02000600000000000000" pitchFamily="2" charset="0"/>
+                </a:rPr>
+                <a:t>లేఖన మందలి పాత్రలు –</a:t>
               </a:r>
             </a:p>
             <a:p>
               <a:pPr defTabSz="439781">
                 <a:defRPr/>
               </a:pPr>
-              <a:endParaRPr lang="te-IN" sz="2500" dirty="0">
+              <a:r>
+                <a:rPr lang="te-IN" sz="2200" dirty="0">
+                  <a:latin typeface="Ramabhadra" panose="02000600000000000000" pitchFamily="2" charset="0"/>
+                  <a:cs typeface="Ramabhadra" panose="02000600000000000000" pitchFamily="2" charset="0"/>
+                </a:rPr>
+                <a:t>ప్రభుని స్తుతించెను</a:t>
+              </a:r>
+            </a:p>
+            <a:p>
+              <a:pPr defTabSz="439781">
+                <a:defRPr/>
+              </a:pPr>
+              <a:r>
+                <a:rPr lang="te-IN" sz="2200" dirty="0">
+                  <a:latin typeface="Ramabhadra" panose="02000600000000000000" pitchFamily="2" charset="0"/>
+                  <a:cs typeface="Ramabhadra" panose="02000600000000000000" pitchFamily="2" charset="0"/>
+                </a:rPr>
+                <a:t>నన్ను అలంటి పాత్రగా –</a:t>
+              </a:r>
+            </a:p>
+            <a:p>
+              <a:pPr defTabSz="439781">
+                <a:defRPr/>
+              </a:pPr>
+              <a:r>
+                <a:rPr lang="te-IN" sz="2200" dirty="0">
+                  <a:latin typeface="Ramabhadra" panose="02000600000000000000" pitchFamily="2" charset="0"/>
+                  <a:cs typeface="Ramabhadra" panose="02000600000000000000" pitchFamily="2" charset="0"/>
+                </a:rPr>
+                <a:t>మార్చి వేయుమా</a:t>
+              </a:r>
+            </a:p>
+            <a:p>
+              <a:pPr defTabSz="439781">
+                <a:defRPr/>
+              </a:pPr>
+              <a:endParaRPr lang="te-IN" sz="2200" dirty="0">
                 <a:latin typeface="Ramabhadra" panose="02000600000000000000" pitchFamily="2" charset="0"/>
                 <a:cs typeface="Ramabhadra" panose="02000600000000000000" pitchFamily="2" charset="0"/>
               </a:endParaRPr>
@@ -4272,130 +4255,47 @@
                 <a:defRPr/>
               </a:pPr>
               <a:r>
-                <a:rPr lang="te-IN" sz="2500" dirty="0">
-                  <a:latin typeface="Ramabhadra" panose="02000600000000000000" pitchFamily="2" charset="0"/>
-                  <a:cs typeface="Ramabhadra" panose="02000600000000000000" pitchFamily="2" charset="0"/>
-                </a:rPr>
-                <a:t>నా పాపము బాప నరరూపివైనావు</a:t>
-              </a:r>
-              <a:br>
-                <a:rPr lang="te-IN" sz="2500" dirty="0">
-                  <a:latin typeface="Ramabhadra" panose="02000600000000000000" pitchFamily="2" charset="0"/>
-                  <a:cs typeface="Ramabhadra" panose="02000600000000000000" pitchFamily="2" charset="0"/>
-                </a:rPr>
-              </a:br>
-              <a:r>
-                <a:rPr lang="te-IN" sz="2500" dirty="0">
-                  <a:latin typeface="Ramabhadra" panose="02000600000000000000" pitchFamily="2" charset="0"/>
-                  <a:cs typeface="Ramabhadra" panose="02000600000000000000" pitchFamily="2" charset="0"/>
-                </a:rPr>
-                <a:t>నా శాపము మాప నలిగి వ్రేలాడితివి</a:t>
-              </a:r>
-              <a:br>
-                <a:rPr lang="te-IN" sz="2500" dirty="0">
-                  <a:latin typeface="Ramabhadra" panose="02000600000000000000" pitchFamily="2" charset="0"/>
-                  <a:cs typeface="Ramabhadra" panose="02000600000000000000" pitchFamily="2" charset="0"/>
-                </a:rPr>
-              </a:br>
-              <a:r>
-                <a:rPr lang="te-IN" sz="2500" dirty="0">
-                  <a:latin typeface="Ramabhadra" panose="02000600000000000000" pitchFamily="2" charset="0"/>
-                  <a:cs typeface="Ramabhadra" panose="02000600000000000000" pitchFamily="2" charset="0"/>
-                </a:rPr>
-                <a:t>నాకు చాలిన దేవుడవు</a:t>
-              </a:r>
-              <a:r>
-                <a:rPr lang="en-IN" sz="2500" dirty="0">
-                  <a:latin typeface="Ramabhadra" panose="02000600000000000000" pitchFamily="2" charset="0"/>
-                  <a:cs typeface="Ramabhadra" panose="02000600000000000000" pitchFamily="2" charset="0"/>
-                </a:rPr>
-                <a:t> </a:t>
-              </a:r>
-              <a:r>
-                <a:rPr lang="te-IN" sz="2500" dirty="0">
-                  <a:latin typeface="Ramabhadra" panose="02000600000000000000" pitchFamily="2" charset="0"/>
-                  <a:cs typeface="Ramabhadra" panose="02000600000000000000" pitchFamily="2" charset="0"/>
-                </a:rPr>
-                <a:t>నీవే </a:t>
-              </a:r>
-              <a:endParaRPr lang="en-IN" sz="2500" dirty="0">
-                <a:latin typeface="Ramabhadra" panose="02000600000000000000" pitchFamily="2" charset="0"/>
-                <a:cs typeface="Ramabhadra" panose="02000600000000000000" pitchFamily="2" charset="0"/>
-              </a:endParaRPr>
+                <a:rPr lang="te-IN" sz="2200" dirty="0">
+                  <a:latin typeface="Ramabhadra" panose="02000600000000000000" pitchFamily="2" charset="0"/>
+                  <a:cs typeface="Ramabhadra" panose="02000600000000000000" pitchFamily="2" charset="0"/>
+                </a:rPr>
+                <a:t>సౌభాగ్యమైన పాత్రగా –</a:t>
+              </a:r>
             </a:p>
             <a:p>
               <a:pPr defTabSz="439781">
                 <a:defRPr/>
               </a:pPr>
               <a:r>
-                <a:rPr lang="te-IN" sz="2500" dirty="0">
-                  <a:latin typeface="Ramabhadra" panose="02000600000000000000" pitchFamily="2" charset="0"/>
-                  <a:cs typeface="Ramabhadra" panose="02000600000000000000" pitchFamily="2" charset="0"/>
-                </a:rPr>
-                <a:t>నా స్థానములో నీవే (2)         </a:t>
+                <a:rPr lang="te-IN" sz="2200" dirty="0">
+                  <a:latin typeface="Ramabhadra" panose="02000600000000000000" pitchFamily="2" charset="0"/>
+                  <a:cs typeface="Ramabhadra" panose="02000600000000000000" pitchFamily="2" charset="0"/>
+                </a:rPr>
+                <a:t>నన్ను చేయుమా</a:t>
               </a:r>
             </a:p>
             <a:p>
               <a:pPr defTabSz="439781">
                 <a:defRPr/>
               </a:pPr>
-              <a:endParaRPr lang="te-IN" sz="2500" dirty="0">
-                <a:latin typeface="Ramabhadra" panose="02000600000000000000" pitchFamily="2" charset="0"/>
-                <a:cs typeface="Ramabhadra" panose="02000600000000000000" pitchFamily="2" charset="0"/>
-              </a:endParaRPr>
+              <a:r>
+                <a:rPr lang="te-IN" sz="2200" dirty="0">
+                  <a:latin typeface="Ramabhadra" panose="02000600000000000000" pitchFamily="2" charset="0"/>
+                  <a:cs typeface="Ramabhadra" panose="02000600000000000000" pitchFamily="2" charset="0"/>
+                </a:rPr>
+                <a:t>సొగస్సులన్ని  కూడనుంచి –</a:t>
+              </a:r>
             </a:p>
             <a:p>
               <a:pPr defTabSz="439781">
                 <a:defRPr/>
               </a:pPr>
               <a:r>
-                <a:rPr lang="te-IN" sz="2500" dirty="0">
-                  <a:latin typeface="Ramabhadra" panose="02000600000000000000" pitchFamily="2" charset="0"/>
-                  <a:cs typeface="Ramabhadra" panose="02000600000000000000" pitchFamily="2" charset="0"/>
-                </a:rPr>
-                <a:t>నీ రూపము నాలో నిర్మించియున్నావు</a:t>
-              </a:r>
-              <a:br>
-                <a:rPr lang="te-IN" sz="2500" dirty="0">
-                  <a:latin typeface="Ramabhadra" panose="02000600000000000000" pitchFamily="2" charset="0"/>
-                  <a:cs typeface="Ramabhadra" panose="02000600000000000000" pitchFamily="2" charset="0"/>
-                </a:rPr>
-              </a:br>
-              <a:r>
-                <a:rPr lang="te-IN" sz="2500" dirty="0">
-                  <a:latin typeface="Ramabhadra" panose="02000600000000000000" pitchFamily="2" charset="0"/>
-                  <a:cs typeface="Ramabhadra" panose="02000600000000000000" pitchFamily="2" charset="0"/>
-                </a:rPr>
-                <a:t>నీ పోలికలోనే నివసించుమన్నావు</a:t>
-              </a:r>
-              <a:br>
-                <a:rPr lang="te-IN" sz="2500" dirty="0">
-                  <a:latin typeface="Ramabhadra" panose="02000600000000000000" pitchFamily="2" charset="0"/>
-                  <a:cs typeface="Ramabhadra" panose="02000600000000000000" pitchFamily="2" charset="0"/>
-                </a:rPr>
-              </a:br>
-              <a:r>
-                <a:rPr lang="te-IN" sz="2500" dirty="0">
-                  <a:latin typeface="Ramabhadra" panose="02000600000000000000" pitchFamily="2" charset="0"/>
-                  <a:cs typeface="Ramabhadra" panose="02000600000000000000" pitchFamily="2" charset="0"/>
-                </a:rPr>
-                <a:t>నీవు నన్ను ఎన్నుకొంటివి</a:t>
-              </a:r>
-              <a:endParaRPr lang="en-IN" sz="2500" dirty="0">
-                <a:latin typeface="Ramabhadra" panose="02000600000000000000" pitchFamily="2" charset="0"/>
-                <a:cs typeface="Ramabhadra" panose="02000600000000000000" pitchFamily="2" charset="0"/>
-              </a:endParaRPr>
-            </a:p>
-            <a:p>
-              <a:pPr defTabSz="439781">
-                <a:defRPr/>
-              </a:pPr>
-              <a:r>
-                <a:rPr lang="te-IN" sz="2500" dirty="0">
-                  <a:latin typeface="Ramabhadra" panose="02000600000000000000" pitchFamily="2" charset="0"/>
-                  <a:cs typeface="Ramabhadra" panose="02000600000000000000" pitchFamily="2" charset="0"/>
-                </a:rPr>
-                <a:t>నీ కొరకై నీ కృపలో (2)           </a:t>
+                <a:rPr lang="te-IN" sz="2200" dirty="0">
+                  <a:latin typeface="Ramabhadra" panose="02000600000000000000" pitchFamily="2" charset="0"/>
+                  <a:cs typeface="Ramabhadra" panose="02000600000000000000" pitchFamily="2" charset="0"/>
+                </a:rPr>
+                <a:t>నన్ను మార్చుమా</a:t>
               </a:r>
             </a:p>
           </p:txBody>

</xml_diff>

<commit_message>
08 dec 24 songs
</commit_message>
<xml_diff>
--- a/songsTemplate.pptx
+++ b/songsTemplate.pptx
@@ -255,7 +255,7 @@
           <a:p>
             <a:fld id="{F1102B08-ED9E-409F-B95F-09CAA1DAF6E0}" type="datetimeFigureOut">
               <a:rPr lang="en-IN" smtClean="0"/>
-              <a:t>30-11-2024</a:t>
+              <a:t>07-12-2024</a:t>
             </a:fld>
             <a:endParaRPr lang="en-IN"/>
           </a:p>
@@ -425,7 +425,7 @@
           <a:p>
             <a:fld id="{F1102B08-ED9E-409F-B95F-09CAA1DAF6E0}" type="datetimeFigureOut">
               <a:rPr lang="en-IN" smtClean="0"/>
-              <a:t>30-11-2024</a:t>
+              <a:t>07-12-2024</a:t>
             </a:fld>
             <a:endParaRPr lang="en-IN"/>
           </a:p>
@@ -605,7 +605,7 @@
           <a:p>
             <a:fld id="{F1102B08-ED9E-409F-B95F-09CAA1DAF6E0}" type="datetimeFigureOut">
               <a:rPr lang="en-IN" smtClean="0"/>
-              <a:t>30-11-2024</a:t>
+              <a:t>07-12-2024</a:t>
             </a:fld>
             <a:endParaRPr lang="en-IN"/>
           </a:p>
@@ -775,7 +775,7 @@
           <a:p>
             <a:fld id="{F1102B08-ED9E-409F-B95F-09CAA1DAF6E0}" type="datetimeFigureOut">
               <a:rPr lang="en-IN" smtClean="0"/>
-              <a:t>30-11-2024</a:t>
+              <a:t>07-12-2024</a:t>
             </a:fld>
             <a:endParaRPr lang="en-IN"/>
           </a:p>
@@ -1019,7 +1019,7 @@
           <a:p>
             <a:fld id="{F1102B08-ED9E-409F-B95F-09CAA1DAF6E0}" type="datetimeFigureOut">
               <a:rPr lang="en-IN" smtClean="0"/>
-              <a:t>30-11-2024</a:t>
+              <a:t>07-12-2024</a:t>
             </a:fld>
             <a:endParaRPr lang="en-IN"/>
           </a:p>
@@ -1251,7 +1251,7 @@
           <a:p>
             <a:fld id="{F1102B08-ED9E-409F-B95F-09CAA1DAF6E0}" type="datetimeFigureOut">
               <a:rPr lang="en-IN" smtClean="0"/>
-              <a:t>30-11-2024</a:t>
+              <a:t>07-12-2024</a:t>
             </a:fld>
             <a:endParaRPr lang="en-IN"/>
           </a:p>
@@ -1618,7 +1618,7 @@
           <a:p>
             <a:fld id="{F1102B08-ED9E-409F-B95F-09CAA1DAF6E0}" type="datetimeFigureOut">
               <a:rPr lang="en-IN" smtClean="0"/>
-              <a:t>30-11-2024</a:t>
+              <a:t>07-12-2024</a:t>
             </a:fld>
             <a:endParaRPr lang="en-IN"/>
           </a:p>
@@ -1736,7 +1736,7 @@
           <a:p>
             <a:fld id="{F1102B08-ED9E-409F-B95F-09CAA1DAF6E0}" type="datetimeFigureOut">
               <a:rPr lang="en-IN" smtClean="0"/>
-              <a:t>30-11-2024</a:t>
+              <a:t>07-12-2024</a:t>
             </a:fld>
             <a:endParaRPr lang="en-IN"/>
           </a:p>
@@ -1831,7 +1831,7 @@
           <a:p>
             <a:fld id="{F1102B08-ED9E-409F-B95F-09CAA1DAF6E0}" type="datetimeFigureOut">
               <a:rPr lang="en-IN" smtClean="0"/>
-              <a:t>30-11-2024</a:t>
+              <a:t>07-12-2024</a:t>
             </a:fld>
             <a:endParaRPr lang="en-IN"/>
           </a:p>
@@ -2108,7 +2108,7 @@
           <a:p>
             <a:fld id="{F1102B08-ED9E-409F-B95F-09CAA1DAF6E0}" type="datetimeFigureOut">
               <a:rPr lang="en-IN" smtClean="0"/>
-              <a:t>30-11-2024</a:t>
+              <a:t>07-12-2024</a:t>
             </a:fld>
             <a:endParaRPr lang="en-IN"/>
           </a:p>
@@ -2365,7 +2365,7 @@
           <a:p>
             <a:fld id="{F1102B08-ED9E-409F-B95F-09CAA1DAF6E0}" type="datetimeFigureOut">
               <a:rPr lang="en-IN" smtClean="0"/>
-              <a:t>30-11-2024</a:t>
+              <a:t>07-12-2024</a:t>
             </a:fld>
             <a:endParaRPr lang="en-IN"/>
           </a:p>
@@ -2578,7 +2578,7 @@
           <a:p>
             <a:fld id="{F1102B08-ED9E-409F-B95F-09CAA1DAF6E0}" type="datetimeFigureOut">
               <a:rPr lang="en-IN" smtClean="0"/>
-              <a:t>30-11-2024</a:t>
+              <a:t>07-12-2024</a:t>
             </a:fld>
             <a:endParaRPr lang="en-IN"/>
           </a:p>
@@ -2998,9 +2998,9 @@
         <p:grpSpPr>
           <a:xfrm>
             <a:off x="160868" y="182032"/>
-            <a:ext cx="5369490" cy="6493935"/>
+            <a:ext cx="4648200" cy="6493935"/>
             <a:chOff x="160868" y="182032"/>
-            <a:chExt cx="5369490" cy="6493935"/>
+            <a:chExt cx="4648200" cy="6493935"/>
           </a:xfrm>
         </p:grpSpPr>
         <p:sp>
@@ -3072,8 +3072,8 @@
           </p:nvSpPr>
           <p:spPr>
             <a:xfrm>
-              <a:off x="416948" y="710999"/>
-              <a:ext cx="5113410" cy="5262979"/>
+              <a:off x="272140" y="309857"/>
+              <a:ext cx="4483140" cy="5847755"/>
             </a:xfrm>
             <a:prstGeom prst="rect">
               <a:avLst/>
@@ -3090,11 +3090,11 @@
                 <a:defRPr/>
               </a:pPr>
               <a:r>
-                <a:rPr lang="te-IN" sz="2400" dirty="0">
-                  <a:latin typeface="Ramabhadra" panose="02000600000000000000" pitchFamily="2" charset="0"/>
-                  <a:cs typeface="Ramabhadra" panose="02000600000000000000" pitchFamily="2" charset="0"/>
-                </a:rPr>
-                <a:t>నా స్తుతి పాత్రుడా – నా యేసయ్యా</a:t>
+                <a:rPr lang="te-IN" sz="2200" dirty="0">
+                  <a:latin typeface="Ramabhadra" panose="02000600000000000000" pitchFamily="2" charset="0"/>
+                  <a:cs typeface="Ramabhadra" panose="02000600000000000000" pitchFamily="2" charset="0"/>
+                </a:rPr>
+                <a:t>మహాఘనుడవు మహోన్నతుడవు</a:t>
               </a:r>
             </a:p>
             <a:p>
@@ -3102,18 +3102,54 @@
                 <a:defRPr/>
               </a:pPr>
               <a:r>
-                <a:rPr lang="te-IN" sz="2400" dirty="0">
-                  <a:latin typeface="Ramabhadra" panose="02000600000000000000" pitchFamily="2" charset="0"/>
-                  <a:cs typeface="Ramabhadra" panose="02000600000000000000" pitchFamily="2" charset="0"/>
-                </a:rPr>
-                <a:t>నా ఆరాధనకు నీవె యోగ్యుడవయ్యా (2)</a:t>
+                <a:rPr lang="te-IN" sz="2200" dirty="0">
+                  <a:latin typeface="Ramabhadra" panose="02000600000000000000" pitchFamily="2" charset="0"/>
+                  <a:cs typeface="Ramabhadra" panose="02000600000000000000" pitchFamily="2" charset="0"/>
+                </a:rPr>
+                <a:t>పరిశుద్ధ స్థలములోనే నివసించువాడవు (2)</a:t>
               </a:r>
             </a:p>
             <a:p>
               <a:pPr defTabSz="439781">
                 <a:defRPr/>
               </a:pPr>
-              <a:endParaRPr lang="te-IN" sz="2400" dirty="0">
+              <a:r>
+                <a:rPr lang="te-IN" sz="2200" dirty="0">
+                  <a:latin typeface="Ramabhadra" panose="02000600000000000000" pitchFamily="2" charset="0"/>
+                  <a:cs typeface="Ramabhadra" panose="02000600000000000000" pitchFamily="2" charset="0"/>
+                </a:rPr>
+                <a:t>కృపా సత్య సంపూర్ణమై</a:t>
+              </a:r>
+            </a:p>
+            <a:p>
+              <a:pPr defTabSz="439781">
+                <a:defRPr/>
+              </a:pPr>
+              <a:r>
+                <a:rPr lang="te-IN" sz="2200" dirty="0">
+                  <a:latin typeface="Ramabhadra" panose="02000600000000000000" pitchFamily="2" charset="0"/>
+                  <a:cs typeface="Ramabhadra" panose="02000600000000000000" pitchFamily="2" charset="0"/>
+                </a:rPr>
+                <a:t>మా మధ్యలో నివసించుట న్యాయమా</a:t>
+              </a:r>
+            </a:p>
+            <a:p>
+              <a:pPr defTabSz="439781">
+                <a:defRPr/>
+              </a:pPr>
+              <a:r>
+                <a:rPr lang="te-IN" sz="2200" dirty="0">
+                  <a:latin typeface="Ramabhadra" panose="02000600000000000000" pitchFamily="2" charset="0"/>
+                  <a:cs typeface="Ramabhadra" panose="02000600000000000000" pitchFamily="2" charset="0"/>
+                </a:rPr>
+                <a:t>నను పరిశుద్ధపరచుటే నీ ధర్మమా (2)</a:t>
+              </a:r>
+            </a:p>
+            <a:p>
+              <a:pPr defTabSz="439781">
+                <a:defRPr/>
+              </a:pPr>
+              <a:endParaRPr lang="te-IN" sz="2200" dirty="0">
                 <a:latin typeface="Ramabhadra" panose="02000600000000000000" pitchFamily="2" charset="0"/>
                 <a:cs typeface="Ramabhadra" panose="02000600000000000000" pitchFamily="2" charset="0"/>
               </a:endParaRPr>
@@ -3123,11 +3159,11 @@
                 <a:defRPr/>
               </a:pPr>
               <a:r>
-                <a:rPr lang="te-IN" sz="2400" dirty="0">
-                  <a:latin typeface="Ramabhadra" panose="02000600000000000000" pitchFamily="2" charset="0"/>
-                  <a:cs typeface="Ramabhadra" panose="02000600000000000000" pitchFamily="2" charset="0"/>
-                </a:rPr>
-                <a:t>నీ వాక్యమే నా పరవశము</a:t>
+                <a:rPr lang="te-IN" sz="2200" dirty="0">
+                  <a:latin typeface="Ramabhadra" panose="02000600000000000000" pitchFamily="2" charset="0"/>
+                  <a:cs typeface="Ramabhadra" panose="02000600000000000000" pitchFamily="2" charset="0"/>
+                </a:rPr>
+                <a:t>వినయముగల వారిని</a:t>
               </a:r>
             </a:p>
             <a:p>
@@ -3135,11 +3171,11 @@
                 <a:defRPr/>
               </a:pPr>
               <a:r>
-                <a:rPr lang="te-IN" sz="2400" dirty="0">
-                  <a:latin typeface="Ramabhadra" panose="02000600000000000000" pitchFamily="2" charset="0"/>
-                  <a:cs typeface="Ramabhadra" panose="02000600000000000000" pitchFamily="2" charset="0"/>
-                </a:rPr>
-                <a:t>నీ వాక్యమే నా ఆత్మకు ఆహారము (2)</a:t>
+                <a:rPr lang="te-IN" sz="2200" dirty="0">
+                  <a:latin typeface="Ramabhadra" panose="02000600000000000000" pitchFamily="2" charset="0"/>
+                  <a:cs typeface="Ramabhadra" panose="02000600000000000000" pitchFamily="2" charset="0"/>
+                </a:rPr>
+                <a:t>తగిన సమయములో హెచ్చించువాడవని (2)</a:t>
               </a:r>
             </a:p>
             <a:p>
@@ -3147,18 +3183,37 @@
                 <a:defRPr/>
               </a:pPr>
               <a:r>
-                <a:rPr lang="te-IN" sz="2400" dirty="0">
-                  <a:latin typeface="Ramabhadra" panose="02000600000000000000" pitchFamily="2" charset="0"/>
-                  <a:cs typeface="Ramabhadra" panose="02000600000000000000" pitchFamily="2" charset="0"/>
-                </a:rPr>
-                <a:t>నీ వాక్యమే నా పాదములకు దీపము (3)</a:t>
+                <a:rPr lang="te-IN" sz="2200" dirty="0">
+                  <a:latin typeface="Ramabhadra" panose="02000600000000000000" pitchFamily="2" charset="0"/>
+                  <a:cs typeface="Ramabhadra" panose="02000600000000000000" pitchFamily="2" charset="0"/>
+                </a:rPr>
+                <a:t>నీవు వాడు పాత్రనై నేనుండుటకై</a:t>
               </a:r>
             </a:p>
             <a:p>
               <a:pPr defTabSz="439781">
                 <a:defRPr/>
               </a:pPr>
-              <a:endParaRPr lang="te-IN" sz="2400" dirty="0">
+              <a:r>
+                <a:rPr lang="te-IN" sz="2200" dirty="0">
+                  <a:latin typeface="Ramabhadra" panose="02000600000000000000" pitchFamily="2" charset="0"/>
+                  <a:cs typeface="Ramabhadra" panose="02000600000000000000" pitchFamily="2" charset="0"/>
+                </a:rPr>
+                <a:t>నిలిచియుందును పవిత్రతతో (2)</a:t>
+              </a:r>
+            </a:p>
+            <a:p>
+              <a:pPr defTabSz="439781">
+                <a:defRPr/>
+              </a:pPr>
+              <a:r>
+                <a:rPr lang="te-IN" sz="2200" dirty="0">
+                  <a:latin typeface="Ramabhadra" panose="02000600000000000000" pitchFamily="2" charset="0"/>
+                  <a:cs typeface="Ramabhadra" panose="02000600000000000000" pitchFamily="2" charset="0"/>
+                </a:rPr>
+                <a:t>హల్లెలూయా యేసయ్యా నీకే స్తోత్రమయా (2)</a:t>
+              </a:r>
+              <a:endParaRPr lang="en-IN" sz="2200" dirty="0">
                 <a:latin typeface="Ramabhadra" panose="02000600000000000000" pitchFamily="2" charset="0"/>
                 <a:cs typeface="Ramabhadra" panose="02000600000000000000" pitchFamily="2" charset="0"/>
               </a:endParaRPr>
@@ -3167,24 +3222,21 @@
               <a:pPr defTabSz="439781">
                 <a:defRPr/>
               </a:pPr>
-              <a:r>
-                <a:rPr lang="te-IN" sz="2400" dirty="0">
-                  <a:latin typeface="Ramabhadra" panose="02000600000000000000" pitchFamily="2" charset="0"/>
-                  <a:cs typeface="Ramabhadra" panose="02000600000000000000" pitchFamily="2" charset="0"/>
-                </a:rPr>
-                <a:t>నీ కృపయే నా ఆశ్రయము</a:t>
-              </a:r>
+              <a:endParaRPr lang="te-IN" sz="2200" dirty="0">
+                <a:latin typeface="Ramabhadra" panose="02000600000000000000" pitchFamily="2" charset="0"/>
+                <a:cs typeface="Ramabhadra" panose="02000600000000000000" pitchFamily="2" charset="0"/>
+              </a:endParaRPr>
             </a:p>
             <a:p>
               <a:pPr defTabSz="439781">
                 <a:defRPr/>
               </a:pPr>
               <a:r>
-                <a:rPr lang="te-IN" sz="2400" dirty="0">
-                  <a:latin typeface="Ramabhadra" panose="02000600000000000000" pitchFamily="2" charset="0"/>
-                  <a:cs typeface="Ramabhadra" panose="02000600000000000000" pitchFamily="2" charset="0"/>
-                </a:rPr>
-                <a:t>నీ కృపయే నా ఆత్మకు అభిషేకము (2)</a:t>
+                <a:rPr lang="te-IN" sz="2200" dirty="0">
+                  <a:latin typeface="Ramabhadra" panose="02000600000000000000" pitchFamily="2" charset="0"/>
+                  <a:cs typeface="Ramabhadra" panose="02000600000000000000" pitchFamily="2" charset="0"/>
+                </a:rPr>
+                <a:t>దీన మనస్సు గలవారికే</a:t>
               </a:r>
             </a:p>
             <a:p>
@@ -3192,32 +3244,35 @@
                 <a:defRPr/>
               </a:pPr>
               <a:r>
-                <a:rPr lang="te-IN" sz="2400" dirty="0">
-                  <a:latin typeface="Ramabhadra" panose="02000600000000000000" pitchFamily="2" charset="0"/>
-                  <a:cs typeface="Ramabhadra" panose="02000600000000000000" pitchFamily="2" charset="0"/>
-                </a:rPr>
-                <a:t>నీ కృపయే నా జీవన ఆధారము (3)</a:t>
+                <a:rPr lang="te-IN" sz="2200" dirty="0">
+                  <a:latin typeface="Ramabhadra" panose="02000600000000000000" pitchFamily="2" charset="0"/>
+                  <a:cs typeface="Ramabhadra" panose="02000600000000000000" pitchFamily="2" charset="0"/>
+                </a:rPr>
+                <a:t>సమృద్ధిగా కృపను దయచేయువాడవని (2)</a:t>
               </a:r>
             </a:p>
             <a:p>
               <a:pPr defTabSz="439781">
                 <a:defRPr/>
               </a:pPr>
-              <a:endParaRPr lang="te-IN" sz="2400" dirty="0">
-                <a:latin typeface="Ramabhadra" panose="02000600000000000000" pitchFamily="2" charset="0"/>
-                <a:cs typeface="Ramabhadra" panose="02000600000000000000" pitchFamily="2" charset="0"/>
-              </a:endParaRPr>
+              <a:r>
+                <a:rPr lang="te-IN" sz="2200" dirty="0">
+                  <a:latin typeface="Ramabhadra" panose="02000600000000000000" pitchFamily="2" charset="0"/>
+                  <a:cs typeface="Ramabhadra" panose="02000600000000000000" pitchFamily="2" charset="0"/>
+                </a:rPr>
+                <a:t>నీ సముఖములో సజీవ సాక్షినై</a:t>
+              </a:r>
             </a:p>
             <a:p>
               <a:pPr defTabSz="439781">
                 <a:defRPr/>
               </a:pPr>
               <a:r>
-                <a:rPr lang="te-IN" sz="2400" dirty="0">
-                  <a:latin typeface="Ramabhadra" panose="02000600000000000000" pitchFamily="2" charset="0"/>
-                  <a:cs typeface="Ramabhadra" panose="02000600000000000000" pitchFamily="2" charset="0"/>
-                </a:rPr>
-                <a:t>నీ సౌందర్యము యెరూషలేము</a:t>
+                <a:rPr lang="te-IN" sz="2200" dirty="0">
+                  <a:latin typeface="Ramabhadra" panose="02000600000000000000" pitchFamily="2" charset="0"/>
+                  <a:cs typeface="Ramabhadra" panose="02000600000000000000" pitchFamily="2" charset="0"/>
+                </a:rPr>
+                <a:t>కాపాడుకొందును మెళకువతో (2)</a:t>
               </a:r>
             </a:p>
             <a:p>
@@ -3225,23 +3280,11 @@
                 <a:defRPr/>
               </a:pPr>
               <a:r>
-                <a:rPr lang="te-IN" sz="2400" dirty="0">
-                  <a:latin typeface="Ramabhadra" panose="02000600000000000000" pitchFamily="2" charset="0"/>
-                  <a:cs typeface="Ramabhadra" panose="02000600000000000000" pitchFamily="2" charset="0"/>
-                </a:rPr>
-                <a:t>నీ పరిపూర్ణత సీయోను శిఖరము (2)</a:t>
-              </a:r>
-            </a:p>
-            <a:p>
-              <a:pPr defTabSz="439781">
-                <a:defRPr/>
-              </a:pPr>
-              <a:r>
-                <a:rPr lang="te-IN" sz="2400" dirty="0">
-                  <a:latin typeface="Ramabhadra" panose="02000600000000000000" pitchFamily="2" charset="0"/>
-                  <a:cs typeface="Ramabhadra" panose="02000600000000000000" pitchFamily="2" charset="0"/>
-                </a:rPr>
-                <a:t>నీ పరిపూర్ణత నా జీవిత గమ్యము (3)</a:t>
+                <a:rPr lang="te-IN" sz="2200" dirty="0">
+                  <a:latin typeface="Ramabhadra" panose="02000600000000000000" pitchFamily="2" charset="0"/>
+                  <a:cs typeface="Ramabhadra" panose="02000600000000000000" pitchFamily="2" charset="0"/>
+                </a:rPr>
+                <a:t>హల్లెలూయా యేసయ్యా నీకే స్తోత్రమయా (2)</a:t>
               </a:r>
             </a:p>
           </p:txBody>
@@ -3260,7 +3303,7 @@
           </p:nvSpPr>
           <p:spPr>
             <a:xfrm>
-              <a:off x="318523" y="320474"/>
+              <a:off x="4312694" y="309857"/>
               <a:ext cx="390525" cy="390525"/>
             </a:xfrm>
             <a:prstGeom prst="ellipse">
@@ -3324,9 +3367,9 @@
         <p:grpSpPr>
           <a:xfrm>
             <a:off x="5104338" y="182031"/>
-            <a:ext cx="4741088" cy="6493935"/>
+            <a:ext cx="4648200" cy="6493935"/>
             <a:chOff x="160868" y="182032"/>
-            <a:chExt cx="4741088" cy="6493935"/>
+            <a:chExt cx="4648200" cy="6493935"/>
           </a:xfrm>
         </p:grpSpPr>
         <p:sp>
@@ -3398,8 +3441,8 @@
           </p:nvSpPr>
           <p:spPr>
             <a:xfrm>
-              <a:off x="360650" y="320475"/>
-              <a:ext cx="4541306" cy="5324535"/>
+              <a:off x="267762" y="838158"/>
+              <a:ext cx="4541306" cy="4493538"/>
             </a:xfrm>
             <a:prstGeom prst="rect">
               <a:avLst/>
@@ -3413,192 +3456,157 @@
             <a:lstStyle/>
             <a:p>
               <a:r>
-                <a:rPr lang="te-IN" sz="2000" dirty="0">
-                  <a:latin typeface="Ramabhadra" panose="02000600000000000000" pitchFamily="2" charset="0"/>
-                  <a:cs typeface="Ramabhadra" panose="02000600000000000000" pitchFamily="2" charset="0"/>
-                </a:rPr>
-                <a:t>ఇంత కాలం నీదు కృపలో కాచిన దేవా (2)</a:t>
-              </a:r>
-              <a:br>
-                <a:rPr lang="te-IN" sz="2000" dirty="0">
-                  <a:latin typeface="Ramabhadra" panose="02000600000000000000" pitchFamily="2" charset="0"/>
-                  <a:cs typeface="Ramabhadra" panose="02000600000000000000" pitchFamily="2" charset="0"/>
-                </a:rPr>
-              </a:br>
-              <a:r>
-                <a:rPr lang="te-IN" sz="2000" dirty="0">
-                  <a:latin typeface="Ramabhadra" panose="02000600000000000000" pitchFamily="2" charset="0"/>
-                  <a:cs typeface="Ramabhadra" panose="02000600000000000000" pitchFamily="2" charset="0"/>
-                </a:rPr>
-                <a:t>ఇకను కూడా మాకు తోడు నీడ నీవే కదా (2)        </a:t>
-              </a:r>
-            </a:p>
-            <a:p>
-              <a:endParaRPr lang="te-IN" sz="2000" dirty="0">
+                <a:rPr lang="te-IN" sz="2200" dirty="0">
+                  <a:latin typeface="Ramabhadra" panose="02000600000000000000" pitchFamily="2" charset="0"/>
+                  <a:cs typeface="Ramabhadra" panose="02000600000000000000" pitchFamily="2" charset="0"/>
+                </a:rPr>
+                <a:t>యేసు నీకృపలో - మము కాపాడుము</a:t>
+              </a:r>
+              <a:r>
+                <a:rPr lang="en-IN" sz="2200" dirty="0">
+                  <a:latin typeface="Ramabhadra" panose="02000600000000000000" pitchFamily="2" charset="0"/>
+                  <a:cs typeface="Ramabhadra" panose="02000600000000000000" pitchFamily="2" charset="0"/>
+                </a:rPr>
+                <a:t> </a:t>
+              </a:r>
+              <a:r>
+                <a:rPr lang="te-IN" sz="2200" dirty="0">
+                  <a:latin typeface="Ramabhadra" panose="02000600000000000000" pitchFamily="2" charset="0"/>
+                  <a:cs typeface="Ramabhadra" panose="02000600000000000000" pitchFamily="2" charset="0"/>
+                </a:rPr>
+                <a:t>దేవా</a:t>
+              </a:r>
+              <a:endParaRPr lang="en-IN" sz="2200" dirty="0">
                 <a:latin typeface="Ramabhadra" panose="02000600000000000000" pitchFamily="2" charset="0"/>
                 <a:cs typeface="Ramabhadra" panose="02000600000000000000" pitchFamily="2" charset="0"/>
               </a:endParaRPr>
             </a:p>
             <a:p>
               <a:r>
-                <a:rPr lang="te-IN" sz="2000" dirty="0">
-                  <a:latin typeface="Ramabhadra" panose="02000600000000000000" pitchFamily="2" charset="0"/>
-                  <a:cs typeface="Ramabhadra" panose="02000600000000000000" pitchFamily="2" charset="0"/>
-                </a:rPr>
-                <a:t>ఎన్ని ఏళ్ళు గడచినా –</a:t>
-              </a:r>
-              <a:endParaRPr lang="en-IN" sz="2000" dirty="0">
+                <a:rPr lang="te-IN" sz="2200" dirty="0">
+                  <a:latin typeface="Ramabhadra" panose="02000600000000000000" pitchFamily="2" charset="0"/>
+                  <a:cs typeface="Ramabhadra" panose="02000600000000000000" pitchFamily="2" charset="0"/>
+                </a:rPr>
+                <a:t>మమ్ము రక్షించి </a:t>
+              </a:r>
+              <a:r>
+                <a:rPr lang="en-IN" sz="2200" dirty="0">
+                  <a:latin typeface="Ramabhadra" panose="02000600000000000000" pitchFamily="2" charset="0"/>
+                  <a:cs typeface="Ramabhadra" panose="02000600000000000000" pitchFamily="2" charset="0"/>
+                </a:rPr>
+                <a:t>- </a:t>
+              </a:r>
+              <a:r>
+                <a:rPr lang="te-IN" sz="2200" dirty="0">
+                  <a:latin typeface="Ramabhadra" panose="02000600000000000000" pitchFamily="2" charset="0"/>
+                  <a:cs typeface="Ramabhadra" panose="02000600000000000000" pitchFamily="2" charset="0"/>
+                </a:rPr>
+                <a:t>నిత్య రాజ్యములో</a:t>
+              </a:r>
+              <a:endParaRPr lang="en-IN" sz="2200" dirty="0">
                 <a:latin typeface="Ramabhadra" panose="02000600000000000000" pitchFamily="2" charset="0"/>
                 <a:cs typeface="Ramabhadra" panose="02000600000000000000" pitchFamily="2" charset="0"/>
               </a:endParaRPr>
             </a:p>
             <a:p>
               <a:r>
-                <a:rPr lang="te-IN" sz="2000" dirty="0">
-                  <a:latin typeface="Ramabhadra" panose="02000600000000000000" pitchFamily="2" charset="0"/>
-                  <a:cs typeface="Ramabhadra" panose="02000600000000000000" pitchFamily="2" charset="0"/>
-                </a:rPr>
-                <a:t>ఎన్ని తరాలు మారినా (2)</a:t>
-              </a:r>
-              <a:br>
-                <a:rPr lang="te-IN" sz="2000" dirty="0">
-                  <a:latin typeface="Ramabhadra" panose="02000600000000000000" pitchFamily="2" charset="0"/>
-                  <a:cs typeface="Ramabhadra" panose="02000600000000000000" pitchFamily="2" charset="0"/>
-                </a:rPr>
-              </a:br>
-              <a:r>
-                <a:rPr lang="te-IN" sz="2000" dirty="0">
-                  <a:latin typeface="Ramabhadra" panose="02000600000000000000" pitchFamily="2" charset="0"/>
-                  <a:cs typeface="Ramabhadra" panose="02000600000000000000" pitchFamily="2" charset="0"/>
-                </a:rPr>
-                <a:t>మారని వీడని ప్రేమే నీదయ్యా</a:t>
-              </a:r>
-              <a:br>
-                <a:rPr lang="te-IN" sz="2000" dirty="0">
-                  <a:latin typeface="Ramabhadra" panose="02000600000000000000" pitchFamily="2" charset="0"/>
-                  <a:cs typeface="Ramabhadra" panose="02000600000000000000" pitchFamily="2" charset="0"/>
-                </a:rPr>
-              </a:br>
-              <a:r>
-                <a:rPr lang="te-IN" sz="2000" dirty="0">
-                  <a:latin typeface="Ramabhadra" panose="02000600000000000000" pitchFamily="2" charset="0"/>
-                  <a:cs typeface="Ramabhadra" panose="02000600000000000000" pitchFamily="2" charset="0"/>
-                </a:rPr>
-                <a:t>మార్చిన నా జీవితం నీకే యేసయ్యా (2)  </a:t>
-              </a:r>
-            </a:p>
-            <a:p>
-              <a:r>
-                <a:rPr lang="te-IN" sz="2000" dirty="0">
-                  <a:latin typeface="Ramabhadra" panose="02000600000000000000" pitchFamily="2" charset="0"/>
-                  <a:cs typeface="Ramabhadra" panose="02000600000000000000" pitchFamily="2" charset="0"/>
-                </a:rPr>
-                <a:t>       </a:t>
-              </a:r>
-            </a:p>
-            <a:p>
-              <a:r>
-                <a:rPr lang="te-IN" sz="2000" dirty="0">
-                  <a:latin typeface="Ramabhadra" panose="02000600000000000000" pitchFamily="2" charset="0"/>
-                  <a:cs typeface="Ramabhadra" panose="02000600000000000000" pitchFamily="2" charset="0"/>
-                </a:rPr>
-                <a:t>నీవు చేసిన మేలులు –</a:t>
-              </a:r>
-              <a:endParaRPr lang="en-IN" sz="2000" dirty="0">
+                <a:rPr lang="te-IN" sz="2200" dirty="0">
+                  <a:latin typeface="Ramabhadra" panose="02000600000000000000" pitchFamily="2" charset="0"/>
+                  <a:cs typeface="Ramabhadra" panose="02000600000000000000" pitchFamily="2" charset="0"/>
+                </a:rPr>
+                <a:t>నడుపుము మా ప్రభువా - నడుపుము మా ప్రభువా</a:t>
+              </a:r>
+              <a:endParaRPr lang="en-IN" sz="2200" dirty="0">
                 <a:latin typeface="Ramabhadra" panose="02000600000000000000" pitchFamily="2" charset="0"/>
                 <a:cs typeface="Ramabhadra" panose="02000600000000000000" pitchFamily="2" charset="0"/>
               </a:endParaRPr>
             </a:p>
             <a:p>
-              <a:r>
-                <a:rPr lang="te-IN" sz="2000" dirty="0">
-                  <a:latin typeface="Ramabhadra" panose="02000600000000000000" pitchFamily="2" charset="0"/>
-                  <a:cs typeface="Ramabhadra" panose="02000600000000000000" pitchFamily="2" charset="0"/>
-                </a:rPr>
-                <a:t>తలచుకుందును అనుదినం (2)</a:t>
-              </a:r>
-              <a:br>
-                <a:rPr lang="te-IN" sz="2000" dirty="0">
-                  <a:latin typeface="Ramabhadra" panose="02000600000000000000" pitchFamily="2" charset="0"/>
-                  <a:cs typeface="Ramabhadra" panose="02000600000000000000" pitchFamily="2" charset="0"/>
-                </a:rPr>
-              </a:br>
-              <a:r>
-                <a:rPr lang="te-IN" sz="2000" dirty="0">
-                  <a:latin typeface="Ramabhadra" panose="02000600000000000000" pitchFamily="2" charset="0"/>
-                  <a:cs typeface="Ramabhadra" panose="02000600000000000000" pitchFamily="2" charset="0"/>
-                </a:rPr>
-                <a:t>నా స్తుతి స్తోత్రము నీకే యేసయ్యా</a:t>
-              </a:r>
-              <a:br>
-                <a:rPr lang="te-IN" sz="2000" dirty="0">
-                  <a:latin typeface="Ramabhadra" panose="02000600000000000000" pitchFamily="2" charset="0"/>
-                  <a:cs typeface="Ramabhadra" panose="02000600000000000000" pitchFamily="2" charset="0"/>
-                </a:rPr>
-              </a:br>
-              <a:r>
-                <a:rPr lang="te-IN" sz="2000" dirty="0">
-                  <a:latin typeface="Ramabhadra" panose="02000600000000000000" pitchFamily="2" charset="0"/>
-                  <a:cs typeface="Ramabhadra" panose="02000600000000000000" pitchFamily="2" charset="0"/>
-                </a:rPr>
-                <a:t>వేరుగా ఏమియు చెల్లించలేనయ్యా (2) </a:t>
-              </a:r>
-            </a:p>
-            <a:p>
-              <a:r>
-                <a:rPr lang="te-IN" sz="2000" dirty="0">
-                  <a:latin typeface="Ramabhadra" panose="02000600000000000000" pitchFamily="2" charset="0"/>
-                  <a:cs typeface="Ramabhadra" panose="02000600000000000000" pitchFamily="2" charset="0"/>
-                </a:rPr>
-                <a:t>          </a:t>
-              </a:r>
-            </a:p>
-            <a:p>
-              <a:r>
-                <a:rPr lang="te-IN" sz="2000" dirty="0">
-                  <a:latin typeface="Ramabhadra" panose="02000600000000000000" pitchFamily="2" charset="0"/>
-                  <a:cs typeface="Ramabhadra" panose="02000600000000000000" pitchFamily="2" charset="0"/>
-                </a:rPr>
-                <a:t>దూరమైతిరి ఆప్తులు –</a:t>
-              </a:r>
-              <a:endParaRPr lang="en-IN" sz="2000" dirty="0">
+              <a:endParaRPr lang="en-IN" sz="2200" dirty="0">
                 <a:latin typeface="Ramabhadra" panose="02000600000000000000" pitchFamily="2" charset="0"/>
                 <a:cs typeface="Ramabhadra" panose="02000600000000000000" pitchFamily="2" charset="0"/>
               </a:endParaRPr>
             </a:p>
             <a:p>
               <a:r>
-                <a:rPr lang="te-IN" sz="2000" dirty="0">
-                  <a:latin typeface="Ramabhadra" panose="02000600000000000000" pitchFamily="2" charset="0"/>
-                  <a:cs typeface="Ramabhadra" panose="02000600000000000000" pitchFamily="2" charset="0"/>
-                </a:rPr>
-                <a:t>విడచిపోతిరి నా హితులు (2)</a:t>
-              </a:r>
-              <a:br>
-                <a:rPr lang="te-IN" sz="2000" dirty="0">
-                  <a:latin typeface="Ramabhadra" panose="02000600000000000000" pitchFamily="2" charset="0"/>
-                  <a:cs typeface="Ramabhadra" panose="02000600000000000000" pitchFamily="2" charset="0"/>
-                </a:rPr>
-              </a:br>
-              <a:r>
-                <a:rPr lang="te-IN" sz="2000" dirty="0">
-                  <a:latin typeface="Ramabhadra" panose="02000600000000000000" pitchFamily="2" charset="0"/>
-                  <a:cs typeface="Ramabhadra" panose="02000600000000000000" pitchFamily="2" charset="0"/>
-                </a:rPr>
-                <a:t>శోధన వేదన తీర్చిన యేసయ్యా</a:t>
-              </a:r>
-              <a:br>
-                <a:rPr lang="te-IN" sz="2000" dirty="0">
-                  <a:latin typeface="Ramabhadra" panose="02000600000000000000" pitchFamily="2" charset="0"/>
-                  <a:cs typeface="Ramabhadra" panose="02000600000000000000" pitchFamily="2" charset="0"/>
-                </a:rPr>
-              </a:br>
-              <a:r>
-                <a:rPr lang="te-IN" sz="2000" dirty="0">
-                  <a:latin typeface="Ramabhadra" panose="02000600000000000000" pitchFamily="2" charset="0"/>
-                  <a:cs typeface="Ramabhadra" panose="02000600000000000000" pitchFamily="2" charset="0"/>
-                </a:rPr>
-                <a:t>తల్లిలా తండ్రిలా కాచిన యేసయ్యా (2) </a:t>
+                <a:rPr lang="te-IN" sz="2200" dirty="0">
+                  <a:latin typeface="Ramabhadra" panose="02000600000000000000" pitchFamily="2" charset="0"/>
+                  <a:cs typeface="Ramabhadra" panose="02000600000000000000" pitchFamily="2" charset="0"/>
+                </a:rPr>
+                <a:t>సిలువను మోసుకొని - సువార్త చాటింప</a:t>
+              </a:r>
+              <a:endParaRPr lang="en-IN" sz="2200" dirty="0">
+                <a:latin typeface="Ramabhadra" panose="02000600000000000000" pitchFamily="2" charset="0"/>
+                <a:cs typeface="Ramabhadra" panose="02000600000000000000" pitchFamily="2" charset="0"/>
+              </a:endParaRPr>
+            </a:p>
+            <a:p>
+              <a:r>
+                <a:rPr lang="te-IN" sz="2200" dirty="0">
+                  <a:latin typeface="Ramabhadra" panose="02000600000000000000" pitchFamily="2" charset="0"/>
+                  <a:cs typeface="Ramabhadra" panose="02000600000000000000" pitchFamily="2" charset="0"/>
+                </a:rPr>
+                <a:t>విలువగు నీ శక్తిచే - నిత్యము నడిపించు</a:t>
+              </a:r>
+            </a:p>
+            <a:p>
+              <a:r>
+                <a:rPr lang="te-IN" sz="2200" dirty="0">
+                  <a:latin typeface="Ramabhadra" panose="02000600000000000000" pitchFamily="2" charset="0"/>
+                  <a:cs typeface="Ramabhadra" panose="02000600000000000000" pitchFamily="2" charset="0"/>
+                </a:rPr>
+                <a:t>యేసు నీ రక్తములో - శుద్దిపరచి నన్ను</a:t>
+              </a:r>
+            </a:p>
+            <a:p>
+              <a:r>
+                <a:rPr lang="te-IN" sz="2200" dirty="0">
+                  <a:latin typeface="Ramabhadra" panose="02000600000000000000" pitchFamily="2" charset="0"/>
+                  <a:cs typeface="Ramabhadra" panose="02000600000000000000" pitchFamily="2" charset="0"/>
+                </a:rPr>
+                <a:t>నిలుపుము జ్యోతివలె - నిలుపుము జ్యోతివలె  </a:t>
+              </a:r>
+            </a:p>
+            <a:p>
+              <a:endParaRPr lang="te-IN" sz="2200" dirty="0">
+                <a:latin typeface="Ramabhadra" panose="02000600000000000000" pitchFamily="2" charset="0"/>
+                <a:cs typeface="Ramabhadra" panose="02000600000000000000" pitchFamily="2" charset="0"/>
+              </a:endParaRPr>
+            </a:p>
+            <a:p>
+              <a:r>
+                <a:rPr lang="te-IN" sz="2200" dirty="0">
+                  <a:latin typeface="Ramabhadra" panose="02000600000000000000" pitchFamily="2" charset="0"/>
+                  <a:cs typeface="Ramabhadra" panose="02000600000000000000" pitchFamily="2" charset="0"/>
+                </a:rPr>
+                <a:t>కృంగిన వేళలలో - అలసిన సమయములో</a:t>
+              </a:r>
+            </a:p>
+            <a:p>
+              <a:r>
+                <a:rPr lang="te-IN" sz="2200" dirty="0">
+                  <a:latin typeface="Ramabhadra" panose="02000600000000000000" pitchFamily="2" charset="0"/>
+                  <a:cs typeface="Ramabhadra" panose="02000600000000000000" pitchFamily="2" charset="0"/>
+                </a:rPr>
+                <a:t>నా చేయి విడువకుము - నన్ను నిలబెట్టు</a:t>
+              </a:r>
+            </a:p>
+            <a:p>
+              <a:r>
+                <a:rPr lang="te-IN" sz="2200" dirty="0">
+                  <a:latin typeface="Ramabhadra" panose="02000600000000000000" pitchFamily="2" charset="0"/>
+                  <a:cs typeface="Ramabhadra" panose="02000600000000000000" pitchFamily="2" charset="0"/>
+                </a:rPr>
+                <a:t>యేసు నీ రక్తములో - శుద్దిపరచి నన్ను</a:t>
+              </a:r>
+            </a:p>
+            <a:p>
+              <a:r>
+                <a:rPr lang="te-IN" sz="2200" dirty="0">
+                  <a:latin typeface="Ramabhadra" panose="02000600000000000000" pitchFamily="2" charset="0"/>
+                  <a:cs typeface="Ramabhadra" panose="02000600000000000000" pitchFamily="2" charset="0"/>
+                </a:rPr>
+                <a:t>నిలుపుము జ్యోతివలె - నిలుపుము జ్యోతివలె</a:t>
               </a:r>
             </a:p>
           </p:txBody>
@@ -3785,8 +3793,8 @@
           </p:nvSpPr>
           <p:spPr>
             <a:xfrm>
-              <a:off x="343961" y="809050"/>
-              <a:ext cx="4648200" cy="5632311"/>
+              <a:off x="343961" y="716954"/>
+              <a:ext cx="4648200" cy="5509200"/>
             </a:xfrm>
             <a:prstGeom prst="rect">
               <a:avLst/>
@@ -3803,11 +3811,18 @@
                 <a:defRPr/>
               </a:pPr>
               <a:r>
-                <a:rPr lang="te-IN" sz="2400" dirty="0">
-                  <a:latin typeface="Ramabhadra" panose="02000600000000000000" pitchFamily="2" charset="0"/>
-                  <a:cs typeface="Ramabhadra" panose="02000600000000000000" pitchFamily="2" charset="0"/>
-                </a:rPr>
-                <a:t>యేసయ్యా.. యేసయ్యా.. యేసయ్యా.. యేసయ్యా..</a:t>
+                <a:rPr lang="te-IN" sz="2200" dirty="0">
+                  <a:latin typeface="Ramabhadra" panose="02000600000000000000" pitchFamily="2" charset="0"/>
+                  <a:cs typeface="Ramabhadra" panose="02000600000000000000" pitchFamily="2" charset="0"/>
+                </a:rPr>
+                <a:t>మదుర స్తుతులతో </a:t>
+              </a:r>
+              <a:r>
+                <a:rPr lang="en-IN" sz="2200" dirty="0">
+                  <a:latin typeface="Ramabhadra" panose="02000600000000000000" pitchFamily="2" charset="0"/>
+                  <a:cs typeface="Ramabhadra" panose="02000600000000000000" pitchFamily="2" charset="0"/>
+                </a:rPr>
+                <a:t>–</a:t>
               </a:r>
             </a:p>
             <a:p>
@@ -3815,42 +3830,64 @@
                 <a:defRPr/>
               </a:pPr>
               <a:r>
-                <a:rPr lang="te-IN" sz="2400" dirty="0">
-                  <a:latin typeface="Ramabhadra" panose="02000600000000000000" pitchFamily="2" charset="0"/>
-                  <a:cs typeface="Ramabhadra" panose="02000600000000000000" pitchFamily="2" charset="0"/>
-                </a:rPr>
-                <a:t>నిన్నే నిన్నే నే కొలుతునయ్యా</a:t>
-              </a:r>
+                <a:rPr lang="te-IN" sz="2200" dirty="0">
+                  <a:latin typeface="Ramabhadra" panose="02000600000000000000" pitchFamily="2" charset="0"/>
+                  <a:cs typeface="Ramabhadra" panose="02000600000000000000" pitchFamily="2" charset="0"/>
+                </a:rPr>
+                <a:t>మ్రోదములరగ సదమదని</a:t>
+              </a:r>
+              <a:r>
+                <a:rPr lang="en-US" sz="2200" dirty="0">
+                  <a:latin typeface="Ramabhadra" panose="02000600000000000000" pitchFamily="2" charset="0"/>
+                  <a:cs typeface="Ramabhadra" panose="02000600000000000000" pitchFamily="2" charset="0"/>
+                </a:rPr>
+                <a:t> </a:t>
+              </a:r>
+              <a:r>
+                <a:rPr lang="te-IN" sz="2200" dirty="0">
+                  <a:latin typeface="Ramabhadra" panose="02000600000000000000" pitchFamily="2" charset="0"/>
+                  <a:cs typeface="Ramabhadra" panose="02000600000000000000" pitchFamily="2" charset="0"/>
+                </a:rPr>
+                <a:t>పాడుదమా</a:t>
+              </a:r>
+              <a:endParaRPr lang="en-IN" sz="2200" dirty="0">
+                <a:latin typeface="Ramabhadra" panose="02000600000000000000" pitchFamily="2" charset="0"/>
+                <a:cs typeface="Ramabhadra" panose="02000600000000000000" pitchFamily="2" charset="0"/>
+              </a:endParaRPr>
             </a:p>
             <a:p>
               <a:pPr defTabSz="439781">
                 <a:defRPr/>
               </a:pPr>
               <a:r>
-                <a:rPr lang="te-IN" sz="2400" dirty="0">
-                  <a:latin typeface="Ramabhadra" panose="02000600000000000000" pitchFamily="2" charset="0"/>
-                  <a:cs typeface="Ramabhadra" panose="02000600000000000000" pitchFamily="2" charset="0"/>
-                </a:rPr>
-                <a:t>నీవే నీవే నా రాజువయ్యా (2)</a:t>
-              </a:r>
+                <a:rPr lang="te-IN" sz="2200" dirty="0">
+                  <a:latin typeface="Ramabhadra" panose="02000600000000000000" pitchFamily="2" charset="0"/>
+                  <a:cs typeface="Ramabhadra" panose="02000600000000000000" pitchFamily="2" charset="0"/>
+                </a:rPr>
+                <a:t>క్రీస్తుకు గానం చేయుదమా –</a:t>
+              </a:r>
+              <a:endParaRPr lang="en-IN" sz="2200" dirty="0">
+                <a:latin typeface="Ramabhadra" panose="02000600000000000000" pitchFamily="2" charset="0"/>
+                <a:cs typeface="Ramabhadra" panose="02000600000000000000" pitchFamily="2" charset="0"/>
+              </a:endParaRPr>
             </a:p>
             <a:p>
               <a:pPr defTabSz="439781">
                 <a:defRPr/>
               </a:pPr>
               <a:r>
-                <a:rPr lang="te-IN" sz="2400" dirty="0">
-                  <a:latin typeface="Ramabhadra" panose="02000600000000000000" pitchFamily="2" charset="0"/>
-                  <a:cs typeface="Ramabhadra" panose="02000600000000000000" pitchFamily="2" charset="0"/>
-                </a:rPr>
-                <a:t>యేసయ్య యేసయ్య యేసయ్యా…</a:t>
+                <a:rPr lang="te-IN" sz="2200" dirty="0">
+                  <a:latin typeface="Ramabhadra" panose="02000600000000000000" pitchFamily="2" charset="0"/>
+                  <a:cs typeface="Ramabhadra" panose="02000600000000000000" pitchFamily="2" charset="0"/>
+                </a:rPr>
+                <a:t>నూతన గానము చేయుదమా</a:t>
               </a:r>
             </a:p>
             <a:p>
               <a:pPr defTabSz="439781">
                 <a:defRPr/>
               </a:pPr>
-              <a:endParaRPr lang="te-IN" sz="2400" dirty="0">
+              <a:endParaRPr lang="en-IN" sz="2200" dirty="0">
                 <a:latin typeface="Ramabhadra" panose="02000600000000000000" pitchFamily="2" charset="0"/>
                 <a:cs typeface="Ramabhadra" panose="02000600000000000000" pitchFamily="2" charset="0"/>
               </a:endParaRPr>
@@ -3860,11 +3897,25 @@
                 <a:defRPr/>
               </a:pPr>
               <a:r>
-                <a:rPr lang="te-IN" sz="2400" dirty="0">
-                  <a:latin typeface="Ramabhadra" panose="02000600000000000000" pitchFamily="2" charset="0"/>
-                  <a:cs typeface="Ramabhadra" panose="02000600000000000000" pitchFamily="2" charset="0"/>
-                </a:rPr>
-                <a:t>కొండలలో లోయలలో</a:t>
+                <a:rPr lang="te-IN" sz="2200" dirty="0">
+                  <a:latin typeface="Ramabhadra" panose="02000600000000000000" pitchFamily="2" charset="0"/>
+                  <a:cs typeface="Ramabhadra" panose="02000600000000000000" pitchFamily="2" charset="0"/>
+                </a:rPr>
+                <a:t>యేసే దేవుడని దేవుని కుమారుడని (</a:t>
+              </a:r>
+              <a:r>
+                <a:rPr lang="en-IN" sz="2200" dirty="0">
+                  <a:latin typeface="Ramabhadra" panose="02000600000000000000" pitchFamily="2" charset="0"/>
+                  <a:cs typeface="Ramabhadra" panose="02000600000000000000" pitchFamily="2" charset="0"/>
+                </a:rPr>
+                <a:t>2</a:t>
+              </a:r>
+              <a:r>
+                <a:rPr lang="te-IN" sz="2200" dirty="0">
+                  <a:latin typeface="Ramabhadra" panose="02000600000000000000" pitchFamily="2" charset="0"/>
+                  <a:cs typeface="Ramabhadra" panose="02000600000000000000" pitchFamily="2" charset="0"/>
+                </a:rPr>
+                <a:t>)</a:t>
               </a:r>
             </a:p>
             <a:p>
@@ -3872,42 +3923,54 @@
                 <a:defRPr/>
               </a:pPr>
               <a:r>
-                <a:rPr lang="te-IN" sz="2400" dirty="0">
-                  <a:latin typeface="Ramabhadra" panose="02000600000000000000" pitchFamily="2" charset="0"/>
-                  <a:cs typeface="Ramabhadra" panose="02000600000000000000" pitchFamily="2" charset="0"/>
-                </a:rPr>
-                <a:t>అడవులలో ఎడారులలో (2)</a:t>
-              </a:r>
+                <a:rPr lang="te-IN" sz="2200" dirty="0">
+                  <a:latin typeface="Ramabhadra" panose="02000600000000000000" pitchFamily="2" charset="0"/>
+                  <a:cs typeface="Ramabhadra" panose="02000600000000000000" pitchFamily="2" charset="0"/>
+                </a:rPr>
+                <a:t>ఆయనే పూజ్యడని –</a:t>
+              </a:r>
+              <a:endParaRPr lang="en-IN" sz="2200" dirty="0">
+                <a:latin typeface="Ramabhadra" panose="02000600000000000000" pitchFamily="2" charset="0"/>
+                <a:cs typeface="Ramabhadra" panose="02000600000000000000" pitchFamily="2" charset="0"/>
+              </a:endParaRPr>
             </a:p>
             <a:p>
               <a:pPr defTabSz="439781">
                 <a:defRPr/>
               </a:pPr>
               <a:r>
-                <a:rPr lang="te-IN" sz="2400" dirty="0">
-                  <a:latin typeface="Ramabhadra" panose="02000600000000000000" pitchFamily="2" charset="0"/>
-                  <a:cs typeface="Ramabhadra" panose="02000600000000000000" pitchFamily="2" charset="0"/>
-                </a:rPr>
-                <a:t>నన్ను గమనించినావా</a:t>
-              </a:r>
+                <a:rPr lang="te-IN" sz="2200" dirty="0">
+                  <a:latin typeface="Ramabhadra" panose="02000600000000000000" pitchFamily="2" charset="0"/>
+                  <a:cs typeface="Ramabhadra" panose="02000600000000000000" pitchFamily="2" charset="0"/>
+                </a:rPr>
+                <a:t>ప్రభువుకు గానం చేయుదమా</a:t>
+              </a:r>
+              <a:endParaRPr lang="en-US" sz="2200" dirty="0">
+                <a:latin typeface="Ramabhadra" panose="02000600000000000000" pitchFamily="2" charset="0"/>
+                <a:cs typeface="Ramabhadra" panose="02000600000000000000" pitchFamily="2" charset="0"/>
+              </a:endParaRPr>
             </a:p>
             <a:p>
               <a:pPr defTabSz="439781">
                 <a:defRPr/>
               </a:pPr>
               <a:r>
-                <a:rPr lang="te-IN" sz="2400" dirty="0">
-                  <a:latin typeface="Ramabhadra" panose="02000600000000000000" pitchFamily="2" charset="0"/>
-                  <a:cs typeface="Ramabhadra" panose="02000600000000000000" pitchFamily="2" charset="0"/>
-                </a:rPr>
-                <a:t>నన్ను నడిపించినావా (2)</a:t>
-              </a:r>
+                <a:rPr lang="te-IN" sz="2200" dirty="0">
+                  <a:latin typeface="Ramabhadra" panose="02000600000000000000" pitchFamily="2" charset="0"/>
+                  <a:cs typeface="Ramabhadra" panose="02000600000000000000" pitchFamily="2" charset="0"/>
+                </a:rPr>
+                <a:t>నూతన గానము చేయుదమా</a:t>
+              </a:r>
+              <a:endParaRPr lang="en-US" sz="2200" dirty="0">
+                <a:latin typeface="Ramabhadra" panose="02000600000000000000" pitchFamily="2" charset="0"/>
+                <a:cs typeface="Ramabhadra" panose="02000600000000000000" pitchFamily="2" charset="0"/>
+              </a:endParaRPr>
             </a:p>
             <a:p>
               <a:pPr defTabSz="439781">
                 <a:defRPr/>
               </a:pPr>
-              <a:endParaRPr lang="te-IN" sz="2400" dirty="0">
+              <a:endParaRPr lang="en-US" sz="2200" dirty="0">
                 <a:latin typeface="Ramabhadra" panose="02000600000000000000" pitchFamily="2" charset="0"/>
                 <a:cs typeface="Ramabhadra" panose="02000600000000000000" pitchFamily="2" charset="0"/>
               </a:endParaRPr>
@@ -3917,47 +3980,91 @@
                 <a:defRPr/>
               </a:pPr>
               <a:r>
-                <a:rPr lang="te-IN" sz="2400" dirty="0">
-                  <a:latin typeface="Ramabhadra" panose="02000600000000000000" pitchFamily="2" charset="0"/>
-                  <a:cs typeface="Ramabhadra" panose="02000600000000000000" pitchFamily="2" charset="0"/>
-                </a:rPr>
-                <a:t>ఆత్మీయులే నన్ను అవమానించగా</a:t>
-              </a:r>
+                <a:rPr lang="te-IN" sz="2200" dirty="0">
+                  <a:latin typeface="Ramabhadra" panose="02000600000000000000" pitchFamily="2" charset="0"/>
+                  <a:cs typeface="Ramabhadra" panose="02000600000000000000" pitchFamily="2" charset="0"/>
+                </a:rPr>
+                <a:t>స్వర మండలముతో సితార సునాదముతో</a:t>
+              </a:r>
+              <a:endParaRPr lang="en-US" sz="2200" dirty="0">
+                <a:latin typeface="Ramabhadra" panose="02000600000000000000" pitchFamily="2" charset="0"/>
+                <a:cs typeface="Ramabhadra" panose="02000600000000000000" pitchFamily="2" charset="0"/>
+              </a:endParaRPr>
             </a:p>
             <a:p>
               <a:pPr defTabSz="439781">
                 <a:defRPr/>
               </a:pPr>
               <a:r>
-                <a:rPr lang="te-IN" sz="2400" dirty="0">
-                  <a:latin typeface="Ramabhadra" panose="02000600000000000000" pitchFamily="2" charset="0"/>
-                  <a:cs typeface="Ramabhadra" panose="02000600000000000000" pitchFamily="2" charset="0"/>
-                </a:rPr>
-                <a:t>అన్యులు నన్ను అపహసించగా (2)</a:t>
-              </a:r>
+                <a:rPr lang="te-IN" sz="2200" dirty="0">
+                  <a:latin typeface="Ramabhadra" panose="02000600000000000000" pitchFamily="2" charset="0"/>
+                  <a:cs typeface="Ramabhadra" panose="02000600000000000000" pitchFamily="2" charset="0"/>
+                </a:rPr>
+                <a:t>తంతి వాయిద్యములతో పిల్లన గ్రోవులతో</a:t>
+              </a:r>
+              <a:endParaRPr lang="en-US" sz="2200" dirty="0">
+                <a:latin typeface="Ramabhadra" panose="02000600000000000000" pitchFamily="2" charset="0"/>
+                <a:cs typeface="Ramabhadra" panose="02000600000000000000" pitchFamily="2" charset="0"/>
+              </a:endParaRPr>
             </a:p>
             <a:p>
               <a:pPr defTabSz="439781">
                 <a:defRPr/>
               </a:pPr>
               <a:r>
-                <a:rPr lang="te-IN" sz="2400" dirty="0">
-                  <a:latin typeface="Ramabhadra" panose="02000600000000000000" pitchFamily="2" charset="0"/>
-                  <a:cs typeface="Ramabhadra" panose="02000600000000000000" pitchFamily="2" charset="0"/>
-                </a:rPr>
-                <a:t>అండ నీవైతివయ్యా</a:t>
-              </a:r>
+                <a:rPr lang="te-IN" sz="2200" dirty="0">
+                  <a:latin typeface="Ramabhadra" panose="02000600000000000000" pitchFamily="2" charset="0"/>
+                  <a:cs typeface="Ramabhadra" panose="02000600000000000000" pitchFamily="2" charset="0"/>
+                </a:rPr>
+                <a:t>మ్రోగుతాంబూలతో బూరల నాదముతో</a:t>
+              </a:r>
+              <a:endParaRPr lang="en-IN" sz="2200" dirty="0">
+                <a:latin typeface="Ramabhadra" panose="02000600000000000000" pitchFamily="2" charset="0"/>
+                <a:cs typeface="Ramabhadra" panose="02000600000000000000" pitchFamily="2" charset="0"/>
+              </a:endParaRPr>
             </a:p>
             <a:p>
               <a:pPr defTabSz="439781">
                 <a:defRPr/>
               </a:pPr>
               <a:r>
-                <a:rPr lang="te-IN" sz="2400" dirty="0">
-                  <a:latin typeface="Ramabhadra" panose="02000600000000000000" pitchFamily="2" charset="0"/>
-                  <a:cs typeface="Ramabhadra" panose="02000600000000000000" pitchFamily="2" charset="0"/>
-                </a:rPr>
-                <a:t>నా.. కొండ నీవే యేసయ్యా (2)</a:t>
+                <a:rPr lang="te-IN" sz="2200" dirty="0">
+                  <a:latin typeface="Ramabhadra" panose="02000600000000000000" pitchFamily="2" charset="0"/>
+                  <a:cs typeface="Ramabhadra" panose="02000600000000000000" pitchFamily="2" charset="0"/>
+                </a:rPr>
+                <a:t>గంభీర జయ ధ్వనులతో</a:t>
+              </a:r>
+              <a:endParaRPr lang="en-IN" sz="2200" dirty="0">
+                <a:latin typeface="Ramabhadra" panose="02000600000000000000" pitchFamily="2" charset="0"/>
+                <a:cs typeface="Ramabhadra" panose="02000600000000000000" pitchFamily="2" charset="0"/>
+              </a:endParaRPr>
+            </a:p>
+            <a:p>
+              <a:pPr defTabSz="439781">
+                <a:defRPr/>
+              </a:pPr>
+              <a:r>
+                <a:rPr lang="te-IN" sz="2200" dirty="0">
+                  <a:latin typeface="Ramabhadra" panose="02000600000000000000" pitchFamily="2" charset="0"/>
+                  <a:cs typeface="Ramabhadra" panose="02000600000000000000" pitchFamily="2" charset="0"/>
+                </a:rPr>
+                <a:t>ప్రభువుకు గానము చేయుదమా</a:t>
+              </a:r>
+              <a:endParaRPr lang="en-US" sz="2200" dirty="0">
+                <a:latin typeface="Ramabhadra" panose="02000600000000000000" pitchFamily="2" charset="0"/>
+                <a:cs typeface="Ramabhadra" panose="02000600000000000000" pitchFamily="2" charset="0"/>
+              </a:endParaRPr>
+            </a:p>
+            <a:p>
+              <a:pPr defTabSz="439781">
+                <a:defRPr/>
+              </a:pPr>
+              <a:r>
+                <a:rPr lang="te-IN" sz="2200" dirty="0">
+                  <a:latin typeface="Ramabhadra" panose="02000600000000000000" pitchFamily="2" charset="0"/>
+                  <a:cs typeface="Ramabhadra" panose="02000600000000000000" pitchFamily="2" charset="0"/>
+                </a:rPr>
+                <a:t>నూతన గానము చేయుదమా</a:t>
               </a:r>
             </a:p>
           </p:txBody>
@@ -4040,9 +4147,9 @@
         <p:grpSpPr>
           <a:xfrm>
             <a:off x="5104338" y="182031"/>
-            <a:ext cx="4943469" cy="6493935"/>
+            <a:ext cx="4932894" cy="6493935"/>
             <a:chOff x="160868" y="182032"/>
-            <a:chExt cx="4943469" cy="6493935"/>
+            <a:chExt cx="4932894" cy="6493935"/>
           </a:xfrm>
         </p:grpSpPr>
         <p:sp>
@@ -4114,8 +4221,8 @@
           </p:nvSpPr>
           <p:spPr>
             <a:xfrm>
-              <a:off x="354536" y="716955"/>
-              <a:ext cx="4749801" cy="5909310"/>
+              <a:off x="343961" y="799864"/>
+              <a:ext cx="4749801" cy="5693866"/>
             </a:xfrm>
             <a:prstGeom prst="rect">
               <a:avLst/>
@@ -4132,11 +4239,18 @@
                 <a:defRPr/>
               </a:pPr>
               <a:r>
-                <a:rPr lang="te-IN" sz="2100" dirty="0">
-                  <a:latin typeface="Ramabhadra" panose="02000600000000000000" pitchFamily="2" charset="0"/>
-                  <a:cs typeface="Ramabhadra" panose="02000600000000000000" pitchFamily="2" charset="0"/>
-                </a:rPr>
-                <a:t>వందనం త్రియేకుడా - ఘన మహిమ నీకెగా (2)</a:t>
+                <a:rPr lang="te-IN" sz="2600" dirty="0">
+                  <a:latin typeface="Ramabhadra" panose="02000600000000000000" pitchFamily="2" charset="0"/>
+                  <a:cs typeface="Ramabhadra" panose="02000600000000000000" pitchFamily="2" charset="0"/>
+                </a:rPr>
+                <a:t>తేజోమయా యేసయ్యా</a:t>
+              </a:r>
+              <a:r>
+                <a:rPr lang="en-US" sz="2600" dirty="0">
+                  <a:latin typeface="Ramabhadra" panose="02000600000000000000" pitchFamily="2" charset="0"/>
+                  <a:cs typeface="Ramabhadra" panose="02000600000000000000" pitchFamily="2" charset="0"/>
+                </a:rPr>
+                <a:t>-</a:t>
               </a:r>
             </a:p>
             <a:p>
@@ -4144,30 +4258,45 @@
                 <a:defRPr/>
               </a:pPr>
               <a:r>
-                <a:rPr lang="te-IN" sz="2100" dirty="0">
-                  <a:latin typeface="Ramabhadra" panose="02000600000000000000" pitchFamily="2" charset="0"/>
-                  <a:cs typeface="Ramabhadra" panose="02000600000000000000" pitchFamily="2" charset="0"/>
-                </a:rPr>
-                <a:t>ఏ పాటి వాడను యేసయ్యా, నన్ను కోరుకొంటివే</a:t>
-              </a:r>
+                <a:rPr lang="te-IN" sz="2600" dirty="0">
+                  <a:latin typeface="Ramabhadra" panose="02000600000000000000" pitchFamily="2" charset="0"/>
+                  <a:cs typeface="Ramabhadra" panose="02000600000000000000" pitchFamily="2" charset="0"/>
+                </a:rPr>
+                <a:t>స్తుతి పాత్రుడవు నీవయ్యా</a:t>
+              </a:r>
+              <a:endParaRPr lang="en-US" sz="2600" dirty="0">
+                <a:latin typeface="Ramabhadra" panose="02000600000000000000" pitchFamily="2" charset="0"/>
+                <a:cs typeface="Ramabhadra" panose="02000600000000000000" pitchFamily="2" charset="0"/>
+              </a:endParaRPr>
             </a:p>
             <a:p>
               <a:pPr defTabSz="439781">
                 <a:defRPr/>
               </a:pPr>
               <a:r>
-                <a:rPr lang="te-IN" sz="2100" dirty="0">
-                  <a:latin typeface="Ramabhadra" panose="02000600000000000000" pitchFamily="2" charset="0"/>
-                  <a:cs typeface="Ramabhadra" panose="02000600000000000000" pitchFamily="2" charset="0"/>
-                </a:rPr>
-                <a:t>ఏ పాటి దానను యేసయ్యా, నన్ను కోరుకొంటివే</a:t>
-              </a:r>
+                <a:rPr lang="te-IN" sz="2600" dirty="0">
+                  <a:latin typeface="Ramabhadra" panose="02000600000000000000" pitchFamily="2" charset="0"/>
+                  <a:cs typeface="Ramabhadra" panose="02000600000000000000" pitchFamily="2" charset="0"/>
+                </a:rPr>
+                <a:t>మహిమ ఘనత ప్రభావములు</a:t>
+              </a:r>
+              <a:endParaRPr lang="en-US" sz="2600" dirty="0">
+                <a:latin typeface="Ramabhadra" panose="02000600000000000000" pitchFamily="2" charset="0"/>
+                <a:cs typeface="Ramabhadra" panose="02000600000000000000" pitchFamily="2" charset="0"/>
+              </a:endParaRPr>
             </a:p>
             <a:p>
               <a:pPr defTabSz="439781">
                 <a:defRPr/>
               </a:pPr>
-              <a:endParaRPr lang="te-IN" sz="2100" dirty="0">
+              <a:r>
+                <a:rPr lang="te-IN" sz="2600" dirty="0">
+                  <a:latin typeface="Ramabhadra" panose="02000600000000000000" pitchFamily="2" charset="0"/>
+                  <a:cs typeface="Ramabhadra" panose="02000600000000000000" pitchFamily="2" charset="0"/>
+                </a:rPr>
+                <a:t>సమస్తము నీకేనయా</a:t>
+              </a:r>
+              <a:endParaRPr lang="en-US" sz="2600" dirty="0">
                 <a:latin typeface="Ramabhadra" panose="02000600000000000000" pitchFamily="2" charset="0"/>
                 <a:cs typeface="Ramabhadra" panose="02000600000000000000" pitchFamily="2" charset="0"/>
               </a:endParaRPr>
@@ -4176,162 +4305,143 @@
               <a:pPr defTabSz="439781">
                 <a:defRPr/>
               </a:pPr>
-              <a:r>
-                <a:rPr lang="te-IN" sz="2100" dirty="0">
-                  <a:latin typeface="Ramabhadra" panose="02000600000000000000" pitchFamily="2" charset="0"/>
-                  <a:cs typeface="Ramabhadra" panose="02000600000000000000" pitchFamily="2" charset="0"/>
-                </a:rPr>
-                <a:t>ఈవులెన్నెన్నో దయచేసితివి</a:t>
-              </a:r>
+              <a:endParaRPr lang="en-US" sz="2600" dirty="0">
+                <a:latin typeface="Ramabhadra" panose="02000600000000000000" pitchFamily="2" charset="0"/>
+                <a:cs typeface="Ramabhadra" panose="02000600000000000000" pitchFamily="2" charset="0"/>
+              </a:endParaRPr>
             </a:p>
             <a:p>
               <a:pPr defTabSz="439781">
                 <a:defRPr/>
               </a:pPr>
               <a:r>
-                <a:rPr lang="te-IN" sz="2100" dirty="0">
-                  <a:latin typeface="Ramabhadra" panose="02000600000000000000" pitchFamily="2" charset="0"/>
-                  <a:cs typeface="Ramabhadra" panose="02000600000000000000" pitchFamily="2" charset="0"/>
-                </a:rPr>
-                <a:t>నీ స్నేహమే నాకు స్థిరపరచితివి (2)</a:t>
-              </a:r>
+                <a:rPr lang="te-IN" sz="2600" dirty="0">
+                  <a:latin typeface="Ramabhadra" panose="02000600000000000000" pitchFamily="2" charset="0"/>
+                  <a:cs typeface="Ramabhadra" panose="02000600000000000000" pitchFamily="2" charset="0"/>
+                </a:rPr>
+                <a:t>నిజమైన దేవా నీవంటివాడు లేడు</a:t>
+              </a:r>
+              <a:endParaRPr lang="en-US" sz="2600" dirty="0">
+                <a:latin typeface="Ramabhadra" panose="02000600000000000000" pitchFamily="2" charset="0"/>
+                <a:cs typeface="Ramabhadra" panose="02000600000000000000" pitchFamily="2" charset="0"/>
+              </a:endParaRPr>
             </a:p>
             <a:p>
               <a:pPr defTabSz="439781">
                 <a:defRPr/>
               </a:pPr>
               <a:r>
-                <a:rPr lang="te-IN" sz="2100" dirty="0">
-                  <a:latin typeface="Ramabhadra" panose="02000600000000000000" pitchFamily="2" charset="0"/>
-                  <a:cs typeface="Ramabhadra" panose="02000600000000000000" pitchFamily="2" charset="0"/>
-                </a:rPr>
-                <a:t>నీ పాద సేవ చేయుట కన్నా</a:t>
-              </a:r>
+                <a:rPr lang="te-IN" sz="2600" dirty="0">
+                  <a:latin typeface="Ramabhadra" panose="02000600000000000000" pitchFamily="2" charset="0"/>
+                  <a:cs typeface="Ramabhadra" panose="02000600000000000000" pitchFamily="2" charset="0"/>
+                </a:rPr>
+                <a:t>మహాత్మ్యము గల నిన్ను పోలినవాడెవడు</a:t>
+              </a:r>
+              <a:endParaRPr lang="en-US" sz="2600" dirty="0">
+                <a:latin typeface="Ramabhadra" panose="02000600000000000000" pitchFamily="2" charset="0"/>
+                <a:cs typeface="Ramabhadra" panose="02000600000000000000" pitchFamily="2" charset="0"/>
+              </a:endParaRPr>
             </a:p>
             <a:p>
               <a:pPr defTabSz="439781">
                 <a:defRPr/>
               </a:pPr>
               <a:r>
-                <a:rPr lang="te-IN" sz="2100" dirty="0">
-                  <a:latin typeface="Ramabhadra" panose="02000600000000000000" pitchFamily="2" charset="0"/>
-                  <a:cs typeface="Ramabhadra" panose="02000600000000000000" pitchFamily="2" charset="0"/>
-                </a:rPr>
-                <a:t>విలువైన భాగ్యం లేదు (2) నాకూ</a:t>
-              </a:r>
+                <a:rPr lang="te-IN" sz="2600" dirty="0">
+                  <a:latin typeface="Ramabhadra" panose="02000600000000000000" pitchFamily="2" charset="0"/>
+                  <a:cs typeface="Ramabhadra" panose="02000600000000000000" pitchFamily="2" charset="0"/>
+                </a:rPr>
+                <a:t>నీ నామము ఘనమైనదయా –</a:t>
+              </a:r>
+              <a:endParaRPr lang="en-US" sz="2600" dirty="0">
+                <a:latin typeface="Ramabhadra" panose="02000600000000000000" pitchFamily="2" charset="0"/>
+                <a:cs typeface="Ramabhadra" panose="02000600000000000000" pitchFamily="2" charset="0"/>
+              </a:endParaRPr>
             </a:p>
             <a:p>
               <a:pPr defTabSz="439781">
                 <a:defRPr/>
               </a:pPr>
-              <a:endParaRPr lang="te-IN" sz="2100" dirty="0">
+              <a:r>
+                <a:rPr lang="te-IN" sz="2600" dirty="0">
+                  <a:latin typeface="Ramabhadra" panose="02000600000000000000" pitchFamily="2" charset="0"/>
+                  <a:cs typeface="Ramabhadra" panose="02000600000000000000" pitchFamily="2" charset="0"/>
+                </a:rPr>
+                <a:t>నరులు నీకు భయపడెదరయా</a:t>
+              </a:r>
+              <a:endParaRPr lang="en-US" sz="2600" dirty="0">
                 <a:latin typeface="Ramabhadra" panose="02000600000000000000" pitchFamily="2" charset="0"/>
                 <a:cs typeface="Ramabhadra" panose="02000600000000000000" pitchFamily="2" charset="0"/>
               </a:endParaRPr>
             </a:p>
             <a:p>
+              <a:pPr marL="457200" indent="-457200" defTabSz="439781">
+                <a:buAutoNum type="arabicPeriod"/>
+                <a:defRPr/>
+              </a:pPr>
+              <a:endParaRPr lang="en-US" sz="2600" dirty="0">
+                <a:latin typeface="Ramabhadra" panose="02000600000000000000" pitchFamily="2" charset="0"/>
+                <a:cs typeface="Ramabhadra" panose="02000600000000000000" pitchFamily="2" charset="0"/>
+              </a:endParaRPr>
+            </a:p>
+            <a:p>
               <a:pPr defTabSz="439781">
                 <a:defRPr/>
               </a:pPr>
               <a:r>
-                <a:rPr lang="te-IN" sz="2100" dirty="0">
-                  <a:latin typeface="Ramabhadra" panose="02000600000000000000" pitchFamily="2" charset="0"/>
-                  <a:cs typeface="Ramabhadra" panose="02000600000000000000" pitchFamily="2" charset="0"/>
-                </a:rPr>
-                <a:t>అవసరతలు ఏవైన తీర్చెడి</a:t>
-              </a:r>
+                <a:rPr lang="te-IN" sz="2600" dirty="0">
+                  <a:latin typeface="Ramabhadra" panose="02000600000000000000" pitchFamily="2" charset="0"/>
+                  <a:cs typeface="Ramabhadra" panose="02000600000000000000" pitchFamily="2" charset="0"/>
+                </a:rPr>
+                <a:t>జనములకు రాజా జీవముగలిగిన నాథా</a:t>
+              </a:r>
+              <a:endParaRPr lang="en-US" sz="2600" dirty="0">
+                <a:latin typeface="Ramabhadra" panose="02000600000000000000" pitchFamily="2" charset="0"/>
+                <a:cs typeface="Ramabhadra" panose="02000600000000000000" pitchFamily="2" charset="0"/>
+              </a:endParaRPr>
             </a:p>
             <a:p>
               <a:pPr defTabSz="439781">
                 <a:defRPr/>
               </a:pPr>
               <a:r>
-                <a:rPr lang="te-IN" sz="2100" dirty="0">
-                  <a:latin typeface="Ramabhadra" panose="02000600000000000000" pitchFamily="2" charset="0"/>
-                  <a:cs typeface="Ramabhadra" panose="02000600000000000000" pitchFamily="2" charset="0"/>
-                </a:rPr>
-                <a:t>యెహోవా యిరే నీవే (2)</a:t>
-              </a:r>
+                <a:rPr lang="te-IN" sz="2600" dirty="0">
+                  <a:latin typeface="Ramabhadra" panose="02000600000000000000" pitchFamily="2" charset="0"/>
+                  <a:cs typeface="Ramabhadra" panose="02000600000000000000" pitchFamily="2" charset="0"/>
+                </a:rPr>
+                <a:t>సమస్తము నిర్మించినవాడవు నీవెగదా</a:t>
+              </a:r>
+              <a:endParaRPr lang="en-US" sz="2600" dirty="0">
+                <a:latin typeface="Ramabhadra" panose="02000600000000000000" pitchFamily="2" charset="0"/>
+                <a:cs typeface="Ramabhadra" panose="02000600000000000000" pitchFamily="2" charset="0"/>
+              </a:endParaRPr>
             </a:p>
             <a:p>
               <a:pPr defTabSz="439781">
                 <a:defRPr/>
               </a:pPr>
               <a:r>
-                <a:rPr lang="te-IN" sz="2100" dirty="0">
-                  <a:latin typeface="Ramabhadra" panose="02000600000000000000" pitchFamily="2" charset="0"/>
-                  <a:cs typeface="Ramabhadra" panose="02000600000000000000" pitchFamily="2" charset="0"/>
-                </a:rPr>
-                <a:t>నా కోరికంతా ఏ క్షణమైనా</a:t>
-              </a:r>
+                <a:rPr lang="te-IN" sz="2600" dirty="0">
+                  <a:latin typeface="Ramabhadra" panose="02000600000000000000" pitchFamily="2" charset="0"/>
+                  <a:cs typeface="Ramabhadra" panose="02000600000000000000" pitchFamily="2" charset="0"/>
+                </a:rPr>
+                <a:t>నీ ఉగ్రత తాళలేమయా –</a:t>
+              </a:r>
+              <a:endParaRPr lang="en-US" sz="2600" dirty="0">
+                <a:latin typeface="Ramabhadra" panose="02000600000000000000" pitchFamily="2" charset="0"/>
+                <a:cs typeface="Ramabhadra" panose="02000600000000000000" pitchFamily="2" charset="0"/>
+              </a:endParaRPr>
             </a:p>
             <a:p>
               <a:pPr defTabSz="439781">
                 <a:defRPr/>
               </a:pPr>
               <a:r>
-                <a:rPr lang="te-IN" sz="2100" dirty="0">
-                  <a:latin typeface="Ramabhadra" panose="02000600000000000000" pitchFamily="2" charset="0"/>
-                  <a:cs typeface="Ramabhadra" panose="02000600000000000000" pitchFamily="2" charset="0"/>
-                </a:rPr>
-                <a:t>నీవేగా నా యేసూ (2) ఆమెన్</a:t>
-              </a:r>
-            </a:p>
-            <a:p>
-              <a:pPr defTabSz="439781">
-                <a:defRPr/>
-              </a:pPr>
-              <a:endParaRPr lang="te-IN" sz="2100" dirty="0">
-                <a:latin typeface="Ramabhadra" panose="02000600000000000000" pitchFamily="2" charset="0"/>
-                <a:cs typeface="Ramabhadra" panose="02000600000000000000" pitchFamily="2" charset="0"/>
-              </a:endParaRPr>
-            </a:p>
-            <a:p>
-              <a:pPr defTabSz="439781">
-                <a:defRPr/>
-              </a:pPr>
-              <a:r>
-                <a:rPr lang="te-IN" sz="2100" dirty="0">
-                  <a:latin typeface="Ramabhadra" panose="02000600000000000000" pitchFamily="2" charset="0"/>
-                  <a:cs typeface="Ramabhadra" panose="02000600000000000000" pitchFamily="2" charset="0"/>
-                </a:rPr>
-                <a:t>మా సర్వమంతా నీవే నయ్యా</a:t>
-              </a:r>
-            </a:p>
-            <a:p>
-              <a:pPr defTabSz="439781">
-                <a:defRPr/>
-              </a:pPr>
-              <a:r>
-                <a:rPr lang="te-IN" sz="2100" dirty="0">
-                  <a:latin typeface="Ramabhadra" panose="02000600000000000000" pitchFamily="2" charset="0"/>
-                  <a:cs typeface="Ramabhadra" panose="02000600000000000000" pitchFamily="2" charset="0"/>
-                </a:rPr>
-                <a:t>నీకే గా అంకితం చేసితిమీ (2)</a:t>
-              </a:r>
-            </a:p>
-            <a:p>
-              <a:pPr defTabSz="439781">
-                <a:defRPr/>
-              </a:pPr>
-              <a:r>
-                <a:rPr lang="te-IN" sz="2100" dirty="0">
-                  <a:latin typeface="Ramabhadra" panose="02000600000000000000" pitchFamily="2" charset="0"/>
-                  <a:cs typeface="Ramabhadra" panose="02000600000000000000" pitchFamily="2" charset="0"/>
-                </a:rPr>
-                <a:t>వేచియున్నాము సెలవిమ్ము దేవా</a:t>
-              </a:r>
-            </a:p>
-            <a:p>
-              <a:pPr defTabSz="439781">
-                <a:defRPr/>
-              </a:pPr>
-              <a:r>
-                <a:rPr lang="te-IN" sz="2100" dirty="0">
-                  <a:latin typeface="Ramabhadra" panose="02000600000000000000" pitchFamily="2" charset="0"/>
-                  <a:cs typeface="Ramabhadra" panose="02000600000000000000" pitchFamily="2" charset="0"/>
-                </a:rPr>
-                <a:t>నీ ఆజ్ఞ పాటించెదమూ (2) స్తోత్రం</a:t>
+                <a:rPr lang="te-IN" sz="2600" dirty="0">
+                  <a:latin typeface="Ramabhadra" panose="02000600000000000000" pitchFamily="2" charset="0"/>
+                  <a:cs typeface="Ramabhadra" panose="02000600000000000000" pitchFamily="2" charset="0"/>
+                </a:rPr>
+                <a:t>మేలు చేయగలవు నీవయా</a:t>
               </a:r>
             </a:p>
           </p:txBody>

</xml_diff>

<commit_message>
08 sunday songs dec 24
</commit_message>
<xml_diff>
--- a/songsTemplate.pptx
+++ b/songsTemplate.pptx
@@ -3834,7 +3834,7 @@
                   <a:latin typeface="Ramabhadra" panose="02000600000000000000" pitchFamily="2" charset="0"/>
                   <a:cs typeface="Ramabhadra" panose="02000600000000000000" pitchFamily="2" charset="0"/>
                 </a:rPr>
-                <a:t>మ్రోదములరగ సదమదని</a:t>
+                <a:t>మ్రోదములరగ సదమది</a:t>
               </a:r>
               <a:r>
                 <a:rPr lang="en-US" sz="2200" dirty="0">
@@ -3901,7 +3901,7 @@
                   <a:latin typeface="Ramabhadra" panose="02000600000000000000" pitchFamily="2" charset="0"/>
                   <a:cs typeface="Ramabhadra" panose="02000600000000000000" pitchFamily="2" charset="0"/>
                 </a:rPr>
-                <a:t>యేసే దేవుడని దేవుని కుమారుడని (</a:t>
+                <a:t>యేసే దేవుడని దేవుని కుమరుడని (</a:t>
               </a:r>
               <a:r>
                 <a:rPr lang="en-IN" sz="2200" dirty="0">
@@ -3927,7 +3927,7 @@
                   <a:latin typeface="Ramabhadra" panose="02000600000000000000" pitchFamily="2" charset="0"/>
                   <a:cs typeface="Ramabhadra" panose="02000600000000000000" pitchFamily="2" charset="0"/>
                 </a:rPr>
-                <a:t>ఆయనే పూజ్యడని –</a:t>
+                <a:t>ఆయనే పుజ్యుడని –</a:t>
               </a:r>
               <a:endParaRPr lang="en-IN" sz="2200" dirty="0">
                 <a:latin typeface="Ramabhadra" panose="02000600000000000000" pitchFamily="2" charset="0"/>
@@ -4016,7 +4016,7 @@
                   <a:latin typeface="Ramabhadra" panose="02000600000000000000" pitchFamily="2" charset="0"/>
                   <a:cs typeface="Ramabhadra" panose="02000600000000000000" pitchFamily="2" charset="0"/>
                 </a:rPr>
-                <a:t>మ్రోగుతాంబూలతో బూరల నాదముతో</a:t>
+                <a:t>మ్రోగుతాలంబులతో బూరల నాదముతో</a:t>
               </a:r>
               <a:endParaRPr lang="en-IN" sz="2200" dirty="0">
                 <a:latin typeface="Ramabhadra" panose="02000600000000000000" pitchFamily="2" charset="0"/>

</xml_diff>

<commit_message>
15 sunday dec 24 songs
</commit_message>
<xml_diff>
--- a/songsTemplate.pptx
+++ b/songsTemplate.pptx
@@ -255,7 +255,7 @@
           <a:p>
             <a:fld id="{F1102B08-ED9E-409F-B95F-09CAA1DAF6E0}" type="datetimeFigureOut">
               <a:rPr lang="en-IN" smtClean="0"/>
-              <a:t>07-12-2024</a:t>
+              <a:t>14-12-2024</a:t>
             </a:fld>
             <a:endParaRPr lang="en-IN"/>
           </a:p>
@@ -425,7 +425,7 @@
           <a:p>
             <a:fld id="{F1102B08-ED9E-409F-B95F-09CAA1DAF6E0}" type="datetimeFigureOut">
               <a:rPr lang="en-IN" smtClean="0"/>
-              <a:t>07-12-2024</a:t>
+              <a:t>14-12-2024</a:t>
             </a:fld>
             <a:endParaRPr lang="en-IN"/>
           </a:p>
@@ -605,7 +605,7 @@
           <a:p>
             <a:fld id="{F1102B08-ED9E-409F-B95F-09CAA1DAF6E0}" type="datetimeFigureOut">
               <a:rPr lang="en-IN" smtClean="0"/>
-              <a:t>07-12-2024</a:t>
+              <a:t>14-12-2024</a:t>
             </a:fld>
             <a:endParaRPr lang="en-IN"/>
           </a:p>
@@ -775,7 +775,7 @@
           <a:p>
             <a:fld id="{F1102B08-ED9E-409F-B95F-09CAA1DAF6E0}" type="datetimeFigureOut">
               <a:rPr lang="en-IN" smtClean="0"/>
-              <a:t>07-12-2024</a:t>
+              <a:t>14-12-2024</a:t>
             </a:fld>
             <a:endParaRPr lang="en-IN"/>
           </a:p>
@@ -1019,7 +1019,7 @@
           <a:p>
             <a:fld id="{F1102B08-ED9E-409F-B95F-09CAA1DAF6E0}" type="datetimeFigureOut">
               <a:rPr lang="en-IN" smtClean="0"/>
-              <a:t>07-12-2024</a:t>
+              <a:t>14-12-2024</a:t>
             </a:fld>
             <a:endParaRPr lang="en-IN"/>
           </a:p>
@@ -1251,7 +1251,7 @@
           <a:p>
             <a:fld id="{F1102B08-ED9E-409F-B95F-09CAA1DAF6E0}" type="datetimeFigureOut">
               <a:rPr lang="en-IN" smtClean="0"/>
-              <a:t>07-12-2024</a:t>
+              <a:t>14-12-2024</a:t>
             </a:fld>
             <a:endParaRPr lang="en-IN"/>
           </a:p>
@@ -1618,7 +1618,7 @@
           <a:p>
             <a:fld id="{F1102B08-ED9E-409F-B95F-09CAA1DAF6E0}" type="datetimeFigureOut">
               <a:rPr lang="en-IN" smtClean="0"/>
-              <a:t>07-12-2024</a:t>
+              <a:t>14-12-2024</a:t>
             </a:fld>
             <a:endParaRPr lang="en-IN"/>
           </a:p>
@@ -1736,7 +1736,7 @@
           <a:p>
             <a:fld id="{F1102B08-ED9E-409F-B95F-09CAA1DAF6E0}" type="datetimeFigureOut">
               <a:rPr lang="en-IN" smtClean="0"/>
-              <a:t>07-12-2024</a:t>
+              <a:t>14-12-2024</a:t>
             </a:fld>
             <a:endParaRPr lang="en-IN"/>
           </a:p>
@@ -1831,7 +1831,7 @@
           <a:p>
             <a:fld id="{F1102B08-ED9E-409F-B95F-09CAA1DAF6E0}" type="datetimeFigureOut">
               <a:rPr lang="en-IN" smtClean="0"/>
-              <a:t>07-12-2024</a:t>
+              <a:t>14-12-2024</a:t>
             </a:fld>
             <a:endParaRPr lang="en-IN"/>
           </a:p>
@@ -2108,7 +2108,7 @@
           <a:p>
             <a:fld id="{F1102B08-ED9E-409F-B95F-09CAA1DAF6E0}" type="datetimeFigureOut">
               <a:rPr lang="en-IN" smtClean="0"/>
-              <a:t>07-12-2024</a:t>
+              <a:t>14-12-2024</a:t>
             </a:fld>
             <a:endParaRPr lang="en-IN"/>
           </a:p>
@@ -2365,7 +2365,7 @@
           <a:p>
             <a:fld id="{F1102B08-ED9E-409F-B95F-09CAA1DAF6E0}" type="datetimeFigureOut">
               <a:rPr lang="en-IN" smtClean="0"/>
-              <a:t>07-12-2024</a:t>
+              <a:t>14-12-2024</a:t>
             </a:fld>
             <a:endParaRPr lang="en-IN"/>
           </a:p>
@@ -2578,7 +2578,7 @@
           <a:p>
             <a:fld id="{F1102B08-ED9E-409F-B95F-09CAA1DAF6E0}" type="datetimeFigureOut">
               <a:rPr lang="en-IN" smtClean="0"/>
-              <a:t>07-12-2024</a:t>
+              <a:t>14-12-2024</a:t>
             </a:fld>
             <a:endParaRPr lang="en-IN"/>
           </a:p>
@@ -3073,7 +3073,7 @@
           <p:spPr>
             <a:xfrm>
               <a:off x="272140" y="309857"/>
-              <a:ext cx="4483140" cy="5847755"/>
+              <a:ext cx="4483140" cy="6001643"/>
             </a:xfrm>
             <a:prstGeom prst="rect">
               <a:avLst/>
@@ -3090,11 +3090,63 @@
                 <a:defRPr/>
               </a:pPr>
               <a:r>
-                <a:rPr lang="te-IN" sz="2200" dirty="0">
-                  <a:latin typeface="Ramabhadra" panose="02000600000000000000" pitchFamily="2" charset="0"/>
-                  <a:cs typeface="Ramabhadra" panose="02000600000000000000" pitchFamily="2" charset="0"/>
-                </a:rPr>
-                <a:t>మహాఘనుడవు మహోన్నతుడవు</a:t>
+                <a:rPr lang="te-IN" sz="2400" dirty="0">
+                  <a:latin typeface="Ramabhadra" panose="02000600000000000000" pitchFamily="2" charset="0"/>
+                  <a:cs typeface="Ramabhadra" panose="02000600000000000000" pitchFamily="2" charset="0"/>
+                </a:rPr>
+                <a:t>దేవా నా దేవా – నీవే నా కాపరి</a:t>
+              </a:r>
+              <a:br>
+                <a:rPr lang="te-IN" sz="2400" dirty="0">
+                  <a:latin typeface="Ramabhadra" panose="02000600000000000000" pitchFamily="2" charset="0"/>
+                  <a:cs typeface="Ramabhadra" panose="02000600000000000000" pitchFamily="2" charset="0"/>
+                </a:rPr>
+              </a:br>
+              <a:r>
+                <a:rPr lang="te-IN" sz="2400" dirty="0">
+                  <a:latin typeface="Ramabhadra" panose="02000600000000000000" pitchFamily="2" charset="0"/>
+                  <a:cs typeface="Ramabhadra" panose="02000600000000000000" pitchFamily="2" charset="0"/>
+                </a:rPr>
+                <a:t>నీ ప్రేమ నీ క్షమా – ఎంతో గొప్పది (2)</a:t>
+              </a:r>
+              <a:br>
+                <a:rPr lang="te-IN" sz="2400" dirty="0">
+                  <a:latin typeface="Ramabhadra" panose="02000600000000000000" pitchFamily="2" charset="0"/>
+                  <a:cs typeface="Ramabhadra" panose="02000600000000000000" pitchFamily="2" charset="0"/>
+                </a:rPr>
+              </a:br>
+              <a:r>
+                <a:rPr lang="te-IN" sz="2400" dirty="0">
+                  <a:latin typeface="Ramabhadra" panose="02000600000000000000" pitchFamily="2" charset="0"/>
+                  <a:cs typeface="Ramabhadra" panose="02000600000000000000" pitchFamily="2" charset="0"/>
+                </a:rPr>
+                <a:t>ఆరాధింతును హృదయాంతరంగములో</a:t>
+              </a:r>
+              <a:br>
+                <a:rPr lang="te-IN" sz="2400" dirty="0">
+                  <a:latin typeface="Ramabhadra" panose="02000600000000000000" pitchFamily="2" charset="0"/>
+                  <a:cs typeface="Ramabhadra" panose="02000600000000000000" pitchFamily="2" charset="0"/>
+                </a:rPr>
+              </a:br>
+              <a:r>
+                <a:rPr lang="te-IN" sz="2400" dirty="0">
+                  <a:latin typeface="Ramabhadra" panose="02000600000000000000" pitchFamily="2" charset="0"/>
+                  <a:cs typeface="Ramabhadra" panose="02000600000000000000" pitchFamily="2" charset="0"/>
+                </a:rPr>
+                <a:t>స్తుతించెదను నీ పాద సన్నిధిలో (2)</a:t>
+              </a:r>
+              <a:br>
+                <a:rPr lang="te-IN" sz="2400" dirty="0">
+                  <a:latin typeface="Ramabhadra" panose="02000600000000000000" pitchFamily="2" charset="0"/>
+                  <a:cs typeface="Ramabhadra" panose="02000600000000000000" pitchFamily="2" charset="0"/>
+                </a:rPr>
+              </a:br>
+              <a:r>
+                <a:rPr lang="te-IN" sz="2400" dirty="0">
+                  <a:latin typeface="Ramabhadra" panose="02000600000000000000" pitchFamily="2" charset="0"/>
+                  <a:cs typeface="Ramabhadra" panose="02000600000000000000" pitchFamily="2" charset="0"/>
+                </a:rPr>
+                <a:t>నీవే కదా దేవుడవు – (2)</a:t>
               </a:r>
             </a:p>
             <a:p>
@@ -3102,189 +3154,131 @@
                 <a:defRPr/>
               </a:pPr>
               <a:r>
-                <a:rPr lang="te-IN" sz="2200" dirty="0">
-                  <a:latin typeface="Ramabhadra" panose="02000600000000000000" pitchFamily="2" charset="0"/>
-                  <a:cs typeface="Ramabhadra" panose="02000600000000000000" pitchFamily="2" charset="0"/>
-                </a:rPr>
-                <a:t>పరిశుద్ధ స్థలములోనే నివసించువాడవు (2)</a:t>
+                <a:rPr lang="te-IN" sz="2400" dirty="0">
+                  <a:latin typeface="Ramabhadra" panose="02000600000000000000" pitchFamily="2" charset="0"/>
+                  <a:cs typeface="Ramabhadra" panose="02000600000000000000" pitchFamily="2" charset="0"/>
+                </a:rPr>
+                <a:t>దేవా యేసు దేవా (4)     </a:t>
               </a:r>
             </a:p>
             <a:p>
               <a:pPr defTabSz="439781">
                 <a:defRPr/>
               </a:pPr>
-              <a:r>
-                <a:rPr lang="te-IN" sz="2200" dirty="0">
-                  <a:latin typeface="Ramabhadra" panose="02000600000000000000" pitchFamily="2" charset="0"/>
-                  <a:cs typeface="Ramabhadra" panose="02000600000000000000" pitchFamily="2" charset="0"/>
-                </a:rPr>
-                <a:t>కృపా సత్య సంపూర్ణమై</a:t>
-              </a:r>
+              <a:endParaRPr lang="te-IN" sz="2400" dirty="0">
+                <a:latin typeface="Ramabhadra" panose="02000600000000000000" pitchFamily="2" charset="0"/>
+                <a:cs typeface="Ramabhadra" panose="02000600000000000000" pitchFamily="2" charset="0"/>
+              </a:endParaRPr>
             </a:p>
             <a:p>
               <a:pPr defTabSz="439781">
                 <a:defRPr/>
               </a:pPr>
               <a:r>
-                <a:rPr lang="te-IN" sz="2200" dirty="0">
-                  <a:latin typeface="Ramabhadra" panose="02000600000000000000" pitchFamily="2" charset="0"/>
-                  <a:cs typeface="Ramabhadra" panose="02000600000000000000" pitchFamily="2" charset="0"/>
-                </a:rPr>
-                <a:t>మా మధ్యలో నివసించుట న్యాయమా</a:t>
+                <a:rPr lang="te-IN" sz="2400" dirty="0">
+                  <a:latin typeface="Ramabhadra" panose="02000600000000000000" pitchFamily="2" charset="0"/>
+                  <a:cs typeface="Ramabhadra" panose="02000600000000000000" pitchFamily="2" charset="0"/>
+                </a:rPr>
+                <a:t>పాపము నుండి విడిపించినావు</a:t>
+              </a:r>
+              <a:br>
+                <a:rPr lang="te-IN" sz="2400" dirty="0">
+                  <a:latin typeface="Ramabhadra" panose="02000600000000000000" pitchFamily="2" charset="0"/>
+                  <a:cs typeface="Ramabhadra" panose="02000600000000000000" pitchFamily="2" charset="0"/>
+                </a:rPr>
+              </a:br>
+              <a:r>
+                <a:rPr lang="te-IN" sz="2400" dirty="0">
+                  <a:latin typeface="Ramabhadra" panose="02000600000000000000" pitchFamily="2" charset="0"/>
+                  <a:cs typeface="Ramabhadra" panose="02000600000000000000" pitchFamily="2" charset="0"/>
+                </a:rPr>
+                <a:t>పరిశుద్ధుని చేసి ప్రేమించినావు (2)</a:t>
+              </a:r>
+              <a:br>
+                <a:rPr lang="te-IN" sz="2400" dirty="0">
+                  <a:latin typeface="Ramabhadra" panose="02000600000000000000" pitchFamily="2" charset="0"/>
+                  <a:cs typeface="Ramabhadra" panose="02000600000000000000" pitchFamily="2" charset="0"/>
+                </a:rPr>
+              </a:br>
+              <a:r>
+                <a:rPr lang="te-IN" sz="2400" dirty="0">
+                  <a:latin typeface="Ramabhadra" panose="02000600000000000000" pitchFamily="2" charset="0"/>
+                  <a:cs typeface="Ramabhadra" panose="02000600000000000000" pitchFamily="2" charset="0"/>
+                </a:rPr>
+                <a:t>నీవే కదా దేవుడవు – (2)</a:t>
+              </a:r>
+              <a:br>
+                <a:rPr lang="te-IN" sz="2400" dirty="0">
+                  <a:latin typeface="Ramabhadra" panose="02000600000000000000" pitchFamily="2" charset="0"/>
+                  <a:cs typeface="Ramabhadra" panose="02000600000000000000" pitchFamily="2" charset="0"/>
+                </a:rPr>
+              </a:br>
+              <a:r>
+                <a:rPr lang="te-IN" sz="2400" dirty="0">
+                  <a:latin typeface="Ramabhadra" panose="02000600000000000000" pitchFamily="2" charset="0"/>
+                  <a:cs typeface="Ramabhadra" panose="02000600000000000000" pitchFamily="2" charset="0"/>
+                </a:rPr>
+                <a:t>దేవా యేసు దేవా (4)       </a:t>
               </a:r>
             </a:p>
             <a:p>
               <a:pPr defTabSz="439781">
                 <a:defRPr/>
               </a:pPr>
-              <a:r>
-                <a:rPr lang="te-IN" sz="2200" dirty="0">
-                  <a:latin typeface="Ramabhadra" panose="02000600000000000000" pitchFamily="2" charset="0"/>
-                  <a:cs typeface="Ramabhadra" panose="02000600000000000000" pitchFamily="2" charset="0"/>
-                </a:rPr>
-                <a:t>నను పరిశుద్ధపరచుటే నీ ధర్మమా (2)</a:t>
-              </a:r>
+              <a:endParaRPr lang="te-IN" sz="2400" dirty="0">
+                <a:latin typeface="Ramabhadra" panose="02000600000000000000" pitchFamily="2" charset="0"/>
+                <a:cs typeface="Ramabhadra" panose="02000600000000000000" pitchFamily="2" charset="0"/>
+              </a:endParaRPr>
             </a:p>
             <a:p>
               <a:pPr defTabSz="439781">
                 <a:defRPr/>
               </a:pPr>
-              <a:endParaRPr lang="te-IN" sz="2200" dirty="0">
-                <a:latin typeface="Ramabhadra" panose="02000600000000000000" pitchFamily="2" charset="0"/>
-                <a:cs typeface="Ramabhadra" panose="02000600000000000000" pitchFamily="2" charset="0"/>
-              </a:endParaRPr>
-            </a:p>
-            <a:p>
-              <a:pPr defTabSz="439781">
-                <a:defRPr/>
-              </a:pPr>
-              <a:r>
-                <a:rPr lang="te-IN" sz="2200" dirty="0">
-                  <a:latin typeface="Ramabhadra" panose="02000600000000000000" pitchFamily="2" charset="0"/>
-                  <a:cs typeface="Ramabhadra" panose="02000600000000000000" pitchFamily="2" charset="0"/>
-                </a:rPr>
-                <a:t>వినయముగల వారిని</a:t>
-              </a:r>
-            </a:p>
-            <a:p>
-              <a:pPr defTabSz="439781">
-                <a:defRPr/>
-              </a:pPr>
-              <a:r>
-                <a:rPr lang="te-IN" sz="2200" dirty="0">
-                  <a:latin typeface="Ramabhadra" panose="02000600000000000000" pitchFamily="2" charset="0"/>
-                  <a:cs typeface="Ramabhadra" panose="02000600000000000000" pitchFamily="2" charset="0"/>
-                </a:rPr>
-                <a:t>తగిన సమయములో హెచ్చించువాడవని (2)</a:t>
-              </a:r>
-            </a:p>
-            <a:p>
-              <a:pPr defTabSz="439781">
-                <a:defRPr/>
-              </a:pPr>
-              <a:r>
-                <a:rPr lang="te-IN" sz="2200" dirty="0">
-                  <a:latin typeface="Ramabhadra" panose="02000600000000000000" pitchFamily="2" charset="0"/>
-                  <a:cs typeface="Ramabhadra" panose="02000600000000000000" pitchFamily="2" charset="0"/>
-                </a:rPr>
-                <a:t>నీవు వాడు పాత్రనై నేనుండుటకై</a:t>
-              </a:r>
-            </a:p>
-            <a:p>
-              <a:pPr defTabSz="439781">
-                <a:defRPr/>
-              </a:pPr>
-              <a:r>
-                <a:rPr lang="te-IN" sz="2200" dirty="0">
-                  <a:latin typeface="Ramabhadra" panose="02000600000000000000" pitchFamily="2" charset="0"/>
-                  <a:cs typeface="Ramabhadra" panose="02000600000000000000" pitchFamily="2" charset="0"/>
-                </a:rPr>
-                <a:t>నిలిచియుందును పవిత్రతతో (2)</a:t>
-              </a:r>
-            </a:p>
-            <a:p>
-              <a:pPr defTabSz="439781">
-                <a:defRPr/>
-              </a:pPr>
-              <a:r>
-                <a:rPr lang="te-IN" sz="2200" dirty="0">
-                  <a:latin typeface="Ramabhadra" panose="02000600000000000000" pitchFamily="2" charset="0"/>
-                  <a:cs typeface="Ramabhadra" panose="02000600000000000000" pitchFamily="2" charset="0"/>
-                </a:rPr>
-                <a:t>హల్లెలూయా యేసయ్యా నీకే స్తోత్రమయా (2)</a:t>
-              </a:r>
-              <a:endParaRPr lang="en-IN" sz="2200" dirty="0">
-                <a:latin typeface="Ramabhadra" panose="02000600000000000000" pitchFamily="2" charset="0"/>
-                <a:cs typeface="Ramabhadra" panose="02000600000000000000" pitchFamily="2" charset="0"/>
-              </a:endParaRPr>
-            </a:p>
-            <a:p>
-              <a:pPr defTabSz="439781">
-                <a:defRPr/>
-              </a:pPr>
-              <a:endParaRPr lang="te-IN" sz="2200" dirty="0">
-                <a:latin typeface="Ramabhadra" panose="02000600000000000000" pitchFamily="2" charset="0"/>
-                <a:cs typeface="Ramabhadra" panose="02000600000000000000" pitchFamily="2" charset="0"/>
-              </a:endParaRPr>
-            </a:p>
-            <a:p>
-              <a:pPr defTabSz="439781">
-                <a:defRPr/>
-              </a:pPr>
-              <a:r>
-                <a:rPr lang="te-IN" sz="2200" dirty="0">
-                  <a:latin typeface="Ramabhadra" panose="02000600000000000000" pitchFamily="2" charset="0"/>
-                  <a:cs typeface="Ramabhadra" panose="02000600000000000000" pitchFamily="2" charset="0"/>
-                </a:rPr>
-                <a:t>దీన మనస్సు గలవారికే</a:t>
-              </a:r>
-            </a:p>
-            <a:p>
-              <a:pPr defTabSz="439781">
-                <a:defRPr/>
-              </a:pPr>
-              <a:r>
-                <a:rPr lang="te-IN" sz="2200" dirty="0">
-                  <a:latin typeface="Ramabhadra" panose="02000600000000000000" pitchFamily="2" charset="0"/>
-                  <a:cs typeface="Ramabhadra" panose="02000600000000000000" pitchFamily="2" charset="0"/>
-                </a:rPr>
-                <a:t>సమృద్ధిగా కృపను దయచేయువాడవని (2)</a:t>
-              </a:r>
-            </a:p>
-            <a:p>
-              <a:pPr defTabSz="439781">
-                <a:defRPr/>
-              </a:pPr>
-              <a:r>
-                <a:rPr lang="te-IN" sz="2200" dirty="0">
-                  <a:latin typeface="Ramabhadra" panose="02000600000000000000" pitchFamily="2" charset="0"/>
-                  <a:cs typeface="Ramabhadra" panose="02000600000000000000" pitchFamily="2" charset="0"/>
-                </a:rPr>
-                <a:t>నీ సముఖములో సజీవ సాక్షినై</a:t>
-              </a:r>
-            </a:p>
-            <a:p>
-              <a:pPr defTabSz="439781">
-                <a:defRPr/>
-              </a:pPr>
-              <a:r>
-                <a:rPr lang="te-IN" sz="2200" dirty="0">
-                  <a:latin typeface="Ramabhadra" panose="02000600000000000000" pitchFamily="2" charset="0"/>
-                  <a:cs typeface="Ramabhadra" panose="02000600000000000000" pitchFamily="2" charset="0"/>
-                </a:rPr>
-                <a:t>కాపాడుకొందును మెళకువతో (2)</a:t>
-              </a:r>
-            </a:p>
-            <a:p>
-              <a:pPr defTabSz="439781">
-                <a:defRPr/>
-              </a:pPr>
-              <a:r>
-                <a:rPr lang="te-IN" sz="2200" dirty="0">
-                  <a:latin typeface="Ramabhadra" panose="02000600000000000000" pitchFamily="2" charset="0"/>
-                  <a:cs typeface="Ramabhadra" panose="02000600000000000000" pitchFamily="2" charset="0"/>
-                </a:rPr>
-                <a:t>హల్లెలూయా యేసయ్యా నీకే స్తోత్రమయా (2)</a:t>
+              <a:r>
+                <a:rPr lang="te-IN" sz="2400" dirty="0">
+                  <a:latin typeface="Ramabhadra" panose="02000600000000000000" pitchFamily="2" charset="0"/>
+                  <a:cs typeface="Ramabhadra" panose="02000600000000000000" pitchFamily="2" charset="0"/>
+                </a:rPr>
+                <a:t>పరిశుద్ధాత్మను నాలో నింపావు</a:t>
+              </a:r>
+              <a:br>
+                <a:rPr lang="te-IN" sz="2400" dirty="0">
+                  <a:latin typeface="Ramabhadra" panose="02000600000000000000" pitchFamily="2" charset="0"/>
+                  <a:cs typeface="Ramabhadra" panose="02000600000000000000" pitchFamily="2" charset="0"/>
+                </a:rPr>
+              </a:br>
+              <a:r>
+                <a:rPr lang="te-IN" sz="2400" dirty="0">
+                  <a:latin typeface="Ramabhadra" panose="02000600000000000000" pitchFamily="2" charset="0"/>
+                  <a:cs typeface="Ramabhadra" panose="02000600000000000000" pitchFamily="2" charset="0"/>
+                </a:rPr>
+                <a:t>మట్టి దేహమును మహిమతో నింపావు (2)</a:t>
+              </a:r>
+              <a:br>
+                <a:rPr lang="te-IN" sz="2400" dirty="0">
+                  <a:latin typeface="Ramabhadra" panose="02000600000000000000" pitchFamily="2" charset="0"/>
+                  <a:cs typeface="Ramabhadra" panose="02000600000000000000" pitchFamily="2" charset="0"/>
+                </a:rPr>
+              </a:br>
+              <a:r>
+                <a:rPr lang="te-IN" sz="2400" dirty="0">
+                  <a:latin typeface="Ramabhadra" panose="02000600000000000000" pitchFamily="2" charset="0"/>
+                  <a:cs typeface="Ramabhadra" panose="02000600000000000000" pitchFamily="2" charset="0"/>
+                </a:rPr>
+                <a:t>నీవే కదా దేవుడవు – (2)</a:t>
+              </a:r>
+              <a:br>
+                <a:rPr lang="te-IN" sz="2400" dirty="0">
+                  <a:latin typeface="Ramabhadra" panose="02000600000000000000" pitchFamily="2" charset="0"/>
+                  <a:cs typeface="Ramabhadra" panose="02000600000000000000" pitchFamily="2" charset="0"/>
+                </a:rPr>
+              </a:br>
+              <a:r>
+                <a:rPr lang="te-IN" sz="2400" dirty="0">
+                  <a:latin typeface="Ramabhadra" panose="02000600000000000000" pitchFamily="2" charset="0"/>
+                  <a:cs typeface="Ramabhadra" panose="02000600000000000000" pitchFamily="2" charset="0"/>
+                </a:rPr>
+                <a:t>దేవా యేసు దేవా (4)       </a:t>
               </a:r>
             </a:p>
           </p:txBody>
@@ -3367,9 +3361,9 @@
         <p:grpSpPr>
           <a:xfrm>
             <a:off x="5104338" y="182031"/>
-            <a:ext cx="4648200" cy="6493935"/>
+            <a:ext cx="5703362" cy="6493935"/>
             <a:chOff x="160868" y="182032"/>
-            <a:chExt cx="4648200" cy="6493935"/>
+            <a:chExt cx="5703362" cy="6493935"/>
           </a:xfrm>
         </p:grpSpPr>
         <p:sp>
@@ -3441,8 +3435,8 @@
           </p:nvSpPr>
           <p:spPr>
             <a:xfrm>
-              <a:off x="267762" y="838158"/>
-              <a:ext cx="4541306" cy="4493538"/>
+              <a:off x="249768" y="309858"/>
+              <a:ext cx="5614462" cy="5632311"/>
             </a:xfrm>
             <a:prstGeom prst="rect">
               <a:avLst/>
@@ -3456,157 +3450,250 @@
             <a:lstStyle/>
             <a:p>
               <a:r>
-                <a:rPr lang="te-IN" sz="2200" dirty="0">
-                  <a:latin typeface="Ramabhadra" panose="02000600000000000000" pitchFamily="2" charset="0"/>
-                  <a:cs typeface="Ramabhadra" panose="02000600000000000000" pitchFamily="2" charset="0"/>
-                </a:rPr>
-                <a:t>యేసు నీకృపలో - మము కాపాడుము</a:t>
-              </a:r>
-              <a:r>
-                <a:rPr lang="en-IN" sz="2200" dirty="0">
-                  <a:latin typeface="Ramabhadra" panose="02000600000000000000" pitchFamily="2" charset="0"/>
-                  <a:cs typeface="Ramabhadra" panose="02000600000000000000" pitchFamily="2" charset="0"/>
-                </a:rPr>
-                <a:t> </a:t>
-              </a:r>
-              <a:r>
-                <a:rPr lang="te-IN" sz="2200" dirty="0">
-                  <a:latin typeface="Ramabhadra" panose="02000600000000000000" pitchFamily="2" charset="0"/>
-                  <a:cs typeface="Ramabhadra" panose="02000600000000000000" pitchFamily="2" charset="0"/>
-                </a:rPr>
-                <a:t>దేవా</a:t>
-              </a:r>
-              <a:endParaRPr lang="en-IN" sz="2200" dirty="0">
+                <a:rPr lang="te-IN" dirty="0">
+                  <a:latin typeface="Ramabhadra" panose="02000600000000000000" pitchFamily="2" charset="0"/>
+                  <a:cs typeface="Ramabhadra" panose="02000600000000000000" pitchFamily="2" charset="0"/>
+                </a:rPr>
+                <a:t>ఘనమైనవి నీ కార్యములు నా యెడల</a:t>
+              </a:r>
+              <a:br>
+                <a:rPr lang="te-IN" dirty="0">
+                  <a:latin typeface="Ramabhadra" panose="02000600000000000000" pitchFamily="2" charset="0"/>
+                  <a:cs typeface="Ramabhadra" panose="02000600000000000000" pitchFamily="2" charset="0"/>
+                </a:rPr>
+              </a:br>
+              <a:r>
+                <a:rPr lang="te-IN" dirty="0">
+                  <a:latin typeface="Ramabhadra" panose="02000600000000000000" pitchFamily="2" charset="0"/>
+                  <a:cs typeface="Ramabhadra" panose="02000600000000000000" pitchFamily="2" charset="0"/>
+                </a:rPr>
+                <a:t>స్థిరమైనవి నీ ఆలోచనలు నా యేసయ్యా (2)</a:t>
+              </a:r>
+              <a:br>
+                <a:rPr lang="te-IN" dirty="0">
+                  <a:latin typeface="Ramabhadra" panose="02000600000000000000" pitchFamily="2" charset="0"/>
+                  <a:cs typeface="Ramabhadra" panose="02000600000000000000" pitchFamily="2" charset="0"/>
+                </a:rPr>
+              </a:br>
+              <a:r>
+                <a:rPr lang="te-IN" dirty="0">
+                  <a:latin typeface="Ramabhadra" panose="02000600000000000000" pitchFamily="2" charset="0"/>
+                  <a:cs typeface="Ramabhadra" panose="02000600000000000000" pitchFamily="2" charset="0"/>
+                </a:rPr>
+                <a:t>కృపలను పొందుచు కృతజ్ఞత కలిగి</a:t>
+              </a:r>
+              <a:br>
+                <a:rPr lang="te-IN" dirty="0">
+                  <a:latin typeface="Ramabhadra" panose="02000600000000000000" pitchFamily="2" charset="0"/>
+                  <a:cs typeface="Ramabhadra" panose="02000600000000000000" pitchFamily="2" charset="0"/>
+                </a:rPr>
+              </a:br>
+              <a:r>
+                <a:rPr lang="te-IN" dirty="0">
+                  <a:latin typeface="Ramabhadra" panose="02000600000000000000" pitchFamily="2" charset="0"/>
+                  <a:cs typeface="Ramabhadra" panose="02000600000000000000" pitchFamily="2" charset="0"/>
+                </a:rPr>
+                <a:t>స్తుతులర్పించెదను అన్నివేళలా (2)</a:t>
+              </a:r>
+              <a:br>
+                <a:rPr lang="te-IN" dirty="0">
+                  <a:latin typeface="Ramabhadra" panose="02000600000000000000" pitchFamily="2" charset="0"/>
+                  <a:cs typeface="Ramabhadra" panose="02000600000000000000" pitchFamily="2" charset="0"/>
+                </a:rPr>
+              </a:br>
+              <a:r>
+                <a:rPr lang="te-IN" dirty="0">
+                  <a:latin typeface="Ramabhadra" panose="02000600000000000000" pitchFamily="2" charset="0"/>
+                  <a:cs typeface="Ramabhadra" panose="02000600000000000000" pitchFamily="2" charset="0"/>
+                </a:rPr>
+                <a:t>అనుదినము నీ అనుగ్రహమే</a:t>
+              </a:r>
+              <a:br>
+                <a:rPr lang="te-IN" dirty="0">
+                  <a:latin typeface="Ramabhadra" panose="02000600000000000000" pitchFamily="2" charset="0"/>
+                  <a:cs typeface="Ramabhadra" panose="02000600000000000000" pitchFamily="2" charset="0"/>
+                </a:rPr>
+              </a:br>
+              <a:r>
+                <a:rPr lang="te-IN" dirty="0">
+                  <a:latin typeface="Ramabhadra" panose="02000600000000000000" pitchFamily="2" charset="0"/>
+                  <a:cs typeface="Ramabhadra" panose="02000600000000000000" pitchFamily="2" charset="0"/>
+                </a:rPr>
+                <a:t>ఆయుష్కాలము నీ వరమే (2)</a:t>
+              </a:r>
+            </a:p>
+            <a:p>
+              <a:endParaRPr lang="te-IN" dirty="0">
                 <a:latin typeface="Ramabhadra" panose="02000600000000000000" pitchFamily="2" charset="0"/>
                 <a:cs typeface="Ramabhadra" panose="02000600000000000000" pitchFamily="2" charset="0"/>
               </a:endParaRPr>
             </a:p>
             <a:p>
               <a:r>
-                <a:rPr lang="te-IN" sz="2200" dirty="0">
-                  <a:latin typeface="Ramabhadra" panose="02000600000000000000" pitchFamily="2" charset="0"/>
-                  <a:cs typeface="Ramabhadra" panose="02000600000000000000" pitchFamily="2" charset="0"/>
-                </a:rPr>
-                <a:t>మమ్ము రక్షించి </a:t>
-              </a:r>
-              <a:r>
-                <a:rPr lang="en-IN" sz="2200" dirty="0">
-                  <a:latin typeface="Ramabhadra" panose="02000600000000000000" pitchFamily="2" charset="0"/>
-                  <a:cs typeface="Ramabhadra" panose="02000600000000000000" pitchFamily="2" charset="0"/>
-                </a:rPr>
-                <a:t>- </a:t>
-              </a:r>
-              <a:r>
-                <a:rPr lang="te-IN" sz="2200" dirty="0">
-                  <a:latin typeface="Ramabhadra" panose="02000600000000000000" pitchFamily="2" charset="0"/>
-                  <a:cs typeface="Ramabhadra" panose="02000600000000000000" pitchFamily="2" charset="0"/>
-                </a:rPr>
-                <a:t>నిత్య రాజ్యములో</a:t>
-              </a:r>
-              <a:endParaRPr lang="en-IN" sz="2200" dirty="0">
+                <a:rPr lang="te-IN" dirty="0">
+                  <a:latin typeface="Ramabhadra" panose="02000600000000000000" pitchFamily="2" charset="0"/>
+                  <a:cs typeface="Ramabhadra" panose="02000600000000000000" pitchFamily="2" charset="0"/>
+                </a:rPr>
+                <a:t>యే తెగులు సమీపించనీయక–</a:t>
+              </a:r>
+              <a:endParaRPr lang="en-IN" dirty="0">
                 <a:latin typeface="Ramabhadra" panose="02000600000000000000" pitchFamily="2" charset="0"/>
                 <a:cs typeface="Ramabhadra" panose="02000600000000000000" pitchFamily="2" charset="0"/>
               </a:endParaRPr>
             </a:p>
             <a:p>
               <a:r>
-                <a:rPr lang="te-IN" sz="2200" dirty="0">
-                  <a:latin typeface="Ramabhadra" panose="02000600000000000000" pitchFamily="2" charset="0"/>
-                  <a:cs typeface="Ramabhadra" panose="02000600000000000000" pitchFamily="2" charset="0"/>
-                </a:rPr>
-                <a:t>నడుపుము మా ప్రభువా - నడుపుము మా ప్రభువా</a:t>
-              </a:r>
-              <a:endParaRPr lang="en-IN" sz="2200" dirty="0">
+                <a:rPr lang="te-IN" dirty="0">
+                  <a:latin typeface="Ramabhadra" panose="02000600000000000000" pitchFamily="2" charset="0"/>
+                  <a:cs typeface="Ramabhadra" panose="02000600000000000000" pitchFamily="2" charset="0"/>
+                </a:rPr>
+                <a:t>యే కీడైన</a:t>
+              </a:r>
+              <a:r>
+                <a:rPr lang="en-IN" dirty="0">
+                  <a:latin typeface="Ramabhadra" panose="02000600000000000000" pitchFamily="2" charset="0"/>
+                  <a:cs typeface="Ramabhadra" panose="02000600000000000000" pitchFamily="2" charset="0"/>
+                </a:rPr>
+                <a:t> </a:t>
+              </a:r>
+              <a:r>
+                <a:rPr lang="te-IN" dirty="0">
+                  <a:latin typeface="Ramabhadra" panose="02000600000000000000" pitchFamily="2" charset="0"/>
+                  <a:cs typeface="Ramabhadra" panose="02000600000000000000" pitchFamily="2" charset="0"/>
+                </a:rPr>
+                <a:t>దరిచేరనీయక</a:t>
+              </a:r>
+              <a:br>
+                <a:rPr lang="te-IN" dirty="0">
+                  <a:latin typeface="Ramabhadra" panose="02000600000000000000" pitchFamily="2" charset="0"/>
+                  <a:cs typeface="Ramabhadra" panose="02000600000000000000" pitchFamily="2" charset="0"/>
+                </a:rPr>
+              </a:br>
+              <a:r>
+                <a:rPr lang="te-IN" dirty="0">
+                  <a:latin typeface="Ramabhadra" panose="02000600000000000000" pitchFamily="2" charset="0"/>
+                  <a:cs typeface="Ramabhadra" panose="02000600000000000000" pitchFamily="2" charset="0"/>
+                </a:rPr>
+                <a:t>ఆపదలన్ని తొలగే వరకు–</a:t>
+              </a:r>
+              <a:endParaRPr lang="en-IN" dirty="0">
                 <a:latin typeface="Ramabhadra" panose="02000600000000000000" pitchFamily="2" charset="0"/>
                 <a:cs typeface="Ramabhadra" panose="02000600000000000000" pitchFamily="2" charset="0"/>
               </a:endParaRPr>
             </a:p>
             <a:p>
-              <a:endParaRPr lang="en-IN" sz="2200" dirty="0">
+              <a:r>
+                <a:rPr lang="te-IN" dirty="0">
+                  <a:latin typeface="Ramabhadra" panose="02000600000000000000" pitchFamily="2" charset="0"/>
+                  <a:cs typeface="Ramabhadra" panose="02000600000000000000" pitchFamily="2" charset="0"/>
+                </a:rPr>
+                <a:t>ఆత్మలో నెమ్మది కలిగే వరకు (2)</a:t>
+              </a:r>
+              <a:br>
+                <a:rPr lang="te-IN" dirty="0">
+                  <a:latin typeface="Ramabhadra" panose="02000600000000000000" pitchFamily="2" charset="0"/>
+                  <a:cs typeface="Ramabhadra" panose="02000600000000000000" pitchFamily="2" charset="0"/>
+                </a:rPr>
+              </a:br>
+              <a:r>
+                <a:rPr lang="te-IN" dirty="0">
+                  <a:latin typeface="Ramabhadra" panose="02000600000000000000" pitchFamily="2" charset="0"/>
+                  <a:cs typeface="Ramabhadra" panose="02000600000000000000" pitchFamily="2" charset="0"/>
+                </a:rPr>
+                <a:t>నా భారము మోసి – బాసటగా నిలిచి – ఆదరించితివి</a:t>
+              </a:r>
+              <a:br>
+                <a:rPr lang="te-IN" dirty="0">
+                  <a:latin typeface="Ramabhadra" panose="02000600000000000000" pitchFamily="2" charset="0"/>
+                  <a:cs typeface="Ramabhadra" panose="02000600000000000000" pitchFamily="2" charset="0"/>
+                </a:rPr>
+              </a:br>
+              <a:r>
+                <a:rPr lang="te-IN" dirty="0">
+                  <a:latin typeface="Ramabhadra" panose="02000600000000000000" pitchFamily="2" charset="0"/>
+                  <a:cs typeface="Ramabhadra" panose="02000600000000000000" pitchFamily="2" charset="0"/>
+                </a:rPr>
+                <a:t>ఈ స్తుతి మహిమలు నీకే – చెల్లించెదను – జీవితాంతము</a:t>
+              </a:r>
+            </a:p>
+            <a:p>
+              <a:endParaRPr lang="te-IN" dirty="0">
                 <a:latin typeface="Ramabhadra" panose="02000600000000000000" pitchFamily="2" charset="0"/>
                 <a:cs typeface="Ramabhadra" panose="02000600000000000000" pitchFamily="2" charset="0"/>
               </a:endParaRPr>
             </a:p>
             <a:p>
               <a:r>
-                <a:rPr lang="te-IN" sz="2200" dirty="0">
-                  <a:latin typeface="Ramabhadra" panose="02000600000000000000" pitchFamily="2" charset="0"/>
-                  <a:cs typeface="Ramabhadra" panose="02000600000000000000" pitchFamily="2" charset="0"/>
-                </a:rPr>
-                <a:t>సిలువను మోసుకొని - సువార్త చాటింప</a:t>
-              </a:r>
-              <a:endParaRPr lang="en-IN" sz="2200" dirty="0">
+                <a:rPr lang="te-IN" dirty="0">
+                  <a:latin typeface="Ramabhadra" panose="02000600000000000000" pitchFamily="2" charset="0"/>
+                  <a:cs typeface="Ramabhadra" panose="02000600000000000000" pitchFamily="2" charset="0"/>
+                </a:rPr>
+                <a:t>నాకు ఎత్తైన కోటవు నీవే –</a:t>
+              </a:r>
+              <a:endParaRPr lang="en-IN" dirty="0">
                 <a:latin typeface="Ramabhadra" panose="02000600000000000000" pitchFamily="2" charset="0"/>
                 <a:cs typeface="Ramabhadra" panose="02000600000000000000" pitchFamily="2" charset="0"/>
               </a:endParaRPr>
             </a:p>
             <a:p>
               <a:r>
-                <a:rPr lang="te-IN" sz="2200" dirty="0">
-                  <a:latin typeface="Ramabhadra" panose="02000600000000000000" pitchFamily="2" charset="0"/>
-                  <a:cs typeface="Ramabhadra" panose="02000600000000000000" pitchFamily="2" charset="0"/>
-                </a:rPr>
-                <a:t>విలువగు నీ శక్తిచే - నిత్యము నడిపించు</a:t>
-              </a:r>
-            </a:p>
-            <a:p>
-              <a:r>
-                <a:rPr lang="te-IN" sz="2200" dirty="0">
-                  <a:latin typeface="Ramabhadra" panose="02000600000000000000" pitchFamily="2" charset="0"/>
-                  <a:cs typeface="Ramabhadra" panose="02000600000000000000" pitchFamily="2" charset="0"/>
-                </a:rPr>
-                <a:t>యేసు నీ రక్తములో - శుద్దిపరచి నన్ను</a:t>
-              </a:r>
-            </a:p>
-            <a:p>
-              <a:r>
-                <a:rPr lang="te-IN" sz="2200" dirty="0">
-                  <a:latin typeface="Ramabhadra" panose="02000600000000000000" pitchFamily="2" charset="0"/>
-                  <a:cs typeface="Ramabhadra" panose="02000600000000000000" pitchFamily="2" charset="0"/>
-                </a:rPr>
-                <a:t>నిలుపుము జ్యోతివలె - నిలుపుము జ్యోతివలె  </a:t>
-              </a:r>
-            </a:p>
-            <a:p>
-              <a:endParaRPr lang="te-IN" sz="2200" dirty="0">
+                <a:rPr lang="te-IN" dirty="0">
+                  <a:latin typeface="Ramabhadra" panose="02000600000000000000" pitchFamily="2" charset="0"/>
+                  <a:cs typeface="Ramabhadra" panose="02000600000000000000" pitchFamily="2" charset="0"/>
+                </a:rPr>
+                <a:t>నన్ను కాపాడు కేడెము నీవే</a:t>
+              </a:r>
+              <a:br>
+                <a:rPr lang="te-IN" dirty="0">
+                  <a:latin typeface="Ramabhadra" panose="02000600000000000000" pitchFamily="2" charset="0"/>
+                  <a:cs typeface="Ramabhadra" panose="02000600000000000000" pitchFamily="2" charset="0"/>
+                </a:rPr>
+              </a:br>
+              <a:r>
+                <a:rPr lang="te-IN" dirty="0">
+                  <a:latin typeface="Ramabhadra" panose="02000600000000000000" pitchFamily="2" charset="0"/>
+                  <a:cs typeface="Ramabhadra" panose="02000600000000000000" pitchFamily="2" charset="0"/>
+                </a:rPr>
+                <a:t>ఆశ్రయమైన బండవు నీవే –</a:t>
+              </a:r>
+              <a:endParaRPr lang="en-IN" dirty="0">
                 <a:latin typeface="Ramabhadra" panose="02000600000000000000" pitchFamily="2" charset="0"/>
                 <a:cs typeface="Ramabhadra" panose="02000600000000000000" pitchFamily="2" charset="0"/>
               </a:endParaRPr>
             </a:p>
             <a:p>
               <a:r>
-                <a:rPr lang="te-IN" sz="2200" dirty="0">
-                  <a:latin typeface="Ramabhadra" panose="02000600000000000000" pitchFamily="2" charset="0"/>
-                  <a:cs typeface="Ramabhadra" panose="02000600000000000000" pitchFamily="2" charset="0"/>
-                </a:rPr>
-                <a:t>కృంగిన వేళలలో - అలసిన సమయములో</a:t>
-              </a:r>
-            </a:p>
-            <a:p>
-              <a:r>
-                <a:rPr lang="te-IN" sz="2200" dirty="0">
-                  <a:latin typeface="Ramabhadra" panose="02000600000000000000" pitchFamily="2" charset="0"/>
-                  <a:cs typeface="Ramabhadra" panose="02000600000000000000" pitchFamily="2" charset="0"/>
-                </a:rPr>
-                <a:t>నా చేయి విడువకుము - నన్ను నిలబెట్టు</a:t>
-              </a:r>
-            </a:p>
-            <a:p>
-              <a:r>
-                <a:rPr lang="te-IN" sz="2200" dirty="0">
-                  <a:latin typeface="Ramabhadra" panose="02000600000000000000" pitchFamily="2" charset="0"/>
-                  <a:cs typeface="Ramabhadra" panose="02000600000000000000" pitchFamily="2" charset="0"/>
-                </a:rPr>
-                <a:t>యేసు నీ రక్తములో - శుద్దిపరచి నన్ను</a:t>
-              </a:r>
-            </a:p>
-            <a:p>
-              <a:r>
-                <a:rPr lang="te-IN" sz="2200" dirty="0">
-                  <a:latin typeface="Ramabhadra" panose="02000600000000000000" pitchFamily="2" charset="0"/>
-                  <a:cs typeface="Ramabhadra" panose="02000600000000000000" pitchFamily="2" charset="0"/>
-                </a:rPr>
-                <a:t>నిలుపుము జ్యోతివలె - నిలుపుము జ్యోతివలె</a:t>
+                <a:rPr lang="te-IN" dirty="0">
+                  <a:latin typeface="Ramabhadra" panose="02000600000000000000" pitchFamily="2" charset="0"/>
+                  <a:cs typeface="Ramabhadra" panose="02000600000000000000" pitchFamily="2" charset="0"/>
+                </a:rPr>
+                <a:t>శాశ్వత కృపకాధారము నీవే (2)</a:t>
+              </a:r>
+              <a:br>
+                <a:rPr lang="te-IN" dirty="0">
+                  <a:latin typeface="Ramabhadra" panose="02000600000000000000" pitchFamily="2" charset="0"/>
+                  <a:cs typeface="Ramabhadra" panose="02000600000000000000" pitchFamily="2" charset="0"/>
+                </a:rPr>
+              </a:br>
+              <a:r>
+                <a:rPr lang="te-IN" dirty="0">
+                  <a:latin typeface="Ramabhadra" panose="02000600000000000000" pitchFamily="2" charset="0"/>
+                  <a:cs typeface="Ramabhadra" panose="02000600000000000000" pitchFamily="2" charset="0"/>
+                </a:rPr>
+                <a:t>నా ప్రతిక్షణమును నీవు –దీవెనగా మార్చి–నడిపించుచున్నావు</a:t>
+              </a:r>
+              <a:br>
+                <a:rPr lang="te-IN" dirty="0">
+                  <a:latin typeface="Ramabhadra" panose="02000600000000000000" pitchFamily="2" charset="0"/>
+                  <a:cs typeface="Ramabhadra" panose="02000600000000000000" pitchFamily="2" charset="0"/>
+                </a:rPr>
+              </a:br>
+              <a:r>
+                <a:rPr lang="te-IN" dirty="0">
+                  <a:latin typeface="Ramabhadra" panose="02000600000000000000" pitchFamily="2" charset="0"/>
+                  <a:cs typeface="Ramabhadra" panose="02000600000000000000" pitchFamily="2" charset="0"/>
+                </a:rPr>
+                <a:t>ఈ స్తుతి మహిమలు నీకే – చెల్లించెదను – జీవితాంతము</a:t>
               </a:r>
             </a:p>
           </p:txBody>
@@ -3719,9 +3806,9 @@
         <p:grpSpPr>
           <a:xfrm>
             <a:off x="160868" y="182032"/>
-            <a:ext cx="4831293" cy="6493935"/>
+            <a:ext cx="4936066" cy="6493935"/>
             <a:chOff x="160868" y="182032"/>
-            <a:chExt cx="4831293" cy="6493935"/>
+            <a:chExt cx="4936066" cy="6493935"/>
           </a:xfrm>
         </p:grpSpPr>
         <p:sp>
@@ -3793,8 +3880,8 @@
           </p:nvSpPr>
           <p:spPr>
             <a:xfrm>
-              <a:off x="343961" y="716954"/>
-              <a:ext cx="4648200" cy="5509200"/>
+              <a:off x="448734" y="799863"/>
+              <a:ext cx="4648200" cy="5262979"/>
             </a:xfrm>
             <a:prstGeom prst="rect">
               <a:avLst/>
@@ -3811,18 +3898,11 @@
                 <a:defRPr/>
               </a:pPr>
               <a:r>
-                <a:rPr lang="te-IN" sz="2200" dirty="0">
-                  <a:latin typeface="Ramabhadra" panose="02000600000000000000" pitchFamily="2" charset="0"/>
-                  <a:cs typeface="Ramabhadra" panose="02000600000000000000" pitchFamily="2" charset="0"/>
-                </a:rPr>
-                <a:t>మదుర స్తుతులతో </a:t>
-              </a:r>
-              <a:r>
-                <a:rPr lang="en-IN" sz="2200" dirty="0">
-                  <a:latin typeface="Ramabhadra" panose="02000600000000000000" pitchFamily="2" charset="0"/>
-                  <a:cs typeface="Ramabhadra" panose="02000600000000000000" pitchFamily="2" charset="0"/>
-                </a:rPr>
-                <a:t>–</a:t>
+                <a:rPr lang="te-IN" sz="2400" dirty="0">
+                  <a:latin typeface="Ramabhadra" panose="02000600000000000000" pitchFamily="2" charset="0"/>
+                  <a:cs typeface="Ramabhadra" panose="02000600000000000000" pitchFamily="2" charset="0"/>
+                </a:rPr>
+                <a:t>స్తుతియించెదా నీ నామం</a:t>
               </a:r>
             </a:p>
             <a:p>
@@ -3830,27 +3910,42 @@
                 <a:defRPr/>
               </a:pPr>
               <a:r>
-                <a:rPr lang="te-IN" sz="2200" dirty="0">
-                  <a:latin typeface="Ramabhadra" panose="02000600000000000000" pitchFamily="2" charset="0"/>
-                  <a:cs typeface="Ramabhadra" panose="02000600000000000000" pitchFamily="2" charset="0"/>
-                </a:rPr>
-                <a:t>మ్రోదములరగ సదమది</a:t>
-              </a:r>
-              <a:r>
-                <a:rPr lang="en-US" sz="2200" dirty="0">
-                  <a:latin typeface="Ramabhadra" panose="02000600000000000000" pitchFamily="2" charset="0"/>
-                  <a:cs typeface="Ramabhadra" panose="02000600000000000000" pitchFamily="2" charset="0"/>
-                </a:rPr>
-                <a:t> </a:t>
-              </a:r>
-              <a:r>
-                <a:rPr lang="te-IN" sz="2200" dirty="0">
-                  <a:latin typeface="Ramabhadra" panose="02000600000000000000" pitchFamily="2" charset="0"/>
-                  <a:cs typeface="Ramabhadra" panose="02000600000000000000" pitchFamily="2" charset="0"/>
-                </a:rPr>
-                <a:t>పాడుదమా</a:t>
-              </a:r>
-              <a:endParaRPr lang="en-IN" sz="2200" dirty="0">
+                <a:rPr lang="te-IN" sz="2400" dirty="0">
+                  <a:latin typeface="Ramabhadra" panose="02000600000000000000" pitchFamily="2" charset="0"/>
+                  <a:cs typeface="Ramabhadra" panose="02000600000000000000" pitchFamily="2" charset="0"/>
+                </a:rPr>
+                <a:t>దేవా అనుదినం </a:t>
+              </a:r>
+            </a:p>
+            <a:p>
+              <a:pPr defTabSz="439781">
+                <a:defRPr/>
+              </a:pPr>
+              <a:r>
+                <a:rPr lang="te-IN" sz="2400" dirty="0">
+                  <a:latin typeface="Ramabhadra" panose="02000600000000000000" pitchFamily="2" charset="0"/>
+                  <a:cs typeface="Ramabhadra" panose="02000600000000000000" pitchFamily="2" charset="0"/>
+                </a:rPr>
+                <a:t>స్తుతియించెదా నీ నామం</a:t>
+              </a:r>
+            </a:p>
+            <a:p>
+              <a:pPr defTabSz="439781">
+                <a:defRPr/>
+              </a:pPr>
+              <a:r>
+                <a:rPr lang="te-IN" sz="2400" dirty="0">
+                  <a:latin typeface="Ramabhadra" panose="02000600000000000000" pitchFamily="2" charset="0"/>
+                  <a:cs typeface="Ramabhadra" panose="02000600000000000000" pitchFamily="2" charset="0"/>
+                </a:rPr>
+                <a:t>దేవా అనుక్షణం</a:t>
+              </a:r>
+            </a:p>
+            <a:p>
+              <a:pPr defTabSz="439781">
+                <a:defRPr/>
+              </a:pPr>
+              <a:endParaRPr lang="te-IN" sz="2400" dirty="0">
                 <a:latin typeface="Ramabhadra" panose="02000600000000000000" pitchFamily="2" charset="0"/>
                 <a:cs typeface="Ramabhadra" panose="02000600000000000000" pitchFamily="2" charset="0"/>
               </a:endParaRPr>
@@ -3860,62 +3955,47 @@
                 <a:defRPr/>
               </a:pPr>
               <a:r>
-                <a:rPr lang="te-IN" sz="2200" dirty="0">
-                  <a:latin typeface="Ramabhadra" panose="02000600000000000000" pitchFamily="2" charset="0"/>
-                  <a:cs typeface="Ramabhadra" panose="02000600000000000000" pitchFamily="2" charset="0"/>
-                </a:rPr>
-                <a:t>క్రీస్తుకు గానం చేయుదమా –</a:t>
-              </a:r>
-              <a:endParaRPr lang="en-IN" sz="2200" dirty="0">
-                <a:latin typeface="Ramabhadra" panose="02000600000000000000" pitchFamily="2" charset="0"/>
-                <a:cs typeface="Ramabhadra" panose="02000600000000000000" pitchFamily="2" charset="0"/>
-              </a:endParaRPr>
+                <a:rPr lang="te-IN" sz="2400" dirty="0">
+                  <a:latin typeface="Ramabhadra" panose="02000600000000000000" pitchFamily="2" charset="0"/>
+                  <a:cs typeface="Ramabhadra" panose="02000600000000000000" pitchFamily="2" charset="0"/>
+                </a:rPr>
+                <a:t>దయతో కాపాడినావు</a:t>
+              </a:r>
             </a:p>
             <a:p>
               <a:pPr defTabSz="439781">
                 <a:defRPr/>
               </a:pPr>
               <a:r>
-                <a:rPr lang="te-IN" sz="2200" dirty="0">
-                  <a:latin typeface="Ramabhadra" panose="02000600000000000000" pitchFamily="2" charset="0"/>
-                  <a:cs typeface="Ramabhadra" panose="02000600000000000000" pitchFamily="2" charset="0"/>
-                </a:rPr>
-                <a:t>నూతన గానము చేయుదమా</a:t>
+                <a:rPr lang="te-IN" sz="2400" dirty="0">
+                  <a:latin typeface="Ramabhadra" panose="02000600000000000000" pitchFamily="2" charset="0"/>
+                  <a:cs typeface="Ramabhadra" panose="02000600000000000000" pitchFamily="2" charset="0"/>
+                </a:rPr>
+                <a:t>కృపనే చూపించినావు (2) </a:t>
               </a:r>
             </a:p>
             <a:p>
               <a:pPr defTabSz="439781">
                 <a:defRPr/>
               </a:pPr>
-              <a:endParaRPr lang="en-IN" sz="2200" dirty="0">
-                <a:latin typeface="Ramabhadra" panose="02000600000000000000" pitchFamily="2" charset="0"/>
-                <a:cs typeface="Ramabhadra" panose="02000600000000000000" pitchFamily="2" charset="0"/>
-              </a:endParaRPr>
+              <a:r>
+                <a:rPr lang="te-IN" sz="2400" dirty="0">
+                  <a:latin typeface="Ramabhadra" panose="02000600000000000000" pitchFamily="2" charset="0"/>
+                  <a:cs typeface="Ramabhadra" panose="02000600000000000000" pitchFamily="2" charset="0"/>
+                </a:rPr>
+                <a:t>నిను నే మరువనేసు</a:t>
+              </a:r>
             </a:p>
             <a:p>
               <a:pPr defTabSz="439781">
                 <a:defRPr/>
               </a:pPr>
               <a:r>
-                <a:rPr lang="te-IN" sz="2200" dirty="0">
-                  <a:latin typeface="Ramabhadra" panose="02000600000000000000" pitchFamily="2" charset="0"/>
-                  <a:cs typeface="Ramabhadra" panose="02000600000000000000" pitchFamily="2" charset="0"/>
-                </a:rPr>
-                <a:t>యేసే దేవుడని దేవుని కుమరుడని (</a:t>
-              </a:r>
-              <a:r>
-                <a:rPr lang="en-IN" sz="2200" dirty="0">
-                  <a:latin typeface="Ramabhadra" panose="02000600000000000000" pitchFamily="2" charset="0"/>
-                  <a:cs typeface="Ramabhadra" panose="02000600000000000000" pitchFamily="2" charset="0"/>
-                </a:rPr>
-                <a:t>2</a:t>
-              </a:r>
-              <a:r>
-                <a:rPr lang="te-IN" sz="2200" dirty="0">
-                  <a:latin typeface="Ramabhadra" panose="02000600000000000000" pitchFamily="2" charset="0"/>
-                  <a:cs typeface="Ramabhadra" panose="02000600000000000000" pitchFamily="2" charset="0"/>
-                </a:rPr>
-                <a:t>)</a:t>
+                <a:rPr lang="te-IN" sz="2400" dirty="0">
+                  <a:latin typeface="Ramabhadra" panose="02000600000000000000" pitchFamily="2" charset="0"/>
+                  <a:cs typeface="Ramabhadra" panose="02000600000000000000" pitchFamily="2" charset="0"/>
+                </a:rPr>
+                <a:t>నిను నే విడువనేసు</a:t>
               </a:r>
             </a:p>
             <a:p>
@@ -3923,148 +4003,59 @@
                 <a:defRPr/>
               </a:pPr>
               <a:r>
-                <a:rPr lang="te-IN" sz="2200" dirty="0">
-                  <a:latin typeface="Ramabhadra" panose="02000600000000000000" pitchFamily="2" charset="0"/>
-                  <a:cs typeface="Ramabhadra" panose="02000600000000000000" pitchFamily="2" charset="0"/>
-                </a:rPr>
-                <a:t>ఆయనే పుజ్యుడని –</a:t>
-              </a:r>
-              <a:endParaRPr lang="en-IN" sz="2200" dirty="0">
-                <a:latin typeface="Ramabhadra" panose="02000600000000000000" pitchFamily="2" charset="0"/>
-                <a:cs typeface="Ramabhadra" panose="02000600000000000000" pitchFamily="2" charset="0"/>
-              </a:endParaRPr>
+                <a:rPr lang="te-IN" sz="2400" dirty="0">
+                  <a:latin typeface="Ramabhadra" panose="02000600000000000000" pitchFamily="2" charset="0"/>
+                  <a:cs typeface="Ramabhadra" panose="02000600000000000000" pitchFamily="2" charset="0"/>
+                </a:rPr>
+                <a:t> </a:t>
+              </a:r>
             </a:p>
             <a:p>
               <a:pPr defTabSz="439781">
                 <a:defRPr/>
               </a:pPr>
               <a:r>
-                <a:rPr lang="te-IN" sz="2200" dirty="0">
-                  <a:latin typeface="Ramabhadra" panose="02000600000000000000" pitchFamily="2" charset="0"/>
-                  <a:cs typeface="Ramabhadra" panose="02000600000000000000" pitchFamily="2" charset="0"/>
-                </a:rPr>
-                <a:t>ప్రభువుకు గానం చేయుదమా</a:t>
-              </a:r>
-              <a:endParaRPr lang="en-US" sz="2200" dirty="0">
-                <a:latin typeface="Ramabhadra" panose="02000600000000000000" pitchFamily="2" charset="0"/>
-                <a:cs typeface="Ramabhadra" panose="02000600000000000000" pitchFamily="2" charset="0"/>
-              </a:endParaRPr>
+                <a:rPr lang="te-IN" sz="2400" dirty="0">
+                  <a:latin typeface="Ramabhadra" panose="02000600000000000000" pitchFamily="2" charset="0"/>
+                  <a:cs typeface="Ramabhadra" panose="02000600000000000000" pitchFamily="2" charset="0"/>
+                </a:rPr>
+                <a:t>పాపినై యుండగ నేను</a:t>
+              </a:r>
             </a:p>
             <a:p>
               <a:pPr defTabSz="439781">
                 <a:defRPr/>
               </a:pPr>
               <a:r>
-                <a:rPr lang="te-IN" sz="2200" dirty="0">
-                  <a:latin typeface="Ramabhadra" panose="02000600000000000000" pitchFamily="2" charset="0"/>
-                  <a:cs typeface="Ramabhadra" panose="02000600000000000000" pitchFamily="2" charset="0"/>
-                </a:rPr>
-                <a:t>నూతన గానము చేయుదమా</a:t>
-              </a:r>
-              <a:endParaRPr lang="en-US" sz="2200" dirty="0">
-                <a:latin typeface="Ramabhadra" panose="02000600000000000000" pitchFamily="2" charset="0"/>
-                <a:cs typeface="Ramabhadra" panose="02000600000000000000" pitchFamily="2" charset="0"/>
-              </a:endParaRPr>
+                <a:rPr lang="te-IN" sz="2400" dirty="0">
+                  <a:latin typeface="Ramabhadra" panose="02000600000000000000" pitchFamily="2" charset="0"/>
+                  <a:cs typeface="Ramabhadra" panose="02000600000000000000" pitchFamily="2" charset="0"/>
+                </a:rPr>
+                <a:t>రక్షించి దరి చేర్చినావు (2)  </a:t>
+              </a:r>
             </a:p>
             <a:p>
               <a:pPr defTabSz="439781">
                 <a:defRPr/>
               </a:pPr>
-              <a:endParaRPr lang="en-US" sz="2200" dirty="0">
-                <a:latin typeface="Ramabhadra" panose="02000600000000000000" pitchFamily="2" charset="0"/>
-                <a:cs typeface="Ramabhadra" panose="02000600000000000000" pitchFamily="2" charset="0"/>
-              </a:endParaRPr>
+              <a:r>
+                <a:rPr lang="te-IN" sz="2400" dirty="0">
+                  <a:latin typeface="Ramabhadra" panose="02000600000000000000" pitchFamily="2" charset="0"/>
+                  <a:cs typeface="Ramabhadra" panose="02000600000000000000" pitchFamily="2" charset="0"/>
+                </a:rPr>
+                <a:t>నిను నే మరువనేసు</a:t>
+              </a:r>
             </a:p>
             <a:p>
               <a:pPr defTabSz="439781">
                 <a:defRPr/>
               </a:pPr>
               <a:r>
-                <a:rPr lang="te-IN" sz="2200" dirty="0">
-                  <a:latin typeface="Ramabhadra" panose="02000600000000000000" pitchFamily="2" charset="0"/>
-                  <a:cs typeface="Ramabhadra" panose="02000600000000000000" pitchFamily="2" charset="0"/>
-                </a:rPr>
-                <a:t>స్వర మండలముతో సితార సునాదముతో</a:t>
-              </a:r>
-              <a:endParaRPr lang="en-US" sz="2200" dirty="0">
-                <a:latin typeface="Ramabhadra" panose="02000600000000000000" pitchFamily="2" charset="0"/>
-                <a:cs typeface="Ramabhadra" panose="02000600000000000000" pitchFamily="2" charset="0"/>
-              </a:endParaRPr>
-            </a:p>
-            <a:p>
-              <a:pPr defTabSz="439781">
-                <a:defRPr/>
-              </a:pPr>
-              <a:r>
-                <a:rPr lang="te-IN" sz="2200" dirty="0">
-                  <a:latin typeface="Ramabhadra" panose="02000600000000000000" pitchFamily="2" charset="0"/>
-                  <a:cs typeface="Ramabhadra" panose="02000600000000000000" pitchFamily="2" charset="0"/>
-                </a:rPr>
-                <a:t>తంతి వాయిద్యములతో పిల్లన గ్రోవులతో</a:t>
-              </a:r>
-              <a:endParaRPr lang="en-US" sz="2200" dirty="0">
-                <a:latin typeface="Ramabhadra" panose="02000600000000000000" pitchFamily="2" charset="0"/>
-                <a:cs typeface="Ramabhadra" panose="02000600000000000000" pitchFamily="2" charset="0"/>
-              </a:endParaRPr>
-            </a:p>
-            <a:p>
-              <a:pPr defTabSz="439781">
-                <a:defRPr/>
-              </a:pPr>
-              <a:r>
-                <a:rPr lang="te-IN" sz="2200" dirty="0">
-                  <a:latin typeface="Ramabhadra" panose="02000600000000000000" pitchFamily="2" charset="0"/>
-                  <a:cs typeface="Ramabhadra" panose="02000600000000000000" pitchFamily="2" charset="0"/>
-                </a:rPr>
-                <a:t>మ్రోగుతాలంబులతో బూరల నాదముతో</a:t>
-              </a:r>
-              <a:endParaRPr lang="en-IN" sz="2200" dirty="0">
-                <a:latin typeface="Ramabhadra" panose="02000600000000000000" pitchFamily="2" charset="0"/>
-                <a:cs typeface="Ramabhadra" panose="02000600000000000000" pitchFamily="2" charset="0"/>
-              </a:endParaRPr>
-            </a:p>
-            <a:p>
-              <a:pPr defTabSz="439781">
-                <a:defRPr/>
-              </a:pPr>
-              <a:r>
-                <a:rPr lang="te-IN" sz="2200" dirty="0">
-                  <a:latin typeface="Ramabhadra" panose="02000600000000000000" pitchFamily="2" charset="0"/>
-                  <a:cs typeface="Ramabhadra" panose="02000600000000000000" pitchFamily="2" charset="0"/>
-                </a:rPr>
-                <a:t>గంభీర జయ ధ్వనులతో</a:t>
-              </a:r>
-              <a:endParaRPr lang="en-IN" sz="2200" dirty="0">
-                <a:latin typeface="Ramabhadra" panose="02000600000000000000" pitchFamily="2" charset="0"/>
-                <a:cs typeface="Ramabhadra" panose="02000600000000000000" pitchFamily="2" charset="0"/>
-              </a:endParaRPr>
-            </a:p>
-            <a:p>
-              <a:pPr defTabSz="439781">
-                <a:defRPr/>
-              </a:pPr>
-              <a:r>
-                <a:rPr lang="te-IN" sz="2200" dirty="0">
-                  <a:latin typeface="Ramabhadra" panose="02000600000000000000" pitchFamily="2" charset="0"/>
-                  <a:cs typeface="Ramabhadra" panose="02000600000000000000" pitchFamily="2" charset="0"/>
-                </a:rPr>
-                <a:t>ప్రభువుకు గానము చేయుదమా</a:t>
-              </a:r>
-              <a:endParaRPr lang="en-US" sz="2200" dirty="0">
-                <a:latin typeface="Ramabhadra" panose="02000600000000000000" pitchFamily="2" charset="0"/>
-                <a:cs typeface="Ramabhadra" panose="02000600000000000000" pitchFamily="2" charset="0"/>
-              </a:endParaRPr>
-            </a:p>
-            <a:p>
-              <a:pPr defTabSz="439781">
-                <a:defRPr/>
-              </a:pPr>
-              <a:r>
-                <a:rPr lang="te-IN" sz="2200" dirty="0">
-                  <a:latin typeface="Ramabhadra" panose="02000600000000000000" pitchFamily="2" charset="0"/>
-                  <a:cs typeface="Ramabhadra" panose="02000600000000000000" pitchFamily="2" charset="0"/>
-                </a:rPr>
-                <a:t>నూతన గానము చేయుదమా</a:t>
+                <a:rPr lang="te-IN" sz="2400" dirty="0">
+                  <a:latin typeface="Ramabhadra" panose="02000600000000000000" pitchFamily="2" charset="0"/>
+                  <a:cs typeface="Ramabhadra" panose="02000600000000000000" pitchFamily="2" charset="0"/>
+                </a:rPr>
+                <a:t>నిను నే విడువనేసు</a:t>
               </a:r>
             </a:p>
           </p:txBody>
@@ -4147,9 +4138,9 @@
         <p:grpSpPr>
           <a:xfrm>
             <a:off x="5104338" y="182031"/>
-            <a:ext cx="4932894" cy="6493935"/>
+            <a:ext cx="4801662" cy="6493935"/>
             <a:chOff x="160868" y="182032"/>
-            <a:chExt cx="4932894" cy="6493935"/>
+            <a:chExt cx="4801662" cy="6493935"/>
           </a:xfrm>
         </p:grpSpPr>
         <p:sp>
@@ -4221,8 +4212,8 @@
           </p:nvSpPr>
           <p:spPr>
             <a:xfrm>
-              <a:off x="343961" y="799864"/>
-              <a:ext cx="4749801" cy="5693866"/>
+              <a:off x="212729" y="286334"/>
+              <a:ext cx="4749801" cy="5940088"/>
             </a:xfrm>
             <a:prstGeom prst="rect">
               <a:avLst/>
@@ -4239,32 +4230,41 @@
                 <a:defRPr/>
               </a:pPr>
               <a:r>
-                <a:rPr lang="te-IN" sz="2600" dirty="0">
-                  <a:latin typeface="Ramabhadra" panose="02000600000000000000" pitchFamily="2" charset="0"/>
-                  <a:cs typeface="Ramabhadra" panose="02000600000000000000" pitchFamily="2" charset="0"/>
-                </a:rPr>
-                <a:t>తేజోమయా యేసయ్యా</a:t>
-              </a:r>
-              <a:r>
-                <a:rPr lang="en-US" sz="2600" dirty="0">
-                  <a:latin typeface="Ramabhadra" panose="02000600000000000000" pitchFamily="2" charset="0"/>
-                  <a:cs typeface="Ramabhadra" panose="02000600000000000000" pitchFamily="2" charset="0"/>
-                </a:rPr>
-                <a:t>-</a:t>
-              </a:r>
+                <a:rPr lang="te-IN" sz="2000" dirty="0">
+                  <a:latin typeface="Ramabhadra" panose="02000600000000000000" pitchFamily="2" charset="0"/>
+                  <a:cs typeface="Ramabhadra" panose="02000600000000000000" pitchFamily="2" charset="0"/>
+                </a:rPr>
+                <a:t>సుమధుర స్వరముల గానాలతో –</a:t>
+              </a:r>
+              <a:endParaRPr lang="en-IN" sz="2000" dirty="0">
+                <a:latin typeface="Ramabhadra" panose="02000600000000000000" pitchFamily="2" charset="0"/>
+                <a:cs typeface="Ramabhadra" panose="02000600000000000000" pitchFamily="2" charset="0"/>
+              </a:endParaRPr>
             </a:p>
             <a:p>
               <a:pPr defTabSz="439781">
                 <a:defRPr/>
               </a:pPr>
               <a:r>
-                <a:rPr lang="te-IN" sz="2600" dirty="0">
-                  <a:latin typeface="Ramabhadra" panose="02000600000000000000" pitchFamily="2" charset="0"/>
-                  <a:cs typeface="Ramabhadra" panose="02000600000000000000" pitchFamily="2" charset="0"/>
-                </a:rPr>
-                <a:t>స్తుతి పాత్రుడవు నీవయ్యా</a:t>
-              </a:r>
-              <a:endParaRPr lang="en-US" sz="2600" dirty="0">
+                <a:rPr lang="te-IN" sz="2000" dirty="0">
+                  <a:latin typeface="Ramabhadra" panose="02000600000000000000" pitchFamily="2" charset="0"/>
+                  <a:cs typeface="Ramabhadra" panose="02000600000000000000" pitchFamily="2" charset="0"/>
+                </a:rPr>
+                <a:t>వేలాది దూతల గళములతో</a:t>
+              </a:r>
+            </a:p>
+            <a:p>
+              <a:pPr defTabSz="439781">
+                <a:defRPr/>
+              </a:pPr>
+              <a:r>
+                <a:rPr lang="te-IN" sz="2000" dirty="0">
+                  <a:latin typeface="Ramabhadra" panose="02000600000000000000" pitchFamily="2" charset="0"/>
+                  <a:cs typeface="Ramabhadra" panose="02000600000000000000" pitchFamily="2" charset="0"/>
+                </a:rPr>
+                <a:t>కొనియాడబడుచున్న నా యేసయ్యా –</a:t>
+              </a:r>
+              <a:endParaRPr lang="en-IN" sz="2000" dirty="0">
                 <a:latin typeface="Ramabhadra" panose="02000600000000000000" pitchFamily="2" charset="0"/>
                 <a:cs typeface="Ramabhadra" panose="02000600000000000000" pitchFamily="2" charset="0"/>
               </a:endParaRPr>
@@ -4274,13 +4274,42 @@
                 <a:defRPr/>
               </a:pPr>
               <a:r>
-                <a:rPr lang="te-IN" sz="2600" dirty="0">
-                  <a:latin typeface="Ramabhadra" panose="02000600000000000000" pitchFamily="2" charset="0"/>
-                  <a:cs typeface="Ramabhadra" panose="02000600000000000000" pitchFamily="2" charset="0"/>
-                </a:rPr>
-                <a:t>మహిమ ఘనత ప్రభావములు</a:t>
-              </a:r>
-              <a:endParaRPr lang="en-US" sz="2600" dirty="0">
+                <a:rPr lang="te-IN" sz="2000" dirty="0">
+                  <a:latin typeface="Ramabhadra" panose="02000600000000000000" pitchFamily="2" charset="0"/>
+                  <a:cs typeface="Ramabhadra" panose="02000600000000000000" pitchFamily="2" charset="0"/>
+                </a:rPr>
+                <a:t>నీకే నా ఆరాధన (2)</a:t>
+              </a:r>
+            </a:p>
+            <a:p>
+              <a:pPr defTabSz="439781">
+                <a:defRPr/>
+              </a:pPr>
+              <a:r>
+                <a:rPr lang="te-IN" sz="2000" dirty="0">
+                  <a:latin typeface="Ramabhadra" panose="02000600000000000000" pitchFamily="2" charset="0"/>
+                  <a:cs typeface="Ramabhadra" panose="02000600000000000000" pitchFamily="2" charset="0"/>
+                </a:rPr>
+                <a:t>మహదానందమే నాలో పరవశమే</a:t>
+              </a:r>
+            </a:p>
+            <a:p>
+              <a:pPr defTabSz="439781">
+                <a:defRPr/>
+              </a:pPr>
+              <a:r>
+                <a:rPr lang="te-IN" sz="2000" dirty="0">
+                  <a:latin typeface="Ramabhadra" panose="02000600000000000000" pitchFamily="2" charset="0"/>
+                  <a:cs typeface="Ramabhadra" panose="02000600000000000000" pitchFamily="2" charset="0"/>
+                </a:rPr>
+                <a:t>నిన్ను స్తుతించిన ప్రతీక్షణం (2)</a:t>
+              </a:r>
+            </a:p>
+            <a:p>
+              <a:pPr defTabSz="439781">
+                <a:defRPr/>
+              </a:pPr>
+              <a:endParaRPr lang="te-IN" sz="2000" dirty="0">
                 <a:latin typeface="Ramabhadra" panose="02000600000000000000" pitchFamily="2" charset="0"/>
                 <a:cs typeface="Ramabhadra" panose="02000600000000000000" pitchFamily="2" charset="0"/>
               </a:endParaRPr>
@@ -4290,13 +4319,13 @@
                 <a:defRPr/>
               </a:pPr>
               <a:r>
-                <a:rPr lang="te-IN" sz="2600" dirty="0">
-                  <a:latin typeface="Ramabhadra" panose="02000600000000000000" pitchFamily="2" charset="0"/>
-                  <a:cs typeface="Ramabhadra" panose="02000600000000000000" pitchFamily="2" charset="0"/>
-                </a:rPr>
-                <a:t>సమస్తము నీకేనయా</a:t>
-              </a:r>
-              <a:endParaRPr lang="en-US" sz="2600" dirty="0">
+                <a:rPr lang="te-IN" sz="2000" dirty="0">
+                  <a:latin typeface="Ramabhadra" panose="02000600000000000000" pitchFamily="2" charset="0"/>
+                  <a:cs typeface="Ramabhadra" panose="02000600000000000000" pitchFamily="2" charset="0"/>
+                </a:rPr>
+                <a:t>ఎడారి త్రోవలో నే నడిచినా –</a:t>
+              </a:r>
+              <a:endParaRPr lang="en-IN" sz="2000" dirty="0">
                 <a:latin typeface="Ramabhadra" panose="02000600000000000000" pitchFamily="2" charset="0"/>
                 <a:cs typeface="Ramabhadra" panose="02000600000000000000" pitchFamily="2" charset="0"/>
               </a:endParaRPr>
@@ -4305,7 +4334,26 @@
               <a:pPr defTabSz="439781">
                 <a:defRPr/>
               </a:pPr>
-              <a:endParaRPr lang="en-US" sz="2600" dirty="0">
+              <a:r>
+                <a:rPr lang="te-IN" sz="2000" dirty="0">
+                  <a:latin typeface="Ramabhadra" panose="02000600000000000000" pitchFamily="2" charset="0"/>
+                  <a:cs typeface="Ramabhadra" panose="02000600000000000000" pitchFamily="2" charset="0"/>
+                </a:rPr>
+                <a:t>ఎరుగని మార్గములో నను నడిపినా</a:t>
+              </a:r>
+            </a:p>
+            <a:p>
+              <a:pPr defTabSz="439781">
+                <a:defRPr/>
+              </a:pPr>
+              <a:r>
+                <a:rPr lang="te-IN" sz="2000" dirty="0">
+                  <a:latin typeface="Ramabhadra" panose="02000600000000000000" pitchFamily="2" charset="0"/>
+                  <a:cs typeface="Ramabhadra" panose="02000600000000000000" pitchFamily="2" charset="0"/>
+                </a:rPr>
+                <a:t>నా ముందు నడచిన జయవీరుడా –</a:t>
+              </a:r>
+              <a:endParaRPr lang="en-IN" sz="2000" dirty="0">
                 <a:latin typeface="Ramabhadra" panose="02000600000000000000" pitchFamily="2" charset="0"/>
                 <a:cs typeface="Ramabhadra" panose="02000600000000000000" pitchFamily="2" charset="0"/>
               </a:endParaRPr>
@@ -4315,13 +4363,42 @@
                 <a:defRPr/>
               </a:pPr>
               <a:r>
-                <a:rPr lang="te-IN" sz="2600" dirty="0">
-                  <a:latin typeface="Ramabhadra" panose="02000600000000000000" pitchFamily="2" charset="0"/>
-                  <a:cs typeface="Ramabhadra" panose="02000600000000000000" pitchFamily="2" charset="0"/>
-                </a:rPr>
-                <a:t>నిజమైన దేవా నీవంటివాడు లేడు</a:t>
-              </a:r>
-              <a:endParaRPr lang="en-US" sz="2600" dirty="0">
+                <a:rPr lang="te-IN" sz="2000" dirty="0">
+                  <a:latin typeface="Ramabhadra" panose="02000600000000000000" pitchFamily="2" charset="0"/>
+                  <a:cs typeface="Ramabhadra" panose="02000600000000000000" pitchFamily="2" charset="0"/>
+                </a:rPr>
+                <a:t>నా విజయ సంకేతమా (2)</a:t>
+              </a:r>
+            </a:p>
+            <a:p>
+              <a:pPr defTabSz="439781">
+                <a:defRPr/>
+              </a:pPr>
+              <a:r>
+                <a:rPr lang="te-IN" sz="2000" dirty="0">
+                  <a:latin typeface="Ramabhadra" panose="02000600000000000000" pitchFamily="2" charset="0"/>
+                  <a:cs typeface="Ramabhadra" panose="02000600000000000000" pitchFamily="2" charset="0"/>
+                </a:rPr>
+                <a:t>నీవే నీవే – నా ఆనందము</a:t>
+              </a:r>
+            </a:p>
+            <a:p>
+              <a:pPr defTabSz="439781">
+                <a:defRPr/>
+              </a:pPr>
+              <a:r>
+                <a:rPr lang="te-IN" sz="2000" dirty="0">
+                  <a:latin typeface="Ramabhadra" panose="02000600000000000000" pitchFamily="2" charset="0"/>
+                  <a:cs typeface="Ramabhadra" panose="02000600000000000000" pitchFamily="2" charset="0"/>
+                </a:rPr>
+                <a:t>నీవే నీవే – నా ఆధారము (2)</a:t>
+              </a:r>
+            </a:p>
+            <a:p>
+              <a:pPr defTabSz="439781">
+                <a:defRPr/>
+              </a:pPr>
+              <a:endParaRPr lang="te-IN" sz="2000" dirty="0">
                 <a:latin typeface="Ramabhadra" panose="02000600000000000000" pitchFamily="2" charset="0"/>
                 <a:cs typeface="Ramabhadra" panose="02000600000000000000" pitchFamily="2" charset="0"/>
               </a:endParaRPr>
@@ -4331,13 +4408,25 @@
                 <a:defRPr/>
               </a:pPr>
               <a:r>
-                <a:rPr lang="te-IN" sz="2600" dirty="0">
-                  <a:latin typeface="Ramabhadra" panose="02000600000000000000" pitchFamily="2" charset="0"/>
-                  <a:cs typeface="Ramabhadra" panose="02000600000000000000" pitchFamily="2" charset="0"/>
-                </a:rPr>
-                <a:t>మహాత్మ్యము గల నిన్ను పోలినవాడెవడు</a:t>
-              </a:r>
-              <a:endParaRPr lang="en-US" sz="2600" dirty="0">
+                <a:rPr lang="te-IN" sz="2000" dirty="0">
+                  <a:latin typeface="Ramabhadra" panose="02000600000000000000" pitchFamily="2" charset="0"/>
+                  <a:cs typeface="Ramabhadra" panose="02000600000000000000" pitchFamily="2" charset="0"/>
+                </a:rPr>
+                <a:t>సంపూర్ణమైన నీ చిత్తమే – అనుకూలమైన సంకల్పమే</a:t>
+              </a:r>
+            </a:p>
+            <a:p>
+              <a:pPr defTabSz="439781">
+                <a:defRPr/>
+              </a:pPr>
+              <a:r>
+                <a:rPr lang="te-IN" sz="2000" dirty="0">
+                  <a:latin typeface="Ramabhadra" panose="02000600000000000000" pitchFamily="2" charset="0"/>
+                  <a:cs typeface="Ramabhadra" panose="02000600000000000000" pitchFamily="2" charset="0"/>
+                </a:rPr>
+                <a:t>జరిగించుచున్నావు నను విడువక –</a:t>
+              </a:r>
+              <a:endParaRPr lang="en-IN" sz="2000" dirty="0">
                 <a:latin typeface="Ramabhadra" panose="02000600000000000000" pitchFamily="2" charset="0"/>
                 <a:cs typeface="Ramabhadra" panose="02000600000000000000" pitchFamily="2" charset="0"/>
               </a:endParaRPr>
@@ -4347,101 +4436,35 @@
                 <a:defRPr/>
               </a:pPr>
               <a:r>
-                <a:rPr lang="te-IN" sz="2600" dirty="0">
-                  <a:latin typeface="Ramabhadra" panose="02000600000000000000" pitchFamily="2" charset="0"/>
-                  <a:cs typeface="Ramabhadra" panose="02000600000000000000" pitchFamily="2" charset="0"/>
-                </a:rPr>
-                <a:t>నీ నామము ఘనమైనదయా –</a:t>
-              </a:r>
-              <a:endParaRPr lang="en-US" sz="2600" dirty="0">
-                <a:latin typeface="Ramabhadra" panose="02000600000000000000" pitchFamily="2" charset="0"/>
-                <a:cs typeface="Ramabhadra" panose="02000600000000000000" pitchFamily="2" charset="0"/>
-              </a:endParaRPr>
+                <a:rPr lang="te-IN" sz="2000" dirty="0">
+                  <a:latin typeface="Ramabhadra" panose="02000600000000000000" pitchFamily="2" charset="0"/>
+                  <a:cs typeface="Ramabhadra" panose="02000600000000000000" pitchFamily="2" charset="0"/>
+                </a:rPr>
+                <a:t>నా ధైర్యము నీవేగా (2)</a:t>
+              </a:r>
             </a:p>
             <a:p>
               <a:pPr defTabSz="439781">
                 <a:defRPr/>
               </a:pPr>
               <a:r>
-                <a:rPr lang="te-IN" sz="2600" dirty="0">
-                  <a:latin typeface="Ramabhadra" panose="02000600000000000000" pitchFamily="2" charset="0"/>
-                  <a:cs typeface="Ramabhadra" panose="02000600000000000000" pitchFamily="2" charset="0"/>
-                </a:rPr>
-                <a:t>నరులు నీకు భయపడెదరయా</a:t>
-              </a:r>
-              <a:endParaRPr lang="en-US" sz="2600" dirty="0">
-                <a:latin typeface="Ramabhadra" panose="02000600000000000000" pitchFamily="2" charset="0"/>
-                <a:cs typeface="Ramabhadra" panose="02000600000000000000" pitchFamily="2" charset="0"/>
-              </a:endParaRPr>
-            </a:p>
-            <a:p>
-              <a:pPr marL="457200" indent="-457200" defTabSz="439781">
-                <a:buAutoNum type="arabicPeriod"/>
-                <a:defRPr/>
-              </a:pPr>
-              <a:endParaRPr lang="en-US" sz="2600" dirty="0">
-                <a:latin typeface="Ramabhadra" panose="02000600000000000000" pitchFamily="2" charset="0"/>
-                <a:cs typeface="Ramabhadra" panose="02000600000000000000" pitchFamily="2" charset="0"/>
-              </a:endParaRPr>
+                <a:rPr lang="te-IN" sz="2000" dirty="0">
+                  <a:latin typeface="Ramabhadra" panose="02000600000000000000" pitchFamily="2" charset="0"/>
+                  <a:cs typeface="Ramabhadra" panose="02000600000000000000" pitchFamily="2" charset="0"/>
+                </a:rPr>
+                <a:t>నీవే నీవే – నా జయగీతము</a:t>
+              </a:r>
             </a:p>
             <a:p>
               <a:pPr defTabSz="439781">
                 <a:defRPr/>
               </a:pPr>
               <a:r>
-                <a:rPr lang="te-IN" sz="2600" dirty="0">
-                  <a:latin typeface="Ramabhadra" panose="02000600000000000000" pitchFamily="2" charset="0"/>
-                  <a:cs typeface="Ramabhadra" panose="02000600000000000000" pitchFamily="2" charset="0"/>
-                </a:rPr>
-                <a:t>జనములకు రాజా జీవముగలిగిన నాథా</a:t>
-              </a:r>
-              <a:endParaRPr lang="en-US" sz="2600" dirty="0">
-                <a:latin typeface="Ramabhadra" panose="02000600000000000000" pitchFamily="2" charset="0"/>
-                <a:cs typeface="Ramabhadra" panose="02000600000000000000" pitchFamily="2" charset="0"/>
-              </a:endParaRPr>
-            </a:p>
-            <a:p>
-              <a:pPr defTabSz="439781">
-                <a:defRPr/>
-              </a:pPr>
-              <a:r>
-                <a:rPr lang="te-IN" sz="2600" dirty="0">
-                  <a:latin typeface="Ramabhadra" panose="02000600000000000000" pitchFamily="2" charset="0"/>
-                  <a:cs typeface="Ramabhadra" panose="02000600000000000000" pitchFamily="2" charset="0"/>
-                </a:rPr>
-                <a:t>సమస్తము నిర్మించినవాడవు నీవెగదా</a:t>
-              </a:r>
-              <a:endParaRPr lang="en-US" sz="2600" dirty="0">
-                <a:latin typeface="Ramabhadra" panose="02000600000000000000" pitchFamily="2" charset="0"/>
-                <a:cs typeface="Ramabhadra" panose="02000600000000000000" pitchFamily="2" charset="0"/>
-              </a:endParaRPr>
-            </a:p>
-            <a:p>
-              <a:pPr defTabSz="439781">
-                <a:defRPr/>
-              </a:pPr>
-              <a:r>
-                <a:rPr lang="te-IN" sz="2600" dirty="0">
-                  <a:latin typeface="Ramabhadra" panose="02000600000000000000" pitchFamily="2" charset="0"/>
-                  <a:cs typeface="Ramabhadra" panose="02000600000000000000" pitchFamily="2" charset="0"/>
-                </a:rPr>
-                <a:t>నీ ఉగ్రత తాళలేమయా –</a:t>
-              </a:r>
-              <a:endParaRPr lang="en-US" sz="2600" dirty="0">
-                <a:latin typeface="Ramabhadra" panose="02000600000000000000" pitchFamily="2" charset="0"/>
-                <a:cs typeface="Ramabhadra" panose="02000600000000000000" pitchFamily="2" charset="0"/>
-              </a:endParaRPr>
-            </a:p>
-            <a:p>
-              <a:pPr defTabSz="439781">
-                <a:defRPr/>
-              </a:pPr>
-              <a:r>
-                <a:rPr lang="te-IN" sz="2600" dirty="0">
-                  <a:latin typeface="Ramabhadra" panose="02000600000000000000" pitchFamily="2" charset="0"/>
-                  <a:cs typeface="Ramabhadra" panose="02000600000000000000" pitchFamily="2" charset="0"/>
-                </a:rPr>
-                <a:t>మేలు చేయగలవు నీవయా</a:t>
+                <a:rPr lang="te-IN" sz="2000" dirty="0">
+                  <a:latin typeface="Ramabhadra" panose="02000600000000000000" pitchFamily="2" charset="0"/>
+                  <a:cs typeface="Ramabhadra" panose="02000600000000000000" pitchFamily="2" charset="0"/>
+                </a:rPr>
+                <a:t>నీవే నీవే – నా స్తుతిగీతము (2)</a:t>
               </a:r>
             </a:p>
           </p:txBody>
@@ -4460,7 +4483,7 @@
           </p:nvSpPr>
           <p:spPr>
             <a:xfrm>
-              <a:off x="343961" y="326430"/>
+              <a:off x="4300012" y="286334"/>
               <a:ext cx="390525" cy="390525"/>
             </a:xfrm>
             <a:prstGeom prst="ellipse">

</xml_diff>

<commit_message>
22 dec 24 songs
</commit_message>
<xml_diff>
--- a/songsTemplate.pptx
+++ b/songsTemplate.pptx
@@ -255,7 +255,7 @@
           <a:p>
             <a:fld id="{F1102B08-ED9E-409F-B95F-09CAA1DAF6E0}" type="datetimeFigureOut">
               <a:rPr lang="en-IN" smtClean="0"/>
-              <a:t>14-12-2024</a:t>
+              <a:t>21-12-2024</a:t>
             </a:fld>
             <a:endParaRPr lang="en-IN"/>
           </a:p>
@@ -425,7 +425,7 @@
           <a:p>
             <a:fld id="{F1102B08-ED9E-409F-B95F-09CAA1DAF6E0}" type="datetimeFigureOut">
               <a:rPr lang="en-IN" smtClean="0"/>
-              <a:t>14-12-2024</a:t>
+              <a:t>21-12-2024</a:t>
             </a:fld>
             <a:endParaRPr lang="en-IN"/>
           </a:p>
@@ -605,7 +605,7 @@
           <a:p>
             <a:fld id="{F1102B08-ED9E-409F-B95F-09CAA1DAF6E0}" type="datetimeFigureOut">
               <a:rPr lang="en-IN" smtClean="0"/>
-              <a:t>14-12-2024</a:t>
+              <a:t>21-12-2024</a:t>
             </a:fld>
             <a:endParaRPr lang="en-IN"/>
           </a:p>
@@ -775,7 +775,7 @@
           <a:p>
             <a:fld id="{F1102B08-ED9E-409F-B95F-09CAA1DAF6E0}" type="datetimeFigureOut">
               <a:rPr lang="en-IN" smtClean="0"/>
-              <a:t>14-12-2024</a:t>
+              <a:t>21-12-2024</a:t>
             </a:fld>
             <a:endParaRPr lang="en-IN"/>
           </a:p>
@@ -1019,7 +1019,7 @@
           <a:p>
             <a:fld id="{F1102B08-ED9E-409F-B95F-09CAA1DAF6E0}" type="datetimeFigureOut">
               <a:rPr lang="en-IN" smtClean="0"/>
-              <a:t>14-12-2024</a:t>
+              <a:t>21-12-2024</a:t>
             </a:fld>
             <a:endParaRPr lang="en-IN"/>
           </a:p>
@@ -1251,7 +1251,7 @@
           <a:p>
             <a:fld id="{F1102B08-ED9E-409F-B95F-09CAA1DAF6E0}" type="datetimeFigureOut">
               <a:rPr lang="en-IN" smtClean="0"/>
-              <a:t>14-12-2024</a:t>
+              <a:t>21-12-2024</a:t>
             </a:fld>
             <a:endParaRPr lang="en-IN"/>
           </a:p>
@@ -1618,7 +1618,7 @@
           <a:p>
             <a:fld id="{F1102B08-ED9E-409F-B95F-09CAA1DAF6E0}" type="datetimeFigureOut">
               <a:rPr lang="en-IN" smtClean="0"/>
-              <a:t>14-12-2024</a:t>
+              <a:t>21-12-2024</a:t>
             </a:fld>
             <a:endParaRPr lang="en-IN"/>
           </a:p>
@@ -1736,7 +1736,7 @@
           <a:p>
             <a:fld id="{F1102B08-ED9E-409F-B95F-09CAA1DAF6E0}" type="datetimeFigureOut">
               <a:rPr lang="en-IN" smtClean="0"/>
-              <a:t>14-12-2024</a:t>
+              <a:t>21-12-2024</a:t>
             </a:fld>
             <a:endParaRPr lang="en-IN"/>
           </a:p>
@@ -1831,7 +1831,7 @@
           <a:p>
             <a:fld id="{F1102B08-ED9E-409F-B95F-09CAA1DAF6E0}" type="datetimeFigureOut">
               <a:rPr lang="en-IN" smtClean="0"/>
-              <a:t>14-12-2024</a:t>
+              <a:t>21-12-2024</a:t>
             </a:fld>
             <a:endParaRPr lang="en-IN"/>
           </a:p>
@@ -2108,7 +2108,7 @@
           <a:p>
             <a:fld id="{F1102B08-ED9E-409F-B95F-09CAA1DAF6E0}" type="datetimeFigureOut">
               <a:rPr lang="en-IN" smtClean="0"/>
-              <a:t>14-12-2024</a:t>
+              <a:t>21-12-2024</a:t>
             </a:fld>
             <a:endParaRPr lang="en-IN"/>
           </a:p>
@@ -2365,7 +2365,7 @@
           <a:p>
             <a:fld id="{F1102B08-ED9E-409F-B95F-09CAA1DAF6E0}" type="datetimeFigureOut">
               <a:rPr lang="en-IN" smtClean="0"/>
-              <a:t>14-12-2024</a:t>
+              <a:t>21-12-2024</a:t>
             </a:fld>
             <a:endParaRPr lang="en-IN"/>
           </a:p>
@@ -2578,7 +2578,7 @@
           <a:p>
             <a:fld id="{F1102B08-ED9E-409F-B95F-09CAA1DAF6E0}" type="datetimeFigureOut">
               <a:rPr lang="en-IN" smtClean="0"/>
-              <a:t>14-12-2024</a:t>
+              <a:t>21-12-2024</a:t>
             </a:fld>
             <a:endParaRPr lang="en-IN"/>
           </a:p>
@@ -3073,7 +3073,7 @@
           <p:spPr>
             <a:xfrm>
               <a:off x="272140" y="309857"/>
-              <a:ext cx="4483140" cy="6001643"/>
+              <a:ext cx="4483140" cy="5847755"/>
             </a:xfrm>
             <a:prstGeom prst="rect">
               <a:avLst/>
@@ -3090,82 +3090,78 @@
                 <a:defRPr/>
               </a:pPr>
               <a:r>
-                <a:rPr lang="te-IN" sz="2400" dirty="0">
-                  <a:latin typeface="Ramabhadra" panose="02000600000000000000" pitchFamily="2" charset="0"/>
-                  <a:cs typeface="Ramabhadra" panose="02000600000000000000" pitchFamily="2" charset="0"/>
-                </a:rPr>
-                <a:t>దేవా నా దేవా – నీవే నా కాపరి</a:t>
-              </a:r>
-              <a:br>
-                <a:rPr lang="te-IN" sz="2400" dirty="0">
-                  <a:latin typeface="Ramabhadra" panose="02000600000000000000" pitchFamily="2" charset="0"/>
-                  <a:cs typeface="Ramabhadra" panose="02000600000000000000" pitchFamily="2" charset="0"/>
-                </a:rPr>
-              </a:br>
-              <a:r>
-                <a:rPr lang="te-IN" sz="2400" dirty="0">
-                  <a:latin typeface="Ramabhadra" panose="02000600000000000000" pitchFamily="2" charset="0"/>
-                  <a:cs typeface="Ramabhadra" panose="02000600000000000000" pitchFamily="2" charset="0"/>
-                </a:rPr>
-                <a:t>నీ ప్రేమ నీ క్షమా – ఎంతో గొప్పది (2)</a:t>
-              </a:r>
-              <a:br>
-                <a:rPr lang="te-IN" sz="2400" dirty="0">
-                  <a:latin typeface="Ramabhadra" panose="02000600000000000000" pitchFamily="2" charset="0"/>
-                  <a:cs typeface="Ramabhadra" panose="02000600000000000000" pitchFamily="2" charset="0"/>
-                </a:rPr>
-              </a:br>
-              <a:r>
-                <a:rPr lang="te-IN" sz="2400" dirty="0">
-                  <a:latin typeface="Ramabhadra" panose="02000600000000000000" pitchFamily="2" charset="0"/>
-                  <a:cs typeface="Ramabhadra" panose="02000600000000000000" pitchFamily="2" charset="0"/>
-                </a:rPr>
-                <a:t>ఆరాధింతును హృదయాంతరంగములో</a:t>
-              </a:r>
-              <a:br>
-                <a:rPr lang="te-IN" sz="2400" dirty="0">
-                  <a:latin typeface="Ramabhadra" panose="02000600000000000000" pitchFamily="2" charset="0"/>
-                  <a:cs typeface="Ramabhadra" panose="02000600000000000000" pitchFamily="2" charset="0"/>
-                </a:rPr>
-              </a:br>
-              <a:r>
-                <a:rPr lang="te-IN" sz="2400" dirty="0">
-                  <a:latin typeface="Ramabhadra" panose="02000600000000000000" pitchFamily="2" charset="0"/>
-                  <a:cs typeface="Ramabhadra" panose="02000600000000000000" pitchFamily="2" charset="0"/>
-                </a:rPr>
-                <a:t>స్తుతించెదను నీ పాద సన్నిధిలో (2)</a:t>
-              </a:r>
-              <a:br>
-                <a:rPr lang="te-IN" sz="2400" dirty="0">
-                  <a:latin typeface="Ramabhadra" panose="02000600000000000000" pitchFamily="2" charset="0"/>
-                  <a:cs typeface="Ramabhadra" panose="02000600000000000000" pitchFamily="2" charset="0"/>
-                </a:rPr>
-              </a:br>
-              <a:r>
-                <a:rPr lang="te-IN" sz="2400" dirty="0">
-                  <a:latin typeface="Ramabhadra" panose="02000600000000000000" pitchFamily="2" charset="0"/>
-                  <a:cs typeface="Ramabhadra" panose="02000600000000000000" pitchFamily="2" charset="0"/>
-                </a:rPr>
-                <a:t>నీవే కదా దేవుడవు – (2)</a:t>
-              </a:r>
-            </a:p>
-            <a:p>
-              <a:pPr defTabSz="439781">
-                <a:defRPr/>
-              </a:pPr>
-              <a:r>
-                <a:rPr lang="te-IN" sz="2400" dirty="0">
-                  <a:latin typeface="Ramabhadra" panose="02000600000000000000" pitchFamily="2" charset="0"/>
-                  <a:cs typeface="Ramabhadra" panose="02000600000000000000" pitchFamily="2" charset="0"/>
-                </a:rPr>
-                <a:t>దేవా యేసు దేవా (4)     </a:t>
-              </a:r>
-            </a:p>
-            <a:p>
-              <a:pPr defTabSz="439781">
-                <a:defRPr/>
-              </a:pPr>
-              <a:endParaRPr lang="te-IN" sz="2400" dirty="0">
+                <a:rPr lang="te-IN" sz="2200" dirty="0">
+                  <a:latin typeface="Ramabhadra" panose="02000600000000000000" pitchFamily="2" charset="0"/>
+                  <a:cs typeface="Ramabhadra" panose="02000600000000000000" pitchFamily="2" charset="0"/>
+                </a:rPr>
+                <a:t>చాలిన దేవుడవు యేసు </a:t>
+              </a:r>
+            </a:p>
+            <a:p>
+              <a:pPr defTabSz="439781">
+                <a:defRPr/>
+              </a:pPr>
+              <a:r>
+                <a:rPr lang="te-IN" sz="2200" dirty="0">
+                  <a:latin typeface="Ramabhadra" panose="02000600000000000000" pitchFamily="2" charset="0"/>
+                  <a:cs typeface="Ramabhadra" panose="02000600000000000000" pitchFamily="2" charset="0"/>
+                </a:rPr>
+                <a:t>చాలిన దేవుడ నీవు</a:t>
+              </a:r>
+            </a:p>
+            <a:p>
+              <a:pPr defTabSz="439781">
+                <a:defRPr/>
+              </a:pPr>
+              <a:r>
+                <a:rPr lang="te-IN" sz="2200" dirty="0">
+                  <a:latin typeface="Ramabhadra" panose="02000600000000000000" pitchFamily="2" charset="0"/>
+                  <a:cs typeface="Ramabhadra" panose="02000600000000000000" pitchFamily="2" charset="0"/>
+                </a:rPr>
+                <a:t>వ్యాధి బాధ సమయములో</a:t>
+              </a:r>
+            </a:p>
+            <a:p>
+              <a:pPr defTabSz="439781">
+                <a:defRPr/>
+              </a:pPr>
+              <a:r>
+                <a:rPr lang="te-IN" sz="2200" dirty="0">
+                  <a:latin typeface="Ramabhadra" panose="02000600000000000000" pitchFamily="2" charset="0"/>
+                  <a:cs typeface="Ramabhadra" panose="02000600000000000000" pitchFamily="2" charset="0"/>
+                </a:rPr>
+                <a:t>కష్టసుడుల తరంగములో</a:t>
+              </a:r>
+            </a:p>
+            <a:p>
+              <a:pPr defTabSz="439781">
+                <a:defRPr/>
+              </a:pPr>
+              <a:r>
+                <a:rPr lang="te-IN" sz="2200" dirty="0">
+                  <a:latin typeface="Ramabhadra" panose="02000600000000000000" pitchFamily="2" charset="0"/>
+                  <a:cs typeface="Ramabhadra" panose="02000600000000000000" pitchFamily="2" charset="0"/>
+                </a:rPr>
+                <a:t>ఏమున్నా లేకున్నా ఏ స్ధితికైనా</a:t>
+              </a:r>
+            </a:p>
+            <a:p>
+              <a:pPr defTabSz="439781">
+                <a:defRPr/>
+              </a:pPr>
+              <a:r>
+                <a:rPr lang="te-IN" sz="2200" dirty="0">
+                  <a:latin typeface="Ramabhadra" panose="02000600000000000000" pitchFamily="2" charset="0"/>
+                  <a:cs typeface="Ramabhadra" panose="02000600000000000000" pitchFamily="2" charset="0"/>
+                </a:rPr>
+                <a:t>చాలిన దేవుడ నీవు</a:t>
+              </a:r>
+            </a:p>
+            <a:p>
+              <a:pPr defTabSz="439781">
+                <a:defRPr/>
+              </a:pPr>
+              <a:endParaRPr lang="te-IN" sz="2200" dirty="0">
                 <a:latin typeface="Ramabhadra" panose="02000600000000000000" pitchFamily="2" charset="0"/>
                 <a:cs typeface="Ramabhadra" panose="02000600000000000000" pitchFamily="2" charset="0"/>
               </a:endParaRPr>
@@ -3175,57 +3171,54 @@
                 <a:defRPr/>
               </a:pPr>
               <a:r>
-                <a:rPr lang="te-IN" sz="2400" dirty="0">
-                  <a:latin typeface="Ramabhadra" panose="02000600000000000000" pitchFamily="2" charset="0"/>
-                  <a:cs typeface="Ramabhadra" panose="02000600000000000000" pitchFamily="2" charset="0"/>
-                </a:rPr>
-                <a:t>పాపము నుండి విడిపించినావు</a:t>
-              </a:r>
-              <a:br>
-                <a:rPr lang="te-IN" sz="2400" dirty="0">
-                  <a:latin typeface="Ramabhadra" panose="02000600000000000000" pitchFamily="2" charset="0"/>
-                  <a:cs typeface="Ramabhadra" panose="02000600000000000000" pitchFamily="2" charset="0"/>
-                </a:rPr>
-              </a:br>
-              <a:r>
-                <a:rPr lang="te-IN" sz="2400" dirty="0">
-                  <a:latin typeface="Ramabhadra" panose="02000600000000000000" pitchFamily="2" charset="0"/>
-                  <a:cs typeface="Ramabhadra" panose="02000600000000000000" pitchFamily="2" charset="0"/>
-                </a:rPr>
-                <a:t>పరిశుద్ధుని చేసి ప్రేమించినావు (2)</a:t>
-              </a:r>
-              <a:br>
-                <a:rPr lang="te-IN" sz="2400" dirty="0">
-                  <a:latin typeface="Ramabhadra" panose="02000600000000000000" pitchFamily="2" charset="0"/>
-                  <a:cs typeface="Ramabhadra" panose="02000600000000000000" pitchFamily="2" charset="0"/>
-                </a:rPr>
-              </a:br>
-              <a:r>
-                <a:rPr lang="te-IN" sz="2400" dirty="0">
-                  <a:latin typeface="Ramabhadra" panose="02000600000000000000" pitchFamily="2" charset="0"/>
-                  <a:cs typeface="Ramabhadra" panose="02000600000000000000" pitchFamily="2" charset="0"/>
-                </a:rPr>
-                <a:t>నీవే కదా దేవుడవు – (2)</a:t>
-              </a:r>
-              <a:br>
-                <a:rPr lang="te-IN" sz="2400" dirty="0">
-                  <a:latin typeface="Ramabhadra" panose="02000600000000000000" pitchFamily="2" charset="0"/>
-                  <a:cs typeface="Ramabhadra" panose="02000600000000000000" pitchFamily="2" charset="0"/>
-                </a:rPr>
-              </a:br>
-              <a:r>
-                <a:rPr lang="te-IN" sz="2400" dirty="0">
-                  <a:latin typeface="Ramabhadra" panose="02000600000000000000" pitchFamily="2" charset="0"/>
-                  <a:cs typeface="Ramabhadra" panose="02000600000000000000" pitchFamily="2" charset="0"/>
-                </a:rPr>
-                <a:t>దేవా యేసు దేవా (4)       </a:t>
-              </a:r>
-            </a:p>
-            <a:p>
-              <a:pPr defTabSz="439781">
-                <a:defRPr/>
-              </a:pPr>
-              <a:endParaRPr lang="te-IN" sz="2400" dirty="0">
+                <a:rPr lang="te-IN" sz="2200" dirty="0">
+                  <a:latin typeface="Ramabhadra" panose="02000600000000000000" pitchFamily="2" charset="0"/>
+                  <a:cs typeface="Ramabhadra" panose="02000600000000000000" pitchFamily="2" charset="0"/>
+                </a:rPr>
+                <a:t>అంజూర చెట్లు పూయకున్నను</a:t>
+              </a:r>
+            </a:p>
+            <a:p>
+              <a:pPr defTabSz="439781">
+                <a:defRPr/>
+              </a:pPr>
+              <a:r>
+                <a:rPr lang="te-IN" sz="2200" dirty="0">
+                  <a:latin typeface="Ramabhadra" panose="02000600000000000000" pitchFamily="2" charset="0"/>
+                  <a:cs typeface="Ramabhadra" panose="02000600000000000000" pitchFamily="2" charset="0"/>
+                </a:rPr>
+                <a:t>ద్రాక్ష చెట్లు ఫలింపకున్నను</a:t>
+              </a:r>
+            </a:p>
+            <a:p>
+              <a:pPr defTabSz="439781">
+                <a:defRPr/>
+              </a:pPr>
+              <a:r>
+                <a:rPr lang="te-IN" sz="2200" dirty="0">
+                  <a:latin typeface="Ramabhadra" panose="02000600000000000000" pitchFamily="2" charset="0"/>
+                  <a:cs typeface="Ramabhadra" panose="02000600000000000000" pitchFamily="2" charset="0"/>
+                </a:rPr>
+                <a:t>చేనులోని పైరు పండకపోయినను</a:t>
+              </a:r>
+            </a:p>
+            <a:p>
+              <a:pPr defTabSz="439781">
+                <a:defRPr/>
+              </a:pPr>
+              <a:r>
+                <a:rPr lang="te-IN" sz="2200" dirty="0">
+                  <a:latin typeface="Ramabhadra" panose="02000600000000000000" pitchFamily="2" charset="0"/>
+                  <a:cs typeface="Ramabhadra" panose="02000600000000000000" pitchFamily="2" charset="0"/>
+                </a:rPr>
+                <a:t>శాలలోని పశువులు లేక పోయినను</a:t>
+              </a:r>
+            </a:p>
+            <a:p>
+              <a:pPr defTabSz="439781">
+                <a:defRPr/>
+              </a:pPr>
+              <a:endParaRPr lang="te-IN" sz="2200" dirty="0">
                 <a:latin typeface="Ramabhadra" panose="02000600000000000000" pitchFamily="2" charset="0"/>
                 <a:cs typeface="Ramabhadra" panose="02000600000000000000" pitchFamily="2" charset="0"/>
               </a:endParaRPr>
@@ -3235,50 +3228,63 @@
                 <a:defRPr/>
               </a:pPr>
               <a:r>
-                <a:rPr lang="te-IN" sz="2400" dirty="0">
-                  <a:latin typeface="Ramabhadra" panose="02000600000000000000" pitchFamily="2" charset="0"/>
-                  <a:cs typeface="Ramabhadra" panose="02000600000000000000" pitchFamily="2" charset="0"/>
-                </a:rPr>
-                <a:t>పరిశుద్ధాత్మను నాలో నింపావు</a:t>
-              </a:r>
-              <a:br>
-                <a:rPr lang="te-IN" sz="2400" dirty="0">
-                  <a:latin typeface="Ramabhadra" panose="02000600000000000000" pitchFamily="2" charset="0"/>
-                  <a:cs typeface="Ramabhadra" panose="02000600000000000000" pitchFamily="2" charset="0"/>
-                </a:rPr>
-              </a:br>
-              <a:r>
-                <a:rPr lang="te-IN" sz="2400" dirty="0">
-                  <a:latin typeface="Ramabhadra" panose="02000600000000000000" pitchFamily="2" charset="0"/>
-                  <a:cs typeface="Ramabhadra" panose="02000600000000000000" pitchFamily="2" charset="0"/>
-                </a:rPr>
-                <a:t>మట్టి దేహమును మహిమతో నింపావు (2)</a:t>
-              </a:r>
-              <a:br>
-                <a:rPr lang="te-IN" sz="2400" dirty="0">
-                  <a:latin typeface="Ramabhadra" panose="02000600000000000000" pitchFamily="2" charset="0"/>
-                  <a:cs typeface="Ramabhadra" panose="02000600000000000000" pitchFamily="2" charset="0"/>
-                </a:rPr>
-              </a:br>
-              <a:r>
-                <a:rPr lang="te-IN" sz="2400" dirty="0">
-                  <a:latin typeface="Ramabhadra" panose="02000600000000000000" pitchFamily="2" charset="0"/>
-                  <a:cs typeface="Ramabhadra" panose="02000600000000000000" pitchFamily="2" charset="0"/>
-                </a:rPr>
-                <a:t>నీవే కదా దేవుడవు – (2)</a:t>
-              </a:r>
-              <a:br>
-                <a:rPr lang="te-IN" sz="2400" dirty="0">
-                  <a:latin typeface="Ramabhadra" panose="02000600000000000000" pitchFamily="2" charset="0"/>
-                  <a:cs typeface="Ramabhadra" panose="02000600000000000000" pitchFamily="2" charset="0"/>
-                </a:rPr>
-              </a:br>
-              <a:r>
-                <a:rPr lang="te-IN" sz="2400" dirty="0">
-                  <a:latin typeface="Ramabhadra" panose="02000600000000000000" pitchFamily="2" charset="0"/>
-                  <a:cs typeface="Ramabhadra" panose="02000600000000000000" pitchFamily="2" charset="0"/>
-                </a:rPr>
-                <a:t>దేవా యేసు దేవా (4)       </a:t>
+                <a:rPr lang="te-IN" sz="2200" dirty="0">
+                  <a:latin typeface="Ramabhadra" panose="02000600000000000000" pitchFamily="2" charset="0"/>
+                  <a:cs typeface="Ramabhadra" panose="02000600000000000000" pitchFamily="2" charset="0"/>
+                </a:rPr>
+                <a:t>గాఢాంధకారాన పయనించిన </a:t>
+              </a:r>
+            </a:p>
+            <a:p>
+              <a:pPr defTabSz="439781">
+                <a:defRPr/>
+              </a:pPr>
+              <a:r>
+                <a:rPr lang="te-IN" sz="2200" dirty="0">
+                  <a:latin typeface="Ramabhadra" panose="02000600000000000000" pitchFamily="2" charset="0"/>
+                  <a:cs typeface="Ramabhadra" panose="02000600000000000000" pitchFamily="2" charset="0"/>
+                </a:rPr>
+                <a:t>పొంగు సాగరా లెదురైన</a:t>
+              </a:r>
+            </a:p>
+            <a:p>
+              <a:pPr defTabSz="439781">
+                <a:defRPr/>
+              </a:pPr>
+              <a:r>
+                <a:rPr lang="te-IN" sz="2200" dirty="0">
+                  <a:latin typeface="Ramabhadra" panose="02000600000000000000" pitchFamily="2" charset="0"/>
+                  <a:cs typeface="Ramabhadra" panose="02000600000000000000" pitchFamily="2" charset="0"/>
+                </a:rPr>
+                <a:t>లోకమంత ఒకటైన</a:t>
+              </a:r>
+              <a:endParaRPr lang="en-IN" sz="2200" dirty="0">
+                <a:latin typeface="Ramabhadra" panose="02000600000000000000" pitchFamily="2" charset="0"/>
+                <a:cs typeface="Ramabhadra" panose="02000600000000000000" pitchFamily="2" charset="0"/>
+              </a:endParaRPr>
+            </a:p>
+            <a:p>
+              <a:pPr defTabSz="439781">
+                <a:defRPr/>
+              </a:pPr>
+              <a:r>
+                <a:rPr lang="te-IN" sz="2200" dirty="0">
+                  <a:latin typeface="Ramabhadra" panose="02000600000000000000" pitchFamily="2" charset="0"/>
+                  <a:cs typeface="Ramabhadra" panose="02000600000000000000" pitchFamily="2" charset="0"/>
+                </a:rPr>
+                <a:t>అన్యాయ తీర్పుకు గురిచేసిన</a:t>
+              </a:r>
+            </a:p>
+            <a:p>
+              <a:pPr defTabSz="439781">
+                <a:defRPr/>
+              </a:pPr>
+              <a:r>
+                <a:rPr lang="te-IN" sz="2200" dirty="0">
+                  <a:latin typeface="Ramabhadra" panose="02000600000000000000" pitchFamily="2" charset="0"/>
+                  <a:cs typeface="Ramabhadra" panose="02000600000000000000" pitchFamily="2" charset="0"/>
+                </a:rPr>
+                <a:t>సత్యము పలుకుటచే నష్టము కలిగినను</a:t>
               </a:r>
             </a:p>
           </p:txBody>
@@ -3361,9 +3367,9 @@
         <p:grpSpPr>
           <a:xfrm>
             <a:off x="5104338" y="182031"/>
-            <a:ext cx="5703362" cy="6493935"/>
+            <a:ext cx="5693837" cy="6493935"/>
             <a:chOff x="160868" y="182032"/>
-            <a:chExt cx="5703362" cy="6493935"/>
+            <a:chExt cx="5693837" cy="6493935"/>
           </a:xfrm>
         </p:grpSpPr>
         <p:sp>
@@ -3435,8 +3441,8 @@
           </p:nvSpPr>
           <p:spPr>
             <a:xfrm>
-              <a:off x="249768" y="309858"/>
-              <a:ext cx="5614462" cy="5632311"/>
+              <a:off x="240243" y="276251"/>
+              <a:ext cx="5614462" cy="6232475"/>
             </a:xfrm>
             <a:prstGeom prst="rect">
               <a:avLst/>
@@ -3450,250 +3456,167 @@
             <a:lstStyle/>
             <a:p>
               <a:r>
-                <a:rPr lang="te-IN" dirty="0">
-                  <a:latin typeface="Ramabhadra" panose="02000600000000000000" pitchFamily="2" charset="0"/>
-                  <a:cs typeface="Ramabhadra" panose="02000600000000000000" pitchFamily="2" charset="0"/>
-                </a:rPr>
-                <a:t>ఘనమైనవి నీ కార్యములు నా యెడల</a:t>
-              </a:r>
-              <a:br>
-                <a:rPr lang="te-IN" dirty="0">
-                  <a:latin typeface="Ramabhadra" panose="02000600000000000000" pitchFamily="2" charset="0"/>
-                  <a:cs typeface="Ramabhadra" panose="02000600000000000000" pitchFamily="2" charset="0"/>
-                </a:rPr>
-              </a:br>
-              <a:r>
-                <a:rPr lang="te-IN" dirty="0">
-                  <a:latin typeface="Ramabhadra" panose="02000600000000000000" pitchFamily="2" charset="0"/>
-                  <a:cs typeface="Ramabhadra" panose="02000600000000000000" pitchFamily="2" charset="0"/>
-                </a:rPr>
-                <a:t>స్థిరమైనవి నీ ఆలోచనలు నా యేసయ్యా (2)</a:t>
-              </a:r>
-              <a:br>
-                <a:rPr lang="te-IN" dirty="0">
-                  <a:latin typeface="Ramabhadra" panose="02000600000000000000" pitchFamily="2" charset="0"/>
-                  <a:cs typeface="Ramabhadra" panose="02000600000000000000" pitchFamily="2" charset="0"/>
-                </a:rPr>
-              </a:br>
-              <a:r>
-                <a:rPr lang="te-IN" dirty="0">
-                  <a:latin typeface="Ramabhadra" panose="02000600000000000000" pitchFamily="2" charset="0"/>
-                  <a:cs typeface="Ramabhadra" panose="02000600000000000000" pitchFamily="2" charset="0"/>
-                </a:rPr>
-                <a:t>కృపలను పొందుచు కృతజ్ఞత కలిగి</a:t>
-              </a:r>
-              <a:br>
-                <a:rPr lang="te-IN" dirty="0">
-                  <a:latin typeface="Ramabhadra" panose="02000600000000000000" pitchFamily="2" charset="0"/>
-                  <a:cs typeface="Ramabhadra" panose="02000600000000000000" pitchFamily="2" charset="0"/>
-                </a:rPr>
-              </a:br>
-              <a:r>
-                <a:rPr lang="te-IN" dirty="0">
-                  <a:latin typeface="Ramabhadra" panose="02000600000000000000" pitchFamily="2" charset="0"/>
-                  <a:cs typeface="Ramabhadra" panose="02000600000000000000" pitchFamily="2" charset="0"/>
-                </a:rPr>
-                <a:t>స్తుతులర్పించెదను అన్నివేళలా (2)</a:t>
-              </a:r>
-              <a:br>
-                <a:rPr lang="te-IN" dirty="0">
-                  <a:latin typeface="Ramabhadra" panose="02000600000000000000" pitchFamily="2" charset="0"/>
-                  <a:cs typeface="Ramabhadra" panose="02000600000000000000" pitchFamily="2" charset="0"/>
-                </a:rPr>
-              </a:br>
-              <a:r>
-                <a:rPr lang="te-IN" dirty="0">
-                  <a:latin typeface="Ramabhadra" panose="02000600000000000000" pitchFamily="2" charset="0"/>
-                  <a:cs typeface="Ramabhadra" panose="02000600000000000000" pitchFamily="2" charset="0"/>
-                </a:rPr>
-                <a:t>అనుదినము నీ అనుగ్రహమే</a:t>
-              </a:r>
-              <a:br>
-                <a:rPr lang="te-IN" dirty="0">
-                  <a:latin typeface="Ramabhadra" panose="02000600000000000000" pitchFamily="2" charset="0"/>
-                  <a:cs typeface="Ramabhadra" panose="02000600000000000000" pitchFamily="2" charset="0"/>
-                </a:rPr>
-              </a:br>
-              <a:r>
-                <a:rPr lang="te-IN" dirty="0">
-                  <a:latin typeface="Ramabhadra" panose="02000600000000000000" pitchFamily="2" charset="0"/>
-                  <a:cs typeface="Ramabhadra" panose="02000600000000000000" pitchFamily="2" charset="0"/>
-                </a:rPr>
-                <a:t>ఆయుష్కాలము నీ వరమే (2)</a:t>
-              </a:r>
-            </a:p>
-            <a:p>
-              <a:endParaRPr lang="te-IN" dirty="0">
+                <a:rPr lang="te-IN" sz="2100" dirty="0">
+                  <a:latin typeface="Ramabhadra" panose="02000600000000000000" pitchFamily="2" charset="0"/>
+                  <a:cs typeface="Ramabhadra" panose="02000600000000000000" pitchFamily="2" charset="0"/>
+                </a:rPr>
+                <a:t>నీతో గడిపే ప్రతి క్షణము</a:t>
+              </a:r>
+            </a:p>
+            <a:p>
+              <a:r>
+                <a:rPr lang="te-IN" sz="2100" dirty="0">
+                  <a:latin typeface="Ramabhadra" panose="02000600000000000000" pitchFamily="2" charset="0"/>
+                  <a:cs typeface="Ramabhadra" panose="02000600000000000000" pitchFamily="2" charset="0"/>
+                </a:rPr>
+                <a:t>ఆనంద బాష్పాలు ఆగవయ్యా (2)</a:t>
+              </a:r>
+            </a:p>
+            <a:p>
+              <a:r>
+                <a:rPr lang="te-IN" sz="2100" dirty="0">
+                  <a:latin typeface="Ramabhadra" panose="02000600000000000000" pitchFamily="2" charset="0"/>
+                  <a:cs typeface="Ramabhadra" panose="02000600000000000000" pitchFamily="2" charset="0"/>
+                </a:rPr>
+                <a:t>కృప తలంచగా మేళ్లు యోచించగా (2)</a:t>
+              </a:r>
+            </a:p>
+            <a:p>
+              <a:r>
+                <a:rPr lang="te-IN" sz="2100" dirty="0">
+                  <a:latin typeface="Ramabhadra" panose="02000600000000000000" pitchFamily="2" charset="0"/>
+                  <a:cs typeface="Ramabhadra" panose="02000600000000000000" pitchFamily="2" charset="0"/>
+                </a:rPr>
+                <a:t>నా గలమాగదు స్తుతించక – నిను కీర్తించక</a:t>
+              </a:r>
+            </a:p>
+            <a:p>
+              <a:r>
+                <a:rPr lang="te-IN" sz="2100" dirty="0">
+                  <a:latin typeface="Ramabhadra" panose="02000600000000000000" pitchFamily="2" charset="0"/>
+                  <a:cs typeface="Ramabhadra" panose="02000600000000000000" pitchFamily="2" charset="0"/>
+                </a:rPr>
+                <a:t>యేసయ్యా యేసయ్యా – నా యేసయ్యా (4)</a:t>
+              </a:r>
+            </a:p>
+            <a:p>
+              <a:endParaRPr lang="te-IN" sz="2100" dirty="0">
                 <a:latin typeface="Ramabhadra" panose="02000600000000000000" pitchFamily="2" charset="0"/>
                 <a:cs typeface="Ramabhadra" panose="02000600000000000000" pitchFamily="2" charset="0"/>
               </a:endParaRPr>
             </a:p>
             <a:p>
               <a:r>
-                <a:rPr lang="te-IN" dirty="0">
-                  <a:latin typeface="Ramabhadra" panose="02000600000000000000" pitchFamily="2" charset="0"/>
-                  <a:cs typeface="Ramabhadra" panose="02000600000000000000" pitchFamily="2" charset="0"/>
-                </a:rPr>
-                <a:t>యే తెగులు సమీపించనీయక–</a:t>
-              </a:r>
-              <a:endParaRPr lang="en-IN" dirty="0">
+                <a:rPr lang="te-IN" sz="2100" dirty="0">
+                  <a:latin typeface="Ramabhadra" panose="02000600000000000000" pitchFamily="2" charset="0"/>
+                  <a:cs typeface="Ramabhadra" panose="02000600000000000000" pitchFamily="2" charset="0"/>
+                </a:rPr>
+                <a:t>మారా వంటి నా జీవితాన్ని</a:t>
+              </a:r>
+            </a:p>
+            <a:p>
+              <a:r>
+                <a:rPr lang="te-IN" sz="2100" dirty="0">
+                  <a:latin typeface="Ramabhadra" panose="02000600000000000000" pitchFamily="2" charset="0"/>
+                  <a:cs typeface="Ramabhadra" panose="02000600000000000000" pitchFamily="2" charset="0"/>
+                </a:rPr>
+                <a:t>మధురముగా మార్చి ఘనపరచినావు (2)</a:t>
+              </a:r>
+            </a:p>
+            <a:p>
+              <a:r>
+                <a:rPr lang="te-IN" sz="2100" dirty="0">
+                  <a:latin typeface="Ramabhadra" panose="02000600000000000000" pitchFamily="2" charset="0"/>
+                  <a:cs typeface="Ramabhadra" panose="02000600000000000000" pitchFamily="2" charset="0"/>
+                </a:rPr>
+                <a:t>నా ప్రేమ చేత కాదు</a:t>
+              </a:r>
+            </a:p>
+            <a:p>
+              <a:r>
+                <a:rPr lang="te-IN" sz="2100" dirty="0">
+                  <a:latin typeface="Ramabhadra" panose="02000600000000000000" pitchFamily="2" charset="0"/>
+                  <a:cs typeface="Ramabhadra" panose="02000600000000000000" pitchFamily="2" charset="0"/>
+                </a:rPr>
+                <a:t>నీవే నను ప్రేమించి (2)</a:t>
+              </a:r>
+            </a:p>
+            <a:p>
+              <a:r>
+                <a:rPr lang="te-IN" sz="2100" dirty="0">
+                  <a:latin typeface="Ramabhadra" panose="02000600000000000000" pitchFamily="2" charset="0"/>
+                  <a:cs typeface="Ramabhadra" panose="02000600000000000000" pitchFamily="2" charset="0"/>
+                </a:rPr>
+                <a:t>రక్తాన్ని చిందించి</a:t>
+              </a:r>
+            </a:p>
+            <a:p>
+              <a:r>
+                <a:rPr lang="te-IN" sz="2100" dirty="0">
+                  <a:latin typeface="Ramabhadra" panose="02000600000000000000" pitchFamily="2" charset="0"/>
+                  <a:cs typeface="Ramabhadra" panose="02000600000000000000" pitchFamily="2" charset="0"/>
+                </a:rPr>
+                <a:t>నన్ను రక్షించావు (2)</a:t>
+              </a:r>
+            </a:p>
+            <a:p>
+              <a:endParaRPr lang="te-IN" sz="2100" dirty="0">
                 <a:latin typeface="Ramabhadra" panose="02000600000000000000" pitchFamily="2" charset="0"/>
                 <a:cs typeface="Ramabhadra" panose="02000600000000000000" pitchFamily="2" charset="0"/>
               </a:endParaRPr>
             </a:p>
             <a:p>
               <a:r>
-                <a:rPr lang="te-IN" dirty="0">
-                  <a:latin typeface="Ramabhadra" panose="02000600000000000000" pitchFamily="2" charset="0"/>
-                  <a:cs typeface="Ramabhadra" panose="02000600000000000000" pitchFamily="2" charset="0"/>
-                </a:rPr>
-                <a:t>యే కీడైన</a:t>
-              </a:r>
-              <a:r>
-                <a:rPr lang="en-IN" dirty="0">
-                  <a:latin typeface="Ramabhadra" panose="02000600000000000000" pitchFamily="2" charset="0"/>
-                  <a:cs typeface="Ramabhadra" panose="02000600000000000000" pitchFamily="2" charset="0"/>
-                </a:rPr>
-                <a:t> </a:t>
-              </a:r>
-              <a:r>
-                <a:rPr lang="te-IN" dirty="0">
-                  <a:latin typeface="Ramabhadra" panose="02000600000000000000" pitchFamily="2" charset="0"/>
-                  <a:cs typeface="Ramabhadra" panose="02000600000000000000" pitchFamily="2" charset="0"/>
-                </a:rPr>
-                <a:t>దరిచేరనీయక</a:t>
-              </a:r>
-              <a:br>
-                <a:rPr lang="te-IN" dirty="0">
-                  <a:latin typeface="Ramabhadra" panose="02000600000000000000" pitchFamily="2" charset="0"/>
-                  <a:cs typeface="Ramabhadra" panose="02000600000000000000" pitchFamily="2" charset="0"/>
-                </a:rPr>
-              </a:br>
-              <a:r>
-                <a:rPr lang="te-IN" dirty="0">
-                  <a:latin typeface="Ramabhadra" panose="02000600000000000000" pitchFamily="2" charset="0"/>
-                  <a:cs typeface="Ramabhadra" panose="02000600000000000000" pitchFamily="2" charset="0"/>
-                </a:rPr>
-                <a:t>ఆపదలన్ని తొలగే వరకు–</a:t>
-              </a:r>
-              <a:endParaRPr lang="en-IN" dirty="0">
-                <a:latin typeface="Ramabhadra" panose="02000600000000000000" pitchFamily="2" charset="0"/>
-                <a:cs typeface="Ramabhadra" panose="02000600000000000000" pitchFamily="2" charset="0"/>
-              </a:endParaRPr>
-            </a:p>
-            <a:p>
-              <a:r>
-                <a:rPr lang="te-IN" dirty="0">
-                  <a:latin typeface="Ramabhadra" panose="02000600000000000000" pitchFamily="2" charset="0"/>
-                  <a:cs typeface="Ramabhadra" panose="02000600000000000000" pitchFamily="2" charset="0"/>
-                </a:rPr>
-                <a:t>ఆత్మలో నెమ్మది కలిగే వరకు (2)</a:t>
-              </a:r>
-              <a:br>
-                <a:rPr lang="te-IN" dirty="0">
-                  <a:latin typeface="Ramabhadra" panose="02000600000000000000" pitchFamily="2" charset="0"/>
-                  <a:cs typeface="Ramabhadra" panose="02000600000000000000" pitchFamily="2" charset="0"/>
-                </a:rPr>
-              </a:br>
-              <a:r>
-                <a:rPr lang="te-IN" dirty="0">
-                  <a:latin typeface="Ramabhadra" panose="02000600000000000000" pitchFamily="2" charset="0"/>
-                  <a:cs typeface="Ramabhadra" panose="02000600000000000000" pitchFamily="2" charset="0"/>
-                </a:rPr>
-                <a:t>నా భారము మోసి – బాసటగా నిలిచి – ఆదరించితివి</a:t>
-              </a:r>
-              <a:br>
-                <a:rPr lang="te-IN" dirty="0">
-                  <a:latin typeface="Ramabhadra" panose="02000600000000000000" pitchFamily="2" charset="0"/>
-                  <a:cs typeface="Ramabhadra" panose="02000600000000000000" pitchFamily="2" charset="0"/>
-                </a:rPr>
-              </a:br>
-              <a:r>
-                <a:rPr lang="te-IN" dirty="0">
-                  <a:latin typeface="Ramabhadra" panose="02000600000000000000" pitchFamily="2" charset="0"/>
-                  <a:cs typeface="Ramabhadra" panose="02000600000000000000" pitchFamily="2" charset="0"/>
-                </a:rPr>
-                <a:t>ఈ స్తుతి మహిమలు నీకే – చెల్లించెదను – జీవితాంతము</a:t>
-              </a:r>
-            </a:p>
-            <a:p>
-              <a:endParaRPr lang="te-IN" dirty="0">
-                <a:latin typeface="Ramabhadra" panose="02000600000000000000" pitchFamily="2" charset="0"/>
-                <a:cs typeface="Ramabhadra" panose="02000600000000000000" pitchFamily="2" charset="0"/>
-              </a:endParaRPr>
-            </a:p>
-            <a:p>
-              <a:r>
-                <a:rPr lang="te-IN" dirty="0">
-                  <a:latin typeface="Ramabhadra" panose="02000600000000000000" pitchFamily="2" charset="0"/>
-                  <a:cs typeface="Ramabhadra" panose="02000600000000000000" pitchFamily="2" charset="0"/>
-                </a:rPr>
-                <a:t>నాకు ఎత్తైన కోటవు నీవే –</a:t>
-              </a:r>
-              <a:endParaRPr lang="en-IN" dirty="0">
-                <a:latin typeface="Ramabhadra" panose="02000600000000000000" pitchFamily="2" charset="0"/>
-                <a:cs typeface="Ramabhadra" panose="02000600000000000000" pitchFamily="2" charset="0"/>
-              </a:endParaRPr>
-            </a:p>
-            <a:p>
-              <a:r>
-                <a:rPr lang="te-IN" dirty="0">
-                  <a:latin typeface="Ramabhadra" panose="02000600000000000000" pitchFamily="2" charset="0"/>
-                  <a:cs typeface="Ramabhadra" panose="02000600000000000000" pitchFamily="2" charset="0"/>
-                </a:rPr>
-                <a:t>నన్ను కాపాడు కేడెము నీవే</a:t>
-              </a:r>
-              <a:br>
-                <a:rPr lang="te-IN" dirty="0">
-                  <a:latin typeface="Ramabhadra" panose="02000600000000000000" pitchFamily="2" charset="0"/>
-                  <a:cs typeface="Ramabhadra" panose="02000600000000000000" pitchFamily="2" charset="0"/>
-                </a:rPr>
-              </a:br>
-              <a:r>
-                <a:rPr lang="te-IN" dirty="0">
-                  <a:latin typeface="Ramabhadra" panose="02000600000000000000" pitchFamily="2" charset="0"/>
-                  <a:cs typeface="Ramabhadra" panose="02000600000000000000" pitchFamily="2" charset="0"/>
-                </a:rPr>
-                <a:t>ఆశ్రయమైన బండవు నీవే –</a:t>
-              </a:r>
-              <a:endParaRPr lang="en-IN" dirty="0">
-                <a:latin typeface="Ramabhadra" panose="02000600000000000000" pitchFamily="2" charset="0"/>
-                <a:cs typeface="Ramabhadra" panose="02000600000000000000" pitchFamily="2" charset="0"/>
-              </a:endParaRPr>
-            </a:p>
-            <a:p>
-              <a:r>
-                <a:rPr lang="te-IN" dirty="0">
-                  <a:latin typeface="Ramabhadra" panose="02000600000000000000" pitchFamily="2" charset="0"/>
-                  <a:cs typeface="Ramabhadra" panose="02000600000000000000" pitchFamily="2" charset="0"/>
-                </a:rPr>
-                <a:t>శాశ్వత కృపకాధారము నీవే (2)</a:t>
-              </a:r>
-              <a:br>
-                <a:rPr lang="te-IN" dirty="0">
-                  <a:latin typeface="Ramabhadra" panose="02000600000000000000" pitchFamily="2" charset="0"/>
-                  <a:cs typeface="Ramabhadra" panose="02000600000000000000" pitchFamily="2" charset="0"/>
-                </a:rPr>
-              </a:br>
-              <a:r>
-                <a:rPr lang="te-IN" dirty="0">
-                  <a:latin typeface="Ramabhadra" panose="02000600000000000000" pitchFamily="2" charset="0"/>
-                  <a:cs typeface="Ramabhadra" panose="02000600000000000000" pitchFamily="2" charset="0"/>
-                </a:rPr>
-                <a:t>నా ప్రతిక్షణమును నీవు –దీవెనగా మార్చి–నడిపించుచున్నావు</a:t>
-              </a:r>
-              <a:br>
-                <a:rPr lang="te-IN" dirty="0">
-                  <a:latin typeface="Ramabhadra" panose="02000600000000000000" pitchFamily="2" charset="0"/>
-                  <a:cs typeface="Ramabhadra" panose="02000600000000000000" pitchFamily="2" charset="0"/>
-                </a:rPr>
-              </a:br>
-              <a:r>
-                <a:rPr lang="te-IN" dirty="0">
-                  <a:latin typeface="Ramabhadra" panose="02000600000000000000" pitchFamily="2" charset="0"/>
-                  <a:cs typeface="Ramabhadra" panose="02000600000000000000" pitchFamily="2" charset="0"/>
-                </a:rPr>
-                <a:t>ఈ స్తుతి మహిమలు నీకే – చెల్లించెదను – జీవితాంతము</a:t>
+                <a:rPr lang="te-IN" sz="2100" dirty="0">
+                  <a:latin typeface="Ramabhadra" panose="02000600000000000000" pitchFamily="2" charset="0"/>
+                  <a:cs typeface="Ramabhadra" panose="02000600000000000000" pitchFamily="2" charset="0"/>
+                </a:rPr>
+                <a:t>గమ్యమే లేని ఓ బాటసారిని</a:t>
+              </a:r>
+            </a:p>
+            <a:p>
+              <a:r>
+                <a:rPr lang="te-IN" sz="2100" dirty="0">
+                  <a:latin typeface="Ramabhadra" panose="02000600000000000000" pitchFamily="2" charset="0"/>
+                  <a:cs typeface="Ramabhadra" panose="02000600000000000000" pitchFamily="2" charset="0"/>
+                </a:rPr>
+                <a:t>నీతో ఉన్నాను భయము లేదన్నావు (2)</a:t>
+              </a:r>
+            </a:p>
+            <a:p>
+              <a:r>
+                <a:rPr lang="te-IN" sz="2100" dirty="0">
+                  <a:latin typeface="Ramabhadra" panose="02000600000000000000" pitchFamily="2" charset="0"/>
+                  <a:cs typeface="Ramabhadra" panose="02000600000000000000" pitchFamily="2" charset="0"/>
+                </a:rPr>
+                <a:t>నా శక్తి చేత కాదు</a:t>
+              </a:r>
+            </a:p>
+            <a:p>
+              <a:r>
+                <a:rPr lang="te-IN" sz="2100" dirty="0">
+                  <a:latin typeface="Ramabhadra" panose="02000600000000000000" pitchFamily="2" charset="0"/>
+                  <a:cs typeface="Ramabhadra" panose="02000600000000000000" pitchFamily="2" charset="0"/>
+                </a:rPr>
+                <a:t>నీ ఆత్మ ద్వారానే (2)</a:t>
+              </a:r>
+            </a:p>
+            <a:p>
+              <a:r>
+                <a:rPr lang="te-IN" sz="2100" dirty="0">
+                  <a:latin typeface="Ramabhadra" panose="02000600000000000000" pitchFamily="2" charset="0"/>
+                  <a:cs typeface="Ramabhadra" panose="02000600000000000000" pitchFamily="2" charset="0"/>
+                </a:rPr>
+                <a:t>వాగ్ధానము నెరవేర్చి</a:t>
+              </a:r>
+            </a:p>
+            <a:p>
+              <a:r>
+                <a:rPr lang="te-IN" sz="2100" dirty="0">
+                  <a:latin typeface="Ramabhadra" panose="02000600000000000000" pitchFamily="2" charset="0"/>
+                  <a:cs typeface="Ramabhadra" panose="02000600000000000000" pitchFamily="2" charset="0"/>
+                </a:rPr>
+                <a:t>వారసుని చేసావు (2)</a:t>
               </a:r>
             </a:p>
           </p:txBody>
@@ -3806,9 +3729,9 @@
         <p:grpSpPr>
           <a:xfrm>
             <a:off x="160868" y="182032"/>
-            <a:ext cx="4936066" cy="6493935"/>
+            <a:ext cx="4795835" cy="6493935"/>
             <a:chOff x="160868" y="182032"/>
-            <a:chExt cx="4936066" cy="6493935"/>
+            <a:chExt cx="4795835" cy="6493935"/>
           </a:xfrm>
         </p:grpSpPr>
         <p:sp>
@@ -3880,8 +3803,8 @@
           </p:nvSpPr>
           <p:spPr>
             <a:xfrm>
-              <a:off x="448734" y="799863"/>
-              <a:ext cx="4648200" cy="5262979"/>
+              <a:off x="308503" y="768683"/>
+              <a:ext cx="4648200" cy="4154984"/>
             </a:xfrm>
             <a:prstGeom prst="rect">
               <a:avLst/>
@@ -3898,54 +3821,30 @@
                 <a:defRPr/>
               </a:pPr>
               <a:r>
-                <a:rPr lang="te-IN" sz="2400" dirty="0">
-                  <a:latin typeface="Ramabhadra" panose="02000600000000000000" pitchFamily="2" charset="0"/>
-                  <a:cs typeface="Ramabhadra" panose="02000600000000000000" pitchFamily="2" charset="0"/>
-                </a:rPr>
-                <a:t>స్తుతియించెదా నీ నామం</a:t>
-              </a:r>
-            </a:p>
-            <a:p>
-              <a:pPr defTabSz="439781">
-                <a:defRPr/>
-              </a:pPr>
-              <a:r>
-                <a:rPr lang="te-IN" sz="2400" dirty="0">
-                  <a:latin typeface="Ramabhadra" panose="02000600000000000000" pitchFamily="2" charset="0"/>
-                  <a:cs typeface="Ramabhadra" panose="02000600000000000000" pitchFamily="2" charset="0"/>
-                </a:rPr>
-                <a:t>దేవా అనుదినం </a:t>
-              </a:r>
-            </a:p>
-            <a:p>
-              <a:pPr defTabSz="439781">
-                <a:defRPr/>
-              </a:pPr>
-              <a:r>
-                <a:rPr lang="te-IN" sz="2400" dirty="0">
-                  <a:latin typeface="Ramabhadra" panose="02000600000000000000" pitchFamily="2" charset="0"/>
-                  <a:cs typeface="Ramabhadra" panose="02000600000000000000" pitchFamily="2" charset="0"/>
-                </a:rPr>
-                <a:t>స్తుతియించెదా నీ నామం</a:t>
-              </a:r>
-            </a:p>
-            <a:p>
-              <a:pPr defTabSz="439781">
-                <a:defRPr/>
-              </a:pPr>
-              <a:r>
-                <a:rPr lang="te-IN" sz="2400" dirty="0">
-                  <a:latin typeface="Ramabhadra" panose="02000600000000000000" pitchFamily="2" charset="0"/>
-                  <a:cs typeface="Ramabhadra" panose="02000600000000000000" pitchFamily="2" charset="0"/>
-                </a:rPr>
-                <a:t>దేవా అనుక్షణం</a:t>
-              </a:r>
-            </a:p>
-            <a:p>
-              <a:pPr defTabSz="439781">
-                <a:defRPr/>
-              </a:pPr>
-              <a:endParaRPr lang="te-IN" sz="2400" dirty="0">
+                <a:rPr lang="te-IN" sz="2200" dirty="0">
+                  <a:latin typeface="Ramabhadra" panose="02000600000000000000" pitchFamily="2" charset="0"/>
+                  <a:cs typeface="Ramabhadra" panose="02000600000000000000" pitchFamily="2" charset="0"/>
+                </a:rPr>
+                <a:t>స్తుతి సింహాసనాసీనుడా</a:t>
+              </a:r>
+            </a:p>
+            <a:p>
+              <a:pPr defTabSz="439781">
+                <a:defRPr/>
+              </a:pPr>
+              <a:r>
+                <a:rPr lang="te-IN" sz="2200" dirty="0">
+                  <a:latin typeface="Ramabhadra" panose="02000600000000000000" pitchFamily="2" charset="0"/>
+                  <a:cs typeface="Ramabhadra" panose="02000600000000000000" pitchFamily="2" charset="0"/>
+                </a:rPr>
+                <a:t>యేసు రాజా దివ్య తేజా (2)</a:t>
+              </a:r>
+            </a:p>
+            <a:p>
+              <a:pPr defTabSz="439781">
+                <a:defRPr/>
+              </a:pPr>
+              <a:endParaRPr lang="te-IN" sz="2200" dirty="0">
                 <a:latin typeface="Ramabhadra" panose="02000600000000000000" pitchFamily="2" charset="0"/>
                 <a:cs typeface="Ramabhadra" panose="02000600000000000000" pitchFamily="2" charset="0"/>
               </a:endParaRPr>
@@ -3955,107 +3854,104 @@
                 <a:defRPr/>
               </a:pPr>
               <a:r>
-                <a:rPr lang="te-IN" sz="2400" dirty="0">
-                  <a:latin typeface="Ramabhadra" panose="02000600000000000000" pitchFamily="2" charset="0"/>
-                  <a:cs typeface="Ramabhadra" panose="02000600000000000000" pitchFamily="2" charset="0"/>
-                </a:rPr>
-                <a:t>దయతో కాపాడినావు</a:t>
-              </a:r>
-            </a:p>
-            <a:p>
-              <a:pPr defTabSz="439781">
-                <a:defRPr/>
-              </a:pPr>
-              <a:r>
-                <a:rPr lang="te-IN" sz="2400" dirty="0">
-                  <a:latin typeface="Ramabhadra" panose="02000600000000000000" pitchFamily="2" charset="0"/>
-                  <a:cs typeface="Ramabhadra" panose="02000600000000000000" pitchFamily="2" charset="0"/>
-                </a:rPr>
-                <a:t>కృపనే చూపించినావు (2) </a:t>
-              </a:r>
-            </a:p>
-            <a:p>
-              <a:pPr defTabSz="439781">
-                <a:defRPr/>
-              </a:pPr>
-              <a:r>
-                <a:rPr lang="te-IN" sz="2400" dirty="0">
-                  <a:latin typeface="Ramabhadra" panose="02000600000000000000" pitchFamily="2" charset="0"/>
-                  <a:cs typeface="Ramabhadra" panose="02000600000000000000" pitchFamily="2" charset="0"/>
-                </a:rPr>
-                <a:t>నిను నే మరువనేసు</a:t>
-              </a:r>
-            </a:p>
-            <a:p>
-              <a:pPr defTabSz="439781">
-                <a:defRPr/>
-              </a:pPr>
-              <a:r>
-                <a:rPr lang="te-IN" sz="2400" dirty="0">
-                  <a:latin typeface="Ramabhadra" panose="02000600000000000000" pitchFamily="2" charset="0"/>
-                  <a:cs typeface="Ramabhadra" panose="02000600000000000000" pitchFamily="2" charset="0"/>
-                </a:rPr>
-                <a:t>నిను నే విడువనేసు</a:t>
-              </a:r>
-            </a:p>
-            <a:p>
-              <a:pPr defTabSz="439781">
-                <a:defRPr/>
-              </a:pPr>
-              <a:r>
-                <a:rPr lang="te-IN" sz="2400" dirty="0">
-                  <a:latin typeface="Ramabhadra" panose="02000600000000000000" pitchFamily="2" charset="0"/>
-                  <a:cs typeface="Ramabhadra" panose="02000600000000000000" pitchFamily="2" charset="0"/>
-                </a:rPr>
-                <a:t> </a:t>
-              </a:r>
-            </a:p>
-            <a:p>
-              <a:pPr defTabSz="439781">
-                <a:defRPr/>
-              </a:pPr>
-              <a:r>
-                <a:rPr lang="te-IN" sz="2400" dirty="0">
-                  <a:latin typeface="Ramabhadra" panose="02000600000000000000" pitchFamily="2" charset="0"/>
-                  <a:cs typeface="Ramabhadra" panose="02000600000000000000" pitchFamily="2" charset="0"/>
-                </a:rPr>
-                <a:t>పాపినై యుండగ నేను</a:t>
-              </a:r>
-            </a:p>
-            <a:p>
-              <a:pPr defTabSz="439781">
-                <a:defRPr/>
-              </a:pPr>
-              <a:r>
-                <a:rPr lang="te-IN" sz="2400" dirty="0">
-                  <a:latin typeface="Ramabhadra" panose="02000600000000000000" pitchFamily="2" charset="0"/>
-                  <a:cs typeface="Ramabhadra" panose="02000600000000000000" pitchFamily="2" charset="0"/>
-                </a:rPr>
-                <a:t>రక్షించి దరి చేర్చినావు (2)  </a:t>
-              </a:r>
-            </a:p>
-            <a:p>
-              <a:pPr defTabSz="439781">
-                <a:defRPr/>
-              </a:pPr>
-              <a:r>
-                <a:rPr lang="te-IN" sz="2400" dirty="0">
-                  <a:latin typeface="Ramabhadra" panose="02000600000000000000" pitchFamily="2" charset="0"/>
-                  <a:cs typeface="Ramabhadra" panose="02000600000000000000" pitchFamily="2" charset="0"/>
-                </a:rPr>
-                <a:t>నిను నే మరువనేసు</a:t>
-              </a:r>
-            </a:p>
-            <a:p>
-              <a:pPr defTabSz="439781">
-                <a:defRPr/>
-              </a:pPr>
-              <a:r>
-                <a:rPr lang="te-IN" sz="2400" dirty="0">
-                  <a:latin typeface="Ramabhadra" panose="02000600000000000000" pitchFamily="2" charset="0"/>
-                  <a:cs typeface="Ramabhadra" panose="02000600000000000000" pitchFamily="2" charset="0"/>
-                </a:rPr>
-                <a:t>నిను నే విడువనేసు</a:t>
+                <a:rPr lang="te-IN" sz="2200" dirty="0">
+                  <a:latin typeface="Ramabhadra" panose="02000600000000000000" pitchFamily="2" charset="0"/>
+                  <a:cs typeface="Ramabhadra" panose="02000600000000000000" pitchFamily="2" charset="0"/>
+                </a:rPr>
+                <a:t>అద్వితీయుడవు పరిశుద్ధుడవు</a:t>
+              </a:r>
+            </a:p>
+            <a:p>
+              <a:pPr defTabSz="439781">
+                <a:defRPr/>
+              </a:pPr>
+              <a:r>
+                <a:rPr lang="te-IN" sz="2200" dirty="0">
+                  <a:latin typeface="Ramabhadra" panose="02000600000000000000" pitchFamily="2" charset="0"/>
+                  <a:cs typeface="Ramabhadra" panose="02000600000000000000" pitchFamily="2" charset="0"/>
+                </a:rPr>
+                <a:t>అతి సుందరుడవు నీవే ప్రభూ (2)</a:t>
+              </a:r>
+            </a:p>
+            <a:p>
+              <a:pPr defTabSz="439781">
+                <a:defRPr/>
+              </a:pPr>
+              <a:r>
+                <a:rPr lang="te-IN" sz="2200" dirty="0">
+                  <a:latin typeface="Ramabhadra" panose="02000600000000000000" pitchFamily="2" charset="0"/>
+                  <a:cs typeface="Ramabhadra" panose="02000600000000000000" pitchFamily="2" charset="0"/>
+                </a:rPr>
+                <a:t>నీతి న్యాయములు నీ సింహాసనాధారం (2)</a:t>
+              </a:r>
+            </a:p>
+            <a:p>
+              <a:pPr defTabSz="439781">
+                <a:defRPr/>
+              </a:pPr>
+              <a:r>
+                <a:rPr lang="te-IN" sz="2200" dirty="0">
+                  <a:latin typeface="Ramabhadra" panose="02000600000000000000" pitchFamily="2" charset="0"/>
+                  <a:cs typeface="Ramabhadra" panose="02000600000000000000" pitchFamily="2" charset="0"/>
+                </a:rPr>
+                <a:t>కృపా సత్యములు నీ సన్నిధానవర్తులు (2)</a:t>
+              </a:r>
+            </a:p>
+            <a:p>
+              <a:pPr defTabSz="439781">
+                <a:defRPr/>
+              </a:pPr>
+              <a:endParaRPr lang="te-IN" sz="2200" dirty="0">
+                <a:latin typeface="Ramabhadra" panose="02000600000000000000" pitchFamily="2" charset="0"/>
+                <a:cs typeface="Ramabhadra" panose="02000600000000000000" pitchFamily="2" charset="0"/>
+              </a:endParaRPr>
+            </a:p>
+            <a:p>
+              <a:pPr defTabSz="439781">
+                <a:defRPr/>
+              </a:pPr>
+              <a:r>
+                <a:rPr lang="te-IN" sz="2200" dirty="0">
+                  <a:latin typeface="Ramabhadra" panose="02000600000000000000" pitchFamily="2" charset="0"/>
+                  <a:cs typeface="Ramabhadra" panose="02000600000000000000" pitchFamily="2" charset="0"/>
+                </a:rPr>
+                <a:t>బలియు అర్పణ కోరవు నీవు</a:t>
+              </a:r>
+            </a:p>
+            <a:p>
+              <a:pPr defTabSz="439781">
+                <a:defRPr/>
+              </a:pPr>
+              <a:r>
+                <a:rPr lang="te-IN" sz="2200" dirty="0">
+                  <a:latin typeface="Ramabhadra" panose="02000600000000000000" pitchFamily="2" charset="0"/>
+                  <a:cs typeface="Ramabhadra" panose="02000600000000000000" pitchFamily="2" charset="0"/>
+                </a:rPr>
+                <a:t>బలియైతివి నా దోషముకై (2)</a:t>
+              </a:r>
+            </a:p>
+            <a:p>
+              <a:pPr defTabSz="439781">
+                <a:defRPr/>
+              </a:pPr>
+              <a:r>
+                <a:rPr lang="te-IN" sz="2200" dirty="0">
+                  <a:latin typeface="Ramabhadra" panose="02000600000000000000" pitchFamily="2" charset="0"/>
+                  <a:cs typeface="Ramabhadra" panose="02000600000000000000" pitchFamily="2" charset="0"/>
+                </a:rPr>
+                <a:t>నా హృదయమే నీ ప్రియమగు ఆలయం (2)</a:t>
+              </a:r>
+            </a:p>
+            <a:p>
+              <a:pPr defTabSz="439781">
+                <a:defRPr/>
+              </a:pPr>
+              <a:r>
+                <a:rPr lang="te-IN" sz="2200" dirty="0">
+                  <a:latin typeface="Ramabhadra" panose="02000600000000000000" pitchFamily="2" charset="0"/>
+                  <a:cs typeface="Ramabhadra" panose="02000600000000000000" pitchFamily="2" charset="0"/>
+                </a:rPr>
+                <a:t>స్తుతియాగమునే చేసెద నిరతం (2)</a:t>
               </a:r>
             </a:p>
           </p:txBody>
@@ -4138,9 +4034,9 @@
         <p:grpSpPr>
           <a:xfrm>
             <a:off x="5104338" y="182031"/>
-            <a:ext cx="4801662" cy="6493935"/>
+            <a:ext cx="4828492" cy="6538635"/>
             <a:chOff x="160868" y="182032"/>
-            <a:chExt cx="4801662" cy="6493935"/>
+            <a:chExt cx="4828492" cy="6538635"/>
           </a:xfrm>
         </p:grpSpPr>
         <p:sp>
@@ -4212,8 +4108,8 @@
           </p:nvSpPr>
           <p:spPr>
             <a:xfrm>
-              <a:off x="212729" y="286334"/>
-              <a:ext cx="4749801" cy="5940088"/>
+              <a:off x="239559" y="195804"/>
+              <a:ext cx="4749801" cy="6524863"/>
             </a:xfrm>
             <a:prstGeom prst="rect">
               <a:avLst/>
@@ -4230,13 +4126,66 @@
                 <a:defRPr/>
               </a:pPr>
               <a:r>
-                <a:rPr lang="te-IN" sz="2000" dirty="0">
-                  <a:latin typeface="Ramabhadra" panose="02000600000000000000" pitchFamily="2" charset="0"/>
-                  <a:cs typeface="Ramabhadra" panose="02000600000000000000" pitchFamily="2" charset="0"/>
-                </a:rPr>
-                <a:t>సుమధుర స్వరముల గానాలతో –</a:t>
-              </a:r>
-              <a:endParaRPr lang="en-IN" sz="2000" dirty="0">
+                <a:rPr lang="te-IN" sz="2200" dirty="0">
+                  <a:latin typeface="Ramabhadra" panose="02000600000000000000" pitchFamily="2" charset="0"/>
+                  <a:cs typeface="Ramabhadra" panose="02000600000000000000" pitchFamily="2" charset="0"/>
+                </a:rPr>
+                <a:t>అపారమైనది నీ కృప  </a:t>
+              </a:r>
+            </a:p>
+            <a:p>
+              <a:pPr defTabSz="439781">
+                <a:defRPr/>
+              </a:pPr>
+              <a:r>
+                <a:rPr lang="te-IN" sz="2200" dirty="0">
+                  <a:latin typeface="Ramabhadra" panose="02000600000000000000" pitchFamily="2" charset="0"/>
+                  <a:cs typeface="Ramabhadra" panose="02000600000000000000" pitchFamily="2" charset="0"/>
+                </a:rPr>
+                <a:t>అమూల్యమైనది నీ కృప</a:t>
+              </a:r>
+            </a:p>
+            <a:p>
+              <a:pPr defTabSz="439781">
+                <a:defRPr/>
+              </a:pPr>
+              <a:r>
+                <a:rPr lang="te-IN" sz="2200" dirty="0">
+                  <a:latin typeface="Ramabhadra" panose="02000600000000000000" pitchFamily="2" charset="0"/>
+                  <a:cs typeface="Ramabhadra" panose="02000600000000000000" pitchFamily="2" charset="0"/>
+                </a:rPr>
+                <a:t>జీవము కంటె ఉత్తమమైనది  </a:t>
+              </a:r>
+            </a:p>
+            <a:p>
+              <a:pPr defTabSz="439781">
+                <a:defRPr/>
+              </a:pPr>
+              <a:r>
+                <a:rPr lang="te-IN" sz="2200" dirty="0">
+                  <a:latin typeface="Ramabhadra" panose="02000600000000000000" pitchFamily="2" charset="0"/>
+                  <a:cs typeface="Ramabhadra" panose="02000600000000000000" pitchFamily="2" charset="0"/>
+                </a:rPr>
+                <a:t>పర్వత శిఖరము కన్న ఎతైనది</a:t>
+              </a:r>
+            </a:p>
+            <a:p>
+              <a:pPr defTabSz="439781">
+                <a:defRPr/>
+              </a:pPr>
+              <a:r>
+                <a:rPr lang="te-IN" sz="2200" dirty="0">
+                  <a:latin typeface="Ramabhadra" panose="02000600000000000000" pitchFamily="2" charset="0"/>
+                  <a:cs typeface="Ramabhadra" panose="02000600000000000000" pitchFamily="2" charset="0"/>
+                </a:rPr>
+                <a:t>కృప కృప కృప కృప నీకృప   ॥2॥</a:t>
+              </a:r>
+            </a:p>
+            <a:p>
+              <a:pPr defTabSz="439781">
+                <a:defRPr/>
+              </a:pPr>
+              <a:endParaRPr lang="te-IN" sz="2200" dirty="0">
                 <a:latin typeface="Ramabhadra" panose="02000600000000000000" pitchFamily="2" charset="0"/>
                 <a:cs typeface="Ramabhadra" panose="02000600000000000000" pitchFamily="2" charset="0"/>
               </a:endParaRPr>
@@ -4246,25 +4195,78 @@
                 <a:defRPr/>
               </a:pPr>
               <a:r>
-                <a:rPr lang="te-IN" sz="2000" dirty="0">
-                  <a:latin typeface="Ramabhadra" panose="02000600000000000000" pitchFamily="2" charset="0"/>
-                  <a:cs typeface="Ramabhadra" panose="02000600000000000000" pitchFamily="2" charset="0"/>
-                </a:rPr>
-                <a:t>వేలాది దూతల గళములతో</a:t>
-              </a:r>
-            </a:p>
-            <a:p>
-              <a:pPr defTabSz="439781">
-                <a:defRPr/>
-              </a:pPr>
-              <a:r>
-                <a:rPr lang="te-IN" sz="2000" dirty="0">
-                  <a:latin typeface="Ramabhadra" panose="02000600000000000000" pitchFamily="2" charset="0"/>
-                  <a:cs typeface="Ramabhadra" panose="02000600000000000000" pitchFamily="2" charset="0"/>
-                </a:rPr>
-                <a:t>కొనియాడబడుచున్న నా యేసయ్యా –</a:t>
-              </a:r>
-              <a:endParaRPr lang="en-IN" sz="2000" dirty="0">
+                <a:rPr lang="te-IN" sz="2200" dirty="0">
+                  <a:latin typeface="Ramabhadra" panose="02000600000000000000" pitchFamily="2" charset="0"/>
+                  <a:cs typeface="Ramabhadra" panose="02000600000000000000" pitchFamily="2" charset="0"/>
+                </a:rPr>
+                <a:t>పాప దాస్యములో చిక్కబడి యుండగా </a:t>
+              </a:r>
+            </a:p>
+            <a:p>
+              <a:pPr defTabSz="439781">
+                <a:defRPr/>
+              </a:pPr>
+              <a:r>
+                <a:rPr lang="te-IN" sz="2200" dirty="0">
+                  <a:latin typeface="Ramabhadra" panose="02000600000000000000" pitchFamily="2" charset="0"/>
+                  <a:cs typeface="Ramabhadra" panose="02000600000000000000" pitchFamily="2" charset="0"/>
+                </a:rPr>
+                <a:t>నను రక్షించెను నీకృప</a:t>
+              </a:r>
+            </a:p>
+            <a:p>
+              <a:pPr defTabSz="439781">
+                <a:defRPr/>
+              </a:pPr>
+              <a:r>
+                <a:rPr lang="te-IN" sz="2200" dirty="0">
+                  <a:latin typeface="Ramabhadra" panose="02000600000000000000" pitchFamily="2" charset="0"/>
+                  <a:cs typeface="Ramabhadra" panose="02000600000000000000" pitchFamily="2" charset="0"/>
+                </a:rPr>
+                <a:t>రోగబలహీనతందునే కృంగి యుండగా</a:t>
+              </a:r>
+            </a:p>
+            <a:p>
+              <a:pPr defTabSz="439781">
+                <a:defRPr/>
+              </a:pPr>
+              <a:r>
+                <a:rPr lang="te-IN" sz="2200" dirty="0">
+                  <a:latin typeface="Ramabhadra" panose="02000600000000000000" pitchFamily="2" charset="0"/>
+                  <a:cs typeface="Ramabhadra" panose="02000600000000000000" pitchFamily="2" charset="0"/>
+                </a:rPr>
+                <a:t>నను స్వస్థపరచును నీకృప</a:t>
+              </a:r>
+            </a:p>
+            <a:p>
+              <a:pPr defTabSz="439781">
+                <a:defRPr/>
+              </a:pPr>
+              <a:r>
+                <a:rPr lang="te-IN" sz="2200" dirty="0">
+                  <a:latin typeface="Ramabhadra" panose="02000600000000000000" pitchFamily="2" charset="0"/>
+                  <a:cs typeface="Ramabhadra" panose="02000600000000000000" pitchFamily="2" charset="0"/>
+                </a:rPr>
+                <a:t>మారా వంటి జీవితం </a:t>
+              </a:r>
+            </a:p>
+            <a:p>
+              <a:pPr defTabSz="439781">
+                <a:defRPr/>
+              </a:pPr>
+              <a:r>
+                <a:rPr lang="te-IN" sz="2200" dirty="0">
+                  <a:latin typeface="Ramabhadra" panose="02000600000000000000" pitchFamily="2" charset="0"/>
+                  <a:cs typeface="Ramabhadra" panose="02000600000000000000" pitchFamily="2" charset="0"/>
+                </a:rPr>
+                <a:t>మధురముగా మార్చెను నీ కృప</a:t>
+              </a:r>
+            </a:p>
+            <a:p>
+              <a:pPr defTabSz="439781">
+                <a:defRPr/>
+              </a:pPr>
+              <a:endParaRPr lang="te-IN" sz="2200" dirty="0">
                 <a:latin typeface="Ramabhadra" panose="02000600000000000000" pitchFamily="2" charset="0"/>
                 <a:cs typeface="Ramabhadra" panose="02000600000000000000" pitchFamily="2" charset="0"/>
               </a:endParaRPr>
@@ -4274,197 +4276,71 @@
                 <a:defRPr/>
               </a:pPr>
               <a:r>
-                <a:rPr lang="te-IN" sz="2000" dirty="0">
-                  <a:latin typeface="Ramabhadra" panose="02000600000000000000" pitchFamily="2" charset="0"/>
-                  <a:cs typeface="Ramabhadra" panose="02000600000000000000" pitchFamily="2" charset="0"/>
-                </a:rPr>
-                <a:t>నీకే నా ఆరాధన (2)</a:t>
-              </a:r>
-            </a:p>
-            <a:p>
-              <a:pPr defTabSz="439781">
-                <a:defRPr/>
-              </a:pPr>
-              <a:r>
-                <a:rPr lang="te-IN" sz="2000" dirty="0">
-                  <a:latin typeface="Ramabhadra" panose="02000600000000000000" pitchFamily="2" charset="0"/>
-                  <a:cs typeface="Ramabhadra" panose="02000600000000000000" pitchFamily="2" charset="0"/>
-                </a:rPr>
-                <a:t>మహదానందమే నాలో పరవశమే</a:t>
-              </a:r>
-            </a:p>
-            <a:p>
-              <a:pPr defTabSz="439781">
-                <a:defRPr/>
-              </a:pPr>
-              <a:r>
-                <a:rPr lang="te-IN" sz="2000" dirty="0">
-                  <a:latin typeface="Ramabhadra" panose="02000600000000000000" pitchFamily="2" charset="0"/>
-                  <a:cs typeface="Ramabhadra" panose="02000600000000000000" pitchFamily="2" charset="0"/>
-                </a:rPr>
-                <a:t>నిన్ను స్తుతించిన ప్రతీక్షణం (2)</a:t>
-              </a:r>
-            </a:p>
-            <a:p>
-              <a:pPr defTabSz="439781">
-                <a:defRPr/>
-              </a:pPr>
-              <a:endParaRPr lang="te-IN" sz="2000" dirty="0">
-                <a:latin typeface="Ramabhadra" panose="02000600000000000000" pitchFamily="2" charset="0"/>
-                <a:cs typeface="Ramabhadra" panose="02000600000000000000" pitchFamily="2" charset="0"/>
-              </a:endParaRPr>
-            </a:p>
-            <a:p>
-              <a:pPr defTabSz="439781">
-                <a:defRPr/>
-              </a:pPr>
-              <a:r>
-                <a:rPr lang="te-IN" sz="2000" dirty="0">
-                  <a:latin typeface="Ramabhadra" panose="02000600000000000000" pitchFamily="2" charset="0"/>
-                  <a:cs typeface="Ramabhadra" panose="02000600000000000000" pitchFamily="2" charset="0"/>
-                </a:rPr>
-                <a:t>ఎడారి త్రోవలో నే నడిచినా –</a:t>
-              </a:r>
-              <a:endParaRPr lang="en-IN" sz="2000" dirty="0">
-                <a:latin typeface="Ramabhadra" panose="02000600000000000000" pitchFamily="2" charset="0"/>
-                <a:cs typeface="Ramabhadra" panose="02000600000000000000" pitchFamily="2" charset="0"/>
-              </a:endParaRPr>
-            </a:p>
-            <a:p>
-              <a:pPr defTabSz="439781">
-                <a:defRPr/>
-              </a:pPr>
-              <a:r>
-                <a:rPr lang="te-IN" sz="2000" dirty="0">
-                  <a:latin typeface="Ramabhadra" panose="02000600000000000000" pitchFamily="2" charset="0"/>
-                  <a:cs typeface="Ramabhadra" panose="02000600000000000000" pitchFamily="2" charset="0"/>
-                </a:rPr>
-                <a:t>ఎరుగని మార్గములో నను నడిపినా</a:t>
-              </a:r>
-            </a:p>
-            <a:p>
-              <a:pPr defTabSz="439781">
-                <a:defRPr/>
-              </a:pPr>
-              <a:r>
-                <a:rPr lang="te-IN" sz="2000" dirty="0">
-                  <a:latin typeface="Ramabhadra" panose="02000600000000000000" pitchFamily="2" charset="0"/>
-                  <a:cs typeface="Ramabhadra" panose="02000600000000000000" pitchFamily="2" charset="0"/>
-                </a:rPr>
-                <a:t>నా ముందు నడచిన జయవీరుడా –</a:t>
-              </a:r>
-              <a:endParaRPr lang="en-IN" sz="2000" dirty="0">
-                <a:latin typeface="Ramabhadra" panose="02000600000000000000" pitchFamily="2" charset="0"/>
-                <a:cs typeface="Ramabhadra" panose="02000600000000000000" pitchFamily="2" charset="0"/>
-              </a:endParaRPr>
-            </a:p>
-            <a:p>
-              <a:pPr defTabSz="439781">
-                <a:defRPr/>
-              </a:pPr>
-              <a:r>
-                <a:rPr lang="te-IN" sz="2000" dirty="0">
-                  <a:latin typeface="Ramabhadra" panose="02000600000000000000" pitchFamily="2" charset="0"/>
-                  <a:cs typeface="Ramabhadra" panose="02000600000000000000" pitchFamily="2" charset="0"/>
-                </a:rPr>
-                <a:t>నా విజయ సంకేతమా (2)</a:t>
-              </a:r>
-            </a:p>
-            <a:p>
-              <a:pPr defTabSz="439781">
-                <a:defRPr/>
-              </a:pPr>
-              <a:r>
-                <a:rPr lang="te-IN" sz="2000" dirty="0">
-                  <a:latin typeface="Ramabhadra" panose="02000600000000000000" pitchFamily="2" charset="0"/>
-                  <a:cs typeface="Ramabhadra" panose="02000600000000000000" pitchFamily="2" charset="0"/>
-                </a:rPr>
-                <a:t>నీవే నీవే – నా ఆనందము</a:t>
-              </a:r>
-            </a:p>
-            <a:p>
-              <a:pPr defTabSz="439781">
-                <a:defRPr/>
-              </a:pPr>
-              <a:r>
-                <a:rPr lang="te-IN" sz="2000" dirty="0">
-                  <a:latin typeface="Ramabhadra" panose="02000600000000000000" pitchFamily="2" charset="0"/>
-                  <a:cs typeface="Ramabhadra" panose="02000600000000000000" pitchFamily="2" charset="0"/>
-                </a:rPr>
-                <a:t>నీవే నీవే – నా ఆధారము (2)</a:t>
-              </a:r>
-            </a:p>
-            <a:p>
-              <a:pPr defTabSz="439781">
-                <a:defRPr/>
-              </a:pPr>
-              <a:endParaRPr lang="te-IN" sz="2000" dirty="0">
-                <a:latin typeface="Ramabhadra" panose="02000600000000000000" pitchFamily="2" charset="0"/>
-                <a:cs typeface="Ramabhadra" panose="02000600000000000000" pitchFamily="2" charset="0"/>
-              </a:endParaRPr>
-            </a:p>
-            <a:p>
-              <a:pPr defTabSz="439781">
-                <a:defRPr/>
-              </a:pPr>
-              <a:r>
-                <a:rPr lang="te-IN" sz="2000" dirty="0">
-                  <a:latin typeface="Ramabhadra" panose="02000600000000000000" pitchFamily="2" charset="0"/>
-                  <a:cs typeface="Ramabhadra" panose="02000600000000000000" pitchFamily="2" charset="0"/>
-                </a:rPr>
-                <a:t>సంపూర్ణమైన నీ చిత్తమే – అనుకూలమైన సంకల్పమే</a:t>
-              </a:r>
-            </a:p>
-            <a:p>
-              <a:pPr defTabSz="439781">
-                <a:defRPr/>
-              </a:pPr>
-              <a:r>
-                <a:rPr lang="te-IN" sz="2000" dirty="0">
-                  <a:latin typeface="Ramabhadra" panose="02000600000000000000" pitchFamily="2" charset="0"/>
-                  <a:cs typeface="Ramabhadra" panose="02000600000000000000" pitchFamily="2" charset="0"/>
-                </a:rPr>
-                <a:t>జరిగించుచున్నావు నను విడువక –</a:t>
-              </a:r>
-              <a:endParaRPr lang="en-IN" sz="2000" dirty="0">
-                <a:latin typeface="Ramabhadra" panose="02000600000000000000" pitchFamily="2" charset="0"/>
-                <a:cs typeface="Ramabhadra" panose="02000600000000000000" pitchFamily="2" charset="0"/>
-              </a:endParaRPr>
-            </a:p>
-            <a:p>
-              <a:pPr defTabSz="439781">
-                <a:defRPr/>
-              </a:pPr>
-              <a:r>
-                <a:rPr lang="te-IN" sz="2000" dirty="0">
-                  <a:latin typeface="Ramabhadra" panose="02000600000000000000" pitchFamily="2" charset="0"/>
-                  <a:cs typeface="Ramabhadra" panose="02000600000000000000" pitchFamily="2" charset="0"/>
-                </a:rPr>
-                <a:t>నా ధైర్యము నీవేగా (2)</a:t>
-              </a:r>
-            </a:p>
-            <a:p>
-              <a:pPr defTabSz="439781">
-                <a:defRPr/>
-              </a:pPr>
-              <a:r>
-                <a:rPr lang="te-IN" sz="2000" dirty="0">
-                  <a:latin typeface="Ramabhadra" panose="02000600000000000000" pitchFamily="2" charset="0"/>
-                  <a:cs typeface="Ramabhadra" panose="02000600000000000000" pitchFamily="2" charset="0"/>
-                </a:rPr>
-                <a:t>నీవే నీవే – నా జయగీతము</a:t>
-              </a:r>
-            </a:p>
-            <a:p>
-              <a:pPr defTabSz="439781">
-                <a:defRPr/>
-              </a:pPr>
-              <a:r>
-                <a:rPr lang="te-IN" sz="2000" dirty="0">
-                  <a:latin typeface="Ramabhadra" panose="02000600000000000000" pitchFamily="2" charset="0"/>
-                  <a:cs typeface="Ramabhadra" panose="02000600000000000000" pitchFamily="2" charset="0"/>
-                </a:rPr>
-                <a:t>నీవే నీవే – నా స్తుతిగీతము (2)</a:t>
+                <a:rPr lang="te-IN" sz="2200" dirty="0">
+                  <a:latin typeface="Ramabhadra" panose="02000600000000000000" pitchFamily="2" charset="0"/>
+                  <a:cs typeface="Ramabhadra" panose="02000600000000000000" pitchFamily="2" charset="0"/>
+                </a:rPr>
+                <a:t>నా హీన స్థితిలో పడిపోయి ఉండగా</a:t>
+              </a:r>
+            </a:p>
+            <a:p>
+              <a:pPr defTabSz="439781">
+                <a:defRPr/>
+              </a:pPr>
+              <a:r>
+                <a:rPr lang="te-IN" sz="2200" dirty="0">
+                  <a:latin typeface="Ramabhadra" panose="02000600000000000000" pitchFamily="2" charset="0"/>
+                  <a:cs typeface="Ramabhadra" panose="02000600000000000000" pitchFamily="2" charset="0"/>
+                </a:rPr>
+                <a:t>నను లేవనెత్తేను నీ కృప</a:t>
+              </a:r>
+            </a:p>
+            <a:p>
+              <a:pPr defTabSz="439781">
+                <a:defRPr/>
+              </a:pPr>
+              <a:r>
+                <a:rPr lang="te-IN" sz="2200" dirty="0">
+                  <a:latin typeface="Ramabhadra" panose="02000600000000000000" pitchFamily="2" charset="0"/>
+                  <a:cs typeface="Ramabhadra" panose="02000600000000000000" pitchFamily="2" charset="0"/>
+                </a:rPr>
+                <a:t>ఆదరించు వారు లేక అలసియున్న నన్ను </a:t>
+              </a:r>
+            </a:p>
+            <a:p>
+              <a:pPr defTabSz="439781">
+                <a:defRPr/>
+              </a:pPr>
+              <a:r>
+                <a:rPr lang="te-IN" sz="2200" dirty="0">
+                  <a:latin typeface="Ramabhadra" panose="02000600000000000000" pitchFamily="2" charset="0"/>
+                  <a:cs typeface="Ramabhadra" panose="02000600000000000000" pitchFamily="2" charset="0"/>
+                </a:rPr>
+                <a:t>ఆదరించెను నీ కృప</a:t>
+              </a:r>
+            </a:p>
+            <a:p>
+              <a:pPr defTabSz="439781">
+                <a:defRPr/>
+              </a:pPr>
+              <a:r>
+                <a:rPr lang="te-IN" sz="2200" dirty="0">
+                  <a:latin typeface="Ramabhadra" panose="02000600000000000000" pitchFamily="2" charset="0"/>
+                  <a:cs typeface="Ramabhadra" panose="02000600000000000000" pitchFamily="2" charset="0"/>
+                </a:rPr>
+                <a:t>మోడైన నా జీవితం </a:t>
+              </a:r>
+            </a:p>
+            <a:p>
+              <a:pPr defTabSz="439781">
+                <a:defRPr/>
+              </a:pPr>
+              <a:r>
+                <a:rPr lang="te-IN" sz="2200" dirty="0">
+                  <a:latin typeface="Ramabhadra" panose="02000600000000000000" pitchFamily="2" charset="0"/>
+                  <a:cs typeface="Ramabhadra" panose="02000600000000000000" pitchFamily="2" charset="0"/>
+                </a:rPr>
+                <a:t>చిగురింపజేసెను నీ కృప </a:t>
               </a:r>
             </a:p>
           </p:txBody>

</xml_diff>

<commit_message>
29 sun dec 24 songs
</commit_message>
<xml_diff>
--- a/songsTemplate.pptx
+++ b/songsTemplate.pptx
@@ -255,7 +255,7 @@
           <a:p>
             <a:fld id="{F1102B08-ED9E-409F-B95F-09CAA1DAF6E0}" type="datetimeFigureOut">
               <a:rPr lang="en-IN" smtClean="0"/>
-              <a:t>21-12-2024</a:t>
+              <a:t>28-12-2024</a:t>
             </a:fld>
             <a:endParaRPr lang="en-IN"/>
           </a:p>
@@ -425,7 +425,7 @@
           <a:p>
             <a:fld id="{F1102B08-ED9E-409F-B95F-09CAA1DAF6E0}" type="datetimeFigureOut">
               <a:rPr lang="en-IN" smtClean="0"/>
-              <a:t>21-12-2024</a:t>
+              <a:t>28-12-2024</a:t>
             </a:fld>
             <a:endParaRPr lang="en-IN"/>
           </a:p>
@@ -605,7 +605,7 @@
           <a:p>
             <a:fld id="{F1102B08-ED9E-409F-B95F-09CAA1DAF6E0}" type="datetimeFigureOut">
               <a:rPr lang="en-IN" smtClean="0"/>
-              <a:t>21-12-2024</a:t>
+              <a:t>28-12-2024</a:t>
             </a:fld>
             <a:endParaRPr lang="en-IN"/>
           </a:p>
@@ -775,7 +775,7 @@
           <a:p>
             <a:fld id="{F1102B08-ED9E-409F-B95F-09CAA1DAF6E0}" type="datetimeFigureOut">
               <a:rPr lang="en-IN" smtClean="0"/>
-              <a:t>21-12-2024</a:t>
+              <a:t>28-12-2024</a:t>
             </a:fld>
             <a:endParaRPr lang="en-IN"/>
           </a:p>
@@ -1019,7 +1019,7 @@
           <a:p>
             <a:fld id="{F1102B08-ED9E-409F-B95F-09CAA1DAF6E0}" type="datetimeFigureOut">
               <a:rPr lang="en-IN" smtClean="0"/>
-              <a:t>21-12-2024</a:t>
+              <a:t>28-12-2024</a:t>
             </a:fld>
             <a:endParaRPr lang="en-IN"/>
           </a:p>
@@ -1251,7 +1251,7 @@
           <a:p>
             <a:fld id="{F1102B08-ED9E-409F-B95F-09CAA1DAF6E0}" type="datetimeFigureOut">
               <a:rPr lang="en-IN" smtClean="0"/>
-              <a:t>21-12-2024</a:t>
+              <a:t>28-12-2024</a:t>
             </a:fld>
             <a:endParaRPr lang="en-IN"/>
           </a:p>
@@ -1618,7 +1618,7 @@
           <a:p>
             <a:fld id="{F1102B08-ED9E-409F-B95F-09CAA1DAF6E0}" type="datetimeFigureOut">
               <a:rPr lang="en-IN" smtClean="0"/>
-              <a:t>21-12-2024</a:t>
+              <a:t>28-12-2024</a:t>
             </a:fld>
             <a:endParaRPr lang="en-IN"/>
           </a:p>
@@ -1736,7 +1736,7 @@
           <a:p>
             <a:fld id="{F1102B08-ED9E-409F-B95F-09CAA1DAF6E0}" type="datetimeFigureOut">
               <a:rPr lang="en-IN" smtClean="0"/>
-              <a:t>21-12-2024</a:t>
+              <a:t>28-12-2024</a:t>
             </a:fld>
             <a:endParaRPr lang="en-IN"/>
           </a:p>
@@ -1831,7 +1831,7 @@
           <a:p>
             <a:fld id="{F1102B08-ED9E-409F-B95F-09CAA1DAF6E0}" type="datetimeFigureOut">
               <a:rPr lang="en-IN" smtClean="0"/>
-              <a:t>21-12-2024</a:t>
+              <a:t>28-12-2024</a:t>
             </a:fld>
             <a:endParaRPr lang="en-IN"/>
           </a:p>
@@ -2108,7 +2108,7 @@
           <a:p>
             <a:fld id="{F1102B08-ED9E-409F-B95F-09CAA1DAF6E0}" type="datetimeFigureOut">
               <a:rPr lang="en-IN" smtClean="0"/>
-              <a:t>21-12-2024</a:t>
+              <a:t>28-12-2024</a:t>
             </a:fld>
             <a:endParaRPr lang="en-IN"/>
           </a:p>
@@ -2365,7 +2365,7 @@
           <a:p>
             <a:fld id="{F1102B08-ED9E-409F-B95F-09CAA1DAF6E0}" type="datetimeFigureOut">
               <a:rPr lang="en-IN" smtClean="0"/>
-              <a:t>21-12-2024</a:t>
+              <a:t>28-12-2024</a:t>
             </a:fld>
             <a:endParaRPr lang="en-IN"/>
           </a:p>
@@ -2578,7 +2578,7 @@
           <a:p>
             <a:fld id="{F1102B08-ED9E-409F-B95F-09CAA1DAF6E0}" type="datetimeFigureOut">
               <a:rPr lang="en-IN" smtClean="0"/>
-              <a:t>21-12-2024</a:t>
+              <a:t>28-12-2024</a:t>
             </a:fld>
             <a:endParaRPr lang="en-IN"/>
           </a:p>
@@ -3072,8 +3072,8 @@
           </p:nvSpPr>
           <p:spPr>
             <a:xfrm>
-              <a:off x="272140" y="309857"/>
-              <a:ext cx="4483140" cy="5847755"/>
+              <a:off x="318523" y="331486"/>
+              <a:ext cx="4483140" cy="5170646"/>
             </a:xfrm>
             <a:prstGeom prst="rect">
               <a:avLst/>
@@ -3094,7 +3094,7 @@
                   <a:latin typeface="Ramabhadra" panose="02000600000000000000" pitchFamily="2" charset="0"/>
                   <a:cs typeface="Ramabhadra" panose="02000600000000000000" pitchFamily="2" charset="0"/>
                 </a:rPr>
-                <a:t>చాలిన దేవుడవు యేసు </a:t>
+                <a:t>నా స్తుతుల పైన నివసించువాడా</a:t>
               </a:r>
             </a:p>
             <a:p>
@@ -3106,7 +3106,7 @@
                   <a:latin typeface="Ramabhadra" panose="02000600000000000000" pitchFamily="2" charset="0"/>
                   <a:cs typeface="Ramabhadra" panose="02000600000000000000" pitchFamily="2" charset="0"/>
                 </a:rPr>
-                <a:t>చాలిన దేవుడ నీవు</a:t>
+                <a:t>నా అంతరంగికుడా యేసయ్యా (2)</a:t>
               </a:r>
             </a:p>
             <a:p>
@@ -3118,7 +3118,7 @@
                   <a:latin typeface="Ramabhadra" panose="02000600000000000000" pitchFamily="2" charset="0"/>
                   <a:cs typeface="Ramabhadra" panose="02000600000000000000" pitchFamily="2" charset="0"/>
                 </a:rPr>
-                <a:t>వ్యాధి బాధ సమయములో</a:t>
+                <a:t>నీవు నా పక్షమై యున్నావు గనుకే</a:t>
               </a:r>
             </a:p>
             <a:p>
@@ -3130,31 +3130,7 @@
                   <a:latin typeface="Ramabhadra" panose="02000600000000000000" pitchFamily="2" charset="0"/>
                   <a:cs typeface="Ramabhadra" panose="02000600000000000000" pitchFamily="2" charset="0"/>
                 </a:rPr>
-                <a:t>కష్టసుడుల తరంగములో</a:t>
-              </a:r>
-            </a:p>
-            <a:p>
-              <a:pPr defTabSz="439781">
-                <a:defRPr/>
-              </a:pPr>
-              <a:r>
-                <a:rPr lang="te-IN" sz="2200" dirty="0">
-                  <a:latin typeface="Ramabhadra" panose="02000600000000000000" pitchFamily="2" charset="0"/>
-                  <a:cs typeface="Ramabhadra" panose="02000600000000000000" pitchFamily="2" charset="0"/>
-                </a:rPr>
-                <a:t>ఏమున్నా లేకున్నా ఏ స్ధితికైనా</a:t>
-              </a:r>
-            </a:p>
-            <a:p>
-              <a:pPr defTabSz="439781">
-                <a:defRPr/>
-              </a:pPr>
-              <a:r>
-                <a:rPr lang="te-IN" sz="2200" dirty="0">
-                  <a:latin typeface="Ramabhadra" panose="02000600000000000000" pitchFamily="2" charset="0"/>
-                  <a:cs typeface="Ramabhadra" panose="02000600000000000000" pitchFamily="2" charset="0"/>
-                </a:rPr>
-                <a:t>చాలిన దేవుడ నీవు</a:t>
+                <a:t>జయమే జయమే ఎల్లవేళలా జయమే (2)</a:t>
               </a:r>
             </a:p>
             <a:p>
@@ -3175,8 +3151,12 @@
                   <a:latin typeface="Ramabhadra" panose="02000600000000000000" pitchFamily="2" charset="0"/>
                   <a:cs typeface="Ramabhadra" panose="02000600000000000000" pitchFamily="2" charset="0"/>
                 </a:rPr>
-                <a:t>అంజూర చెట్లు పూయకున్నను</a:t>
-              </a:r>
+                <a:t>నన్ను నిర్మించిన రీతి తలచగా –</a:t>
+              </a:r>
+              <a:endParaRPr lang="en-IN" sz="2200" dirty="0">
+                <a:latin typeface="Ramabhadra" panose="02000600000000000000" pitchFamily="2" charset="0"/>
+                <a:cs typeface="Ramabhadra" panose="02000600000000000000" pitchFamily="2" charset="0"/>
+              </a:endParaRPr>
             </a:p>
             <a:p>
               <a:pPr defTabSz="439781">
@@ -3187,7 +3167,7 @@
                   <a:latin typeface="Ramabhadra" panose="02000600000000000000" pitchFamily="2" charset="0"/>
                   <a:cs typeface="Ramabhadra" panose="02000600000000000000" pitchFamily="2" charset="0"/>
                 </a:rPr>
-                <a:t>ద్రాక్ష చెట్లు ఫలింపకున్నను</a:t>
+                <a:t>ఎంతో ఆశ్చర్యమే</a:t>
               </a:r>
             </a:p>
             <a:p>
@@ -3199,7 +3179,7 @@
                   <a:latin typeface="Ramabhadra" panose="02000600000000000000" pitchFamily="2" charset="0"/>
                   <a:cs typeface="Ramabhadra" panose="02000600000000000000" pitchFamily="2" charset="0"/>
                 </a:rPr>
-                <a:t>చేనులోని పైరు పండకపోయినను</a:t>
+                <a:t>అది నా ఊహకే వింతైనది (2)</a:t>
               </a:r>
             </a:p>
             <a:p>
@@ -3211,7 +3191,19 @@
                   <a:latin typeface="Ramabhadra" panose="02000600000000000000" pitchFamily="2" charset="0"/>
                   <a:cs typeface="Ramabhadra" panose="02000600000000000000" pitchFamily="2" charset="0"/>
                 </a:rPr>
-                <a:t>శాలలోని పశువులు లేక పోయినను</a:t>
+                <a:t>ఎరుపెక్కిన శత్రువుల చూపు నుండి తప్పించి</a:t>
+              </a:r>
+            </a:p>
+            <a:p>
+              <a:pPr defTabSz="439781">
+                <a:defRPr/>
+              </a:pPr>
+              <a:r>
+                <a:rPr lang="te-IN" sz="2200" dirty="0">
+                  <a:latin typeface="Ramabhadra" panose="02000600000000000000" pitchFamily="2" charset="0"/>
+                  <a:cs typeface="Ramabhadra" panose="02000600000000000000" pitchFamily="2" charset="0"/>
+                </a:rPr>
+                <a:t>ఎనలేని ప్రేమను నాపై కురిపించావు (2)</a:t>
               </a:r>
             </a:p>
             <a:p>
@@ -3232,7 +3224,7 @@
                   <a:latin typeface="Ramabhadra" panose="02000600000000000000" pitchFamily="2" charset="0"/>
                   <a:cs typeface="Ramabhadra" panose="02000600000000000000" pitchFamily="2" charset="0"/>
                 </a:rPr>
-                <a:t>గాఢాంధకారాన పయనించిన </a:t>
+                <a:t>ద్రాక్షావల్లి అయిన నీలోనే - బహుగా వేరు పారగా</a:t>
               </a:r>
             </a:p>
             <a:p>
@@ -3244,7 +3236,7 @@
                   <a:latin typeface="Ramabhadra" panose="02000600000000000000" pitchFamily="2" charset="0"/>
                   <a:cs typeface="Ramabhadra" panose="02000600000000000000" pitchFamily="2" charset="0"/>
                 </a:rPr>
-                <a:t>పొంగు సాగరా లెదురైన</a:t>
+                <a:t>నీతో మధురమైన ఫలములీయనా (2)</a:t>
               </a:r>
             </a:p>
             <a:p>
@@ -3256,12 +3248,8 @@
                   <a:latin typeface="Ramabhadra" panose="02000600000000000000" pitchFamily="2" charset="0"/>
                   <a:cs typeface="Ramabhadra" panose="02000600000000000000" pitchFamily="2" charset="0"/>
                 </a:rPr>
-                <a:t>లోకమంత ఒకటైన</a:t>
-              </a:r>
-              <a:endParaRPr lang="en-IN" sz="2200" dirty="0">
-                <a:latin typeface="Ramabhadra" panose="02000600000000000000" pitchFamily="2" charset="0"/>
-                <a:cs typeface="Ramabhadra" panose="02000600000000000000" pitchFamily="2" charset="0"/>
-              </a:endParaRPr>
+                <a:t>ఉన్నత స్థలములపై నాకు స్థానమిచ్చితివే</a:t>
+              </a:r>
             </a:p>
             <a:p>
               <a:pPr defTabSz="439781">
@@ -3272,19 +3260,7 @@
                   <a:latin typeface="Ramabhadra" panose="02000600000000000000" pitchFamily="2" charset="0"/>
                   <a:cs typeface="Ramabhadra" panose="02000600000000000000" pitchFamily="2" charset="0"/>
                 </a:rPr>
-                <a:t>అన్యాయ తీర్పుకు గురిచేసిన</a:t>
-              </a:r>
-            </a:p>
-            <a:p>
-              <a:pPr defTabSz="439781">
-                <a:defRPr/>
-              </a:pPr>
-              <a:r>
-                <a:rPr lang="te-IN" sz="2200" dirty="0">
-                  <a:latin typeface="Ramabhadra" panose="02000600000000000000" pitchFamily="2" charset="0"/>
-                  <a:cs typeface="Ramabhadra" panose="02000600000000000000" pitchFamily="2" charset="0"/>
-                </a:rPr>
-                <a:t>సత్యము పలుకుటచే నష్టము కలిగినను</a:t>
+                <a:t>విజయుడా నీ కృప చాలును నా జీవితాన (2)</a:t>
               </a:r>
             </a:p>
           </p:txBody>
@@ -3442,7 +3418,7 @@
           <p:spPr>
             <a:xfrm>
               <a:off x="240243" y="276251"/>
-              <a:ext cx="5614462" cy="6232475"/>
+              <a:ext cx="5614462" cy="6247864"/>
             </a:xfrm>
             <a:prstGeom prst="rect">
               <a:avLst/>
@@ -3456,167 +3432,176 @@
             <a:lstStyle/>
             <a:p>
               <a:r>
-                <a:rPr lang="te-IN" sz="2100" dirty="0">
-                  <a:latin typeface="Ramabhadra" panose="02000600000000000000" pitchFamily="2" charset="0"/>
-                  <a:cs typeface="Ramabhadra" panose="02000600000000000000" pitchFamily="2" charset="0"/>
-                </a:rPr>
-                <a:t>నీతో గడిపే ప్రతి క్షణము</a:t>
-              </a:r>
-            </a:p>
-            <a:p>
-              <a:r>
-                <a:rPr lang="te-IN" sz="2100" dirty="0">
-                  <a:latin typeface="Ramabhadra" panose="02000600000000000000" pitchFamily="2" charset="0"/>
-                  <a:cs typeface="Ramabhadra" panose="02000600000000000000" pitchFamily="2" charset="0"/>
-                </a:rPr>
-                <a:t>ఆనంద బాష్పాలు ఆగవయ్యా (2)</a:t>
-              </a:r>
-            </a:p>
-            <a:p>
-              <a:r>
-                <a:rPr lang="te-IN" sz="2100" dirty="0">
-                  <a:latin typeface="Ramabhadra" panose="02000600000000000000" pitchFamily="2" charset="0"/>
-                  <a:cs typeface="Ramabhadra" panose="02000600000000000000" pitchFamily="2" charset="0"/>
-                </a:rPr>
-                <a:t>కృప తలంచగా మేళ్లు యోచించగా (2)</a:t>
-              </a:r>
-            </a:p>
-            <a:p>
-              <a:r>
-                <a:rPr lang="te-IN" sz="2100" dirty="0">
-                  <a:latin typeface="Ramabhadra" panose="02000600000000000000" pitchFamily="2" charset="0"/>
-                  <a:cs typeface="Ramabhadra" panose="02000600000000000000" pitchFamily="2" charset="0"/>
-                </a:rPr>
-                <a:t>నా గలమాగదు స్తుతించక – నిను కీర్తించక</a:t>
-              </a:r>
-            </a:p>
-            <a:p>
-              <a:r>
-                <a:rPr lang="te-IN" sz="2100" dirty="0">
-                  <a:latin typeface="Ramabhadra" panose="02000600000000000000" pitchFamily="2" charset="0"/>
-                  <a:cs typeface="Ramabhadra" panose="02000600000000000000" pitchFamily="2" charset="0"/>
-                </a:rPr>
-                <a:t>యేసయ్యా యేసయ్యా – నా యేసయ్యా (4)</a:t>
-              </a:r>
-            </a:p>
-            <a:p>
-              <a:endParaRPr lang="te-IN" sz="2100" dirty="0">
+                <a:rPr lang="te-IN" sz="2000" dirty="0">
+                  <a:latin typeface="Ramabhadra" panose="02000600000000000000" pitchFamily="2" charset="0"/>
+                  <a:cs typeface="Ramabhadra" panose="02000600000000000000" pitchFamily="2" charset="0"/>
+                </a:rPr>
+                <a:t>యేసయ్యా .. నీ కృప నాకు చాలయ్యా.. </a:t>
+              </a:r>
+            </a:p>
+            <a:p>
+              <a:r>
+                <a:rPr lang="te-IN" sz="2000" dirty="0">
+                  <a:latin typeface="Ramabhadra" panose="02000600000000000000" pitchFamily="2" charset="0"/>
+                  <a:cs typeface="Ramabhadra" panose="02000600000000000000" pitchFamily="2" charset="0"/>
+                </a:rPr>
+                <a:t>నీ కృప లేనిదే నే బ్రతుకలేనయ్యా … </a:t>
+              </a:r>
+            </a:p>
+            <a:p>
+              <a:r>
+                <a:rPr lang="te-IN" sz="2000" dirty="0">
+                  <a:latin typeface="Ramabhadra" panose="02000600000000000000" pitchFamily="2" charset="0"/>
+                  <a:cs typeface="Ramabhadra" panose="02000600000000000000" pitchFamily="2" charset="0"/>
+                </a:rPr>
+                <a:t>నీ కృప లేని క్షణము – నీ దయ లేని క్షణము </a:t>
+              </a:r>
+            </a:p>
+            <a:p>
+              <a:r>
+                <a:rPr lang="te-IN" sz="2000" dirty="0">
+                  <a:latin typeface="Ramabhadra" panose="02000600000000000000" pitchFamily="2" charset="0"/>
+                  <a:cs typeface="Ramabhadra" panose="02000600000000000000" pitchFamily="2" charset="0"/>
+                </a:rPr>
+                <a:t>నేనూహించలేను యేసయ్యా.. (2)</a:t>
+              </a:r>
+            </a:p>
+            <a:p>
+              <a:r>
+                <a:rPr lang="te-IN" sz="2000" dirty="0">
+                  <a:latin typeface="Ramabhadra" panose="02000600000000000000" pitchFamily="2" charset="0"/>
+                  <a:cs typeface="Ramabhadra" panose="02000600000000000000" pitchFamily="2" charset="0"/>
+                </a:rPr>
+                <a:t>యేసయ్యా నీ కృప నాకు చాలయ్యా –</a:t>
+              </a:r>
+            </a:p>
+            <a:p>
+              <a:r>
+                <a:rPr lang="te-IN" sz="2000" dirty="0">
+                  <a:latin typeface="Ramabhadra" panose="02000600000000000000" pitchFamily="2" charset="0"/>
+                  <a:cs typeface="Ramabhadra" panose="02000600000000000000" pitchFamily="2" charset="0"/>
+                </a:rPr>
+                <a:t>నీ కృప లేనిదే నేనుండలేనయ్యా (2) నీ కృప</a:t>
+              </a:r>
+            </a:p>
+            <a:p>
+              <a:endParaRPr lang="te-IN" sz="2000" dirty="0">
                 <a:latin typeface="Ramabhadra" panose="02000600000000000000" pitchFamily="2" charset="0"/>
                 <a:cs typeface="Ramabhadra" panose="02000600000000000000" pitchFamily="2" charset="0"/>
               </a:endParaRPr>
             </a:p>
             <a:p>
               <a:r>
-                <a:rPr lang="te-IN" sz="2100" dirty="0">
-                  <a:latin typeface="Ramabhadra" panose="02000600000000000000" pitchFamily="2" charset="0"/>
-                  <a:cs typeface="Ramabhadra" panose="02000600000000000000" pitchFamily="2" charset="0"/>
-                </a:rPr>
-                <a:t>మారా వంటి నా జీవితాన్ని</a:t>
-              </a:r>
-            </a:p>
-            <a:p>
-              <a:r>
-                <a:rPr lang="te-IN" sz="2100" dirty="0">
-                  <a:latin typeface="Ramabhadra" panose="02000600000000000000" pitchFamily="2" charset="0"/>
-                  <a:cs typeface="Ramabhadra" panose="02000600000000000000" pitchFamily="2" charset="0"/>
-                </a:rPr>
-                <a:t>మధురముగా మార్చి ఘనపరచినావు (2)</a:t>
-              </a:r>
-            </a:p>
-            <a:p>
-              <a:r>
-                <a:rPr lang="te-IN" sz="2100" dirty="0">
-                  <a:latin typeface="Ramabhadra" panose="02000600000000000000" pitchFamily="2" charset="0"/>
-                  <a:cs typeface="Ramabhadra" panose="02000600000000000000" pitchFamily="2" charset="0"/>
-                </a:rPr>
-                <a:t>నా ప్రేమ చేత కాదు</a:t>
-              </a:r>
-            </a:p>
-            <a:p>
-              <a:r>
-                <a:rPr lang="te-IN" sz="2100" dirty="0">
-                  <a:latin typeface="Ramabhadra" panose="02000600000000000000" pitchFamily="2" charset="0"/>
-                  <a:cs typeface="Ramabhadra" panose="02000600000000000000" pitchFamily="2" charset="0"/>
-                </a:rPr>
-                <a:t>నీవే నను ప్రేమించి (2)</a:t>
-              </a:r>
-            </a:p>
-            <a:p>
-              <a:r>
-                <a:rPr lang="te-IN" sz="2100" dirty="0">
-                  <a:latin typeface="Ramabhadra" panose="02000600000000000000" pitchFamily="2" charset="0"/>
-                  <a:cs typeface="Ramabhadra" panose="02000600000000000000" pitchFamily="2" charset="0"/>
-                </a:rPr>
-                <a:t>రక్తాన్ని చిందించి</a:t>
-              </a:r>
-            </a:p>
-            <a:p>
-              <a:r>
-                <a:rPr lang="te-IN" sz="2100" dirty="0">
-                  <a:latin typeface="Ramabhadra" panose="02000600000000000000" pitchFamily="2" charset="0"/>
-                  <a:cs typeface="Ramabhadra" panose="02000600000000000000" pitchFamily="2" charset="0"/>
-                </a:rPr>
-                <a:t>నన్ను రక్షించావు (2)</a:t>
-              </a:r>
-            </a:p>
-            <a:p>
-              <a:endParaRPr lang="te-IN" sz="2100" dirty="0">
+                <a:rPr lang="te-IN" sz="2000" dirty="0">
+                  <a:latin typeface="Ramabhadra" panose="02000600000000000000" pitchFamily="2" charset="0"/>
+                  <a:cs typeface="Ramabhadra" panose="02000600000000000000" pitchFamily="2" charset="0"/>
+                </a:rPr>
+                <a:t>మహిమను విడిచి – మహిలోకి దిగివచ్చి </a:t>
+              </a:r>
+            </a:p>
+            <a:p>
+              <a:r>
+                <a:rPr lang="te-IN" sz="2000" dirty="0">
+                  <a:latin typeface="Ramabhadra" panose="02000600000000000000" pitchFamily="2" charset="0"/>
+                  <a:cs typeface="Ramabhadra" panose="02000600000000000000" pitchFamily="2" charset="0"/>
+                </a:rPr>
+                <a:t>మార్గముగా మారి – మనిషిగ మార్చావు </a:t>
+              </a:r>
+            </a:p>
+            <a:p>
+              <a:r>
+                <a:rPr lang="te-IN" sz="2000" dirty="0">
+                  <a:latin typeface="Ramabhadra" panose="02000600000000000000" pitchFamily="2" charset="0"/>
+                  <a:cs typeface="Ramabhadra" panose="02000600000000000000" pitchFamily="2" charset="0"/>
+                </a:rPr>
+                <a:t>మహినే నీవు మాధుర్యముగ మార్చి </a:t>
+              </a:r>
+            </a:p>
+            <a:p>
+              <a:r>
+                <a:rPr lang="te-IN" sz="2000" dirty="0">
+                  <a:latin typeface="Ramabhadra" panose="02000600000000000000" pitchFamily="2" charset="0"/>
+                  <a:cs typeface="Ramabhadra" panose="02000600000000000000" pitchFamily="2" charset="0"/>
+                </a:rPr>
+                <a:t>మాదిరి చూపి మరు రూపమిచ్చావు(2)</a:t>
+              </a:r>
+            </a:p>
+            <a:p>
+              <a:r>
+                <a:rPr lang="te-IN" sz="2000" dirty="0">
+                  <a:latin typeface="Ramabhadra" panose="02000600000000000000" pitchFamily="2" charset="0"/>
+                  <a:cs typeface="Ramabhadra" panose="02000600000000000000" pitchFamily="2" charset="0"/>
+                </a:rPr>
+                <a:t>మహిమలో నేను మహిమను పొంద </a:t>
+              </a:r>
+            </a:p>
+            <a:p>
+              <a:r>
+                <a:rPr lang="te-IN" sz="2000" dirty="0">
+                  <a:latin typeface="Ramabhadra" panose="02000600000000000000" pitchFamily="2" charset="0"/>
+                  <a:cs typeface="Ramabhadra" panose="02000600000000000000" pitchFamily="2" charset="0"/>
+                </a:rPr>
+                <a:t>మహిమగ మార్చింది నీకృప (2) యేసయ్యా నీ కృప</a:t>
+              </a:r>
+            </a:p>
+            <a:p>
+              <a:endParaRPr lang="te-IN" sz="2000" dirty="0">
                 <a:latin typeface="Ramabhadra" panose="02000600000000000000" pitchFamily="2" charset="0"/>
                 <a:cs typeface="Ramabhadra" panose="02000600000000000000" pitchFamily="2" charset="0"/>
               </a:endParaRPr>
             </a:p>
             <a:p>
               <a:r>
-                <a:rPr lang="te-IN" sz="2100" dirty="0">
-                  <a:latin typeface="Ramabhadra" panose="02000600000000000000" pitchFamily="2" charset="0"/>
-                  <a:cs typeface="Ramabhadra" panose="02000600000000000000" pitchFamily="2" charset="0"/>
-                </a:rPr>
-                <a:t>గమ్యమే లేని ఓ బాటసారిని</a:t>
-              </a:r>
-            </a:p>
-            <a:p>
-              <a:r>
-                <a:rPr lang="te-IN" sz="2100" dirty="0">
-                  <a:latin typeface="Ramabhadra" panose="02000600000000000000" pitchFamily="2" charset="0"/>
-                  <a:cs typeface="Ramabhadra" panose="02000600000000000000" pitchFamily="2" charset="0"/>
-                </a:rPr>
-                <a:t>నీతో ఉన్నాను భయము లేదన్నావు (2)</a:t>
-              </a:r>
-            </a:p>
-            <a:p>
-              <a:r>
-                <a:rPr lang="te-IN" sz="2100" dirty="0">
-                  <a:latin typeface="Ramabhadra" panose="02000600000000000000" pitchFamily="2" charset="0"/>
-                  <a:cs typeface="Ramabhadra" panose="02000600000000000000" pitchFamily="2" charset="0"/>
-                </a:rPr>
-                <a:t>నా శక్తి చేత కాదు</a:t>
-              </a:r>
-            </a:p>
-            <a:p>
-              <a:r>
-                <a:rPr lang="te-IN" sz="2100" dirty="0">
-                  <a:latin typeface="Ramabhadra" panose="02000600000000000000" pitchFamily="2" charset="0"/>
-                  <a:cs typeface="Ramabhadra" panose="02000600000000000000" pitchFamily="2" charset="0"/>
-                </a:rPr>
-                <a:t>నీ ఆత్మ ద్వారానే (2)</a:t>
-              </a:r>
-            </a:p>
-            <a:p>
-              <a:r>
-                <a:rPr lang="te-IN" sz="2100" dirty="0">
-                  <a:latin typeface="Ramabhadra" panose="02000600000000000000" pitchFamily="2" charset="0"/>
-                  <a:cs typeface="Ramabhadra" panose="02000600000000000000" pitchFamily="2" charset="0"/>
-                </a:rPr>
-                <a:t>వాగ్ధానము నెరవేర్చి</a:t>
-              </a:r>
-            </a:p>
-            <a:p>
-              <a:r>
-                <a:rPr lang="te-IN" sz="2100" dirty="0">
-                  <a:latin typeface="Ramabhadra" panose="02000600000000000000" pitchFamily="2" charset="0"/>
-                  <a:cs typeface="Ramabhadra" panose="02000600000000000000" pitchFamily="2" charset="0"/>
-                </a:rPr>
-                <a:t>వారసుని చేసావు (2)</a:t>
+                <a:rPr lang="te-IN" sz="2000" dirty="0">
+                  <a:latin typeface="Ramabhadra" panose="02000600000000000000" pitchFamily="2" charset="0"/>
+                  <a:cs typeface="Ramabhadra" panose="02000600000000000000" pitchFamily="2" charset="0"/>
+                </a:rPr>
+                <a:t>ఆజ్ఞల మార్గమున ఆశ్రయమును ఇచ్చి </a:t>
+              </a:r>
+            </a:p>
+            <a:p>
+              <a:r>
+                <a:rPr lang="te-IN" sz="2000" dirty="0">
+                  <a:latin typeface="Ramabhadra" panose="02000600000000000000" pitchFamily="2" charset="0"/>
+                  <a:cs typeface="Ramabhadra" panose="02000600000000000000" pitchFamily="2" charset="0"/>
+                </a:rPr>
+                <a:t>ఆపత్కాలమున ఆదుకొన్నావు </a:t>
+              </a:r>
+            </a:p>
+            <a:p>
+              <a:r>
+                <a:rPr lang="te-IN" sz="2000" dirty="0">
+                  <a:latin typeface="Ramabhadra" panose="02000600000000000000" pitchFamily="2" charset="0"/>
+                  <a:cs typeface="Ramabhadra" panose="02000600000000000000" pitchFamily="2" charset="0"/>
+                </a:rPr>
+                <a:t>ఆత్మీయులతో – ఆనందింపజేసి </a:t>
+              </a:r>
+            </a:p>
+            <a:p>
+              <a:r>
+                <a:rPr lang="te-IN" sz="2000" dirty="0">
+                  <a:latin typeface="Ramabhadra" panose="02000600000000000000" pitchFamily="2" charset="0"/>
+                  <a:cs typeface="Ramabhadra" panose="02000600000000000000" pitchFamily="2" charset="0"/>
+                </a:rPr>
+                <a:t>ఆనంద తైలముతో – అభిషేకించావు  (2)</a:t>
+              </a:r>
+            </a:p>
+            <a:p>
+              <a:r>
+                <a:rPr lang="te-IN" sz="2000" dirty="0">
+                  <a:latin typeface="Ramabhadra" panose="02000600000000000000" pitchFamily="2" charset="0"/>
+                  <a:cs typeface="Ramabhadra" panose="02000600000000000000" pitchFamily="2" charset="0"/>
+                </a:rPr>
+                <a:t>నా ఆశతీర ఆరాధన చేసే </a:t>
+              </a:r>
+            </a:p>
+            <a:p>
+              <a:r>
+                <a:rPr lang="te-IN" sz="2000" dirty="0">
+                  <a:latin typeface="Ramabhadra" panose="02000600000000000000" pitchFamily="2" charset="0"/>
+                  <a:cs typeface="Ramabhadra" panose="02000600000000000000" pitchFamily="2" charset="0"/>
+                </a:rPr>
+                <a:t>అదృష్టమిచ్చింది నీ కృప (2)యేసయ్యా నీ కృప</a:t>
               </a:r>
             </a:p>
           </p:txBody>
@@ -3804,7 +3789,7 @@
           <p:spPr>
             <a:xfrm>
               <a:off x="308503" y="768683"/>
-              <a:ext cx="4648200" cy="4154984"/>
+              <a:ext cx="4648200" cy="5262979"/>
             </a:xfrm>
             <a:prstGeom prst="rect">
               <a:avLst/>
@@ -3821,11 +3806,11 @@
                 <a:defRPr/>
               </a:pPr>
               <a:r>
-                <a:rPr lang="te-IN" sz="2200" dirty="0">
-                  <a:latin typeface="Ramabhadra" panose="02000600000000000000" pitchFamily="2" charset="0"/>
-                  <a:cs typeface="Ramabhadra" panose="02000600000000000000" pitchFamily="2" charset="0"/>
-                </a:rPr>
-                <a:t>స్తుతి సింహాసనాసీనుడా</a:t>
+                <a:rPr lang="te-IN" sz="2400" dirty="0">
+                  <a:latin typeface="Ramabhadra" panose="02000600000000000000" pitchFamily="2" charset="0"/>
+                  <a:cs typeface="Ramabhadra" panose="02000600000000000000" pitchFamily="2" charset="0"/>
+                </a:rPr>
+                <a:t>నజరేయుడా నా యేసయ్య</a:t>
               </a:r>
             </a:p>
             <a:p>
@@ -3833,18 +3818,42 @@
                 <a:defRPr/>
               </a:pPr>
               <a:r>
-                <a:rPr lang="te-IN" sz="2200" dirty="0">
-                  <a:latin typeface="Ramabhadra" panose="02000600000000000000" pitchFamily="2" charset="0"/>
-                  <a:cs typeface="Ramabhadra" panose="02000600000000000000" pitchFamily="2" charset="0"/>
-                </a:rPr>
-                <a:t>యేసు రాజా దివ్య తేజా (2)</a:t>
+                <a:rPr lang="te-IN" sz="2400" dirty="0">
+                  <a:latin typeface="Ramabhadra" panose="02000600000000000000" pitchFamily="2" charset="0"/>
+                  <a:cs typeface="Ramabhadra" panose="02000600000000000000" pitchFamily="2" charset="0"/>
+                </a:rPr>
+                <a:t>ఎన్ని యుగాలకైనా</a:t>
               </a:r>
             </a:p>
             <a:p>
               <a:pPr defTabSz="439781">
                 <a:defRPr/>
               </a:pPr>
-              <a:endParaRPr lang="te-IN" sz="2200" dirty="0">
+              <a:r>
+                <a:rPr lang="te-IN" sz="2400" dirty="0">
+                  <a:latin typeface="Ramabhadra" panose="02000600000000000000" pitchFamily="2" charset="0"/>
+                  <a:cs typeface="Ramabhadra" panose="02000600000000000000" pitchFamily="2" charset="0"/>
+                </a:rPr>
+                <a:t>ఆరాధ్య దైవము నీవేనని</a:t>
+              </a:r>
+            </a:p>
+            <a:p>
+              <a:pPr defTabSz="439781">
+                <a:defRPr/>
+              </a:pPr>
+              <a:r>
+                <a:rPr lang="te-IN" sz="2400" dirty="0">
+                  <a:latin typeface="Ramabhadra" panose="02000600000000000000" pitchFamily="2" charset="0"/>
+                  <a:cs typeface="Ramabhadra" panose="02000600000000000000" pitchFamily="2" charset="0"/>
+                </a:rPr>
+                <a:t>గళమెత్తి నీ కీర్తి నే చాటెద</a:t>
+              </a:r>
+            </a:p>
+            <a:p>
+              <a:pPr defTabSz="439781">
+                <a:defRPr/>
+              </a:pPr>
+              <a:endParaRPr lang="te-IN" sz="2400" dirty="0">
                 <a:latin typeface="Ramabhadra" panose="02000600000000000000" pitchFamily="2" charset="0"/>
                 <a:cs typeface="Ramabhadra" panose="02000600000000000000" pitchFamily="2" charset="0"/>
               </a:endParaRPr>
@@ -3854,11 +3863,11 @@
                 <a:defRPr/>
               </a:pPr>
               <a:r>
-                <a:rPr lang="te-IN" sz="2200" dirty="0">
-                  <a:latin typeface="Ramabhadra" panose="02000600000000000000" pitchFamily="2" charset="0"/>
-                  <a:cs typeface="Ramabhadra" panose="02000600000000000000" pitchFamily="2" charset="0"/>
-                </a:rPr>
-                <a:t>అద్వితీయుడవు పరిశుద్ధుడవు</a:t>
+                <a:rPr lang="te-IN" sz="2400" dirty="0">
+                  <a:latin typeface="Ramabhadra" panose="02000600000000000000" pitchFamily="2" charset="0"/>
+                  <a:cs typeface="Ramabhadra" panose="02000600000000000000" pitchFamily="2" charset="0"/>
+                </a:rPr>
+                <a:t>ఆకాశ గగనాలను నీ జేనతో కొలిచితివి (2)</a:t>
               </a:r>
             </a:p>
             <a:p>
@@ -3866,11 +3875,11 @@
                 <a:defRPr/>
               </a:pPr>
               <a:r>
-                <a:rPr lang="te-IN" sz="2200" dirty="0">
-                  <a:latin typeface="Ramabhadra" panose="02000600000000000000" pitchFamily="2" charset="0"/>
-                  <a:cs typeface="Ramabhadra" panose="02000600000000000000" pitchFamily="2" charset="0"/>
-                </a:rPr>
-                <a:t>అతి సుందరుడవు నీవే ప్రభూ (2)</a:t>
+                <a:rPr lang="te-IN" sz="2400" dirty="0">
+                  <a:latin typeface="Ramabhadra" panose="02000600000000000000" pitchFamily="2" charset="0"/>
+                  <a:cs typeface="Ramabhadra" panose="02000600000000000000" pitchFamily="2" charset="0"/>
+                </a:rPr>
+                <a:t>శూన్యములో ఈ భూమిని</a:t>
               </a:r>
             </a:p>
             <a:p>
@@ -3878,11 +3887,11 @@
                 <a:defRPr/>
               </a:pPr>
               <a:r>
-                <a:rPr lang="te-IN" sz="2200" dirty="0">
-                  <a:latin typeface="Ramabhadra" panose="02000600000000000000" pitchFamily="2" charset="0"/>
-                  <a:cs typeface="Ramabhadra" panose="02000600000000000000" pitchFamily="2" charset="0"/>
-                </a:rPr>
-                <a:t>నీతి న్యాయములు నీ సింహాసనాధారం (2)</a:t>
+                <a:rPr lang="te-IN" sz="2400" dirty="0">
+                  <a:latin typeface="Ramabhadra" panose="02000600000000000000" pitchFamily="2" charset="0"/>
+                  <a:cs typeface="Ramabhadra" panose="02000600000000000000" pitchFamily="2" charset="0"/>
+                </a:rPr>
+                <a:t>వ్రేలాడదీసిన నా యేసయ్య (2)</a:t>
               </a:r>
             </a:p>
             <a:p>
@@ -3890,18 +3899,18 @@
                 <a:defRPr/>
               </a:pPr>
               <a:r>
-                <a:rPr lang="te-IN" sz="2200" dirty="0">
-                  <a:latin typeface="Ramabhadra" panose="02000600000000000000" pitchFamily="2" charset="0"/>
-                  <a:cs typeface="Ramabhadra" panose="02000600000000000000" pitchFamily="2" charset="0"/>
-                </a:rPr>
-                <a:t>కృపా సత్యములు నీ సన్నిధానవర్తులు (2)</a:t>
+                <a:rPr lang="te-IN" sz="2400" dirty="0">
+                  <a:latin typeface="Ramabhadra" panose="02000600000000000000" pitchFamily="2" charset="0"/>
+                  <a:cs typeface="Ramabhadra" panose="02000600000000000000" pitchFamily="2" charset="0"/>
+                </a:rPr>
+                <a:t>నీకే వందనం నీకే వందనం (2)</a:t>
               </a:r>
             </a:p>
             <a:p>
               <a:pPr defTabSz="439781">
                 <a:defRPr/>
               </a:pPr>
-              <a:endParaRPr lang="te-IN" sz="2200" dirty="0">
+              <a:endParaRPr lang="te-IN" sz="2400" dirty="0">
                 <a:latin typeface="Ramabhadra" panose="02000600000000000000" pitchFamily="2" charset="0"/>
                 <a:cs typeface="Ramabhadra" panose="02000600000000000000" pitchFamily="2" charset="0"/>
               </a:endParaRPr>
@@ -3911,11 +3920,11 @@
                 <a:defRPr/>
               </a:pPr>
               <a:r>
-                <a:rPr lang="te-IN" sz="2200" dirty="0">
-                  <a:latin typeface="Ramabhadra" panose="02000600000000000000" pitchFamily="2" charset="0"/>
-                  <a:cs typeface="Ramabhadra" panose="02000600000000000000" pitchFamily="2" charset="0"/>
-                </a:rPr>
-                <a:t>బలియు అర్పణ కోరవు నీవు</a:t>
+                <a:rPr lang="te-IN" sz="2400" dirty="0">
+                  <a:latin typeface="Ramabhadra" panose="02000600000000000000" pitchFamily="2" charset="0"/>
+                  <a:cs typeface="Ramabhadra" panose="02000600000000000000" pitchFamily="2" charset="0"/>
+                </a:rPr>
+                <a:t>అగాధ సముద్రాలకు నీవే ఎల్లలు వేసితివి (2)</a:t>
               </a:r>
             </a:p>
             <a:p>
@@ -3923,11 +3932,11 @@
                 <a:defRPr/>
               </a:pPr>
               <a:r>
-                <a:rPr lang="te-IN" sz="2200" dirty="0">
-                  <a:latin typeface="Ramabhadra" panose="02000600000000000000" pitchFamily="2" charset="0"/>
-                  <a:cs typeface="Ramabhadra" panose="02000600000000000000" pitchFamily="2" charset="0"/>
-                </a:rPr>
-                <a:t>బలియైతివి నా దోషముకై (2)</a:t>
+                <a:rPr lang="te-IN" sz="2400" dirty="0">
+                  <a:latin typeface="Ramabhadra" panose="02000600000000000000" pitchFamily="2" charset="0"/>
+                  <a:cs typeface="Ramabhadra" panose="02000600000000000000" pitchFamily="2" charset="0"/>
+                </a:rPr>
+                <a:t>జలములలోబడి నే వెళ్ళినా</a:t>
               </a:r>
             </a:p>
             <a:p>
@@ -3935,11 +3944,11 @@
                 <a:defRPr/>
               </a:pPr>
               <a:r>
-                <a:rPr lang="te-IN" sz="2200" dirty="0">
-                  <a:latin typeface="Ramabhadra" panose="02000600000000000000" pitchFamily="2" charset="0"/>
-                  <a:cs typeface="Ramabhadra" panose="02000600000000000000" pitchFamily="2" charset="0"/>
-                </a:rPr>
-                <a:t>నా హృదయమే నీ ప్రియమగు ఆలయం (2)</a:t>
+                <a:rPr lang="te-IN" sz="2400" dirty="0">
+                  <a:latin typeface="Ramabhadra" panose="02000600000000000000" pitchFamily="2" charset="0"/>
+                  <a:cs typeface="Ramabhadra" panose="02000600000000000000" pitchFamily="2" charset="0"/>
+                </a:rPr>
+                <a:t>నన్నేమి చేయవు నా యేసయ్యా (2)</a:t>
               </a:r>
             </a:p>
             <a:p>
@@ -3947,11 +3956,11 @@
                 <a:defRPr/>
               </a:pPr>
               <a:r>
-                <a:rPr lang="te-IN" sz="2200" dirty="0">
-                  <a:latin typeface="Ramabhadra" panose="02000600000000000000" pitchFamily="2" charset="0"/>
-                  <a:cs typeface="Ramabhadra" panose="02000600000000000000" pitchFamily="2" charset="0"/>
-                </a:rPr>
-                <a:t>స్తుతియాగమునే చేసెద నిరతం (2)</a:t>
+                <a:rPr lang="te-IN" sz="2400" dirty="0">
+                  <a:latin typeface="Ramabhadra" panose="02000600000000000000" pitchFamily="2" charset="0"/>
+                  <a:cs typeface="Ramabhadra" panose="02000600000000000000" pitchFamily="2" charset="0"/>
+                </a:rPr>
+                <a:t>నీకే వందనం నీకే వందనం (2) </a:t>
               </a:r>
             </a:p>
           </p:txBody>
@@ -4034,9 +4043,9 @@
         <p:grpSpPr>
           <a:xfrm>
             <a:off x="5104338" y="182031"/>
-            <a:ext cx="4828492" cy="6538635"/>
+            <a:ext cx="4897436" cy="6493935"/>
             <a:chOff x="160868" y="182032"/>
-            <a:chExt cx="4828492" cy="6538635"/>
+            <a:chExt cx="4897436" cy="6493935"/>
           </a:xfrm>
         </p:grpSpPr>
         <p:sp>
@@ -4108,8 +4117,8 @@
           </p:nvSpPr>
           <p:spPr>
             <a:xfrm>
-              <a:off x="239559" y="195804"/>
-              <a:ext cx="4749801" cy="6524863"/>
+              <a:off x="308503" y="521693"/>
+              <a:ext cx="4749801" cy="4693593"/>
             </a:xfrm>
             <a:prstGeom prst="rect">
               <a:avLst/>
@@ -4126,11 +4135,11 @@
                 <a:defRPr/>
               </a:pPr>
               <a:r>
-                <a:rPr lang="te-IN" sz="2200" dirty="0">
-                  <a:latin typeface="Ramabhadra" panose="02000600000000000000" pitchFamily="2" charset="0"/>
-                  <a:cs typeface="Ramabhadra" panose="02000600000000000000" pitchFamily="2" charset="0"/>
-                </a:rPr>
-                <a:t>అపారమైనది నీ కృప  </a:t>
+                <a:rPr lang="te-IN" sz="2300" dirty="0">
+                  <a:latin typeface="Ramabhadra" panose="02000600000000000000" pitchFamily="2" charset="0"/>
+                  <a:cs typeface="Ramabhadra" panose="02000600000000000000" pitchFamily="2" charset="0"/>
+                </a:rPr>
+                <a:t>నీవుంటే నాకు చాలు యేసయ్యా</a:t>
               </a:r>
             </a:p>
             <a:p>
@@ -4138,11 +4147,11 @@
                 <a:defRPr/>
               </a:pPr>
               <a:r>
-                <a:rPr lang="te-IN" sz="2200" dirty="0">
-                  <a:latin typeface="Ramabhadra" panose="02000600000000000000" pitchFamily="2" charset="0"/>
-                  <a:cs typeface="Ramabhadra" panose="02000600000000000000" pitchFamily="2" charset="0"/>
-                </a:rPr>
-                <a:t>అమూల్యమైనది నీ కృప</a:t>
+                <a:rPr lang="te-IN" sz="2300" dirty="0">
+                  <a:latin typeface="Ramabhadra" panose="02000600000000000000" pitchFamily="2" charset="0"/>
+                  <a:cs typeface="Ramabhadra" panose="02000600000000000000" pitchFamily="2" charset="0"/>
+                </a:rPr>
+                <a:t>నీవెంటే నేను ఉంటానేసయ్యా (2)</a:t>
               </a:r>
             </a:p>
             <a:p>
@@ -4150,11 +4159,11 @@
                 <a:defRPr/>
               </a:pPr>
               <a:r>
-                <a:rPr lang="te-IN" sz="2200" dirty="0">
-                  <a:latin typeface="Ramabhadra" panose="02000600000000000000" pitchFamily="2" charset="0"/>
-                  <a:cs typeface="Ramabhadra" panose="02000600000000000000" pitchFamily="2" charset="0"/>
-                </a:rPr>
-                <a:t>జీవము కంటె ఉత్తమమైనది  </a:t>
+                <a:rPr lang="te-IN" sz="2300" dirty="0">
+                  <a:latin typeface="Ramabhadra" panose="02000600000000000000" pitchFamily="2" charset="0"/>
+                  <a:cs typeface="Ramabhadra" panose="02000600000000000000" pitchFamily="2" charset="0"/>
+                </a:rPr>
+                <a:t>నీ మాట చాలయ్యా నీ చూపు చాలయ్యా</a:t>
               </a:r>
             </a:p>
             <a:p>
@@ -4162,30 +4171,50 @@
                 <a:defRPr/>
               </a:pPr>
               <a:r>
-                <a:rPr lang="te-IN" sz="2200" dirty="0">
-                  <a:latin typeface="Ramabhadra" panose="02000600000000000000" pitchFamily="2" charset="0"/>
-                  <a:cs typeface="Ramabhadra" panose="02000600000000000000" pitchFamily="2" charset="0"/>
-                </a:rPr>
-                <a:t>పర్వత శిఖరము కన్న ఎతైనది</a:t>
-              </a:r>
+                <a:rPr lang="te-IN" sz="2300" dirty="0">
+                  <a:latin typeface="Ramabhadra" panose="02000600000000000000" pitchFamily="2" charset="0"/>
+                  <a:cs typeface="Ramabhadra" panose="02000600000000000000" pitchFamily="2" charset="0"/>
+                </a:rPr>
+                <a:t>నీ తోడు చాలయ్యా నీ నీడ చాలయ్యా (2)</a:t>
+              </a:r>
+              <a:endParaRPr lang="en-IN" sz="2300" dirty="0">
+                <a:latin typeface="Ramabhadra" panose="02000600000000000000" pitchFamily="2" charset="0"/>
+                <a:cs typeface="Ramabhadra" panose="02000600000000000000" pitchFamily="2" charset="0"/>
+              </a:endParaRPr>
             </a:p>
             <a:p>
               <a:pPr defTabSz="439781">
                 <a:defRPr/>
               </a:pPr>
-              <a:r>
-                <a:rPr lang="te-IN" sz="2200" dirty="0">
-                  <a:latin typeface="Ramabhadra" panose="02000600000000000000" pitchFamily="2" charset="0"/>
-                  <a:cs typeface="Ramabhadra" panose="02000600000000000000" pitchFamily="2" charset="0"/>
-                </a:rPr>
-                <a:t>కృప కృప కృప కృప నీకృప   ॥2॥</a:t>
-              </a:r>
+              <a:endParaRPr lang="te-IN" sz="2300" dirty="0">
+                <a:latin typeface="Ramabhadra" panose="02000600000000000000" pitchFamily="2" charset="0"/>
+                <a:cs typeface="Ramabhadra" panose="02000600000000000000" pitchFamily="2" charset="0"/>
+              </a:endParaRPr>
             </a:p>
             <a:p>
               <a:pPr defTabSz="439781">
                 <a:defRPr/>
               </a:pPr>
-              <a:endParaRPr lang="te-IN" sz="2200" dirty="0">
+              <a:r>
+                <a:rPr lang="te-IN" sz="2300" dirty="0">
+                  <a:latin typeface="Ramabhadra" panose="02000600000000000000" pitchFamily="2" charset="0"/>
+                  <a:cs typeface="Ramabhadra" panose="02000600000000000000" pitchFamily="2" charset="0"/>
+                </a:rPr>
+                <a:t>ఎన్ని బాధలున్ననూ ఇబ్బందులైననూ</a:t>
+              </a:r>
+            </a:p>
+            <a:p>
+              <a:pPr defTabSz="439781">
+                <a:defRPr/>
+              </a:pPr>
+              <a:r>
+                <a:rPr lang="te-IN" sz="2300" dirty="0">
+                  <a:latin typeface="Ramabhadra" panose="02000600000000000000" pitchFamily="2" charset="0"/>
+                  <a:cs typeface="Ramabhadra" panose="02000600000000000000" pitchFamily="2" charset="0"/>
+                </a:rPr>
+                <a:t>ఎంత కష్టమొచ్చినా నిష్టూరమైననూ (2)</a:t>
+              </a:r>
+              <a:endParaRPr lang="en-IN" sz="2300" dirty="0">
                 <a:latin typeface="Ramabhadra" panose="02000600000000000000" pitchFamily="2" charset="0"/>
                 <a:cs typeface="Ramabhadra" panose="02000600000000000000" pitchFamily="2" charset="0"/>
               </a:endParaRPr>
@@ -4194,24 +4223,21 @@
               <a:pPr defTabSz="439781">
                 <a:defRPr/>
               </a:pPr>
-              <a:r>
-                <a:rPr lang="te-IN" sz="2200" dirty="0">
-                  <a:latin typeface="Ramabhadra" panose="02000600000000000000" pitchFamily="2" charset="0"/>
-                  <a:cs typeface="Ramabhadra" panose="02000600000000000000" pitchFamily="2" charset="0"/>
-                </a:rPr>
-                <a:t>పాప దాస్యములో చిక్కబడి యుండగా </a:t>
-              </a:r>
+              <a:endParaRPr lang="te-IN" sz="2300" dirty="0">
+                <a:latin typeface="Ramabhadra" panose="02000600000000000000" pitchFamily="2" charset="0"/>
+                <a:cs typeface="Ramabhadra" panose="02000600000000000000" pitchFamily="2" charset="0"/>
+              </a:endParaRPr>
             </a:p>
             <a:p>
               <a:pPr defTabSz="439781">
                 <a:defRPr/>
               </a:pPr>
               <a:r>
-                <a:rPr lang="te-IN" sz="2200" dirty="0">
-                  <a:latin typeface="Ramabhadra" panose="02000600000000000000" pitchFamily="2" charset="0"/>
-                  <a:cs typeface="Ramabhadra" panose="02000600000000000000" pitchFamily="2" charset="0"/>
-                </a:rPr>
-                <a:t>నను రక్షించెను నీకృప</a:t>
+                <a:rPr lang="te-IN" sz="2300" dirty="0">
+                  <a:latin typeface="Ramabhadra" panose="02000600000000000000" pitchFamily="2" charset="0"/>
+                  <a:cs typeface="Ramabhadra" panose="02000600000000000000" pitchFamily="2" charset="0"/>
+                </a:rPr>
+                <a:t>బ్రతుకు నావ పగిలినా కడలి పాలైననూ</a:t>
               </a:r>
             </a:p>
             <a:p>
@@ -4219,35 +4245,36 @@
                 <a:defRPr/>
               </a:pPr>
               <a:r>
-                <a:rPr lang="te-IN" sz="2200" dirty="0">
-                  <a:latin typeface="Ramabhadra" panose="02000600000000000000" pitchFamily="2" charset="0"/>
-                  <a:cs typeface="Ramabhadra" panose="02000600000000000000" pitchFamily="2" charset="0"/>
-                </a:rPr>
-                <a:t>రోగబలహీనతందునే కృంగి యుండగా</a:t>
-              </a:r>
+                <a:rPr lang="te-IN" sz="2300" dirty="0">
+                  <a:latin typeface="Ramabhadra" panose="02000600000000000000" pitchFamily="2" charset="0"/>
+                  <a:cs typeface="Ramabhadra" panose="02000600000000000000" pitchFamily="2" charset="0"/>
+                </a:rPr>
+                <a:t>అలలు ముంచి వేసినా ఆశలు అనగారినా (2)</a:t>
+              </a:r>
+              <a:endParaRPr lang="en-IN" sz="2300" dirty="0">
+                <a:latin typeface="Ramabhadra" panose="02000600000000000000" pitchFamily="2" charset="0"/>
+                <a:cs typeface="Ramabhadra" panose="02000600000000000000" pitchFamily="2" charset="0"/>
+              </a:endParaRPr>
             </a:p>
             <a:p>
               <a:pPr defTabSz="439781">
                 <a:defRPr/>
               </a:pPr>
-              <a:r>
-                <a:rPr lang="te-IN" sz="2200" dirty="0">
-                  <a:latin typeface="Ramabhadra" panose="02000600000000000000" pitchFamily="2" charset="0"/>
-                  <a:cs typeface="Ramabhadra" panose="02000600000000000000" pitchFamily="2" charset="0"/>
-                </a:rPr>
-                <a:t>నను స్వస్థపరచును నీకృప</a:t>
-              </a:r>
+              <a:endParaRPr lang="te-IN" sz="2300" dirty="0">
+                <a:latin typeface="Ramabhadra" panose="02000600000000000000" pitchFamily="2" charset="0"/>
+                <a:cs typeface="Ramabhadra" panose="02000600000000000000" pitchFamily="2" charset="0"/>
+              </a:endParaRPr>
             </a:p>
             <a:p>
               <a:pPr defTabSz="439781">
                 <a:defRPr/>
               </a:pPr>
               <a:r>
-                <a:rPr lang="te-IN" sz="2200" dirty="0">
-                  <a:latin typeface="Ramabhadra" panose="02000600000000000000" pitchFamily="2" charset="0"/>
-                  <a:cs typeface="Ramabhadra" panose="02000600000000000000" pitchFamily="2" charset="0"/>
-                </a:rPr>
-                <a:t>మారా వంటి జీవితం </a:t>
+                <a:rPr lang="te-IN" sz="2300" dirty="0">
+                  <a:latin typeface="Ramabhadra" panose="02000600000000000000" pitchFamily="2" charset="0"/>
+                  <a:cs typeface="Ramabhadra" panose="02000600000000000000" pitchFamily="2" charset="0"/>
+                </a:rPr>
+                <a:t>ఆస్తులన్నీ పోయినా అనాథగా మిగిలినా</a:t>
               </a:r>
             </a:p>
             <a:p>
@@ -4255,92 +4282,11 @@
                 <a:defRPr/>
               </a:pPr>
               <a:r>
-                <a:rPr lang="te-IN" sz="2200" dirty="0">
-                  <a:latin typeface="Ramabhadra" panose="02000600000000000000" pitchFamily="2" charset="0"/>
-                  <a:cs typeface="Ramabhadra" panose="02000600000000000000" pitchFamily="2" charset="0"/>
-                </a:rPr>
-                <a:t>మధురముగా మార్చెను నీ కృప</a:t>
-              </a:r>
-            </a:p>
-            <a:p>
-              <a:pPr defTabSz="439781">
-                <a:defRPr/>
-              </a:pPr>
-              <a:endParaRPr lang="te-IN" sz="2200" dirty="0">
-                <a:latin typeface="Ramabhadra" panose="02000600000000000000" pitchFamily="2" charset="0"/>
-                <a:cs typeface="Ramabhadra" panose="02000600000000000000" pitchFamily="2" charset="0"/>
-              </a:endParaRPr>
-            </a:p>
-            <a:p>
-              <a:pPr defTabSz="439781">
-                <a:defRPr/>
-              </a:pPr>
-              <a:r>
-                <a:rPr lang="te-IN" sz="2200" dirty="0">
-                  <a:latin typeface="Ramabhadra" panose="02000600000000000000" pitchFamily="2" charset="0"/>
-                  <a:cs typeface="Ramabhadra" panose="02000600000000000000" pitchFamily="2" charset="0"/>
-                </a:rPr>
-                <a:t>నా హీన స్థితిలో పడిపోయి ఉండగా</a:t>
-              </a:r>
-            </a:p>
-            <a:p>
-              <a:pPr defTabSz="439781">
-                <a:defRPr/>
-              </a:pPr>
-              <a:r>
-                <a:rPr lang="te-IN" sz="2200" dirty="0">
-                  <a:latin typeface="Ramabhadra" panose="02000600000000000000" pitchFamily="2" charset="0"/>
-                  <a:cs typeface="Ramabhadra" panose="02000600000000000000" pitchFamily="2" charset="0"/>
-                </a:rPr>
-                <a:t>నను లేవనెత్తేను నీ కృప</a:t>
-              </a:r>
-            </a:p>
-            <a:p>
-              <a:pPr defTabSz="439781">
-                <a:defRPr/>
-              </a:pPr>
-              <a:r>
-                <a:rPr lang="te-IN" sz="2200" dirty="0">
-                  <a:latin typeface="Ramabhadra" panose="02000600000000000000" pitchFamily="2" charset="0"/>
-                  <a:cs typeface="Ramabhadra" panose="02000600000000000000" pitchFamily="2" charset="0"/>
-                </a:rPr>
-                <a:t>ఆదరించు వారు లేక అలసియున్న నన్ను </a:t>
-              </a:r>
-            </a:p>
-            <a:p>
-              <a:pPr defTabSz="439781">
-                <a:defRPr/>
-              </a:pPr>
-              <a:r>
-                <a:rPr lang="te-IN" sz="2200" dirty="0">
-                  <a:latin typeface="Ramabhadra" panose="02000600000000000000" pitchFamily="2" charset="0"/>
-                  <a:cs typeface="Ramabhadra" panose="02000600000000000000" pitchFamily="2" charset="0"/>
-                </a:rPr>
-                <a:t>ఆదరించెను నీ కృప</a:t>
-              </a:r>
-            </a:p>
-            <a:p>
-              <a:pPr defTabSz="439781">
-                <a:defRPr/>
-              </a:pPr>
-              <a:r>
-                <a:rPr lang="te-IN" sz="2200" dirty="0">
-                  <a:latin typeface="Ramabhadra" panose="02000600000000000000" pitchFamily="2" charset="0"/>
-                  <a:cs typeface="Ramabhadra" panose="02000600000000000000" pitchFamily="2" charset="0"/>
-                </a:rPr>
-                <a:t>మోడైన నా జీవితం </a:t>
-              </a:r>
-            </a:p>
-            <a:p>
-              <a:pPr defTabSz="439781">
-                <a:defRPr/>
-              </a:pPr>
-              <a:r>
-                <a:rPr lang="te-IN" sz="2200" dirty="0">
-                  <a:latin typeface="Ramabhadra" panose="02000600000000000000" pitchFamily="2" charset="0"/>
-                  <a:cs typeface="Ramabhadra" panose="02000600000000000000" pitchFamily="2" charset="0"/>
-                </a:rPr>
-                <a:t>చిగురింపజేసెను నీ కృప </a:t>
+                <a:rPr lang="te-IN" sz="2300" dirty="0">
+                  <a:latin typeface="Ramabhadra" panose="02000600000000000000" pitchFamily="2" charset="0"/>
+                  <a:cs typeface="Ramabhadra" panose="02000600000000000000" pitchFamily="2" charset="0"/>
+                </a:rPr>
+                <a:t>ఆప్తులే విడనాడినా ఆరోగ్యం క్షీణించినా (2) </a:t>
               </a:r>
             </a:p>
           </p:txBody>

</xml_diff>

<commit_message>
05 sunday songs 2025 jan
</commit_message>
<xml_diff>
--- a/songsTemplate.pptx
+++ b/songsTemplate.pptx
@@ -255,7 +255,7 @@
           <a:p>
             <a:fld id="{F1102B08-ED9E-409F-B95F-09CAA1DAF6E0}" type="datetimeFigureOut">
               <a:rPr lang="en-IN" smtClean="0"/>
-              <a:t>28-12-2024</a:t>
+              <a:t>04-01-2025</a:t>
             </a:fld>
             <a:endParaRPr lang="en-IN"/>
           </a:p>
@@ -425,7 +425,7 @@
           <a:p>
             <a:fld id="{F1102B08-ED9E-409F-B95F-09CAA1DAF6E0}" type="datetimeFigureOut">
               <a:rPr lang="en-IN" smtClean="0"/>
-              <a:t>28-12-2024</a:t>
+              <a:t>04-01-2025</a:t>
             </a:fld>
             <a:endParaRPr lang="en-IN"/>
           </a:p>
@@ -605,7 +605,7 @@
           <a:p>
             <a:fld id="{F1102B08-ED9E-409F-B95F-09CAA1DAF6E0}" type="datetimeFigureOut">
               <a:rPr lang="en-IN" smtClean="0"/>
-              <a:t>28-12-2024</a:t>
+              <a:t>04-01-2025</a:t>
             </a:fld>
             <a:endParaRPr lang="en-IN"/>
           </a:p>
@@ -775,7 +775,7 @@
           <a:p>
             <a:fld id="{F1102B08-ED9E-409F-B95F-09CAA1DAF6E0}" type="datetimeFigureOut">
               <a:rPr lang="en-IN" smtClean="0"/>
-              <a:t>28-12-2024</a:t>
+              <a:t>04-01-2025</a:t>
             </a:fld>
             <a:endParaRPr lang="en-IN"/>
           </a:p>
@@ -1019,7 +1019,7 @@
           <a:p>
             <a:fld id="{F1102B08-ED9E-409F-B95F-09CAA1DAF6E0}" type="datetimeFigureOut">
               <a:rPr lang="en-IN" smtClean="0"/>
-              <a:t>28-12-2024</a:t>
+              <a:t>04-01-2025</a:t>
             </a:fld>
             <a:endParaRPr lang="en-IN"/>
           </a:p>
@@ -1251,7 +1251,7 @@
           <a:p>
             <a:fld id="{F1102B08-ED9E-409F-B95F-09CAA1DAF6E0}" type="datetimeFigureOut">
               <a:rPr lang="en-IN" smtClean="0"/>
-              <a:t>28-12-2024</a:t>
+              <a:t>04-01-2025</a:t>
             </a:fld>
             <a:endParaRPr lang="en-IN"/>
           </a:p>
@@ -1618,7 +1618,7 @@
           <a:p>
             <a:fld id="{F1102B08-ED9E-409F-B95F-09CAA1DAF6E0}" type="datetimeFigureOut">
               <a:rPr lang="en-IN" smtClean="0"/>
-              <a:t>28-12-2024</a:t>
+              <a:t>04-01-2025</a:t>
             </a:fld>
             <a:endParaRPr lang="en-IN"/>
           </a:p>
@@ -1736,7 +1736,7 @@
           <a:p>
             <a:fld id="{F1102B08-ED9E-409F-B95F-09CAA1DAF6E0}" type="datetimeFigureOut">
               <a:rPr lang="en-IN" smtClean="0"/>
-              <a:t>28-12-2024</a:t>
+              <a:t>04-01-2025</a:t>
             </a:fld>
             <a:endParaRPr lang="en-IN"/>
           </a:p>
@@ -1831,7 +1831,7 @@
           <a:p>
             <a:fld id="{F1102B08-ED9E-409F-B95F-09CAA1DAF6E0}" type="datetimeFigureOut">
               <a:rPr lang="en-IN" smtClean="0"/>
-              <a:t>28-12-2024</a:t>
+              <a:t>04-01-2025</a:t>
             </a:fld>
             <a:endParaRPr lang="en-IN"/>
           </a:p>
@@ -2108,7 +2108,7 @@
           <a:p>
             <a:fld id="{F1102B08-ED9E-409F-B95F-09CAA1DAF6E0}" type="datetimeFigureOut">
               <a:rPr lang="en-IN" smtClean="0"/>
-              <a:t>28-12-2024</a:t>
+              <a:t>04-01-2025</a:t>
             </a:fld>
             <a:endParaRPr lang="en-IN"/>
           </a:p>
@@ -2365,7 +2365,7 @@
           <a:p>
             <a:fld id="{F1102B08-ED9E-409F-B95F-09CAA1DAF6E0}" type="datetimeFigureOut">
               <a:rPr lang="en-IN" smtClean="0"/>
-              <a:t>28-12-2024</a:t>
+              <a:t>04-01-2025</a:t>
             </a:fld>
             <a:endParaRPr lang="en-IN"/>
           </a:p>
@@ -2578,7 +2578,7 @@
           <a:p>
             <a:fld id="{F1102B08-ED9E-409F-B95F-09CAA1DAF6E0}" type="datetimeFigureOut">
               <a:rPr lang="en-IN" smtClean="0"/>
-              <a:t>28-12-2024</a:t>
+              <a:t>04-01-2025</a:t>
             </a:fld>
             <a:endParaRPr lang="en-IN"/>
           </a:p>
@@ -3094,7 +3094,7 @@
                   <a:latin typeface="Ramabhadra" panose="02000600000000000000" pitchFamily="2" charset="0"/>
                   <a:cs typeface="Ramabhadra" panose="02000600000000000000" pitchFamily="2" charset="0"/>
                 </a:rPr>
-                <a:t>నా స్తుతుల పైన నివసించువాడా</a:t>
+                <a:t>ఈ దినం సదా నా యేసుకే సొంతం</a:t>
               </a:r>
             </a:p>
             <a:p>
@@ -3106,7 +3106,7 @@
                   <a:latin typeface="Ramabhadra" panose="02000600000000000000" pitchFamily="2" charset="0"/>
                   <a:cs typeface="Ramabhadra" panose="02000600000000000000" pitchFamily="2" charset="0"/>
                 </a:rPr>
-                <a:t>నా అంతరంగికుడా యేసయ్యా (2)</a:t>
+                <a:t>నా నాధుని ప్రసన్నత</a:t>
               </a:r>
             </a:p>
             <a:p>
@@ -3118,7 +3118,7 @@
                   <a:latin typeface="Ramabhadra" panose="02000600000000000000" pitchFamily="2" charset="0"/>
                   <a:cs typeface="Ramabhadra" panose="02000600000000000000" pitchFamily="2" charset="0"/>
                 </a:rPr>
-                <a:t>నీవు నా పక్షమై యున్నావు గనుకే</a:t>
+                <a:t>నా తోడ నడచును (2)</a:t>
               </a:r>
             </a:p>
             <a:p>
@@ -3130,7 +3130,19 @@
                   <a:latin typeface="Ramabhadra" panose="02000600000000000000" pitchFamily="2" charset="0"/>
                   <a:cs typeface="Ramabhadra" panose="02000600000000000000" pitchFamily="2" charset="0"/>
                 </a:rPr>
-                <a:t>జయమే జయమే ఎల్లవేళలా జయమే (2)</a:t>
+                <a:t>రానున్న కాలము – కలత నివ్వదు (2)</a:t>
+              </a:r>
+            </a:p>
+            <a:p>
+              <a:pPr defTabSz="439781">
+                <a:defRPr/>
+              </a:pPr>
+              <a:r>
+                <a:rPr lang="te-IN" sz="2200" dirty="0">
+                  <a:latin typeface="Ramabhadra" panose="02000600000000000000" pitchFamily="2" charset="0"/>
+                  <a:cs typeface="Ramabhadra" panose="02000600000000000000" pitchFamily="2" charset="0"/>
+                </a:rPr>
+                <a:t>నా మంచి కాపరీ సదా – నన్ను నడుపును</a:t>
               </a:r>
             </a:p>
             <a:p>
@@ -3151,12 +3163,8 @@
                   <a:latin typeface="Ramabhadra" panose="02000600000000000000" pitchFamily="2" charset="0"/>
                   <a:cs typeface="Ramabhadra" panose="02000600000000000000" pitchFamily="2" charset="0"/>
                 </a:rPr>
-                <a:t>నన్ను నిర్మించిన రీతి తలచగా –</a:t>
-              </a:r>
-              <a:endParaRPr lang="en-IN" sz="2200" dirty="0">
-                <a:latin typeface="Ramabhadra" panose="02000600000000000000" pitchFamily="2" charset="0"/>
-                <a:cs typeface="Ramabhadra" panose="02000600000000000000" pitchFamily="2" charset="0"/>
-              </a:endParaRPr>
+                <a:t>ఎడారులు లోయలు ఎదురు నిలచినా</a:t>
+              </a:r>
             </a:p>
             <a:p>
               <a:pPr defTabSz="439781">
@@ -3167,7 +3175,7 @@
                   <a:latin typeface="Ramabhadra" panose="02000600000000000000" pitchFamily="2" charset="0"/>
                   <a:cs typeface="Ramabhadra" panose="02000600000000000000" pitchFamily="2" charset="0"/>
                 </a:rPr>
-                <a:t>ఎంతో ఆశ్చర్యమే</a:t>
+                <a:t>ఎన్నడెవరు నడువని బాటయైనను (2)</a:t>
               </a:r>
             </a:p>
             <a:p>
@@ -3179,7 +3187,7 @@
                   <a:latin typeface="Ramabhadra" panose="02000600000000000000" pitchFamily="2" charset="0"/>
                   <a:cs typeface="Ramabhadra" panose="02000600000000000000" pitchFamily="2" charset="0"/>
                 </a:rPr>
-                <a:t>అది నా ఊహకే వింతైనది (2)</a:t>
+                <a:t>వెరవదెన్నడైనను నాదు హృదయము (2)</a:t>
               </a:r>
             </a:p>
             <a:p>
@@ -3191,19 +3199,21 @@
                   <a:latin typeface="Ramabhadra" panose="02000600000000000000" pitchFamily="2" charset="0"/>
                   <a:cs typeface="Ramabhadra" panose="02000600000000000000" pitchFamily="2" charset="0"/>
                 </a:rPr>
-                <a:t>ఎరుపెక్కిన శత్రువుల చూపు నుండి తప్పించి</a:t>
-              </a:r>
-            </a:p>
-            <a:p>
-              <a:pPr defTabSz="439781">
-                <a:defRPr/>
-              </a:pPr>
+                <a:t>గాయపడిన యేసుపాదం</a:t>
+              </a:r>
+              <a:r>
+                <a:rPr lang="en-IN" sz="2200" dirty="0">
+                  <a:latin typeface="Ramabhadra" panose="02000600000000000000" pitchFamily="2" charset="0"/>
+                  <a:cs typeface="Ramabhadra" panose="02000600000000000000" pitchFamily="2" charset="0"/>
+                </a:rPr>
+                <a:t> </a:t>
+              </a:r>
               <a:r>
                 <a:rPr lang="te-IN" sz="2200" dirty="0">
                   <a:latin typeface="Ramabhadra" panose="02000600000000000000" pitchFamily="2" charset="0"/>
                   <a:cs typeface="Ramabhadra" panose="02000600000000000000" pitchFamily="2" charset="0"/>
                 </a:rPr>
-                <a:t>ఎనలేని ప్రేమను నాపై కురిపించావు (2)</a:t>
+                <a:t>అందు నడచెను (2)</a:t>
               </a:r>
             </a:p>
             <a:p>
@@ -3224,7 +3234,7 @@
                   <a:latin typeface="Ramabhadra" panose="02000600000000000000" pitchFamily="2" charset="0"/>
                   <a:cs typeface="Ramabhadra" panose="02000600000000000000" pitchFamily="2" charset="0"/>
                 </a:rPr>
-                <a:t>ద్రాక్షావల్లి అయిన నీలోనే - బహుగా వేరు పారగా</a:t>
+                <a:t>ప్రవాహం వోలె శోదకుండు ఎదురు వచ్చినా</a:t>
               </a:r>
             </a:p>
             <a:p>
@@ -3236,7 +3246,21 @@
                   <a:latin typeface="Ramabhadra" panose="02000600000000000000" pitchFamily="2" charset="0"/>
                   <a:cs typeface="Ramabhadra" panose="02000600000000000000" pitchFamily="2" charset="0"/>
                 </a:rPr>
-                <a:t>నీతో మధురమైన ఫలములీయనా (2)</a:t>
+                <a:t>యుద్ధకేక నా నోట యేసు నామమే</a:t>
+              </a:r>
+              <a:r>
+                <a:rPr lang="en-IN" sz="2200" dirty="0">
+                  <a:latin typeface="Ramabhadra" panose="02000600000000000000" pitchFamily="2" charset="0"/>
+                  <a:cs typeface="Ramabhadra" panose="02000600000000000000" pitchFamily="2" charset="0"/>
+                </a:rPr>
+                <a:t> </a:t>
+              </a:r>
+              <a:r>
+                <a:rPr lang="te-IN" sz="2200" dirty="0">
+                  <a:latin typeface="Ramabhadra" panose="02000600000000000000" pitchFamily="2" charset="0"/>
+                  <a:cs typeface="Ramabhadra" panose="02000600000000000000" pitchFamily="2" charset="0"/>
+                </a:rPr>
+                <a:t>(2)</a:t>
               </a:r>
             </a:p>
             <a:p>
@@ -3248,7 +3272,21 @@
                   <a:latin typeface="Ramabhadra" panose="02000600000000000000" pitchFamily="2" charset="0"/>
                   <a:cs typeface="Ramabhadra" panose="02000600000000000000" pitchFamily="2" charset="0"/>
                 </a:rPr>
-                <a:t>ఉన్నత స్థలములపై నాకు స్థానమిచ్చితివే</a:t>
+                <a:t>విరోదమైన ఆయుధాలు యేవి ఫలించవు</a:t>
+              </a:r>
+              <a:r>
+                <a:rPr lang="en-IN" sz="2200" dirty="0">
+                  <a:latin typeface="Ramabhadra" panose="02000600000000000000" pitchFamily="2" charset="0"/>
+                  <a:cs typeface="Ramabhadra" panose="02000600000000000000" pitchFamily="2" charset="0"/>
+                </a:rPr>
+                <a:t> </a:t>
+              </a:r>
+              <a:r>
+                <a:rPr lang="te-IN" sz="2200" dirty="0">
+                  <a:latin typeface="Ramabhadra" panose="02000600000000000000" pitchFamily="2" charset="0"/>
+                  <a:cs typeface="Ramabhadra" panose="02000600000000000000" pitchFamily="2" charset="0"/>
+                </a:rPr>
+                <a:t>(2)</a:t>
               </a:r>
             </a:p>
             <a:p>
@@ -3260,7 +3298,21 @@
                   <a:latin typeface="Ramabhadra" panose="02000600000000000000" pitchFamily="2" charset="0"/>
                   <a:cs typeface="Ramabhadra" panose="02000600000000000000" pitchFamily="2" charset="0"/>
                 </a:rPr>
-                <a:t>విజయుడా నీ కృప చాలును నా జీవితాన (2)</a:t>
+                <a:t>యెహోవా నిస్సియే నాదు విజయము</a:t>
+              </a:r>
+              <a:r>
+                <a:rPr lang="en-IN" sz="2200" dirty="0">
+                  <a:latin typeface="Ramabhadra" panose="02000600000000000000" pitchFamily="2" charset="0"/>
+                  <a:cs typeface="Ramabhadra" panose="02000600000000000000" pitchFamily="2" charset="0"/>
+                </a:rPr>
+                <a:t> </a:t>
+              </a:r>
+              <a:r>
+                <a:rPr lang="te-IN" sz="2200" dirty="0">
+                  <a:latin typeface="Ramabhadra" panose="02000600000000000000" pitchFamily="2" charset="0"/>
+                  <a:cs typeface="Ramabhadra" panose="02000600000000000000" pitchFamily="2" charset="0"/>
+                </a:rPr>
+                <a:t>(2)</a:t>
               </a:r>
             </a:p>
           </p:txBody>
@@ -3343,9 +3395,9 @@
         <p:grpSpPr>
           <a:xfrm>
             <a:off x="5104338" y="182031"/>
-            <a:ext cx="5693837" cy="6493935"/>
+            <a:ext cx="5650295" cy="6493935"/>
             <a:chOff x="160868" y="182032"/>
-            <a:chExt cx="5693837" cy="6493935"/>
+            <a:chExt cx="5650295" cy="6493935"/>
           </a:xfrm>
         </p:grpSpPr>
         <p:sp>
@@ -3417,8 +3469,8 @@
           </p:nvSpPr>
           <p:spPr>
             <a:xfrm>
-              <a:off x="240243" y="276251"/>
-              <a:ext cx="5614462" cy="6247864"/>
+              <a:off x="196701" y="276251"/>
+              <a:ext cx="5614462" cy="6001643"/>
             </a:xfrm>
             <a:prstGeom prst="rect">
               <a:avLst/>
@@ -3432,176 +3484,140 @@
             <a:lstStyle/>
             <a:p>
               <a:r>
-                <a:rPr lang="te-IN" sz="2000" dirty="0">
-                  <a:latin typeface="Ramabhadra" panose="02000600000000000000" pitchFamily="2" charset="0"/>
-                  <a:cs typeface="Ramabhadra" panose="02000600000000000000" pitchFamily="2" charset="0"/>
-                </a:rPr>
-                <a:t>యేసయ్యా .. నీ కృప నాకు చాలయ్యా.. </a:t>
-              </a:r>
-            </a:p>
-            <a:p>
-              <a:r>
-                <a:rPr lang="te-IN" sz="2000" dirty="0">
-                  <a:latin typeface="Ramabhadra" panose="02000600000000000000" pitchFamily="2" charset="0"/>
-                  <a:cs typeface="Ramabhadra" panose="02000600000000000000" pitchFamily="2" charset="0"/>
-                </a:rPr>
-                <a:t>నీ కృప లేనిదే నే బ్రతుకలేనయ్యా … </a:t>
-              </a:r>
-            </a:p>
-            <a:p>
-              <a:r>
-                <a:rPr lang="te-IN" sz="2000" dirty="0">
-                  <a:latin typeface="Ramabhadra" panose="02000600000000000000" pitchFamily="2" charset="0"/>
-                  <a:cs typeface="Ramabhadra" panose="02000600000000000000" pitchFamily="2" charset="0"/>
-                </a:rPr>
-                <a:t>నీ కృప లేని క్షణము – నీ దయ లేని క్షణము </a:t>
-              </a:r>
-            </a:p>
-            <a:p>
-              <a:r>
-                <a:rPr lang="te-IN" sz="2000" dirty="0">
-                  <a:latin typeface="Ramabhadra" panose="02000600000000000000" pitchFamily="2" charset="0"/>
-                  <a:cs typeface="Ramabhadra" panose="02000600000000000000" pitchFamily="2" charset="0"/>
-                </a:rPr>
-                <a:t>నేనూహించలేను యేసయ్యా.. (2)</a:t>
-              </a:r>
-            </a:p>
-            <a:p>
-              <a:r>
-                <a:rPr lang="te-IN" sz="2000" dirty="0">
-                  <a:latin typeface="Ramabhadra" panose="02000600000000000000" pitchFamily="2" charset="0"/>
-                  <a:cs typeface="Ramabhadra" panose="02000600000000000000" pitchFamily="2" charset="0"/>
-                </a:rPr>
-                <a:t>యేసయ్యా నీ కృప నాకు చాలయ్యా –</a:t>
-              </a:r>
-            </a:p>
-            <a:p>
-              <a:r>
-                <a:rPr lang="te-IN" sz="2000" dirty="0">
-                  <a:latin typeface="Ramabhadra" panose="02000600000000000000" pitchFamily="2" charset="0"/>
-                  <a:cs typeface="Ramabhadra" panose="02000600000000000000" pitchFamily="2" charset="0"/>
-                </a:rPr>
-                <a:t>నీ కృప లేనిదే నేనుండలేనయ్యా (2) నీ కృప</a:t>
-              </a:r>
-            </a:p>
-            <a:p>
-              <a:endParaRPr lang="te-IN" sz="2000" dirty="0">
+                <a:rPr lang="te-IN" sz="2400" dirty="0">
+                  <a:latin typeface="Ramabhadra" panose="02000600000000000000" pitchFamily="2" charset="0"/>
+                  <a:cs typeface="Ramabhadra" panose="02000600000000000000" pitchFamily="2" charset="0"/>
+                </a:rPr>
+                <a:t>సద్గుణ శీలుడా నీవే పూజ్యుడవు</a:t>
+              </a:r>
+            </a:p>
+            <a:p>
+              <a:r>
+                <a:rPr lang="te-IN" sz="2400" dirty="0">
+                  <a:latin typeface="Ramabhadra" panose="02000600000000000000" pitchFamily="2" charset="0"/>
+                  <a:cs typeface="Ramabhadra" panose="02000600000000000000" pitchFamily="2" charset="0"/>
+                </a:rPr>
+                <a:t>స్తుతి ఆరాధనకు నీవే యోగ్యుడవు</a:t>
+              </a:r>
+            </a:p>
+            <a:p>
+              <a:r>
+                <a:rPr lang="te-IN" sz="2400" dirty="0">
+                  <a:latin typeface="Ramabhadra" panose="02000600000000000000" pitchFamily="2" charset="0"/>
+                  <a:cs typeface="Ramabhadra" panose="02000600000000000000" pitchFamily="2" charset="0"/>
+                </a:rPr>
+                <a:t>సత్య ప్రమాణముతో శాశ్వత కృపనిచ్చి</a:t>
+              </a:r>
+            </a:p>
+            <a:p>
+              <a:r>
+                <a:rPr lang="te-IN" sz="2400" dirty="0">
+                  <a:latin typeface="Ramabhadra" panose="02000600000000000000" pitchFamily="2" charset="0"/>
+                  <a:cs typeface="Ramabhadra" panose="02000600000000000000" pitchFamily="2" charset="0"/>
+                </a:rPr>
+                <a:t>నీ ప్రియుని స్వాస్థ్యము నాకిచ్చితివి</a:t>
+              </a:r>
+            </a:p>
+            <a:p>
+              <a:r>
+                <a:rPr lang="te-IN" sz="2400" dirty="0">
+                  <a:latin typeface="Ramabhadra" panose="02000600000000000000" pitchFamily="2" charset="0"/>
+                  <a:cs typeface="Ramabhadra" panose="02000600000000000000" pitchFamily="2" charset="0"/>
+                </a:rPr>
+                <a:t>యేసయ్యా నీ సంకల్పమే</a:t>
+              </a:r>
+            </a:p>
+            <a:p>
+              <a:r>
+                <a:rPr lang="te-IN" sz="2400" dirty="0">
+                  <a:latin typeface="Ramabhadra" panose="02000600000000000000" pitchFamily="2" charset="0"/>
+                  <a:cs typeface="Ramabhadra" panose="02000600000000000000" pitchFamily="2" charset="0"/>
+                </a:rPr>
+                <a:t>ఇది నాపై నీకున్న అనురాగమే</a:t>
+              </a:r>
+            </a:p>
+            <a:p>
+              <a:endParaRPr lang="te-IN" sz="2400" dirty="0">
                 <a:latin typeface="Ramabhadra" panose="02000600000000000000" pitchFamily="2" charset="0"/>
                 <a:cs typeface="Ramabhadra" panose="02000600000000000000" pitchFamily="2" charset="0"/>
               </a:endParaRPr>
             </a:p>
             <a:p>
               <a:r>
-                <a:rPr lang="te-IN" sz="2000" dirty="0">
-                  <a:latin typeface="Ramabhadra" panose="02000600000000000000" pitchFamily="2" charset="0"/>
-                  <a:cs typeface="Ramabhadra" panose="02000600000000000000" pitchFamily="2" charset="0"/>
-                </a:rPr>
-                <a:t>మహిమను విడిచి – మహిలోకి దిగివచ్చి </a:t>
-              </a:r>
-            </a:p>
-            <a:p>
-              <a:r>
-                <a:rPr lang="te-IN" sz="2000" dirty="0">
-                  <a:latin typeface="Ramabhadra" panose="02000600000000000000" pitchFamily="2" charset="0"/>
-                  <a:cs typeface="Ramabhadra" panose="02000600000000000000" pitchFamily="2" charset="0"/>
-                </a:rPr>
-                <a:t>మార్గముగా మారి – మనిషిగ మార్చావు </a:t>
-              </a:r>
-            </a:p>
-            <a:p>
-              <a:r>
-                <a:rPr lang="te-IN" sz="2000" dirty="0">
-                  <a:latin typeface="Ramabhadra" panose="02000600000000000000" pitchFamily="2" charset="0"/>
-                  <a:cs typeface="Ramabhadra" panose="02000600000000000000" pitchFamily="2" charset="0"/>
-                </a:rPr>
-                <a:t>మహినే నీవు మాధుర్యముగ మార్చి </a:t>
-              </a:r>
-            </a:p>
-            <a:p>
-              <a:r>
-                <a:rPr lang="te-IN" sz="2000" dirty="0">
-                  <a:latin typeface="Ramabhadra" panose="02000600000000000000" pitchFamily="2" charset="0"/>
-                  <a:cs typeface="Ramabhadra" panose="02000600000000000000" pitchFamily="2" charset="0"/>
-                </a:rPr>
-                <a:t>మాదిరి చూపి మరు రూపమిచ్చావు(2)</a:t>
-              </a:r>
-            </a:p>
-            <a:p>
-              <a:r>
-                <a:rPr lang="te-IN" sz="2000" dirty="0">
-                  <a:latin typeface="Ramabhadra" panose="02000600000000000000" pitchFamily="2" charset="0"/>
-                  <a:cs typeface="Ramabhadra" panose="02000600000000000000" pitchFamily="2" charset="0"/>
-                </a:rPr>
-                <a:t>మహిమలో నేను మహిమను పొంద </a:t>
-              </a:r>
-            </a:p>
-            <a:p>
-              <a:r>
-                <a:rPr lang="te-IN" sz="2000" dirty="0">
-                  <a:latin typeface="Ramabhadra" panose="02000600000000000000" pitchFamily="2" charset="0"/>
-                  <a:cs typeface="Ramabhadra" panose="02000600000000000000" pitchFamily="2" charset="0"/>
-                </a:rPr>
-                <a:t>మహిమగ మార్చింది నీకృప (2) యేసయ్యా నీ కృప</a:t>
-              </a:r>
-            </a:p>
-            <a:p>
-              <a:endParaRPr lang="te-IN" sz="2000" dirty="0">
+                <a:rPr lang="te-IN" sz="2400" dirty="0">
+                  <a:latin typeface="Ramabhadra" panose="02000600000000000000" pitchFamily="2" charset="0"/>
+                  <a:cs typeface="Ramabhadra" panose="02000600000000000000" pitchFamily="2" charset="0"/>
+                </a:rPr>
+                <a:t>సిలువ సునాదమును నా శ్రమదినమున</a:t>
+              </a:r>
+            </a:p>
+            <a:p>
+              <a:r>
+                <a:rPr lang="te-IN" sz="2400" dirty="0">
+                  <a:latin typeface="Ramabhadra" panose="02000600000000000000" pitchFamily="2" charset="0"/>
+                  <a:cs typeface="Ramabhadra" panose="02000600000000000000" pitchFamily="2" charset="0"/>
+                </a:rPr>
+                <a:t>మధుర గీతికగా మదిలో వినిపించి</a:t>
+              </a:r>
+            </a:p>
+            <a:p>
+              <a:r>
+                <a:rPr lang="te-IN" sz="2400" dirty="0">
+                  <a:latin typeface="Ramabhadra" panose="02000600000000000000" pitchFamily="2" charset="0"/>
+                  <a:cs typeface="Ramabhadra" panose="02000600000000000000" pitchFamily="2" charset="0"/>
+                </a:rPr>
+                <a:t>సిలువలో దాగిన సర్వసంపదలిచ్చి</a:t>
+              </a:r>
+            </a:p>
+            <a:p>
+              <a:r>
+                <a:rPr lang="te-IN" sz="2400" dirty="0">
+                  <a:latin typeface="Ramabhadra" panose="02000600000000000000" pitchFamily="2" charset="0"/>
+                  <a:cs typeface="Ramabhadra" panose="02000600000000000000" pitchFamily="2" charset="0"/>
+                </a:rPr>
+                <a:t>కాంతిమయముగా కనపరచితివే నీ ఆత్మ శక్తితో</a:t>
+              </a:r>
+            </a:p>
+            <a:p>
+              <a:endParaRPr lang="te-IN" sz="2400" dirty="0">
                 <a:latin typeface="Ramabhadra" panose="02000600000000000000" pitchFamily="2" charset="0"/>
                 <a:cs typeface="Ramabhadra" panose="02000600000000000000" pitchFamily="2" charset="0"/>
               </a:endParaRPr>
             </a:p>
             <a:p>
               <a:r>
-                <a:rPr lang="te-IN" sz="2000" dirty="0">
-                  <a:latin typeface="Ramabhadra" panose="02000600000000000000" pitchFamily="2" charset="0"/>
-                  <a:cs typeface="Ramabhadra" panose="02000600000000000000" pitchFamily="2" charset="0"/>
-                </a:rPr>
-                <a:t>ఆజ్ఞల మార్గమున ఆశ్రయమును ఇచ్చి </a:t>
-              </a:r>
-            </a:p>
-            <a:p>
-              <a:r>
-                <a:rPr lang="te-IN" sz="2000" dirty="0">
-                  <a:latin typeface="Ramabhadra" panose="02000600000000000000" pitchFamily="2" charset="0"/>
-                  <a:cs typeface="Ramabhadra" panose="02000600000000000000" pitchFamily="2" charset="0"/>
-                </a:rPr>
-                <a:t>ఆపత్కాలమున ఆదుకొన్నావు </a:t>
-              </a:r>
-            </a:p>
-            <a:p>
-              <a:r>
-                <a:rPr lang="te-IN" sz="2000" dirty="0">
-                  <a:latin typeface="Ramabhadra" panose="02000600000000000000" pitchFamily="2" charset="0"/>
-                  <a:cs typeface="Ramabhadra" panose="02000600000000000000" pitchFamily="2" charset="0"/>
-                </a:rPr>
-                <a:t>ఆత్మీయులతో – ఆనందింపజేసి </a:t>
-              </a:r>
-            </a:p>
-            <a:p>
-              <a:r>
-                <a:rPr lang="te-IN" sz="2000" dirty="0">
-                  <a:latin typeface="Ramabhadra" panose="02000600000000000000" pitchFamily="2" charset="0"/>
-                  <a:cs typeface="Ramabhadra" panose="02000600000000000000" pitchFamily="2" charset="0"/>
-                </a:rPr>
-                <a:t>ఆనంద తైలముతో – అభిషేకించావు  (2)</a:t>
-              </a:r>
-            </a:p>
-            <a:p>
-              <a:r>
-                <a:rPr lang="te-IN" sz="2000" dirty="0">
-                  <a:latin typeface="Ramabhadra" panose="02000600000000000000" pitchFamily="2" charset="0"/>
-                  <a:cs typeface="Ramabhadra" panose="02000600000000000000" pitchFamily="2" charset="0"/>
-                </a:rPr>
-                <a:t>నా ఆశతీర ఆరాధన చేసే </a:t>
-              </a:r>
-            </a:p>
-            <a:p>
-              <a:r>
-                <a:rPr lang="te-IN" sz="2000" dirty="0">
-                  <a:latin typeface="Ramabhadra" panose="02000600000000000000" pitchFamily="2" charset="0"/>
-                  <a:cs typeface="Ramabhadra" panose="02000600000000000000" pitchFamily="2" charset="0"/>
-                </a:rPr>
-                <a:t>అదృష్టమిచ్చింది నీ కృప (2)యేసయ్యా నీ కృప</a:t>
+                <a:rPr lang="te-IN" sz="2400" dirty="0">
+                  <a:latin typeface="Ramabhadra" panose="02000600000000000000" pitchFamily="2" charset="0"/>
+                  <a:cs typeface="Ramabhadra" panose="02000600000000000000" pitchFamily="2" charset="0"/>
+                </a:rPr>
+                <a:t>నాతోడు నీడవై మరపురాని</a:t>
+              </a:r>
+            </a:p>
+            <a:p>
+              <a:r>
+                <a:rPr lang="te-IN" sz="2400" dirty="0">
+                  <a:latin typeface="Ramabhadra" panose="02000600000000000000" pitchFamily="2" charset="0"/>
+                  <a:cs typeface="Ramabhadra" panose="02000600000000000000" pitchFamily="2" charset="0"/>
+                </a:rPr>
+                <a:t>మహోప కార్యములు నాకై చేసి</a:t>
+              </a:r>
+            </a:p>
+            <a:p>
+              <a:r>
+                <a:rPr lang="te-IN" sz="2400" dirty="0">
+                  <a:latin typeface="Ramabhadra" panose="02000600000000000000" pitchFamily="2" charset="0"/>
+                  <a:cs typeface="Ramabhadra" panose="02000600000000000000" pitchFamily="2" charset="0"/>
+                </a:rPr>
+                <a:t>చీకటి దాచిన -వేకువగా మార్చి</a:t>
+              </a:r>
+            </a:p>
+            <a:p>
+              <a:r>
+                <a:rPr lang="te-IN" sz="2400" dirty="0">
+                  <a:latin typeface="Ramabhadra" panose="02000600000000000000" pitchFamily="2" charset="0"/>
+                  <a:cs typeface="Ramabhadra" panose="02000600000000000000" pitchFamily="2" charset="0"/>
+                </a:rPr>
+                <a:t>బలమైన జనముగా నిర్దారించితివి నీ కీర్తి కొరకే</a:t>
               </a:r>
             </a:p>
           </p:txBody>
@@ -3714,9 +3730,9 @@
         <p:grpSpPr>
           <a:xfrm>
             <a:off x="160868" y="182032"/>
-            <a:ext cx="4795835" cy="6493935"/>
+            <a:ext cx="5506736" cy="6493935"/>
             <a:chOff x="160868" y="182032"/>
-            <a:chExt cx="4795835" cy="6493935"/>
+            <a:chExt cx="5506736" cy="6493935"/>
           </a:xfrm>
         </p:grpSpPr>
         <p:sp>
@@ -3788,8 +3804,8 @@
           </p:nvSpPr>
           <p:spPr>
             <a:xfrm>
-              <a:off x="308503" y="768683"/>
-              <a:ext cx="4648200" cy="5262979"/>
+              <a:off x="271993" y="352014"/>
+              <a:ext cx="5395611" cy="5755422"/>
             </a:xfrm>
             <a:prstGeom prst="rect">
               <a:avLst/>
@@ -3806,11 +3822,11 @@
                 <a:defRPr/>
               </a:pPr>
               <a:r>
-                <a:rPr lang="te-IN" sz="2400" dirty="0">
-                  <a:latin typeface="Ramabhadra" panose="02000600000000000000" pitchFamily="2" charset="0"/>
-                  <a:cs typeface="Ramabhadra" panose="02000600000000000000" pitchFamily="2" charset="0"/>
-                </a:rPr>
-                <a:t>నజరేయుడా నా యేసయ్య</a:t>
+                <a:rPr lang="te-IN" sz="2300" dirty="0">
+                  <a:latin typeface="Ramabhadra" panose="02000600000000000000" pitchFamily="2" charset="0"/>
+                  <a:cs typeface="Ramabhadra" panose="02000600000000000000" pitchFamily="2" charset="0"/>
+                </a:rPr>
+                <a:t>కృపా సత్య సంపూర్ణుడా</a:t>
               </a:r>
             </a:p>
             <a:p>
@@ -3818,11 +3834,11 @@
                 <a:defRPr/>
               </a:pPr>
               <a:r>
-                <a:rPr lang="te-IN" sz="2400" dirty="0">
-                  <a:latin typeface="Ramabhadra" panose="02000600000000000000" pitchFamily="2" charset="0"/>
-                  <a:cs typeface="Ramabhadra" panose="02000600000000000000" pitchFamily="2" charset="0"/>
-                </a:rPr>
-                <a:t>ఎన్ని యుగాలకైనా</a:t>
+                <a:rPr lang="te-IN" sz="2300" dirty="0">
+                  <a:latin typeface="Ramabhadra" panose="02000600000000000000" pitchFamily="2" charset="0"/>
+                  <a:cs typeface="Ramabhadra" panose="02000600000000000000" pitchFamily="2" charset="0"/>
+                </a:rPr>
+                <a:t>సర్వలోకానికే చక్రవర్తివి నీవే యేసయ్యా -2</a:t>
               </a:r>
             </a:p>
             <a:p>
@@ -3830,11 +3846,11 @@
                 <a:defRPr/>
               </a:pPr>
               <a:r>
-                <a:rPr lang="te-IN" sz="2400" dirty="0">
-                  <a:latin typeface="Ramabhadra" panose="02000600000000000000" pitchFamily="2" charset="0"/>
-                  <a:cs typeface="Ramabhadra" panose="02000600000000000000" pitchFamily="2" charset="0"/>
-                </a:rPr>
-                <a:t>ఆరాధ్య దైవము నీవేనని</a:t>
+                <a:rPr lang="te-IN" sz="2300" dirty="0">
+                  <a:latin typeface="Ramabhadra" panose="02000600000000000000" pitchFamily="2" charset="0"/>
+                  <a:cs typeface="Ramabhadra" panose="02000600000000000000" pitchFamily="2" charset="0"/>
+                </a:rPr>
+                <a:t>నా సన్మానానికే మహనీయుడవు నీవేనయా ... </a:t>
               </a:r>
             </a:p>
             <a:p>
@@ -3842,18 +3858,31 @@
                 <a:defRPr/>
               </a:pPr>
               <a:r>
-                <a:rPr lang="te-IN" sz="2400" dirty="0">
-                  <a:latin typeface="Ramabhadra" panose="02000600000000000000" pitchFamily="2" charset="0"/>
-                  <a:cs typeface="Ramabhadra" panose="02000600000000000000" pitchFamily="2" charset="0"/>
-                </a:rPr>
-                <a:t>గళమెత్తి నీ కీర్తి నే చాటెద</a:t>
+                <a:rPr lang="te-IN" sz="2300" dirty="0">
+                  <a:latin typeface="Ramabhadra" panose="02000600000000000000" pitchFamily="2" charset="0"/>
+                  <a:cs typeface="Ramabhadra" panose="02000600000000000000" pitchFamily="2" charset="0"/>
+                </a:rPr>
+                <a:t>మహనీయుడవు నీవేనయా ... </a:t>
               </a:r>
             </a:p>
             <a:p>
               <a:pPr defTabSz="439781">
                 <a:defRPr/>
               </a:pPr>
-              <a:endParaRPr lang="te-IN" sz="2400" dirty="0">
+              <a:br>
+                <a:rPr lang="te-IN" sz="2300" dirty="0">
+                  <a:latin typeface="Ramabhadra" panose="02000600000000000000" pitchFamily="2" charset="0"/>
+                  <a:cs typeface="Ramabhadra" panose="02000600000000000000" pitchFamily="2" charset="0"/>
+                </a:rPr>
+              </a:br>
+              <a:r>
+                <a:rPr lang="te-IN" sz="2300" dirty="0">
+                  <a:latin typeface="Ramabhadra" panose="02000600000000000000" pitchFamily="2" charset="0"/>
+                  <a:cs typeface="Ramabhadra" panose="02000600000000000000" pitchFamily="2" charset="0"/>
+                </a:rPr>
+                <a:t>ఎర్ర సముద్రము నీ ఆజ్ఞ మేరకు</a:t>
+              </a:r>
+              <a:endParaRPr lang="en-IN" sz="2300" dirty="0">
                 <a:latin typeface="Ramabhadra" panose="02000600000000000000" pitchFamily="2" charset="0"/>
                 <a:cs typeface="Ramabhadra" panose="02000600000000000000" pitchFamily="2" charset="0"/>
               </a:endParaRPr>
@@ -3863,11 +3892,11 @@
                 <a:defRPr/>
               </a:pPr>
               <a:r>
-                <a:rPr lang="te-IN" sz="2400" dirty="0">
-                  <a:latin typeface="Ramabhadra" panose="02000600000000000000" pitchFamily="2" charset="0"/>
-                  <a:cs typeface="Ramabhadra" panose="02000600000000000000" pitchFamily="2" charset="0"/>
-                </a:rPr>
-                <a:t>ఆకాశ గగనాలను నీ జేనతో కొలిచితివి (2)</a:t>
+                <a:rPr lang="te-IN" sz="2300" dirty="0">
+                  <a:latin typeface="Ramabhadra" panose="02000600000000000000" pitchFamily="2" charset="0"/>
+                  <a:cs typeface="Ramabhadra" panose="02000600000000000000" pitchFamily="2" charset="0"/>
+                </a:rPr>
+                <a:t>రహదారిగా మారగా </a:t>
               </a:r>
             </a:p>
             <a:p>
@@ -3875,11 +3904,11 @@
                 <a:defRPr/>
               </a:pPr>
               <a:r>
-                <a:rPr lang="te-IN" sz="2400" dirty="0">
-                  <a:latin typeface="Ramabhadra" panose="02000600000000000000" pitchFamily="2" charset="0"/>
-                  <a:cs typeface="Ramabhadra" panose="02000600000000000000" pitchFamily="2" charset="0"/>
-                </a:rPr>
-                <a:t>శూన్యములో ఈ భూమిని</a:t>
+                <a:rPr lang="te-IN" sz="2300" dirty="0">
+                  <a:latin typeface="Ramabhadra" panose="02000600000000000000" pitchFamily="2" charset="0"/>
+                  <a:cs typeface="Ramabhadra" panose="02000600000000000000" pitchFamily="2" charset="0"/>
+                </a:rPr>
+                <a:t>దాటిరే నీ జనులు బహు క్షేమముగా -2</a:t>
               </a:r>
             </a:p>
             <a:p>
@@ -3887,30 +3916,61 @@
                 <a:defRPr/>
               </a:pPr>
               <a:r>
-                <a:rPr lang="te-IN" sz="2400" dirty="0">
-                  <a:latin typeface="Ramabhadra" panose="02000600000000000000" pitchFamily="2" charset="0"/>
-                  <a:cs typeface="Ramabhadra" panose="02000600000000000000" pitchFamily="2" charset="0"/>
-                </a:rPr>
-                <a:t>వ్రేలాడదీసిన నా యేసయ్య (2)</a:t>
-              </a:r>
+                <a:rPr lang="te-IN" sz="2300" dirty="0">
+                  <a:latin typeface="Ramabhadra" panose="02000600000000000000" pitchFamily="2" charset="0"/>
+                  <a:cs typeface="Ramabhadra" panose="02000600000000000000" pitchFamily="2" charset="0"/>
+                </a:rPr>
+                <a:t>ఆ జలములలోనే</a:t>
+              </a:r>
+              <a:endParaRPr lang="en-IN" sz="2300" dirty="0">
+                <a:latin typeface="Ramabhadra" panose="02000600000000000000" pitchFamily="2" charset="0"/>
+                <a:cs typeface="Ramabhadra" panose="02000600000000000000" pitchFamily="2" charset="0"/>
+              </a:endParaRPr>
             </a:p>
             <a:p>
               <a:pPr defTabSz="439781">
                 <a:defRPr/>
               </a:pPr>
               <a:r>
-                <a:rPr lang="te-IN" sz="2400" dirty="0">
-                  <a:latin typeface="Ramabhadra" panose="02000600000000000000" pitchFamily="2" charset="0"/>
-                  <a:cs typeface="Ramabhadra" panose="02000600000000000000" pitchFamily="2" charset="0"/>
-                </a:rPr>
-                <a:t>నీకే వందనం నీకే వందనం (2)</a:t>
+                <a:rPr lang="te-IN" sz="2300" dirty="0">
+                  <a:latin typeface="Ramabhadra" panose="02000600000000000000" pitchFamily="2" charset="0"/>
+                  <a:cs typeface="Ramabhadra" panose="02000600000000000000" pitchFamily="2" charset="0"/>
+                </a:rPr>
+                <a:t>శత్రు సైన్యము</a:t>
+              </a:r>
+              <a:r>
+                <a:rPr lang="en-IN" sz="2300" dirty="0">
+                  <a:latin typeface="Ramabhadra" panose="02000600000000000000" pitchFamily="2" charset="0"/>
+                  <a:cs typeface="Ramabhadra" panose="02000600000000000000" pitchFamily="2" charset="0"/>
+                </a:rPr>
+                <a:t> </a:t>
+              </a:r>
+              <a:r>
+                <a:rPr lang="te-IN" sz="2300" dirty="0">
+                  <a:latin typeface="Ramabhadra" panose="02000600000000000000" pitchFamily="2" charset="0"/>
+                  <a:cs typeface="Ramabhadra" panose="02000600000000000000" pitchFamily="2" charset="0"/>
+                </a:rPr>
+                <a:t>మునిగిపోయెనే - 2            </a:t>
               </a:r>
             </a:p>
             <a:p>
               <a:pPr defTabSz="439781">
                 <a:defRPr/>
               </a:pPr>
-              <a:endParaRPr lang="te-IN" sz="2400" dirty="0">
+              <a:br>
+                <a:rPr lang="te-IN" sz="2300" dirty="0">
+                  <a:latin typeface="Ramabhadra" panose="02000600000000000000" pitchFamily="2" charset="0"/>
+                  <a:cs typeface="Ramabhadra" panose="02000600000000000000" pitchFamily="2" charset="0"/>
+                </a:rPr>
+              </a:br>
+              <a:r>
+                <a:rPr lang="te-IN" sz="2300" dirty="0">
+                  <a:latin typeface="Ramabhadra" panose="02000600000000000000" pitchFamily="2" charset="0"/>
+                  <a:cs typeface="Ramabhadra" panose="02000600000000000000" pitchFamily="2" charset="0"/>
+                </a:rPr>
+                <a:t>నూతన క్రియను చేయుచున్నానని</a:t>
+              </a:r>
+              <a:endParaRPr lang="en-IN" sz="2300" dirty="0">
                 <a:latin typeface="Ramabhadra" panose="02000600000000000000" pitchFamily="2" charset="0"/>
                 <a:cs typeface="Ramabhadra" panose="02000600000000000000" pitchFamily="2" charset="0"/>
               </a:endParaRPr>
@@ -3920,11 +3980,11 @@
                 <a:defRPr/>
               </a:pPr>
               <a:r>
-                <a:rPr lang="te-IN" sz="2400" dirty="0">
-                  <a:latin typeface="Ramabhadra" panose="02000600000000000000" pitchFamily="2" charset="0"/>
-                  <a:cs typeface="Ramabhadra" panose="02000600000000000000" pitchFamily="2" charset="0"/>
-                </a:rPr>
-                <a:t>అగాధ సముద్రాలకు నీవే ఎల్లలు వేసితివి (2)</a:t>
+                <a:rPr lang="te-IN" sz="2300" dirty="0">
+                  <a:latin typeface="Ramabhadra" panose="02000600000000000000" pitchFamily="2" charset="0"/>
+                  <a:cs typeface="Ramabhadra" panose="02000600000000000000" pitchFamily="2" charset="0"/>
+                </a:rPr>
+                <a:t>నీవు సెలవీయ్యగా </a:t>
               </a:r>
             </a:p>
             <a:p>
@@ -3932,11 +3992,11 @@
                 <a:defRPr/>
               </a:pPr>
               <a:r>
-                <a:rPr lang="te-IN" sz="2400" dirty="0">
-                  <a:latin typeface="Ramabhadra" panose="02000600000000000000" pitchFamily="2" charset="0"/>
-                  <a:cs typeface="Ramabhadra" panose="02000600000000000000" pitchFamily="2" charset="0"/>
-                </a:rPr>
-                <a:t>జలములలోబడి నే వెళ్ళినా</a:t>
+                <a:rPr lang="te-IN" sz="2300" dirty="0">
+                  <a:latin typeface="Ramabhadra" panose="02000600000000000000" pitchFamily="2" charset="0"/>
+                  <a:cs typeface="Ramabhadra" panose="02000600000000000000" pitchFamily="2" charset="0"/>
+                </a:rPr>
+                <a:t>నా ఎడారి జీవితమే సుఖ సౌఖ్యము కాగా -2</a:t>
               </a:r>
             </a:p>
             <a:p>
@@ -3944,23 +4004,27 @@
                 <a:defRPr/>
               </a:pPr>
               <a:r>
-                <a:rPr lang="te-IN" sz="2400" dirty="0">
-                  <a:latin typeface="Ramabhadra" panose="02000600000000000000" pitchFamily="2" charset="0"/>
-                  <a:cs typeface="Ramabhadra" panose="02000600000000000000" pitchFamily="2" charset="0"/>
-                </a:rPr>
-                <a:t>నన్నేమి చేయవు నా యేసయ్యా (2)</a:t>
-              </a:r>
+                <a:rPr lang="te-IN" sz="2300" dirty="0">
+                  <a:latin typeface="Ramabhadra" panose="02000600000000000000" pitchFamily="2" charset="0"/>
+                  <a:cs typeface="Ramabhadra" panose="02000600000000000000" pitchFamily="2" charset="0"/>
+                </a:rPr>
+                <a:t>నా అరణ్య రోదన</a:t>
+              </a:r>
+              <a:endParaRPr lang="en-IN" sz="2300" dirty="0">
+                <a:latin typeface="Ramabhadra" panose="02000600000000000000" pitchFamily="2" charset="0"/>
+                <a:cs typeface="Ramabhadra" panose="02000600000000000000" pitchFamily="2" charset="0"/>
+              </a:endParaRPr>
             </a:p>
             <a:p>
               <a:pPr defTabSz="439781">
                 <a:defRPr/>
               </a:pPr>
               <a:r>
-                <a:rPr lang="te-IN" sz="2400" dirty="0">
-                  <a:latin typeface="Ramabhadra" panose="02000600000000000000" pitchFamily="2" charset="0"/>
-                  <a:cs typeface="Ramabhadra" panose="02000600000000000000" pitchFamily="2" charset="0"/>
-                </a:rPr>
-                <a:t>నీకే వందనం నీకే వందనం (2) </a:t>
+                <a:rPr lang="te-IN" sz="2300" dirty="0">
+                  <a:latin typeface="Ramabhadra" panose="02000600000000000000" pitchFamily="2" charset="0"/>
+                  <a:cs typeface="Ramabhadra" panose="02000600000000000000" pitchFamily="2" charset="0"/>
+                </a:rPr>
+                <a:t>ఉల్లాసముగా మారిపోయెనే - 2                    </a:t>
               </a:r>
             </a:p>
           </p:txBody>
@@ -3979,7 +4043,7 @@
           </p:nvSpPr>
           <p:spPr>
             <a:xfrm>
-              <a:off x="343961" y="326430"/>
+              <a:off x="4282546" y="320167"/>
               <a:ext cx="390525" cy="390525"/>
             </a:xfrm>
             <a:prstGeom prst="ellipse">
@@ -4043,9 +4107,9 @@
         <p:grpSpPr>
           <a:xfrm>
             <a:off x="5104338" y="182031"/>
-            <a:ext cx="4897436" cy="6493935"/>
+            <a:ext cx="4801662" cy="6493935"/>
             <a:chOff x="160868" y="182032"/>
-            <a:chExt cx="4897436" cy="6493935"/>
+            <a:chExt cx="4801662" cy="6493935"/>
           </a:xfrm>
         </p:grpSpPr>
         <p:sp>
@@ -4117,8 +4181,8 @@
           </p:nvSpPr>
           <p:spPr>
             <a:xfrm>
-              <a:off x="308503" y="521693"/>
-              <a:ext cx="4749801" cy="4693593"/>
+              <a:off x="212729" y="286334"/>
+              <a:ext cx="4749801" cy="5755422"/>
             </a:xfrm>
             <a:prstGeom prst="rect">
               <a:avLst/>
@@ -4139,154 +4203,175 @@
                   <a:latin typeface="Ramabhadra" panose="02000600000000000000" pitchFamily="2" charset="0"/>
                   <a:cs typeface="Ramabhadra" panose="02000600000000000000" pitchFamily="2" charset="0"/>
                 </a:rPr>
-                <a:t>నీవుంటే నాకు చాలు యేసయ్యా</a:t>
-              </a:r>
-            </a:p>
-            <a:p>
-              <a:pPr defTabSz="439781">
-                <a:defRPr/>
-              </a:pPr>
-              <a:r>
+                <a:t>నమ్మదగిన వాడవు సహయుడవు యెసయ్యా</a:t>
+              </a:r>
+              <a:br>
                 <a:rPr lang="te-IN" sz="2300" dirty="0">
                   <a:latin typeface="Ramabhadra" panose="02000600000000000000" pitchFamily="2" charset="0"/>
                   <a:cs typeface="Ramabhadra" panose="02000600000000000000" pitchFamily="2" charset="0"/>
                 </a:rPr>
-                <a:t>నీవెంటే నేను ఉంటానేసయ్యా (2)</a:t>
-              </a:r>
-            </a:p>
-            <a:p>
-              <a:pPr defTabSz="439781">
-                <a:defRPr/>
-              </a:pPr>
+              </a:br>
               <a:r>
                 <a:rPr lang="te-IN" sz="2300" dirty="0">
                   <a:latin typeface="Ramabhadra" panose="02000600000000000000" pitchFamily="2" charset="0"/>
                   <a:cs typeface="Ramabhadra" panose="02000600000000000000" pitchFamily="2" charset="0"/>
                 </a:rPr>
-                <a:t>నీ మాట చాలయ్యా నీ చూపు చాలయ్యా</a:t>
-              </a:r>
-            </a:p>
-            <a:p>
-              <a:pPr defTabSz="439781">
-                <a:defRPr/>
-              </a:pPr>
-              <a:r>
+                <a:t>ఆపత్కలములో ఆశ్రయమైనది నీవేనయ్యా</a:t>
+              </a:r>
+              <a:br>
                 <a:rPr lang="te-IN" sz="2300" dirty="0">
                   <a:latin typeface="Ramabhadra" panose="02000600000000000000" pitchFamily="2" charset="0"/>
                   <a:cs typeface="Ramabhadra" panose="02000600000000000000" pitchFamily="2" charset="0"/>
                 </a:rPr>
-                <a:t>నీ తోడు చాలయ్యా నీ నీడ చాలయ్యా (2)</a:t>
-              </a:r>
-              <a:endParaRPr lang="en-IN" sz="2300" dirty="0">
-                <a:latin typeface="Ramabhadra" panose="02000600000000000000" pitchFamily="2" charset="0"/>
-                <a:cs typeface="Ramabhadra" panose="02000600000000000000" pitchFamily="2" charset="0"/>
-              </a:endParaRPr>
-            </a:p>
-            <a:p>
-              <a:pPr defTabSz="439781">
-                <a:defRPr/>
-              </a:pPr>
-              <a:endParaRPr lang="te-IN" sz="2300" dirty="0">
-                <a:latin typeface="Ramabhadra" panose="02000600000000000000" pitchFamily="2" charset="0"/>
-                <a:cs typeface="Ramabhadra" panose="02000600000000000000" pitchFamily="2" charset="0"/>
-              </a:endParaRPr>
-            </a:p>
-            <a:p>
-              <a:pPr defTabSz="439781">
-                <a:defRPr/>
-              </a:pPr>
+              </a:br>
               <a:r>
                 <a:rPr lang="te-IN" sz="2300" dirty="0">
                   <a:latin typeface="Ramabhadra" panose="02000600000000000000" pitchFamily="2" charset="0"/>
                   <a:cs typeface="Ramabhadra" panose="02000600000000000000" pitchFamily="2" charset="0"/>
                 </a:rPr>
-                <a:t>ఎన్ని బాధలున్ననూ ఇబ్బందులైననూ</a:t>
-              </a:r>
-            </a:p>
-            <a:p>
-              <a:pPr defTabSz="439781">
-                <a:defRPr/>
-              </a:pPr>
-              <a:r>
+                <a:t>చెర నుండి విడిపించి చెలిమితో మంధించి</a:t>
+              </a:r>
+              <a:br>
                 <a:rPr lang="te-IN" sz="2300" dirty="0">
                   <a:latin typeface="Ramabhadra" panose="02000600000000000000" pitchFamily="2" charset="0"/>
                   <a:cs typeface="Ramabhadra" panose="02000600000000000000" pitchFamily="2" charset="0"/>
                 </a:rPr>
-                <a:t>ఎంత కష్టమొచ్చినా నిష్టూరమైననూ (2)</a:t>
-              </a:r>
-              <a:endParaRPr lang="en-IN" sz="2300" dirty="0">
-                <a:latin typeface="Ramabhadra" panose="02000600000000000000" pitchFamily="2" charset="0"/>
-                <a:cs typeface="Ramabhadra" panose="02000600000000000000" pitchFamily="2" charset="0"/>
-              </a:endParaRPr>
-            </a:p>
-            <a:p>
-              <a:pPr defTabSz="439781">
-                <a:defRPr/>
-              </a:pPr>
-              <a:endParaRPr lang="te-IN" sz="2300" dirty="0">
-                <a:latin typeface="Ramabhadra" panose="02000600000000000000" pitchFamily="2" charset="0"/>
-                <a:cs typeface="Ramabhadra" panose="02000600000000000000" pitchFamily="2" charset="0"/>
-              </a:endParaRPr>
-            </a:p>
-            <a:p>
-              <a:pPr defTabSz="439781">
-                <a:defRPr/>
-              </a:pPr>
+              </a:br>
               <a:r>
                 <a:rPr lang="te-IN" sz="2300" dirty="0">
                   <a:latin typeface="Ramabhadra" panose="02000600000000000000" pitchFamily="2" charset="0"/>
                   <a:cs typeface="Ramabhadra" panose="02000600000000000000" pitchFamily="2" charset="0"/>
                 </a:rPr>
-                <a:t>బ్రతుకు నావ పగిలినా కడలి పాలైననూ</a:t>
-              </a:r>
-            </a:p>
-            <a:p>
-              <a:pPr defTabSz="439781">
-                <a:defRPr/>
-              </a:pPr>
-              <a:r>
+                <a:t>నడిపించినావే మందవలె నీ స్వాస్ధ్యమును</a:t>
+              </a:r>
+              <a:br>
                 <a:rPr lang="te-IN" sz="2300" dirty="0">
                   <a:latin typeface="Ramabhadra" panose="02000600000000000000" pitchFamily="2" charset="0"/>
                   <a:cs typeface="Ramabhadra" panose="02000600000000000000" pitchFamily="2" charset="0"/>
                 </a:rPr>
-                <a:t>అలలు ముంచి వేసినా ఆశలు అనగారినా (2)</a:t>
-              </a:r>
-              <a:endParaRPr lang="en-IN" sz="2300" dirty="0">
-                <a:latin typeface="Ramabhadra" panose="02000600000000000000" pitchFamily="2" charset="0"/>
-                <a:cs typeface="Ramabhadra" panose="02000600000000000000" pitchFamily="2" charset="0"/>
-              </a:endParaRPr>
-            </a:p>
-            <a:p>
-              <a:pPr defTabSz="439781">
-                <a:defRPr/>
-              </a:pPr>
-              <a:endParaRPr lang="te-IN" sz="2300" dirty="0">
-                <a:latin typeface="Ramabhadra" panose="02000600000000000000" pitchFamily="2" charset="0"/>
-                <a:cs typeface="Ramabhadra" panose="02000600000000000000" pitchFamily="2" charset="0"/>
-              </a:endParaRPr>
-            </a:p>
-            <a:p>
-              <a:pPr defTabSz="439781">
-                <a:defRPr/>
-              </a:pPr>
-              <a:r>
+              </a:br>
+              <a:br>
                 <a:rPr lang="te-IN" sz="2300" dirty="0">
                   <a:latin typeface="Ramabhadra" panose="02000600000000000000" pitchFamily="2" charset="0"/>
                   <a:cs typeface="Ramabhadra" panose="02000600000000000000" pitchFamily="2" charset="0"/>
                 </a:rPr>
-                <a:t>ఆస్తులన్నీ పోయినా అనాథగా మిగిలినా</a:t>
-              </a:r>
-            </a:p>
-            <a:p>
-              <a:pPr defTabSz="439781">
-                <a:defRPr/>
-              </a:pPr>
+              </a:br>
               <a:r>
                 <a:rPr lang="te-IN" sz="2300" dirty="0">
                   <a:latin typeface="Ramabhadra" panose="02000600000000000000" pitchFamily="2" charset="0"/>
                   <a:cs typeface="Ramabhadra" panose="02000600000000000000" pitchFamily="2" charset="0"/>
                 </a:rPr>
-                <a:t>ఆప్తులే విడనాడినా ఆరోగ్యం క్షీణించినా (2) </a:t>
+                <a:t>నీ జనులకు నీవు న్యయాధిపతివైతివే శత్రువుల కోటలన్ని కూలిపొయెను</a:t>
+              </a:r>
+              <a:br>
+                <a:rPr lang="te-IN" sz="2300" dirty="0">
+                  <a:latin typeface="Ramabhadra" panose="02000600000000000000" pitchFamily="2" charset="0"/>
+                  <a:cs typeface="Ramabhadra" panose="02000600000000000000" pitchFamily="2" charset="0"/>
+                </a:rPr>
+              </a:br>
+              <a:r>
+                <a:rPr lang="te-IN" sz="2300" dirty="0">
+                  <a:latin typeface="Ramabhadra" panose="02000600000000000000" pitchFamily="2" charset="0"/>
+                  <a:cs typeface="Ramabhadra" panose="02000600000000000000" pitchFamily="2" charset="0"/>
+                </a:rPr>
+                <a:t>సంకెళ్ళ సంబరాలు మూగబోయెను</a:t>
+              </a:r>
+              <a:br>
+                <a:rPr lang="te-IN" sz="2300" dirty="0">
+                  <a:latin typeface="Ramabhadra" panose="02000600000000000000" pitchFamily="2" charset="0"/>
+                  <a:cs typeface="Ramabhadra" panose="02000600000000000000" pitchFamily="2" charset="0"/>
+                </a:rPr>
+              </a:br>
+              <a:r>
+                <a:rPr lang="te-IN" sz="2300" dirty="0">
+                  <a:latin typeface="Ramabhadra" panose="02000600000000000000" pitchFamily="2" charset="0"/>
+                  <a:cs typeface="Ramabhadra" panose="02000600000000000000" pitchFamily="2" charset="0"/>
+                </a:rPr>
+                <a:t>నీరిక్షణ కర్తవైన నిన్నే నమ్మిన ప్రజలు</a:t>
+              </a:r>
+              <a:br>
+                <a:rPr lang="te-IN" sz="2300" dirty="0">
+                  <a:latin typeface="Ramabhadra" panose="02000600000000000000" pitchFamily="2" charset="0"/>
+                  <a:cs typeface="Ramabhadra" panose="02000600000000000000" pitchFamily="2" charset="0"/>
+                </a:rPr>
+              </a:br>
+              <a:r>
+                <a:rPr lang="te-IN" sz="2300" dirty="0">
+                  <a:latin typeface="Ramabhadra" panose="02000600000000000000" pitchFamily="2" charset="0"/>
+                  <a:cs typeface="Ramabhadra" panose="02000600000000000000" pitchFamily="2" charset="0"/>
+                </a:rPr>
+                <a:t>నిత్యనంద భరితులై సీయోను కు తిరిగి వచ్చెను</a:t>
+              </a:r>
+              <a:br>
+                <a:rPr lang="te-IN" sz="2300" dirty="0">
+                  <a:latin typeface="Ramabhadra" panose="02000600000000000000" pitchFamily="2" charset="0"/>
+                  <a:cs typeface="Ramabhadra" panose="02000600000000000000" pitchFamily="2" charset="0"/>
+                </a:rPr>
+              </a:br>
+              <a:br>
+                <a:rPr lang="te-IN" sz="2300" dirty="0">
+                  <a:latin typeface="Ramabhadra" panose="02000600000000000000" pitchFamily="2" charset="0"/>
+                  <a:cs typeface="Ramabhadra" panose="02000600000000000000" pitchFamily="2" charset="0"/>
+                </a:rPr>
+              </a:br>
+              <a:r>
+                <a:rPr lang="te-IN" sz="2300" dirty="0">
+                  <a:latin typeface="Ramabhadra" panose="02000600000000000000" pitchFamily="2" charset="0"/>
+                  <a:cs typeface="Ramabhadra" panose="02000600000000000000" pitchFamily="2" charset="0"/>
+                </a:rPr>
+                <a:t>నీ ప్రియులను నీవు కాపాడే మంచి కాపరి</a:t>
+              </a:r>
+              <a:br>
+                <a:rPr lang="te-IN" sz="2300" dirty="0">
+                  <a:latin typeface="Ramabhadra" panose="02000600000000000000" pitchFamily="2" charset="0"/>
+                  <a:cs typeface="Ramabhadra" panose="02000600000000000000" pitchFamily="2" charset="0"/>
+                </a:rPr>
+              </a:br>
+              <a:r>
+                <a:rPr lang="te-IN" sz="2300" dirty="0">
+                  <a:latin typeface="Ramabhadra" panose="02000600000000000000" pitchFamily="2" charset="0"/>
+                  <a:cs typeface="Ramabhadra" panose="02000600000000000000" pitchFamily="2" charset="0"/>
+                </a:rPr>
+                <a:t>జఠిలమైన త్రోవలన్ని దాటించితివి</a:t>
+              </a:r>
+              <a:br>
+                <a:rPr lang="te-IN" sz="2300" dirty="0">
+                  <a:latin typeface="Ramabhadra" panose="02000600000000000000" pitchFamily="2" charset="0"/>
+                  <a:cs typeface="Ramabhadra" panose="02000600000000000000" pitchFamily="2" charset="0"/>
+                </a:rPr>
+              </a:br>
+              <a:r>
+                <a:rPr lang="te-IN" sz="2300" dirty="0">
+                  <a:latin typeface="Ramabhadra" panose="02000600000000000000" pitchFamily="2" charset="0"/>
+                  <a:cs typeface="Ramabhadra" panose="02000600000000000000" pitchFamily="2" charset="0"/>
+                </a:rPr>
+                <a:t>సమృద్ధి జీవముతో పోషించితివి</a:t>
+              </a:r>
+              <a:br>
+                <a:rPr lang="te-IN" sz="2300" dirty="0">
+                  <a:latin typeface="Ramabhadra" panose="02000600000000000000" pitchFamily="2" charset="0"/>
+                  <a:cs typeface="Ramabhadra" panose="02000600000000000000" pitchFamily="2" charset="0"/>
+                </a:rPr>
+              </a:br>
+              <a:r>
+                <a:rPr lang="te-IN" sz="2300" dirty="0">
+                  <a:latin typeface="Ramabhadra" panose="02000600000000000000" pitchFamily="2" charset="0"/>
+                  <a:cs typeface="Ramabhadra" panose="02000600000000000000" pitchFamily="2" charset="0"/>
+                </a:rPr>
+                <a:t>ఆలోచన కర్తవైన నీ స్వరమే వినగా</a:t>
+              </a:r>
+              <a:br>
+                <a:rPr lang="te-IN" sz="2300" dirty="0">
+                  <a:latin typeface="Ramabhadra" panose="02000600000000000000" pitchFamily="2" charset="0"/>
+                  <a:cs typeface="Ramabhadra" panose="02000600000000000000" pitchFamily="2" charset="0"/>
+                </a:rPr>
+              </a:br>
+              <a:r>
+                <a:rPr lang="te-IN" sz="2300" dirty="0">
+                  <a:latin typeface="Ramabhadra" panose="02000600000000000000" pitchFamily="2" charset="0"/>
+                  <a:cs typeface="Ramabhadra" panose="02000600000000000000" pitchFamily="2" charset="0"/>
+                </a:rPr>
+                <a:t>నిత్యాదరణను పొంది నీ క్రియలను వివరించెను</a:t>
               </a:r>
             </a:p>
           </p:txBody>

</xml_diff>

<commit_message>
12 jan 25 sunday
</commit_message>
<xml_diff>
--- a/songsTemplate.pptx
+++ b/songsTemplate.pptx
@@ -255,7 +255,7 @@
           <a:p>
             <a:fld id="{F1102B08-ED9E-409F-B95F-09CAA1DAF6E0}" type="datetimeFigureOut">
               <a:rPr lang="en-IN" smtClean="0"/>
-              <a:t>04-01-2025</a:t>
+              <a:t>11-01-2025</a:t>
             </a:fld>
             <a:endParaRPr lang="en-IN"/>
           </a:p>
@@ -425,7 +425,7 @@
           <a:p>
             <a:fld id="{F1102B08-ED9E-409F-B95F-09CAA1DAF6E0}" type="datetimeFigureOut">
               <a:rPr lang="en-IN" smtClean="0"/>
-              <a:t>04-01-2025</a:t>
+              <a:t>11-01-2025</a:t>
             </a:fld>
             <a:endParaRPr lang="en-IN"/>
           </a:p>
@@ -605,7 +605,7 @@
           <a:p>
             <a:fld id="{F1102B08-ED9E-409F-B95F-09CAA1DAF6E0}" type="datetimeFigureOut">
               <a:rPr lang="en-IN" smtClean="0"/>
-              <a:t>04-01-2025</a:t>
+              <a:t>11-01-2025</a:t>
             </a:fld>
             <a:endParaRPr lang="en-IN"/>
           </a:p>
@@ -775,7 +775,7 @@
           <a:p>
             <a:fld id="{F1102B08-ED9E-409F-B95F-09CAA1DAF6E0}" type="datetimeFigureOut">
               <a:rPr lang="en-IN" smtClean="0"/>
-              <a:t>04-01-2025</a:t>
+              <a:t>11-01-2025</a:t>
             </a:fld>
             <a:endParaRPr lang="en-IN"/>
           </a:p>
@@ -1019,7 +1019,7 @@
           <a:p>
             <a:fld id="{F1102B08-ED9E-409F-B95F-09CAA1DAF6E0}" type="datetimeFigureOut">
               <a:rPr lang="en-IN" smtClean="0"/>
-              <a:t>04-01-2025</a:t>
+              <a:t>11-01-2025</a:t>
             </a:fld>
             <a:endParaRPr lang="en-IN"/>
           </a:p>
@@ -1251,7 +1251,7 @@
           <a:p>
             <a:fld id="{F1102B08-ED9E-409F-B95F-09CAA1DAF6E0}" type="datetimeFigureOut">
               <a:rPr lang="en-IN" smtClean="0"/>
-              <a:t>04-01-2025</a:t>
+              <a:t>11-01-2025</a:t>
             </a:fld>
             <a:endParaRPr lang="en-IN"/>
           </a:p>
@@ -1618,7 +1618,7 @@
           <a:p>
             <a:fld id="{F1102B08-ED9E-409F-B95F-09CAA1DAF6E0}" type="datetimeFigureOut">
               <a:rPr lang="en-IN" smtClean="0"/>
-              <a:t>04-01-2025</a:t>
+              <a:t>11-01-2025</a:t>
             </a:fld>
             <a:endParaRPr lang="en-IN"/>
           </a:p>
@@ -1736,7 +1736,7 @@
           <a:p>
             <a:fld id="{F1102B08-ED9E-409F-B95F-09CAA1DAF6E0}" type="datetimeFigureOut">
               <a:rPr lang="en-IN" smtClean="0"/>
-              <a:t>04-01-2025</a:t>
+              <a:t>11-01-2025</a:t>
             </a:fld>
             <a:endParaRPr lang="en-IN"/>
           </a:p>
@@ -1831,7 +1831,7 @@
           <a:p>
             <a:fld id="{F1102B08-ED9E-409F-B95F-09CAA1DAF6E0}" type="datetimeFigureOut">
               <a:rPr lang="en-IN" smtClean="0"/>
-              <a:t>04-01-2025</a:t>
+              <a:t>11-01-2025</a:t>
             </a:fld>
             <a:endParaRPr lang="en-IN"/>
           </a:p>
@@ -2108,7 +2108,7 @@
           <a:p>
             <a:fld id="{F1102B08-ED9E-409F-B95F-09CAA1DAF6E0}" type="datetimeFigureOut">
               <a:rPr lang="en-IN" smtClean="0"/>
-              <a:t>04-01-2025</a:t>
+              <a:t>11-01-2025</a:t>
             </a:fld>
             <a:endParaRPr lang="en-IN"/>
           </a:p>
@@ -2365,7 +2365,7 @@
           <a:p>
             <a:fld id="{F1102B08-ED9E-409F-B95F-09CAA1DAF6E0}" type="datetimeFigureOut">
               <a:rPr lang="en-IN" smtClean="0"/>
-              <a:t>04-01-2025</a:t>
+              <a:t>11-01-2025</a:t>
             </a:fld>
             <a:endParaRPr lang="en-IN"/>
           </a:p>
@@ -2578,7 +2578,7 @@
           <a:p>
             <a:fld id="{F1102B08-ED9E-409F-B95F-09CAA1DAF6E0}" type="datetimeFigureOut">
               <a:rPr lang="en-IN" smtClean="0"/>
-              <a:t>04-01-2025</a:t>
+              <a:t>11-01-2025</a:t>
             </a:fld>
             <a:endParaRPr lang="en-IN"/>
           </a:p>
@@ -2997,10 +2997,10 @@
         </p:nvGrpSpPr>
         <p:grpSpPr>
           <a:xfrm>
-            <a:off x="160868" y="182032"/>
-            <a:ext cx="4648200" cy="6493935"/>
-            <a:chOff x="160868" y="182032"/>
-            <a:chExt cx="4648200" cy="6493935"/>
+            <a:off x="160868" y="182031"/>
+            <a:ext cx="4648200" cy="6863417"/>
+            <a:chOff x="160868" y="182031"/>
+            <a:chExt cx="4648200" cy="6863417"/>
           </a:xfrm>
         </p:grpSpPr>
         <p:sp>
@@ -3072,8 +3072,8 @@
           </p:nvSpPr>
           <p:spPr>
             <a:xfrm>
-              <a:off x="318523" y="331486"/>
-              <a:ext cx="4483140" cy="5170646"/>
+              <a:off x="243398" y="182031"/>
+              <a:ext cx="4483140" cy="6863417"/>
             </a:xfrm>
             <a:prstGeom prst="rect">
               <a:avLst/>
@@ -3094,7 +3094,33 @@
                   <a:latin typeface="Ramabhadra" panose="02000600000000000000" pitchFamily="2" charset="0"/>
                   <a:cs typeface="Ramabhadra" panose="02000600000000000000" pitchFamily="2" charset="0"/>
                 </a:rPr>
-                <a:t>ఈ దినం సదా నా యేసుకే సొంతం</a:t>
+                <a:t>నిజమైన ద్రాక్షావల్లి నీవే</a:t>
+              </a:r>
+              <a:br>
+                <a:rPr lang="te-IN" sz="2200" dirty="0">
+                  <a:latin typeface="Ramabhadra" panose="02000600000000000000" pitchFamily="2" charset="0"/>
+                  <a:cs typeface="Ramabhadra" panose="02000600000000000000" pitchFamily="2" charset="0"/>
+                </a:rPr>
+              </a:br>
+              <a:r>
+                <a:rPr lang="te-IN" sz="2200" dirty="0">
+                  <a:latin typeface="Ramabhadra" panose="02000600000000000000" pitchFamily="2" charset="0"/>
+                  <a:cs typeface="Ramabhadra" panose="02000600000000000000" pitchFamily="2" charset="0"/>
+                </a:rPr>
+                <a:t>నిత్యమైన సంతోషము నీలోనే </a:t>
+              </a:r>
+              <a:br>
+                <a:rPr lang="te-IN" sz="2200" dirty="0">
+                  <a:latin typeface="Ramabhadra" panose="02000600000000000000" pitchFamily="2" charset="0"/>
+                  <a:cs typeface="Ramabhadra" panose="02000600000000000000" pitchFamily="2" charset="0"/>
+                </a:rPr>
+              </a:br>
+              <a:r>
+                <a:rPr lang="te-IN" sz="2200" dirty="0">
+                  <a:latin typeface="Ramabhadra" panose="02000600000000000000" pitchFamily="2" charset="0"/>
+                  <a:cs typeface="Ramabhadra" panose="02000600000000000000" pitchFamily="2" charset="0"/>
+                </a:rPr>
+                <a:t>శాశ్వతమైనది ఎంతో మధురమైనది</a:t>
               </a:r>
             </a:p>
             <a:p>
@@ -3106,43 +3132,7 @@
                   <a:latin typeface="Ramabhadra" panose="02000600000000000000" pitchFamily="2" charset="0"/>
                   <a:cs typeface="Ramabhadra" panose="02000600000000000000" pitchFamily="2" charset="0"/>
                 </a:rPr>
-                <a:t>నా నాధుని ప్రసన్నత</a:t>
-              </a:r>
-            </a:p>
-            <a:p>
-              <a:pPr defTabSz="439781">
-                <a:defRPr/>
-              </a:pPr>
-              <a:r>
-                <a:rPr lang="te-IN" sz="2200" dirty="0">
-                  <a:latin typeface="Ramabhadra" panose="02000600000000000000" pitchFamily="2" charset="0"/>
-                  <a:cs typeface="Ramabhadra" panose="02000600000000000000" pitchFamily="2" charset="0"/>
-                </a:rPr>
-                <a:t>నా తోడ నడచును (2)</a:t>
-              </a:r>
-            </a:p>
-            <a:p>
-              <a:pPr defTabSz="439781">
-                <a:defRPr/>
-              </a:pPr>
-              <a:r>
-                <a:rPr lang="te-IN" sz="2200" dirty="0">
-                  <a:latin typeface="Ramabhadra" panose="02000600000000000000" pitchFamily="2" charset="0"/>
-                  <a:cs typeface="Ramabhadra" panose="02000600000000000000" pitchFamily="2" charset="0"/>
-                </a:rPr>
-                <a:t>రానున్న కాలము – కలత నివ్వదు (2)</a:t>
-              </a:r>
-            </a:p>
-            <a:p>
-              <a:pPr defTabSz="439781">
-                <a:defRPr/>
-              </a:pPr>
-              <a:r>
-                <a:rPr lang="te-IN" sz="2200" dirty="0">
-                  <a:latin typeface="Ramabhadra" panose="02000600000000000000" pitchFamily="2" charset="0"/>
-                  <a:cs typeface="Ramabhadra" panose="02000600000000000000" pitchFamily="2" charset="0"/>
-                </a:rPr>
-                <a:t>నా మంచి కాపరీ సదా – నన్ను నడుపును</a:t>
+                <a:t>నాపైన నీకున్న ప్రేమ ఎనలేని నీ ప్రేమ    </a:t>
               </a:r>
             </a:p>
             <a:p>
@@ -3163,57 +3153,46 @@
                   <a:latin typeface="Ramabhadra" panose="02000600000000000000" pitchFamily="2" charset="0"/>
                   <a:cs typeface="Ramabhadra" panose="02000600000000000000" pitchFamily="2" charset="0"/>
                 </a:rPr>
-                <a:t>ఎడారులు లోయలు ఎదురు నిలచినా</a:t>
-              </a:r>
-            </a:p>
-            <a:p>
-              <a:pPr defTabSz="439781">
-                <a:defRPr/>
-              </a:pPr>
-              <a:r>
+                <a:t>అతి కాంక్షనీయుడా దివ్యమైన నీ రూపులో</a:t>
+              </a:r>
+              <a:br>
                 <a:rPr lang="te-IN" sz="2200" dirty="0">
                   <a:latin typeface="Ramabhadra" panose="02000600000000000000" pitchFamily="2" charset="0"/>
                   <a:cs typeface="Ramabhadra" panose="02000600000000000000" pitchFamily="2" charset="0"/>
                 </a:rPr>
-                <a:t>ఎన్నడెవరు నడువని బాటయైనను (2)</a:t>
-              </a:r>
-            </a:p>
-            <a:p>
-              <a:pPr defTabSz="439781">
-                <a:defRPr/>
-              </a:pPr>
+              </a:br>
               <a:r>
                 <a:rPr lang="te-IN" sz="2200" dirty="0">
                   <a:latin typeface="Ramabhadra" panose="02000600000000000000" pitchFamily="2" charset="0"/>
                   <a:cs typeface="Ramabhadra" panose="02000600000000000000" pitchFamily="2" charset="0"/>
                 </a:rPr>
-                <a:t>వెరవదెన్నడైనను నాదు హృదయము (2)</a:t>
-              </a:r>
-            </a:p>
-            <a:p>
-              <a:pPr defTabSz="439781">
-                <a:defRPr/>
-              </a:pPr>
-              <a:r>
+                <a:t>జీవించున్నాను నీ ప్రేమకు నే పత్రికగా </a:t>
+              </a:r>
+              <a:br>
                 <a:rPr lang="te-IN" sz="2200" dirty="0">
                   <a:latin typeface="Ramabhadra" panose="02000600000000000000" pitchFamily="2" charset="0"/>
                   <a:cs typeface="Ramabhadra" panose="02000600000000000000" pitchFamily="2" charset="0"/>
                 </a:rPr>
-                <a:t>గాయపడిన యేసుపాదం</a:t>
-              </a:r>
-              <a:r>
-                <a:rPr lang="en-IN" sz="2200" dirty="0">
-                  <a:latin typeface="Ramabhadra" panose="02000600000000000000" pitchFamily="2" charset="0"/>
-                  <a:cs typeface="Ramabhadra" panose="02000600000000000000" pitchFamily="2" charset="0"/>
-                </a:rPr>
-                <a:t> </a:t>
-              </a:r>
+              </a:br>
               <a:r>
                 <a:rPr lang="te-IN" sz="2200" dirty="0">
                   <a:latin typeface="Ramabhadra" panose="02000600000000000000" pitchFamily="2" charset="0"/>
                   <a:cs typeface="Ramabhadra" panose="02000600000000000000" pitchFamily="2" charset="0"/>
                 </a:rPr>
-                <a:t>అందు నడచెను (2)</a:t>
+                <a:t>శిధిలమై యుండగా నన్ను నీదు రక్తముతో కడిగి</a:t>
+              </a:r>
+              <a:br>
+                <a:rPr lang="te-IN" sz="2200" dirty="0">
+                  <a:latin typeface="Ramabhadra" panose="02000600000000000000" pitchFamily="2" charset="0"/>
+                  <a:cs typeface="Ramabhadra" panose="02000600000000000000" pitchFamily="2" charset="0"/>
+                </a:rPr>
+              </a:br>
+              <a:r>
+                <a:rPr lang="te-IN" sz="2200" dirty="0">
+                  <a:latin typeface="Ramabhadra" panose="02000600000000000000" pitchFamily="2" charset="0"/>
+                  <a:cs typeface="Ramabhadra" panose="02000600000000000000" pitchFamily="2" charset="0"/>
+                </a:rPr>
+                <a:t>నీ పోలికగా మార్చినావే నా యేసయ్యా      </a:t>
               </a:r>
             </a:p>
             <a:p>
@@ -3234,34 +3213,60 @@
                   <a:latin typeface="Ramabhadra" panose="02000600000000000000" pitchFamily="2" charset="0"/>
                   <a:cs typeface="Ramabhadra" panose="02000600000000000000" pitchFamily="2" charset="0"/>
                 </a:rPr>
-                <a:t>ప్రవాహం వోలె శోదకుండు ఎదురు వచ్చినా</a:t>
-              </a:r>
+                <a:t>నా ప్రాణ ప్రియుడా శ్రేష్టమైన ఫలములతో</a:t>
+              </a:r>
+              <a:br>
+                <a:rPr lang="te-IN" sz="2200" dirty="0">
+                  <a:latin typeface="Ramabhadra" panose="02000600000000000000" pitchFamily="2" charset="0"/>
+                  <a:cs typeface="Ramabhadra" panose="02000600000000000000" pitchFamily="2" charset="0"/>
+                </a:rPr>
+              </a:br>
+              <a:r>
+                <a:rPr lang="te-IN" sz="2200" dirty="0">
+                  <a:latin typeface="Ramabhadra" panose="02000600000000000000" pitchFamily="2" charset="0"/>
+                  <a:cs typeface="Ramabhadra" panose="02000600000000000000" pitchFamily="2" charset="0"/>
+                </a:rPr>
+                <a:t>అర్పించుచున్నాను సర్వము నీకే అర్పణగా </a:t>
+              </a:r>
+              <a:br>
+                <a:rPr lang="te-IN" sz="2200" dirty="0">
+                  <a:latin typeface="Ramabhadra" panose="02000600000000000000" pitchFamily="2" charset="0"/>
+                  <a:cs typeface="Ramabhadra" panose="02000600000000000000" pitchFamily="2" charset="0"/>
+                </a:rPr>
+              </a:br>
+              <a:r>
+                <a:rPr lang="te-IN" sz="2200" dirty="0">
+                  <a:latin typeface="Ramabhadra" panose="02000600000000000000" pitchFamily="2" charset="0"/>
+                  <a:cs typeface="Ramabhadra" panose="02000600000000000000" pitchFamily="2" charset="0"/>
+                </a:rPr>
+                <a:t>వాడిపోనివ్వక నాకు ఆశ్రయమైతివి నీవు</a:t>
+              </a:r>
+              <a:br>
+                <a:rPr lang="te-IN" sz="2200" dirty="0">
+                  <a:latin typeface="Ramabhadra" panose="02000600000000000000" pitchFamily="2" charset="0"/>
+                  <a:cs typeface="Ramabhadra" panose="02000600000000000000" pitchFamily="2" charset="0"/>
+                </a:rPr>
+              </a:br>
+              <a:r>
+                <a:rPr lang="te-IN" sz="2200" dirty="0">
+                  <a:latin typeface="Ramabhadra" panose="02000600000000000000" pitchFamily="2" charset="0"/>
+                  <a:cs typeface="Ramabhadra" panose="02000600000000000000" pitchFamily="2" charset="0"/>
+                </a:rPr>
+                <a:t>జీవపు ఊటవై బలపరచితివి నా యేసయ్యా </a:t>
+              </a:r>
+              <a:endParaRPr lang="en-US" sz="2200" dirty="0">
+                <a:latin typeface="Ramabhadra" panose="02000600000000000000" pitchFamily="2" charset="0"/>
+                <a:cs typeface="Ramabhadra" panose="02000600000000000000" pitchFamily="2" charset="0"/>
+              </a:endParaRPr>
             </a:p>
             <a:p>
               <a:pPr defTabSz="439781">
                 <a:defRPr/>
               </a:pPr>
-              <a:r>
-                <a:rPr lang="te-IN" sz="2200" dirty="0">
-                  <a:latin typeface="Ramabhadra" panose="02000600000000000000" pitchFamily="2" charset="0"/>
-                  <a:cs typeface="Ramabhadra" panose="02000600000000000000" pitchFamily="2" charset="0"/>
-                </a:rPr>
-                <a:t>యుద్ధకేక నా నోట యేసు నామమే</a:t>
-              </a:r>
-              <a:r>
-                <a:rPr lang="en-IN" sz="2200" dirty="0">
-                  <a:latin typeface="Ramabhadra" panose="02000600000000000000" pitchFamily="2" charset="0"/>
-                  <a:cs typeface="Ramabhadra" panose="02000600000000000000" pitchFamily="2" charset="0"/>
-                </a:rPr>
-                <a:t> </a:t>
-              </a:r>
-              <a:r>
-                <a:rPr lang="te-IN" sz="2200" dirty="0">
-                  <a:latin typeface="Ramabhadra" panose="02000600000000000000" pitchFamily="2" charset="0"/>
-                  <a:cs typeface="Ramabhadra" panose="02000600000000000000" pitchFamily="2" charset="0"/>
-                </a:rPr>
-                <a:t>(2)</a:t>
-              </a:r>
+              <a:endParaRPr lang="en-US" sz="2200" dirty="0">
+                <a:latin typeface="Ramabhadra" panose="02000600000000000000" pitchFamily="2" charset="0"/>
+                <a:cs typeface="Ramabhadra" panose="02000600000000000000" pitchFamily="2" charset="0"/>
+              </a:endParaRPr>
             </a:p>
             <a:p>
               <a:pPr defTabSz="439781">
@@ -3272,48 +3277,56 @@
                   <a:latin typeface="Ramabhadra" panose="02000600000000000000" pitchFamily="2" charset="0"/>
                   <a:cs typeface="Ramabhadra" panose="02000600000000000000" pitchFamily="2" charset="0"/>
                 </a:rPr>
-                <a:t>విరోదమైన ఆయుధాలు యేవి ఫలించవు</a:t>
-              </a:r>
-              <a:r>
-                <a:rPr lang="en-IN" sz="2200" dirty="0">
-                  <a:latin typeface="Ramabhadra" panose="02000600000000000000" pitchFamily="2" charset="0"/>
-                  <a:cs typeface="Ramabhadra" panose="02000600000000000000" pitchFamily="2" charset="0"/>
-                </a:rPr>
-                <a:t> </a:t>
-              </a:r>
-              <a:r>
+                <a:t>షాలేము రాజా రమ్యమైన సీయోనుకే</a:t>
+              </a:r>
+              <a:br>
                 <a:rPr lang="te-IN" sz="2200" dirty="0">
                   <a:latin typeface="Ramabhadra" panose="02000600000000000000" pitchFamily="2" charset="0"/>
                   <a:cs typeface="Ramabhadra" panose="02000600000000000000" pitchFamily="2" charset="0"/>
                 </a:rPr>
-                <a:t>(2)</a:t>
+              </a:br>
+              <a:r>
+                <a:rPr lang="te-IN" sz="2200" dirty="0">
+                  <a:latin typeface="Ramabhadra" panose="02000600000000000000" pitchFamily="2" charset="0"/>
+                  <a:cs typeface="Ramabhadra" panose="02000600000000000000" pitchFamily="2" charset="0"/>
+                </a:rPr>
+                <a:t>నను నడిపించుము నీ చిత్తమైన మార్గములో </a:t>
+              </a:r>
+              <a:br>
+                <a:rPr lang="te-IN" sz="2200" dirty="0">
+                  <a:latin typeface="Ramabhadra" panose="02000600000000000000" pitchFamily="2" charset="0"/>
+                  <a:cs typeface="Ramabhadra" panose="02000600000000000000" pitchFamily="2" charset="0"/>
+                </a:rPr>
+              </a:br>
+              <a:r>
+                <a:rPr lang="te-IN" sz="2200" dirty="0">
+                  <a:latin typeface="Ramabhadra" panose="02000600000000000000" pitchFamily="2" charset="0"/>
+                  <a:cs typeface="Ramabhadra" panose="02000600000000000000" pitchFamily="2" charset="0"/>
+                </a:rPr>
+                <a:t>అలసి పోనివ్వక నన్ను నీదు ఆత్మతో నింపి</a:t>
+              </a:r>
+              <a:br>
+                <a:rPr lang="te-IN" sz="2200" dirty="0">
+                  <a:latin typeface="Ramabhadra" panose="02000600000000000000" pitchFamily="2" charset="0"/>
+                  <a:cs typeface="Ramabhadra" panose="02000600000000000000" pitchFamily="2" charset="0"/>
+                </a:rPr>
+              </a:br>
+              <a:r>
+                <a:rPr lang="te-IN" sz="2200" dirty="0">
+                  <a:latin typeface="Ramabhadra" panose="02000600000000000000" pitchFamily="2" charset="0"/>
+                  <a:cs typeface="Ramabhadra" panose="02000600000000000000" pitchFamily="2" charset="0"/>
+                </a:rPr>
+                <a:t>ఆదరణ కర్తవై నను చేర్చుము నీ రాజ్యములో</a:t>
               </a:r>
             </a:p>
             <a:p>
               <a:pPr defTabSz="439781">
                 <a:defRPr/>
               </a:pPr>
-              <a:r>
-                <a:rPr lang="te-IN" sz="2200" dirty="0">
-                  <a:latin typeface="Ramabhadra" panose="02000600000000000000" pitchFamily="2" charset="0"/>
-                  <a:cs typeface="Ramabhadra" panose="02000600000000000000" pitchFamily="2" charset="0"/>
-                </a:rPr>
-                <a:t>యెహోవా నిస్సియే నాదు విజయము</a:t>
-              </a:r>
-              <a:r>
-                <a:rPr lang="en-IN" sz="2200" dirty="0">
-                  <a:latin typeface="Ramabhadra" panose="02000600000000000000" pitchFamily="2" charset="0"/>
-                  <a:cs typeface="Ramabhadra" panose="02000600000000000000" pitchFamily="2" charset="0"/>
-                </a:rPr>
-                <a:t> </a:t>
-              </a:r>
-              <a:r>
-                <a:rPr lang="te-IN" sz="2200" dirty="0">
-                  <a:latin typeface="Ramabhadra" panose="02000600000000000000" pitchFamily="2" charset="0"/>
-                  <a:cs typeface="Ramabhadra" panose="02000600000000000000" pitchFamily="2" charset="0"/>
-                </a:rPr>
-                <a:t>(2)</a:t>
-              </a:r>
+              <a:endParaRPr lang="te-IN" sz="2200" dirty="0">
+                <a:latin typeface="Ramabhadra" panose="02000600000000000000" pitchFamily="2" charset="0"/>
+                <a:cs typeface="Ramabhadra" panose="02000600000000000000" pitchFamily="2" charset="0"/>
+              </a:endParaRPr>
             </a:p>
           </p:txBody>
         </p:sp>
@@ -3395,9 +3408,9 @@
         <p:grpSpPr>
           <a:xfrm>
             <a:off x="5104338" y="182031"/>
-            <a:ext cx="5650295" cy="6493935"/>
+            <a:ext cx="5718029" cy="6524392"/>
             <a:chOff x="160868" y="182032"/>
-            <a:chExt cx="5650295" cy="6493935"/>
+            <a:chExt cx="5718029" cy="6524392"/>
           </a:xfrm>
         </p:grpSpPr>
         <p:sp>
@@ -3469,8 +3482,8 @@
           </p:nvSpPr>
           <p:spPr>
             <a:xfrm>
-              <a:off x="196701" y="276251"/>
-              <a:ext cx="5614462" cy="6001643"/>
+              <a:off x="264435" y="243116"/>
+              <a:ext cx="5614462" cy="6463308"/>
             </a:xfrm>
             <a:prstGeom prst="rect">
               <a:avLst/>
@@ -3484,140 +3497,158 @@
             <a:lstStyle/>
             <a:p>
               <a:r>
-                <a:rPr lang="te-IN" sz="2400" dirty="0">
-                  <a:latin typeface="Ramabhadra" panose="02000600000000000000" pitchFamily="2" charset="0"/>
-                  <a:cs typeface="Ramabhadra" panose="02000600000000000000" pitchFamily="2" charset="0"/>
-                </a:rPr>
-                <a:t>సద్గుణ శీలుడా నీవే పూజ్యుడవు</a:t>
-              </a:r>
-            </a:p>
-            <a:p>
-              <a:r>
-                <a:rPr lang="te-IN" sz="2400" dirty="0">
-                  <a:latin typeface="Ramabhadra" panose="02000600000000000000" pitchFamily="2" charset="0"/>
-                  <a:cs typeface="Ramabhadra" panose="02000600000000000000" pitchFamily="2" charset="0"/>
-                </a:rPr>
-                <a:t>స్తుతి ఆరాధనకు నీవే యోగ్యుడవు</a:t>
-              </a:r>
-            </a:p>
-            <a:p>
-              <a:r>
-                <a:rPr lang="te-IN" sz="2400" dirty="0">
-                  <a:latin typeface="Ramabhadra" panose="02000600000000000000" pitchFamily="2" charset="0"/>
-                  <a:cs typeface="Ramabhadra" panose="02000600000000000000" pitchFamily="2" charset="0"/>
-                </a:rPr>
-                <a:t>సత్య ప్రమాణముతో శాశ్వత కృపనిచ్చి</a:t>
-              </a:r>
-            </a:p>
-            <a:p>
-              <a:r>
-                <a:rPr lang="te-IN" sz="2400" dirty="0">
-                  <a:latin typeface="Ramabhadra" panose="02000600000000000000" pitchFamily="2" charset="0"/>
-                  <a:cs typeface="Ramabhadra" panose="02000600000000000000" pitchFamily="2" charset="0"/>
-                </a:rPr>
-                <a:t>నీ ప్రియుని స్వాస్థ్యము నాకిచ్చితివి</a:t>
-              </a:r>
-            </a:p>
-            <a:p>
-              <a:r>
-                <a:rPr lang="te-IN" sz="2400" dirty="0">
-                  <a:latin typeface="Ramabhadra" panose="02000600000000000000" pitchFamily="2" charset="0"/>
-                  <a:cs typeface="Ramabhadra" panose="02000600000000000000" pitchFamily="2" charset="0"/>
-                </a:rPr>
-                <a:t>యేసయ్యా నీ సంకల్పమే</a:t>
-              </a:r>
-            </a:p>
-            <a:p>
-              <a:r>
-                <a:rPr lang="te-IN" sz="2400" dirty="0">
-                  <a:latin typeface="Ramabhadra" panose="02000600000000000000" pitchFamily="2" charset="0"/>
-                  <a:cs typeface="Ramabhadra" panose="02000600000000000000" pitchFamily="2" charset="0"/>
-                </a:rPr>
-                <a:t>ఇది నాపై నీకున్న అనురాగమే</a:t>
-              </a:r>
-            </a:p>
-            <a:p>
-              <a:endParaRPr lang="te-IN" sz="2400" dirty="0">
+                <a:rPr lang="te-IN" sz="2300" dirty="0">
+                  <a:latin typeface="Ramabhadra" panose="02000600000000000000" pitchFamily="2" charset="0"/>
+                  <a:cs typeface="Ramabhadra" panose="02000600000000000000" pitchFamily="2" charset="0"/>
+                </a:rPr>
+                <a:t>నీ ప్రేమ ఎంతో అపారము</a:t>
+              </a:r>
+            </a:p>
+            <a:p>
+              <a:r>
+                <a:rPr lang="te-IN" sz="2300" dirty="0">
+                  <a:latin typeface="Ramabhadra" panose="02000600000000000000" pitchFamily="2" charset="0"/>
+                  <a:cs typeface="Ramabhadra" panose="02000600000000000000" pitchFamily="2" charset="0"/>
+                </a:rPr>
+                <a:t>వర్ణింపతరమా నా ప్రభూ</a:t>
+              </a:r>
+            </a:p>
+            <a:p>
+              <a:r>
+                <a:rPr lang="te-IN" sz="2300" dirty="0">
+                  <a:latin typeface="Ramabhadra" panose="02000600000000000000" pitchFamily="2" charset="0"/>
+                  <a:cs typeface="Ramabhadra" panose="02000600000000000000" pitchFamily="2" charset="0"/>
+                </a:rPr>
+                <a:t>పులకింప చేసెను నా హృది</a:t>
+              </a:r>
+            </a:p>
+            <a:p>
+              <a:r>
+                <a:rPr lang="te-IN" sz="2300" dirty="0">
+                  <a:latin typeface="Ramabhadra" panose="02000600000000000000" pitchFamily="2" charset="0"/>
+                  <a:cs typeface="Ramabhadra" panose="02000600000000000000" pitchFamily="2" charset="0"/>
+                </a:rPr>
+                <a:t>హృదయేశ్వరా నా యేసువా</a:t>
+              </a:r>
+            </a:p>
+            <a:p>
+              <a:endParaRPr lang="te-IN" sz="2300" dirty="0">
                 <a:latin typeface="Ramabhadra" panose="02000600000000000000" pitchFamily="2" charset="0"/>
                 <a:cs typeface="Ramabhadra" panose="02000600000000000000" pitchFamily="2" charset="0"/>
               </a:endParaRPr>
             </a:p>
             <a:p>
               <a:r>
-                <a:rPr lang="te-IN" sz="2400" dirty="0">
-                  <a:latin typeface="Ramabhadra" panose="02000600000000000000" pitchFamily="2" charset="0"/>
-                  <a:cs typeface="Ramabhadra" panose="02000600000000000000" pitchFamily="2" charset="0"/>
-                </a:rPr>
-                <a:t>సిలువ సునాదమును నా శ్రమదినమున</a:t>
-              </a:r>
-            </a:p>
-            <a:p>
-              <a:r>
-                <a:rPr lang="te-IN" sz="2400" dirty="0">
-                  <a:latin typeface="Ramabhadra" panose="02000600000000000000" pitchFamily="2" charset="0"/>
-                  <a:cs typeface="Ramabhadra" panose="02000600000000000000" pitchFamily="2" charset="0"/>
-                </a:rPr>
-                <a:t>మధుర గీతికగా మదిలో వినిపించి</a:t>
-              </a:r>
-            </a:p>
-            <a:p>
-              <a:r>
-                <a:rPr lang="te-IN" sz="2400" dirty="0">
-                  <a:latin typeface="Ramabhadra" panose="02000600000000000000" pitchFamily="2" charset="0"/>
-                  <a:cs typeface="Ramabhadra" panose="02000600000000000000" pitchFamily="2" charset="0"/>
-                </a:rPr>
-                <a:t>సిలువలో దాగిన సర్వసంపదలిచ్చి</a:t>
-              </a:r>
-            </a:p>
-            <a:p>
-              <a:r>
-                <a:rPr lang="te-IN" sz="2400" dirty="0">
-                  <a:latin typeface="Ramabhadra" panose="02000600000000000000" pitchFamily="2" charset="0"/>
-                  <a:cs typeface="Ramabhadra" panose="02000600000000000000" pitchFamily="2" charset="0"/>
-                </a:rPr>
-                <a:t>కాంతిమయముగా కనపరచితివే నీ ఆత్మ శక్తితో</a:t>
-              </a:r>
-            </a:p>
-            <a:p>
-              <a:endParaRPr lang="te-IN" sz="2400" dirty="0">
+                <a:rPr lang="te-IN" sz="2300" dirty="0">
+                  <a:latin typeface="Ramabhadra" panose="02000600000000000000" pitchFamily="2" charset="0"/>
+                  <a:cs typeface="Ramabhadra" panose="02000600000000000000" pitchFamily="2" charset="0"/>
+                </a:rPr>
+                <a:t>నన్ను ఎంతో ప్రేమించి</a:t>
+              </a:r>
+            </a:p>
+            <a:p>
+              <a:r>
+                <a:rPr lang="te-IN" sz="2300" dirty="0">
+                  <a:latin typeface="Ramabhadra" panose="02000600000000000000" pitchFamily="2" charset="0"/>
+                  <a:cs typeface="Ramabhadra" panose="02000600000000000000" pitchFamily="2" charset="0"/>
+                </a:rPr>
+                <a:t>నాదు పాపమె క్షమియించి</a:t>
+              </a:r>
+            </a:p>
+            <a:p>
+              <a:r>
+                <a:rPr lang="te-IN" sz="2300" dirty="0">
+                  <a:latin typeface="Ramabhadra" panose="02000600000000000000" pitchFamily="2" charset="0"/>
+                  <a:cs typeface="Ramabhadra" panose="02000600000000000000" pitchFamily="2" charset="0"/>
+                </a:rPr>
+                <a:t>కృప కనికరముల నీడలో</a:t>
+              </a:r>
+            </a:p>
+            <a:p>
+              <a:r>
+                <a:rPr lang="te-IN" sz="2300" dirty="0">
+                  <a:latin typeface="Ramabhadra" panose="02000600000000000000" pitchFamily="2" charset="0"/>
+                  <a:cs typeface="Ramabhadra" panose="02000600000000000000" pitchFamily="2" charset="0"/>
+                </a:rPr>
+                <a:t>నన్ను చేర్చిన నా ప్రభూ</a:t>
+              </a:r>
+            </a:p>
+            <a:p>
+              <a:r>
+                <a:rPr lang="te-IN" sz="2300" dirty="0">
+                  <a:latin typeface="Ramabhadra" panose="02000600000000000000" pitchFamily="2" charset="0"/>
+                  <a:cs typeface="Ramabhadra" panose="02000600000000000000" pitchFamily="2" charset="0"/>
+                </a:rPr>
+                <a:t>జీవితమంతా స్తుతియించినా</a:t>
+              </a:r>
+            </a:p>
+            <a:p>
+              <a:r>
+                <a:rPr lang="te-IN" sz="2300" dirty="0">
+                  <a:latin typeface="Ramabhadra" panose="02000600000000000000" pitchFamily="2" charset="0"/>
+                  <a:cs typeface="Ramabhadra" panose="02000600000000000000" pitchFamily="2" charset="0"/>
+                </a:rPr>
+                <a:t>తీరునా నీ ఋణం</a:t>
+              </a:r>
+            </a:p>
+            <a:p>
+              <a:endParaRPr lang="te-IN" sz="2300" dirty="0">
                 <a:latin typeface="Ramabhadra" panose="02000600000000000000" pitchFamily="2" charset="0"/>
                 <a:cs typeface="Ramabhadra" panose="02000600000000000000" pitchFamily="2" charset="0"/>
               </a:endParaRPr>
             </a:p>
             <a:p>
               <a:r>
-                <a:rPr lang="te-IN" sz="2400" dirty="0">
-                  <a:latin typeface="Ramabhadra" panose="02000600000000000000" pitchFamily="2" charset="0"/>
-                  <a:cs typeface="Ramabhadra" panose="02000600000000000000" pitchFamily="2" charset="0"/>
-                </a:rPr>
-                <a:t>నాతోడు నీడవై మరపురాని</a:t>
-              </a:r>
-            </a:p>
-            <a:p>
-              <a:r>
-                <a:rPr lang="te-IN" sz="2400" dirty="0">
-                  <a:latin typeface="Ramabhadra" panose="02000600000000000000" pitchFamily="2" charset="0"/>
-                  <a:cs typeface="Ramabhadra" panose="02000600000000000000" pitchFamily="2" charset="0"/>
-                </a:rPr>
-                <a:t>మహోప కార్యములు నాకై చేసి</a:t>
-              </a:r>
-            </a:p>
-            <a:p>
-              <a:r>
-                <a:rPr lang="te-IN" sz="2400" dirty="0">
-                  <a:latin typeface="Ramabhadra" panose="02000600000000000000" pitchFamily="2" charset="0"/>
-                  <a:cs typeface="Ramabhadra" panose="02000600000000000000" pitchFamily="2" charset="0"/>
-                </a:rPr>
-                <a:t>చీకటి దాచిన -వేకువగా మార్చి</a:t>
-              </a:r>
-            </a:p>
-            <a:p>
-              <a:r>
-                <a:rPr lang="te-IN" sz="2400" dirty="0">
-                  <a:latin typeface="Ramabhadra" panose="02000600000000000000" pitchFamily="2" charset="0"/>
-                  <a:cs typeface="Ramabhadra" panose="02000600000000000000" pitchFamily="2" charset="0"/>
-                </a:rPr>
-                <a:t>బలమైన జనముగా నిర్దారించితివి నీ కీర్తి కొరకే</a:t>
+                <a:rPr lang="te-IN" sz="2300" dirty="0">
+                  <a:latin typeface="Ramabhadra" panose="02000600000000000000" pitchFamily="2" charset="0"/>
+                  <a:cs typeface="Ramabhadra" panose="02000600000000000000" pitchFamily="2" charset="0"/>
+                </a:rPr>
+                <a:t>నీదు సన్నిధిలో కాంక్షించి</a:t>
+              </a:r>
+            </a:p>
+            <a:p>
+              <a:r>
+                <a:rPr lang="te-IN" sz="2300" dirty="0">
+                  <a:latin typeface="Ramabhadra" panose="02000600000000000000" pitchFamily="2" charset="0"/>
+                  <a:cs typeface="Ramabhadra" panose="02000600000000000000" pitchFamily="2" charset="0"/>
+                </a:rPr>
+                <a:t>పాప బ్రతుకే వీడితిని</a:t>
+              </a:r>
+            </a:p>
+            <a:p>
+              <a:r>
+                <a:rPr lang="te-IN" sz="2300" dirty="0">
+                  <a:latin typeface="Ramabhadra" panose="02000600000000000000" pitchFamily="2" charset="0"/>
+                  <a:cs typeface="Ramabhadra" panose="02000600000000000000" pitchFamily="2" charset="0"/>
+                </a:rPr>
+                <a:t>నీదు జీవమె నిండుగ</a:t>
+              </a:r>
+            </a:p>
+            <a:p>
+              <a:r>
+                <a:rPr lang="te-IN" sz="2300" dirty="0">
+                  <a:latin typeface="Ramabhadra" panose="02000600000000000000" pitchFamily="2" charset="0"/>
+                  <a:cs typeface="Ramabhadra" panose="02000600000000000000" pitchFamily="2" charset="0"/>
+                </a:rPr>
+                <a:t>నాలో నింపుము నా ప్రభు</a:t>
+              </a:r>
+            </a:p>
+            <a:p>
+              <a:r>
+                <a:rPr lang="te-IN" sz="2300" dirty="0">
+                  <a:latin typeface="Ramabhadra" panose="02000600000000000000" pitchFamily="2" charset="0"/>
+                  <a:cs typeface="Ramabhadra" panose="02000600000000000000" pitchFamily="2" charset="0"/>
+                </a:rPr>
+                <a:t>జీవితమంతా నీ ప్రేమనూ</a:t>
+              </a:r>
+            </a:p>
+            <a:p>
+              <a:r>
+                <a:rPr lang="te-IN" sz="2300" dirty="0">
+                  <a:latin typeface="Ramabhadra" panose="02000600000000000000" pitchFamily="2" charset="0"/>
+                  <a:cs typeface="Ramabhadra" panose="02000600000000000000" pitchFamily="2" charset="0"/>
+                </a:rPr>
+                <a:t>చాటుచు నుందును</a:t>
               </a:r>
             </a:p>
           </p:txBody>
@@ -3730,9 +3761,9 @@
         <p:grpSpPr>
           <a:xfrm>
             <a:off x="160868" y="182032"/>
-            <a:ext cx="5506736" cy="6493935"/>
+            <a:ext cx="5472868" cy="6551396"/>
             <a:chOff x="160868" y="182032"/>
-            <a:chExt cx="5506736" cy="6493935"/>
+            <a:chExt cx="5472868" cy="6551396"/>
           </a:xfrm>
         </p:grpSpPr>
         <p:sp>
@@ -3804,8 +3835,8 @@
           </p:nvSpPr>
           <p:spPr>
             <a:xfrm>
-              <a:off x="271993" y="352014"/>
-              <a:ext cx="5395611" cy="5755422"/>
+              <a:off x="238125" y="208565"/>
+              <a:ext cx="5395611" cy="6524863"/>
             </a:xfrm>
             <a:prstGeom prst="rect">
               <a:avLst/>
@@ -3822,11 +3853,11 @@
                 <a:defRPr/>
               </a:pPr>
               <a:r>
-                <a:rPr lang="te-IN" sz="2300" dirty="0">
-                  <a:latin typeface="Ramabhadra" panose="02000600000000000000" pitchFamily="2" charset="0"/>
-                  <a:cs typeface="Ramabhadra" panose="02000600000000000000" pitchFamily="2" charset="0"/>
-                </a:rPr>
-                <a:t>కృపా సత్య సంపూర్ణుడా</a:t>
+                <a:rPr lang="te-IN" sz="2200" dirty="0">
+                  <a:latin typeface="Ramabhadra" panose="02000600000000000000" pitchFamily="2" charset="0"/>
+                  <a:cs typeface="Ramabhadra" panose="02000600000000000000" pitchFamily="2" charset="0"/>
+                </a:rPr>
+                <a:t>సంవత్సరములు గతియించు చుండ –</a:t>
               </a:r>
             </a:p>
             <a:p>
@@ -3834,11 +3865,11 @@
                 <a:defRPr/>
               </a:pPr>
               <a:r>
-                <a:rPr lang="te-IN" sz="2300" dirty="0">
-                  <a:latin typeface="Ramabhadra" panose="02000600000000000000" pitchFamily="2" charset="0"/>
-                  <a:cs typeface="Ramabhadra" panose="02000600000000000000" pitchFamily="2" charset="0"/>
-                </a:rPr>
-                <a:t>సర్వలోకానికే చక్రవర్తివి నీవే యేసయ్యా -2</a:t>
+                <a:rPr lang="te-IN" sz="2200" dirty="0">
+                  <a:latin typeface="Ramabhadra" panose="02000600000000000000" pitchFamily="2" charset="0"/>
+                  <a:cs typeface="Ramabhadra" panose="02000600000000000000" pitchFamily="2" charset="0"/>
+                </a:rPr>
+                <a:t>నను నూతన పరుచుము</a:t>
               </a:r>
             </a:p>
             <a:p>
@@ -3846,43 +3877,67 @@
                 <a:defRPr/>
               </a:pPr>
               <a:r>
-                <a:rPr lang="te-IN" sz="2300" dirty="0">
-                  <a:latin typeface="Ramabhadra" panose="02000600000000000000" pitchFamily="2" charset="0"/>
-                  <a:cs typeface="Ramabhadra" panose="02000600000000000000" pitchFamily="2" charset="0"/>
-                </a:rPr>
-                <a:t>నా సన్మానానికే మహనీయుడవు నీవేనయా ... </a:t>
-              </a:r>
+                <a:rPr lang="te-IN" sz="2200" dirty="0">
+                  <a:latin typeface="Ramabhadra" panose="02000600000000000000" pitchFamily="2" charset="0"/>
+                  <a:cs typeface="Ramabhadra" panose="02000600000000000000" pitchFamily="2" charset="0"/>
+                </a:rPr>
+                <a:t>యేసయ్యా నీ రూపముకు మార్చుము </a:t>
+              </a:r>
+              <a:r>
+                <a:rPr lang="en-US" sz="2200" dirty="0">
+                  <a:latin typeface="Ramabhadra" panose="02000600000000000000" pitchFamily="2" charset="0"/>
+                  <a:cs typeface="Ramabhadra" panose="02000600000000000000" pitchFamily="2" charset="0"/>
+                </a:rPr>
+                <a:t>(2)</a:t>
+              </a:r>
+              <a:endParaRPr lang="te-IN" sz="2200" dirty="0">
+                <a:latin typeface="Ramabhadra" panose="02000600000000000000" pitchFamily="2" charset="0"/>
+                <a:cs typeface="Ramabhadra" panose="02000600000000000000" pitchFamily="2" charset="0"/>
+              </a:endParaRPr>
             </a:p>
             <a:p>
               <a:pPr defTabSz="439781">
                 <a:defRPr/>
               </a:pPr>
               <a:r>
-                <a:rPr lang="te-IN" sz="2300" dirty="0">
-                  <a:latin typeface="Ramabhadra" panose="02000600000000000000" pitchFamily="2" charset="0"/>
-                  <a:cs typeface="Ramabhadra" panose="02000600000000000000" pitchFamily="2" charset="0"/>
-                </a:rPr>
-                <a:t>మహనీయుడవు నీవేనయా ... </a:t>
+                <a:rPr lang="te-IN" sz="2200" dirty="0">
+                  <a:latin typeface="Ramabhadra" panose="02000600000000000000" pitchFamily="2" charset="0"/>
+                  <a:cs typeface="Ramabhadra" panose="02000600000000000000" pitchFamily="2" charset="0"/>
+                </a:rPr>
+                <a:t>హిమము కంటే తెల్లగా –</a:t>
               </a:r>
             </a:p>
             <a:p>
               <a:pPr defTabSz="439781">
                 <a:defRPr/>
               </a:pPr>
-              <a:br>
-                <a:rPr lang="te-IN" sz="2300" dirty="0">
-                  <a:latin typeface="Ramabhadra" panose="02000600000000000000" pitchFamily="2" charset="0"/>
-                  <a:cs typeface="Ramabhadra" panose="02000600000000000000" pitchFamily="2" charset="0"/>
-                </a:rPr>
-              </a:br>
-              <a:r>
-                <a:rPr lang="te-IN" sz="2300" dirty="0">
-                  <a:latin typeface="Ramabhadra" panose="02000600000000000000" pitchFamily="2" charset="0"/>
-                  <a:cs typeface="Ramabhadra" panose="02000600000000000000" pitchFamily="2" charset="0"/>
-                </a:rPr>
-                <a:t>ఎర్ర సముద్రము నీ ఆజ్ఞ మేరకు</a:t>
-              </a:r>
-              <a:endParaRPr lang="en-IN" sz="2300" dirty="0">
+              <a:r>
+                <a:rPr lang="te-IN" sz="2200" dirty="0">
+                  <a:latin typeface="Ramabhadra" panose="02000600000000000000" pitchFamily="2" charset="0"/>
+                  <a:cs typeface="Ramabhadra" panose="02000600000000000000" pitchFamily="2" charset="0"/>
+                </a:rPr>
+                <a:t>పరిశుద్ధపరుచుము నా రక్షకా </a:t>
+              </a:r>
+              <a:r>
+                <a:rPr lang="en-US" sz="2200" dirty="0">
+                  <a:latin typeface="Ramabhadra" panose="02000600000000000000" pitchFamily="2" charset="0"/>
+                  <a:cs typeface="Ramabhadra" panose="02000600000000000000" pitchFamily="2" charset="0"/>
+                </a:rPr>
+                <a:t>(2)</a:t>
+              </a:r>
+              <a:r>
+                <a:rPr lang="te-IN" sz="2200" dirty="0">
+                  <a:latin typeface="Ramabhadra" panose="02000600000000000000" pitchFamily="2" charset="0"/>
+                  <a:cs typeface="Ramabhadra" panose="02000600000000000000" pitchFamily="2" charset="0"/>
+                </a:rPr>
+                <a:t> </a:t>
+              </a:r>
+            </a:p>
+            <a:p>
+              <a:pPr defTabSz="439781">
+                <a:defRPr/>
+              </a:pPr>
+              <a:endParaRPr lang="te-IN" sz="2200" dirty="0">
                 <a:latin typeface="Ramabhadra" panose="02000600000000000000" pitchFamily="2" charset="0"/>
                 <a:cs typeface="Ramabhadra" panose="02000600000000000000" pitchFamily="2" charset="0"/>
               </a:endParaRPr>
@@ -3892,11 +3947,11 @@
                 <a:defRPr/>
               </a:pPr>
               <a:r>
-                <a:rPr lang="te-IN" sz="2300" dirty="0">
-                  <a:latin typeface="Ramabhadra" panose="02000600000000000000" pitchFamily="2" charset="0"/>
-                  <a:cs typeface="Ramabhadra" panose="02000600000000000000" pitchFamily="2" charset="0"/>
-                </a:rPr>
-                <a:t>రహదారిగా మారగా </a:t>
+                <a:rPr lang="te-IN" sz="2200" dirty="0">
+                  <a:latin typeface="Ramabhadra" panose="02000600000000000000" pitchFamily="2" charset="0"/>
+                  <a:cs typeface="Ramabhadra" panose="02000600000000000000" pitchFamily="2" charset="0"/>
+                </a:rPr>
+                <a:t>దినదినంబు నీకు సమీపమై –</a:t>
               </a:r>
             </a:p>
             <a:p>
@@ -3904,11 +3959,11 @@
                 <a:defRPr/>
               </a:pPr>
               <a:r>
-                <a:rPr lang="te-IN" sz="2300" dirty="0">
-                  <a:latin typeface="Ramabhadra" panose="02000600000000000000" pitchFamily="2" charset="0"/>
-                  <a:cs typeface="Ramabhadra" panose="02000600000000000000" pitchFamily="2" charset="0"/>
-                </a:rPr>
-                <a:t>దాటిరే నీ జనులు బహు క్షేమముగా -2</a:t>
+                <a:rPr lang="te-IN" sz="2200" dirty="0">
+                  <a:latin typeface="Ramabhadra" panose="02000600000000000000" pitchFamily="2" charset="0"/>
+                  <a:cs typeface="Ramabhadra" panose="02000600000000000000" pitchFamily="2" charset="0"/>
+                </a:rPr>
+                <a:t>ప్రతి క్షణం నా సిలువను మోయుచు</a:t>
               </a:r>
             </a:p>
             <a:p>
@@ -3916,13 +3971,56 @@
                 <a:defRPr/>
               </a:pPr>
               <a:r>
-                <a:rPr lang="te-IN" sz="2300" dirty="0">
-                  <a:latin typeface="Ramabhadra" panose="02000600000000000000" pitchFamily="2" charset="0"/>
-                  <a:cs typeface="Ramabhadra" panose="02000600000000000000" pitchFamily="2" charset="0"/>
-                </a:rPr>
-                <a:t>ఆ జలములలోనే</a:t>
-              </a:r>
-              <a:endParaRPr lang="en-IN" sz="2300" dirty="0">
+                <a:rPr lang="te-IN" sz="2200" dirty="0">
+                  <a:latin typeface="Ramabhadra" panose="02000600000000000000" pitchFamily="2" charset="0"/>
+                  <a:cs typeface="Ramabhadra" panose="02000600000000000000" pitchFamily="2" charset="0"/>
+                </a:rPr>
+                <a:t>వెనుకకు  చూడకనే నేను సాగెదను-</a:t>
+              </a:r>
+            </a:p>
+            <a:p>
+              <a:pPr defTabSz="439781">
+                <a:defRPr/>
+              </a:pPr>
+              <a:r>
+                <a:rPr lang="te-IN" sz="2200" dirty="0">
+                  <a:latin typeface="Ramabhadra" panose="02000600000000000000" pitchFamily="2" charset="0"/>
+                  <a:cs typeface="Ramabhadra" panose="02000600000000000000" pitchFamily="2" charset="0"/>
+                </a:rPr>
+                <a:t>శిలువను చూచుచునే గురిని చేరెదను</a:t>
+              </a:r>
+            </a:p>
+            <a:p>
+              <a:pPr defTabSz="439781">
+                <a:defRPr/>
+              </a:pPr>
+              <a:r>
+                <a:rPr lang="te-IN" sz="2200" dirty="0">
+                  <a:latin typeface="Ramabhadra" panose="02000600000000000000" pitchFamily="2" charset="0"/>
+                  <a:cs typeface="Ramabhadra" panose="02000600000000000000" pitchFamily="2" charset="0"/>
+                </a:rPr>
+                <a:t>నీ ఆత్మతో నను నింపుమా –</a:t>
+              </a:r>
+            </a:p>
+            <a:p>
+              <a:pPr defTabSz="439781">
+                <a:defRPr/>
+              </a:pPr>
+              <a:r>
+                <a:rPr lang="te-IN" sz="2200" dirty="0">
+                  <a:latin typeface="Ramabhadra" panose="02000600000000000000" pitchFamily="2" charset="0"/>
+                  <a:cs typeface="Ramabhadra" panose="02000600000000000000" pitchFamily="2" charset="0"/>
+                </a:rPr>
+                <a:t>నీ సేవజేతును స్థిరపరచుమా</a:t>
+              </a:r>
+              <a:r>
+                <a:rPr lang="en-US" sz="2200" dirty="0">
+                  <a:latin typeface="Ramabhadra" panose="02000600000000000000" pitchFamily="2" charset="0"/>
+                  <a:cs typeface="Ramabhadra" panose="02000600000000000000" pitchFamily="2" charset="0"/>
+                </a:rPr>
+                <a:t> (2)</a:t>
+              </a:r>
+              <a:endParaRPr lang="te-IN" sz="2200" dirty="0">
                 <a:latin typeface="Ramabhadra" panose="02000600000000000000" pitchFamily="2" charset="0"/>
                 <a:cs typeface="Ramabhadra" panose="02000600000000000000" pitchFamily="2" charset="0"/>
               </a:endParaRPr>
@@ -3931,101 +4029,107 @@
               <a:pPr defTabSz="439781">
                 <a:defRPr/>
               </a:pPr>
-              <a:r>
-                <a:rPr lang="te-IN" sz="2300" dirty="0">
-                  <a:latin typeface="Ramabhadra" panose="02000600000000000000" pitchFamily="2" charset="0"/>
-                  <a:cs typeface="Ramabhadra" panose="02000600000000000000" pitchFamily="2" charset="0"/>
-                </a:rPr>
-                <a:t>శత్రు సైన్యము</a:t>
-              </a:r>
-              <a:r>
-                <a:rPr lang="en-IN" sz="2300" dirty="0">
-                  <a:latin typeface="Ramabhadra" panose="02000600000000000000" pitchFamily="2" charset="0"/>
-                  <a:cs typeface="Ramabhadra" panose="02000600000000000000" pitchFamily="2" charset="0"/>
-                </a:rPr>
-                <a:t> </a:t>
-              </a:r>
-              <a:r>
-                <a:rPr lang="te-IN" sz="2300" dirty="0">
-                  <a:latin typeface="Ramabhadra" panose="02000600000000000000" pitchFamily="2" charset="0"/>
-                  <a:cs typeface="Ramabhadra" panose="02000600000000000000" pitchFamily="2" charset="0"/>
-                </a:rPr>
-                <a:t>మునిగిపోయెనే - 2            </a:t>
-              </a:r>
+              <a:endParaRPr lang="te-IN" sz="2200" dirty="0">
+                <a:latin typeface="Ramabhadra" panose="02000600000000000000" pitchFamily="2" charset="0"/>
+                <a:cs typeface="Ramabhadra" panose="02000600000000000000" pitchFamily="2" charset="0"/>
+              </a:endParaRPr>
             </a:p>
             <a:p>
               <a:pPr defTabSz="439781">
                 <a:defRPr/>
               </a:pPr>
-              <a:br>
-                <a:rPr lang="te-IN" sz="2300" dirty="0">
-                  <a:latin typeface="Ramabhadra" panose="02000600000000000000" pitchFamily="2" charset="0"/>
-                  <a:cs typeface="Ramabhadra" panose="02000600000000000000" pitchFamily="2" charset="0"/>
-                </a:rPr>
-              </a:br>
-              <a:r>
-                <a:rPr lang="te-IN" sz="2300" dirty="0">
-                  <a:latin typeface="Ramabhadra" panose="02000600000000000000" pitchFamily="2" charset="0"/>
-                  <a:cs typeface="Ramabhadra" panose="02000600000000000000" pitchFamily="2" charset="0"/>
-                </a:rPr>
-                <a:t>నూతన క్రియను చేయుచున్నానని</a:t>
-              </a:r>
-              <a:endParaRPr lang="en-IN" sz="2300" dirty="0">
+              <a:r>
+                <a:rPr lang="te-IN" sz="2200" dirty="0">
+                  <a:latin typeface="Ramabhadra" panose="02000600000000000000" pitchFamily="2" charset="0"/>
+                  <a:cs typeface="Ramabhadra" panose="02000600000000000000" pitchFamily="2" charset="0"/>
+                </a:rPr>
+                <a:t>నూత్న మనస్సు </a:t>
+              </a:r>
+              <a:r>
+                <a:rPr lang="en-US" sz="2200" dirty="0">
+                  <a:latin typeface="Ramabhadra" panose="02000600000000000000" pitchFamily="2" charset="0"/>
+                  <a:cs typeface="Ramabhadra" panose="02000600000000000000" pitchFamily="2" charset="0"/>
+                </a:rPr>
+                <a:t>-</a:t>
+              </a:r>
+              <a:r>
+                <a:rPr lang="te-IN" sz="2200" dirty="0">
+                  <a:latin typeface="Ramabhadra" panose="02000600000000000000" pitchFamily="2" charset="0"/>
+                  <a:cs typeface="Ramabhadra" panose="02000600000000000000" pitchFamily="2" charset="0"/>
+                </a:rPr>
+                <a:t> నూత్న ఆత్మను</a:t>
+              </a:r>
+            </a:p>
+            <a:p>
+              <a:pPr defTabSz="439781">
+                <a:defRPr/>
+              </a:pPr>
+              <a:r>
+                <a:rPr lang="te-IN" sz="2200" dirty="0">
+                  <a:latin typeface="Ramabhadra" panose="02000600000000000000" pitchFamily="2" charset="0"/>
+                  <a:cs typeface="Ramabhadra" panose="02000600000000000000" pitchFamily="2" charset="0"/>
+                </a:rPr>
+                <a:t>- నూత్నజీవమును నింపుము దేవా</a:t>
+              </a:r>
+            </a:p>
+            <a:p>
+              <a:pPr defTabSz="439781">
+                <a:defRPr/>
+              </a:pPr>
+              <a:r>
+                <a:rPr lang="te-IN" sz="2200" dirty="0">
+                  <a:latin typeface="Ramabhadra" panose="02000600000000000000" pitchFamily="2" charset="0"/>
+                  <a:cs typeface="Ramabhadra" panose="02000600000000000000" pitchFamily="2" charset="0"/>
+                </a:rPr>
+                <a:t>రాతిగుండెనే మార్చు యేసయ్యా –</a:t>
+              </a:r>
+            </a:p>
+            <a:p>
+              <a:pPr defTabSz="439781">
+                <a:defRPr/>
+              </a:pPr>
+              <a:r>
+                <a:rPr lang="te-IN" sz="2200" dirty="0">
+                  <a:latin typeface="Ramabhadra" panose="02000600000000000000" pitchFamily="2" charset="0"/>
+                  <a:cs typeface="Ramabhadra" panose="02000600000000000000" pitchFamily="2" charset="0"/>
+                </a:rPr>
+                <a:t>మాంసపు గుండెనే అమర్చుమో దేవా</a:t>
+              </a:r>
+            </a:p>
+            <a:p>
+              <a:pPr defTabSz="439781">
+                <a:defRPr/>
+              </a:pPr>
+              <a:r>
+                <a:rPr lang="te-IN" sz="2200" dirty="0">
+                  <a:latin typeface="Ramabhadra" panose="02000600000000000000" pitchFamily="2" charset="0"/>
+                  <a:cs typeface="Ramabhadra" panose="02000600000000000000" pitchFamily="2" charset="0"/>
+                </a:rPr>
+                <a:t>నీ హృదయము నాకిమ్మయ్యా –</a:t>
+              </a:r>
+            </a:p>
+            <a:p>
+              <a:pPr defTabSz="439781">
+                <a:defRPr/>
+              </a:pPr>
+              <a:r>
+                <a:rPr lang="te-IN" sz="2200" dirty="0">
+                  <a:latin typeface="Ramabhadra" panose="02000600000000000000" pitchFamily="2" charset="0"/>
+                  <a:cs typeface="Ramabhadra" panose="02000600000000000000" pitchFamily="2" charset="0"/>
+                </a:rPr>
+                <a:t>లోకాన్ని నీకై సంపాదించెదా</a:t>
+              </a:r>
+              <a:r>
+                <a:rPr lang="en-US" sz="2200" dirty="0">
+                  <a:latin typeface="Ramabhadra" panose="02000600000000000000" pitchFamily="2" charset="0"/>
+                  <a:cs typeface="Ramabhadra" panose="02000600000000000000" pitchFamily="2" charset="0"/>
+                </a:rPr>
+                <a:t> (2)</a:t>
+              </a:r>
+              <a:endParaRPr lang="te-IN" sz="2200" dirty="0">
                 <a:latin typeface="Ramabhadra" panose="02000600000000000000" pitchFamily="2" charset="0"/>
                 <a:cs typeface="Ramabhadra" panose="02000600000000000000" pitchFamily="2" charset="0"/>
               </a:endParaRPr>
-            </a:p>
-            <a:p>
-              <a:pPr defTabSz="439781">
-                <a:defRPr/>
-              </a:pPr>
-              <a:r>
-                <a:rPr lang="te-IN" sz="2300" dirty="0">
-                  <a:latin typeface="Ramabhadra" panose="02000600000000000000" pitchFamily="2" charset="0"/>
-                  <a:cs typeface="Ramabhadra" panose="02000600000000000000" pitchFamily="2" charset="0"/>
-                </a:rPr>
-                <a:t>నీవు సెలవీయ్యగా </a:t>
-              </a:r>
-            </a:p>
-            <a:p>
-              <a:pPr defTabSz="439781">
-                <a:defRPr/>
-              </a:pPr>
-              <a:r>
-                <a:rPr lang="te-IN" sz="2300" dirty="0">
-                  <a:latin typeface="Ramabhadra" panose="02000600000000000000" pitchFamily="2" charset="0"/>
-                  <a:cs typeface="Ramabhadra" panose="02000600000000000000" pitchFamily="2" charset="0"/>
-                </a:rPr>
-                <a:t>నా ఎడారి జీవితమే సుఖ సౌఖ్యము కాగా -2</a:t>
-              </a:r>
-            </a:p>
-            <a:p>
-              <a:pPr defTabSz="439781">
-                <a:defRPr/>
-              </a:pPr>
-              <a:r>
-                <a:rPr lang="te-IN" sz="2300" dirty="0">
-                  <a:latin typeface="Ramabhadra" panose="02000600000000000000" pitchFamily="2" charset="0"/>
-                  <a:cs typeface="Ramabhadra" panose="02000600000000000000" pitchFamily="2" charset="0"/>
-                </a:rPr>
-                <a:t>నా అరణ్య రోదన</a:t>
-              </a:r>
-              <a:endParaRPr lang="en-IN" sz="2300" dirty="0">
-                <a:latin typeface="Ramabhadra" panose="02000600000000000000" pitchFamily="2" charset="0"/>
-                <a:cs typeface="Ramabhadra" panose="02000600000000000000" pitchFamily="2" charset="0"/>
-              </a:endParaRPr>
-            </a:p>
-            <a:p>
-              <a:pPr defTabSz="439781">
-                <a:defRPr/>
-              </a:pPr>
-              <a:r>
-                <a:rPr lang="te-IN" sz="2300" dirty="0">
-                  <a:latin typeface="Ramabhadra" panose="02000600000000000000" pitchFamily="2" charset="0"/>
-                  <a:cs typeface="Ramabhadra" panose="02000600000000000000" pitchFamily="2" charset="0"/>
-                </a:rPr>
-                <a:t>ఉల్లాసముగా మారిపోయెనే - 2                    </a:t>
-              </a:r>
             </a:p>
           </p:txBody>
         </p:sp>
@@ -4107,9 +4211,9 @@
         <p:grpSpPr>
           <a:xfrm>
             <a:off x="5104338" y="182031"/>
-            <a:ext cx="4801662" cy="6493935"/>
+            <a:ext cx="4930770" cy="6493935"/>
             <a:chOff x="160868" y="182032"/>
-            <a:chExt cx="4801662" cy="6493935"/>
+            <a:chExt cx="4930770" cy="6493935"/>
           </a:xfrm>
         </p:grpSpPr>
         <p:sp>
@@ -4181,8 +4285,8 @@
           </p:nvSpPr>
           <p:spPr>
             <a:xfrm>
-              <a:off x="212729" y="286334"/>
-              <a:ext cx="4749801" cy="5755422"/>
+              <a:off x="341837" y="324434"/>
+              <a:ext cx="4749801" cy="6232475"/>
             </a:xfrm>
             <a:prstGeom prst="rect">
               <a:avLst/>
@@ -4199,13 +4303,54 @@
                 <a:defRPr/>
               </a:pPr>
               <a:r>
-                <a:rPr lang="te-IN" sz="2300" dirty="0">
-                  <a:latin typeface="Ramabhadra" panose="02000600000000000000" pitchFamily="2" charset="0"/>
-                  <a:cs typeface="Ramabhadra" panose="02000600000000000000" pitchFamily="2" charset="0"/>
-                </a:rPr>
-                <a:t>నమ్మదగిన వాడవు సహాయుడవు యేసయ్య</a:t>
-              </a:r>
-              <a:endParaRPr lang="en-IN" sz="2300" dirty="0">
+                <a:rPr lang="te-IN" sz="2100" dirty="0">
+                  <a:latin typeface="Ramabhadra" panose="02000600000000000000" pitchFamily="2" charset="0"/>
+                  <a:cs typeface="Ramabhadra" panose="02000600000000000000" pitchFamily="2" charset="0"/>
+                </a:rPr>
+                <a:t>స్తుతులన్ గైకొనుమా</a:t>
+              </a:r>
+            </a:p>
+            <a:p>
+              <a:pPr defTabSz="439781">
+                <a:defRPr/>
+              </a:pPr>
+              <a:r>
+                <a:rPr lang="te-IN" sz="2100" dirty="0">
+                  <a:latin typeface="Ramabhadra" panose="02000600000000000000" pitchFamily="2" charset="0"/>
+                  <a:cs typeface="Ramabhadra" panose="02000600000000000000" pitchFamily="2" charset="0"/>
+                </a:rPr>
+                <a:t>సుత యేసు క్రీస్తువా</a:t>
+              </a:r>
+            </a:p>
+            <a:p>
+              <a:pPr defTabSz="439781">
+                <a:defRPr/>
+              </a:pPr>
+              <a:r>
+                <a:rPr lang="te-IN" sz="2100" dirty="0">
+                  <a:latin typeface="Ramabhadra" panose="02000600000000000000" pitchFamily="2" charset="0"/>
+                  <a:cs typeface="Ramabhadra" panose="02000600000000000000" pitchFamily="2" charset="0"/>
+                </a:rPr>
+                <a:t>సతతము మమ్ములను </a:t>
+              </a:r>
+            </a:p>
+            <a:p>
+              <a:pPr defTabSz="439781">
+                <a:defRPr/>
+              </a:pPr>
+              <a:r>
+                <a:rPr lang="te-IN" sz="2100" dirty="0">
+                  <a:latin typeface="Ramabhadra" panose="02000600000000000000" pitchFamily="2" charset="0"/>
+                  <a:cs typeface="Ramabhadra" panose="02000600000000000000" pitchFamily="2" charset="0"/>
+                </a:rPr>
+                <a:t>కృపనిడి కావుమా</a:t>
+              </a:r>
+            </a:p>
+            <a:p>
+              <a:pPr defTabSz="439781">
+                <a:defRPr/>
+              </a:pPr>
+              <a:endParaRPr lang="te-IN" sz="2100" dirty="0">
                 <a:latin typeface="Ramabhadra" panose="02000600000000000000" pitchFamily="2" charset="0"/>
                 <a:cs typeface="Ramabhadra" panose="02000600000000000000" pitchFamily="2" charset="0"/>
               </a:endParaRPr>
@@ -4215,13 +4360,54 @@
                 <a:defRPr/>
               </a:pPr>
               <a:r>
-                <a:rPr lang="te-IN" sz="2300" dirty="0">
-                  <a:latin typeface="Ramabhadra" panose="02000600000000000000" pitchFamily="2" charset="0"/>
-                  <a:cs typeface="Ramabhadra" panose="02000600000000000000" pitchFamily="2" charset="0"/>
-                </a:rPr>
-                <a:t>అపత్కాలములో ఆశ్రయమైనది నీవేనయ్యా</a:t>
-              </a:r>
-              <a:endParaRPr lang="en-IN" sz="2300" dirty="0">
+                <a:rPr lang="te-IN" sz="2100" dirty="0">
+                  <a:latin typeface="Ramabhadra" panose="02000600000000000000" pitchFamily="2" charset="0"/>
+                  <a:cs typeface="Ramabhadra" panose="02000600000000000000" pitchFamily="2" charset="0"/>
+                </a:rPr>
+                <a:t>మా పెదవులతో ఎప్పుడు నీ</a:t>
+              </a:r>
+            </a:p>
+            <a:p>
+              <a:pPr defTabSz="439781">
+                <a:defRPr/>
+              </a:pPr>
+              <a:r>
+                <a:rPr lang="te-IN" sz="2100" dirty="0">
+                  <a:latin typeface="Ramabhadra" panose="02000600000000000000" pitchFamily="2" charset="0"/>
+                  <a:cs typeface="Ramabhadra" panose="02000600000000000000" pitchFamily="2" charset="0"/>
+                </a:rPr>
+                <a:t>వాక్యమును పఠింప నిమ్ము</a:t>
+              </a:r>
+            </a:p>
+            <a:p>
+              <a:pPr defTabSz="439781">
+                <a:defRPr/>
+              </a:pPr>
+              <a:r>
+                <a:rPr lang="te-IN" sz="2100" dirty="0">
+                  <a:latin typeface="Ramabhadra" panose="02000600000000000000" pitchFamily="2" charset="0"/>
+                  <a:cs typeface="Ramabhadra" panose="02000600000000000000" pitchFamily="2" charset="0"/>
+                </a:rPr>
+                <a:t>మా కాలు చేతులు ఎప్పుడు నీ </a:t>
+              </a:r>
+            </a:p>
+            <a:p>
+              <a:pPr defTabSz="439781">
+                <a:defRPr/>
+              </a:pPr>
+              <a:r>
+                <a:rPr lang="te-IN" sz="2100" dirty="0">
+                  <a:latin typeface="Ramabhadra" panose="02000600000000000000" pitchFamily="2" charset="0"/>
+                  <a:cs typeface="Ramabhadra" panose="02000600000000000000" pitchFamily="2" charset="0"/>
+                </a:rPr>
+                <a:t>సేవను చేయను వాడనిమ్ము </a:t>
+              </a:r>
+            </a:p>
+            <a:p>
+              <a:pPr defTabSz="439781">
+                <a:defRPr/>
+              </a:pPr>
+              <a:endParaRPr lang="te-IN" sz="2100" dirty="0">
                 <a:latin typeface="Ramabhadra" panose="02000600000000000000" pitchFamily="2" charset="0"/>
                 <a:cs typeface="Ramabhadra" panose="02000600000000000000" pitchFamily="2" charset="0"/>
               </a:endParaRPr>
@@ -4231,13 +4417,54 @@
                 <a:defRPr/>
               </a:pPr>
               <a:r>
-                <a:rPr lang="te-IN" sz="2300" dirty="0">
-                  <a:latin typeface="Ramabhadra" panose="02000600000000000000" pitchFamily="2" charset="0"/>
-                  <a:cs typeface="Ramabhadra" panose="02000600000000000000" pitchFamily="2" charset="0"/>
-                </a:rPr>
-                <a:t>చెరనుండి విడిపించి చెలిమితో బంధించి</a:t>
-              </a:r>
-              <a:endParaRPr lang="en-IN" sz="2300" dirty="0">
+                <a:rPr lang="te-IN" sz="2100" dirty="0">
+                  <a:latin typeface="Ramabhadra" panose="02000600000000000000" pitchFamily="2" charset="0"/>
+                  <a:cs typeface="Ramabhadra" panose="02000600000000000000" pitchFamily="2" charset="0"/>
+                </a:rPr>
+                <a:t>మా కలిమియు పదవుల నెల్ల </a:t>
+              </a:r>
+            </a:p>
+            <a:p>
+              <a:pPr defTabSz="439781">
+                <a:defRPr/>
+              </a:pPr>
+              <a:r>
+                <a:rPr lang="te-IN" sz="2100" dirty="0">
+                  <a:latin typeface="Ramabhadra" panose="02000600000000000000" pitchFamily="2" charset="0"/>
+                  <a:cs typeface="Ramabhadra" panose="02000600000000000000" pitchFamily="2" charset="0"/>
+                </a:rPr>
+                <a:t>నీ శుద్ధ కృపచే పొందితిమి </a:t>
+              </a:r>
+            </a:p>
+            <a:p>
+              <a:pPr defTabSz="439781">
+                <a:defRPr/>
+              </a:pPr>
+              <a:r>
+                <a:rPr lang="te-IN" sz="2100" dirty="0">
+                  <a:latin typeface="Ramabhadra" panose="02000600000000000000" pitchFamily="2" charset="0"/>
+                  <a:cs typeface="Ramabhadra" panose="02000600000000000000" pitchFamily="2" charset="0"/>
+                </a:rPr>
+                <a:t>మా కాలమంతయు జీవింప </a:t>
+              </a:r>
+            </a:p>
+            <a:p>
+              <a:pPr defTabSz="439781">
+                <a:defRPr/>
+              </a:pPr>
+              <a:r>
+                <a:rPr lang="te-IN" sz="2100" dirty="0">
+                  <a:latin typeface="Ramabhadra" panose="02000600000000000000" pitchFamily="2" charset="0"/>
+                  <a:cs typeface="Ramabhadra" panose="02000600000000000000" pitchFamily="2" charset="0"/>
+                </a:rPr>
+                <a:t>నిలకడగ నుండ దీవించుము</a:t>
+              </a:r>
+            </a:p>
+            <a:p>
+              <a:pPr defTabSz="439781">
+                <a:defRPr/>
+              </a:pPr>
+              <a:endParaRPr lang="te-IN" sz="2100" dirty="0">
                 <a:latin typeface="Ramabhadra" panose="02000600000000000000" pitchFamily="2" charset="0"/>
                 <a:cs typeface="Ramabhadra" panose="02000600000000000000" pitchFamily="2" charset="0"/>
               </a:endParaRPr>
@@ -4247,182 +4474,48 @@
                 <a:defRPr/>
               </a:pPr>
               <a:r>
-                <a:rPr lang="te-IN" sz="2300" dirty="0">
-                  <a:latin typeface="Ramabhadra" panose="02000600000000000000" pitchFamily="2" charset="0"/>
-                  <a:cs typeface="Ramabhadra" panose="02000600000000000000" pitchFamily="2" charset="0"/>
-                </a:rPr>
-                <a:t>నడిపించినావే మందవలె నీ స్వాస్థ్యమును</a:t>
-              </a:r>
-              <a:endParaRPr lang="en-IN" sz="2300" dirty="0">
-                <a:latin typeface="Ramabhadra" panose="02000600000000000000" pitchFamily="2" charset="0"/>
-                <a:cs typeface="Ramabhadra" panose="02000600000000000000" pitchFamily="2" charset="0"/>
-              </a:endParaRPr>
+                <a:rPr lang="te-IN" sz="2100" dirty="0">
+                  <a:latin typeface="Ramabhadra" panose="02000600000000000000" pitchFamily="2" charset="0"/>
+                  <a:cs typeface="Ramabhadra" panose="02000600000000000000" pitchFamily="2" charset="0"/>
+                </a:rPr>
+                <a:t>నిజ విశ్వాసములో నెదుగ</a:t>
+              </a:r>
             </a:p>
             <a:p>
               <a:pPr defTabSz="439781">
                 <a:defRPr/>
               </a:pPr>
-              <a:endParaRPr lang="en-IN" sz="2300" dirty="0">
-                <a:latin typeface="Ramabhadra" panose="02000600000000000000" pitchFamily="2" charset="0"/>
-                <a:cs typeface="Ramabhadra" panose="02000600000000000000" pitchFamily="2" charset="0"/>
-              </a:endParaRPr>
+              <a:r>
+                <a:rPr lang="te-IN" sz="2100" dirty="0">
+                  <a:latin typeface="Ramabhadra" panose="02000600000000000000" pitchFamily="2" charset="0"/>
+                  <a:cs typeface="Ramabhadra" panose="02000600000000000000" pitchFamily="2" charset="0"/>
+                </a:rPr>
+                <a:t>నిశ్భల బుద్దిని మా కొసగి</a:t>
+              </a:r>
             </a:p>
             <a:p>
               <a:pPr defTabSz="439781">
                 <a:defRPr/>
               </a:pPr>
               <a:r>
-                <a:rPr lang="te-IN" sz="2300" dirty="0">
-                  <a:latin typeface="Ramabhadra" panose="02000600000000000000" pitchFamily="2" charset="0"/>
-                  <a:cs typeface="Ramabhadra" panose="02000600000000000000" pitchFamily="2" charset="0"/>
-                </a:rPr>
-                <a:t>నీ జనులకు నీవు న్యాయాధిపతివైతివే</a:t>
-              </a:r>
-              <a:endParaRPr lang="en-IN" sz="2300" dirty="0">
-                <a:latin typeface="Ramabhadra" panose="02000600000000000000" pitchFamily="2" charset="0"/>
-                <a:cs typeface="Ramabhadra" panose="02000600000000000000" pitchFamily="2" charset="0"/>
-              </a:endParaRPr>
+                <a:rPr lang="te-IN" sz="2100" dirty="0">
+                  <a:latin typeface="Ramabhadra" panose="02000600000000000000" pitchFamily="2" charset="0"/>
+                  <a:cs typeface="Ramabhadra" panose="02000600000000000000" pitchFamily="2" charset="0"/>
+                </a:rPr>
+                <a:t>నిరతము నీ సేవ చేయుటకు</a:t>
+              </a:r>
             </a:p>
             <a:p>
               <a:pPr defTabSz="439781">
                 <a:defRPr/>
               </a:pPr>
               <a:r>
-                <a:rPr lang="te-IN" sz="2300" dirty="0">
-                  <a:latin typeface="Ramabhadra" panose="02000600000000000000" pitchFamily="2" charset="0"/>
-                  <a:cs typeface="Ramabhadra" panose="02000600000000000000" pitchFamily="2" charset="0"/>
-                </a:rPr>
-                <a:t>శత్రువుల కోటలన్ని కూలిపోయెను</a:t>
-              </a:r>
-              <a:endParaRPr lang="en-IN" sz="2300" dirty="0">
-                <a:latin typeface="Ramabhadra" panose="02000600000000000000" pitchFamily="2" charset="0"/>
-                <a:cs typeface="Ramabhadra" panose="02000600000000000000" pitchFamily="2" charset="0"/>
-              </a:endParaRPr>
-            </a:p>
-            <a:p>
-              <a:pPr defTabSz="439781">
-                <a:defRPr/>
-              </a:pPr>
-              <a:r>
-                <a:rPr lang="te-IN" sz="2300" dirty="0">
-                  <a:latin typeface="Ramabhadra" panose="02000600000000000000" pitchFamily="2" charset="0"/>
-                  <a:cs typeface="Ramabhadra" panose="02000600000000000000" pitchFamily="2" charset="0"/>
-                </a:rPr>
-                <a:t>సంకెళ్ళ సంబరాలు మూగబోయెను</a:t>
-              </a:r>
-              <a:endParaRPr lang="en-IN" sz="2300" dirty="0">
-                <a:latin typeface="Ramabhadra" panose="02000600000000000000" pitchFamily="2" charset="0"/>
-                <a:cs typeface="Ramabhadra" panose="02000600000000000000" pitchFamily="2" charset="0"/>
-              </a:endParaRPr>
-            </a:p>
-            <a:p>
-              <a:pPr defTabSz="439781">
-                <a:defRPr/>
-              </a:pPr>
-              <a:r>
-                <a:rPr lang="te-IN" sz="2300" dirty="0">
-                  <a:latin typeface="Ramabhadra" panose="02000600000000000000" pitchFamily="2" charset="0"/>
-                  <a:cs typeface="Ramabhadra" panose="02000600000000000000" pitchFamily="2" charset="0"/>
-                </a:rPr>
-                <a:t>నిరీక్షణ కర్తవైన నిన్నే నమ్మిన ప్రజలు</a:t>
-              </a:r>
-              <a:endParaRPr lang="en-IN" sz="2300" dirty="0">
-                <a:latin typeface="Ramabhadra" panose="02000600000000000000" pitchFamily="2" charset="0"/>
-                <a:cs typeface="Ramabhadra" panose="02000600000000000000" pitchFamily="2" charset="0"/>
-              </a:endParaRPr>
-            </a:p>
-            <a:p>
-              <a:pPr defTabSz="439781">
-                <a:defRPr/>
-              </a:pPr>
-              <a:r>
-                <a:rPr lang="te-IN" sz="2300" dirty="0">
-                  <a:latin typeface="Ramabhadra" panose="02000600000000000000" pitchFamily="2" charset="0"/>
-                  <a:cs typeface="Ramabhadra" panose="02000600000000000000" pitchFamily="2" charset="0"/>
-                </a:rPr>
-                <a:t>నిత్యానందబారితులై సీయోనుకు తిరిగివచ్చెను</a:t>
-              </a:r>
-              <a:endParaRPr lang="en-IN" sz="2300" dirty="0">
-                <a:latin typeface="Ramabhadra" panose="02000600000000000000" pitchFamily="2" charset="0"/>
-                <a:cs typeface="Ramabhadra" panose="02000600000000000000" pitchFamily="2" charset="0"/>
-              </a:endParaRPr>
-            </a:p>
-            <a:p>
-              <a:pPr defTabSz="439781">
-                <a:defRPr/>
-              </a:pPr>
-              <a:endParaRPr lang="en-IN" sz="2300" dirty="0">
-                <a:latin typeface="Ramabhadra" panose="02000600000000000000" pitchFamily="2" charset="0"/>
-                <a:cs typeface="Ramabhadra" panose="02000600000000000000" pitchFamily="2" charset="0"/>
-              </a:endParaRPr>
-            </a:p>
-            <a:p>
-              <a:pPr defTabSz="439781">
-                <a:defRPr/>
-              </a:pPr>
-              <a:r>
-                <a:rPr lang="te-IN" sz="2300" dirty="0">
-                  <a:latin typeface="Ramabhadra" panose="02000600000000000000" pitchFamily="2" charset="0"/>
-                  <a:cs typeface="Ramabhadra" panose="02000600000000000000" pitchFamily="2" charset="0"/>
-                </a:rPr>
-                <a:t>నీ ప్రియులను నీవు కాపాడే మంచి కాపరి</a:t>
-              </a:r>
-              <a:endParaRPr lang="en-IN" sz="2300" dirty="0">
-                <a:latin typeface="Ramabhadra" panose="02000600000000000000" pitchFamily="2" charset="0"/>
-                <a:cs typeface="Ramabhadra" panose="02000600000000000000" pitchFamily="2" charset="0"/>
-              </a:endParaRPr>
-            </a:p>
-            <a:p>
-              <a:pPr defTabSz="439781">
-                <a:defRPr/>
-              </a:pPr>
-              <a:r>
-                <a:rPr lang="te-IN" sz="2300" dirty="0">
-                  <a:latin typeface="Ramabhadra" panose="02000600000000000000" pitchFamily="2" charset="0"/>
-                  <a:cs typeface="Ramabhadra" panose="02000600000000000000" pitchFamily="2" charset="0"/>
-                </a:rPr>
-                <a:t>జఠిలమైన త్రోవలన్ని దాటించితివి</a:t>
-              </a:r>
-            </a:p>
-            <a:p>
-              <a:pPr defTabSz="439781">
-                <a:defRPr/>
-              </a:pPr>
-              <a:r>
-                <a:rPr lang="te-IN" sz="2300" dirty="0">
-                  <a:latin typeface="Ramabhadra" panose="02000600000000000000" pitchFamily="2" charset="0"/>
-                  <a:cs typeface="Ramabhadra" panose="02000600000000000000" pitchFamily="2" charset="0"/>
-                </a:rPr>
-                <a:t>సంమృద్ది జీవముతో పొషించితివి</a:t>
-              </a:r>
-            </a:p>
-            <a:p>
-              <a:pPr defTabSz="439781">
-                <a:defRPr/>
-              </a:pPr>
-              <a:r>
-                <a:rPr lang="te-IN" sz="2300" dirty="0">
-                  <a:latin typeface="Ramabhadra" panose="02000600000000000000" pitchFamily="2" charset="0"/>
-                  <a:cs typeface="Ramabhadra" panose="02000600000000000000" pitchFamily="2" charset="0"/>
-                </a:rPr>
-                <a:t>ఆలోచన కర్తవైన నీ స్వరమే వినగా</a:t>
-              </a:r>
-            </a:p>
-            <a:p>
-              <a:pPr defTabSz="439781">
-                <a:defRPr/>
-              </a:pPr>
-              <a:r>
-                <a:rPr lang="te-IN" sz="2300" dirty="0">
-                  <a:latin typeface="Ramabhadra" panose="02000600000000000000" pitchFamily="2" charset="0"/>
-                  <a:cs typeface="Ramabhadra" panose="02000600000000000000" pitchFamily="2" charset="0"/>
-                </a:rPr>
-                <a:t>నిత్యాఆదరణను పొంది నీ క్రియలను వివరించగా</a:t>
-              </a:r>
-              <a:endParaRPr lang="en-IN" sz="2300" dirty="0">
-                <a:latin typeface="Ramabhadra" panose="02000600000000000000" pitchFamily="2" charset="0"/>
-                <a:cs typeface="Ramabhadra" panose="02000600000000000000" pitchFamily="2" charset="0"/>
-              </a:endParaRPr>
+                <a:rPr lang="te-IN" sz="2100" dirty="0">
+                  <a:latin typeface="Ramabhadra" panose="02000600000000000000" pitchFamily="2" charset="0"/>
+                  <a:cs typeface="Ramabhadra" panose="02000600000000000000" pitchFamily="2" charset="0"/>
+                </a:rPr>
+                <a:t>నీ ఆత్మ శక్తితో నింపుమయా </a:t>
+              </a:r>
             </a:p>
           </p:txBody>
         </p:sp>

</xml_diff>

<commit_message>
19 jan 25 songs
</commit_message>
<xml_diff>
--- a/songsTemplate.pptx
+++ b/songsTemplate.pptx
@@ -255,7 +255,7 @@
           <a:p>
             <a:fld id="{F1102B08-ED9E-409F-B95F-09CAA1DAF6E0}" type="datetimeFigureOut">
               <a:rPr lang="en-IN" smtClean="0"/>
-              <a:t>11-01-2025</a:t>
+              <a:t>18-01-2025</a:t>
             </a:fld>
             <a:endParaRPr lang="en-IN"/>
           </a:p>
@@ -425,7 +425,7 @@
           <a:p>
             <a:fld id="{F1102B08-ED9E-409F-B95F-09CAA1DAF6E0}" type="datetimeFigureOut">
               <a:rPr lang="en-IN" smtClean="0"/>
-              <a:t>11-01-2025</a:t>
+              <a:t>18-01-2025</a:t>
             </a:fld>
             <a:endParaRPr lang="en-IN"/>
           </a:p>
@@ -605,7 +605,7 @@
           <a:p>
             <a:fld id="{F1102B08-ED9E-409F-B95F-09CAA1DAF6E0}" type="datetimeFigureOut">
               <a:rPr lang="en-IN" smtClean="0"/>
-              <a:t>11-01-2025</a:t>
+              <a:t>18-01-2025</a:t>
             </a:fld>
             <a:endParaRPr lang="en-IN"/>
           </a:p>
@@ -775,7 +775,7 @@
           <a:p>
             <a:fld id="{F1102B08-ED9E-409F-B95F-09CAA1DAF6E0}" type="datetimeFigureOut">
               <a:rPr lang="en-IN" smtClean="0"/>
-              <a:t>11-01-2025</a:t>
+              <a:t>18-01-2025</a:t>
             </a:fld>
             <a:endParaRPr lang="en-IN"/>
           </a:p>
@@ -1019,7 +1019,7 @@
           <a:p>
             <a:fld id="{F1102B08-ED9E-409F-B95F-09CAA1DAF6E0}" type="datetimeFigureOut">
               <a:rPr lang="en-IN" smtClean="0"/>
-              <a:t>11-01-2025</a:t>
+              <a:t>18-01-2025</a:t>
             </a:fld>
             <a:endParaRPr lang="en-IN"/>
           </a:p>
@@ -1251,7 +1251,7 @@
           <a:p>
             <a:fld id="{F1102B08-ED9E-409F-B95F-09CAA1DAF6E0}" type="datetimeFigureOut">
               <a:rPr lang="en-IN" smtClean="0"/>
-              <a:t>11-01-2025</a:t>
+              <a:t>18-01-2025</a:t>
             </a:fld>
             <a:endParaRPr lang="en-IN"/>
           </a:p>
@@ -1618,7 +1618,7 @@
           <a:p>
             <a:fld id="{F1102B08-ED9E-409F-B95F-09CAA1DAF6E0}" type="datetimeFigureOut">
               <a:rPr lang="en-IN" smtClean="0"/>
-              <a:t>11-01-2025</a:t>
+              <a:t>18-01-2025</a:t>
             </a:fld>
             <a:endParaRPr lang="en-IN"/>
           </a:p>
@@ -1736,7 +1736,7 @@
           <a:p>
             <a:fld id="{F1102B08-ED9E-409F-B95F-09CAA1DAF6E0}" type="datetimeFigureOut">
               <a:rPr lang="en-IN" smtClean="0"/>
-              <a:t>11-01-2025</a:t>
+              <a:t>18-01-2025</a:t>
             </a:fld>
             <a:endParaRPr lang="en-IN"/>
           </a:p>
@@ -1831,7 +1831,7 @@
           <a:p>
             <a:fld id="{F1102B08-ED9E-409F-B95F-09CAA1DAF6E0}" type="datetimeFigureOut">
               <a:rPr lang="en-IN" smtClean="0"/>
-              <a:t>11-01-2025</a:t>
+              <a:t>18-01-2025</a:t>
             </a:fld>
             <a:endParaRPr lang="en-IN"/>
           </a:p>
@@ -2108,7 +2108,7 @@
           <a:p>
             <a:fld id="{F1102B08-ED9E-409F-B95F-09CAA1DAF6E0}" type="datetimeFigureOut">
               <a:rPr lang="en-IN" smtClean="0"/>
-              <a:t>11-01-2025</a:t>
+              <a:t>18-01-2025</a:t>
             </a:fld>
             <a:endParaRPr lang="en-IN"/>
           </a:p>
@@ -2365,7 +2365,7 @@
           <a:p>
             <a:fld id="{F1102B08-ED9E-409F-B95F-09CAA1DAF6E0}" type="datetimeFigureOut">
               <a:rPr lang="en-IN" smtClean="0"/>
-              <a:t>11-01-2025</a:t>
+              <a:t>18-01-2025</a:t>
             </a:fld>
             <a:endParaRPr lang="en-IN"/>
           </a:p>
@@ -2578,7 +2578,7 @@
           <a:p>
             <a:fld id="{F1102B08-ED9E-409F-B95F-09CAA1DAF6E0}" type="datetimeFigureOut">
               <a:rPr lang="en-IN" smtClean="0"/>
-              <a:t>11-01-2025</a:t>
+              <a:t>18-01-2025</a:t>
             </a:fld>
             <a:endParaRPr lang="en-IN"/>
           </a:p>
@@ -2998,9 +2998,9 @@
         <p:grpSpPr>
           <a:xfrm>
             <a:off x="160868" y="182031"/>
-            <a:ext cx="4648200" cy="6863417"/>
+            <a:ext cx="4648200" cy="6524863"/>
             <a:chOff x="160868" y="182031"/>
-            <a:chExt cx="4648200" cy="6863417"/>
+            <a:chExt cx="4648200" cy="6524863"/>
           </a:xfrm>
         </p:grpSpPr>
         <p:sp>
@@ -3073,7 +3073,7 @@
           <p:spPr>
             <a:xfrm>
               <a:off x="243398" y="182031"/>
-              <a:ext cx="4483140" cy="6863417"/>
+              <a:ext cx="4483140" cy="6524863"/>
             </a:xfrm>
             <a:prstGeom prst="rect">
               <a:avLst/>
@@ -3094,45 +3094,19 @@
                   <a:latin typeface="Ramabhadra" panose="02000600000000000000" pitchFamily="2" charset="0"/>
                   <a:cs typeface="Ramabhadra" panose="02000600000000000000" pitchFamily="2" charset="0"/>
                 </a:rPr>
-                <a:t>నిజమైన ద్రాక్షావల్లి నీవే</a:t>
-              </a:r>
-              <a:br>
+                <a:t>మంచి దేవుడు భలే మంచి దేవుడు</a:t>
+              </a:r>
+            </a:p>
+            <a:p>
+              <a:pPr defTabSz="439781">
+                <a:defRPr/>
+              </a:pPr>
+              <a:r>
                 <a:rPr lang="te-IN" sz="2200" dirty="0">
                   <a:latin typeface="Ramabhadra" panose="02000600000000000000" pitchFamily="2" charset="0"/>
                   <a:cs typeface="Ramabhadra" panose="02000600000000000000" pitchFamily="2" charset="0"/>
                 </a:rPr>
-              </a:br>
-              <a:r>
-                <a:rPr lang="te-IN" sz="2200" dirty="0">
-                  <a:latin typeface="Ramabhadra" panose="02000600000000000000" pitchFamily="2" charset="0"/>
-                  <a:cs typeface="Ramabhadra" panose="02000600000000000000" pitchFamily="2" charset="0"/>
-                </a:rPr>
-                <a:t>నిత్యమైన సంతోషము నీలోనే </a:t>
-              </a:r>
-              <a:br>
-                <a:rPr lang="te-IN" sz="2200" dirty="0">
-                  <a:latin typeface="Ramabhadra" panose="02000600000000000000" pitchFamily="2" charset="0"/>
-                  <a:cs typeface="Ramabhadra" panose="02000600000000000000" pitchFamily="2" charset="0"/>
-                </a:rPr>
-              </a:br>
-              <a:r>
-                <a:rPr lang="te-IN" sz="2200" dirty="0">
-                  <a:latin typeface="Ramabhadra" panose="02000600000000000000" pitchFamily="2" charset="0"/>
-                  <a:cs typeface="Ramabhadra" panose="02000600000000000000" pitchFamily="2" charset="0"/>
-                </a:rPr>
-                <a:t>శాశ్వతమైనది ఎంతో మధురమైనది</a:t>
-              </a:r>
-            </a:p>
-            <a:p>
-              <a:pPr defTabSz="439781">
-                <a:defRPr/>
-              </a:pPr>
-              <a:r>
-                <a:rPr lang="te-IN" sz="2200" dirty="0">
-                  <a:latin typeface="Ramabhadra" panose="02000600000000000000" pitchFamily="2" charset="0"/>
-                  <a:cs typeface="Ramabhadra" panose="02000600000000000000" pitchFamily="2" charset="0"/>
-                </a:rPr>
-                <a:t>నాపైన నీకున్న ప్రేమ ఎనలేని నీ ప్రేమ    </a:t>
+                <a:t>నిజ దైవం యేసు - అద్వితీయ దేవుడు</a:t>
               </a:r>
             </a:p>
             <a:p>
@@ -3153,47 +3127,60 @@
                   <a:latin typeface="Ramabhadra" panose="02000600000000000000" pitchFamily="2" charset="0"/>
                   <a:cs typeface="Ramabhadra" panose="02000600000000000000" pitchFamily="2" charset="0"/>
                 </a:rPr>
-                <a:t>అతి కాంక్షనీయుడా దివ్యమైన నీ రూపులో</a:t>
-              </a:r>
-              <a:br>
+                <a:t>మ్రొక్కులను కోరడు - మనసిస్తే చాలును</a:t>
+              </a:r>
+            </a:p>
+            <a:p>
+              <a:pPr defTabSz="439781">
+                <a:defRPr/>
+              </a:pPr>
+              <a:r>
                 <a:rPr lang="te-IN" sz="2200" dirty="0">
                   <a:latin typeface="Ramabhadra" panose="02000600000000000000" pitchFamily="2" charset="0"/>
                   <a:cs typeface="Ramabhadra" panose="02000600000000000000" pitchFamily="2" charset="0"/>
                 </a:rPr>
-              </a:br>
+                <a:t>కొండలెక్కి రమ్మనడు - మనలో కొలువుంటాడు</a:t>
+              </a:r>
+            </a:p>
+            <a:p>
+              <a:pPr defTabSz="439781">
+                <a:defRPr/>
+              </a:pPr>
               <a:r>
                 <a:rPr lang="te-IN" sz="2200" dirty="0">
                   <a:latin typeface="Ramabhadra" panose="02000600000000000000" pitchFamily="2" charset="0"/>
                   <a:cs typeface="Ramabhadra" panose="02000600000000000000" pitchFamily="2" charset="0"/>
                 </a:rPr>
-                <a:t>జీవించున్నాను నీ ప్రేమకు నే పత్రికగా </a:t>
-              </a:r>
-              <a:br>
+                <a:t>వెదికితే ప్రతి వారికి - దొరికేను యేసు</a:t>
+              </a:r>
+            </a:p>
+            <a:p>
+              <a:pPr defTabSz="439781">
+                <a:defRPr/>
+              </a:pPr>
+              <a:r>
                 <a:rPr lang="te-IN" sz="2200" dirty="0">
                   <a:latin typeface="Ramabhadra" panose="02000600000000000000" pitchFamily="2" charset="0"/>
                   <a:cs typeface="Ramabhadra" panose="02000600000000000000" pitchFamily="2" charset="0"/>
                 </a:rPr>
-              </a:br>
+                <a:t>పిలిచే ప్రతి వారికి - పలికేను యేసు</a:t>
+              </a:r>
+            </a:p>
+            <a:p>
+              <a:pPr defTabSz="439781">
+                <a:defRPr/>
+              </a:pPr>
               <a:r>
                 <a:rPr lang="te-IN" sz="2200" dirty="0">
                   <a:latin typeface="Ramabhadra" panose="02000600000000000000" pitchFamily="2" charset="0"/>
                   <a:cs typeface="Ramabhadra" panose="02000600000000000000" pitchFamily="2" charset="0"/>
                 </a:rPr>
-                <a:t>శిధిలమై యుండగా నన్ను నీదు రక్తముతో కడిగి</a:t>
-              </a:r>
-              <a:br>
-                <a:rPr lang="te-IN" sz="2200" dirty="0">
-                  <a:latin typeface="Ramabhadra" panose="02000600000000000000" pitchFamily="2" charset="0"/>
-                  <a:cs typeface="Ramabhadra" panose="02000600000000000000" pitchFamily="2" charset="0"/>
-                </a:rPr>
-              </a:br>
-              <a:r>
-                <a:rPr lang="te-IN" sz="2200" dirty="0">
-                  <a:latin typeface="Ramabhadra" panose="02000600000000000000" pitchFamily="2" charset="0"/>
-                  <a:cs typeface="Ramabhadra" panose="02000600000000000000" pitchFamily="2" charset="0"/>
-                </a:rPr>
-                <a:t>నీ పోలికగా మార్చినావే నా యేసయ్యా      </a:t>
-              </a:r>
+                <a:t>బొమ్మ కాదయ్యో - జీవమున్న దేవుడు</a:t>
+              </a:r>
+              <a:endParaRPr lang="en-IN" sz="2200" dirty="0">
+                <a:latin typeface="Ramabhadra" panose="02000600000000000000" pitchFamily="2" charset="0"/>
+                <a:cs typeface="Ramabhadra" panose="02000600000000000000" pitchFamily="2" charset="0"/>
+              </a:endParaRPr>
             </a:p>
             <a:p>
               <a:pPr defTabSz="439781">
@@ -3213,111 +3200,48 @@
                   <a:latin typeface="Ramabhadra" panose="02000600000000000000" pitchFamily="2" charset="0"/>
                   <a:cs typeface="Ramabhadra" panose="02000600000000000000" pitchFamily="2" charset="0"/>
                 </a:rPr>
-                <a:t>నా ప్రాణ ప్రియుడా శ్రేష్టమైన ఫలములతో</a:t>
-              </a:r>
-              <a:br>
+                <a:t>కుంటివాడు గంతులేయ - కాళ్ళ నొసగినాడు</a:t>
+              </a:r>
+            </a:p>
+            <a:p>
+              <a:pPr defTabSz="439781">
+                <a:defRPr/>
+              </a:pPr>
+              <a:r>
                 <a:rPr lang="te-IN" sz="2200" dirty="0">
                   <a:latin typeface="Ramabhadra" panose="02000600000000000000" pitchFamily="2" charset="0"/>
                   <a:cs typeface="Ramabhadra" panose="02000600000000000000" pitchFamily="2" charset="0"/>
                 </a:rPr>
-              </a:br>
+                <a:t>మూగవారు స్తుతిచేయ - నోటినిచ్చినాడు</a:t>
+              </a:r>
+            </a:p>
+            <a:p>
+              <a:pPr defTabSz="439781">
+                <a:defRPr/>
+              </a:pPr>
               <a:r>
                 <a:rPr lang="te-IN" sz="2200" dirty="0">
                   <a:latin typeface="Ramabhadra" panose="02000600000000000000" pitchFamily="2" charset="0"/>
                   <a:cs typeface="Ramabhadra" panose="02000600000000000000" pitchFamily="2" charset="0"/>
                 </a:rPr>
-                <a:t>అర్పించుచున్నాను సర్వము నీకే అర్పణగా </a:t>
-              </a:r>
-              <a:br>
+                <a:t>బధిరులు తన స్వరము విన - చెవులిచ్చినాడు</a:t>
+              </a:r>
+            </a:p>
+            <a:p>
+              <a:pPr defTabSz="439781">
+                <a:defRPr/>
+              </a:pPr>
+              <a:r>
                 <a:rPr lang="te-IN" sz="2200" dirty="0">
                   <a:latin typeface="Ramabhadra" panose="02000600000000000000" pitchFamily="2" charset="0"/>
                   <a:cs typeface="Ramabhadra" panose="02000600000000000000" pitchFamily="2" charset="0"/>
                 </a:rPr>
-              </a:br>
-              <a:r>
-                <a:rPr lang="te-IN" sz="2200" dirty="0">
-                  <a:latin typeface="Ramabhadra" panose="02000600000000000000" pitchFamily="2" charset="0"/>
-                  <a:cs typeface="Ramabhadra" panose="02000600000000000000" pitchFamily="2" charset="0"/>
-                </a:rPr>
-                <a:t>వాడిపోనివ్వక నాకు ఆశ్రయమైతివి నీవు</a:t>
-              </a:r>
-              <a:br>
-                <a:rPr lang="te-IN" sz="2200" dirty="0">
-                  <a:latin typeface="Ramabhadra" panose="02000600000000000000" pitchFamily="2" charset="0"/>
-                  <a:cs typeface="Ramabhadra" panose="02000600000000000000" pitchFamily="2" charset="0"/>
-                </a:rPr>
-              </a:br>
-              <a:r>
-                <a:rPr lang="te-IN" sz="2200" dirty="0">
-                  <a:latin typeface="Ramabhadra" panose="02000600000000000000" pitchFamily="2" charset="0"/>
-                  <a:cs typeface="Ramabhadra" panose="02000600000000000000" pitchFamily="2" charset="0"/>
-                </a:rPr>
-                <a:t>జీవపు ఊటవై బలపరచితివి నా యేసయ్యా </a:t>
-              </a:r>
-              <a:endParaRPr lang="en-US" sz="2200" dirty="0">
+                <a:t>ప్రేమా మయుడు - ఆశ్చర్య దేవుడు</a:t>
+              </a:r>
+              <a:endParaRPr lang="en-IN" sz="2200" dirty="0">
                 <a:latin typeface="Ramabhadra" panose="02000600000000000000" pitchFamily="2" charset="0"/>
                 <a:cs typeface="Ramabhadra" panose="02000600000000000000" pitchFamily="2" charset="0"/>
               </a:endParaRPr>
-            </a:p>
-            <a:p>
-              <a:pPr defTabSz="439781">
-                <a:defRPr/>
-              </a:pPr>
-              <a:endParaRPr lang="en-US" sz="2200" dirty="0">
-                <a:latin typeface="Ramabhadra" panose="02000600000000000000" pitchFamily="2" charset="0"/>
-                <a:cs typeface="Ramabhadra" panose="02000600000000000000" pitchFamily="2" charset="0"/>
-              </a:endParaRPr>
-            </a:p>
-            <a:p>
-              <a:pPr defTabSz="439781">
-                <a:defRPr/>
-              </a:pPr>
-              <a:r>
-                <a:rPr lang="te-IN" sz="2200" dirty="0">
-                  <a:latin typeface="Ramabhadra" panose="02000600000000000000" pitchFamily="2" charset="0"/>
-                  <a:cs typeface="Ramabhadra" panose="02000600000000000000" pitchFamily="2" charset="0"/>
-                </a:rPr>
-                <a:t>షాలేము రాజా రమ్యమైన సీయోనుకే</a:t>
-              </a:r>
-              <a:br>
-                <a:rPr lang="te-IN" sz="2200" dirty="0">
-                  <a:latin typeface="Ramabhadra" panose="02000600000000000000" pitchFamily="2" charset="0"/>
-                  <a:cs typeface="Ramabhadra" panose="02000600000000000000" pitchFamily="2" charset="0"/>
-                </a:rPr>
-              </a:br>
-              <a:r>
-                <a:rPr lang="te-IN" sz="2200" dirty="0">
-                  <a:latin typeface="Ramabhadra" panose="02000600000000000000" pitchFamily="2" charset="0"/>
-                  <a:cs typeface="Ramabhadra" panose="02000600000000000000" pitchFamily="2" charset="0"/>
-                </a:rPr>
-                <a:t>నను నడిపించుము నీ చిత్తమైన మార్గములో </a:t>
-              </a:r>
-              <a:br>
-                <a:rPr lang="te-IN" sz="2200" dirty="0">
-                  <a:latin typeface="Ramabhadra" panose="02000600000000000000" pitchFamily="2" charset="0"/>
-                  <a:cs typeface="Ramabhadra" panose="02000600000000000000" pitchFamily="2" charset="0"/>
-                </a:rPr>
-              </a:br>
-              <a:r>
-                <a:rPr lang="te-IN" sz="2200" dirty="0">
-                  <a:latin typeface="Ramabhadra" panose="02000600000000000000" pitchFamily="2" charset="0"/>
-                  <a:cs typeface="Ramabhadra" panose="02000600000000000000" pitchFamily="2" charset="0"/>
-                </a:rPr>
-                <a:t>అలసి పోనివ్వక నన్ను నీదు ఆత్మతో నింపి</a:t>
-              </a:r>
-              <a:br>
-                <a:rPr lang="te-IN" sz="2200" dirty="0">
-                  <a:latin typeface="Ramabhadra" panose="02000600000000000000" pitchFamily="2" charset="0"/>
-                  <a:cs typeface="Ramabhadra" panose="02000600000000000000" pitchFamily="2" charset="0"/>
-                </a:rPr>
-              </a:br>
-              <a:r>
-                <a:rPr lang="te-IN" sz="2200" dirty="0">
-                  <a:latin typeface="Ramabhadra" panose="02000600000000000000" pitchFamily="2" charset="0"/>
-                  <a:cs typeface="Ramabhadra" panose="02000600000000000000" pitchFamily="2" charset="0"/>
-                </a:rPr>
-                <a:t>ఆదరణ కర్తవై నను చేర్చుము నీ రాజ్యములో</a:t>
-              </a:r>
             </a:p>
             <a:p>
               <a:pPr defTabSz="439781">
@@ -3327,6 +3251,66 @@
                 <a:latin typeface="Ramabhadra" panose="02000600000000000000" pitchFamily="2" charset="0"/>
                 <a:cs typeface="Ramabhadra" panose="02000600000000000000" pitchFamily="2" charset="0"/>
               </a:endParaRPr>
+            </a:p>
+            <a:p>
+              <a:pPr defTabSz="439781">
+                <a:defRPr/>
+              </a:pPr>
+              <a:r>
+                <a:rPr lang="te-IN" sz="2200" dirty="0">
+                  <a:latin typeface="Ramabhadra" panose="02000600000000000000" pitchFamily="2" charset="0"/>
+                  <a:cs typeface="Ramabhadra" panose="02000600000000000000" pitchFamily="2" charset="0"/>
+                </a:rPr>
+                <a:t>చెప్పింది చేసెను - మాదిరుంచి వెళ్ళెను</a:t>
+              </a:r>
+            </a:p>
+            <a:p>
+              <a:pPr defTabSz="439781">
+                <a:defRPr/>
+              </a:pPr>
+              <a:r>
+                <a:rPr lang="te-IN" sz="2200" dirty="0">
+                  <a:latin typeface="Ramabhadra" panose="02000600000000000000" pitchFamily="2" charset="0"/>
+                  <a:cs typeface="Ramabhadra" panose="02000600000000000000" pitchFamily="2" charset="0"/>
+                </a:rPr>
+                <a:t>అడుగు జాడాలుంచెను - అనుసరించ కోరెను</a:t>
+              </a:r>
+            </a:p>
+            <a:p>
+              <a:pPr defTabSz="439781">
+                <a:defRPr/>
+              </a:pPr>
+              <a:r>
+                <a:rPr lang="te-IN" sz="2200" dirty="0">
+                  <a:latin typeface="Ramabhadra" panose="02000600000000000000" pitchFamily="2" charset="0"/>
+                  <a:cs typeface="Ramabhadra" panose="02000600000000000000" pitchFamily="2" charset="0"/>
+                </a:rPr>
+                <a:t>మరణాన్ని జీవాన్ని - మన ఎదుటే వుంచెను</a:t>
+              </a:r>
+            </a:p>
+            <a:p>
+              <a:pPr defTabSz="439781">
+                <a:defRPr/>
+              </a:pPr>
+              <a:r>
+                <a:rPr lang="te-IN" sz="2200" dirty="0">
+                  <a:latin typeface="Ramabhadra" panose="02000600000000000000" pitchFamily="2" charset="0"/>
+                  <a:cs typeface="Ramabhadra" panose="02000600000000000000" pitchFamily="2" charset="0"/>
+                </a:rPr>
+                <a:t>ఎంచుకొనే స్వేచ్చను - మన చేతికిచ్చెను</a:t>
+              </a:r>
+            </a:p>
+            <a:p>
+              <a:pPr defTabSz="439781">
+                <a:defRPr/>
+              </a:pPr>
+              <a:r>
+                <a:rPr lang="te-IN" sz="2200" dirty="0">
+                  <a:latin typeface="Ramabhadra" panose="02000600000000000000" pitchFamily="2" charset="0"/>
+                  <a:cs typeface="Ramabhadra" panose="02000600000000000000" pitchFamily="2" charset="0"/>
+                </a:rPr>
+                <a:t>ఏమి చేతువో - సృష్టికర్త యేసుని</a:t>
+              </a:r>
             </a:p>
           </p:txBody>
         </p:sp>
@@ -3408,9 +3392,9 @@
         <p:grpSpPr>
           <a:xfrm>
             <a:off x="5104338" y="182031"/>
-            <a:ext cx="5718029" cy="6524392"/>
+            <a:ext cx="5718029" cy="6493935"/>
             <a:chOff x="160868" y="182032"/>
-            <a:chExt cx="5718029" cy="6524392"/>
+            <a:chExt cx="5718029" cy="6493935"/>
           </a:xfrm>
         </p:grpSpPr>
         <p:sp>
@@ -3483,7 +3467,7 @@
           <p:spPr>
             <a:xfrm>
               <a:off x="264435" y="243116"/>
-              <a:ext cx="5614462" cy="6463308"/>
+              <a:ext cx="5614462" cy="6109365"/>
             </a:xfrm>
             <a:prstGeom prst="rect">
               <a:avLst/>
@@ -3501,16 +3485,21 @@
                   <a:latin typeface="Ramabhadra" panose="02000600000000000000" pitchFamily="2" charset="0"/>
                   <a:cs typeface="Ramabhadra" panose="02000600000000000000" pitchFamily="2" charset="0"/>
                 </a:rPr>
-                <a:t>నీ ప్రేమ ఎంతో అపారము</a:t>
-              </a:r>
-            </a:p>
-            <a:p>
+                <a:t>స్తుతి పాత్రుడా </a:t>
+              </a:r>
+              <a:r>
+                <a:rPr lang="en-IN" sz="2300" dirty="0">
+                  <a:latin typeface="Ramabhadra" panose="02000600000000000000" pitchFamily="2" charset="0"/>
+                  <a:cs typeface="Ramabhadra" panose="02000600000000000000" pitchFamily="2" charset="0"/>
+                </a:rPr>
+                <a:t>-</a:t>
+              </a:r>
               <a:r>
                 <a:rPr lang="te-IN" sz="2300" dirty="0">
                   <a:latin typeface="Ramabhadra" panose="02000600000000000000" pitchFamily="2" charset="0"/>
                   <a:cs typeface="Ramabhadra" panose="02000600000000000000" pitchFamily="2" charset="0"/>
                 </a:rPr>
-                <a:t>వర్ణింపతరమా నా ప్రభూ</a:t>
+                <a:t> స్తోత్రార్హుడా</a:t>
               </a:r>
             </a:p>
             <a:p>
@@ -3519,16 +3508,55 @@
                   <a:latin typeface="Ramabhadra" panose="02000600000000000000" pitchFamily="2" charset="0"/>
                   <a:cs typeface="Ramabhadra" panose="02000600000000000000" pitchFamily="2" charset="0"/>
                 </a:rPr>
-                <a:t>పులకింప చేసెను నా హృది</a:t>
-              </a:r>
-            </a:p>
-            <a:p>
+                <a:t>స్తుతులందుకో </a:t>
+              </a:r>
+              <a:r>
+                <a:rPr lang="en-IN" sz="2300" dirty="0">
+                  <a:latin typeface="Ramabhadra" panose="02000600000000000000" pitchFamily="2" charset="0"/>
+                  <a:cs typeface="Ramabhadra" panose="02000600000000000000" pitchFamily="2" charset="0"/>
+                </a:rPr>
+                <a:t>-</a:t>
+              </a:r>
               <a:r>
                 <a:rPr lang="te-IN" sz="2300" dirty="0">
                   <a:latin typeface="Ramabhadra" panose="02000600000000000000" pitchFamily="2" charset="0"/>
                   <a:cs typeface="Ramabhadra" panose="02000600000000000000" pitchFamily="2" charset="0"/>
                 </a:rPr>
-                <a:t>హృదయేశ్వరా నా యేసువా</a:t>
+                <a:t> పూజార్హుడా</a:t>
+              </a:r>
+            </a:p>
+            <a:p>
+              <a:r>
+                <a:rPr lang="te-IN" sz="2300" dirty="0">
+                  <a:latin typeface="Ramabhadra" panose="02000600000000000000" pitchFamily="2" charset="0"/>
+                  <a:cs typeface="Ramabhadra" panose="02000600000000000000" pitchFamily="2" charset="0"/>
+                </a:rPr>
+                <a:t>ఆకాశమందు నీవు తప్ప </a:t>
+              </a:r>
+              <a:r>
+                <a:rPr lang="en-IN" sz="2300" dirty="0">
+                  <a:latin typeface="Ramabhadra" panose="02000600000000000000" pitchFamily="2" charset="0"/>
+                  <a:cs typeface="Ramabhadra" panose="02000600000000000000" pitchFamily="2" charset="0"/>
+                </a:rPr>
+                <a:t>-</a:t>
+              </a:r>
+            </a:p>
+            <a:p>
+              <a:r>
+                <a:rPr lang="te-IN" sz="2300" dirty="0">
+                  <a:latin typeface="Ramabhadra" panose="02000600000000000000" pitchFamily="2" charset="0"/>
+                  <a:cs typeface="Ramabhadra" panose="02000600000000000000" pitchFamily="2" charset="0"/>
+                </a:rPr>
+                <a:t>నాకెవరున్నారు నా ప్రభు</a:t>
+              </a:r>
+            </a:p>
+            <a:p>
+              <a:r>
+                <a:rPr lang="te-IN" sz="2300" dirty="0">
+                  <a:latin typeface="Ramabhadra" panose="02000600000000000000" pitchFamily="2" charset="0"/>
+                  <a:cs typeface="Ramabhadra" panose="02000600000000000000" pitchFamily="2" charset="0"/>
+                </a:rPr>
+                <a:t>స్తుతి పాత్రుడా.... ఆఆఅ</a:t>
               </a:r>
             </a:p>
             <a:p>
@@ -3543,8 +3571,12 @@
                   <a:latin typeface="Ramabhadra" panose="02000600000000000000" pitchFamily="2" charset="0"/>
                   <a:cs typeface="Ramabhadra" panose="02000600000000000000" pitchFamily="2" charset="0"/>
                 </a:rPr>
-                <a:t>నన్ను ఎంతో ప్రేమించి</a:t>
-              </a:r>
+                <a:t>నా శత్రువులు నను తరుముచుండగా –</a:t>
+              </a:r>
+              <a:endParaRPr lang="en-IN" sz="2300" dirty="0">
+                <a:latin typeface="Ramabhadra" panose="02000600000000000000" pitchFamily="2" charset="0"/>
+                <a:cs typeface="Ramabhadra" panose="02000600000000000000" pitchFamily="2" charset="0"/>
+              </a:endParaRPr>
             </a:p>
             <a:p>
               <a:r>
@@ -3552,46 +3584,15 @@
                   <a:latin typeface="Ramabhadra" panose="02000600000000000000" pitchFamily="2" charset="0"/>
                   <a:cs typeface="Ramabhadra" panose="02000600000000000000" pitchFamily="2" charset="0"/>
                 </a:rPr>
-                <a:t>నాదు పాపమె క్షమియించి</a:t>
-              </a:r>
-            </a:p>
-            <a:p>
-              <a:r>
-                <a:rPr lang="te-IN" sz="2300" dirty="0">
-                  <a:latin typeface="Ramabhadra" panose="02000600000000000000" pitchFamily="2" charset="0"/>
-                  <a:cs typeface="Ramabhadra" panose="02000600000000000000" pitchFamily="2" charset="0"/>
-                </a:rPr>
-                <a:t>కృప కనికరముల నీడలో</a:t>
-              </a:r>
-            </a:p>
-            <a:p>
-              <a:r>
-                <a:rPr lang="te-IN" sz="2300" dirty="0">
-                  <a:latin typeface="Ramabhadra" panose="02000600000000000000" pitchFamily="2" charset="0"/>
-                  <a:cs typeface="Ramabhadra" panose="02000600000000000000" pitchFamily="2" charset="0"/>
-                </a:rPr>
-                <a:t>నన్ను చేర్చిన నా ప్రభూ</a:t>
-              </a:r>
-            </a:p>
-            <a:p>
-              <a:r>
-                <a:rPr lang="te-IN" sz="2300" dirty="0">
-                  <a:latin typeface="Ramabhadra" panose="02000600000000000000" pitchFamily="2" charset="0"/>
-                  <a:cs typeface="Ramabhadra" panose="02000600000000000000" pitchFamily="2" charset="0"/>
-                </a:rPr>
-                <a:t>జీవితమంతా స్తుతియించినా</a:t>
-              </a:r>
-            </a:p>
-            <a:p>
-              <a:r>
-                <a:rPr lang="te-IN" sz="2300" dirty="0">
-                  <a:latin typeface="Ramabhadra" panose="02000600000000000000" pitchFamily="2" charset="0"/>
-                  <a:cs typeface="Ramabhadra" panose="02000600000000000000" pitchFamily="2" charset="0"/>
-                </a:rPr>
-                <a:t>తీరునా నీ ఋణం</a:t>
-              </a:r>
-            </a:p>
-            <a:p>
+                <a:t>నా యాత్మ నాలో కృంగెనే ప్రభూ </a:t>
+              </a:r>
+              <a:r>
+                <a:rPr lang="en-IN" sz="2300" dirty="0">
+                  <a:latin typeface="Ramabhadra" panose="02000600000000000000" pitchFamily="2" charset="0"/>
+                  <a:cs typeface="Ramabhadra" panose="02000600000000000000" pitchFamily="2" charset="0"/>
+                </a:rPr>
+                <a:t>(2)</a:t>
+              </a:r>
               <a:endParaRPr lang="te-IN" sz="2300" dirty="0">
                 <a:latin typeface="Ramabhadra" panose="02000600000000000000" pitchFamily="2" charset="0"/>
                 <a:cs typeface="Ramabhadra" panose="02000600000000000000" pitchFamily="2" charset="0"/>
@@ -3603,8 +3604,12 @@
                   <a:latin typeface="Ramabhadra" panose="02000600000000000000" pitchFamily="2" charset="0"/>
                   <a:cs typeface="Ramabhadra" panose="02000600000000000000" pitchFamily="2" charset="0"/>
                 </a:rPr>
-                <a:t>నీదు సన్నిధిలో కాంక్షించి</a:t>
-              </a:r>
+                <a:t>నా మనస్సు నీ వైపు త్రిప్పిన వెంటనే –</a:t>
+              </a:r>
+              <a:endParaRPr lang="en-IN" sz="2300" dirty="0">
+                <a:latin typeface="Ramabhadra" panose="02000600000000000000" pitchFamily="2" charset="0"/>
+                <a:cs typeface="Ramabhadra" panose="02000600000000000000" pitchFamily="2" charset="0"/>
+              </a:endParaRPr>
             </a:p>
             <a:p>
               <a:r>
@@ -3612,17 +3617,26 @@
                   <a:latin typeface="Ramabhadra" panose="02000600000000000000" pitchFamily="2" charset="0"/>
                   <a:cs typeface="Ramabhadra" panose="02000600000000000000" pitchFamily="2" charset="0"/>
                 </a:rPr>
-                <a:t>పాప బ్రతుకే వీడితిని</a:t>
-              </a:r>
-            </a:p>
-            <a:p>
+                <a:t>శత్రుల చేతినుండి</a:t>
+              </a:r>
+              <a:r>
+                <a:rPr lang="en-IN" sz="2300" dirty="0">
+                  <a:latin typeface="Ramabhadra" panose="02000600000000000000" pitchFamily="2" charset="0"/>
+                  <a:cs typeface="Ramabhadra" panose="02000600000000000000" pitchFamily="2" charset="0"/>
+                </a:rPr>
+                <a:t> </a:t>
+              </a:r>
               <a:r>
                 <a:rPr lang="te-IN" sz="2300" dirty="0">
                   <a:latin typeface="Ramabhadra" panose="02000600000000000000" pitchFamily="2" charset="0"/>
                   <a:cs typeface="Ramabhadra" panose="02000600000000000000" pitchFamily="2" charset="0"/>
                 </a:rPr>
-                <a:t>నీదు జీవమె నిండుగ</a:t>
-              </a:r>
+                <a:t>విడిపించినావు –</a:t>
+              </a:r>
+              <a:endParaRPr lang="en-IN" sz="2300" dirty="0">
+                <a:latin typeface="Ramabhadra" panose="02000600000000000000" pitchFamily="2" charset="0"/>
+                <a:cs typeface="Ramabhadra" panose="02000600000000000000" pitchFamily="2" charset="0"/>
+              </a:endParaRPr>
             </a:p>
             <a:p>
               <a:r>
@@ -3630,8 +3644,25 @@
                   <a:latin typeface="Ramabhadra" panose="02000600000000000000" pitchFamily="2" charset="0"/>
                   <a:cs typeface="Ramabhadra" panose="02000600000000000000" pitchFamily="2" charset="0"/>
                 </a:rPr>
-                <a:t>నాలో నింపుము నా ప్రభు</a:t>
-              </a:r>
+                <a:t>కాపాడినావు </a:t>
+              </a:r>
+              <a:r>
+                <a:rPr lang="en-IN" sz="2300" dirty="0">
+                  <a:latin typeface="Ramabhadra" panose="02000600000000000000" pitchFamily="2" charset="0"/>
+                  <a:cs typeface="Ramabhadra" panose="02000600000000000000" pitchFamily="2" charset="0"/>
+                </a:rPr>
+                <a:t>(2)</a:t>
+              </a:r>
+              <a:endParaRPr lang="te-IN" sz="2300" dirty="0">
+                <a:latin typeface="Ramabhadra" panose="02000600000000000000" pitchFamily="2" charset="0"/>
+                <a:cs typeface="Ramabhadra" panose="02000600000000000000" pitchFamily="2" charset="0"/>
+              </a:endParaRPr>
+            </a:p>
+            <a:p>
+              <a:endParaRPr lang="te-IN" sz="2300" dirty="0">
+                <a:latin typeface="Ramabhadra" panose="02000600000000000000" pitchFamily="2" charset="0"/>
+                <a:cs typeface="Ramabhadra" panose="02000600000000000000" pitchFamily="2" charset="0"/>
+              </a:endParaRPr>
             </a:p>
             <a:p>
               <a:r>
@@ -3639,8 +3670,12 @@
                   <a:latin typeface="Ramabhadra" panose="02000600000000000000" pitchFamily="2" charset="0"/>
                   <a:cs typeface="Ramabhadra" panose="02000600000000000000" pitchFamily="2" charset="0"/>
                 </a:rPr>
-                <a:t>జీవితమంతా నీ ప్రేమనూ</a:t>
-              </a:r>
+                <a:t>నా ప్రాణ స్నేహితులు నన్ను చూచి</a:t>
+              </a:r>
+              <a:endParaRPr lang="en-IN" sz="2300" dirty="0">
+                <a:latin typeface="Ramabhadra" panose="02000600000000000000" pitchFamily="2" charset="0"/>
+                <a:cs typeface="Ramabhadra" panose="02000600000000000000" pitchFamily="2" charset="0"/>
+              </a:endParaRPr>
             </a:p>
             <a:p>
               <a:r>
@@ -3648,8 +3683,75 @@
                   <a:latin typeface="Ramabhadra" panose="02000600000000000000" pitchFamily="2" charset="0"/>
                   <a:cs typeface="Ramabhadra" panose="02000600000000000000" pitchFamily="2" charset="0"/>
                 </a:rPr>
-                <a:t>చాటుచు నుందును</a:t>
-              </a:r>
+                <a:t>దూరాన నిలిచేరు నా ప్రభూ </a:t>
+              </a:r>
+              <a:r>
+                <a:rPr lang="en-IN" sz="2300" dirty="0">
+                  <a:latin typeface="Ramabhadra" panose="02000600000000000000" pitchFamily="2" charset="0"/>
+                  <a:cs typeface="Ramabhadra" panose="02000600000000000000" pitchFamily="2" charset="0"/>
+                </a:rPr>
+                <a:t>(2)</a:t>
+              </a:r>
+              <a:endParaRPr lang="te-IN" sz="2300" dirty="0">
+                <a:latin typeface="Ramabhadra" panose="02000600000000000000" pitchFamily="2" charset="0"/>
+                <a:cs typeface="Ramabhadra" panose="02000600000000000000" pitchFamily="2" charset="0"/>
+              </a:endParaRPr>
+            </a:p>
+            <a:p>
+              <a:r>
+                <a:rPr lang="te-IN" sz="2300" dirty="0">
+                  <a:latin typeface="Ramabhadra" panose="02000600000000000000" pitchFamily="2" charset="0"/>
+                  <a:cs typeface="Ramabhadra" panose="02000600000000000000" pitchFamily="2" charset="0"/>
+                </a:rPr>
+                <a:t>నీ వాక్య ధ్యానమే నా త్రోవకు వెలుగై</a:t>
+              </a:r>
+              <a:r>
+                <a:rPr lang="en-IN" sz="2300" dirty="0">
+                  <a:latin typeface="Ramabhadra" panose="02000600000000000000" pitchFamily="2" charset="0"/>
+                  <a:cs typeface="Ramabhadra" panose="02000600000000000000" pitchFamily="2" charset="0"/>
+                </a:rPr>
+                <a:t> </a:t>
+              </a:r>
+              <a:r>
+                <a:rPr lang="te-IN" sz="2300" dirty="0">
+                  <a:latin typeface="Ramabhadra" panose="02000600000000000000" pitchFamily="2" charset="0"/>
+                  <a:cs typeface="Ramabhadra" panose="02000600000000000000" pitchFamily="2" charset="0"/>
+                </a:rPr>
+                <a:t>–</a:t>
+              </a:r>
+              <a:endParaRPr lang="en-IN" sz="2300" dirty="0">
+                <a:latin typeface="Ramabhadra" panose="02000600000000000000" pitchFamily="2" charset="0"/>
+                <a:cs typeface="Ramabhadra" panose="02000600000000000000" pitchFamily="2" charset="0"/>
+              </a:endParaRPr>
+            </a:p>
+            <a:p>
+              <a:r>
+                <a:rPr lang="te-IN" sz="2300" dirty="0">
+                  <a:latin typeface="Ramabhadra" panose="02000600000000000000" pitchFamily="2" charset="0"/>
+                  <a:cs typeface="Ramabhadra" panose="02000600000000000000" pitchFamily="2" charset="0"/>
+                </a:rPr>
+                <a:t>నను నిల్పెను</a:t>
+              </a:r>
+            </a:p>
+            <a:p>
+              <a:r>
+                <a:rPr lang="te-IN" sz="2300" dirty="0">
+                  <a:latin typeface="Ramabhadra" panose="02000600000000000000" pitchFamily="2" charset="0"/>
+                  <a:cs typeface="Ramabhadra" panose="02000600000000000000" pitchFamily="2" charset="0"/>
+                </a:rPr>
+                <a:t>నీ సన్నీధిలో - నీ సంఘములో </a:t>
+              </a:r>
+              <a:r>
+                <a:rPr lang="en-IN" sz="2300" dirty="0">
+                  <a:latin typeface="Ramabhadra" panose="02000600000000000000" pitchFamily="2" charset="0"/>
+                  <a:cs typeface="Ramabhadra" panose="02000600000000000000" pitchFamily="2" charset="0"/>
+                </a:rPr>
+                <a:t>(2)</a:t>
+              </a:r>
+              <a:endParaRPr lang="te-IN" sz="2300" dirty="0">
+                <a:latin typeface="Ramabhadra" panose="02000600000000000000" pitchFamily="2" charset="0"/>
+                <a:cs typeface="Ramabhadra" panose="02000600000000000000" pitchFamily="2" charset="0"/>
+              </a:endParaRPr>
             </a:p>
           </p:txBody>
         </p:sp>
@@ -3761,9 +3863,9 @@
         <p:grpSpPr>
           <a:xfrm>
             <a:off x="160868" y="182032"/>
-            <a:ext cx="5472868" cy="6551396"/>
+            <a:ext cx="5472868" cy="6493935"/>
             <a:chOff x="160868" y="182032"/>
-            <a:chExt cx="5472868" cy="6551396"/>
+            <a:chExt cx="5472868" cy="6493935"/>
           </a:xfrm>
         </p:grpSpPr>
         <p:sp>
@@ -3836,7 +3938,7 @@
           <p:spPr>
             <a:xfrm>
               <a:off x="238125" y="208565"/>
-              <a:ext cx="5395611" cy="6524863"/>
+              <a:ext cx="5395611" cy="6463308"/>
             </a:xfrm>
             <a:prstGeom prst="rect">
               <a:avLst/>
@@ -3853,44 +3955,54 @@
                 <a:defRPr/>
               </a:pPr>
               <a:r>
-                <a:rPr lang="te-IN" sz="2200" dirty="0">
-                  <a:latin typeface="Ramabhadra" panose="02000600000000000000" pitchFamily="2" charset="0"/>
-                  <a:cs typeface="Ramabhadra" panose="02000600000000000000" pitchFamily="2" charset="0"/>
-                </a:rPr>
-                <a:t>సంవత్సరములు గతియించు చుండ –</a:t>
-              </a:r>
-            </a:p>
-            <a:p>
-              <a:pPr defTabSz="439781">
-                <a:defRPr/>
-              </a:pPr>
-              <a:r>
-                <a:rPr lang="te-IN" sz="2200" dirty="0">
-                  <a:latin typeface="Ramabhadra" panose="02000600000000000000" pitchFamily="2" charset="0"/>
-                  <a:cs typeface="Ramabhadra" panose="02000600000000000000" pitchFamily="2" charset="0"/>
-                </a:rPr>
-                <a:t>నను నూతన పరుచుము</a:t>
-              </a:r>
-            </a:p>
-            <a:p>
-              <a:pPr defTabSz="439781">
-                <a:defRPr/>
-              </a:pPr>
-              <a:r>
-                <a:rPr lang="te-IN" sz="2200" dirty="0">
-                  <a:latin typeface="Ramabhadra" panose="02000600000000000000" pitchFamily="2" charset="0"/>
-                  <a:cs typeface="Ramabhadra" panose="02000600000000000000" pitchFamily="2" charset="0"/>
-                </a:rPr>
-                <a:t>యేసయ్యా నీ రూపముకు మార్చుము </a:t>
-              </a:r>
-              <a:r>
-                <a:rPr lang="en-US" sz="2200" dirty="0">
-                  <a:latin typeface="Ramabhadra" panose="02000600000000000000" pitchFamily="2" charset="0"/>
-                  <a:cs typeface="Ramabhadra" panose="02000600000000000000" pitchFamily="2" charset="0"/>
-                </a:rPr>
-                <a:t>(2)</a:t>
-              </a:r>
-              <a:endParaRPr lang="te-IN" sz="2200" dirty="0">
+                <a:rPr lang="te-IN" sz="2300" dirty="0">
+                  <a:latin typeface="Ramabhadra" panose="02000600000000000000" pitchFamily="2" charset="0"/>
+                  <a:cs typeface="Ramabhadra" panose="02000600000000000000" pitchFamily="2" charset="0"/>
+                </a:rPr>
+                <a:t>నీ ప్రేమ ఎంతో అపారము</a:t>
+              </a:r>
+            </a:p>
+            <a:p>
+              <a:pPr defTabSz="439781">
+                <a:defRPr/>
+              </a:pPr>
+              <a:r>
+                <a:rPr lang="te-IN" sz="2300" dirty="0">
+                  <a:latin typeface="Ramabhadra" panose="02000600000000000000" pitchFamily="2" charset="0"/>
+                  <a:cs typeface="Ramabhadra" panose="02000600000000000000" pitchFamily="2" charset="0"/>
+                </a:rPr>
+                <a:t>వర్ణింపతరమా నా ప్రభూ</a:t>
+              </a:r>
+            </a:p>
+            <a:p>
+              <a:pPr defTabSz="439781">
+                <a:defRPr/>
+              </a:pPr>
+              <a:r>
+                <a:rPr lang="te-IN" sz="2300" dirty="0">
+                  <a:latin typeface="Ramabhadra" panose="02000600000000000000" pitchFamily="2" charset="0"/>
+                  <a:cs typeface="Ramabhadra" panose="02000600000000000000" pitchFamily="2" charset="0"/>
+                </a:rPr>
+                <a:t>పులకింప చేసెను నా హృది</a:t>
+              </a:r>
+            </a:p>
+            <a:p>
+              <a:pPr defTabSz="439781">
+                <a:defRPr/>
+              </a:pPr>
+              <a:r>
+                <a:rPr lang="te-IN" sz="2300" dirty="0">
+                  <a:latin typeface="Ramabhadra" panose="02000600000000000000" pitchFamily="2" charset="0"/>
+                  <a:cs typeface="Ramabhadra" panose="02000600000000000000" pitchFamily="2" charset="0"/>
+                </a:rPr>
+                <a:t>హృదయేశ్వరా నా యేసువా</a:t>
+              </a:r>
+            </a:p>
+            <a:p>
+              <a:pPr defTabSz="439781">
+                <a:defRPr/>
+              </a:pPr>
+              <a:endParaRPr lang="te-IN" sz="2300" dirty="0">
                 <a:latin typeface="Ramabhadra" panose="02000600000000000000" pitchFamily="2" charset="0"/>
                 <a:cs typeface="Ramabhadra" panose="02000600000000000000" pitchFamily="2" charset="0"/>
               </a:endParaRPr>
@@ -3900,44 +4012,78 @@
                 <a:defRPr/>
               </a:pPr>
               <a:r>
-                <a:rPr lang="te-IN" sz="2200" dirty="0">
-                  <a:latin typeface="Ramabhadra" panose="02000600000000000000" pitchFamily="2" charset="0"/>
-                  <a:cs typeface="Ramabhadra" panose="02000600000000000000" pitchFamily="2" charset="0"/>
-                </a:rPr>
-                <a:t>హిమము కంటే తెల్లగా –</a:t>
-              </a:r>
-            </a:p>
-            <a:p>
-              <a:pPr defTabSz="439781">
-                <a:defRPr/>
-              </a:pPr>
-              <a:r>
-                <a:rPr lang="te-IN" sz="2200" dirty="0">
-                  <a:latin typeface="Ramabhadra" panose="02000600000000000000" pitchFamily="2" charset="0"/>
-                  <a:cs typeface="Ramabhadra" panose="02000600000000000000" pitchFamily="2" charset="0"/>
-                </a:rPr>
-                <a:t>పరిశుద్ధపరుచుము నా రక్షకా </a:t>
-              </a:r>
-              <a:r>
-                <a:rPr lang="en-US" sz="2200" dirty="0">
-                  <a:latin typeface="Ramabhadra" panose="02000600000000000000" pitchFamily="2" charset="0"/>
-                  <a:cs typeface="Ramabhadra" panose="02000600000000000000" pitchFamily="2" charset="0"/>
-                </a:rPr>
-                <a:t>(2)</a:t>
-              </a:r>
-              <a:r>
-                <a:rPr lang="te-IN" sz="2200" dirty="0">
-                  <a:latin typeface="Ramabhadra" panose="02000600000000000000" pitchFamily="2" charset="0"/>
-                  <a:cs typeface="Ramabhadra" panose="02000600000000000000" pitchFamily="2" charset="0"/>
-                </a:rPr>
-                <a:t> </a:t>
-              </a:r>
-            </a:p>
-            <a:p>
-              <a:pPr defTabSz="439781">
-                <a:defRPr/>
-              </a:pPr>
-              <a:endParaRPr lang="te-IN" sz="2200" dirty="0">
+                <a:rPr lang="te-IN" sz="2300" dirty="0">
+                  <a:latin typeface="Ramabhadra" panose="02000600000000000000" pitchFamily="2" charset="0"/>
+                  <a:cs typeface="Ramabhadra" panose="02000600000000000000" pitchFamily="2" charset="0"/>
+                </a:rPr>
+                <a:t>నన్ను ఎంతో ప్రేమించి</a:t>
+              </a:r>
+            </a:p>
+            <a:p>
+              <a:pPr defTabSz="439781">
+                <a:defRPr/>
+              </a:pPr>
+              <a:r>
+                <a:rPr lang="te-IN" sz="2300" dirty="0">
+                  <a:latin typeface="Ramabhadra" panose="02000600000000000000" pitchFamily="2" charset="0"/>
+                  <a:cs typeface="Ramabhadra" panose="02000600000000000000" pitchFamily="2" charset="0"/>
+                </a:rPr>
+                <a:t>నాదు పాపమె క్షమియించి</a:t>
+              </a:r>
+            </a:p>
+            <a:p>
+              <a:pPr defTabSz="439781">
+                <a:defRPr/>
+              </a:pPr>
+              <a:r>
+                <a:rPr lang="te-IN" sz="2300" dirty="0">
+                  <a:latin typeface="Ramabhadra" panose="02000600000000000000" pitchFamily="2" charset="0"/>
+                  <a:cs typeface="Ramabhadra" panose="02000600000000000000" pitchFamily="2" charset="0"/>
+                </a:rPr>
+                <a:t>కృప కనికరముల నీడలో</a:t>
+              </a:r>
+            </a:p>
+            <a:p>
+              <a:pPr defTabSz="439781">
+                <a:defRPr/>
+              </a:pPr>
+              <a:r>
+                <a:rPr lang="te-IN" sz="2300" dirty="0">
+                  <a:latin typeface="Ramabhadra" panose="02000600000000000000" pitchFamily="2" charset="0"/>
+                  <a:cs typeface="Ramabhadra" panose="02000600000000000000" pitchFamily="2" charset="0"/>
+                </a:rPr>
+                <a:t>నన్ను చేర్చిన నా ప్రభూ</a:t>
+              </a:r>
+            </a:p>
+            <a:p>
+              <a:pPr defTabSz="439781">
+                <a:defRPr/>
+              </a:pPr>
+              <a:r>
+                <a:rPr lang="te-IN" sz="2300" dirty="0">
+                  <a:latin typeface="Ramabhadra" panose="02000600000000000000" pitchFamily="2" charset="0"/>
+                  <a:cs typeface="Ramabhadra" panose="02000600000000000000" pitchFamily="2" charset="0"/>
+                </a:rPr>
+                <a:t>జీవితమంతా స్తుతియించినా</a:t>
+              </a:r>
+            </a:p>
+            <a:p>
+              <a:pPr defTabSz="439781">
+                <a:defRPr/>
+              </a:pPr>
+              <a:r>
+                <a:rPr lang="te-IN" sz="2300" dirty="0">
+                  <a:latin typeface="Ramabhadra" panose="02000600000000000000" pitchFamily="2" charset="0"/>
+                  <a:cs typeface="Ramabhadra" panose="02000600000000000000" pitchFamily="2" charset="0"/>
+                </a:rPr>
+                <a:t>తీరునా నీ ఋణం</a:t>
+              </a:r>
+            </a:p>
+            <a:p>
+              <a:pPr defTabSz="439781">
+                <a:defRPr/>
+              </a:pPr>
+              <a:endParaRPr lang="te-IN" sz="2300" dirty="0">
                 <a:latin typeface="Ramabhadra" panose="02000600000000000000" pitchFamily="2" charset="0"/>
                 <a:cs typeface="Ramabhadra" panose="02000600000000000000" pitchFamily="2" charset="0"/>
               </a:endParaRPr>
@@ -3947,189 +4093,72 @@
                 <a:defRPr/>
               </a:pPr>
               <a:r>
-                <a:rPr lang="te-IN" sz="2200" dirty="0">
-                  <a:latin typeface="Ramabhadra" panose="02000600000000000000" pitchFamily="2" charset="0"/>
-                  <a:cs typeface="Ramabhadra" panose="02000600000000000000" pitchFamily="2" charset="0"/>
-                </a:rPr>
-                <a:t>దినదినంబు నీకు సమీపమై –</a:t>
-              </a:r>
-            </a:p>
-            <a:p>
-              <a:pPr defTabSz="439781">
-                <a:defRPr/>
-              </a:pPr>
-              <a:r>
-                <a:rPr lang="te-IN" sz="2200" dirty="0">
-                  <a:latin typeface="Ramabhadra" panose="02000600000000000000" pitchFamily="2" charset="0"/>
-                  <a:cs typeface="Ramabhadra" panose="02000600000000000000" pitchFamily="2" charset="0"/>
-                </a:rPr>
-                <a:t>ప్రతి క్షణం నా సిలువను మోయుచు</a:t>
-              </a:r>
-            </a:p>
-            <a:p>
-              <a:pPr defTabSz="439781">
-                <a:defRPr/>
-              </a:pPr>
-              <a:r>
-                <a:rPr lang="te-IN" sz="2200" dirty="0">
-                  <a:latin typeface="Ramabhadra" panose="02000600000000000000" pitchFamily="2" charset="0"/>
-                  <a:cs typeface="Ramabhadra" panose="02000600000000000000" pitchFamily="2" charset="0"/>
-                </a:rPr>
-                <a:t>వెనుకకు  చూడకనే నేను సాగెదను-</a:t>
-              </a:r>
-            </a:p>
-            <a:p>
-              <a:pPr defTabSz="439781">
-                <a:defRPr/>
-              </a:pPr>
-              <a:r>
-                <a:rPr lang="te-IN" sz="2200" dirty="0">
-                  <a:latin typeface="Ramabhadra" panose="02000600000000000000" pitchFamily="2" charset="0"/>
-                  <a:cs typeface="Ramabhadra" panose="02000600000000000000" pitchFamily="2" charset="0"/>
-                </a:rPr>
-                <a:t>శిలువను చూచుచునే గురిని చేరెదను</a:t>
-              </a:r>
-            </a:p>
-            <a:p>
-              <a:pPr defTabSz="439781">
-                <a:defRPr/>
-              </a:pPr>
-              <a:r>
-                <a:rPr lang="te-IN" sz="2200" dirty="0">
-                  <a:latin typeface="Ramabhadra" panose="02000600000000000000" pitchFamily="2" charset="0"/>
-                  <a:cs typeface="Ramabhadra" panose="02000600000000000000" pitchFamily="2" charset="0"/>
-                </a:rPr>
-                <a:t>నీ ఆత్మతో నను నింపుమా –</a:t>
-              </a:r>
-            </a:p>
-            <a:p>
-              <a:pPr defTabSz="439781">
-                <a:defRPr/>
-              </a:pPr>
-              <a:r>
-                <a:rPr lang="te-IN" sz="2200" dirty="0">
-                  <a:latin typeface="Ramabhadra" panose="02000600000000000000" pitchFamily="2" charset="0"/>
-                  <a:cs typeface="Ramabhadra" panose="02000600000000000000" pitchFamily="2" charset="0"/>
-                </a:rPr>
-                <a:t>నీ సేవజేతును స్థిరపరచుమా</a:t>
-              </a:r>
-              <a:r>
-                <a:rPr lang="en-US" sz="2200" dirty="0">
-                  <a:latin typeface="Ramabhadra" panose="02000600000000000000" pitchFamily="2" charset="0"/>
-                  <a:cs typeface="Ramabhadra" panose="02000600000000000000" pitchFamily="2" charset="0"/>
-                </a:rPr>
-                <a:t> (2)</a:t>
-              </a:r>
-              <a:endParaRPr lang="te-IN" sz="2200" dirty="0">
-                <a:latin typeface="Ramabhadra" panose="02000600000000000000" pitchFamily="2" charset="0"/>
-                <a:cs typeface="Ramabhadra" panose="02000600000000000000" pitchFamily="2" charset="0"/>
-              </a:endParaRPr>
-            </a:p>
-            <a:p>
-              <a:pPr defTabSz="439781">
-                <a:defRPr/>
-              </a:pPr>
-              <a:endParaRPr lang="te-IN" sz="2200" dirty="0">
-                <a:latin typeface="Ramabhadra" panose="02000600000000000000" pitchFamily="2" charset="0"/>
-                <a:cs typeface="Ramabhadra" panose="02000600000000000000" pitchFamily="2" charset="0"/>
-              </a:endParaRPr>
-            </a:p>
-            <a:p>
-              <a:pPr defTabSz="439781">
-                <a:defRPr/>
-              </a:pPr>
-              <a:r>
-                <a:rPr lang="te-IN" sz="2200" dirty="0">
-                  <a:latin typeface="Ramabhadra" panose="02000600000000000000" pitchFamily="2" charset="0"/>
-                  <a:cs typeface="Ramabhadra" panose="02000600000000000000" pitchFamily="2" charset="0"/>
-                </a:rPr>
-                <a:t>నూత్న మనస్సు </a:t>
-              </a:r>
-              <a:r>
-                <a:rPr lang="en-US" sz="2200" dirty="0">
-                  <a:latin typeface="Ramabhadra" panose="02000600000000000000" pitchFamily="2" charset="0"/>
-                  <a:cs typeface="Ramabhadra" panose="02000600000000000000" pitchFamily="2" charset="0"/>
-                </a:rPr>
-                <a:t>-</a:t>
-              </a:r>
-              <a:r>
-                <a:rPr lang="te-IN" sz="2200" dirty="0">
-                  <a:latin typeface="Ramabhadra" panose="02000600000000000000" pitchFamily="2" charset="0"/>
-                  <a:cs typeface="Ramabhadra" panose="02000600000000000000" pitchFamily="2" charset="0"/>
-                </a:rPr>
-                <a:t> నూత్న ఆత్మను</a:t>
-              </a:r>
-            </a:p>
-            <a:p>
-              <a:pPr defTabSz="439781">
-                <a:defRPr/>
-              </a:pPr>
-              <a:r>
-                <a:rPr lang="te-IN" sz="2200" dirty="0">
-                  <a:latin typeface="Ramabhadra" panose="02000600000000000000" pitchFamily="2" charset="0"/>
-                  <a:cs typeface="Ramabhadra" panose="02000600000000000000" pitchFamily="2" charset="0"/>
-                </a:rPr>
-                <a:t>- నూత్నజీవమును నింపుము దేవా</a:t>
-              </a:r>
-            </a:p>
-            <a:p>
-              <a:pPr defTabSz="439781">
-                <a:defRPr/>
-              </a:pPr>
-              <a:r>
-                <a:rPr lang="te-IN" sz="2200" dirty="0">
-                  <a:latin typeface="Ramabhadra" panose="02000600000000000000" pitchFamily="2" charset="0"/>
-                  <a:cs typeface="Ramabhadra" panose="02000600000000000000" pitchFamily="2" charset="0"/>
-                </a:rPr>
-                <a:t>రాతిగుండెనే మార్చు యేసయ్యా –</a:t>
-              </a:r>
-            </a:p>
-            <a:p>
-              <a:pPr defTabSz="439781">
-                <a:defRPr/>
-              </a:pPr>
-              <a:r>
-                <a:rPr lang="te-IN" sz="2200" dirty="0">
-                  <a:latin typeface="Ramabhadra" panose="02000600000000000000" pitchFamily="2" charset="0"/>
-                  <a:cs typeface="Ramabhadra" panose="02000600000000000000" pitchFamily="2" charset="0"/>
-                </a:rPr>
-                <a:t>మాంసపు గుండెనే అమర్చుమో దేవా</a:t>
-              </a:r>
-            </a:p>
-            <a:p>
-              <a:pPr defTabSz="439781">
-                <a:defRPr/>
-              </a:pPr>
-              <a:r>
-                <a:rPr lang="te-IN" sz="2200" dirty="0">
-                  <a:latin typeface="Ramabhadra" panose="02000600000000000000" pitchFamily="2" charset="0"/>
-                  <a:cs typeface="Ramabhadra" panose="02000600000000000000" pitchFamily="2" charset="0"/>
-                </a:rPr>
-                <a:t>నీ హృదయము నాకిమ్మయ్యా –</a:t>
-              </a:r>
-            </a:p>
-            <a:p>
-              <a:pPr defTabSz="439781">
-                <a:defRPr/>
-              </a:pPr>
-              <a:r>
-                <a:rPr lang="te-IN" sz="2200" dirty="0">
-                  <a:latin typeface="Ramabhadra" panose="02000600000000000000" pitchFamily="2" charset="0"/>
-                  <a:cs typeface="Ramabhadra" panose="02000600000000000000" pitchFamily="2" charset="0"/>
-                </a:rPr>
-                <a:t>లోకాన్ని నీకై సంపాదించెదా</a:t>
-              </a:r>
-              <a:r>
-                <a:rPr lang="en-US" sz="2200" dirty="0">
-                  <a:latin typeface="Ramabhadra" panose="02000600000000000000" pitchFamily="2" charset="0"/>
-                  <a:cs typeface="Ramabhadra" panose="02000600000000000000" pitchFamily="2" charset="0"/>
-                </a:rPr>
-                <a:t> (2)</a:t>
-              </a:r>
-              <a:endParaRPr lang="te-IN" sz="2200" dirty="0">
-                <a:latin typeface="Ramabhadra" panose="02000600000000000000" pitchFamily="2" charset="0"/>
-                <a:cs typeface="Ramabhadra" panose="02000600000000000000" pitchFamily="2" charset="0"/>
-              </a:endParaRPr>
+                <a:rPr lang="te-IN" sz="2300" dirty="0">
+                  <a:latin typeface="Ramabhadra" panose="02000600000000000000" pitchFamily="2" charset="0"/>
+                  <a:cs typeface="Ramabhadra" panose="02000600000000000000" pitchFamily="2" charset="0"/>
+                </a:rPr>
+                <a:t>నీదు సన్నిధిలో కాంక్షించి</a:t>
+              </a:r>
+            </a:p>
+            <a:p>
+              <a:pPr defTabSz="439781">
+                <a:defRPr/>
+              </a:pPr>
+              <a:r>
+                <a:rPr lang="te-IN" sz="2300" dirty="0">
+                  <a:latin typeface="Ramabhadra" panose="02000600000000000000" pitchFamily="2" charset="0"/>
+                  <a:cs typeface="Ramabhadra" panose="02000600000000000000" pitchFamily="2" charset="0"/>
+                </a:rPr>
+                <a:t>పాప బ్రతుకే వీడితిని</a:t>
+              </a:r>
+            </a:p>
+            <a:p>
+              <a:pPr defTabSz="439781">
+                <a:defRPr/>
+              </a:pPr>
+              <a:r>
+                <a:rPr lang="te-IN" sz="2300" dirty="0">
+                  <a:latin typeface="Ramabhadra" panose="02000600000000000000" pitchFamily="2" charset="0"/>
+                  <a:cs typeface="Ramabhadra" panose="02000600000000000000" pitchFamily="2" charset="0"/>
+                </a:rPr>
+                <a:t>నీదు జీవమె నిండుగ</a:t>
+              </a:r>
+            </a:p>
+            <a:p>
+              <a:pPr defTabSz="439781">
+                <a:defRPr/>
+              </a:pPr>
+              <a:r>
+                <a:rPr lang="te-IN" sz="2300" dirty="0">
+                  <a:latin typeface="Ramabhadra" panose="02000600000000000000" pitchFamily="2" charset="0"/>
+                  <a:cs typeface="Ramabhadra" panose="02000600000000000000" pitchFamily="2" charset="0"/>
+                </a:rPr>
+                <a:t>నాలో నింపుము నా ప్రభు</a:t>
+              </a:r>
+            </a:p>
+            <a:p>
+              <a:pPr defTabSz="439781">
+                <a:defRPr/>
+              </a:pPr>
+              <a:r>
+                <a:rPr lang="te-IN" sz="2300" dirty="0">
+                  <a:latin typeface="Ramabhadra" panose="02000600000000000000" pitchFamily="2" charset="0"/>
+                  <a:cs typeface="Ramabhadra" panose="02000600000000000000" pitchFamily="2" charset="0"/>
+                </a:rPr>
+                <a:t>జీవితమంతా నీ ప్రేమనూ</a:t>
+              </a:r>
+            </a:p>
+            <a:p>
+              <a:pPr defTabSz="439781">
+                <a:defRPr/>
+              </a:pPr>
+              <a:r>
+                <a:rPr lang="te-IN" sz="2300" dirty="0">
+                  <a:latin typeface="Ramabhadra" panose="02000600000000000000" pitchFamily="2" charset="0"/>
+                  <a:cs typeface="Ramabhadra" panose="02000600000000000000" pitchFamily="2" charset="0"/>
+                </a:rPr>
+                <a:t>చాటుచు నుందును</a:t>
+              </a:r>
             </a:p>
           </p:txBody>
         </p:sp>
@@ -4307,7 +4336,7 @@
                   <a:latin typeface="Ramabhadra" panose="02000600000000000000" pitchFamily="2" charset="0"/>
                   <a:cs typeface="Ramabhadra" panose="02000600000000000000" pitchFamily="2" charset="0"/>
                 </a:rPr>
-                <a:t>స్తుతులన్ గైకొనుమా</a:t>
+                <a:t>సంఘమా - క్రైస్తవ సంఘమా</a:t>
               </a:r>
             </a:p>
             <a:p>
@@ -4319,7 +4348,7 @@
                   <a:latin typeface="Ramabhadra" panose="02000600000000000000" pitchFamily="2" charset="0"/>
                   <a:cs typeface="Ramabhadra" panose="02000600000000000000" pitchFamily="2" charset="0"/>
                 </a:rPr>
-                <a:t>సుత యేసు క్రీస్తువా</a:t>
+                <a:t>యేసునే పోలి నడువుమా –</a:t>
               </a:r>
             </a:p>
             <a:p>
@@ -4331,19 +4360,7 @@
                   <a:latin typeface="Ramabhadra" panose="02000600000000000000" pitchFamily="2" charset="0"/>
                   <a:cs typeface="Ramabhadra" panose="02000600000000000000" pitchFamily="2" charset="0"/>
                 </a:rPr>
-                <a:t>సతతము మమ్ములను </a:t>
-              </a:r>
-            </a:p>
-            <a:p>
-              <a:pPr defTabSz="439781">
-                <a:defRPr/>
-              </a:pPr>
-              <a:r>
-                <a:rPr lang="te-IN" sz="2100" dirty="0">
-                  <a:latin typeface="Ramabhadra" panose="02000600000000000000" pitchFamily="2" charset="0"/>
-                  <a:cs typeface="Ramabhadra" panose="02000600000000000000" pitchFamily="2" charset="0"/>
-                </a:rPr>
-                <a:t>కృపనిడి కావుమా</a:t>
+                <a:t>క్రీస్తు మనసు కలిగియుండుమా</a:t>
               </a:r>
             </a:p>
             <a:p>
@@ -4364,7 +4381,7 @@
                   <a:latin typeface="Ramabhadra" panose="02000600000000000000" pitchFamily="2" charset="0"/>
                   <a:cs typeface="Ramabhadra" panose="02000600000000000000" pitchFamily="2" charset="0"/>
                 </a:rPr>
-                <a:t>మా పెదవులతో ఎప్పుడు నీ</a:t>
+                <a:t>ఆది సంఘము మోకరిల్లగ</a:t>
               </a:r>
             </a:p>
             <a:p>
@@ -4376,7 +4393,7 @@
                   <a:latin typeface="Ramabhadra" panose="02000600000000000000" pitchFamily="2" charset="0"/>
                   <a:cs typeface="Ramabhadra" panose="02000600000000000000" pitchFamily="2" charset="0"/>
                 </a:rPr>
-                <a:t>వాక్యమును పఠింప నిమ్ము</a:t>
+                <a:t>చెరసాల తలుపులు - బ్రద్ధలాయెను</a:t>
               </a:r>
             </a:p>
             <a:p>
@@ -4388,7 +4405,7 @@
                   <a:latin typeface="Ramabhadra" panose="02000600000000000000" pitchFamily="2" charset="0"/>
                   <a:cs typeface="Ramabhadra" panose="02000600000000000000" pitchFamily="2" charset="0"/>
                 </a:rPr>
-                <a:t>మా కాలు చేతులు ఎప్పుడు నీ </a:t>
+                <a:t>ప్రధమ సంఘము - ప్రార్థింపగ</a:t>
               </a:r>
             </a:p>
             <a:p>
@@ -4400,7 +4417,43 @@
                   <a:latin typeface="Ramabhadra" panose="02000600000000000000" pitchFamily="2" charset="0"/>
                   <a:cs typeface="Ramabhadra" panose="02000600000000000000" pitchFamily="2" charset="0"/>
                 </a:rPr>
-                <a:t>సేవను చేయను వాడనిమ్ము </a:t>
+                <a:t>పరిశుద్ధ  ఆత్మయే – భువికేగెను (2)</a:t>
+              </a:r>
+            </a:p>
+            <a:p>
+              <a:pPr defTabSz="439781">
+                <a:defRPr/>
+              </a:pPr>
+              <a:r>
+                <a:rPr lang="te-IN" sz="2100" dirty="0">
+                  <a:latin typeface="Ramabhadra" panose="02000600000000000000" pitchFamily="2" charset="0"/>
+                  <a:cs typeface="Ramabhadra" panose="02000600000000000000" pitchFamily="2" charset="0"/>
+                </a:rPr>
+                <a:t>ఆనాటి విజ్ఞాపన - ఏమాయెను</a:t>
+              </a:r>
+            </a:p>
+            <a:p>
+              <a:pPr defTabSz="439781">
+                <a:defRPr/>
+              </a:pPr>
+              <a:r>
+                <a:rPr lang="te-IN" sz="2100" dirty="0">
+                  <a:latin typeface="Ramabhadra" panose="02000600000000000000" pitchFamily="2" charset="0"/>
+                  <a:cs typeface="Ramabhadra" panose="02000600000000000000" pitchFamily="2" charset="0"/>
+                </a:rPr>
+                <a:t>ఈనాడు అద్భుతాలు కొదువాయెను</a:t>
+              </a:r>
+            </a:p>
+            <a:p>
+              <a:pPr defTabSz="439781">
+                <a:defRPr/>
+              </a:pPr>
+              <a:r>
+                <a:rPr lang="te-IN" sz="2100" dirty="0">
+                  <a:latin typeface="Ramabhadra" panose="02000600000000000000" pitchFamily="2" charset="0"/>
+                  <a:cs typeface="Ramabhadra" panose="02000600000000000000" pitchFamily="2" charset="0"/>
+                </a:rPr>
+                <a:t>మేలుకో లెమ్ము తేజరిల్లుమా</a:t>
               </a:r>
             </a:p>
             <a:p>
@@ -4421,7 +4474,7 @@
                   <a:latin typeface="Ramabhadra" panose="02000600000000000000" pitchFamily="2" charset="0"/>
                   <a:cs typeface="Ramabhadra" panose="02000600000000000000" pitchFamily="2" charset="0"/>
                 </a:rPr>
-                <a:t>మా కలిమియు పదవుల నెల్ల </a:t>
+                <a:t>క్రియలు లేని నీ - విశ్వాసము</a:t>
               </a:r>
             </a:p>
             <a:p>
@@ -4433,7 +4486,7 @@
                   <a:latin typeface="Ramabhadra" panose="02000600000000000000" pitchFamily="2" charset="0"/>
                   <a:cs typeface="Ramabhadra" panose="02000600000000000000" pitchFamily="2" charset="0"/>
                 </a:rPr>
-                <a:t>నీ శుద్ధ కృపచే పొందితిమి </a:t>
+                <a:t>మ్రుతమైనది - అది కొరకానిది</a:t>
               </a:r>
             </a:p>
             <a:p>
@@ -4445,7 +4498,7 @@
                   <a:latin typeface="Ramabhadra" panose="02000600000000000000" pitchFamily="2" charset="0"/>
                   <a:cs typeface="Ramabhadra" panose="02000600000000000000" pitchFamily="2" charset="0"/>
                 </a:rPr>
-                <a:t>మా కాలమంతయు జీవింప </a:t>
+                <a:t>శక్తి లేని నీ - భక్తి మొత్తము</a:t>
               </a:r>
             </a:p>
             <a:p>
@@ -4457,17 +4510,8 @@
                   <a:latin typeface="Ramabhadra" panose="02000600000000000000" pitchFamily="2" charset="0"/>
                   <a:cs typeface="Ramabhadra" panose="02000600000000000000" pitchFamily="2" charset="0"/>
                 </a:rPr>
-                <a:t>నిలకడగ నుండ దీవించుము</a:t>
-              </a:r>
-            </a:p>
-            <a:p>
-              <a:pPr defTabSz="439781">
-                <a:defRPr/>
-              </a:pPr>
-              <a:endParaRPr lang="te-IN" sz="2100" dirty="0">
-                <a:latin typeface="Ramabhadra" panose="02000600000000000000" pitchFamily="2" charset="0"/>
-                <a:cs typeface="Ramabhadra" panose="02000600000000000000" pitchFamily="2" charset="0"/>
-              </a:endParaRPr>
+                <a:t>వ్యర్థమైనది అది మేలు చేయదు (2)</a:t>
+              </a:r>
             </a:p>
             <a:p>
               <a:pPr defTabSz="439781">
@@ -4478,7 +4522,7 @@
                   <a:latin typeface="Ramabhadra" panose="02000600000000000000" pitchFamily="2" charset="0"/>
                   <a:cs typeface="Ramabhadra" panose="02000600000000000000" pitchFamily="2" charset="0"/>
                 </a:rPr>
-                <a:t>నిజ విశ్వాసములో నెదుగ</a:t>
+                <a:t>నామకార్ధమును విడిచి నమ్మీ చూడుము</a:t>
               </a:r>
             </a:p>
             <a:p>
@@ -4490,7 +4534,7 @@
                   <a:latin typeface="Ramabhadra" panose="02000600000000000000" pitchFamily="2" charset="0"/>
                   <a:cs typeface="Ramabhadra" panose="02000600000000000000" pitchFamily="2" charset="0"/>
                 </a:rPr>
-                <a:t>నిశ్భల బుద్దిని మా కొసగి</a:t>
+                <a:t>యదార్థమైన మనసును ఆశించుము</a:t>
               </a:r>
             </a:p>
             <a:p>
@@ -4502,19 +4546,7 @@
                   <a:latin typeface="Ramabhadra" panose="02000600000000000000" pitchFamily="2" charset="0"/>
                   <a:cs typeface="Ramabhadra" panose="02000600000000000000" pitchFamily="2" charset="0"/>
                 </a:rPr>
-                <a:t>నిరతము నీ సేవ చేయుటకు</a:t>
-              </a:r>
-            </a:p>
-            <a:p>
-              <a:pPr defTabSz="439781">
-                <a:defRPr/>
-              </a:pPr>
-              <a:r>
-                <a:rPr lang="te-IN" sz="2100" dirty="0">
-                  <a:latin typeface="Ramabhadra" panose="02000600000000000000" pitchFamily="2" charset="0"/>
-                  <a:cs typeface="Ramabhadra" panose="02000600000000000000" pitchFamily="2" charset="0"/>
-                </a:rPr>
-                <a:t>నీ ఆత్మ శక్తితో నింపుమయా </a:t>
+                <a:t>మేలుకో లెమ్ము తేజరిల్లుమా</a:t>
               </a:r>
             </a:p>
           </p:txBody>

</xml_diff>